<commit_message>
deck_dyson: text before figures on the scaling and seed slides; shorter notes
Co-Authored-By: Claude Fable 5.1 <noreply@anthropic.com>
</commit_message>
<xml_diff>
--- a/demo_session/deck_dyson.pptx
+++ b/demo_session/deck_dyson.pptx
@@ -6427,7 +6427,7 @@
                 </a:solidFill>
                 <a:latin typeface="Arial"/>
               </a:rPr>
-              <a:t>Chain: design/src/spectrometer_geom.m; emitter: spectrometer_rx.m; the grating groove period is solved so the band spans the 9 mm focal plane.</a:t>
+              <a:t>Chain spectrometer_geom.m, emitter spectrometer_rx.m; the groove period is solved so the band spans the 9 mm focal plane.</a:t>
             </a:r>
           </a:p>
         </p:txBody>
@@ -6549,9 +6549,64 @@
           </a:p>
         </p:txBody>
       </p:sp>
+      <p:sp>
+        <p:nvSpPr>
+          <p:cNvPr id="4" name="TextBox 3"/>
+          <p:cNvSpPr txBox="1"/>
+          <p:nvPr/>
+        </p:nvSpPr>
+        <p:spPr>
+          <a:xfrm>
+            <a:off x="411480" y="1298448"/>
+            <a:ext cx="11368735" cy="274320"/>
+          </a:xfrm>
+          <a:prstGeom prst="rect">
+            <a:avLst/>
+          </a:prstGeom>
+          <a:noFill/>
+        </p:spPr>
+        <p:txBody>
+          <a:bodyPr wrap="square">
+            <a:spAutoFit/>
+          </a:bodyPr>
+          <a:lstStyle/>
+          <a:p>
+            <a:pPr>
+              <a:spcAft>
+                <a:spcPts val="600"/>
+              </a:spcAft>
+            </a:pPr>
+            <a:r>
+              <a:rPr sz="1500" b="0">
+                <a:solidFill>
+                  <a:srgbClr val="282828"/>
+                </a:solidFill>
+                <a:latin typeface="Arial"/>
+              </a:rPr>
+              <a:t>•  The Dyson condition R_g = n·r / (n − 1) is the blur minimum by exact 3-D trace: 0.67 µm at the condition against 4–5 µm at ±5 %, image at −h, residual fifth order (h⁴·¹⁷, r⁻³·¹⁹).</a:t>
+            </a:r>
+          </a:p>
+          <a:p>
+            <a:pPr>
+              <a:spcAft>
+                <a:spcPts val="600"/>
+              </a:spcAft>
+            </a:pPr>
+            <a:r>
+              <a:rPr sz="1500" b="0">
+                <a:solidFill>
+                  <a:srgbClr val="282828"/>
+                </a:solidFill>
+                <a:latin typeface="Arial"/>
+              </a:rPr>
+              <a:t>•  The scaling answer, before any element was added: a single concentric block meets a quarter-pixel corner blur only at r ≥ 213 mm, about twice flight scale, which is why the flight forms add an asphere, a meniscus or an air gap.</a:t>
+            </a:r>
+          </a:p>
+        </p:txBody>
+      </p:sp>
       <p:pic>
         <p:nvPicPr>
-          <p:cNvPr id="4" name="Picture 3" descr="dyson5_s0_scaling.png"/>
+          <p:cNvPr id="5" name="Picture 4" descr="dyson5_s0_scaling.png"/>
           <p:cNvPicPr>
             <a:picLocks noChangeAspect="1"/>
           </p:cNvPicPr>
@@ -6565,8 +6620,8 @@
         </p:blipFill>
         <p:spPr>
           <a:xfrm>
-            <a:off x="2288221" y="1298448"/>
-            <a:ext cx="7615253" cy="5000752"/>
+            <a:off x="3283835" y="2606039"/>
+            <a:ext cx="5624023" cy="3693160"/>
           </a:xfrm>
           <a:prstGeom prst="rect">
             <a:avLst/>
@@ -6575,7 +6630,7 @@
       </p:pic>
       <p:sp>
         <p:nvSpPr>
-          <p:cNvPr id="5" name="TextBox 4"/>
+          <p:cNvPr id="6" name="TextBox 5"/>
           <p:cNvSpPr txBox="1"/>
           <p:nvPr/>
         </p:nvSpPr>
@@ -6614,68 +6669,13 @@
       </p:sp>
       <p:sp>
         <p:nvSpPr>
-          <p:cNvPr id="6" name="TextBox 5"/>
-          <p:cNvSpPr txBox="1"/>
-          <p:nvPr/>
-        </p:nvSpPr>
-        <p:spPr>
-          <a:xfrm>
-            <a:off x="411480" y="6748272"/>
-            <a:ext cx="11368735" cy="274320"/>
-          </a:xfrm>
-          <a:prstGeom prst="rect">
-            <a:avLst/>
-          </a:prstGeom>
-          <a:noFill/>
-        </p:spPr>
-        <p:txBody>
-          <a:bodyPr wrap="square">
-            <a:spAutoFit/>
-          </a:bodyPr>
-          <a:lstStyle/>
-          <a:p>
-            <a:pPr>
-              <a:spcAft>
-                <a:spcPts val="600"/>
-              </a:spcAft>
-            </a:pPr>
-            <a:r>
-              <a:rPr sz="1500" b="0">
-                <a:solidFill>
-                  <a:srgbClr val="282828"/>
-                </a:solidFill>
-                <a:latin typeface="Arial"/>
-              </a:rPr>
-              <a:t>•  The Dyson condition R_g = n·r / (n − 1) is the blur minimum by exact 3-D trace: 0.67 µm at the condition against 4–5 µm at ±5 %, image at −h, residual fifth order (h⁴·¹⁷, r⁻³·¹⁹).</a:t>
-            </a:r>
-          </a:p>
-          <a:p>
-            <a:pPr>
-              <a:spcAft>
-                <a:spcPts val="600"/>
-              </a:spcAft>
-            </a:pPr>
-            <a:r>
-              <a:rPr sz="1500" b="0">
-                <a:solidFill>
-                  <a:srgbClr val="282828"/>
-                </a:solidFill>
-                <a:latin typeface="Arial"/>
-              </a:rPr>
-              <a:t>•  The scaling answer, before any element was added: a single concentric block meets a quarter-pixel corner blur only at r ≥ 213 mm, about twice flight scale, which is why the flight forms add an asphere, a meniscus or an air gap.</a:t>
-            </a:r>
-          </a:p>
-        </p:txBody>
-      </p:sp>
-      <p:sp>
-        <p:nvSpPr>
           <p:cNvPr id="7" name="TextBox 6"/>
           <p:cNvSpPr txBox="1"/>
           <p:nvPr/>
         </p:nvSpPr>
         <p:spPr>
           <a:xfrm>
-            <a:off x="411480" y="8055863"/>
+            <a:off x="411480" y="6748272"/>
             <a:ext cx="11368735" cy="274320"/>
           </a:xfrm>
           <a:prstGeom prst="rect">
@@ -7089,9 +7089,64 @@
           </a:p>
         </p:txBody>
       </p:sp>
+      <p:sp>
+        <p:nvSpPr>
+          <p:cNvPr id="4" name="TextBox 3"/>
+          <p:cNvSpPr txBox="1"/>
+          <p:nvPr/>
+        </p:nvSpPr>
+        <p:spPr>
+          <a:xfrm>
+            <a:off x="411480" y="1298448"/>
+            <a:ext cx="11368735" cy="274320"/>
+          </a:xfrm>
+          <a:prstGeom prst="rect">
+            <a:avLst/>
+          </a:prstGeom>
+          <a:noFill/>
+        </p:spPr>
+        <p:txBody>
+          <a:bodyPr wrap="square">
+            <a:spAutoFit/>
+          </a:bodyPr>
+          <a:lstStyle/>
+          <a:p>
+            <a:pPr>
+              <a:spcAft>
+                <a:spcPts val="600"/>
+              </a:spcAft>
+            </a:pPr>
+            <a:r>
+              <a:rPr sz="1500" b="0">
+                <a:solidFill>
+                  <a:srgbClr val="282828"/>
+                </a:solidFill>
+                <a:latin typeface="Arial"/>
+              </a:rPr>
+              <a:t>•  Smile is met at the seed (below 0.01 pixel on both forms); the field-angle map is linear along the slit as designed.</a:t>
+            </a:r>
+          </a:p>
+          <a:p>
+            <a:pPr>
+              <a:spcAft>
+                <a:spcPts val="600"/>
+              </a:spcAft>
+            </a:pPr>
+            <a:r>
+              <a:rPr sz="1500" b="0">
+                <a:solidFill>
+                  <a:srgbClr val="282828"/>
+                </a:solidFill>
+                <a:latin typeface="Arial"/>
+              </a:rPr>
+              <a:t>•  These maps predate the grating fixes of 2026-10-01: the SRF ramp with wavelength is the groove-period defect, not the design; the re-scored maps replace this figure.</a:t>
+            </a:r>
+          </a:p>
+        </p:txBody>
+      </p:sp>
       <p:pic>
         <p:nvPicPr>
-          <p:cNvPr id="4" name="Picture 3" descr="dyson5_s2_maps.png"/>
+          <p:cNvPr id="5" name="Picture 4" descr="dyson5_s2_maps.png"/>
           <p:cNvPicPr>
             <a:picLocks noChangeAspect="1"/>
           </p:cNvPicPr>
@@ -7105,8 +7160,8 @@
         </p:blipFill>
         <p:spPr>
           <a:xfrm>
-            <a:off x="1818057" y="1298448"/>
-            <a:ext cx="8555579" cy="5000752"/>
+            <a:off x="2724763" y="2358390"/>
+            <a:ext cx="6742168" cy="3940810"/>
           </a:xfrm>
           <a:prstGeom prst="rect">
             <a:avLst/>
@@ -7115,7 +7170,7 @@
       </p:pic>
       <p:sp>
         <p:nvSpPr>
-          <p:cNvPr id="5" name="TextBox 4"/>
+          <p:cNvPr id="6" name="TextBox 5"/>
           <p:cNvSpPr txBox="1"/>
           <p:nvPr/>
         </p:nvSpPr>
@@ -7147,14 +7202,14 @@
                 </a:solidFill>
                 <a:latin typeface="Arial"/>
               </a:rPr>
-              <a:t>Scorer maps for the two seeds at 220 mm (rows: Dyson, Offner): field-angle map, smile (pixels, mean over the slit removed), SRF FWHM (pixels), geometric ensquared energy in one pixel, each versus slit position and wavelength.</a:t>
-            </a:r>
-          </a:p>
-        </p:txBody>
-      </p:sp>
-      <p:sp>
-        <p:nvSpPr>
-          <p:cNvPr id="6" name="TextBox 5"/>
+              <a:t>Scorer maps for the two seeds at 220 mm (rows: Dyson, Offner): field-angle map, smile (pixels), SRF FWHM (pixels), ensquared energy in one pixel, versus slit position and wavelength.</a:t>
+            </a:r>
+          </a:p>
+        </p:txBody>
+      </p:sp>
+      <p:sp>
+        <p:nvSpPr>
+          <p:cNvPr id="7" name="TextBox 6"/>
           <p:cNvSpPr txBox="1"/>
           <p:nvPr/>
         </p:nvSpPr>
@@ -7186,7 +7241,7 @@
                 </a:solidFill>
                 <a:latin typeface="Arial"/>
               </a:rPr>
-              <a:t>These maps predate the grating fixes of 2026-10-01 (the SRF ramp with wavelength is the groove-period defect, not the design); the re-scored maps replace this figure.  Records dyson5_s1.txt, dyson5_s2.txt.</a:t>
+              <a:t>Records dyson5_s1.txt, dyson5_s2.txt.</a:t>
             </a:r>
           </a:p>
         </p:txBody>

</xml_diff>

<commit_message>
deck_dyson: provenance notes moved to one Backup records slide (no per-slide footers)
Co-Authored-By: Claude Fable 5.1 <noreply@anthropic.com>
</commit_message>
<xml_diff>
--- a/demo_session/deck_dyson.pptx
+++ b/demo_session/deck_dyson.pptx
@@ -20,6 +20,7 @@
     <p:sldId id="268" r:id="rId19"/>
     <p:sldId id="269" r:id="rId20"/>
     <p:sldId id="270" r:id="rId21"/>
+    <p:sldId id="271" r:id="rId22"/>
   </p:sldIdLst>
   <p:sldSz cx="12191695" cy="6858000" type="screen4x3"/>
   <p:notesSz cx="6858000" cy="9144000"/>
@@ -4890,6 +4891,730 @@
                 </a:solidFill>
                 <a:latin typeface="Arial"/>
               </a:rPr>
+              <a:t>Backup: records and tools behind each slide</a:t>
+            </a:r>
+          </a:p>
+          <a:p>
+            <a:pPr>
+              <a:spcAft>
+                <a:spcPts val="0"/>
+              </a:spcAft>
+            </a:pPr>
+            <a:r>
+              <a:rPr sz="1250" b="0">
+                <a:solidFill>
+                  <a:srgbClr val="6E6E6E"/>
+                </a:solidFill>
+                <a:latin typeface="Arial"/>
+              </a:rPr>
+              <a:t>Every number traces to a runner stage and its record file</a:t>
+            </a:r>
+          </a:p>
+        </p:txBody>
+      </p:sp>
+      <p:sp>
+        <p:nvSpPr>
+          <p:cNvPr id="3" name="Rectangle 2"/>
+          <p:cNvSpPr/>
+          <p:nvPr/>
+        </p:nvSpPr>
+        <p:spPr>
+          <a:xfrm>
+            <a:off x="411480" y="1133856"/>
+            <a:ext cx="11368735" cy="20320"/>
+          </a:xfrm>
+          <a:prstGeom prst="rect">
+            <a:avLst/>
+          </a:prstGeom>
+          <a:solidFill>
+            <a:srgbClr val="B8C6D4"/>
+          </a:solidFill>
+          <a:ln>
+            <a:noFill/>
+          </a:ln>
+          <a:effectLst/>
+        </p:spPr>
+        <p:style>
+          <a:lnRef idx="1">
+            <a:schemeClr val="accent1"/>
+          </a:lnRef>
+          <a:fillRef idx="3">
+            <a:schemeClr val="accent1"/>
+          </a:fillRef>
+          <a:effectRef idx="2">
+            <a:schemeClr val="accent1"/>
+          </a:effectRef>
+          <a:fontRef idx="minor">
+            <a:schemeClr val="lt1"/>
+          </a:fontRef>
+        </p:style>
+        <p:txBody>
+          <a:bodyPr rtlCol="0" anchor="ctr"/>
+          <a:lstStyle/>
+          <a:p>
+            <a:pPr algn="ctr"/>
+          </a:p>
+        </p:txBody>
+      </p:sp>
+      <p:graphicFrame>
+        <p:nvGraphicFramePr>
+          <p:cNvPr id="4" name="Table 3"/>
+          <p:cNvGraphicFramePr>
+            <a:graphicFrameLocks noGrp="1"/>
+          </p:cNvGraphicFramePr>
+          <p:nvPr/>
+        </p:nvGraphicFramePr>
+        <p:xfrm>
+          <a:off x="411480" y="1298448"/>
+          <a:ext cx="11368735" cy="2057400"/>
+        </p:xfrm>
+        <a:graphic>
+          <a:graphicData uri="http://schemas.openxmlformats.org/drawingml/2006/table">
+            <a:tbl>
+              <a:tblPr firstRow="1" bandRow="1">
+                <a:tableStyleId>{5C22544A-7EE6-4342-B048-85BDC9FD1C3A}</a:tableStyleId>
+              </a:tblPr>
+              <a:tblGrid>
+                <a:gridCol w="1744472"/>
+                <a:gridCol w="1817116"/>
+                <a:gridCol w="3733853"/>
+                <a:gridCol w="4073294"/>
+              </a:tblGrid>
+              <a:tr h="280035">
+                <a:tc>
+                  <a:txBody>
+                    <a:bodyPr wrap="square"/>
+                    <a:lstStyle/>
+                    <a:p>
+                      <a:r>
+                        <a:rPr sz="1100" b="1">
+                          <a:solidFill>
+                            <a:srgbClr val="FFFFFF"/>
+                          </a:solidFill>
+                          <a:latin typeface="Arial"/>
+                        </a:rPr>
+                        <a:t>slide</a:t>
+                      </a:r>
+                    </a:p>
+                  </a:txBody>
+                  <a:tcPr marL="54864" marR="54864" marT="18288" marB="18288">
+                    <a:solidFill>
+                      <a:srgbClr val="1F4E79"/>
+                    </a:solidFill>
+                  </a:tcPr>
+                </a:tc>
+                <a:tc>
+                  <a:txBody>
+                    <a:bodyPr wrap="square"/>
+                    <a:lstStyle/>
+                    <a:p>
+                      <a:r>
+                        <a:rPr sz="1100" b="1">
+                          <a:solidFill>
+                            <a:srgbClr val="FFFFFF"/>
+                          </a:solidFill>
+                          <a:latin typeface="Arial"/>
+                        </a:rPr>
+                        <a:t>runner stage</a:t>
+                      </a:r>
+                    </a:p>
+                  </a:txBody>
+                  <a:tcPr marL="54864" marR="54864" marT="18288" marB="18288">
+                    <a:solidFill>
+                      <a:srgbClr val="1F4E79"/>
+                    </a:solidFill>
+                  </a:tcPr>
+                </a:tc>
+                <a:tc>
+                  <a:txBody>
+                    <a:bodyPr wrap="square"/>
+                    <a:lstStyle/>
+                    <a:p>
+                      <a:r>
+                        <a:rPr sz="1100" b="1">
+                          <a:solidFill>
+                            <a:srgbClr val="FFFFFF"/>
+                          </a:solidFill>
+                          <a:latin typeface="Arial"/>
+                        </a:rPr>
+                        <a:t>record</a:t>
+                      </a:r>
+                    </a:p>
+                  </a:txBody>
+                  <a:tcPr marL="54864" marR="54864" marT="18288" marB="18288">
+                    <a:solidFill>
+                      <a:srgbClr val="1F4E79"/>
+                    </a:solidFill>
+                  </a:tcPr>
+                </a:tc>
+                <a:tc>
+                  <a:txBody>
+                    <a:bodyPr wrap="square"/>
+                    <a:lstStyle/>
+                    <a:p>
+                      <a:r>
+                        <a:rPr sz="1100" b="1">
+                          <a:solidFill>
+                            <a:srgbClr val="FFFFFF"/>
+                          </a:solidFill>
+                          <a:latin typeface="Arial"/>
+                        </a:rPr>
+                        <a:t>tool</a:t>
+                      </a:r>
+                    </a:p>
+                  </a:txBody>
+                  <a:tcPr marL="54864" marR="54864" marT="18288" marB="18288">
+                    <a:solidFill>
+                      <a:srgbClr val="1F4E79"/>
+                    </a:solidFill>
+                  </a:tcPr>
+                </a:tc>
+              </a:tr>
+              <a:tr h="280035">
+                <a:tc>
+                  <a:txBody>
+                    <a:bodyPr wrap="square"/>
+                    <a:lstStyle/>
+                    <a:p>
+                      <a:r>
+                        <a:rPr sz="1100" b="0">
+                          <a:solidFill>
+                            <a:srgbClr val="282828"/>
+                          </a:solidFill>
+                          <a:latin typeface="Arial"/>
+                        </a:rPr>
+                        <a:t>scaling law</a:t>
+                      </a:r>
+                    </a:p>
+                  </a:txBody>
+                  <a:tcPr marL="54864" marR="54864" marT="18288" marB="18288">
+                    <a:solidFill>
+                      <a:srgbClr val="FFFFFF"/>
+                    </a:solidFill>
+                  </a:tcPr>
+                </a:tc>
+                <a:tc>
+                  <a:txBody>
+                    <a:bodyPr wrap="square"/>
+                    <a:lstStyle/>
+                    <a:p>
+                      <a:r>
+                        <a:rPr sz="1100" b="0">
+                          <a:solidFill>
+                            <a:srgbClr val="282828"/>
+                          </a:solidFill>
+                          <a:latin typeface="Arial"/>
+                        </a:rPr>
+                        <a:t>s0 (engine-free)</a:t>
+                      </a:r>
+                    </a:p>
+                  </a:txBody>
+                  <a:tcPr marL="54864" marR="54864" marT="18288" marB="18288">
+                    <a:solidFill>
+                      <a:srgbClr val="FFFFFF"/>
+                    </a:solidFill>
+                  </a:tcPr>
+                </a:tc>
+                <a:tc>
+                  <a:txBody>
+                    <a:bodyPr wrap="square"/>
+                    <a:lstStyle/>
+                    <a:p>
+                      <a:r>
+                        <a:rPr sz="1100" b="0">
+                          <a:solidFill>
+                            <a:srgbClr val="282828"/>
+                          </a:solidFill>
+                          <a:latin typeface="Arial"/>
+                        </a:rPr>
+                        <a:t>dyson5_s0_scaling.txt</a:t>
+                      </a:r>
+                    </a:p>
+                  </a:txBody>
+                  <a:tcPr marL="54864" marR="54864" marT="18288" marB="18288">
+                    <a:solidFill>
+                      <a:srgbClr val="FFFFFF"/>
+                    </a:solidFill>
+                  </a:tcPr>
+                </a:tc>
+                <a:tc>
+                  <a:txBody>
+                    <a:bodyPr wrap="square"/>
+                    <a:lstStyle/>
+                    <a:p>
+                      <a:r>
+                        <a:rPr sz="1100" b="0">
+                          <a:solidFill>
+                            <a:srgbClr val="282828"/>
+                          </a:solidFill>
+                          <a:latin typeface="Arial"/>
+                        </a:rPr>
+                        <a:t>design/src/dyson_layout.m, dyson_scaling.m</a:t>
+                      </a:r>
+                    </a:p>
+                  </a:txBody>
+                  <a:tcPr marL="54864" marR="54864" marT="18288" marB="18288">
+                    <a:solidFill>
+                      <a:srgbClr val="FFFFFF"/>
+                    </a:solidFill>
+                  </a:tcPr>
+                </a:tc>
+              </a:tr>
+              <a:tr h="468630">
+                <a:tc>
+                  <a:txBody>
+                    <a:bodyPr wrap="square"/>
+                    <a:lstStyle/>
+                    <a:p>
+                      <a:r>
+                        <a:rPr sz="1100" b="0">
+                          <a:solidFill>
+                            <a:srgbClr val="282828"/>
+                          </a:solidFill>
+                          <a:latin typeface="Arial"/>
+                        </a:rPr>
+                        <a:t>two forms, seed scored</a:t>
+                      </a:r>
+                    </a:p>
+                  </a:txBody>
+                  <a:tcPr marL="54864" marR="54864" marT="18288" marB="18288">
+                    <a:solidFill>
+                      <a:srgbClr val="ECF1F6"/>
+                    </a:solidFill>
+                  </a:tcPr>
+                </a:tc>
+                <a:tc>
+                  <a:txBody>
+                    <a:bodyPr wrap="square"/>
+                    <a:lstStyle/>
+                    <a:p>
+                      <a:r>
+                        <a:rPr sz="1100" b="0">
+                          <a:solidFill>
+                            <a:srgbClr val="282828"/>
+                          </a:solidFill>
+                          <a:latin typeface="Arial"/>
+                        </a:rPr>
+                        <a:t>s1 emit, s2 score</a:t>
+                      </a:r>
+                    </a:p>
+                  </a:txBody>
+                  <a:tcPr marL="54864" marR="54864" marT="18288" marB="18288">
+                    <a:solidFill>
+                      <a:srgbClr val="ECF1F6"/>
+                    </a:solidFill>
+                  </a:tcPr>
+                </a:tc>
+                <a:tc>
+                  <a:txBody>
+                    <a:bodyPr wrap="square"/>
+                    <a:lstStyle/>
+                    <a:p>
+                      <a:r>
+                        <a:rPr sz="1100" b="0">
+                          <a:solidFill>
+                            <a:srgbClr val="282828"/>
+                          </a:solidFill>
+                          <a:latin typeface="Arial"/>
+                        </a:rPr>
+                        <a:t>dyson5_s1.txt, dyson5_s2.txt, dyson5_s2_maps.png</a:t>
+                      </a:r>
+                    </a:p>
+                  </a:txBody>
+                  <a:tcPr marL="54864" marR="54864" marT="18288" marB="18288">
+                    <a:solidFill>
+                      <a:srgbClr val="ECF1F6"/>
+                    </a:solidFill>
+                  </a:tcPr>
+                </a:tc>
+                <a:tc>
+                  <a:txBody>
+                    <a:bodyPr wrap="square"/>
+                    <a:lstStyle/>
+                    <a:p>
+                      <a:r>
+                        <a:rPr sz="1100" b="0">
+                          <a:solidFill>
+                            <a:srgbClr val="282828"/>
+                          </a:solidFill>
+                          <a:latin typeface="Arial"/>
+                        </a:rPr>
+                        <a:t>spectrometer_geom.m, spectrometer_rx.m, spectrometer_score.m</a:t>
+                      </a:r>
+                    </a:p>
+                  </a:txBody>
+                  <a:tcPr marL="54864" marR="54864" marT="18288" marB="18288">
+                    <a:solidFill>
+                      <a:srgbClr val="ECF1F6"/>
+                    </a:solidFill>
+                  </a:tcPr>
+                </a:tc>
+              </a:tr>
+              <a:tr h="280035">
+                <a:tc>
+                  <a:txBody>
+                    <a:bodyPr wrap="square"/>
+                    <a:lstStyle/>
+                    <a:p>
+                      <a:r>
+                        <a:rPr sz="1100" b="0">
+                          <a:solidFill>
+                            <a:srgbClr val="282828"/>
+                          </a:solidFill>
+                          <a:latin typeface="Arial"/>
+                        </a:rPr>
+                        <a:t>chain vs engine</a:t>
+                      </a:r>
+                    </a:p>
+                  </a:txBody>
+                  <a:tcPr marL="54864" marR="54864" marT="18288" marB="18288">
+                    <a:solidFill>
+                      <a:srgbClr val="FFFFFF"/>
+                    </a:solidFill>
+                  </a:tcPr>
+                </a:tc>
+                <a:tc>
+                  <a:txBody>
+                    <a:bodyPr wrap="square"/>
+                    <a:lstStyle/>
+                    <a:p>
+                      <a:r>
+                        <a:rPr sz="1100" b="0">
+                          <a:solidFill>
+                            <a:srgbClr val="282828"/>
+                          </a:solidFill>
+                          <a:latin typeface="Arial"/>
+                        </a:rPr>
+                        <a:t>gate</a:t>
+                      </a:r>
+                    </a:p>
+                  </a:txBody>
+                  <a:tcPr marL="54864" marR="54864" marT="18288" marB="18288">
+                    <a:solidFill>
+                      <a:srgbClr val="FFFFFF"/>
+                    </a:solidFill>
+                  </a:tcPr>
+                </a:tc>
+                <a:tc>
+                  <a:txBody>
+                    <a:bodyPr wrap="square"/>
+                    <a:lstStyle/>
+                    <a:p>
+                      <a:r>
+                        <a:rPr sz="1100" b="0">
+                          <a:solidFill>
+                            <a:srgbClr val="282828"/>
+                          </a:solidFill>
+                          <a:latin typeface="Arial"/>
+                        </a:rPr>
+                        <a:t>tests/tSpectrometerRx.m</a:t>
+                      </a:r>
+                    </a:p>
+                  </a:txBody>
+                  <a:tcPr marL="54864" marR="54864" marT="18288" marB="18288">
+                    <a:solidFill>
+                      <a:srgbClr val="FFFFFF"/>
+                    </a:solidFill>
+                  </a:tcPr>
+                </a:tc>
+                <a:tc>
+                  <a:txBody>
+                    <a:bodyPr wrap="square"/>
+                    <a:lstStyle/>
+                    <a:p>
+                      <a:r>
+                        <a:rPr sz="1100" b="0">
+                          <a:solidFill>
+                            <a:srgbClr val="282828"/>
+                          </a:solidFill>
+                          <a:latin typeface="Arial"/>
+                        </a:rPr>
+                        <a:t>per-ray re-trace, 1e-9 m</a:t>
+                      </a:r>
+                    </a:p>
+                  </a:txBody>
+                  <a:tcPr marL="54864" marR="54864" marT="18288" marB="18288">
+                    <a:solidFill>
+                      <a:srgbClr val="FFFFFF"/>
+                    </a:solidFill>
+                  </a:tcPr>
+                </a:tc>
+              </a:tr>
+              <a:tr h="280035">
+                <a:tc>
+                  <a:txBody>
+                    <a:bodyPr wrap="square"/>
+                    <a:lstStyle/>
+                    <a:p>
+                      <a:r>
+                        <a:rPr sz="1100" b="0">
+                          <a:solidFill>
+                            <a:srgbClr val="282828"/>
+                          </a:solidFill>
+                          <a:latin typeface="Arial"/>
+                        </a:rPr>
+                        <a:t>propagation twin</a:t>
+                      </a:r>
+                    </a:p>
+                  </a:txBody>
+                  <a:tcPr marL="54864" marR="54864" marT="18288" marB="18288">
+                    <a:solidFill>
+                      <a:srgbClr val="ECF1F6"/>
+                    </a:solidFill>
+                  </a:tcPr>
+                </a:tc>
+                <a:tc>
+                  <a:txBody>
+                    <a:bodyPr wrap="square"/>
+                    <a:lstStyle/>
+                    <a:p>
+                      <a:r>
+                        <a:rPr sz="1100" b="0">
+                          <a:solidFill>
+                            <a:srgbClr val="282828"/>
+                          </a:solidFill>
+                          <a:latin typeface="Arial"/>
+                        </a:rPr>
+                        <a:t>s2w (opt-in, model 512)</a:t>
+                      </a:r>
+                    </a:p>
+                  </a:txBody>
+                  <a:tcPr marL="54864" marR="54864" marT="18288" marB="18288">
+                    <a:solidFill>
+                      <a:srgbClr val="ECF1F6"/>
+                    </a:solidFill>
+                  </a:tcPr>
+                </a:tc>
+                <a:tc>
+                  <a:txBody>
+                    <a:bodyPr wrap="square"/>
+                    <a:lstStyle/>
+                    <a:p>
+                      <a:r>
+                        <a:rPr sz="1100" b="0">
+                          <a:solidFill>
+                            <a:srgbClr val="282828"/>
+                          </a:solidFill>
+                          <a:latin typeface="Arial"/>
+                        </a:rPr>
+                        <a:t>dyson5_s2w.txt</a:t>
+                      </a:r>
+                    </a:p>
+                  </a:txBody>
+                  <a:tcPr marL="54864" marR="54864" marT="18288" marB="18288">
+                    <a:solidFill>
+                      <a:srgbClr val="ECF1F6"/>
+                    </a:solidFill>
+                  </a:tcPr>
+                </a:tc>
+                <a:tc>
+                  <a:txBody>
+                    <a:bodyPr wrap="square"/>
+                    <a:lstStyle/>
+                    <a:p>
+                      <a:r>
+                        <a:rPr sz="1100" b="0">
+                          <a:solidFill>
+                            <a:srgbClr val="282828"/>
+                          </a:solidFill>
+                          <a:latin typeface="Arial"/>
+                        </a:rPr>
+                        <a:t>spectrometer_wave.m</a:t>
+                      </a:r>
+                    </a:p>
+                  </a:txBody>
+                  <a:tcPr marL="54864" marR="54864" marT="18288" marB="18288">
+                    <a:solidFill>
+                      <a:srgbClr val="ECF1F6"/>
+                    </a:solidFill>
+                  </a:tcPr>
+                </a:tc>
+              </a:tr>
+              <a:tr h="468630">
+                <a:tc>
+                  <a:txBody>
+                    <a:bodyPr wrap="square"/>
+                    <a:lstStyle/>
+                    <a:p>
+                      <a:r>
+                        <a:rPr sz="1100" b="0">
+                          <a:solidFill>
+                            <a:srgbClr val="282828"/>
+                          </a:solidFill>
+                          <a:latin typeface="Arial"/>
+                        </a:rPr>
+                        <a:t>departure ladder</a:t>
+                      </a:r>
+                    </a:p>
+                  </a:txBody>
+                  <a:tcPr marL="54864" marR="54864" marT="18288" marB="18288">
+                    <a:solidFill>
+                      <a:srgbClr val="FFFFFF"/>
+                    </a:solidFill>
+                  </a:tcPr>
+                </a:tc>
+                <a:tc>
+                  <a:txBody>
+                    <a:bodyPr wrap="square"/>
+                    <a:lstStyle/>
+                    <a:p>
+                      <a:r>
+                        <a:rPr sz="1100" b="0">
+                          <a:solidFill>
+                            <a:srgbClr val="282828"/>
+                          </a:solidFill>
+                          <a:latin typeface="Arial"/>
+                        </a:rPr>
+                        <a:t>s3, s3free</a:t>
+                      </a:r>
+                    </a:p>
+                  </a:txBody>
+                  <a:tcPr marL="54864" marR="54864" marT="18288" marB="18288">
+                    <a:solidFill>
+                      <a:srgbClr val="FFFFFF"/>
+                    </a:solidFill>
+                  </a:tcPr>
+                </a:tc>
+                <a:tc>
+                  <a:txBody>
+                    <a:bodyPr wrap="square"/>
+                    <a:lstStyle/>
+                    <a:p>
+                      <a:r>
+                        <a:rPr sz="1100" b="0">
+                          <a:solidFill>
+                            <a:srgbClr val="282828"/>
+                          </a:solidFill>
+                          <a:latin typeface="Arial"/>
+                        </a:rPr>
+                        <a:t>dyson5_s3.txt, dyson5_s3free.txt, dyson5_s3*_ladder.png</a:t>
+                      </a:r>
+                    </a:p>
+                  </a:txBody>
+                  <a:tcPr marL="54864" marR="54864" marT="18288" marB="18288">
+                    <a:solidFill>
+                      <a:srgbClr val="FFFFFF"/>
+                    </a:solidFill>
+                  </a:tcPr>
+                </a:tc>
+                <a:tc>
+                  <a:txBody>
+                    <a:bodyPr wrap="square"/>
+                    <a:lstStyle/>
+                    <a:p>
+                      <a:r>
+                        <a:rPr sz="1100" b="0">
+                          <a:solidFill>
+                            <a:srgbClr val="282828"/>
+                          </a:solidFill>
+                          <a:latin typeface="Arial"/>
+                        </a:rPr>
+                        <a:t>dyson_ladder.m</a:t>
+                      </a:r>
+                    </a:p>
+                  </a:txBody>
+                  <a:tcPr marL="54864" marR="54864" marT="18288" marB="18288">
+                    <a:solidFill>
+                      <a:srgbClr val="FFFFFF"/>
+                    </a:solidFill>
+                  </a:tcPr>
+                </a:tc>
+              </a:tr>
+            </a:tbl>
+          </a:graphicData>
+        </a:graphic>
+      </p:graphicFrame>
+      <p:sp>
+        <p:nvSpPr>
+          <p:cNvPr id="5" name="TextBox 4"/>
+          <p:cNvSpPr txBox="1"/>
+          <p:nvPr/>
+        </p:nvSpPr>
+        <p:spPr>
+          <a:xfrm>
+            <a:off x="411480" y="3502152"/>
+            <a:ext cx="11368735" cy="274320"/>
+          </a:xfrm>
+          <a:prstGeom prst="rect">
+            <a:avLst/>
+          </a:prstGeom>
+          <a:noFill/>
+        </p:spPr>
+        <p:txBody>
+          <a:bodyPr wrap="square">
+            <a:spAutoFit/>
+          </a:bodyPr>
+          <a:lstStyle/>
+          <a:p>
+            <a:pPr>
+              <a:spcAft>
+                <a:spcPts val="600"/>
+              </a:spcAft>
+            </a:pPr>
+            <a:r>
+              <a:rPr sz="1050" b="0">
+                <a:solidFill>
+                  <a:srgbClr val="6E6E6E"/>
+                </a:solidFill>
+                <a:latin typeface="Arial"/>
+              </a:rPr>
+              <a:t>Conventions behind the scaling law: block index n(silica, 1 µm) = 1.450417; in-glass marginal half-angle u = asin(1 / 2nF); field height h from the Dyson axis on the flat face; the slit corner is h = hypot(27 mm, 8 mm).</a:t>
+            </a:r>
+          </a:p>
+        </p:txBody>
+      </p:sp>
+    </p:spTree>
+  </p:cSld>
+  <p:clrMapOvr>
+    <a:masterClrMapping/>
+  </p:clrMapOvr>
+</p:sld>
+</file>
+
+<file path=ppt/slides/slide16.xml><?xml version="1.0" encoding="utf-8"?>
+<p:sld xmlns:a="http://schemas.openxmlformats.org/drawingml/2006/main" xmlns:p="http://schemas.openxmlformats.org/presentationml/2006/main" xmlns:r="http://schemas.openxmlformats.org/officeDocument/2006/relationships">
+  <p:cSld>
+    <p:spTree>
+      <p:nvGrpSpPr>
+        <p:cNvPr id="1" name=""/>
+        <p:cNvGrpSpPr/>
+        <p:nvPr/>
+      </p:nvGrpSpPr>
+      <p:grpSpPr/>
+      <p:sp>
+        <p:nvSpPr>
+          <p:cNvPr id="2" name="TextBox 1"/>
+          <p:cNvSpPr txBox="1"/>
+          <p:nvPr/>
+        </p:nvSpPr>
+        <p:spPr>
+          <a:xfrm>
+            <a:off x="411480" y="201168"/>
+            <a:ext cx="11368735" cy="914400"/>
+          </a:xfrm>
+          <a:prstGeom prst="rect">
+            <a:avLst/>
+          </a:prstGeom>
+          <a:noFill/>
+        </p:spPr>
+        <p:txBody>
+          <a:bodyPr wrap="square">
+            <a:spAutoFit/>
+          </a:bodyPr>
+          <a:lstStyle/>
+          <a:p>
+            <a:pPr>
+              <a:spcAft>
+                <a:spcPts val="400"/>
+              </a:spcAft>
+            </a:pPr>
+            <a:r>
+              <a:rPr sz="2400" b="1">
+                <a:solidFill>
+                  <a:srgbClr val="1F4E79"/>
+                </a:solidFill>
+                <a:latin typeface="Arial"/>
+              </a:rPr>
               <a:t>Backup: conventions pinned on the way</a:t>
             </a:r>
           </a:p>
@@ -6393,45 +7118,6 @@
           </a:p>
         </p:txBody>
       </p:sp>
-      <p:sp>
-        <p:nvSpPr>
-          <p:cNvPr id="7" name="TextBox 6"/>
-          <p:cNvSpPr txBox="1"/>
-          <p:nvPr/>
-        </p:nvSpPr>
-        <p:spPr>
-          <a:xfrm>
-            <a:off x="411480" y="6748272"/>
-            <a:ext cx="11368735" cy="274320"/>
-          </a:xfrm>
-          <a:prstGeom prst="rect">
-            <a:avLst/>
-          </a:prstGeom>
-          <a:noFill/>
-        </p:spPr>
-        <p:txBody>
-          <a:bodyPr wrap="square">
-            <a:spAutoFit/>
-          </a:bodyPr>
-          <a:lstStyle/>
-          <a:p>
-            <a:pPr>
-              <a:spcAft>
-                <a:spcPts val="600"/>
-              </a:spcAft>
-            </a:pPr>
-            <a:r>
-              <a:rPr sz="1050" b="0">
-                <a:solidFill>
-                  <a:srgbClr val="6E6E6E"/>
-                </a:solidFill>
-                <a:latin typeface="Arial"/>
-              </a:rPr>
-              <a:t>Chain spectrometer_geom.m, emitter spectrometer_rx.m; the groove period is solved so the band spans the 9 mm focal plane.</a:t>
-            </a:r>
-          </a:p>
-        </p:txBody>
-      </p:sp>
     </p:spTree>
   </p:cSld>
   <p:clrMapOvr>
@@ -6667,45 +7353,6 @@
           </a:p>
         </p:txBody>
       </p:sp>
-      <p:sp>
-        <p:nvSpPr>
-          <p:cNvPr id="7" name="TextBox 6"/>
-          <p:cNvSpPr txBox="1"/>
-          <p:nvPr/>
-        </p:nvSpPr>
-        <p:spPr>
-          <a:xfrm>
-            <a:off x="411480" y="6748272"/>
-            <a:ext cx="11368735" cy="274320"/>
-          </a:xfrm>
-          <a:prstGeom prst="rect">
-            <a:avLst/>
-          </a:prstGeom>
-          <a:noFill/>
-        </p:spPr>
-        <p:txBody>
-          <a:bodyPr wrap="square">
-            <a:spAutoFit/>
-          </a:bodyPr>
-          <a:lstStyle/>
-          <a:p>
-            <a:pPr>
-              <a:spcAft>
-                <a:spcPts val="600"/>
-              </a:spcAft>
-            </a:pPr>
-            <a:r>
-              <a:rPr sz="1050" b="0">
-                <a:solidFill>
-                  <a:srgbClr val="6E6E6E"/>
-                </a:solidFill>
-                <a:latin typeface="Arial"/>
-              </a:rPr>
-              <a:t>Runner stage s0 (engine-free); record dyson5_s0_scaling.txt.  Block index n(silica, 1 µm) = 1.450417; in-glass marginal half-angle u = asin(1 / 2nF).</a:t>
-            </a:r>
-          </a:p>
-        </p:txBody>
-      </p:sp>
     </p:spTree>
   </p:cSld>
   <p:clrMapOvr>
@@ -7203,45 +7850,6 @@
                 <a:latin typeface="Arial"/>
               </a:rPr>
               <a:t>Scorer maps for the two seeds at 220 mm (rows: Dyson, Offner): field-angle map, smile (pixels), SRF FWHM (pixels), ensquared energy in one pixel, versus slit position and wavelength.</a:t>
-            </a:r>
-          </a:p>
-        </p:txBody>
-      </p:sp>
-      <p:sp>
-        <p:nvSpPr>
-          <p:cNvPr id="7" name="TextBox 6"/>
-          <p:cNvSpPr txBox="1"/>
-          <p:nvPr/>
-        </p:nvSpPr>
-        <p:spPr>
-          <a:xfrm>
-            <a:off x="411480" y="6748272"/>
-            <a:ext cx="11368735" cy="274320"/>
-          </a:xfrm>
-          <a:prstGeom prst="rect">
-            <a:avLst/>
-          </a:prstGeom>
-          <a:noFill/>
-        </p:spPr>
-        <p:txBody>
-          <a:bodyPr wrap="square">
-            <a:spAutoFit/>
-          </a:bodyPr>
-          <a:lstStyle/>
-          <a:p>
-            <a:pPr>
-              <a:spcAft>
-                <a:spcPts val="600"/>
-              </a:spcAft>
-            </a:pPr>
-            <a:r>
-              <a:rPr sz="1050" b="0">
-                <a:solidFill>
-                  <a:srgbClr val="6E6E6E"/>
-                </a:solidFill>
-                <a:latin typeface="Arial"/>
-              </a:rPr>
-              <a:t>Records dyson5_s1.txt, dyson5_s2.txt.</a:t>
             </a:r>
           </a:p>
         </p:txBody>

</xml_diff>

<commit_message>
deck_dyson: the two layout slides state what the renders showed -- no apertures declared, the Offner's grating inside the slit beam (slit offset to ~0.2 R), the Dyson's element sizes and slit-to-band distance
Co-Authored-By: Claude Fable 5.1 <noreply@anthropic.com>
</commit_message>
<xml_diff>
--- a/demo_session/deck_dyson.pptx
+++ b/demo_session/deck_dyson.pptx
@@ -7914,7 +7914,7 @@
                 </a:solidFill>
                 <a:latin typeface="Arial"/>
               </a:rPr>
-              <a:t>Step R3 of the ladder: silica block, air gap, concave grating at the stop; rays from the slit return dispersed to the focal plane on the block's face</a:t>
+              <a:t>Step R3 of the ladder, before apertures: the beams clear every body, but the grating is 270 mm wide on a 0.70 m radius and the slit sits 18 mm from the band</a:t>
             </a:r>
           </a:p>
         </p:txBody>
@@ -8013,7 +8013,23 @@
                 </a:solidFill>
                 <a:latin typeface="Arial"/>
               </a:rPr>
-              <a:t>•  The slit sits on the block's flat face, so the glass is the source medium and only the spherical face is a refracting element; the dispersion is the fan in the right-hand (Y-Z) view returning to the face.</a:t>
+              <a:t>•  Sizes from the traced footprints: block face 85 mm across at the sphere (220 mm radius, 217 mm thick), grating 270 mm across (0.70 m radius) at 0.69 m from the face; slit at +6 mm, this wavelength lands at −12 mm on the same face.</a:t>
+            </a:r>
+          </a:p>
+          <a:p>
+            <a:pPr>
+              <a:spcAft>
+                <a:spcPts val="600"/>
+              </a:spcAft>
+            </a:pPr>
+            <a:r>
+              <a:rPr sz="1500" b="0">
+                <a:solidFill>
+                  <a:srgbClr val="282828"/>
+                </a:solidFill>
+                <a:latin typeface="Arial"/>
+              </a:rPr>
+              <a:t>•  No element declares an aperture yet, so the block draws as the beam's hull and nothing can vignette; apertures, a clearance check and the slit-to-detector package split are the next revision of this layout.</a:t>
             </a:r>
           </a:p>
         </p:txBody>
@@ -8034,8 +8050,8 @@
         </p:blipFill>
         <p:spPr>
           <a:xfrm>
-            <a:off x="3875145" y="2853690"/>
-            <a:ext cx="4441404" cy="3610610"/>
+            <a:off x="4266013" y="3489197"/>
+            <a:ext cx="3659667" cy="2975102"/>
           </a:xfrm>
           <a:prstGeom prst="rect">
             <a:avLst/>
@@ -8149,7 +8165,7 @@
                 </a:solidFill>
                 <a:latin typeface="Arial"/>
               </a:rPr>
-              <a:t>The all-reflective twin: concave mirror, convex grating at the common centre, concave mirror; all in air</a:t>
+              <a:t>The all-reflective twin at F/2.8, before apertures: the grating sits inside the slit-to-mirror beam, so the slit must move out to about 0.2 R</a:t>
             </a:r>
           </a:p>
         </p:txBody>
@@ -8248,7 +8264,23 @@
                 </a:solidFill>
                 <a:latin typeface="Arial"/>
               </a:rPr>
-              <a:t>•  Why it is in the deck: it is where the physical-optics twin is validated (order 0: pupil OPD 8e-11 m, 94 % of the energy in one pixel), and it is the trade's reference form.</a:t>
+              <a:t>•  Obstruction, measured from the ray history: the slit-to-M1 beam crosses the grating's plane over y = −39 to +51 mm while the grating's footprint spans ±45 mm; the return beam crosses it over −58 to +33 mm.  With no apertures declared the trace cannot see this; the slit offset of 6 mm must become about 100 mm (0.2 R, the classical Offner geometry) and the layout re-scored.</a:t>
+            </a:r>
+          </a:p>
+          <a:p>
+            <a:pPr>
+              <a:spcAft>
+                <a:spcPts val="600"/>
+              </a:spcAft>
+            </a:pPr>
+            <a:r>
+              <a:rPr sz="1500" b="0">
+                <a:solidFill>
+                  <a:srgbClr val="282828"/>
+                </a:solidFill>
+                <a:latin typeface="Arial"/>
+              </a:rPr>
+              <a:t>•  Why it stays in the deck: it is where the physical-optics twin is validated (order 0: pupil OPD 8e-11 m, 94 % of the energy in one pixel) and the trade's reference form.</a:t>
             </a:r>
           </a:p>
         </p:txBody>
@@ -8269,8 +8301,8 @@
         </p:blipFill>
         <p:spPr>
           <a:xfrm>
-            <a:off x="3752280" y="2606039"/>
-            <a:ext cx="4687133" cy="3858260"/>
+            <a:off x="4439151" y="3736848"/>
+            <a:ext cx="3313393" cy="2727452"/>
           </a:xfrm>
           <a:prstGeom prst="rect">
             <a:avLst/>

</xml_diff>

<commit_message>
deck_dyson: the compact variant R4 as the design of record (engine render, TO's section, maps, the trade with size columns), the propagation twin and slit-loss evidence, re-scored seed, next steps incl. the EMIT telescope
Co-Authored-By: Claude Fable 5.1 <noreply@anthropic.com>
</commit_message>
<xml_diff>
--- a/demo_session/deck_dyson.pptx
+++ b/demo_session/deck_dyson.pptx
@@ -22,6 +22,12 @@
     <p:sldId id="270" r:id="rId21"/>
     <p:sldId id="271" r:id="rId22"/>
     <p:sldId id="272" r:id="rId23"/>
+    <p:sldId id="273" r:id="rId24"/>
+    <p:sldId id="274" r:id="rId25"/>
+    <p:sldId id="275" r:id="rId26"/>
+    <p:sldId id="276" r:id="rId27"/>
+    <p:sldId id="277" r:id="rId28"/>
+    <p:sldId id="278" r:id="rId29"/>
   </p:sldIdLst>
   <p:sldSz cx="12191695" cy="6858000" type="screen4x3"/>
   <p:notesSz cx="6858000" cy="9144000"/>
@@ -3202,7 +3208,7 @@
                 </a:solidFill>
                 <a:latin typeface="Arial"/>
               </a:rPr>
-              <a:t>DRAFT — in progress.  Every number is from a committed, parameterized runner (mmacos, dyson5_run); records and figures are the runner's own output.</a:t>
+              <a:t>DRAFT — in progress.  Every number is from a committed, parameterized runner (mmacos, dyson5_run); records and figures are the runner's own output.  Design of record: the compact variant (step R4): keystone 0.0026 px, smile 0.005 px, CRF 1.33 px, 76 % of the energy in one pixel, at a 220 mm block.</a:t>
             </a:r>
           </a:p>
         </p:txBody>
@@ -3299,7 +3305,7 @@
                 </a:solidFill>
                 <a:latin typeface="Arial"/>
               </a:rPr>
-              <a:t>Keystone falls nine-fold at fixed scale; smile and SRF stay at their floors</a:t>
+              <a:t>Keystone falls 37-fold at fixed scale; the meniscus pays only with the block offset and grating radius moving with it</a:t>
             </a:r>
           </a:p>
         </p:txBody>
@@ -3358,7 +3364,7 @@
         </p:nvGraphicFramePr>
         <p:xfrm>
           <a:off x="411480" y="1298448"/>
-          <a:ext cx="11368735" cy="1400175"/>
+          <a:ext cx="11368731" cy="2806065"/>
         </p:xfrm>
         <a:graphic>
           <a:graphicData uri="http://schemas.openxmlformats.org/drawingml/2006/table">
@@ -3367,14 +3373,17 @@
                 <a:tableStyleId>{5C22544A-7EE6-4342-B048-85BDC9FD1C3A}</a:tableStyleId>
               </a:tblPr>
               <a:tblGrid>
-                <a:gridCol w="436880"/>
-                <a:gridCol w="6641795"/>
-                <a:gridCol w="1090676"/>
-                <a:gridCol w="872744"/>
-                <a:gridCol w="1090676"/>
-                <a:gridCol w="1235964"/>
+                <a:gridCol w="724123"/>
+                <a:gridCol w="3910265"/>
+                <a:gridCol w="941360"/>
+                <a:gridCol w="724123"/>
+                <a:gridCol w="941360"/>
+                <a:gridCol w="1086184"/>
+                <a:gridCol w="796535"/>
+                <a:gridCol w="1593071"/>
+                <a:gridCol w="651710"/>
               </a:tblGrid>
-              <a:tr h="280035">
+              <a:tr h="468630">
                 <a:tc>
                   <a:txBody>
                     <a:bodyPr wrap="square"/>
@@ -3498,6 +3507,72 @@
                           <a:latin typeface="Arial"/>
                         </a:rPr>
                         <a:t>ensquared, 1 px</a:t>
+                      </a:r>
+                    </a:p>
+                  </a:txBody>
+                  <a:tcPr marL="54864" marR="54864" marT="18288" marB="18288">
+                    <a:solidFill>
+                      <a:srgbClr val="1F4E79"/>
+                    </a:solidFill>
+                  </a:tcPr>
+                </a:tc>
+                <a:tc>
+                  <a:txBody>
+                    <a:bodyPr wrap="square"/>
+                    <a:lstStyle/>
+                    <a:p>
+                      <a:r>
+                        <a:rPr sz="1100" b="1">
+                          <a:solidFill>
+                            <a:srgbClr val="FFFFFF"/>
+                          </a:solidFill>
+                          <a:latin typeface="Arial"/>
+                        </a:rPr>
+                        <a:t>length (mm)</a:t>
+                      </a:r>
+                    </a:p>
+                  </a:txBody>
+                  <a:tcPr marL="54864" marR="54864" marT="18288" marB="18288">
+                    <a:solidFill>
+                      <a:srgbClr val="1F4E79"/>
+                    </a:solidFill>
+                  </a:tcPr>
+                </a:tc>
+                <a:tc>
+                  <a:txBody>
+                    <a:bodyPr wrap="square"/>
+                    <a:lstStyle/>
+                    <a:p>
+                      <a:r>
+                        <a:rPr sz="1100" b="1">
+                          <a:solidFill>
+                            <a:srgbClr val="FFFFFF"/>
+                          </a:solidFill>
+                          <a:latin typeface="Arial"/>
+                        </a:rPr>
+                        <a:t>grating footprint (mm)</a:t>
+                      </a:r>
+                    </a:p>
+                  </a:txBody>
+                  <a:tcPr marL="54864" marR="54864" marT="18288" marB="18288">
+                    <a:solidFill>
+                      <a:srgbClr val="1F4E79"/>
+                    </a:solidFill>
+                  </a:tcPr>
+                </a:tc>
+                <a:tc>
+                  <a:txBody>
+                    <a:bodyPr wrap="square"/>
+                    <a:lstStyle/>
+                    <a:p>
+                      <a:r>
+                        <a:rPr sz="1100" b="1">
+                          <a:solidFill>
+                            <a:srgbClr val="FFFFFF"/>
+                          </a:solidFill>
+                          <a:latin typeface="Arial"/>
+                        </a:rPr>
+                        <a:t>glass (L)</a:t>
                       </a:r>
                     </a:p>
                   </a:txBody>
@@ -3641,6 +3716,72 @@
                     </a:solidFill>
                   </a:tcPr>
                 </a:tc>
+                <a:tc>
+                  <a:txBody>
+                    <a:bodyPr wrap="square"/>
+                    <a:lstStyle/>
+                    <a:p>
+                      <a:r>
+                        <a:rPr sz="1100" b="0">
+                          <a:solidFill>
+                            <a:srgbClr val="282828"/>
+                          </a:solidFill>
+                          <a:latin typeface="Arial"/>
+                        </a:rPr>
+                        <a:t>708</a:t>
+                      </a:r>
+                    </a:p>
+                  </a:txBody>
+                  <a:tcPr marL="54864" marR="54864" marT="18288" marB="18288">
+                    <a:solidFill>
+                      <a:srgbClr val="FFFFFF"/>
+                    </a:solidFill>
+                  </a:tcPr>
+                </a:tc>
+                <a:tc>
+                  <a:txBody>
+                    <a:bodyPr wrap="square"/>
+                    <a:lstStyle/>
+                    <a:p>
+                      <a:r>
+                        <a:rPr sz="1100" b="0">
+                          <a:solidFill>
+                            <a:srgbClr val="282828"/>
+                          </a:solidFill>
+                          <a:latin typeface="Arial"/>
+                        </a:rPr>
+                        <a:t>275</a:t>
+                      </a:r>
+                    </a:p>
+                  </a:txBody>
+                  <a:tcPr marL="54864" marR="54864" marT="18288" marB="18288">
+                    <a:solidFill>
+                      <a:srgbClr val="FFFFFF"/>
+                    </a:solidFill>
+                  </a:tcPr>
+                </a:tc>
+                <a:tc>
+                  <a:txBody>
+                    <a:bodyPr wrap="square"/>
+                    <a:lstStyle/>
+                    <a:p>
+                      <a:r>
+                        <a:rPr sz="1100" b="0">
+                          <a:solidFill>
+                            <a:srgbClr val="282828"/>
+                          </a:solidFill>
+                          <a:latin typeface="Arial"/>
+                        </a:rPr>
+                        <a:t>22.2</a:t>
+                      </a:r>
+                    </a:p>
+                  </a:txBody>
+                  <a:tcPr marL="54864" marR="54864" marT="18288" marB="18288">
+                    <a:solidFill>
+                      <a:srgbClr val="FFFFFF"/>
+                    </a:solidFill>
+                  </a:tcPr>
+                </a:tc>
               </a:tr>
               <a:tr h="280035">
                 <a:tc>
@@ -3775,6 +3916,72 @@
                     </a:solidFill>
                   </a:tcPr>
                 </a:tc>
+                <a:tc>
+                  <a:txBody>
+                    <a:bodyPr wrap="square"/>
+                    <a:lstStyle/>
+                    <a:p>
+                      <a:r>
+                        <a:rPr sz="1100" b="0">
+                          <a:solidFill>
+                            <a:srgbClr val="282828"/>
+                          </a:solidFill>
+                          <a:latin typeface="Arial"/>
+                        </a:rPr>
+                        <a:t>704</a:t>
+                      </a:r>
+                    </a:p>
+                  </a:txBody>
+                  <a:tcPr marL="54864" marR="54864" marT="18288" marB="18288">
+                    <a:solidFill>
+                      <a:srgbClr val="ECF1F6"/>
+                    </a:solidFill>
+                  </a:tcPr>
+                </a:tc>
+                <a:tc>
+                  <a:txBody>
+                    <a:bodyPr wrap="square"/>
+                    <a:lstStyle/>
+                    <a:p>
+                      <a:r>
+                        <a:rPr sz="1100" b="0">
+                          <a:solidFill>
+                            <a:srgbClr val="282828"/>
+                          </a:solidFill>
+                          <a:latin typeface="Arial"/>
+                        </a:rPr>
+                        <a:t>274</a:t>
+                      </a:r>
+                    </a:p>
+                  </a:txBody>
+                  <a:tcPr marL="54864" marR="54864" marT="18288" marB="18288">
+                    <a:solidFill>
+                      <a:srgbClr val="ECF1F6"/>
+                    </a:solidFill>
+                  </a:tcPr>
+                </a:tc>
+                <a:tc>
+                  <a:txBody>
+                    <a:bodyPr wrap="square"/>
+                    <a:lstStyle/>
+                    <a:p>
+                      <a:r>
+                        <a:rPr sz="1100" b="0">
+                          <a:solidFill>
+                            <a:srgbClr val="282828"/>
+                          </a:solidFill>
+                          <a:latin typeface="Arial"/>
+                        </a:rPr>
+                        <a:t>22.3</a:t>
+                      </a:r>
+                    </a:p>
+                  </a:txBody>
+                  <a:tcPr marL="54864" marR="54864" marT="18288" marB="18288">
+                    <a:solidFill>
+                      <a:srgbClr val="ECF1F6"/>
+                    </a:solidFill>
+                  </a:tcPr>
+                </a:tc>
               </a:tr>
               <a:tr h="280035">
                 <a:tc>
@@ -3909,6 +4116,272 @@
                     </a:solidFill>
                   </a:tcPr>
                 </a:tc>
+                <a:tc>
+                  <a:txBody>
+                    <a:bodyPr wrap="square"/>
+                    <a:lstStyle/>
+                    <a:p>
+                      <a:r>
+                        <a:rPr sz="1100" b="0">
+                          <a:solidFill>
+                            <a:srgbClr val="282828"/>
+                          </a:solidFill>
+                          <a:latin typeface="Arial"/>
+                        </a:rPr>
+                        <a:t>704</a:t>
+                      </a:r>
+                    </a:p>
+                  </a:txBody>
+                  <a:tcPr marL="54864" marR="54864" marT="18288" marB="18288">
+                    <a:solidFill>
+                      <a:srgbClr val="FFFFFF"/>
+                    </a:solidFill>
+                  </a:tcPr>
+                </a:tc>
+                <a:tc>
+                  <a:txBody>
+                    <a:bodyPr wrap="square"/>
+                    <a:lstStyle/>
+                    <a:p>
+                      <a:r>
+                        <a:rPr sz="1100" b="0">
+                          <a:solidFill>
+                            <a:srgbClr val="282828"/>
+                          </a:solidFill>
+                          <a:latin typeface="Arial"/>
+                        </a:rPr>
+                        <a:t>274</a:t>
+                      </a:r>
+                    </a:p>
+                  </a:txBody>
+                  <a:tcPr marL="54864" marR="54864" marT="18288" marB="18288">
+                    <a:solidFill>
+                      <a:srgbClr val="FFFFFF"/>
+                    </a:solidFill>
+                  </a:tcPr>
+                </a:tc>
+                <a:tc>
+                  <a:txBody>
+                    <a:bodyPr wrap="square"/>
+                    <a:lstStyle/>
+                    <a:p>
+                      <a:r>
+                        <a:rPr sz="1100" b="0">
+                          <a:solidFill>
+                            <a:srgbClr val="282828"/>
+                          </a:solidFill>
+                          <a:latin typeface="Arial"/>
+                        </a:rPr>
+                        <a:t>22.3</a:t>
+                      </a:r>
+                    </a:p>
+                  </a:txBody>
+                  <a:tcPr marL="54864" marR="54864" marT="18288" marB="18288">
+                    <a:solidFill>
+                      <a:srgbClr val="FFFFFF"/>
+                    </a:solidFill>
+                  </a:tcPr>
+                </a:tc>
+              </a:tr>
+              <a:tr h="468630">
+                <a:tc>
+                  <a:txBody>
+                    <a:bodyPr wrap="square"/>
+                    <a:lstStyle/>
+                    <a:p>
+                      <a:r>
+                        <a:rPr sz="1100" b="0">
+                          <a:solidFill>
+                            <a:srgbClr val="282828"/>
+                          </a:solidFill>
+                          <a:latin typeface="Arial"/>
+                        </a:rPr>
+                        <a:t>R3</a:t>
+                      </a:r>
+                    </a:p>
+                  </a:txBody>
+                  <a:tcPr marL="54864" marR="54864" marT="18288" marB="18288">
+                    <a:solidFill>
+                      <a:srgbClr val="ECF1F6"/>
+                    </a:solidFill>
+                  </a:tcPr>
+                </a:tc>
+                <a:tc>
+                  <a:txBody>
+                    <a:bodyPr wrap="square"/>
+                    <a:lstStyle/>
+                    <a:p>
+                      <a:r>
+                        <a:rPr sz="1100" b="0">
+                          <a:solidFill>
+                            <a:srgbClr val="282828"/>
+                          </a:solidFill>
+                          <a:latin typeface="Arial"/>
+                        </a:rPr>
+                        <a:t>+ block centre off the grating's, along the dispersion</a:t>
+                      </a:r>
+                    </a:p>
+                  </a:txBody>
+                  <a:tcPr marL="54864" marR="54864" marT="18288" marB="18288">
+                    <a:solidFill>
+                      <a:srgbClr val="ECF1F6"/>
+                    </a:solidFill>
+                  </a:tcPr>
+                </a:tc>
+                <a:tc>
+                  <a:txBody>
+                    <a:bodyPr wrap="square"/>
+                    <a:lstStyle/>
+                    <a:p>
+                      <a:r>
+                        <a:rPr sz="1100" b="0">
+                          <a:solidFill>
+                            <a:srgbClr val="282828"/>
+                          </a:solidFill>
+                          <a:latin typeface="Arial"/>
+                        </a:rPr>
+                        <a:t>0.011</a:t>
+                      </a:r>
+                    </a:p>
+                  </a:txBody>
+                  <a:tcPr marL="54864" marR="54864" marT="18288" marB="18288">
+                    <a:solidFill>
+                      <a:srgbClr val="ECF1F6"/>
+                    </a:solidFill>
+                  </a:tcPr>
+                </a:tc>
+                <a:tc>
+                  <a:txBody>
+                    <a:bodyPr wrap="square"/>
+                    <a:lstStyle/>
+                    <a:p>
+                      <a:r>
+                        <a:rPr sz="1100" b="0">
+                          <a:solidFill>
+                            <a:srgbClr val="282828"/>
+                          </a:solidFill>
+                          <a:latin typeface="Arial"/>
+                        </a:rPr>
+                        <a:t>0.008</a:t>
+                      </a:r>
+                    </a:p>
+                  </a:txBody>
+                  <a:tcPr marL="54864" marR="54864" marT="18288" marB="18288">
+                    <a:solidFill>
+                      <a:srgbClr val="ECF1F6"/>
+                    </a:solidFill>
+                  </a:tcPr>
+                </a:tc>
+                <a:tc>
+                  <a:txBody>
+                    <a:bodyPr wrap="square"/>
+                    <a:lstStyle/>
+                    <a:p>
+                      <a:r>
+                        <a:rPr sz="1100" b="0">
+                          <a:solidFill>
+                            <a:srgbClr val="282828"/>
+                          </a:solidFill>
+                          <a:latin typeface="Arial"/>
+                        </a:rPr>
+                        <a:t>2.10</a:t>
+                      </a:r>
+                    </a:p>
+                  </a:txBody>
+                  <a:tcPr marL="54864" marR="54864" marT="18288" marB="18288">
+                    <a:solidFill>
+                      <a:srgbClr val="ECF1F6"/>
+                    </a:solidFill>
+                  </a:tcPr>
+                </a:tc>
+                <a:tc>
+                  <a:txBody>
+                    <a:bodyPr wrap="square"/>
+                    <a:lstStyle/>
+                    <a:p>
+                      <a:r>
+                        <a:rPr sz="1100" b="0">
+                          <a:solidFill>
+                            <a:srgbClr val="282828"/>
+                          </a:solidFill>
+                          <a:latin typeface="Arial"/>
+                        </a:rPr>
+                        <a:t>0.48</a:t>
+                      </a:r>
+                    </a:p>
+                  </a:txBody>
+                  <a:tcPr marL="54864" marR="54864" marT="18288" marB="18288">
+                    <a:solidFill>
+                      <a:srgbClr val="ECF1F6"/>
+                    </a:solidFill>
+                  </a:tcPr>
+                </a:tc>
+                <a:tc>
+                  <a:txBody>
+                    <a:bodyPr wrap="square"/>
+                    <a:lstStyle/>
+                    <a:p>
+                      <a:r>
+                        <a:rPr sz="1100" b="0">
+                          <a:solidFill>
+                            <a:srgbClr val="282828"/>
+                          </a:solidFill>
+                          <a:latin typeface="Arial"/>
+                        </a:rPr>
+                        <a:t>698</a:t>
+                      </a:r>
+                    </a:p>
+                  </a:txBody>
+                  <a:tcPr marL="54864" marR="54864" marT="18288" marB="18288">
+                    <a:solidFill>
+                      <a:srgbClr val="ECF1F6"/>
+                    </a:solidFill>
+                  </a:tcPr>
+                </a:tc>
+                <a:tc>
+                  <a:txBody>
+                    <a:bodyPr wrap="square"/>
+                    <a:lstStyle/>
+                    <a:p>
+                      <a:r>
+                        <a:rPr sz="1100" b="0">
+                          <a:solidFill>
+                            <a:srgbClr val="282828"/>
+                          </a:solidFill>
+                          <a:latin typeface="Arial"/>
+                        </a:rPr>
+                        <a:t>272</a:t>
+                      </a:r>
+                    </a:p>
+                  </a:txBody>
+                  <a:tcPr marL="54864" marR="54864" marT="18288" marB="18288">
+                    <a:solidFill>
+                      <a:srgbClr val="ECF1F6"/>
+                    </a:solidFill>
+                  </a:tcPr>
+                </a:tc>
+                <a:tc>
+                  <a:txBody>
+                    <a:bodyPr wrap="square"/>
+                    <a:lstStyle/>
+                    <a:p>
+                      <a:r>
+                        <a:rPr sz="1100" b="0">
+                          <a:solidFill>
+                            <a:srgbClr val="282828"/>
+                          </a:solidFill>
+                          <a:latin typeface="Arial"/>
+                        </a:rPr>
+                        <a:t>22.1</a:t>
+                      </a:r>
+                    </a:p>
+                  </a:txBody>
+                  <a:tcPr marL="54864" marR="54864" marT="18288" marB="18288">
+                    <a:solidFill>
+                      <a:srgbClr val="ECF1F6"/>
+                    </a:solidFill>
+                  </a:tcPr>
+                </a:tc>
               </a:tr>
               <a:tr h="280035">
                 <a:tc>
@@ -3923,7 +4396,207 @@
                           </a:solidFill>
                           <a:latin typeface="Arial"/>
                         </a:rPr>
-                        <a:t>R3</a:t>
+                        <a:t>R4a</a:t>
+                      </a:r>
+                    </a:p>
+                  </a:txBody>
+                  <a:tcPr marL="54864" marR="54864" marT="18288" marB="18288">
+                    <a:solidFill>
+                      <a:srgbClr val="FFFFFF"/>
+                    </a:solidFill>
+                  </a:tcPr>
+                </a:tc>
+                <a:tc>
+                  <a:txBody>
+                    <a:bodyPr wrap="square"/>
+                    <a:lstStyle/>
+                    <a:p>
+                      <a:r>
+                        <a:rPr sz="1100" b="0">
+                          <a:solidFill>
+                            <a:srgbClr val="282828"/>
+                          </a:solidFill>
+                          <a:latin typeface="Arial"/>
+                        </a:rPr>
+                        <a:t>meniscus corrector alone</a:t>
+                      </a:r>
+                    </a:p>
+                  </a:txBody>
+                  <a:tcPr marL="54864" marR="54864" marT="18288" marB="18288">
+                    <a:solidFill>
+                      <a:srgbClr val="FFFFFF"/>
+                    </a:solidFill>
+                  </a:tcPr>
+                </a:tc>
+                <a:tc>
+                  <a:txBody>
+                    <a:bodyPr wrap="square"/>
+                    <a:lstStyle/>
+                    <a:p>
+                      <a:r>
+                        <a:rPr sz="1100" b="0">
+                          <a:solidFill>
+                            <a:srgbClr val="282828"/>
+                          </a:solidFill>
+                          <a:latin typeface="Arial"/>
+                        </a:rPr>
+                        <a:t>0.063</a:t>
+                      </a:r>
+                    </a:p>
+                  </a:txBody>
+                  <a:tcPr marL="54864" marR="54864" marT="18288" marB="18288">
+                    <a:solidFill>
+                      <a:srgbClr val="FFFFFF"/>
+                    </a:solidFill>
+                  </a:tcPr>
+                </a:tc>
+                <a:tc>
+                  <a:txBody>
+                    <a:bodyPr wrap="square"/>
+                    <a:lstStyle/>
+                    <a:p>
+                      <a:r>
+                        <a:rPr sz="1100" b="0">
+                          <a:solidFill>
+                            <a:srgbClr val="282828"/>
+                          </a:solidFill>
+                          <a:latin typeface="Arial"/>
+                        </a:rPr>
+                        <a:t>0.012</a:t>
+                      </a:r>
+                    </a:p>
+                  </a:txBody>
+                  <a:tcPr marL="54864" marR="54864" marT="18288" marB="18288">
+                    <a:solidFill>
+                      <a:srgbClr val="FFFFFF"/>
+                    </a:solidFill>
+                  </a:tcPr>
+                </a:tc>
+                <a:tc>
+                  <a:txBody>
+                    <a:bodyPr wrap="square"/>
+                    <a:lstStyle/>
+                    <a:p>
+                      <a:r>
+                        <a:rPr sz="1100" b="0">
+                          <a:solidFill>
+                            <a:srgbClr val="282828"/>
+                          </a:solidFill>
+                          <a:latin typeface="Arial"/>
+                        </a:rPr>
+                        <a:t>2.49</a:t>
+                      </a:r>
+                    </a:p>
+                  </a:txBody>
+                  <a:tcPr marL="54864" marR="54864" marT="18288" marB="18288">
+                    <a:solidFill>
+                      <a:srgbClr val="FFFFFF"/>
+                    </a:solidFill>
+                  </a:tcPr>
+                </a:tc>
+                <a:tc>
+                  <a:txBody>
+                    <a:bodyPr wrap="square"/>
+                    <a:lstStyle/>
+                    <a:p>
+                      <a:r>
+                        <a:rPr sz="1100" b="0">
+                          <a:solidFill>
+                            <a:srgbClr val="282828"/>
+                          </a:solidFill>
+                          <a:latin typeface="Arial"/>
+                        </a:rPr>
+                        <a:t>0.33</a:t>
+                      </a:r>
+                    </a:p>
+                  </a:txBody>
+                  <a:tcPr marL="54864" marR="54864" marT="18288" marB="18288">
+                    <a:solidFill>
+                      <a:srgbClr val="FFFFFF"/>
+                    </a:solidFill>
+                  </a:tcPr>
+                </a:tc>
+                <a:tc>
+                  <a:txBody>
+                    <a:bodyPr wrap="square"/>
+                    <a:lstStyle/>
+                    <a:p>
+                      <a:r>
+                        <a:rPr sz="1100" b="0">
+                          <a:solidFill>
+                            <a:srgbClr val="282828"/>
+                          </a:solidFill>
+                          <a:latin typeface="Arial"/>
+                        </a:rPr>
+                        <a:t>698</a:t>
+                      </a:r>
+                    </a:p>
+                  </a:txBody>
+                  <a:tcPr marL="54864" marR="54864" marT="18288" marB="18288">
+                    <a:solidFill>
+                      <a:srgbClr val="FFFFFF"/>
+                    </a:solidFill>
+                  </a:tcPr>
+                </a:tc>
+                <a:tc>
+                  <a:txBody>
+                    <a:bodyPr wrap="square"/>
+                    <a:lstStyle/>
+                    <a:p>
+                      <a:r>
+                        <a:rPr sz="1100" b="0">
+                          <a:solidFill>
+                            <a:srgbClr val="282828"/>
+                          </a:solidFill>
+                          <a:latin typeface="Arial"/>
+                        </a:rPr>
+                        <a:t>270</a:t>
+                      </a:r>
+                    </a:p>
+                  </a:txBody>
+                  <a:tcPr marL="54864" marR="54864" marT="18288" marB="18288">
+                    <a:solidFill>
+                      <a:srgbClr val="FFFFFF"/>
+                    </a:solidFill>
+                  </a:tcPr>
+                </a:tc>
+                <a:tc>
+                  <a:txBody>
+                    <a:bodyPr wrap="square"/>
+                    <a:lstStyle/>
+                    <a:p>
+                      <a:r>
+                        <a:rPr sz="1100" b="0">
+                          <a:solidFill>
+                            <a:srgbClr val="282828"/>
+                          </a:solidFill>
+                          <a:latin typeface="Arial"/>
+                        </a:rPr>
+                        <a:t>22.3</a:t>
+                      </a:r>
+                    </a:p>
+                  </a:txBody>
+                  <a:tcPr marL="54864" marR="54864" marT="18288" marB="18288">
+                    <a:solidFill>
+                      <a:srgbClr val="FFFFFF"/>
+                    </a:solidFill>
+                  </a:tcPr>
+                </a:tc>
+              </a:tr>
+              <a:tr h="280035">
+                <a:tc>
+                  <a:txBody>
+                    <a:bodyPr wrap="square"/>
+                    <a:lstStyle/>
+                    <a:p>
+                      <a:r>
+                        <a:rPr sz="1100" b="0">
+                          <a:solidFill>
+                            <a:srgbClr val="282828"/>
+                          </a:solidFill>
+                          <a:latin typeface="Arial"/>
+                        </a:rPr>
+                        <a:t>R4</a:t>
                       </a:r>
                     </a:p>
                   </a:txBody>
@@ -3945,7 +4618,7 @@
                           </a:solidFill>
                           <a:latin typeface="Arial"/>
                         </a:rPr>
-                        <a:t>+ block centre 0.86 mm off the grating's, along the dispersion</a:t>
+                        <a:t>meniscus with all variables (the compact variant)</a:t>
                       </a:r>
                     </a:p>
                   </a:txBody>
@@ -3967,7 +4640,7 @@
                           </a:solidFill>
                           <a:latin typeface="Arial"/>
                         </a:rPr>
-                        <a:t>0.011</a:t>
+                        <a:t>0.0026</a:t>
                       </a:r>
                     </a:p>
                   </a:txBody>
@@ -3989,7 +4662,7 @@
                           </a:solidFill>
                           <a:latin typeface="Arial"/>
                         </a:rPr>
-                        <a:t>0.008</a:t>
+                        <a:t>0.005</a:t>
                       </a:r>
                     </a:p>
                   </a:txBody>
@@ -4011,7 +4684,7 @@
                           </a:solidFill>
                           <a:latin typeface="Arial"/>
                         </a:rPr>
-                        <a:t>2.10</a:t>
+                        <a:t>1.33</a:t>
                       </a:r>
                     </a:p>
                   </a:txBody>
@@ -4033,13 +4706,279 @@
                           </a:solidFill>
                           <a:latin typeface="Arial"/>
                         </a:rPr>
-                        <a:t>0.48</a:t>
+                        <a:t>0.76</a:t>
                       </a:r>
                     </a:p>
                   </a:txBody>
                   <a:tcPr marL="54864" marR="54864" marT="18288" marB="18288">
                     <a:solidFill>
                       <a:srgbClr val="ECF1F6"/>
+                    </a:solidFill>
+                  </a:tcPr>
+                </a:tc>
+                <a:tc>
+                  <a:txBody>
+                    <a:bodyPr wrap="square"/>
+                    <a:lstStyle/>
+                    <a:p>
+                      <a:r>
+                        <a:rPr sz="1100" b="0">
+                          <a:solidFill>
+                            <a:srgbClr val="282828"/>
+                          </a:solidFill>
+                          <a:latin typeface="Arial"/>
+                        </a:rPr>
+                        <a:t>694</a:t>
+                      </a:r>
+                    </a:p>
+                  </a:txBody>
+                  <a:tcPr marL="54864" marR="54864" marT="18288" marB="18288">
+                    <a:solidFill>
+                      <a:srgbClr val="ECF1F6"/>
+                    </a:solidFill>
+                  </a:tcPr>
+                </a:tc>
+                <a:tc>
+                  <a:txBody>
+                    <a:bodyPr wrap="square"/>
+                    <a:lstStyle/>
+                    <a:p>
+                      <a:r>
+                        <a:rPr sz="1100" b="0">
+                          <a:solidFill>
+                            <a:srgbClr val="282828"/>
+                          </a:solidFill>
+                          <a:latin typeface="Arial"/>
+                        </a:rPr>
+                        <a:t>269</a:t>
+                      </a:r>
+                    </a:p>
+                  </a:txBody>
+                  <a:tcPr marL="54864" marR="54864" marT="18288" marB="18288">
+                    <a:solidFill>
+                      <a:srgbClr val="ECF1F6"/>
+                    </a:solidFill>
+                  </a:tcPr>
+                </a:tc>
+                <a:tc>
+                  <a:txBody>
+                    <a:bodyPr wrap="square"/>
+                    <a:lstStyle/>
+                    <a:p>
+                      <a:r>
+                        <a:rPr sz="1100" b="0">
+                          <a:solidFill>
+                            <a:srgbClr val="282828"/>
+                          </a:solidFill>
+                          <a:latin typeface="Arial"/>
+                        </a:rPr>
+                        <a:t>22.7</a:t>
+                      </a:r>
+                    </a:p>
+                  </a:txBody>
+                  <a:tcPr marL="54864" marR="54864" marT="18288" marB="18288">
+                    <a:solidFill>
+                      <a:srgbClr val="ECF1F6"/>
+                    </a:solidFill>
+                  </a:tcPr>
+                </a:tc>
+              </a:tr>
+              <a:tr h="468630">
+                <a:tc>
+                  <a:txBody>
+                    <a:bodyPr wrap="square"/>
+                    <a:lstStyle/>
+                    <a:p>
+                      <a:r>
+                        <a:rPr sz="1100" b="0">
+                          <a:solidFill>
+                            <a:srgbClr val="282828"/>
+                          </a:solidFill>
+                          <a:latin typeface="Arial"/>
+                        </a:rPr>
+                        <a:t>size alone</a:t>
+                      </a:r>
+                    </a:p>
+                  </a:txBody>
+                  <a:tcPr marL="54864" marR="54864" marT="18288" marB="18288">
+                    <a:solidFill>
+                      <a:srgbClr val="FFFFFF"/>
+                    </a:solidFill>
+                  </a:tcPr>
+                </a:tc>
+                <a:tc>
+                  <a:txBody>
+                    <a:bodyPr wrap="square"/>
+                    <a:lstStyle/>
+                    <a:p>
+                      <a:r>
+                        <a:rPr sz="1100" b="0">
+                          <a:solidFill>
+                            <a:srgbClr val="282828"/>
+                          </a:solidFill>
+                          <a:latin typeface="Arial"/>
+                        </a:rPr>
+                        <a:t>block radius free (341 mm)</a:t>
+                      </a:r>
+                    </a:p>
+                  </a:txBody>
+                  <a:tcPr marL="54864" marR="54864" marT="18288" marB="18288">
+                    <a:solidFill>
+                      <a:srgbClr val="FFFFFF"/>
+                    </a:solidFill>
+                  </a:tcPr>
+                </a:tc>
+                <a:tc>
+                  <a:txBody>
+                    <a:bodyPr wrap="square"/>
+                    <a:lstStyle/>
+                    <a:p>
+                      <a:r>
+                        <a:rPr sz="1100" b="0">
+                          <a:solidFill>
+                            <a:srgbClr val="282828"/>
+                          </a:solidFill>
+                          <a:latin typeface="Arial"/>
+                        </a:rPr>
+                        <a:t>0.024</a:t>
+                      </a:r>
+                    </a:p>
+                  </a:txBody>
+                  <a:tcPr marL="54864" marR="54864" marT="18288" marB="18288">
+                    <a:solidFill>
+                      <a:srgbClr val="FFFFFF"/>
+                    </a:solidFill>
+                  </a:tcPr>
+                </a:tc>
+                <a:tc>
+                  <a:txBody>
+                    <a:bodyPr wrap="square"/>
+                    <a:lstStyle/>
+                    <a:p>
+                      <a:r>
+                        <a:rPr sz="1100" b="0">
+                          <a:solidFill>
+                            <a:srgbClr val="282828"/>
+                          </a:solidFill>
+                          <a:latin typeface="Arial"/>
+                        </a:rPr>
+                        <a:t>0.001</a:t>
+                      </a:r>
+                    </a:p>
+                  </a:txBody>
+                  <a:tcPr marL="54864" marR="54864" marT="18288" marB="18288">
+                    <a:solidFill>
+                      <a:srgbClr val="FFFFFF"/>
+                    </a:solidFill>
+                  </a:tcPr>
+                </a:tc>
+                <a:tc>
+                  <a:txBody>
+                    <a:bodyPr wrap="square"/>
+                    <a:lstStyle/>
+                    <a:p>
+                      <a:r>
+                        <a:rPr sz="1100" b="0">
+                          <a:solidFill>
+                            <a:srgbClr val="282828"/>
+                          </a:solidFill>
+                          <a:latin typeface="Arial"/>
+                        </a:rPr>
+                        <a:t>1.34</a:t>
+                      </a:r>
+                    </a:p>
+                  </a:txBody>
+                  <a:tcPr marL="54864" marR="54864" marT="18288" marB="18288">
+                    <a:solidFill>
+                      <a:srgbClr val="FFFFFF"/>
+                    </a:solidFill>
+                  </a:tcPr>
+                </a:tc>
+                <a:tc>
+                  <a:txBody>
+                    <a:bodyPr wrap="square"/>
+                    <a:lstStyle/>
+                    <a:p>
+                      <a:r>
+                        <a:rPr sz="1100" b="0">
+                          <a:solidFill>
+                            <a:srgbClr val="282828"/>
+                          </a:solidFill>
+                          <a:latin typeface="Arial"/>
+                        </a:rPr>
+                        <a:t>0.74</a:t>
+                      </a:r>
+                    </a:p>
+                  </a:txBody>
+                  <a:tcPr marL="54864" marR="54864" marT="18288" marB="18288">
+                    <a:solidFill>
+                      <a:srgbClr val="FFFFFF"/>
+                    </a:solidFill>
+                  </a:tcPr>
+                </a:tc>
+                <a:tc>
+                  <a:txBody>
+                    <a:bodyPr wrap="square"/>
+                    <a:lstStyle/>
+                    <a:p>
+                      <a:r>
+                        <a:rPr sz="1100" b="0">
+                          <a:solidFill>
+                            <a:srgbClr val="282828"/>
+                          </a:solidFill>
+                          <a:latin typeface="Arial"/>
+                        </a:rPr>
+                        <a:t>1099</a:t>
+                      </a:r>
+                    </a:p>
+                  </a:txBody>
+                  <a:tcPr marL="54864" marR="54864" marT="18288" marB="18288">
+                    <a:solidFill>
+                      <a:srgbClr val="FFFFFF"/>
+                    </a:solidFill>
+                  </a:tcPr>
+                </a:tc>
+                <a:tc>
+                  <a:txBody>
+                    <a:bodyPr wrap="square"/>
+                    <a:lstStyle/>
+                    <a:p>
+                      <a:r>
+                        <a:rPr sz="1100" b="0">
+                          <a:solidFill>
+                            <a:srgbClr val="282828"/>
+                          </a:solidFill>
+                          <a:latin typeface="Arial"/>
+                        </a:rPr>
+                        <a:t>427</a:t>
+                      </a:r>
+                    </a:p>
+                  </a:txBody>
+                  <a:tcPr marL="54864" marR="54864" marT="18288" marB="18288">
+                    <a:solidFill>
+                      <a:srgbClr val="FFFFFF"/>
+                    </a:solidFill>
+                  </a:tcPr>
+                </a:tc>
+                <a:tc>
+                  <a:txBody>
+                    <a:bodyPr wrap="square"/>
+                    <a:lstStyle/>
+                    <a:p>
+                      <a:r>
+                        <a:rPr sz="1100" b="0">
+                          <a:solidFill>
+                            <a:srgbClr val="282828"/>
+                          </a:solidFill>
+                          <a:latin typeface="Arial"/>
+                        </a:rPr>
+                        <a:t>82.8</a:t>
+                      </a:r>
+                    </a:p>
+                  </a:txBody>
+                  <a:tcPr marL="54864" marR="54864" marT="18288" marB="18288">
+                    <a:solidFill>
+                      <a:srgbClr val="FFFFFF"/>
                     </a:solidFill>
                   </a:tcPr>
                 </a:tc>
@@ -4056,7 +4995,7 @@
         </p:nvSpPr>
         <p:spPr>
           <a:xfrm>
-            <a:off x="411480" y="2844927"/>
+            <a:off x="411480" y="4250817"/>
             <a:ext cx="11368735" cy="274320"/>
           </a:xfrm>
           <a:prstGeom prst="rect">
@@ -4082,7 +5021,7 @@
                 </a:solidFill>
                 <a:latin typeface="Arial"/>
               </a:rPr>
-              <a:t>SRF FWHM is 2.02 px on every step: the floor set by the 2-pixel slit.  Records dyson5_s3.txt; the free-radius variant in dyson5_s3free.txt.</a:t>
+              <a:t>SRF FWHM is 2.02–2.05 px on every step: the 2-pixel-slit floor.  Length = slit plane to grating vertex; footprint = diameter of the grating hits over slit centre and ends × band edges; glass = block cap + meniscus.  Record dyson5_s3_trade.txt.</a:t>
             </a:r>
           </a:p>
         </p:txBody>
@@ -4309,7 +5248,7 @@
                 </a:solidFill>
                 <a:latin typeface="Arial"/>
               </a:rPr>
-              <a:t>•  Two routes buy it: size alone (the free-radius variant reaches 0.74 ensquared at a 341 mm block) or the literature's compact variant, a separate mirror and a meniscus — the next step.</a:t>
+              <a:t>•  Two routes buy it: size alone (0.74 ensquared at a 341 mm block, 1.1 m long, 83 L of glass) or the compact variant: a meniscus corrector in the air gap, solved together with the block offset and the grating radius, reaches the same at the 220 mm block — 63 % of the length, 27 % of the glass.</a:t>
             </a:r>
           </a:p>
         </p:txBody>
@@ -4330,7 +5269,7 @@
         </p:blipFill>
         <p:spPr>
           <a:xfrm>
-            <a:off x="6400800" y="3002280"/>
+            <a:off x="6400800" y="3398520"/>
             <a:ext cx="5394960" cy="2156833"/>
           </a:xfrm>
           <a:prstGeom prst="rect">
@@ -4346,7 +5285,7 @@
         </p:nvSpPr>
         <p:spPr>
           <a:xfrm>
-            <a:off x="6400800" y="5177401"/>
+            <a:off x="6400800" y="5573641"/>
             <a:ext cx="5394960" cy="394208"/>
           </a:xfrm>
           <a:prstGeom prst="rect">
@@ -4429,7 +5368,7 @@
                 </a:solidFill>
                 <a:latin typeface="Arial"/>
               </a:rPr>
-              <a:t>Next: the compact variant</a:t>
+              <a:t>The compact variant, as traced by the engine</a:t>
             </a:r>
           </a:p>
           <a:p>
@@ -4445,7 +5384,7 @@
                 </a:solidFill>
                 <a:latin typeface="Arial"/>
               </a:rPr>
-              <a:t>Step R4 under the identical operands and scorer, so the trade is one table</a:t>
+              <a:t>Step R4: the meniscus corrector in the air gap between the block and the grating; the design of record at a 220 mm block</a:t>
             </a:r>
           </a:p>
         </p:txBody>
@@ -4503,7 +5442,7 @@
         <p:spPr>
           <a:xfrm>
             <a:off x="411480" y="1298448"/>
-            <a:ext cx="5806440" cy="274320"/>
+            <a:ext cx="11368735" cy="274320"/>
           </a:xfrm>
           <a:prstGeom prst="rect">
             <a:avLst/>
@@ -4522,13 +5461,13 @@
               </a:spcAft>
             </a:pPr>
             <a:r>
-              <a:rPr sz="1200" b="0">
+              <a:rPr sz="1500" b="0">
                 <a:solidFill>
                   <a:srgbClr val="282828"/>
                 </a:solidFill>
                 <a:latin typeface="Arial"/>
               </a:rPr>
-              <a:t>•  R4: the compact Dyson of the review — a separate mirror and a meniscus — solved on the same chain with the same smile and keystone operands, emitted and engine-scored like every other step.</a:t>
+              <a:t>•  The prescription: challenges/dyson5/dyson5_s3_r4.in, nine elements: the block's flat face, its spherical face, the meniscus (two surfaces), the grating, and the return through the meniscus and block to the focal plane.</a:t>
             </a:r>
           </a:p>
           <a:p>
@@ -4538,27 +5477,51 @@
               </a:spcAft>
             </a:pPr>
             <a:r>
-              <a:rPr sz="1200" b="0">
+              <a:rPr sz="1500" b="0">
                 <a:solidFill>
                   <a:srgbClr val="282828"/>
                 </a:solidFill>
                 <a:latin typeface="Arial"/>
               </a:rPr>
-              <a:t>•  One trade table: R3 (de-concentred block at 220 mm), the free-radius block (341 mm), and R4, on keystone, smile, CRF, SRF, ensquared energy, length, footprint, element count and glass volume.</a:t>
-            </a:r>
-          </a:p>
-        </p:txBody>
-      </p:sp>
-      <p:sp>
-        <p:nvSpPr>
-          <p:cNvPr id="5" name="TextBox 4"/>
+              <a:t>•  Bodies, rays and labels read back from the engine; apertures are not yet declared (the block draws as the beam's hull), which the clearance pass adds next.</a:t>
+            </a:r>
+          </a:p>
+        </p:txBody>
+      </p:sp>
+      <p:pic>
+        <p:nvPicPr>
+          <p:cNvPr id="5" name="Picture 4" descr="dyson5_s3_r4_views.png"/>
+          <p:cNvPicPr>
+            <a:picLocks noChangeAspect="1"/>
+          </p:cNvPicPr>
+          <p:nvPr/>
+        </p:nvPicPr>
+        <p:blipFill>
+          <a:blip r:embed="rId2"/>
+          <a:stretch>
+            <a:fillRect/>
+          </a:stretch>
+        </p:blipFill>
+        <p:spPr>
+          <a:xfrm>
+            <a:off x="3720724" y="2606039"/>
+            <a:ext cx="4750245" cy="3858260"/>
+          </a:xfrm>
+          <a:prstGeom prst="rect">
+            <a:avLst/>
+          </a:prstGeom>
+        </p:spPr>
+      </p:pic>
+      <p:sp>
+        <p:nvSpPr>
+          <p:cNvPr id="6" name="TextBox 5"/>
           <p:cNvSpPr txBox="1"/>
           <p:nvPr/>
         </p:nvSpPr>
         <p:spPr>
           <a:xfrm>
-            <a:off x="6400800" y="1298448"/>
-            <a:ext cx="5394960" cy="274320"/>
+            <a:off x="411480" y="6482588"/>
+            <a:ext cx="11368735" cy="229107"/>
           </a:xfrm>
           <a:prstGeom prst="rect">
             <a:avLst/>
@@ -4571,74 +5534,19 @@
           </a:bodyPr>
           <a:lstStyle/>
           <a:p>
-            <a:pPr>
-              <a:spcAft>
-                <a:spcPts val="600"/>
-              </a:spcAft>
-            </a:pPr>
-            <a:r>
-              <a:rPr sz="1200" b="0">
-                <a:solidFill>
-                  <a:srgbClr val="282828"/>
-                </a:solidFill>
-                <a:latin typeface="Arial"/>
-              </a:rPr>
-              <a:t>•  Then the physical-optics twin on the chosen design: PSF centroids against ray centroids, SRF and CRF from the propagated PSF, the slit-width diffraction loss against the sinc² closed form.</a:t>
-            </a:r>
-          </a:p>
-          <a:p>
-            <a:pPr>
-              <a:spcAft>
-                <a:spcPts val="600"/>
-              </a:spcAft>
-            </a:pPr>
-            <a:r>
-              <a:rPr sz="1200" b="0">
-                <a:solidFill>
-                  <a:srgbClr val="282828"/>
-                </a:solidFill>
-                <a:latin typeface="Arial"/>
-              </a:rPr>
-              <a:t>•  Then the native multi-wavelength optimizer with the same operands, to confirm the chain's optimum from the engine side.</a:t>
-            </a:r>
-          </a:p>
-        </p:txBody>
-      </p:sp>
-      <p:sp>
-        <p:nvSpPr>
-          <p:cNvPr id="6" name="TextBox 5"/>
-          <p:cNvSpPr txBox="1"/>
-          <p:nvPr/>
-        </p:nvSpPr>
-        <p:spPr>
-          <a:xfrm>
-            <a:off x="6400800" y="2606040"/>
-            <a:ext cx="5394960" cy="274320"/>
-          </a:xfrm>
-          <a:prstGeom prst="rect">
-            <a:avLst/>
-          </a:prstGeom>
-          <a:noFill/>
-        </p:spPr>
-        <p:txBody>
-          <a:bodyPr wrap="square">
-            <a:spAutoFit/>
-          </a:bodyPr>
-          <a:lstStyle/>
-          <a:p>
-            <a:pPr>
-              <a:spcAft>
-                <a:spcPts val="600"/>
-              </a:spcAft>
-            </a:pPr>
-            <a:r>
-              <a:rPr sz="1050" b="0">
+            <a:pPr algn="ctr">
+              <a:spcAft>
+                <a:spcPts val="0"/>
+              </a:spcAft>
+            </a:pPr>
+            <a:r>
+              <a:rPr sz="1000" b="0">
                 <a:solidFill>
                   <a:srgbClr val="6E6E6E"/>
                 </a:solidFill>
                 <a:latin typeface="Arial"/>
               </a:rPr>
-              <a:t>Across a grating the wavefront is defined only modulo λ (the groove staircase); every OPD comparison in the twin is made in phase or on the complex field, never as unwrapped lengths.</a:t>
+              <a:t>Left: the traced bundle and the solid bodies in 3-D.  Right: the dispersion plane (Y-Z).  Positions in metres, global frame.</a:t>
             </a:r>
           </a:p>
         </p:txBody>
@@ -4695,7 +5603,7 @@
                 </a:solidFill>
                 <a:latin typeface="Arial"/>
               </a:rPr>
-              <a:t>Run it yourself</a:t>
+              <a:t>The compact variant in section</a:t>
             </a:r>
           </a:p>
           <a:p>
@@ -4711,7 +5619,7 @@
                 </a:solidFill>
                 <a:latin typeface="Arial"/>
               </a:rPr>
-              <a:t>One parameter file, one runner, every stage through it</a:t>
+              <a:t>Dispersion plane and slit direction, to scale: block, meniscus, grating; slit and focal plane on the block's face</a:t>
             </a:r>
           </a:p>
         </p:txBody>
@@ -4760,113 +5668,30 @@
           </a:p>
         </p:txBody>
       </p:sp>
-      <p:sp>
-        <p:nvSpPr>
-          <p:cNvPr id="4" name="Rectangle 3"/>
-          <p:cNvSpPr/>
+      <p:pic>
+        <p:nvPicPr>
+          <p:cNvPr id="4" name="Picture 3" descr="dyson5_s3_layout_r4.png"/>
+          <p:cNvPicPr>
+            <a:picLocks noChangeAspect="1"/>
+          </p:cNvPicPr>
           <p:nvPr/>
-        </p:nvSpPr>
-        <p:spPr>
-          <a:xfrm>
-            <a:off x="411480" y="1298448"/>
-            <a:ext cx="11368735" cy="935736"/>
+        </p:nvPicPr>
+        <p:blipFill>
+          <a:blip r:embed="rId2"/>
+          <a:stretch>
+            <a:fillRect/>
+          </a:stretch>
+        </p:blipFill>
+        <p:spPr>
+          <a:xfrm>
+            <a:off x="518592" y="1298448"/>
+            <a:ext cx="11154510" cy="5000752"/>
           </a:xfrm>
           <a:prstGeom prst="rect">
             <a:avLst/>
           </a:prstGeom>
-          <a:solidFill>
-            <a:srgbClr val="FFFFFF"/>
-          </a:solidFill>
-          <a:ln w="9525">
-            <a:solidFill>
-              <a:srgbClr val="1F4E79"/>
-            </a:solidFill>
-          </a:ln>
-          <a:effectLst/>
-        </p:spPr>
-        <p:style>
-          <a:lnRef idx="1">
-            <a:schemeClr val="accent1"/>
-          </a:lnRef>
-          <a:fillRef idx="3">
-            <a:schemeClr val="accent1"/>
-          </a:fillRef>
-          <a:effectRef idx="2">
-            <a:schemeClr val="accent1"/>
-          </a:effectRef>
-          <a:fontRef idx="minor">
-            <a:schemeClr val="lt1"/>
-          </a:fontRef>
-        </p:style>
-        <p:txBody>
-          <a:bodyPr rtlCol="0" anchor="t" wrap="square"/>
-          <a:lstStyle/>
-          <a:p>
-            <a:pPr algn="ctr">
-              <a:spcAft>
-                <a:spcPts val="100"/>
-              </a:spcAft>
-            </a:pPr>
-            <a:r>
-              <a:rPr sz="1150" b="0">
-                <a:solidFill>
-                  <a:srgbClr val="282828"/>
-                </a:solidFill>
-                <a:latin typeface="Consolas"/>
-              </a:rPr>
-              <a:t>run('&lt;path&gt;/mmacos/mmacos_setup.m');</a:t>
-            </a:r>
-          </a:p>
-          <a:p>
-            <a:pPr>
-              <a:spcAft>
-                <a:spcPts val="100"/>
-              </a:spcAft>
-            </a:pPr>
-            <a:r>
-              <a:rPr sz="1150" b="0">
-                <a:solidFill>
-                  <a:srgbClr val="282828"/>
-                </a:solidFill>
-                <a:latin typeface="Consolas"/>
-              </a:rPr>
-              <a:t>addpath('&lt;path&gt;/mmacos/challenges/dyson5');</a:t>
-            </a:r>
-          </a:p>
-          <a:p>
-            <a:pPr>
-              <a:spcAft>
-                <a:spcPts val="100"/>
-              </a:spcAft>
-            </a:pPr>
-            <a:r>
-              <a:rPr sz="1150" b="0">
-                <a:solidFill>
-                  <a:srgbClr val="282828"/>
-                </a:solidFill>
-                <a:latin typeface="Consolas"/>
-              </a:rPr>
-              <a:t>OUT = dyson5_run();                                      % stage s0: the scaling law (engine-free)</a:t>
-            </a:r>
-          </a:p>
-          <a:p>
-            <a:pPr>
-              <a:spcAft>
-                <a:spcPts val="100"/>
-              </a:spcAft>
-            </a:pPr>
-            <a:r>
-              <a:rPr sz="1150" b="0">
-                <a:solidFill>
-                  <a:srgbClr val="282828"/>
-                </a:solidFill>
-                <a:latin typeface="Consolas"/>
-              </a:rPr>
-              <a:t>OUT = dyson5_run(struct('stages', {{'s1','s2','s3'}}));  % emit, score, ladder</a:t>
-            </a:r>
-          </a:p>
-        </p:txBody>
-      </p:sp>
+        </p:spPr>
+      </p:pic>
       <p:sp>
         <p:nvSpPr>
           <p:cNvPr id="5" name="TextBox 4"/>
@@ -4875,8 +5700,8 @@
         </p:nvSpPr>
         <p:spPr>
           <a:xfrm>
-            <a:off x="411480" y="2343912"/>
-            <a:ext cx="11368735" cy="274320"/>
+            <a:off x="411480" y="6317488"/>
+            <a:ext cx="11368735" cy="394208"/>
           </a:xfrm>
           <a:prstGeom prst="rect">
             <a:avLst/>
@@ -4889,6 +5714,45 @@
           </a:bodyPr>
           <a:lstStyle/>
           <a:p>
+            <a:pPr algn="ctr">
+              <a:spcAft>
+                <a:spcPts val="0"/>
+              </a:spcAft>
+            </a:pPr>
+            <a:r>
+              <a:rPr sz="1000" b="0">
+                <a:solidFill>
+                  <a:srgbClr val="6E6E6E"/>
+                </a:solidFill>
+                <a:latin typeface="Arial"/>
+              </a:rPr>
+              <a:t>Left: the dispersion plane, slit centre, rays at 380 / 1440 / 2500 nm (blue / green / red).  Right: the slit direction, slit centre and ends at 1440 nm; the focal plane in magenta.  Block shaded; 100 mm scale bar.</a:t>
+            </a:r>
+          </a:p>
+        </p:txBody>
+      </p:sp>
+      <p:sp>
+        <p:nvSpPr>
+          <p:cNvPr id="6" name="TextBox 5"/>
+          <p:cNvSpPr txBox="1"/>
+          <p:nvPr/>
+        </p:nvSpPr>
+        <p:spPr>
+          <a:xfrm>
+            <a:off x="411480" y="6748272"/>
+            <a:ext cx="11368735" cy="274320"/>
+          </a:xfrm>
+          <a:prstGeom prst="rect">
+            <a:avLst/>
+          </a:prstGeom>
+          <a:noFill/>
+        </p:spPr>
+        <p:txBody>
+          <a:bodyPr wrap="square">
+            <a:spAutoFit/>
+          </a:bodyPr>
+          <a:lstStyle/>
+          <a:p>
             <a:pPr>
               <a:spcAft>
                 <a:spcPts val="600"/>
@@ -4901,7 +5765,7 @@
                 </a:solidFill>
                 <a:latin typeface="Arial"/>
               </a:rPr>
-              <a:t>•  Knobs live in dyson5_params.m (F-number, pixel, band, slit, block radius, ladder options); every record in this deck is a stage output under challenges/dyson5/.</a:t>
+              <a:t>•  Sizes: block radius 220 mm (217 mm thick, 85 mm face), meniscus 4 mm thick at radii near 2 m, grating 269 mm across on a 0.69 m radius; slit plane to grating vertex 694 mm.</a:t>
             </a:r>
           </a:p>
           <a:p>
@@ -4917,7 +5781,7 @@
                 </a:solidFill>
                 <a:latin typeface="Arial"/>
               </a:rPr>
-              <a:t>•  Engine checks: ./run_mmacos_tests.sh tSpectrometerRx and the four grating / glass / propagation classes, all in the fast suite.</a:t>
+              <a:t>•  The solve ends on its bounds (plate thickness and radii), and three solves from the same seed found a multimodal landscape; the global search over the meniscus is the next step.</a:t>
             </a:r>
           </a:p>
         </p:txBody>
@@ -4974,7 +5838,23 @@
                 </a:solidFill>
                 <a:latin typeface="Arial"/>
               </a:rPr>
-              <a:t>Backup</a:t>
+              <a:t>The compact variant, scored</a:t>
+            </a:r>
+          </a:p>
+          <a:p>
+            <a:pPr>
+              <a:spcAft>
+                <a:spcPts val="0"/>
+              </a:spcAft>
+            </a:pPr>
+            <a:r>
+              <a:rPr sz="1250" b="0">
+                <a:solidFill>
+                  <a:srgbClr val="6E6E6E"/>
+                </a:solidFill>
+                <a:latin typeface="Arial"/>
+              </a:rPr>
+              <a:t>Keystone 0.0026 px, smile 0.005 px, CRF 1.33 px, SRF 2.03 px, 76 % of the energy in one pixel, over the slit and the band</a:t>
             </a:r>
           </a:p>
         </p:txBody>
@@ -4987,7 +5867,7 @@
         </p:nvSpPr>
         <p:spPr>
           <a:xfrm>
-            <a:off x="411480" y="914400"/>
+            <a:off x="411480" y="1133856"/>
             <a:ext cx="11368735" cy="20320"/>
           </a:xfrm>
           <a:prstGeom prst="rect">
@@ -5023,16 +5903,40 @@
           </a:p>
         </p:txBody>
       </p:sp>
-      <p:sp>
-        <p:nvSpPr>
-          <p:cNvPr id="4" name="TextBox 3"/>
+      <p:pic>
+        <p:nvPicPr>
+          <p:cNvPr id="4" name="Picture 3" descr="dyson5_s3_maps_r4.png"/>
+          <p:cNvPicPr>
+            <a:picLocks noChangeAspect="1"/>
+          </p:cNvPicPr>
+          <p:nvPr/>
+        </p:nvPicPr>
+        <p:blipFill>
+          <a:blip r:embed="rId2"/>
+          <a:stretch>
+            <a:fillRect/>
+          </a:stretch>
+        </p:blipFill>
+        <p:spPr>
+          <a:xfrm>
+            <a:off x="411480" y="1298448"/>
+            <a:ext cx="11368735" cy="2277103"/>
+          </a:xfrm>
+          <a:prstGeom prst="rect">
+            <a:avLst/>
+          </a:prstGeom>
+        </p:spPr>
+      </p:pic>
+      <p:sp>
+        <p:nvSpPr>
+          <p:cNvPr id="5" name="TextBox 4"/>
           <p:cNvSpPr txBox="1"/>
           <p:nvPr/>
         </p:nvSpPr>
         <p:spPr>
           <a:xfrm>
-            <a:off x="411480" y="1078992"/>
-            <a:ext cx="11368735" cy="274320"/>
+            <a:off x="411480" y="3593839"/>
+            <a:ext cx="11368735" cy="394208"/>
           </a:xfrm>
           <a:prstGeom prst="rect">
             <a:avLst/>
@@ -5045,19 +5949,19 @@
           </a:bodyPr>
           <a:lstStyle/>
           <a:p>
-            <a:pPr>
-              <a:spcAft>
-                <a:spcPts val="600"/>
-              </a:spcAft>
-            </a:pPr>
-            <a:r>
-              <a:rPr sz="1500" b="0">
-                <a:solidFill>
-                  <a:srgbClr val="282828"/>
-                </a:solidFill>
-                <a:latin typeface="Arial"/>
-              </a:rPr>
-              <a:t>Diagnostics, the engine findings, and the conventions behind the main path.</a:t>
+            <a:pPr algn="ctr">
+              <a:spcAft>
+                <a:spcPts val="0"/>
+              </a:spcAft>
+            </a:pPr>
+            <a:r>
+              <a:rPr sz="1000" b="0">
+                <a:solidFill>
+                  <a:srgbClr val="6E6E6E"/>
+                </a:solidFill>
+                <a:latin typeface="Arial"/>
+              </a:rPr>
+              <a:t>Engine-scored maps for R4 on 18 µm pixels, per slit position and wavelength: field-angle map, keystone, smile, SRF FWHM, CRF FWHM, ensquared energy; each convention on its colorbar, maxima in the labels.</a:t>
             </a:r>
           </a:p>
         </p:txBody>
@@ -5071,6 +5975,1721 @@
 </file>
 
 <file path=ppt/slides/slide15.xml><?xml version="1.0" encoding="utf-8"?>
+<p:sld xmlns:a="http://schemas.openxmlformats.org/drawingml/2006/main" xmlns:p="http://schemas.openxmlformats.org/presentationml/2006/main" xmlns:r="http://schemas.openxmlformats.org/officeDocument/2006/relationships">
+  <p:cSld>
+    <p:spTree>
+      <p:nvGrpSpPr>
+        <p:cNvPr id="1" name=""/>
+        <p:cNvGrpSpPr/>
+        <p:nvPr/>
+      </p:nvGrpSpPr>
+      <p:grpSpPr/>
+      <p:sp>
+        <p:nvSpPr>
+          <p:cNvPr id="2" name="TextBox 1"/>
+          <p:cNvSpPr txBox="1"/>
+          <p:nvPr/>
+        </p:nvSpPr>
+        <p:spPr>
+          <a:xfrm>
+            <a:off x="411480" y="201168"/>
+            <a:ext cx="11368735" cy="914400"/>
+          </a:xfrm>
+          <a:prstGeom prst="rect">
+            <a:avLst/>
+          </a:prstGeom>
+          <a:noFill/>
+        </p:spPr>
+        <p:txBody>
+          <a:bodyPr wrap="square">
+            <a:spAutoFit/>
+          </a:bodyPr>
+          <a:lstStyle/>
+          <a:p>
+            <a:pPr>
+              <a:spcAft>
+                <a:spcPts val="400"/>
+              </a:spcAft>
+            </a:pPr>
+            <a:r>
+              <a:rPr sz="2400" b="1">
+                <a:solidFill>
+                  <a:srgbClr val="1F4E79"/>
+                </a:solidFill>
+                <a:latin typeface="Arial"/>
+              </a:rPr>
+              <a:t>The trade at a glance</a:t>
+            </a:r>
+          </a:p>
+          <a:p>
+            <a:pPr>
+              <a:spcAft>
+                <a:spcPts val="0"/>
+              </a:spcAft>
+            </a:pPr>
+            <a:r>
+              <a:rPr sz="1250" b="0">
+                <a:solidFill>
+                  <a:srgbClr val="6E6E6E"/>
+                </a:solidFill>
+                <a:latin typeface="Arial"/>
+              </a:rPr>
+              <a:t>Distortion, response functions and ensquared energy per step, both records; the specification and the literature rules as lines</a:t>
+            </a:r>
+          </a:p>
+        </p:txBody>
+      </p:sp>
+      <p:sp>
+        <p:nvSpPr>
+          <p:cNvPr id="3" name="Rectangle 2"/>
+          <p:cNvSpPr/>
+          <p:nvPr/>
+        </p:nvSpPr>
+        <p:spPr>
+          <a:xfrm>
+            <a:off x="411480" y="1133856"/>
+            <a:ext cx="11368735" cy="20320"/>
+          </a:xfrm>
+          <a:prstGeom prst="rect">
+            <a:avLst/>
+          </a:prstGeom>
+          <a:solidFill>
+            <a:srgbClr val="B8C6D4"/>
+          </a:solidFill>
+          <a:ln>
+            <a:noFill/>
+          </a:ln>
+          <a:effectLst/>
+        </p:spPr>
+        <p:style>
+          <a:lnRef idx="1">
+            <a:schemeClr val="accent1"/>
+          </a:lnRef>
+          <a:fillRef idx="3">
+            <a:schemeClr val="accent1"/>
+          </a:fillRef>
+          <a:effectRef idx="2">
+            <a:schemeClr val="accent1"/>
+          </a:effectRef>
+          <a:fontRef idx="minor">
+            <a:schemeClr val="lt1"/>
+          </a:fontRef>
+        </p:style>
+        <p:txBody>
+          <a:bodyPr rtlCol="0" anchor="ctr"/>
+          <a:lstStyle/>
+          <a:p>
+            <a:pPr algn="ctr"/>
+          </a:p>
+        </p:txBody>
+      </p:sp>
+      <p:pic>
+        <p:nvPicPr>
+          <p:cNvPr id="4" name="Picture 3" descr="dyson5_s3_trade.png"/>
+          <p:cNvPicPr>
+            <a:picLocks noChangeAspect="1"/>
+          </p:cNvPicPr>
+          <p:nvPr/>
+        </p:nvPicPr>
+        <p:blipFill>
+          <a:blip r:embed="rId2"/>
+          <a:stretch>
+            <a:fillRect/>
+          </a:stretch>
+        </p:blipFill>
+        <p:spPr>
+          <a:xfrm>
+            <a:off x="411480" y="1298448"/>
+            <a:ext cx="11368735" cy="3791910"/>
+          </a:xfrm>
+          <a:prstGeom prst="rect">
+            <a:avLst/>
+          </a:prstGeom>
+        </p:spPr>
+      </p:pic>
+      <p:sp>
+        <p:nvSpPr>
+          <p:cNvPr id="5" name="TextBox 4"/>
+          <p:cNvSpPr txBox="1"/>
+          <p:nvPr/>
+        </p:nvSpPr>
+        <p:spPr>
+          <a:xfrm>
+            <a:off x="411480" y="5108646"/>
+            <a:ext cx="11368735" cy="394208"/>
+          </a:xfrm>
+          <a:prstGeom prst="rect">
+            <a:avLst/>
+          </a:prstGeom>
+          <a:noFill/>
+        </p:spPr>
+        <p:txBody>
+          <a:bodyPr wrap="square">
+            <a:spAutoFit/>
+          </a:bodyPr>
+          <a:lstStyle/>
+          <a:p>
+            <a:pPr algn="ctr">
+              <a:spcAft>
+                <a:spcPts val="0"/>
+              </a:spcAft>
+            </a:pPr>
+            <a:r>
+              <a:rPr sz="1000" b="0">
+                <a:solidFill>
+                  <a:srgbClr val="6E6E6E"/>
+                </a:solidFill>
+                <a:latin typeface="Arial"/>
+              </a:rPr>
+              <a:t>Left: keystone and smile maxima (log scale) against the 1 % rule.  Middle: CRF and SRF FWHM against the 1.5 px specification and the 2-px-slit floor.  Right: minimum ensquared energy in one pixel against the 0.75 rule.</a:t>
+            </a:r>
+          </a:p>
+        </p:txBody>
+      </p:sp>
+    </p:spTree>
+  </p:cSld>
+  <p:clrMapOvr>
+    <a:masterClrMapping/>
+  </p:clrMapOvr>
+</p:sld>
+</file>
+
+<file path=ppt/slides/slide16.xml><?xml version="1.0" encoding="utf-8"?>
+<p:sld xmlns:a="http://schemas.openxmlformats.org/drawingml/2006/main" xmlns:p="http://schemas.openxmlformats.org/presentationml/2006/main" xmlns:r="http://schemas.openxmlformats.org/officeDocument/2006/relationships">
+  <p:cSld>
+    <p:spTree>
+      <p:nvGrpSpPr>
+        <p:cNvPr id="1" name=""/>
+        <p:cNvGrpSpPr/>
+        <p:nvPr/>
+      </p:nvGrpSpPr>
+      <p:grpSpPr/>
+      <p:sp>
+        <p:nvSpPr>
+          <p:cNvPr id="2" name="TextBox 1"/>
+          <p:cNvSpPr txBox="1"/>
+          <p:nvPr/>
+        </p:nvSpPr>
+        <p:spPr>
+          <a:xfrm>
+            <a:off x="411480" y="201168"/>
+            <a:ext cx="11368735" cy="914400"/>
+          </a:xfrm>
+          <a:prstGeom prst="rect">
+            <a:avLst/>
+          </a:prstGeom>
+          <a:noFill/>
+        </p:spPr>
+        <p:txBody>
+          <a:bodyPr wrap="square">
+            <a:spAutoFit/>
+          </a:bodyPr>
+          <a:lstStyle/>
+          <a:p>
+            <a:pPr>
+              <a:spcAft>
+                <a:spcPts val="400"/>
+              </a:spcAft>
+            </a:pPr>
+            <a:r>
+              <a:rPr sz="2400" b="1">
+                <a:solidFill>
+                  <a:srgbClr val="1F4E79"/>
+                </a:solidFill>
+                <a:latin typeface="Arial"/>
+              </a:rPr>
+              <a:t>The propagation twin</a:t>
+            </a:r>
+          </a:p>
+          <a:p>
+            <a:pPr>
+              <a:spcAft>
+                <a:spcPts val="0"/>
+              </a:spcAft>
+            </a:pPr>
+            <a:r>
+              <a:rPr sz="1250" b="0">
+                <a:solidFill>
+                  <a:srgbClr val="6E6E6E"/>
+                </a:solidFill>
+                <a:latin typeface="Arial"/>
+              </a:rPr>
+              <a:t>A far-field terminal on a reference sphere, re-posed per slit position and wavelength, agrees with the ray centroids to 0.0013 px</a:t>
+            </a:r>
+          </a:p>
+        </p:txBody>
+      </p:sp>
+      <p:sp>
+        <p:nvSpPr>
+          <p:cNvPr id="3" name="Rectangle 2"/>
+          <p:cNvSpPr/>
+          <p:nvPr/>
+        </p:nvSpPr>
+        <p:spPr>
+          <a:xfrm>
+            <a:off x="411480" y="1133856"/>
+            <a:ext cx="11368735" cy="20320"/>
+          </a:xfrm>
+          <a:prstGeom prst="rect">
+            <a:avLst/>
+          </a:prstGeom>
+          <a:solidFill>
+            <a:srgbClr val="B8C6D4"/>
+          </a:solidFill>
+          <a:ln>
+            <a:noFill/>
+          </a:ln>
+          <a:effectLst/>
+        </p:spPr>
+        <p:style>
+          <a:lnRef idx="1">
+            <a:schemeClr val="accent1"/>
+          </a:lnRef>
+          <a:fillRef idx="3">
+            <a:schemeClr val="accent1"/>
+          </a:fillRef>
+          <a:effectRef idx="2">
+            <a:schemeClr val="accent1"/>
+          </a:effectRef>
+          <a:fontRef idx="minor">
+            <a:schemeClr val="lt1"/>
+          </a:fontRef>
+        </p:style>
+        <p:txBody>
+          <a:bodyPr rtlCol="0" anchor="ctr"/>
+          <a:lstStyle/>
+          <a:p>
+            <a:pPr algn="ctr"/>
+          </a:p>
+        </p:txBody>
+      </p:sp>
+      <p:pic>
+        <p:nvPicPr>
+          <p:cNvPr id="4" name="Picture 3" descr="dyson5_s2w_twin.png"/>
+          <p:cNvPicPr>
+            <a:picLocks noChangeAspect="1"/>
+          </p:cNvPicPr>
+          <p:nvPr/>
+        </p:nvPicPr>
+        <p:blipFill>
+          <a:blip r:embed="rId2"/>
+          <a:stretch>
+            <a:fillRect/>
+          </a:stretch>
+        </p:blipFill>
+        <p:spPr>
+          <a:xfrm>
+            <a:off x="411480" y="1298448"/>
+            <a:ext cx="11368735" cy="3183469"/>
+          </a:xfrm>
+          <a:prstGeom prst="rect">
+            <a:avLst/>
+          </a:prstGeom>
+        </p:spPr>
+      </p:pic>
+      <p:sp>
+        <p:nvSpPr>
+          <p:cNvPr id="5" name="TextBox 4"/>
+          <p:cNvSpPr txBox="1"/>
+          <p:nvPr/>
+        </p:nvSpPr>
+        <p:spPr>
+          <a:xfrm>
+            <a:off x="411480" y="4500205"/>
+            <a:ext cx="11368735" cy="394208"/>
+          </a:xfrm>
+          <a:prstGeom prst="rect">
+            <a:avLst/>
+          </a:prstGeom>
+          <a:noFill/>
+        </p:spPr>
+        <p:txBody>
+          <a:bodyPr wrap="square">
+            <a:spAutoFit/>
+          </a:bodyPr>
+          <a:lstStyle/>
+          <a:p>
+            <a:pPr algn="ctr">
+              <a:spcAft>
+                <a:spcPts val="0"/>
+              </a:spcAft>
+            </a:pPr>
+            <a:r>
+              <a:rPr sz="1000" b="0">
+                <a:solidFill>
+                  <a:srgbClr val="6E6E6E"/>
+                </a:solidFill>
+                <a:latin typeface="Arial"/>
+              </a:rPr>
+              <a:t>Left: the Offner at order 0, PSF (log scale) with the 18 µm pixel box, 85 % ensquared.  Middle: wave-minus-ray centroid over the slit and band, Offner and Dyson seeds.  Right: SRF and CRF from the propagated PSF at the slit centre.</a:t>
+            </a:r>
+          </a:p>
+        </p:txBody>
+      </p:sp>
+      <p:sp>
+        <p:nvSpPr>
+          <p:cNvPr id="6" name="TextBox 5"/>
+          <p:cNvSpPr txBox="1"/>
+          <p:nvPr/>
+        </p:nvSpPr>
+        <p:spPr>
+          <a:xfrm>
+            <a:off x="411480" y="4930989"/>
+            <a:ext cx="11368735" cy="274320"/>
+          </a:xfrm>
+          <a:prstGeom prst="rect">
+            <a:avLst/>
+          </a:prstGeom>
+          <a:noFill/>
+        </p:spPr>
+        <p:txBody>
+          <a:bodyPr wrap="square">
+            <a:spAutoFit/>
+          </a:bodyPr>
+          <a:lstStyle/>
+          <a:p>
+            <a:pPr>
+              <a:spcAft>
+                <a:spcPts val="600"/>
+              </a:spcAft>
+            </a:pPr>
+            <a:r>
+              <a:rPr sz="1500" b="0">
+                <a:solidFill>
+                  <a:srgbClr val="282828"/>
+                </a:solidFill>
+                <a:latin typeface="Arial"/>
+              </a:rPr>
+              <a:t>•  What it checks: the ray-side scorer's centroids and response functions against physical-optics propagation through the same decks; across a grating the comparison is made in phase (modulo λ), never as unwrapped lengths.</a:t>
+            </a:r>
+          </a:p>
+        </p:txBody>
+      </p:sp>
+    </p:spTree>
+  </p:cSld>
+  <p:clrMapOvr>
+    <a:masterClrMapping/>
+  </p:clrMapOvr>
+</p:sld>
+</file>
+
+<file path=ppt/slides/slide17.xml><?xml version="1.0" encoding="utf-8"?>
+<p:sld xmlns:a="http://schemas.openxmlformats.org/drawingml/2006/main" xmlns:p="http://schemas.openxmlformats.org/presentationml/2006/main" xmlns:r="http://schemas.openxmlformats.org/officeDocument/2006/relationships">
+  <p:cSld>
+    <p:spTree>
+      <p:nvGrpSpPr>
+        <p:cNvPr id="1" name=""/>
+        <p:cNvGrpSpPr/>
+        <p:nvPr/>
+      </p:nvGrpSpPr>
+      <p:grpSpPr/>
+      <p:sp>
+        <p:nvSpPr>
+          <p:cNvPr id="2" name="TextBox 1"/>
+          <p:cNvSpPr txBox="1"/>
+          <p:nvPr/>
+        </p:nvSpPr>
+        <p:spPr>
+          <a:xfrm>
+            <a:off x="411480" y="201168"/>
+            <a:ext cx="11368735" cy="914400"/>
+          </a:xfrm>
+          <a:prstGeom prst="rect">
+            <a:avLst/>
+          </a:prstGeom>
+          <a:noFill/>
+        </p:spPr>
+        <p:txBody>
+          <a:bodyPr wrap="square">
+            <a:spAutoFit/>
+          </a:bodyPr>
+          <a:lstStyle/>
+          <a:p>
+            <a:pPr>
+              <a:spcAft>
+                <a:spcPts val="400"/>
+              </a:spcAft>
+            </a:pPr>
+            <a:r>
+              <a:rPr sz="2400" b="1">
+                <a:solidFill>
+                  <a:srgbClr val="1F4E79"/>
+                </a:solidFill>
+                <a:latin typeface="Arial"/>
+              </a:rPr>
+              <a:t>Slit diffraction loss</a:t>
+            </a:r>
+          </a:p>
+          <a:p>
+            <a:pPr>
+              <a:spcAft>
+                <a:spcPts val="0"/>
+              </a:spcAft>
+            </a:pPr>
+            <a:r>
+              <a:rPr sz="1250" b="0">
+                <a:solidFill>
+                  <a:srgbClr val="6E6E6E"/>
+                </a:solidFill>
+                <a:latin typeface="Arial"/>
+              </a:rPr>
+              <a:t>A 36 µm slit at F/1.8: the engine's far-field leg against the sinc² closed form</a:t>
+            </a:r>
+          </a:p>
+        </p:txBody>
+      </p:sp>
+      <p:sp>
+        <p:nvSpPr>
+          <p:cNvPr id="3" name="Rectangle 2"/>
+          <p:cNvSpPr/>
+          <p:nvPr/>
+        </p:nvSpPr>
+        <p:spPr>
+          <a:xfrm>
+            <a:off x="411480" y="1133856"/>
+            <a:ext cx="11368735" cy="20320"/>
+          </a:xfrm>
+          <a:prstGeom prst="rect">
+            <a:avLst/>
+          </a:prstGeom>
+          <a:solidFill>
+            <a:srgbClr val="B8C6D4"/>
+          </a:solidFill>
+          <a:ln>
+            <a:noFill/>
+          </a:ln>
+          <a:effectLst/>
+        </p:spPr>
+        <p:style>
+          <a:lnRef idx="1">
+            <a:schemeClr val="accent1"/>
+          </a:lnRef>
+          <a:fillRef idx="3">
+            <a:schemeClr val="accent1"/>
+          </a:fillRef>
+          <a:effectRef idx="2">
+            <a:schemeClr val="accent1"/>
+          </a:effectRef>
+          <a:fontRef idx="minor">
+            <a:schemeClr val="lt1"/>
+          </a:fontRef>
+        </p:style>
+        <p:txBody>
+          <a:bodyPr rtlCol="0" anchor="ctr"/>
+          <a:lstStyle/>
+          <a:p>
+            <a:pPr algn="ctr"/>
+          </a:p>
+        </p:txBody>
+      </p:sp>
+      <p:pic>
+        <p:nvPicPr>
+          <p:cNvPr id="4" name="Picture 3" descr="dyson5_s2l_slitloss.png"/>
+          <p:cNvPicPr>
+            <a:picLocks noChangeAspect="1"/>
+          </p:cNvPicPr>
+          <p:nvPr/>
+        </p:nvPicPr>
+        <p:blipFill>
+          <a:blip r:embed="rId2"/>
+          <a:stretch>
+            <a:fillRect/>
+          </a:stretch>
+        </p:blipFill>
+        <p:spPr>
+          <a:xfrm>
+            <a:off x="2289166" y="1298448"/>
+            <a:ext cx="7613362" cy="5165852"/>
+          </a:xfrm>
+          <a:prstGeom prst="rect">
+            <a:avLst/>
+          </a:prstGeom>
+        </p:spPr>
+      </p:pic>
+      <p:sp>
+        <p:nvSpPr>
+          <p:cNvPr id="5" name="TextBox 4"/>
+          <p:cNvSpPr txBox="1"/>
+          <p:nvPr/>
+        </p:nvSpPr>
+        <p:spPr>
+          <a:xfrm>
+            <a:off x="411480" y="6482588"/>
+            <a:ext cx="11368735" cy="229107"/>
+          </a:xfrm>
+          <a:prstGeom prst="rect">
+            <a:avLst/>
+          </a:prstGeom>
+          <a:noFill/>
+        </p:spPr>
+        <p:txBody>
+          <a:bodyPr wrap="square">
+            <a:spAutoFit/>
+          </a:bodyPr>
+          <a:lstStyle/>
+          <a:p>
+            <a:pPr algn="ctr">
+              <a:spcAft>
+                <a:spcPts val="0"/>
+              </a:spcAft>
+            </a:pPr>
+            <a:r>
+              <a:rPr sz="1000" b="0">
+                <a:solidFill>
+                  <a:srgbClr val="6E6E6E"/>
+                </a:solidFill>
+                <a:latin typeface="Arial"/>
+              </a:rPr>
+              <a:t>Loss past the grating versus wavelength: engine far-field leg (points) against the sinc² form (line).</a:t>
+            </a:r>
+          </a:p>
+        </p:txBody>
+      </p:sp>
+      <p:sp>
+        <p:nvSpPr>
+          <p:cNvPr id="6" name="TextBox 5"/>
+          <p:cNvSpPr txBox="1"/>
+          <p:nvPr/>
+        </p:nvSpPr>
+        <p:spPr>
+          <a:xfrm>
+            <a:off x="411480" y="6748272"/>
+            <a:ext cx="11368735" cy="274320"/>
+          </a:xfrm>
+          <a:prstGeom prst="rect">
+            <a:avLst/>
+          </a:prstGeom>
+          <a:noFill/>
+        </p:spPr>
+        <p:txBody>
+          <a:bodyPr wrap="square">
+            <a:spAutoFit/>
+          </a:bodyPr>
+          <a:lstStyle/>
+          <a:p>
+            <a:pPr>
+              <a:spcAft>
+                <a:spcPts val="600"/>
+              </a:spcAft>
+            </a:pPr>
+            <a:r>
+              <a:rPr sz="1500" b="0">
+                <a:solidFill>
+                  <a:srgbClr val="282828"/>
+                </a:solidFill>
+                <a:latin typeface="Arial"/>
+              </a:rPr>
+              <a:t>•  Under 2.5 % over the band by both; the engine runs above the closed form at the long end (2.48 % against 1.83 % at 2500 nm) and below it at the short end, and that factor is an open item in the record.</a:t>
+            </a:r>
+          </a:p>
+        </p:txBody>
+      </p:sp>
+    </p:spTree>
+  </p:cSld>
+  <p:clrMapOvr>
+    <a:masterClrMapping/>
+  </p:clrMapOvr>
+</p:sld>
+</file>
+
+<file path=ppt/slides/slide18.xml><?xml version="1.0" encoding="utf-8"?>
+<p:sld xmlns:a="http://schemas.openxmlformats.org/drawingml/2006/main" xmlns:p="http://schemas.openxmlformats.org/presentationml/2006/main" xmlns:r="http://schemas.openxmlformats.org/officeDocument/2006/relationships">
+  <p:cSld>
+    <p:spTree>
+      <p:nvGrpSpPr>
+        <p:cNvPr id="1" name=""/>
+        <p:cNvGrpSpPr/>
+        <p:nvPr/>
+      </p:nvGrpSpPr>
+      <p:grpSpPr/>
+      <p:sp>
+        <p:nvSpPr>
+          <p:cNvPr id="2" name="TextBox 1"/>
+          <p:cNvSpPr txBox="1"/>
+          <p:nvPr/>
+        </p:nvSpPr>
+        <p:spPr>
+          <a:xfrm>
+            <a:off x="411480" y="201168"/>
+            <a:ext cx="11368735" cy="914400"/>
+          </a:xfrm>
+          <a:prstGeom prst="rect">
+            <a:avLst/>
+          </a:prstGeom>
+          <a:noFill/>
+        </p:spPr>
+        <p:txBody>
+          <a:bodyPr wrap="square">
+            <a:spAutoFit/>
+          </a:bodyPr>
+          <a:lstStyle/>
+          <a:p>
+            <a:pPr>
+              <a:spcAft>
+                <a:spcPts val="400"/>
+              </a:spcAft>
+            </a:pPr>
+            <a:r>
+              <a:rPr sz="2400" b="1">
+                <a:solidFill>
+                  <a:srgbClr val="1F4E79"/>
+                </a:solidFill>
+                <a:latin typeface="Arial"/>
+              </a:rPr>
+              <a:t>Next steps</a:t>
+            </a:r>
+          </a:p>
+          <a:p>
+            <a:pPr>
+              <a:spcAft>
+                <a:spcPts val="0"/>
+              </a:spcAft>
+            </a:pPr>
+            <a:r>
+              <a:rPr sz="1250" b="0">
+                <a:solidFill>
+                  <a:srgbClr val="6E6E6E"/>
+                </a:solidFill>
+                <a:latin typeface="Arial"/>
+              </a:rPr>
+              <a:t>Clearance on the design of record, the global meniscus search, and the telescope that feeds the slit</a:t>
+            </a:r>
+          </a:p>
+        </p:txBody>
+      </p:sp>
+      <p:sp>
+        <p:nvSpPr>
+          <p:cNvPr id="3" name="Rectangle 2"/>
+          <p:cNvSpPr/>
+          <p:nvPr/>
+        </p:nvSpPr>
+        <p:spPr>
+          <a:xfrm>
+            <a:off x="411480" y="1133856"/>
+            <a:ext cx="11368735" cy="20320"/>
+          </a:xfrm>
+          <a:prstGeom prst="rect">
+            <a:avLst/>
+          </a:prstGeom>
+          <a:solidFill>
+            <a:srgbClr val="B8C6D4"/>
+          </a:solidFill>
+          <a:ln>
+            <a:noFill/>
+          </a:ln>
+          <a:effectLst/>
+        </p:spPr>
+        <p:style>
+          <a:lnRef idx="1">
+            <a:schemeClr val="accent1"/>
+          </a:lnRef>
+          <a:fillRef idx="3">
+            <a:schemeClr val="accent1"/>
+          </a:fillRef>
+          <a:effectRef idx="2">
+            <a:schemeClr val="accent1"/>
+          </a:effectRef>
+          <a:fontRef idx="minor">
+            <a:schemeClr val="lt1"/>
+          </a:fontRef>
+        </p:style>
+        <p:txBody>
+          <a:bodyPr rtlCol="0" anchor="ctr"/>
+          <a:lstStyle/>
+          <a:p>
+            <a:pPr algn="ctr"/>
+          </a:p>
+        </p:txBody>
+      </p:sp>
+      <p:sp>
+        <p:nvSpPr>
+          <p:cNvPr id="4" name="TextBox 3"/>
+          <p:cNvSpPr txBox="1"/>
+          <p:nvPr/>
+        </p:nvSpPr>
+        <p:spPr>
+          <a:xfrm>
+            <a:off x="411480" y="1298448"/>
+            <a:ext cx="5806440" cy="274320"/>
+          </a:xfrm>
+          <a:prstGeom prst="rect">
+            <a:avLst/>
+          </a:prstGeom>
+          <a:noFill/>
+        </p:spPr>
+        <p:txBody>
+          <a:bodyPr wrap="square">
+            <a:spAutoFit/>
+          </a:bodyPr>
+          <a:lstStyle/>
+          <a:p>
+            <a:pPr>
+              <a:spcAft>
+                <a:spcPts val="600"/>
+              </a:spcAft>
+            </a:pPr>
+            <a:r>
+              <a:rPr sz="1200" b="0">
+                <a:solidFill>
+                  <a:srgbClr val="282828"/>
+                </a:solidFill>
+                <a:latin typeface="Arial"/>
+              </a:rPr>
+              <a:t>•  Apertures and clearance on R4: declare every element's aperture from the footprint hulls, compute the minimum clearance of every beam leg against every body it does not traverse, model the slit-to-detector package on the block's face (a fold prism if it fails), and re-pose the Offner reference at a 0.2 R slit offset.</a:t>
+            </a:r>
+          </a:p>
+          <a:p>
+            <a:pPr>
+              <a:spcAft>
+                <a:spcPts val="600"/>
+              </a:spcAft>
+            </a:pPr>
+            <a:r>
+              <a:rPr sz="1200" b="0">
+                <a:solidFill>
+                  <a:srgbClr val="282828"/>
+                </a:solidFill>
+                <a:latin typeface="Arial"/>
+              </a:rPr>
+              <a:t>•  Beat 4: a global search over the meniscus (the R4 solve ends on its bounds) and the native multi-wavelength optimizer with the same smile and keystone operands.</a:t>
+            </a:r>
+          </a:p>
+        </p:txBody>
+      </p:sp>
+      <p:sp>
+        <p:nvSpPr>
+          <p:cNvPr id="5" name="TextBox 4"/>
+          <p:cNvSpPr txBox="1"/>
+          <p:nvPr/>
+        </p:nvSpPr>
+        <p:spPr>
+          <a:xfrm>
+            <a:off x="6400800" y="1298448"/>
+            <a:ext cx="5394960" cy="274320"/>
+          </a:xfrm>
+          <a:prstGeom prst="rect">
+            <a:avLst/>
+          </a:prstGeom>
+          <a:noFill/>
+        </p:spPr>
+        <p:txBody>
+          <a:bodyPr wrap="square">
+            <a:spAutoFit/>
+          </a:bodyPr>
+          <a:lstStyle/>
+          <a:p>
+            <a:pPr>
+              <a:spcAft>
+                <a:spcPts val="600"/>
+              </a:spcAft>
+            </a:pPr>
+            <a:r>
+              <a:rPr sz="1200" b="0">
+                <a:solidFill>
+                  <a:srgbClr val="282828"/>
+                </a:solidFill>
+                <a:latin typeface="Arial"/>
+              </a:rPr>
+              <a:t>•  Beat 5, the telescope: EMIT parameters — 420 km, 60 m ground sample, 0.143 mrad IFOV, focal length 126 mm, 70 mm aperture at F/1.8, 24.6° cross-track field onto the 54 mm slit, telecentric and flat; the telescope's exit pupil on the grating.  Then spectrometer and telescope traced end to end as one deck.</a:t>
+            </a:r>
+          </a:p>
+          <a:p>
+            <a:pPr>
+              <a:spcAft>
+                <a:spcPts val="600"/>
+              </a:spcAft>
+            </a:pPr>
+            <a:r>
+              <a:rPr sz="1200" b="0">
+                <a:solidFill>
+                  <a:srgbClr val="282828"/>
+                </a:solidFill>
+                <a:latin typeface="Arial"/>
+              </a:rPr>
+              <a:t>•  Then the physical-optics twin on R4 and the radiometric chain against the band.</a:t>
+            </a:r>
+          </a:p>
+        </p:txBody>
+      </p:sp>
+    </p:spTree>
+  </p:cSld>
+  <p:clrMapOvr>
+    <a:masterClrMapping/>
+  </p:clrMapOvr>
+</p:sld>
+</file>
+
+<file path=ppt/slides/slide19.xml><?xml version="1.0" encoding="utf-8"?>
+<p:sld xmlns:a="http://schemas.openxmlformats.org/drawingml/2006/main" xmlns:p="http://schemas.openxmlformats.org/presentationml/2006/main" xmlns:r="http://schemas.openxmlformats.org/officeDocument/2006/relationships">
+  <p:cSld>
+    <p:spTree>
+      <p:nvGrpSpPr>
+        <p:cNvPr id="1" name=""/>
+        <p:cNvGrpSpPr/>
+        <p:nvPr/>
+      </p:nvGrpSpPr>
+      <p:grpSpPr/>
+      <p:sp>
+        <p:nvSpPr>
+          <p:cNvPr id="2" name="TextBox 1"/>
+          <p:cNvSpPr txBox="1"/>
+          <p:nvPr/>
+        </p:nvSpPr>
+        <p:spPr>
+          <a:xfrm>
+            <a:off x="411480" y="201168"/>
+            <a:ext cx="11368735" cy="914400"/>
+          </a:xfrm>
+          <a:prstGeom prst="rect">
+            <a:avLst/>
+          </a:prstGeom>
+          <a:noFill/>
+        </p:spPr>
+        <p:txBody>
+          <a:bodyPr wrap="square">
+            <a:spAutoFit/>
+          </a:bodyPr>
+          <a:lstStyle/>
+          <a:p>
+            <a:pPr>
+              <a:spcAft>
+                <a:spcPts val="400"/>
+              </a:spcAft>
+            </a:pPr>
+            <a:r>
+              <a:rPr sz="2400" b="1">
+                <a:solidFill>
+                  <a:srgbClr val="1F4E79"/>
+                </a:solidFill>
+                <a:latin typeface="Arial"/>
+              </a:rPr>
+              <a:t>Run it yourself</a:t>
+            </a:r>
+          </a:p>
+          <a:p>
+            <a:pPr>
+              <a:spcAft>
+                <a:spcPts val="0"/>
+              </a:spcAft>
+            </a:pPr>
+            <a:r>
+              <a:rPr sz="1250" b="0">
+                <a:solidFill>
+                  <a:srgbClr val="6E6E6E"/>
+                </a:solidFill>
+                <a:latin typeface="Arial"/>
+              </a:rPr>
+              <a:t>One parameter file, one runner, every stage through it</a:t>
+            </a:r>
+          </a:p>
+        </p:txBody>
+      </p:sp>
+      <p:sp>
+        <p:nvSpPr>
+          <p:cNvPr id="3" name="Rectangle 2"/>
+          <p:cNvSpPr/>
+          <p:nvPr/>
+        </p:nvSpPr>
+        <p:spPr>
+          <a:xfrm>
+            <a:off x="411480" y="1133856"/>
+            <a:ext cx="11368735" cy="20320"/>
+          </a:xfrm>
+          <a:prstGeom prst="rect">
+            <a:avLst/>
+          </a:prstGeom>
+          <a:solidFill>
+            <a:srgbClr val="B8C6D4"/>
+          </a:solidFill>
+          <a:ln>
+            <a:noFill/>
+          </a:ln>
+          <a:effectLst/>
+        </p:spPr>
+        <p:style>
+          <a:lnRef idx="1">
+            <a:schemeClr val="accent1"/>
+          </a:lnRef>
+          <a:fillRef idx="3">
+            <a:schemeClr val="accent1"/>
+          </a:fillRef>
+          <a:effectRef idx="2">
+            <a:schemeClr val="accent1"/>
+          </a:effectRef>
+          <a:fontRef idx="minor">
+            <a:schemeClr val="lt1"/>
+          </a:fontRef>
+        </p:style>
+        <p:txBody>
+          <a:bodyPr rtlCol="0" anchor="ctr"/>
+          <a:lstStyle/>
+          <a:p>
+            <a:pPr algn="ctr"/>
+          </a:p>
+        </p:txBody>
+      </p:sp>
+      <p:sp>
+        <p:nvSpPr>
+          <p:cNvPr id="4" name="Rectangle 3"/>
+          <p:cNvSpPr/>
+          <p:nvPr/>
+        </p:nvSpPr>
+        <p:spPr>
+          <a:xfrm>
+            <a:off x="411480" y="1298448"/>
+            <a:ext cx="11368735" cy="935736"/>
+          </a:xfrm>
+          <a:prstGeom prst="rect">
+            <a:avLst/>
+          </a:prstGeom>
+          <a:solidFill>
+            <a:srgbClr val="FFFFFF"/>
+          </a:solidFill>
+          <a:ln w="9525">
+            <a:solidFill>
+              <a:srgbClr val="1F4E79"/>
+            </a:solidFill>
+          </a:ln>
+          <a:effectLst/>
+        </p:spPr>
+        <p:style>
+          <a:lnRef idx="1">
+            <a:schemeClr val="accent1"/>
+          </a:lnRef>
+          <a:fillRef idx="3">
+            <a:schemeClr val="accent1"/>
+          </a:fillRef>
+          <a:effectRef idx="2">
+            <a:schemeClr val="accent1"/>
+          </a:effectRef>
+          <a:fontRef idx="minor">
+            <a:schemeClr val="lt1"/>
+          </a:fontRef>
+        </p:style>
+        <p:txBody>
+          <a:bodyPr rtlCol="0" anchor="t" wrap="square"/>
+          <a:lstStyle/>
+          <a:p>
+            <a:pPr algn="ctr">
+              <a:spcAft>
+                <a:spcPts val="100"/>
+              </a:spcAft>
+            </a:pPr>
+            <a:r>
+              <a:rPr sz="1150" b="0">
+                <a:solidFill>
+                  <a:srgbClr val="282828"/>
+                </a:solidFill>
+                <a:latin typeface="Consolas"/>
+              </a:rPr>
+              <a:t>run('&lt;path&gt;/mmacos/mmacos_setup.m');</a:t>
+            </a:r>
+          </a:p>
+          <a:p>
+            <a:pPr>
+              <a:spcAft>
+                <a:spcPts val="100"/>
+              </a:spcAft>
+            </a:pPr>
+            <a:r>
+              <a:rPr sz="1150" b="0">
+                <a:solidFill>
+                  <a:srgbClr val="282828"/>
+                </a:solidFill>
+                <a:latin typeface="Consolas"/>
+              </a:rPr>
+              <a:t>addpath('&lt;path&gt;/mmacos/challenges/dyson5');</a:t>
+            </a:r>
+          </a:p>
+          <a:p>
+            <a:pPr>
+              <a:spcAft>
+                <a:spcPts val="100"/>
+              </a:spcAft>
+            </a:pPr>
+            <a:r>
+              <a:rPr sz="1150" b="0">
+                <a:solidFill>
+                  <a:srgbClr val="282828"/>
+                </a:solidFill>
+                <a:latin typeface="Consolas"/>
+              </a:rPr>
+              <a:t>OUT = dyson5_run();                                      % stage s0: the scaling law (engine-free)</a:t>
+            </a:r>
+          </a:p>
+          <a:p>
+            <a:pPr>
+              <a:spcAft>
+                <a:spcPts val="100"/>
+              </a:spcAft>
+            </a:pPr>
+            <a:r>
+              <a:rPr sz="1150" b="0">
+                <a:solidFill>
+                  <a:srgbClr val="282828"/>
+                </a:solidFill>
+                <a:latin typeface="Consolas"/>
+              </a:rPr>
+              <a:t>OUT = dyson5_run(struct('stages', {{'s1','s2','s3'}}));  % emit, score, ladder</a:t>
+            </a:r>
+          </a:p>
+        </p:txBody>
+      </p:sp>
+      <p:sp>
+        <p:nvSpPr>
+          <p:cNvPr id="5" name="TextBox 4"/>
+          <p:cNvSpPr txBox="1"/>
+          <p:nvPr/>
+        </p:nvSpPr>
+        <p:spPr>
+          <a:xfrm>
+            <a:off x="411480" y="2343912"/>
+            <a:ext cx="11368735" cy="274320"/>
+          </a:xfrm>
+          <a:prstGeom prst="rect">
+            <a:avLst/>
+          </a:prstGeom>
+          <a:noFill/>
+        </p:spPr>
+        <p:txBody>
+          <a:bodyPr wrap="square">
+            <a:spAutoFit/>
+          </a:bodyPr>
+          <a:lstStyle/>
+          <a:p>
+            <a:pPr>
+              <a:spcAft>
+                <a:spcPts val="600"/>
+              </a:spcAft>
+            </a:pPr>
+            <a:r>
+              <a:rPr sz="1500" b="0">
+                <a:solidFill>
+                  <a:srgbClr val="282828"/>
+                </a:solidFill>
+                <a:latin typeface="Arial"/>
+              </a:rPr>
+              <a:t>•  Knobs live in dyson5_params.m (F-number, pixel, band, slit, block radius, ladder options); every record in this deck is a stage output under challenges/dyson5/.</a:t>
+            </a:r>
+          </a:p>
+          <a:p>
+            <a:pPr>
+              <a:spcAft>
+                <a:spcPts val="600"/>
+              </a:spcAft>
+            </a:pPr>
+            <a:r>
+              <a:rPr sz="1500" b="0">
+                <a:solidFill>
+                  <a:srgbClr val="282828"/>
+                </a:solidFill>
+                <a:latin typeface="Arial"/>
+              </a:rPr>
+              <a:t>•  Engine checks: ./run_mmacos_tests.sh tSpectrometerRx and the four grating / glass / propagation classes, all in the fast suite.</a:t>
+            </a:r>
+          </a:p>
+        </p:txBody>
+      </p:sp>
+    </p:spTree>
+  </p:cSld>
+  <p:clrMapOvr>
+    <a:masterClrMapping/>
+  </p:clrMapOvr>
+</p:sld>
+</file>
+
+<file path=ppt/slides/slide2.xml><?xml version="1.0" encoding="utf-8"?>
+<p:sld xmlns:a="http://schemas.openxmlformats.org/drawingml/2006/main" xmlns:p="http://schemas.openxmlformats.org/presentationml/2006/main" xmlns:r="http://schemas.openxmlformats.org/officeDocument/2006/relationships">
+  <p:cSld>
+    <p:spTree>
+      <p:nvGrpSpPr>
+        <p:cNvPr id="1" name=""/>
+        <p:cNvGrpSpPr/>
+        <p:nvPr/>
+      </p:nvGrpSpPr>
+      <p:grpSpPr/>
+      <p:sp>
+        <p:nvSpPr>
+          <p:cNvPr id="2" name="TextBox 1"/>
+          <p:cNvSpPr txBox="1"/>
+          <p:nvPr/>
+        </p:nvSpPr>
+        <p:spPr>
+          <a:xfrm>
+            <a:off x="411480" y="201168"/>
+            <a:ext cx="11368735" cy="914400"/>
+          </a:xfrm>
+          <a:prstGeom prst="rect">
+            <a:avLst/>
+          </a:prstGeom>
+          <a:noFill/>
+        </p:spPr>
+        <p:txBody>
+          <a:bodyPr wrap="square">
+            <a:spAutoFit/>
+          </a:bodyPr>
+          <a:lstStyle/>
+          <a:p>
+            <a:pPr>
+              <a:spcAft>
+                <a:spcPts val="400"/>
+              </a:spcAft>
+            </a:pPr>
+            <a:r>
+              <a:rPr sz="2400" b="1">
+                <a:solidFill>
+                  <a:srgbClr val="1F4E79"/>
+                </a:solidFill>
+                <a:latin typeface="Arial"/>
+              </a:rPr>
+              <a:t>Contents</a:t>
+            </a:r>
+          </a:p>
+          <a:p>
+            <a:pPr>
+              <a:spcAft>
+                <a:spcPts val="0"/>
+              </a:spcAft>
+            </a:pPr>
+            <a:r>
+              <a:rPr sz="1250" b="0">
+                <a:solidFill>
+                  <a:srgbClr val="6E6E6E"/>
+                </a:solidFill>
+                <a:latin typeface="Arial"/>
+              </a:rPr>
+              <a:t>The target, the forms, the design ladder, the evidence</a:t>
+            </a:r>
+          </a:p>
+        </p:txBody>
+      </p:sp>
+      <p:sp>
+        <p:nvSpPr>
+          <p:cNvPr id="3" name="Rectangle 2"/>
+          <p:cNvSpPr/>
+          <p:nvPr/>
+        </p:nvSpPr>
+        <p:spPr>
+          <a:xfrm>
+            <a:off x="411480" y="1133856"/>
+            <a:ext cx="11368735" cy="20320"/>
+          </a:xfrm>
+          <a:prstGeom prst="rect">
+            <a:avLst/>
+          </a:prstGeom>
+          <a:solidFill>
+            <a:srgbClr val="B8C6D4"/>
+          </a:solidFill>
+          <a:ln>
+            <a:noFill/>
+          </a:ln>
+          <a:effectLst/>
+        </p:spPr>
+        <p:style>
+          <a:lnRef idx="1">
+            <a:schemeClr val="accent1"/>
+          </a:lnRef>
+          <a:fillRef idx="3">
+            <a:schemeClr val="accent1"/>
+          </a:fillRef>
+          <a:effectRef idx="2">
+            <a:schemeClr val="accent1"/>
+          </a:effectRef>
+          <a:fontRef idx="minor">
+            <a:schemeClr val="lt1"/>
+          </a:fontRef>
+        </p:style>
+        <p:txBody>
+          <a:bodyPr rtlCol="0" anchor="ctr"/>
+          <a:lstStyle/>
+          <a:p>
+            <a:pPr algn="ctr"/>
+          </a:p>
+        </p:txBody>
+      </p:sp>
+      <p:sp>
+        <p:nvSpPr>
+          <p:cNvPr id="4" name="TextBox 3"/>
+          <p:cNvSpPr txBox="1"/>
+          <p:nvPr/>
+        </p:nvSpPr>
+        <p:spPr>
+          <a:xfrm>
+            <a:off x="411480" y="1298448"/>
+            <a:ext cx="5806440" cy="274320"/>
+          </a:xfrm>
+          <a:prstGeom prst="rect">
+            <a:avLst/>
+          </a:prstGeom>
+          <a:noFill/>
+        </p:spPr>
+        <p:txBody>
+          <a:bodyPr wrap="square">
+            <a:spAutoFit/>
+          </a:bodyPr>
+          <a:lstStyle/>
+          <a:p>
+            <a:pPr>
+              <a:spcAft>
+                <a:spcPts val="600"/>
+              </a:spcAft>
+            </a:pPr>
+            <a:r>
+              <a:rPr sz="1200" b="0">
+                <a:solidFill>
+                  <a:srgbClr val="282828"/>
+                </a:solidFill>
+                <a:latin typeface="Arial"/>
+              </a:rPr>
+              <a:t>•  3 The target and how it is scored</a:t>
+            </a:r>
+          </a:p>
+          <a:p>
+            <a:pPr>
+              <a:spcAft>
+                <a:spcPts val="600"/>
+              </a:spcAft>
+            </a:pPr>
+            <a:r>
+              <a:rPr sz="1200" b="0">
+                <a:solidFill>
+                  <a:srgbClr val="282828"/>
+                </a:solidFill>
+                <a:latin typeface="Arial"/>
+              </a:rPr>
+              <a:t>•  4 The Dyson as traced by the engine</a:t>
+            </a:r>
+          </a:p>
+          <a:p>
+            <a:pPr>
+              <a:spcAft>
+                <a:spcPts val="600"/>
+              </a:spcAft>
+            </a:pPr>
+            <a:r>
+              <a:rPr sz="1200" b="0">
+                <a:solidFill>
+                  <a:srgbClr val="282828"/>
+                </a:solidFill>
+                <a:latin typeface="Arial"/>
+              </a:rPr>
+              <a:t>•  5 The Offner as traced by the engine</a:t>
+            </a:r>
+          </a:p>
+          <a:p>
+            <a:pPr>
+              <a:spcAft>
+                <a:spcPts val="600"/>
+              </a:spcAft>
+            </a:pPr>
+            <a:r>
+              <a:rPr sz="1200" b="0">
+                <a:solidFill>
+                  <a:srgbClr val="282828"/>
+                </a:solidFill>
+                <a:latin typeface="Arial"/>
+              </a:rPr>
+              <a:t>•  6 The concentric Dyson and its scaling law</a:t>
+            </a:r>
+          </a:p>
+          <a:p>
+            <a:pPr>
+              <a:spcAft>
+                <a:spcPts val="600"/>
+              </a:spcAft>
+            </a:pPr>
+            <a:r>
+              <a:rPr sz="1200" b="0">
+                <a:solidFill>
+                  <a:srgbClr val="282828"/>
+                </a:solidFill>
+                <a:latin typeface="Arial"/>
+              </a:rPr>
+              <a:t>•  7 The exact chain and the engine agree</a:t>
+            </a:r>
+          </a:p>
+          <a:p>
+            <a:pPr>
+              <a:spcAft>
+                <a:spcPts val="600"/>
+              </a:spcAft>
+            </a:pPr>
+            <a:r>
+              <a:rPr sz="1200" b="0">
+                <a:solidFill>
+                  <a:srgbClr val="282828"/>
+                </a:solidFill>
+                <a:latin typeface="Arial"/>
+              </a:rPr>
+              <a:t>•  8 The seed, scored</a:t>
+            </a:r>
+          </a:p>
+          <a:p>
+            <a:pPr>
+              <a:spcAft>
+                <a:spcPts val="600"/>
+              </a:spcAft>
+            </a:pPr>
+            <a:r>
+              <a:rPr sz="1200" b="0">
+                <a:solidFill>
+                  <a:srgbClr val="282828"/>
+                </a:solidFill>
+                <a:latin typeface="Arial"/>
+              </a:rPr>
+              <a:t>•  9 The departure ladder</a:t>
+            </a:r>
+          </a:p>
+          <a:p>
+            <a:pPr>
+              <a:spcAft>
+                <a:spcPts val="600"/>
+              </a:spcAft>
+            </a:pPr>
+            <a:r>
+              <a:rPr sz="1200" b="0">
+                <a:solidFill>
+                  <a:srgbClr val="282828"/>
+                </a:solidFill>
+                <a:latin typeface="Arial"/>
+              </a:rPr>
+              <a:t>•  10 The departure ladder, by the numbers</a:t>
+            </a:r>
+          </a:p>
+        </p:txBody>
+      </p:sp>
+      <p:sp>
+        <p:nvSpPr>
+          <p:cNvPr id="5" name="TextBox 4"/>
+          <p:cNvSpPr txBox="1"/>
+          <p:nvPr/>
+        </p:nvSpPr>
+        <p:spPr>
+          <a:xfrm>
+            <a:off x="6400800" y="1298448"/>
+            <a:ext cx="5394960" cy="274320"/>
+          </a:xfrm>
+          <a:prstGeom prst="rect">
+            <a:avLst/>
+          </a:prstGeom>
+          <a:noFill/>
+        </p:spPr>
+        <p:txBody>
+          <a:bodyPr wrap="square">
+            <a:spAutoFit/>
+          </a:bodyPr>
+          <a:lstStyle/>
+          <a:p>
+            <a:pPr>
+              <a:spcAft>
+                <a:spcPts val="600"/>
+              </a:spcAft>
+            </a:pPr>
+            <a:r>
+              <a:rPr sz="1200" b="0">
+                <a:solidFill>
+                  <a:srgbClr val="282828"/>
+                </a:solidFill>
+                <a:latin typeface="Arial"/>
+              </a:rPr>
+              <a:t>•  11 What each departure buys</a:t>
+            </a:r>
+          </a:p>
+          <a:p>
+            <a:pPr>
+              <a:spcAft>
+                <a:spcPts val="600"/>
+              </a:spcAft>
+            </a:pPr>
+            <a:r>
+              <a:rPr sz="1200" b="0">
+                <a:solidFill>
+                  <a:srgbClr val="282828"/>
+                </a:solidFill>
+                <a:latin typeface="Arial"/>
+              </a:rPr>
+              <a:t>•  12 The compact variant, as traced by the engine</a:t>
+            </a:r>
+          </a:p>
+          <a:p>
+            <a:pPr>
+              <a:spcAft>
+                <a:spcPts val="600"/>
+              </a:spcAft>
+            </a:pPr>
+            <a:r>
+              <a:rPr sz="1200" b="0">
+                <a:solidFill>
+                  <a:srgbClr val="282828"/>
+                </a:solidFill>
+                <a:latin typeface="Arial"/>
+              </a:rPr>
+              <a:t>•  13 The compact variant in section</a:t>
+            </a:r>
+          </a:p>
+          <a:p>
+            <a:pPr>
+              <a:spcAft>
+                <a:spcPts val="600"/>
+              </a:spcAft>
+            </a:pPr>
+            <a:r>
+              <a:rPr sz="1200" b="0">
+                <a:solidFill>
+                  <a:srgbClr val="282828"/>
+                </a:solidFill>
+                <a:latin typeface="Arial"/>
+              </a:rPr>
+              <a:t>•  14 The compact variant, scored</a:t>
+            </a:r>
+          </a:p>
+          <a:p>
+            <a:pPr>
+              <a:spcAft>
+                <a:spcPts val="600"/>
+              </a:spcAft>
+            </a:pPr>
+            <a:r>
+              <a:rPr sz="1200" b="0">
+                <a:solidFill>
+                  <a:srgbClr val="282828"/>
+                </a:solidFill>
+                <a:latin typeface="Arial"/>
+              </a:rPr>
+              <a:t>•  15 The trade at a glance</a:t>
+            </a:r>
+          </a:p>
+          <a:p>
+            <a:pPr>
+              <a:spcAft>
+                <a:spcPts val="600"/>
+              </a:spcAft>
+            </a:pPr>
+            <a:r>
+              <a:rPr sz="1200" b="0">
+                <a:solidFill>
+                  <a:srgbClr val="282828"/>
+                </a:solidFill>
+                <a:latin typeface="Arial"/>
+              </a:rPr>
+              <a:t>•  16 The propagation twin</a:t>
+            </a:r>
+          </a:p>
+          <a:p>
+            <a:pPr>
+              <a:spcAft>
+                <a:spcPts val="600"/>
+              </a:spcAft>
+            </a:pPr>
+            <a:r>
+              <a:rPr sz="1200" b="0">
+                <a:solidFill>
+                  <a:srgbClr val="282828"/>
+                </a:solidFill>
+                <a:latin typeface="Arial"/>
+              </a:rPr>
+              <a:t>•  17 Slit diffraction loss</a:t>
+            </a:r>
+          </a:p>
+          <a:p>
+            <a:pPr>
+              <a:spcAft>
+                <a:spcPts val="600"/>
+              </a:spcAft>
+            </a:pPr>
+            <a:r>
+              <a:rPr sz="1200" b="0">
+                <a:solidFill>
+                  <a:srgbClr val="282828"/>
+                </a:solidFill>
+                <a:latin typeface="Arial"/>
+              </a:rPr>
+              <a:t>•  18 Next steps</a:t>
+            </a:r>
+          </a:p>
+          <a:p>
+            <a:pPr>
+              <a:spcAft>
+                <a:spcPts val="600"/>
+              </a:spcAft>
+            </a:pPr>
+            <a:r>
+              <a:rPr sz="1200" b="0">
+                <a:solidFill>
+                  <a:srgbClr val="282828"/>
+                </a:solidFill>
+                <a:latin typeface="Arial"/>
+              </a:rPr>
+              <a:t>•  19 Run it yourself</a:t>
+            </a:r>
+          </a:p>
+          <a:p>
+            <a:pPr>
+              <a:spcAft>
+                <a:spcPts val="600"/>
+              </a:spcAft>
+            </a:pPr>
+            <a:r>
+              <a:rPr sz="1200" b="0">
+                <a:solidFill>
+                  <a:srgbClr val="282828"/>
+                </a:solidFill>
+                <a:latin typeface="Arial"/>
+              </a:rPr>
+              <a:t>•  20 Backup</a:t>
+            </a:r>
+          </a:p>
+        </p:txBody>
+      </p:sp>
+    </p:spTree>
+  </p:cSld>
+  <p:clrMapOvr>
+    <a:masterClrMapping/>
+  </p:clrMapOvr>
+</p:sld>
+</file>
+
+<file path=ppt/slides/slide20.xml><?xml version="1.0" encoding="utf-8"?>
+<p:sld xmlns:a="http://schemas.openxmlformats.org/drawingml/2006/main" xmlns:p="http://schemas.openxmlformats.org/presentationml/2006/main" xmlns:r="http://schemas.openxmlformats.org/officeDocument/2006/relationships">
+  <p:cSld>
+    <p:spTree>
+      <p:nvGrpSpPr>
+        <p:cNvPr id="1" name=""/>
+        <p:cNvGrpSpPr/>
+        <p:nvPr/>
+      </p:nvGrpSpPr>
+      <p:grpSpPr/>
+      <p:sp>
+        <p:nvSpPr>
+          <p:cNvPr id="2" name="TextBox 1"/>
+          <p:cNvSpPr txBox="1"/>
+          <p:nvPr/>
+        </p:nvSpPr>
+        <p:spPr>
+          <a:xfrm>
+            <a:off x="411480" y="201168"/>
+            <a:ext cx="11368735" cy="914400"/>
+          </a:xfrm>
+          <a:prstGeom prst="rect">
+            <a:avLst/>
+          </a:prstGeom>
+          <a:noFill/>
+        </p:spPr>
+        <p:txBody>
+          <a:bodyPr wrap="square">
+            <a:spAutoFit/>
+          </a:bodyPr>
+          <a:lstStyle/>
+          <a:p>
+            <a:pPr>
+              <a:spcAft>
+                <a:spcPts val="400"/>
+              </a:spcAft>
+            </a:pPr>
+            <a:r>
+              <a:rPr sz="2400" b="1">
+                <a:solidFill>
+                  <a:srgbClr val="1F4E79"/>
+                </a:solidFill>
+                <a:latin typeface="Arial"/>
+              </a:rPr>
+              <a:t>Backup</a:t>
+            </a:r>
+          </a:p>
+        </p:txBody>
+      </p:sp>
+      <p:sp>
+        <p:nvSpPr>
+          <p:cNvPr id="3" name="Rectangle 2"/>
+          <p:cNvSpPr/>
+          <p:nvPr/>
+        </p:nvSpPr>
+        <p:spPr>
+          <a:xfrm>
+            <a:off x="411480" y="914400"/>
+            <a:ext cx="11368735" cy="20320"/>
+          </a:xfrm>
+          <a:prstGeom prst="rect">
+            <a:avLst/>
+          </a:prstGeom>
+          <a:solidFill>
+            <a:srgbClr val="B8C6D4"/>
+          </a:solidFill>
+          <a:ln>
+            <a:noFill/>
+          </a:ln>
+          <a:effectLst/>
+        </p:spPr>
+        <p:style>
+          <a:lnRef idx="1">
+            <a:schemeClr val="accent1"/>
+          </a:lnRef>
+          <a:fillRef idx="3">
+            <a:schemeClr val="accent1"/>
+          </a:fillRef>
+          <a:effectRef idx="2">
+            <a:schemeClr val="accent1"/>
+          </a:effectRef>
+          <a:fontRef idx="minor">
+            <a:schemeClr val="lt1"/>
+          </a:fontRef>
+        </p:style>
+        <p:txBody>
+          <a:bodyPr rtlCol="0" anchor="ctr"/>
+          <a:lstStyle/>
+          <a:p>
+            <a:pPr algn="ctr"/>
+          </a:p>
+        </p:txBody>
+      </p:sp>
+      <p:sp>
+        <p:nvSpPr>
+          <p:cNvPr id="4" name="TextBox 3"/>
+          <p:cNvSpPr txBox="1"/>
+          <p:nvPr/>
+        </p:nvSpPr>
+        <p:spPr>
+          <a:xfrm>
+            <a:off x="411480" y="1078992"/>
+            <a:ext cx="11368735" cy="274320"/>
+          </a:xfrm>
+          <a:prstGeom prst="rect">
+            <a:avLst/>
+          </a:prstGeom>
+          <a:noFill/>
+        </p:spPr>
+        <p:txBody>
+          <a:bodyPr wrap="square">
+            <a:spAutoFit/>
+          </a:bodyPr>
+          <a:lstStyle/>
+          <a:p>
+            <a:pPr>
+              <a:spcAft>
+                <a:spcPts val="600"/>
+              </a:spcAft>
+            </a:pPr>
+            <a:r>
+              <a:rPr sz="1500" b="0">
+                <a:solidFill>
+                  <a:srgbClr val="282828"/>
+                </a:solidFill>
+                <a:latin typeface="Arial"/>
+              </a:rPr>
+              <a:t>Diagnostics, the engine findings, and the conventions behind the main path.</a:t>
+            </a:r>
+          </a:p>
+        </p:txBody>
+      </p:sp>
+    </p:spTree>
+  </p:cSld>
+  <p:clrMapOvr>
+    <a:masterClrMapping/>
+  </p:clrMapOvr>
+</p:sld>
+</file>
+
+<file path=ppt/slides/slide21.xml><?xml version="1.0" encoding="utf-8"?>
 <p:sld xmlns:a="http://schemas.openxmlformats.org/drawingml/2006/main" xmlns:p="http://schemas.openxmlformats.org/presentationml/2006/main" xmlns:r="http://schemas.openxmlformats.org/officeDocument/2006/relationships">
   <p:cSld>
     <p:spTree>
@@ -5704,7 +8323,7 @@
 </p:sld>
 </file>
 
-<file path=ppt/slides/slide16.xml><?xml version="1.0" encoding="utf-8"?>
+<file path=ppt/slides/slide22.xml><?xml version="1.0" encoding="utf-8"?>
 <p:sld xmlns:a="http://schemas.openxmlformats.org/drawingml/2006/main" xmlns:p="http://schemas.openxmlformats.org/presentationml/2006/main" xmlns:r="http://schemas.openxmlformats.org/officeDocument/2006/relationships">
   <p:cSld>
     <p:spTree>
@@ -5823,7 +8442,7 @@
         </p:nvGraphicFramePr>
         <p:xfrm>
           <a:off x="411480" y="1298448"/>
-          <a:ext cx="11368735" cy="2337435"/>
+          <a:ext cx="11368735" cy="2806065"/>
         </p:xfrm>
         <a:graphic>
           <a:graphicData uri="http://schemas.openxmlformats.org/drawingml/2006/table">
@@ -5832,10 +8451,10 @@
                 <a:tableStyleId>{5C22544A-7EE6-4342-B048-85BDC9FD1C3A}</a:tableStyleId>
               </a:tblPr>
               <a:tblGrid>
-                <a:gridCol w="1744472"/>
+                <a:gridCol w="2107692"/>
                 <a:gridCol w="1817116"/>
-                <a:gridCol w="3733853"/>
-                <a:gridCol w="4073294"/>
+                <a:gridCol w="4634898"/>
+                <a:gridCol w="2809029"/>
               </a:tblGrid>
               <a:tr h="280035">
                 <a:tc>
@@ -5927,7 +8546,7 @@
                   </a:tcPr>
                 </a:tc>
               </a:tr>
-              <a:tr h="280035">
+              <a:tr h="468630">
                 <a:tc>
                   <a:txBody>
                     <a:bodyPr wrap="square"/>
@@ -6390,7 +9009,7 @@
                           </a:solidFill>
                           <a:latin typeface="Arial"/>
                         </a:rPr>
-                        <a:t>departure ladder</a:t>
+                        <a:t>departure ladder, R4, trade</a:t>
                       </a:r>
                     </a:p>
                   </a:txBody>
@@ -6412,7 +9031,7 @@
                           </a:solidFill>
                           <a:latin typeface="Arial"/>
                         </a:rPr>
-                        <a:t>s3, s3free</a:t>
+                        <a:t>s3, s3free, s3b</a:t>
                       </a:r>
                     </a:p>
                   </a:txBody>
@@ -6434,7 +9053,7 @@
                           </a:solidFill>
                           <a:latin typeface="Arial"/>
                         </a:rPr>
-                        <a:t>dyson5_s3.txt, dyson5_s3free.txt, dyson5_s3*_ladder.png</a:t>
+                        <a:t>dyson5_s3.txt, dyson5_s3free.txt, dyson5_s3_trade.txt, dyson5_s3_layout_r.png, dyson5_s3_maps_r.png</a:t>
                       </a:r>
                     </a:p>
                   </a:txBody>
@@ -6456,13 +9075,103 @@
                           </a:solidFill>
                           <a:latin typeface="Arial"/>
                         </a:rPr>
-                        <a:t>dyson_ladder.m</a:t>
+                        <a:t>dyson_ladder.m, dyson5_trade.m</a:t>
                       </a:r>
                     </a:p>
                   </a:txBody>
                   <a:tcPr marL="54864" marR="54864" marT="18288" marB="18288">
                     <a:solidFill>
                       <a:srgbClr val="ECF1F6"/>
+                    </a:solidFill>
+                  </a:tcPr>
+                </a:tc>
+              </a:tr>
+              <a:tr h="280035">
+                <a:tc>
+                  <a:txBody>
+                    <a:bodyPr wrap="square"/>
+                    <a:lstStyle/>
+                    <a:p>
+                      <a:r>
+                        <a:rPr sz="1100" b="0">
+                          <a:solidFill>
+                            <a:srgbClr val="282828"/>
+                          </a:solidFill>
+                          <a:latin typeface="Arial"/>
+                        </a:rPr>
+                        <a:t>slit loss</a:t>
+                      </a:r>
+                    </a:p>
+                  </a:txBody>
+                  <a:tcPr marL="54864" marR="54864" marT="18288" marB="18288">
+                    <a:solidFill>
+                      <a:srgbClr val="FFFFFF"/>
+                    </a:solidFill>
+                  </a:tcPr>
+                </a:tc>
+                <a:tc>
+                  <a:txBody>
+                    <a:bodyPr wrap="square"/>
+                    <a:lstStyle/>
+                    <a:p>
+                      <a:r>
+                        <a:rPr sz="1100" b="0">
+                          <a:solidFill>
+                            <a:srgbClr val="282828"/>
+                          </a:solidFill>
+                          <a:latin typeface="Arial"/>
+                        </a:rPr>
+                        <a:t>s2l</a:t>
+                      </a:r>
+                    </a:p>
+                  </a:txBody>
+                  <a:tcPr marL="54864" marR="54864" marT="18288" marB="18288">
+                    <a:solidFill>
+                      <a:srgbClr val="FFFFFF"/>
+                    </a:solidFill>
+                  </a:tcPr>
+                </a:tc>
+                <a:tc>
+                  <a:txBody>
+                    <a:bodyPr wrap="square"/>
+                    <a:lstStyle/>
+                    <a:p>
+                      <a:r>
+                        <a:rPr sz="1100" b="0">
+                          <a:solidFill>
+                            <a:srgbClr val="282828"/>
+                          </a:solidFill>
+                          <a:latin typeface="Arial"/>
+                        </a:rPr>
+                        <a:t>dyson5_s2l.txt, dyson5_s2l_slitloss.png</a:t>
+                      </a:r>
+                    </a:p>
+                  </a:txBody>
+                  <a:tcPr marL="54864" marR="54864" marT="18288" marB="18288">
+                    <a:solidFill>
+                      <a:srgbClr val="FFFFFF"/>
+                    </a:solidFill>
+                  </a:tcPr>
+                </a:tc>
+                <a:tc>
+                  <a:txBody>
+                    <a:bodyPr wrap="square"/>
+                    <a:lstStyle/>
+                    <a:p>
+                      <a:r>
+                        <a:rPr sz="1100" b="0">
+                          <a:solidFill>
+                            <a:srgbClr val="282828"/>
+                          </a:solidFill>
+                          <a:latin typeface="Arial"/>
+                        </a:rPr>
+                        <a:t>far-field leg vs sinc²</a:t>
+                      </a:r>
+                    </a:p>
+                  </a:txBody>
+                  <a:tcPr marL="54864" marR="54864" marT="18288" marB="18288">
+                    <a:solidFill>
+                      <a:srgbClr val="FFFFFF"/>
                     </a:solidFill>
                   </a:tcPr>
                 </a:tc>
@@ -6479,7 +9188,7 @@
         </p:nvSpPr>
         <p:spPr>
           <a:xfrm>
-            <a:off x="411480" y="3782187"/>
+            <a:off x="411480" y="4250817"/>
             <a:ext cx="11368735" cy="274320"/>
           </a:xfrm>
           <a:prstGeom prst="rect">
@@ -6518,7 +9227,7 @@
 </p:sld>
 </file>
 
-<file path=ppt/slides/slide17.xml><?xml version="1.0" encoding="utf-8"?>
+<file path=ppt/slides/slide23.xml><?xml version="1.0" encoding="utf-8"?>
 <p:sld xmlns:a="http://schemas.openxmlformats.org/drawingml/2006/main" xmlns:p="http://schemas.openxmlformats.org/presentationml/2006/main" xmlns:r="http://schemas.openxmlformats.org/officeDocument/2006/relationships">
   <p:cSld>
     <p:spTree>
@@ -6804,361 +9513,6 @@
                 <a:latin typeface="Arial"/>
               </a:rPr>
               <a:t>Reference document: optical_design/SPECTROMETER_DESIGN_REFERENCE.md (forms, conditions, metrics, references).</a:t>
-            </a:r>
-          </a:p>
-        </p:txBody>
-      </p:sp>
-    </p:spTree>
-  </p:cSld>
-  <p:clrMapOvr>
-    <a:masterClrMapping/>
-  </p:clrMapOvr>
-</p:sld>
-</file>
-
-<file path=ppt/slides/slide2.xml><?xml version="1.0" encoding="utf-8"?>
-<p:sld xmlns:a="http://schemas.openxmlformats.org/drawingml/2006/main" xmlns:p="http://schemas.openxmlformats.org/presentationml/2006/main" xmlns:r="http://schemas.openxmlformats.org/officeDocument/2006/relationships">
-  <p:cSld>
-    <p:spTree>
-      <p:nvGrpSpPr>
-        <p:cNvPr id="1" name=""/>
-        <p:cNvGrpSpPr/>
-        <p:nvPr/>
-      </p:nvGrpSpPr>
-      <p:grpSpPr/>
-      <p:sp>
-        <p:nvSpPr>
-          <p:cNvPr id="2" name="TextBox 1"/>
-          <p:cNvSpPr txBox="1"/>
-          <p:nvPr/>
-        </p:nvSpPr>
-        <p:spPr>
-          <a:xfrm>
-            <a:off x="411480" y="201168"/>
-            <a:ext cx="11368735" cy="914400"/>
-          </a:xfrm>
-          <a:prstGeom prst="rect">
-            <a:avLst/>
-          </a:prstGeom>
-          <a:noFill/>
-        </p:spPr>
-        <p:txBody>
-          <a:bodyPr wrap="square">
-            <a:spAutoFit/>
-          </a:bodyPr>
-          <a:lstStyle/>
-          <a:p>
-            <a:pPr>
-              <a:spcAft>
-                <a:spcPts val="400"/>
-              </a:spcAft>
-            </a:pPr>
-            <a:r>
-              <a:rPr sz="2400" b="1">
-                <a:solidFill>
-                  <a:srgbClr val="1F4E79"/>
-                </a:solidFill>
-                <a:latin typeface="Arial"/>
-              </a:rPr>
-              <a:t>Contents</a:t>
-            </a:r>
-          </a:p>
-          <a:p>
-            <a:pPr>
-              <a:spcAft>
-                <a:spcPts val="0"/>
-              </a:spcAft>
-            </a:pPr>
-            <a:r>
-              <a:rPr sz="1250" b="0">
-                <a:solidFill>
-                  <a:srgbClr val="6E6E6E"/>
-                </a:solidFill>
-                <a:latin typeface="Arial"/>
-              </a:rPr>
-              <a:t>The target, the forms, the design ladder, the evidence</a:t>
-            </a:r>
-          </a:p>
-        </p:txBody>
-      </p:sp>
-      <p:sp>
-        <p:nvSpPr>
-          <p:cNvPr id="3" name="Rectangle 2"/>
-          <p:cNvSpPr/>
-          <p:nvPr/>
-        </p:nvSpPr>
-        <p:spPr>
-          <a:xfrm>
-            <a:off x="411480" y="1133856"/>
-            <a:ext cx="11368735" cy="20320"/>
-          </a:xfrm>
-          <a:prstGeom prst="rect">
-            <a:avLst/>
-          </a:prstGeom>
-          <a:solidFill>
-            <a:srgbClr val="B8C6D4"/>
-          </a:solidFill>
-          <a:ln>
-            <a:noFill/>
-          </a:ln>
-          <a:effectLst/>
-        </p:spPr>
-        <p:style>
-          <a:lnRef idx="1">
-            <a:schemeClr val="accent1"/>
-          </a:lnRef>
-          <a:fillRef idx="3">
-            <a:schemeClr val="accent1"/>
-          </a:fillRef>
-          <a:effectRef idx="2">
-            <a:schemeClr val="accent1"/>
-          </a:effectRef>
-          <a:fontRef idx="minor">
-            <a:schemeClr val="lt1"/>
-          </a:fontRef>
-        </p:style>
-        <p:txBody>
-          <a:bodyPr rtlCol="0" anchor="ctr"/>
-          <a:lstStyle/>
-          <a:p>
-            <a:pPr algn="ctr"/>
-          </a:p>
-        </p:txBody>
-      </p:sp>
-      <p:sp>
-        <p:nvSpPr>
-          <p:cNvPr id="4" name="TextBox 3"/>
-          <p:cNvSpPr txBox="1"/>
-          <p:nvPr/>
-        </p:nvSpPr>
-        <p:spPr>
-          <a:xfrm>
-            <a:off x="411480" y="1298448"/>
-            <a:ext cx="5806440" cy="274320"/>
-          </a:xfrm>
-          <a:prstGeom prst="rect">
-            <a:avLst/>
-          </a:prstGeom>
-          <a:noFill/>
-        </p:spPr>
-        <p:txBody>
-          <a:bodyPr wrap="square">
-            <a:spAutoFit/>
-          </a:bodyPr>
-          <a:lstStyle/>
-          <a:p>
-            <a:pPr>
-              <a:spcAft>
-                <a:spcPts val="600"/>
-              </a:spcAft>
-            </a:pPr>
-            <a:r>
-              <a:rPr sz="1200" b="0">
-                <a:solidFill>
-                  <a:srgbClr val="282828"/>
-                </a:solidFill>
-                <a:latin typeface="Arial"/>
-              </a:rPr>
-              <a:t>•  3 The target and how it is scored</a:t>
-            </a:r>
-          </a:p>
-          <a:p>
-            <a:pPr>
-              <a:spcAft>
-                <a:spcPts val="600"/>
-              </a:spcAft>
-            </a:pPr>
-            <a:r>
-              <a:rPr sz="1200" b="0">
-                <a:solidFill>
-                  <a:srgbClr val="282828"/>
-                </a:solidFill>
-                <a:latin typeface="Arial"/>
-              </a:rPr>
-              <a:t>•  4 The Dyson as traced by the engine</a:t>
-            </a:r>
-          </a:p>
-          <a:p>
-            <a:pPr>
-              <a:spcAft>
-                <a:spcPts val="600"/>
-              </a:spcAft>
-            </a:pPr>
-            <a:r>
-              <a:rPr sz="1200" b="0">
-                <a:solidFill>
-                  <a:srgbClr val="282828"/>
-                </a:solidFill>
-                <a:latin typeface="Arial"/>
-              </a:rPr>
-              <a:t>•  5 The Offner as traced by the engine</a:t>
-            </a:r>
-          </a:p>
-          <a:p>
-            <a:pPr>
-              <a:spcAft>
-                <a:spcPts val="600"/>
-              </a:spcAft>
-            </a:pPr>
-            <a:r>
-              <a:rPr sz="1200" b="0">
-                <a:solidFill>
-                  <a:srgbClr val="282828"/>
-                </a:solidFill>
-                <a:latin typeface="Arial"/>
-              </a:rPr>
-              <a:t>•  6 The concentric Dyson and its scaling law</a:t>
-            </a:r>
-          </a:p>
-          <a:p>
-            <a:pPr>
-              <a:spcAft>
-                <a:spcPts val="600"/>
-              </a:spcAft>
-            </a:pPr>
-            <a:r>
-              <a:rPr sz="1200" b="0">
-                <a:solidFill>
-                  <a:srgbClr val="282828"/>
-                </a:solidFill>
-                <a:latin typeface="Arial"/>
-              </a:rPr>
-              <a:t>•  7 The exact chain and the engine agree</a:t>
-            </a:r>
-          </a:p>
-          <a:p>
-            <a:pPr>
-              <a:spcAft>
-                <a:spcPts val="600"/>
-              </a:spcAft>
-            </a:pPr>
-            <a:r>
-              <a:rPr sz="1200" b="0">
-                <a:solidFill>
-                  <a:srgbClr val="282828"/>
-                </a:solidFill>
-                <a:latin typeface="Arial"/>
-              </a:rPr>
-              <a:t>•  8 The seed, scored</a:t>
-            </a:r>
-          </a:p>
-          <a:p>
-            <a:pPr>
-              <a:spcAft>
-                <a:spcPts val="600"/>
-              </a:spcAft>
-            </a:pPr>
-            <a:r>
-              <a:rPr sz="1200" b="0">
-                <a:solidFill>
-                  <a:srgbClr val="282828"/>
-                </a:solidFill>
-                <a:latin typeface="Arial"/>
-              </a:rPr>
-              <a:t>•  9 The departure ladder</a:t>
-            </a:r>
-          </a:p>
-        </p:txBody>
-      </p:sp>
-      <p:sp>
-        <p:nvSpPr>
-          <p:cNvPr id="5" name="TextBox 4"/>
-          <p:cNvSpPr txBox="1"/>
-          <p:nvPr/>
-        </p:nvSpPr>
-        <p:spPr>
-          <a:xfrm>
-            <a:off x="6400800" y="1298448"/>
-            <a:ext cx="5394960" cy="274320"/>
-          </a:xfrm>
-          <a:prstGeom prst="rect">
-            <a:avLst/>
-          </a:prstGeom>
-          <a:noFill/>
-        </p:spPr>
-        <p:txBody>
-          <a:bodyPr wrap="square">
-            <a:spAutoFit/>
-          </a:bodyPr>
-          <a:lstStyle/>
-          <a:p>
-            <a:pPr>
-              <a:spcAft>
-                <a:spcPts val="600"/>
-              </a:spcAft>
-            </a:pPr>
-            <a:r>
-              <a:rPr sz="1200" b="0">
-                <a:solidFill>
-                  <a:srgbClr val="282828"/>
-                </a:solidFill>
-                <a:latin typeface="Arial"/>
-              </a:rPr>
-              <a:t>•  10 The departure ladder, by the numbers</a:t>
-            </a:r>
-          </a:p>
-          <a:p>
-            <a:pPr>
-              <a:spcAft>
-                <a:spcPts val="600"/>
-              </a:spcAft>
-            </a:pPr>
-            <a:r>
-              <a:rPr sz="1200" b="0">
-                <a:solidFill>
-                  <a:srgbClr val="282828"/>
-                </a:solidFill>
-                <a:latin typeface="Arial"/>
-              </a:rPr>
-              <a:t>•  11 What each departure buys</a:t>
-            </a:r>
-          </a:p>
-          <a:p>
-            <a:pPr>
-              <a:spcAft>
-                <a:spcPts val="600"/>
-              </a:spcAft>
-            </a:pPr>
-            <a:r>
-              <a:rPr sz="1200" b="0">
-                <a:solidFill>
-                  <a:srgbClr val="282828"/>
-                </a:solidFill>
-                <a:latin typeface="Arial"/>
-              </a:rPr>
-              <a:t>•  12 Next: the compact variant</a:t>
-            </a:r>
-          </a:p>
-          <a:p>
-            <a:pPr>
-              <a:spcAft>
-                <a:spcPts val="600"/>
-              </a:spcAft>
-            </a:pPr>
-            <a:r>
-              <a:rPr sz="1200" b="0">
-                <a:solidFill>
-                  <a:srgbClr val="282828"/>
-                </a:solidFill>
-                <a:latin typeface="Arial"/>
-              </a:rPr>
-              <a:t>•  13 Run it yourself</a:t>
-            </a:r>
-          </a:p>
-          <a:p>
-            <a:pPr>
-              <a:spcAft>
-                <a:spcPts val="600"/>
-              </a:spcAft>
-            </a:pPr>
-            <a:r>
-              <a:rPr sz="1200" b="0">
-                <a:solidFill>
-                  <a:srgbClr val="282828"/>
-                </a:solidFill>
-                <a:latin typeface="Arial"/>
-              </a:rPr>
-              <a:t>•  14 Backup</a:t>
             </a:r>
           </a:p>
         </p:txBody>
@@ -9016,7 +11370,7 @@
                 </a:solidFill>
                 <a:latin typeface="Arial"/>
               </a:rPr>
-              <a:t>•  These maps predate the grating fixes of 2026-10-01: the SRF ramp with wavelength is the groove-period defect, not the design; the re-scored maps replace this figure.</a:t>
+              <a:t>•  SRF sits at 2.02 pixels on both forms, the floor set by the 2-pixel slit; re-scored on the engine after the grating fixes (the earlier ramp with wavelength was the groove-period defect, not the design).</a:t>
             </a:r>
           </a:p>
         </p:txBody>

</xml_diff>

<commit_message>
deck_dyson: recomposed panel figures in place (maps and twin in two rows; margins trimmed)
Co-Authored-By: Claude Fable 5.1 <noreply@anthropic.com>
</commit_message>
<xml_diff>
--- a/demo_session/deck_dyson.pptx
+++ b/demo_session/deck_dyson.pptx
@@ -5670,7 +5670,7 @@
       </p:sp>
       <p:pic>
         <p:nvPicPr>
-          <p:cNvPr id="4" name="Picture 3" descr="dyson5_s3_layout_r4.png"/>
+          <p:cNvPr id="4" name="Picture 3" descr="dyson5_s3_layout_r4_rc.png"/>
           <p:cNvPicPr>
             <a:picLocks noChangeAspect="1"/>
           </p:cNvPicPr>
@@ -5684,8 +5684,8 @@
         </p:blipFill>
         <p:spPr>
           <a:xfrm>
-            <a:off x="518592" y="1298448"/>
-            <a:ext cx="11154510" cy="5000752"/>
+            <a:off x="411480" y="1298448"/>
+            <a:ext cx="11368735" cy="2895237"/>
           </a:xfrm>
           <a:prstGeom prst="rect">
             <a:avLst/>
@@ -5700,7 +5700,7 @@
         </p:nvSpPr>
         <p:spPr>
           <a:xfrm>
-            <a:off x="411480" y="6317488"/>
+            <a:off x="411480" y="4211973"/>
             <a:ext cx="11368735" cy="394208"/>
           </a:xfrm>
           <a:prstGeom prst="rect">
@@ -5739,7 +5739,7 @@
         </p:nvSpPr>
         <p:spPr>
           <a:xfrm>
-            <a:off x="411480" y="6748272"/>
+            <a:off x="411480" y="4642757"/>
             <a:ext cx="11368735" cy="274320"/>
           </a:xfrm>
           <a:prstGeom prst="rect">
@@ -5905,7 +5905,7 @@
       </p:sp>
       <p:pic>
         <p:nvPicPr>
-          <p:cNvPr id="4" name="Picture 3" descr="dyson5_s3_maps_r4.png"/>
+          <p:cNvPr id="4" name="Picture 3" descr="dyson5_s3_maps_r4_rc.png"/>
           <p:cNvPicPr>
             <a:picLocks noChangeAspect="1"/>
           </p:cNvPicPr>
@@ -5919,8 +5919,8 @@
         </p:blipFill>
         <p:spPr>
           <a:xfrm>
-            <a:off x="411480" y="1298448"/>
-            <a:ext cx="11368735" cy="2277103"/>
+            <a:off x="3574281" y="1298448"/>
+            <a:ext cx="5043131" cy="5000752"/>
           </a:xfrm>
           <a:prstGeom prst="rect">
             <a:avLst/>
@@ -5935,7 +5935,7 @@
         </p:nvSpPr>
         <p:spPr>
           <a:xfrm>
-            <a:off x="411480" y="3593839"/>
+            <a:off x="411480" y="6317488"/>
             <a:ext cx="11368735" cy="394208"/>
           </a:xfrm>
           <a:prstGeom prst="rect">
@@ -6085,7 +6085,7 @@
       </p:sp>
       <p:pic>
         <p:nvPicPr>
-          <p:cNvPr id="4" name="Picture 3" descr="dyson5_s3_trade.png"/>
+          <p:cNvPr id="4" name="Picture 3" descr="dyson5_s3_trade_rc.png"/>
           <p:cNvPicPr>
             <a:picLocks noChangeAspect="1"/>
           </p:cNvPicPr>
@@ -6100,7 +6100,7 @@
         <p:spPr>
           <a:xfrm>
             <a:off x="411480" y="1298448"/>
-            <a:ext cx="11368735" cy="3791910"/>
+            <a:ext cx="11368735" cy="4538913"/>
           </a:xfrm>
           <a:prstGeom prst="rect">
             <a:avLst/>
@@ -6115,7 +6115,7 @@
         </p:nvSpPr>
         <p:spPr>
           <a:xfrm>
-            <a:off x="411480" y="5108646"/>
+            <a:off x="411480" y="5855649"/>
             <a:ext cx="11368735" cy="394208"/>
           </a:xfrm>
           <a:prstGeom prst="rect">
@@ -6265,7 +6265,7 @@
       </p:sp>
       <p:pic>
         <p:nvPicPr>
-          <p:cNvPr id="4" name="Picture 3" descr="dyson5_s2w_twin.png"/>
+          <p:cNvPr id="4" name="Picture 3" descr="dyson5_s2w_twin_rc.png"/>
           <p:cNvPicPr>
             <a:picLocks noChangeAspect="1"/>
           </p:cNvPicPr>
@@ -6279,8 +6279,8 @@
         </p:blipFill>
         <p:spPr>
           <a:xfrm>
-            <a:off x="411480" y="1298448"/>
-            <a:ext cx="11368735" cy="3183469"/>
+            <a:off x="4116751" y="1298448"/>
+            <a:ext cx="3958192" cy="5000752"/>
           </a:xfrm>
           <a:prstGeom prst="rect">
             <a:avLst/>
@@ -6295,7 +6295,7 @@
         </p:nvSpPr>
         <p:spPr>
           <a:xfrm>
-            <a:off x="411480" y="4500205"/>
+            <a:off x="411480" y="6317487"/>
             <a:ext cx="11368735" cy="394208"/>
           </a:xfrm>
           <a:prstGeom prst="rect">
@@ -6334,7 +6334,7 @@
         </p:nvSpPr>
         <p:spPr>
           <a:xfrm>
-            <a:off x="411480" y="4930989"/>
+            <a:off x="411480" y="6748271"/>
             <a:ext cx="11368735" cy="274320"/>
           </a:xfrm>
           <a:prstGeom prst="rect">
@@ -11377,7 +11377,7 @@
       </p:sp>
       <p:pic>
         <p:nvPicPr>
-          <p:cNvPr id="5" name="Picture 4" descr="dyson5_s2_maps.png"/>
+          <p:cNvPr id="5" name="Picture 4" descr="dyson5_s2_maps_rc.png"/>
           <p:cNvPicPr>
             <a:picLocks noChangeAspect="1"/>
           </p:cNvPicPr>
@@ -11391,8 +11391,8 @@
         </p:blipFill>
         <p:spPr>
           <a:xfrm>
-            <a:off x="2724763" y="2358390"/>
-            <a:ext cx="6742168" cy="3940810"/>
+            <a:off x="3084371" y="2358390"/>
+            <a:ext cx="6022953" cy="3940810"/>
           </a:xfrm>
           <a:prstGeom prst="rect">
             <a:avLst/>

</xml_diff>

<commit_message>
deck_dyson: split strips drop their super-title (the caption carries it); twin bullet above its figure
Co-Authored-By: Claude Fable 5.1 <noreply@anthropic.com>
</commit_message>
<xml_diff>
--- a/demo_session/deck_dyson.pptx
+++ b/demo_session/deck_dyson.pptx
@@ -5919,8 +5919,8 @@
         </p:blipFill>
         <p:spPr>
           <a:xfrm>
-            <a:off x="3574281" y="1298448"/>
-            <a:ext cx="5043131" cy="5000752"/>
+            <a:off x="3317652" y="1298448"/>
+            <a:ext cx="5556391" cy="5000752"/>
           </a:xfrm>
           <a:prstGeom prst="rect">
             <a:avLst/>
@@ -6263,9 +6263,48 @@
           </a:p>
         </p:txBody>
       </p:sp>
+      <p:sp>
+        <p:nvSpPr>
+          <p:cNvPr id="4" name="TextBox 3"/>
+          <p:cNvSpPr txBox="1"/>
+          <p:nvPr/>
+        </p:nvSpPr>
+        <p:spPr>
+          <a:xfrm>
+            <a:off x="411480" y="1298448"/>
+            <a:ext cx="11368735" cy="274320"/>
+          </a:xfrm>
+          <a:prstGeom prst="rect">
+            <a:avLst/>
+          </a:prstGeom>
+          <a:noFill/>
+        </p:spPr>
+        <p:txBody>
+          <a:bodyPr wrap="square">
+            <a:spAutoFit/>
+          </a:bodyPr>
+          <a:lstStyle/>
+          <a:p>
+            <a:pPr>
+              <a:spcAft>
+                <a:spcPts val="600"/>
+              </a:spcAft>
+            </a:pPr>
+            <a:r>
+              <a:rPr sz="1500" b="0">
+                <a:solidFill>
+                  <a:srgbClr val="282828"/>
+                </a:solidFill>
+                <a:latin typeface="Arial"/>
+              </a:rPr>
+              <a:t>•  What it checks: the ray-side scorer's centroids and response functions against physical-optics propagation through the same decks; across a grating the comparison is made in phase (modulo λ), never as unwrapped lengths.</a:t>
+            </a:r>
+          </a:p>
+        </p:txBody>
+      </p:sp>
       <p:pic>
         <p:nvPicPr>
-          <p:cNvPr id="4" name="Picture 3" descr="dyson5_s2w_twin_rc.png"/>
+          <p:cNvPr id="5" name="Picture 4" descr="dyson5_s2w_twin_rc.png"/>
           <p:cNvPicPr>
             <a:picLocks noChangeAspect="1"/>
           </p:cNvPicPr>
@@ -6279,8 +6318,8 @@
         </p:blipFill>
         <p:spPr>
           <a:xfrm>
-            <a:off x="4116751" y="1298448"/>
-            <a:ext cx="3958192" cy="5000752"/>
+            <a:off x="4382735" y="1970531"/>
+            <a:ext cx="3426224" cy="4328668"/>
           </a:xfrm>
           <a:prstGeom prst="rect">
             <a:avLst/>
@@ -6289,13 +6328,13 @@
       </p:pic>
       <p:sp>
         <p:nvSpPr>
-          <p:cNvPr id="5" name="TextBox 4"/>
+          <p:cNvPr id="6" name="TextBox 5"/>
           <p:cNvSpPr txBox="1"/>
           <p:nvPr/>
         </p:nvSpPr>
         <p:spPr>
           <a:xfrm>
-            <a:off x="411480" y="6317487"/>
+            <a:off x="411480" y="6317488"/>
             <a:ext cx="11368735" cy="394208"/>
           </a:xfrm>
           <a:prstGeom prst="rect">
@@ -6322,45 +6361,6 @@
                 <a:latin typeface="Arial"/>
               </a:rPr>
               <a:t>Left: the Offner at order 0, PSF (log scale) with the 18 µm pixel box, 85 % ensquared.  Middle: wave-minus-ray centroid over the slit and band, Offner and Dyson seeds.  Right: SRF and CRF from the propagated PSF at the slit centre.</a:t>
-            </a:r>
-          </a:p>
-        </p:txBody>
-      </p:sp>
-      <p:sp>
-        <p:nvSpPr>
-          <p:cNvPr id="6" name="TextBox 5"/>
-          <p:cNvSpPr txBox="1"/>
-          <p:nvPr/>
-        </p:nvSpPr>
-        <p:spPr>
-          <a:xfrm>
-            <a:off x="411480" y="6748271"/>
-            <a:ext cx="11368735" cy="274320"/>
-          </a:xfrm>
-          <a:prstGeom prst="rect">
-            <a:avLst/>
-          </a:prstGeom>
-          <a:noFill/>
-        </p:spPr>
-        <p:txBody>
-          <a:bodyPr wrap="square">
-            <a:spAutoFit/>
-          </a:bodyPr>
-          <a:lstStyle/>
-          <a:p>
-            <a:pPr>
-              <a:spcAft>
-                <a:spcPts val="600"/>
-              </a:spcAft>
-            </a:pPr>
-            <a:r>
-              <a:rPr sz="1500" b="0">
-                <a:solidFill>
-                  <a:srgbClr val="282828"/>
-                </a:solidFill>
-                <a:latin typeface="Arial"/>
-              </a:rPr>
-              <a:t>•  What it checks: the ray-side scorer's centroids and response functions against physical-optics propagation through the same decks; across a grating the comparison is made in phase (modulo λ), never as unwrapped lengths.</a:t>
             </a:r>
           </a:p>
         </p:txBody>

</xml_diff>

<commit_message>
deck_dyson: apertures and clearance numbers, the Offner re-posed at 0.22 R as a real two-zone layout, the twin pair on R4 (0.75 / 0.76), and the open wave-vs-ray centroid finding stated on the title, the R4 slide and next steps
Co-Authored-By: Claude Fable 5.1 <noreply@anthropic.com>
</commit_message>
<xml_diff>
--- a/demo_session/deck_dyson.pptx
+++ b/demo_session/deck_dyson.pptx
@@ -3208,7 +3208,7 @@
                 </a:solidFill>
                 <a:latin typeface="Arial"/>
               </a:rPr>
-              <a:t>DRAFT — in progress.  Every number is from a committed, parameterized runner (mmacos, dyson5_run); records and figures are the runner's own output.  Design of record: the compact variant (step R4): keystone 0.0026 px, smile 0.005 px, CRF 1.33 px, 76 % of the energy in one pixel, at a 220 mm block.</a:t>
+              <a:t>DRAFT — in progress.  Every number is from a committed, parameterized runner (mmacos, dyson5_run); records and figures are the runner's own output.  Design of record: the compact variant (step R4): ray-centroid keystone 0.0026 px, smile 0.005 px, CRF 1.33 px, 76 % of the energy in one pixel, at a 220 mm block.  Open: the propagated-PSF centroid differs from the ray centroid by up to 0.12 px on R4, the detector-seen keystone until it is resolved.</a:t>
             </a:r>
           </a:p>
         </p:txBody>
@@ -5483,7 +5483,7 @@
                 </a:solidFill>
                 <a:latin typeface="Arial"/>
               </a:rPr>
-              <a:t>•  Bodies, rays and labels read back from the engine; apertures are not yet declared (the block draws as the beam's hull), which the clearance pass adds next.</a:t>
+              <a:t>•  Bodies, rays and labels read back from the engine, apertures declared on every surface; the worst clearance on this deck is the returning beam against the detector carrier, +1.19 mm with no cold shield.  Any shield height fails the check, so a fold prism at the slit is the next step's first item.</a:t>
             </a:r>
           </a:p>
         </p:txBody>
@@ -5504,8 +5504,8 @@
         </p:blipFill>
         <p:spPr>
           <a:xfrm>
-            <a:off x="3720724" y="2606039"/>
-            <a:ext cx="4750245" cy="3858260"/>
+            <a:off x="3380999" y="2853690"/>
+            <a:ext cx="5429695" cy="3610610"/>
           </a:xfrm>
           <a:prstGeom prst="rect">
             <a:avLst/>
@@ -5854,7 +5854,7 @@
                 </a:solidFill>
                 <a:latin typeface="Arial"/>
               </a:rPr>
-              <a:t>Keystone 0.0026 px, smile 0.005 px, CRF 1.33 px, SRF 2.03 px, 76 % of the energy in one pixel, over the slit and the band</a:t>
+              <a:t>Ray-centroid keystone 0.0026 px, smile 0.005 px, CRF 1.33 px, SRF 2.03 px; ensquared energy 0.76 geometric and 0.75 with diffraction</a:t>
             </a:r>
           </a:p>
         </p:txBody>
@@ -5962,6 +5962,45 @@
                 <a:latin typeface="Arial"/>
               </a:rPr>
               <a:t>Engine-scored maps for R4 on 18 µm pixels, per slit position and wavelength: field-angle map, keystone, smile, SRF FWHM, CRF FWHM, ensquared energy; each convention on its colorbar, maxima in the labels.</a:t>
+            </a:r>
+          </a:p>
+        </p:txBody>
+      </p:sp>
+      <p:sp>
+        <p:nvSpPr>
+          <p:cNvPr id="6" name="TextBox 5"/>
+          <p:cNvSpPr txBox="1"/>
+          <p:nvPr/>
+        </p:nvSpPr>
+        <p:spPr>
+          <a:xfrm>
+            <a:off x="411480" y="6748272"/>
+            <a:ext cx="11368735" cy="274320"/>
+          </a:xfrm>
+          <a:prstGeom prst="rect">
+            <a:avLst/>
+          </a:prstGeom>
+          <a:noFill/>
+        </p:spPr>
+        <p:txBody>
+          <a:bodyPr wrap="square">
+            <a:spAutoFit/>
+          </a:bodyPr>
+          <a:lstStyle/>
+          <a:p>
+            <a:pPr>
+              <a:spcAft>
+                <a:spcPts val="600"/>
+              </a:spcAft>
+            </a:pPr>
+            <a:r>
+              <a:rPr sz="1500" b="0">
+                <a:solidFill>
+                  <a:srgbClr val="282828"/>
+                </a:solidFill>
+                <a:latin typeface="Arial"/>
+              </a:rPr>
+              <a:t>•  Open: the propagated PSF's centroid parts from the ray centroid by up to 0.12 px on this design (0.001 px on the seeds, 0.03 px on R3), growing with wavelength, with the path-length check green.  A detector measures the intensity centroid, so until this is resolved the keystone that counts against the 0.1 px specification is the wave number.</a:t>
             </a:r>
           </a:p>
         </p:txBody>
@@ -6735,7 +6774,7 @@
                 </a:solidFill>
                 <a:latin typeface="Arial"/>
               </a:rPr>
-              <a:t>•  Apertures and clearance on R4: declare every element's aperture from the footprint hulls, compute the minimum clearance of every beam leg against every body it does not traverse, model the slit-to-detector package on the block's face (a fold prism if it fails), and re-pose the Offner reference at a 0.2 R slit offset.</a:t>
+              <a:t>•  R5, the slit-to-detector split: the returning beam clears the detector carrier by 1.2 mm with no cold shield; a fold prism at the slit (the literature's answer) is the next layout step, scored under the same clearance check.</a:t>
             </a:r>
           </a:p>
           <a:p>
@@ -6751,7 +6790,7 @@
                 </a:solidFill>
                 <a:latin typeface="Arial"/>
               </a:rPr>
-              <a:t>•  Beat 4: a global search over the meniscus (the R4 solve ends on its bounds) and the native multi-wavelength optimizer with the same smile and keystone operands.</a:t>
+              <a:t>•  Beat 4, first: settle the wave-versus-ray centroid difference (amplitude-weighted ray centroid from the engine's pupil amplitude; the twin's window and sampling as the null), then the global search over the meniscus and the native multi-wavelength optimizer with the centroid that a detector sees as the operand.</a:t>
             </a:r>
           </a:p>
         </p:txBody>
@@ -10268,7 +10307,7 @@
                 </a:solidFill>
                 <a:latin typeface="Arial"/>
               </a:rPr>
-              <a:t>Step R3 of the ladder, before apertures: the beams clear every body, but the grating is 270 mm wide on a 0.70 m radius and the slit sits 18 mm from the band</a:t>
+              <a:t>Step R3 of the ladder with every aperture declared: the beams clear every body; the grating is 270 mm wide on a 0.70 m radius and the slit sits 18 mm from the band</a:t>
             </a:r>
           </a:p>
         </p:txBody>
@@ -10383,7 +10422,7 @@
                 </a:solidFill>
                 <a:latin typeface="Arial"/>
               </a:rPr>
-              <a:t>•  No element declares an aperture yet, so the block draws as the beam's hull and nothing can vignette; apertures, a clearance check and the slit-to-detector package split are the next revision of this layout.</a:t>
+              <a:t>•  Every surface carries an aperture cut from the multi-field, multi-wavelength footprint plus 5 mm, and a clearance check scores every beam leg against every body it does not traverse: the worst pair on this deck is the returning beam against the detector carrier, +1.16 mm, with no cold shield.</a:t>
             </a:r>
           </a:p>
         </p:txBody>
@@ -10404,8 +10443,8 @@
         </p:blipFill>
         <p:spPr>
           <a:xfrm>
-            <a:off x="4266013" y="3489197"/>
-            <a:ext cx="3659667" cy="2975102"/>
+            <a:off x="4046540" y="3736848"/>
+            <a:ext cx="4098613" cy="2727452"/>
           </a:xfrm>
           <a:prstGeom prst="rect">
             <a:avLst/>
@@ -10519,7 +10558,7 @@
                 </a:solidFill>
                 <a:latin typeface="Arial"/>
               </a:rPr>
-              <a:t>The all-reflective twin at F/2.8, before apertures: the grating sits inside the slit-to-mirror beam, so the slit must move out to about 0.2 R</a:t>
+              <a:t>The all-reflective reference at F/2.8, re-posed at 0.22 R: the two mirror zones with the grating between the beams, clearing its mount by 10.2 mm</a:t>
             </a:r>
           </a:p>
         </p:txBody>
@@ -10618,7 +10657,7 @@
                 </a:solidFill>
                 <a:latin typeface="Arial"/>
               </a:rPr>
-              <a:t>•  Obstruction, measured from the ray history: the slit-to-M1 beam crosses the grating's plane over y = −39 to +51 mm while the grating's footprint spans ±45 mm; the return beam crosses it over −58 to +33 mm.  With no apertures declared the trace cannot see this; the slit offset of 6 mm must become about 100 mm (0.2 R, the classical Offner geometry) and the layout re-scored.</a:t>
+              <a:t>•  At the first slit offset (6 mm) the grating sat inside the slit-to-mirror beam; at 0.20 R the beams still clipped its mount by 4 mm; at 0.22 R they clear by 10.2 mm, and the concentric form there is astigmatic (15 px), so the classical corrections are applied under the ladder's operands: convex radius × 1.0034, second concave zone × 0.951 with a 0.3 mm offset.</a:t>
             </a:r>
           </a:p>
           <a:p>
@@ -10634,7 +10673,7 @@
                 </a:solidFill>
                 <a:latin typeface="Arial"/>
               </a:rPr>
-              <a:t>•  Why it stays in the deck: it is where the physical-optics twin is validated (order 0: pupil OPD 8e-11 m, 94 % of the energy in one pixel) and the trade's reference form.</a:t>
+              <a:t>•  As corrected: keystone 0.028 px, CRF 1.20 px, SRF 3.69 px, 23 % of the energy in one pixel.  It stays in the deck as the reference form and as the ground where the physical-optics twin is validated (order 0: pupil OPD 8e-11 m, 85 % in one pixel).</a:t>
             </a:r>
           </a:p>
         </p:txBody>
@@ -10655,8 +10694,8 @@
         </p:blipFill>
         <p:spPr>
           <a:xfrm>
-            <a:off x="4439151" y="3736848"/>
-            <a:ext cx="3313393" cy="2727452"/>
+            <a:off x="4397575" y="3984498"/>
+            <a:ext cx="3396544" cy="2479802"/>
           </a:xfrm>
           <a:prstGeom prst="rect">
             <a:avLst/>

</xml_diff>

<commit_message>
deck_dyson: the open centroid bullet above the R4 maps
Co-Authored-By: Claude Fable 5.1 <noreply@anthropic.com>
</commit_message>
<xml_diff>
--- a/demo_session/deck_dyson.pptx
+++ b/demo_session/deck_dyson.pptx
@@ -5903,9 +5903,48 @@
           </a:p>
         </p:txBody>
       </p:sp>
+      <p:sp>
+        <p:nvSpPr>
+          <p:cNvPr id="4" name="TextBox 3"/>
+          <p:cNvSpPr txBox="1"/>
+          <p:nvPr/>
+        </p:nvSpPr>
+        <p:spPr>
+          <a:xfrm>
+            <a:off x="411480" y="1298448"/>
+            <a:ext cx="11368735" cy="274320"/>
+          </a:xfrm>
+          <a:prstGeom prst="rect">
+            <a:avLst/>
+          </a:prstGeom>
+          <a:noFill/>
+        </p:spPr>
+        <p:txBody>
+          <a:bodyPr wrap="square">
+            <a:spAutoFit/>
+          </a:bodyPr>
+          <a:lstStyle/>
+          <a:p>
+            <a:pPr>
+              <a:spcAft>
+                <a:spcPts val="600"/>
+              </a:spcAft>
+            </a:pPr>
+            <a:r>
+              <a:rPr sz="1500" b="0">
+                <a:solidFill>
+                  <a:srgbClr val="282828"/>
+                </a:solidFill>
+                <a:latin typeface="Arial"/>
+              </a:rPr>
+              <a:t>•  Open: the propagated PSF's centroid parts from the ray centroid by up to 0.12 px on this design (0.001 px on the seeds, 0.03 px on R3), growing with wavelength, with the path-length check green.  A detector measures the intensity centroid, so until this is resolved the keystone that counts against the 0.1 px specification is the wave number.</a:t>
+            </a:r>
+          </a:p>
+        </p:txBody>
+      </p:sp>
       <p:pic>
         <p:nvPicPr>
-          <p:cNvPr id="4" name="Picture 3" descr="dyson5_s3_maps_r4_rc.png"/>
+          <p:cNvPr id="5" name="Picture 4" descr="dyson5_s3_maps_r4_rc.png"/>
           <p:cNvPicPr>
             <a:picLocks noChangeAspect="1"/>
           </p:cNvPicPr>
@@ -5919,8 +5958,8 @@
         </p:blipFill>
         <p:spPr>
           <a:xfrm>
-            <a:off x="3317652" y="1298448"/>
-            <a:ext cx="5556391" cy="5000752"/>
+            <a:off x="3828615" y="2218182"/>
+            <a:ext cx="4534464" cy="4081018"/>
           </a:xfrm>
           <a:prstGeom prst="rect">
             <a:avLst/>
@@ -5929,7 +5968,7 @@
       </p:pic>
       <p:sp>
         <p:nvSpPr>
-          <p:cNvPr id="5" name="TextBox 4"/>
+          <p:cNvPr id="6" name="TextBox 5"/>
           <p:cNvSpPr txBox="1"/>
           <p:nvPr/>
         </p:nvSpPr>
@@ -5962,45 +6001,6 @@
                 <a:latin typeface="Arial"/>
               </a:rPr>
               <a:t>Engine-scored maps for R4 on 18 µm pixels, per slit position and wavelength: field-angle map, keystone, smile, SRF FWHM, CRF FWHM, ensquared energy; each convention on its colorbar, maxima in the labels.</a:t>
-            </a:r>
-          </a:p>
-        </p:txBody>
-      </p:sp>
-      <p:sp>
-        <p:nvSpPr>
-          <p:cNvPr id="6" name="TextBox 5"/>
-          <p:cNvSpPr txBox="1"/>
-          <p:nvPr/>
-        </p:nvSpPr>
-        <p:spPr>
-          <a:xfrm>
-            <a:off x="411480" y="6748272"/>
-            <a:ext cx="11368735" cy="274320"/>
-          </a:xfrm>
-          <a:prstGeom prst="rect">
-            <a:avLst/>
-          </a:prstGeom>
-          <a:noFill/>
-        </p:spPr>
-        <p:txBody>
-          <a:bodyPr wrap="square">
-            <a:spAutoFit/>
-          </a:bodyPr>
-          <a:lstStyle/>
-          <a:p>
-            <a:pPr>
-              <a:spcAft>
-                <a:spcPts val="600"/>
-              </a:spcAft>
-            </a:pPr>
-            <a:r>
-              <a:rPr sz="1500" b="0">
-                <a:solidFill>
-                  <a:srgbClr val="282828"/>
-                </a:solidFill>
-                <a:latin typeface="Arial"/>
-              </a:rPr>
-              <a:t>•  Open: the propagated PSF's centroid parts from the ray centroid by up to 0.12 px on this design (0.001 px on the seeds, 0.03 px on R3), growing with wavelength, with the path-length check green.  A detector measures the intensity centroid, so until this is resolved the keystone that counts against the 0.1 px specification is the wave number.</a:t>
             </a:r>
           </a:p>
         </p:txBody>

</xml_diff>

<commit_message>
deck_dyson: future work on the next-steps slide (surface tour, Mouroulis & Green spot diagrams, the telescope); note: 689df35 preserved Dave's UNFOLDED editing copy, not a sync
Co-Authored-By: Claude Fable 5.1 <noreply@anthropic.com>
</commit_message>
<xml_diff>
--- a/demo_session/deck_dyson.pptx
+++ b/demo_session/deck_dyson.pptx
@@ -9874,7 +9874,23 @@
                 </a:solidFill>
                 <a:latin typeface="Arial"/>
               </a:rPr>
-              <a:t>•  Then the physical-optics twin on R4 and the radiometric chain against the band.</a:t>
+              <a:t>•  Then the radiometric chain against the band.</a:t>
+            </a:r>
+          </a:p>
+          <a:p>
+            <a:pPr>
+              <a:spcAft>
+                <a:spcPts val="600"/>
+              </a:spcAft>
+            </a:pPr>
+            <a:r>
+              <a:rPr sz="1200" b="0">
+                <a:solidFill>
+                  <a:srgbClr val="282828"/>
+                </a:solidFill>
+                <a:latin typeface="Arial"/>
+              </a:rPr>
+              <a:t>•  Future work, once the design of record is stable: a surface-by-surface tour of the prescription (role, ray footprint, clearance, and the field where a propagation leg ends, per surface); spot diagrams in the Mouroulis &amp; Green form, slit positions down and wavelengths across inside the 18 µm pixel box; the telescope and the end-to-end instrument.</a:t>
             </a:r>
           </a:p>
         </p:txBody>

</xml_diff>

<commit_message>
deck_dyson: run-it-yourself with the full sequence (cd, matlab, setup, run), the parameter file explained, and the exercised closure envelope stated as exercised
Co-Authored-By: Claude Fable 5.1 <noreply@anthropic.com>
</commit_message>
<xml_diff>
--- a/demo_session/deck_dyson.pptx
+++ b/demo_session/deck_dyson.pptx
@@ -10021,7 +10021,7 @@
         <p:spPr>
           <a:xfrm>
             <a:off x="411480" y="1298448"/>
-            <a:ext cx="11368735" cy="935736"/>
+            <a:ext cx="11368735" cy="1514094"/>
           </a:xfrm>
           <a:prstGeom prst="rect">
             <a:avLst/>
@@ -10066,7 +10066,7 @@
                 </a:solidFill>
                 <a:latin typeface="Consolas"/>
               </a:rPr>
-              <a:t>run('&lt;path&gt;/mmacos/mmacos_setup.m');</a:t>
+              <a:t>cd &lt;path&gt;/MACOS_resources/mmacos                   % the mmacos folder of the repository (the engine is built already)</a:t>
             </a:r>
           </a:p>
           <a:p>
@@ -10082,7 +10082,7 @@
                 </a:solidFill>
                 <a:latin typeface="Consolas"/>
               </a:rPr>
-              <a:t>addpath('&lt;path&gt;/mmacos/challenges/dyson5');</a:t>
+              <a:t>matlab                                            % start MATLAB here</a:t>
             </a:r>
           </a:p>
           <a:p>
@@ -10098,7 +10098,7 @@
                 </a:solidFill>
                 <a:latin typeface="Consolas"/>
               </a:rPr>
-              <a:t>OUT = dyson5_run();                                      % stage s0: the scaling law (engine-free)</a:t>
+              <a:t>&gt;&gt; run('mmacos_setup.m');                          % puts the engine and the design tools on the path</a:t>
             </a:r>
           </a:p>
           <a:p>
@@ -10114,7 +10114,55 @@
                 </a:solidFill>
                 <a:latin typeface="Consolas"/>
               </a:rPr>
-              <a:t>OUT = dyson5_run(struct('stages', {{'s1','s2','s3'}}));  % emit, score, ladder</a:t>
+              <a:t>&gt;&gt; addpath('challenges/dyson5');</a:t>
+            </a:r>
+          </a:p>
+          <a:p>
+            <a:pPr algn="l">
+              <a:spcAft>
+                <a:spcPts val="100"/>
+              </a:spcAft>
+            </a:pPr>
+            <a:r>
+              <a:rPr sz="1150" b="0">
+                <a:solidFill>
+                  <a:srgbClr val="282828"/>
+                </a:solidFill>
+                <a:latin typeface="Consolas"/>
+              </a:rPr>
+              <a:t>&gt;&gt; OUT = dyson5_run();                             % stage s0 only: the scaling law, no engine needed</a:t>
+            </a:r>
+          </a:p>
+          <a:p>
+            <a:pPr algn="l">
+              <a:spcAft>
+                <a:spcPts val="100"/>
+              </a:spcAft>
+            </a:pPr>
+            <a:r>
+              <a:rPr sz="1150" b="0">
+                <a:solidFill>
+                  <a:srgbClr val="282828"/>
+                </a:solidFill>
+                <a:latin typeface="Consolas"/>
+              </a:rPr>
+              <a:t>&gt;&gt; OUT = dyson5_run(struct('stages', {{'s1','s2','s3'}}));   % emit the decks, score them, run the ladder</a:t>
+            </a:r>
+          </a:p>
+          <a:p>
+            <a:pPr algn="l">
+              <a:spcAft>
+                <a:spcPts val="100"/>
+              </a:spcAft>
+            </a:pPr>
+            <a:r>
+              <a:rPr sz="1150" b="0">
+                <a:solidFill>
+                  <a:srgbClr val="282828"/>
+                </a:solidFill>
+                <a:latin typeface="Consolas"/>
+              </a:rPr>
+              <a:t>&gt;&gt; OUT = dyson5_run(struct('Fno', 2.0, 'block_r_m', 0.25, 'stages', {{'s1','s2','s3'}}));  % your own instance</a:t>
             </a:r>
           </a:p>
         </p:txBody>
@@ -10127,7 +10175,7 @@
         </p:nvSpPr>
         <p:spPr>
           <a:xfrm>
-            <a:off x="411480" y="2343912"/>
+            <a:off x="411480" y="2922270"/>
             <a:ext cx="11368735" cy="274320"/>
           </a:xfrm>
           <a:prstGeom prst="rect">
@@ -10153,7 +10201,7 @@
                 </a:solidFill>
                 <a:latin typeface="Arial"/>
               </a:rPr>
-              <a:t>•  Changeable design parameters live in one file, dyson5_params.m (F-number, pixel, band, slit, block radius, the ladder's options); change them to drive different solutions.  Every record in this deck is a stage output under challenges/dyson5/.</a:t>
+              <a:t>•  Changeable design parameters live in one file, dyson5_params.m: F-number, pixel count and pitch, band, slit width in pixels, block radius, glass, diffraction order, the slit offset, the ladder's steps and weights, the aperture and mount margins, the detector package.  Pass any of them as fields of the struct to drive a different solution; every record in this deck is a stage output under challenges/dyson5/.</a:t>
             </a:r>
           </a:p>
           <a:p>
@@ -10169,7 +10217,23 @@
                 </a:solidFill>
                 <a:latin typeface="Arial"/>
               </a:rPr>
-              <a:t>•  Engine checks: ./run_mmacos_tests.sh tSpectrometerRx and the four grating / glass / propagation classes, all in the fast suite.</a:t>
+              <a:t>•  Where designs have closed so far: F/1.8 with a 220 mm silica block, 54 mm slit, 380–2500 nm, 18 µm pixels, order 1 (the design of record); block radii 50–500 mm scanned at order 0 for the scaling law, where a concentric block meets the quarter-pixel blur only above 213 mm; the Offner reference at F/2.8.  The meniscus solve ends on its bounds, so outside this envelope (faster than F/1.8, blocks under 150 mm, slits beyond 54 mm) closure is untested; a sweep is queued.</a:t>
+            </a:r>
+          </a:p>
+          <a:p>
+            <a:pPr>
+              <a:spcAft>
+                <a:spcPts val="600"/>
+              </a:spcAft>
+            </a:pPr>
+            <a:r>
+              <a:rPr sz="1500" b="0">
+                <a:solidFill>
+                  <a:srgbClr val="282828"/>
+                </a:solidFill>
+                <a:latin typeface="Arial"/>
+              </a:rPr>
+              <a:t>•  Checks: ./run_mmacos_tests.sh tSpectrometerRx and the four grating, glass and propagation classes, all in the fast suite.</a:t>
             </a:r>
           </a:p>
         </p:txBody>

</xml_diff>

<commit_message>
deck_dyson: slide 8 in plain words, slide 13 tightened with a pointer to the element table, the centroid diagnostic slide cut, polarization on future work (d65ad63 carried no change)
Co-Authored-By: Claude Fable 5.1 <noreply@anthropic.com>
</commit_message>
<xml_diff>
--- a/demo_session/deck_dyson.pptx
+++ b/demo_session/deck_dyson.pptx
@@ -30,7 +30,6 @@
     <p:sldId id="278" r:id="rId29"/>
     <p:sldId id="279" r:id="rId30"/>
     <p:sldId id="280" r:id="rId31"/>
-    <p:sldId id="281" r:id="rId32"/>
   </p:sldIdLst>
   <p:sldSz cx="12191695" cy="6858000" type="screen4x3"/>
   <p:notesSz cx="6858000" cy="9144000"/>
@@ -5650,7 +5649,7 @@
                 </a:solidFill>
                 <a:latin typeface="Arial"/>
               </a:rPr>
-              <a:t>•  The prescription: challenges/dyson5/dyson5_s3_r4.in, eleven elements: the block's flat face, its spherical face, the meniscus (two surfaces), the grating, and the return through the meniscus and block to the focal plane; the element table is on the next slide.</a:t>
+              <a:t>•  Eleven surfaces: the block's flat and spherical faces, the meniscus, the grating, and the same faces again on the way back to the focal plane; the element table is on the next slide.</a:t>
             </a:r>
           </a:p>
         </p:txBody>
@@ -5671,8 +5670,8 @@
         </p:blipFill>
         <p:spPr>
           <a:xfrm>
-            <a:off x="2903155" y="2218182"/>
-            <a:ext cx="6385383" cy="4246118"/>
+            <a:off x="2716945" y="1970531"/>
+            <a:ext cx="6757803" cy="4493768"/>
           </a:xfrm>
           <a:prstGeom prst="rect">
             <a:avLst/>
@@ -5752,7 +5751,7 @@
                 </a:solidFill>
                 <a:latin typeface="Arial"/>
               </a:rPr>
-              <a:t>•  Clearance: the worst pair is the returning beam against the detector carrier, +1.19 mm with no cold shield; any shield height fails the check, so a fold prism at the slit is the next layout step.</a:t>
+              <a:t>•  Clearance: the returning beam passes the detector carrier by 1.19 mm with no cold shield; any shield fails the check, so a fold prism at the slit is the next layout step.</a:t>
             </a:r>
           </a:p>
         </p:txBody>
@@ -9400,7 +9399,7 @@
                 </a:solidFill>
                 <a:latin typeface="Arial"/>
               </a:rPr>
-              <a:t>•  8 The exact chain and the engine agree</a:t>
+              <a:t>•  8 Two independent ray traces agree</a:t>
             </a:r>
           </a:p>
           <a:p>
@@ -9890,7 +9889,7 @@
                 </a:solidFill>
                 <a:latin typeface="Arial"/>
               </a:rPr>
-              <a:t>•  Future work, once the design of record is stable: a surface-by-surface tour of the prescription (role, ray footprint, clearance, and the field where a propagation leg ends, per surface); spot diagrams in the Mouroulis &amp; Green form, slit positions down and wavelengths across inside the 18 µm pixel box; the telescope and the end-to-end instrument.</a:t>
+              <a:t>•  Future work, once the design of record is stable: a surface-by-surface tour of the prescription (role, ray footprint, clearance, and the field where a propagation leg ends, per surface); spot diagrams in the Mouroulis &amp; Green form, slit positions down and wavelengths across inside the 18 µm pixel box; the telescope and the end-to-end instrument; polarization sensitivity of the Dyson against the Offner, since the Dyson's near-normal incidence is what the literature credits for its low sensitivity.</a:t>
             </a:r>
           </a:p>
         </p:txBody>
@@ -11925,288 +11924,6 @@
 </file>
 
 <file path=ppt/slides/slide25.xml><?xml version="1.0" encoding="utf-8"?>
-<p:sld xmlns:a="http://schemas.openxmlformats.org/drawingml/2006/main" xmlns:p="http://schemas.openxmlformats.org/presentationml/2006/main" xmlns:r="http://schemas.openxmlformats.org/officeDocument/2006/relationships">
-  <p:cSld>
-    <p:spTree>
-      <p:nvGrpSpPr>
-        <p:cNvPr id="1" name=""/>
-        <p:cNvGrpSpPr/>
-        <p:nvPr/>
-      </p:nvGrpSpPr>
-      <p:grpSpPr/>
-      <p:sp>
-        <p:nvSpPr>
-          <p:cNvPr id="2" name="TextBox 1"/>
-          <p:cNvSpPr txBox="1"/>
-          <p:nvPr/>
-        </p:nvSpPr>
-        <p:spPr>
-          <a:xfrm>
-            <a:off x="411480" y="201168"/>
-            <a:ext cx="11368735" cy="914400"/>
-          </a:xfrm>
-          <a:prstGeom prst="rect">
-            <a:avLst/>
-          </a:prstGeom>
-          <a:noFill/>
-        </p:spPr>
-        <p:txBody>
-          <a:bodyPr wrap="square">
-            <a:spAutoFit/>
-          </a:bodyPr>
-          <a:lstStyle/>
-          <a:p>
-            <a:pPr>
-              <a:spcAft>
-                <a:spcPts val="400"/>
-              </a:spcAft>
-            </a:pPr>
-            <a:r>
-              <a:rPr sz="2400" b="1">
-                <a:solidFill>
-                  <a:srgbClr val="1F4E79"/>
-                </a:solidFill>
-                <a:latin typeface="Arial"/>
-              </a:rPr>
-              <a:t>Backup: the centroid question, settled</a:t>
-            </a:r>
-          </a:p>
-          <a:p>
-            <a:pPr>
-              <a:spcAft>
-                <a:spcPts val="0"/>
-              </a:spcAft>
-            </a:pPr>
-            <a:r>
-              <a:rPr sz="1250" b="0">
-                <a:solidFill>
-                  <a:srgbClr val="6E6E6E"/>
-                </a:solidFill>
-                <a:latin typeface="Arial"/>
-              </a:rPr>
-              <a:t>A 0.12 px wave-versus-ray difference on R4 was the twin's grid read in the wrong frame; the detector sees the ray centroid</a:t>
-            </a:r>
-          </a:p>
-        </p:txBody>
-      </p:sp>
-      <p:sp>
-        <p:nvSpPr>
-          <p:cNvPr id="3" name="Rectangle 2"/>
-          <p:cNvSpPr/>
-          <p:nvPr/>
-        </p:nvSpPr>
-        <p:spPr>
-          <a:xfrm>
-            <a:off x="411480" y="1133856"/>
-            <a:ext cx="11368735" cy="20320"/>
-          </a:xfrm>
-          <a:prstGeom prst="rect">
-            <a:avLst/>
-          </a:prstGeom>
-          <a:solidFill>
-            <a:srgbClr val="B8C6D4"/>
-          </a:solidFill>
-          <a:ln>
-            <a:noFill/>
-          </a:ln>
-          <a:effectLst/>
-        </p:spPr>
-        <p:style>
-          <a:lnRef idx="1">
-            <a:schemeClr val="accent1"/>
-          </a:lnRef>
-          <a:fillRef idx="3">
-            <a:schemeClr val="accent1"/>
-          </a:fillRef>
-          <a:effectRef idx="2">
-            <a:schemeClr val="accent1"/>
-          </a:effectRef>
-          <a:fontRef idx="minor">
-            <a:schemeClr val="lt1"/>
-          </a:fontRef>
-        </p:style>
-        <p:txBody>
-          <a:bodyPr rtlCol="0" anchor="ctr"/>
-          <a:lstStyle/>
-          <a:p>
-            <a:pPr algn="ctr"/>
-          </a:p>
-        </p:txBody>
-      </p:sp>
-      <p:sp>
-        <p:nvSpPr>
-          <p:cNvPr id="4" name="TextBox 3"/>
-          <p:cNvSpPr txBox="1"/>
-          <p:nvPr/>
-        </p:nvSpPr>
-        <p:spPr>
-          <a:xfrm>
-            <a:off x="411480" y="1298448"/>
-            <a:ext cx="5806440" cy="274320"/>
-          </a:xfrm>
-          <a:prstGeom prst="rect">
-            <a:avLst/>
-          </a:prstGeom>
-          <a:noFill/>
-        </p:spPr>
-        <p:txBody>
-          <a:bodyPr wrap="square">
-            <a:spAutoFit/>
-          </a:bodyPr>
-          <a:lstStyle/>
-          <a:p>
-            <a:pPr>
-              <a:spcAft>
-                <a:spcPts val="600"/>
-              </a:spcAft>
-            </a:pPr>
-            <a:r>
-              <a:rPr sz="1200" b="0">
-                <a:solidFill>
-                  <a:srgbClr val="282828"/>
-                </a:solidFill>
-                <a:latin typeface="Arial"/>
-              </a:rPr>
-              <a:t>•  The symptom: the propagated point-spread function's centroid parted from the ray centroid by 0.001 px on the seeds, 0.03 px on R3 and 0.12 px on R4, growing with wavelength, while the path-length check passed.</a:t>
-            </a:r>
-          </a:p>
-          <a:p>
-            <a:pPr>
-              <a:spcAft>
-                <a:spcPts val="600"/>
-              </a:spcAft>
-            </a:pPr>
-            <a:r>
-              <a:rPr sz="1200" b="0">
-                <a:solidFill>
-                  <a:srgbClr val="282828"/>
-                </a:solidFill>
-                <a:latin typeface="Arial"/>
-              </a:rPr>
-              <a:t>•  The proposed mechanism, tested and refuted: an amplitude-weighted ray centroid (Fresnel transmission across the pupil) reproduces the ray centroid to 4 % of the offset (0.0505 vs 0.0524 px at 2500 nm).</a:t>
-            </a:r>
-          </a:p>
-          <a:p>
-            <a:pPr>
-              <a:spcAft>
-                <a:spcPts val="600"/>
-              </a:spcAft>
-            </a:pPr>
-            <a:r>
-              <a:rPr sz="1200" b="0">
-                <a:solidFill>
-                  <a:srgbClr val="282828"/>
-                </a:solidFill>
-                <a:latin typeface="Arial"/>
-              </a:rPr>
-              <a:t>•  Numerics ruled out: doubling the window and halving the sampling reproduce every digit.</a:t>
-            </a:r>
-          </a:p>
-        </p:txBody>
-      </p:sp>
-      <p:sp>
-        <p:nvSpPr>
-          <p:cNvPr id="5" name="TextBox 4"/>
-          <p:cNvSpPr txBox="1"/>
-          <p:nvPr/>
-        </p:nvSpPr>
-        <p:spPr>
-          <a:xfrm>
-            <a:off x="6400800" y="1298448"/>
-            <a:ext cx="5394960" cy="274320"/>
-          </a:xfrm>
-          <a:prstGeom prst="rect">
-            <a:avLst/>
-          </a:prstGeom>
-          <a:noFill/>
-        </p:spPr>
-        <p:txBody>
-          <a:bodyPr wrap="square">
-            <a:spAutoFit/>
-          </a:bodyPr>
-          <a:lstStyle/>
-          <a:p>
-            <a:pPr>
-              <a:spcAft>
-                <a:spcPts val="600"/>
-              </a:spcAft>
-            </a:pPr>
-            <a:r>
-              <a:rPr sz="1200" b="0">
-                <a:solidFill>
-                  <a:srgbClr val="282828"/>
-                </a:solidFill>
-                <a:latin typeface="Arial"/>
-              </a:rPr>
-              <a:t>•  The cause: the far-field grid carries the source grid's orientation in index space, inverted by the transform; the prescription's y axis is chief × x, which is +y on the Dyson's chief and −y on the Offner's.  Raw centroids on R4 were the ray offsets with both signs flipped, on the Offner with one.</a:t>
-            </a:r>
-          </a:p>
-          <a:p>
-            <a:pPr>
-              <a:spcAft>
-                <a:spcPts val="600"/>
-              </a:spcAft>
-            </a:pPr>
-            <a:r>
-              <a:rPr sz="1200" b="0">
-                <a:solidFill>
-                  <a:srgbClr val="282828"/>
-                </a:solidFill>
-                <a:latin typeface="Arial"/>
-              </a:rPr>
-              <a:t>•  The fix: the harness takes the signs from the engine's source frame and states them in its record.  After it: agreement 0.0022 px (R4) and 0.0058 px (Offner) at every slit position and wavelength.  The concentric seed could never have shown this; it had no offset to flip.</a:t>
-            </a:r>
-          </a:p>
-        </p:txBody>
-      </p:sp>
-      <p:sp>
-        <p:nvSpPr>
-          <p:cNvPr id="6" name="TextBox 5"/>
-          <p:cNvSpPr txBox="1"/>
-          <p:nvPr/>
-        </p:nvSpPr>
-        <p:spPr>
-          <a:xfrm>
-            <a:off x="6400800" y="3398519"/>
-            <a:ext cx="5394960" cy="274320"/>
-          </a:xfrm>
-          <a:prstGeom prst="rect">
-            <a:avLst/>
-          </a:prstGeom>
-          <a:noFill/>
-        </p:spPr>
-        <p:txBody>
-          <a:bodyPr wrap="square">
-            <a:spAutoFit/>
-          </a:bodyPr>
-          <a:lstStyle/>
-          <a:p>
-            <a:pPr>
-              <a:spcAft>
-                <a:spcPts val="600"/>
-              </a:spcAft>
-            </a:pPr>
-            <a:r>
-              <a:rPr sz="1050" b="0">
-                <a:solidFill>
-                  <a:srgbClr val="6E6E6E"/>
-                </a:solidFill>
-                <a:latin typeface="Arial"/>
-              </a:rPr>
-              <a:t>Record: dyson5_s2w.txt, dyson5_s2w_R3control.txt; convention in the reference document.</a:t>
-            </a:r>
-          </a:p>
-        </p:txBody>
-      </p:sp>
-    </p:spTree>
-  </p:cSld>
-  <p:clrMapOvr>
-    <a:masterClrMapping/>
-  </p:clrMapOvr>
-</p:sld>
-</file>
-
-<file path=ppt/slides/slide26.xml><?xml version="1.0" encoding="utf-8"?>
 <p:sld xmlns:a="http://schemas.openxmlformats.org/drawingml/2006/main" xmlns:p="http://schemas.openxmlformats.org/presentationml/2006/main" xmlns:r="http://schemas.openxmlformats.org/officeDocument/2006/relationships">
   <p:cSld>
     <p:spTree>
@@ -16820,7 +16537,7 @@
                 </a:solidFill>
                 <a:latin typeface="Arial"/>
               </a:rPr>
-              <a:t>The exact chain and the engine agree</a:t>
+              <a:t>Two independent ray traces agree</a:t>
             </a:r>
           </a:p>
           <a:p>
@@ -16836,7 +16553,7 @@
                 </a:solidFill>
                 <a:latin typeface="Arial"/>
               </a:rPr>
-              <a:t>Every engine ray re-traced by the chain from the engine's own launch directions lands within 1e-9 m</a:t>
+              <a:t>The design solver and MACOS place every ray within a nanometre of each other, so the prescription is what the solver intended</a:t>
             </a:r>
           </a:p>
         </p:txBody>
@@ -16919,7 +16636,7 @@
                 </a:solidFill>
                 <a:latin typeface="Arial"/>
               </a:rPr>
-              <a:t>•  The check: the engine's chief ray and every ray of its grid are re-traced through the chain's surfaces from the engine's launch directions; agreement is per ray, every surface, 1e-9 m; the dispersed band spans the focal plane to 1 %.</a:t>
+              <a:t>•  Two programs, one prescription. The design solver (MATLAB) lays out each form from its design rules and writes the prescription.  MACOS then traces that prescription on its own.  The check: every ray MACOS launches is re-traced by the solver through the same surfaces, and the two land within 1e-9 m at every surface; the dispersed band spans the detector to 1 %.</a:t>
             </a:r>
           </a:p>
           <a:p>
@@ -16935,7 +16652,7 @@
                 </a:solidFill>
                 <a:latin typeface="Arial"/>
               </a:rPr>
-              <a:t>•  With the aspheric block face (ladder step R2): agreement 1e-12 m per ray; a sphere-only chain misses by 0.26 mm, so the check is not vacuous.</a:t>
+              <a:t>•  The check is not trivial. With the aspheric block face of ladder step R2 the agreement is 1e-12 m per ray, while a solver that ignores the asphere misses by 0.26 mm.</a:t>
             </a:r>
           </a:p>
           <a:p>
@@ -16951,7 +16668,7 @@
                 </a:solidFill>
                 <a:latin typeface="Arial"/>
               </a:rPr>
-              <a:t>•  The physical-optics twin: a far-field terminal on a reference sphere upstream of the focal plane, re-posed per slit position and wavelength; on the Offner at order 0 the pupil OPD is 8e-11 m and the Airy spot puts 94 % of its energy in one 18 µm pixel.</a:t>
+              <a:t>•  Wave propagation agrees too. On the Offner at order 0 the propagated point image is a clean Airy pattern, 85 % of its energy in one pixel, with a pupil error of 8e-11 m.</a:t>
             </a:r>
           </a:p>
         </p:txBody>
@@ -16990,7 +16707,7 @@
                 </a:solidFill>
                 <a:latin typeface="Arial"/>
               </a:rPr>
-              <a:t>•  What the checks found in the engine, now fixed (details in Backup): glass names were ignored at load; propagation inside glass used the vacuum wavelength; the grating groove period was held constant along the curved surface instead of along the chord; the grating's path-length jump had the matching defect.  Each has a regression test written from the physics, not from the engine.</a:t>
+              <a:t>•  What the checks found in MACOS, and fixed (details in Backup): glass names were ignored when a prescription loaded; propagation inside glass used the vacuum wavelength; a grating's groove spacing was held constant along the curved surface instead of along the chord; the grating's path-length term had the matching defect.  Each now has a regression test written from the physics.</a:t>
             </a:r>
           </a:p>
         </p:txBody>
@@ -17029,7 +16746,7 @@
                 </a:solidFill>
                 <a:latin typeface="Arial"/>
               </a:rPr>
-              <a:t>Regression tests: tSpectrometerRx (3), tGratingOpl (2), tGratingImmersed (4), tGlassDispersion (3), tPropMedium (3); mmacos fast suite 501 pass, 0 fail (2026-10-01).</a:t>
+              <a:t>Regression tests: 15 in five classes; the MACOS fast suite stands at 504 pass, 0 fail (2026-10-01).</a:t>
             </a:r>
           </a:p>
         </p:txBody>

</xml_diff>

<commit_message>
deck_dyson: R4 render slide, both bullets above the figure
Co-Authored-By: Claude Fable 5.1 <noreply@anthropic.com>
</commit_message>
<xml_diff>
--- a/demo_session/deck_dyson.pptx
+++ b/demo_session/deck_dyson.pptx
@@ -5652,6 +5652,22 @@
               <a:t>•  Eleven surfaces: the block's flat and spherical faces, the meniscus, the grating, and the same faces again on the way back to the focal plane; the element table is on the next slide.</a:t>
             </a:r>
           </a:p>
+          <a:p>
+            <a:pPr>
+              <a:spcAft>
+                <a:spcPts val="600"/>
+              </a:spcAft>
+            </a:pPr>
+            <a:r>
+              <a:rPr sz="1500" b="0">
+                <a:solidFill>
+                  <a:srgbClr val="282828"/>
+                </a:solidFill>
+                <a:latin typeface="Arial"/>
+              </a:rPr>
+              <a:t>•  Clearance: the returning beam passes the detector carrier by 1.19 mm with no cold shield; any shield fails the check, so a fold prism at the slit is the next layout step.</a:t>
+            </a:r>
+          </a:p>
         </p:txBody>
       </p:sp>
       <p:pic>
@@ -5670,8 +5686,8 @@
         </p:blipFill>
         <p:spPr>
           <a:xfrm>
-            <a:off x="2716945" y="1970531"/>
-            <a:ext cx="6757803" cy="4493768"/>
+            <a:off x="3194789" y="2606039"/>
+            <a:ext cx="5802116" cy="3858260"/>
           </a:xfrm>
           <a:prstGeom prst="rect">
             <a:avLst/>
@@ -5713,45 +5729,6 @@
                 <a:latin typeface="Arial"/>
               </a:rPr>
               <a:t>3-D view and the dispersion plane (Y-Z), metres, global frame.</a:t>
-            </a:r>
-          </a:p>
-        </p:txBody>
-      </p:sp>
-      <p:sp>
-        <p:nvSpPr>
-          <p:cNvPr id="7" name="TextBox 6"/>
-          <p:cNvSpPr txBox="1"/>
-          <p:nvPr/>
-        </p:nvSpPr>
-        <p:spPr>
-          <a:xfrm>
-            <a:off x="411480" y="6748272"/>
-            <a:ext cx="11368735" cy="274320"/>
-          </a:xfrm>
-          <a:prstGeom prst="rect">
-            <a:avLst/>
-          </a:prstGeom>
-          <a:noFill/>
-        </p:spPr>
-        <p:txBody>
-          <a:bodyPr wrap="square">
-            <a:spAutoFit/>
-          </a:bodyPr>
-          <a:lstStyle/>
-          <a:p>
-            <a:pPr>
-              <a:spcAft>
-                <a:spcPts val="600"/>
-              </a:spcAft>
-            </a:pPr>
-            <a:r>
-              <a:rPr sz="1500" b="0">
-                <a:solidFill>
-                  <a:srgbClr val="282828"/>
-                </a:solidFill>
-                <a:latin typeface="Arial"/>
-              </a:rPr>
-              <a:t>•  Clearance: the returning beam passes the detector carrier by 1.19 mm with no cold shield; any shield fails the check, so a fold prism at the slit is the next layout step.</a:t>
             </a:r>
           </a:p>
         </p:txBody>

</xml_diff>

<commit_message>
CALIB: asphere differential step scales with the coefficient (1e-3 of it; sag-based at the circular aperture for a zero one; legacy per-order step + a line without an aperture) -- the fixed 1e-10 was round-off on metre decks (singular matrix at the first LM step); the LM failure path no longer STOPs the host: optics restored to the last accepted state, rtn_flg=1 through the normal cleanup (the mex raises a catchable error).  Gates: tAsphCalib 2/2, tCalib 9, tDesignTelescope 70, tSpectrometerRx 7, fast 510/0, pymacos 18.  deck_dyson: native optimize result (R4n = R4), sixth engine finding; addendum 16
Co-Authored-By: Claude Fable 5.1 <noreply@anthropic.com>
</commit_message>
<xml_diff>
--- a/demo_session/deck_dyson.pptx
+++ b/demo_session/deck_dyson.pptx
@@ -13894,7 +13894,7 @@
                 </a:solidFill>
                 <a:latin typeface="Arial"/>
               </a:rPr>
-              <a:t>•  The native multi-wavelength optimizer (MACOS CALIB) on the compact variant: built and gated — the engine's spot-size solve over 5 slit positions × 6 wavelengths with the double-pass copies of each surface linked as one, smile and keystone held as walls between iteration chunks on the chain, and the engine's design read back under an identity check.  It runs now that the engine's derivative-loop defect is fixed (Backup); the result is not yet on the record.</a:t>
+              <a:t>•  The native multi-wavelength optimizer (MACOS CALIB) confirms the compact variant: the engine's spot-size solve over 5 slit positions × 6 wavelengths, the double-pass copies of each surface linked as one, smile and keystone held as walls between iteration chunks, the engine's design read back under an identity check (2e-16 m).  With the blur freedoms (block face radius and conic, meniscus faces, focus) every step is rejected: R4 is a local optimum of the engine's merit as well as the chain's.  With the grating's position free the engine bought blur with 15 px of keystone in five iterations and the wall rejected it: the reason the design needs distortion operands, queued as an engine feature.  From a deliberate 0.3 mm defocus the same solve cuts the spot from 97 to 21 µm, so it moves when there is something to gain.  The block's asphere joins the freedoms now that its differential step is fixed (Backup).</a:t>
             </a:r>
           </a:p>
           <a:p>
@@ -14537,7 +14537,7 @@
                 </a:solidFill>
                 <a:latin typeface="Arial"/>
               </a:rPr>
-              <a:t>Backup: five engine findings, each with a regression test</a:t>
+              <a:t>Backup: six engine findings, each with a regression test</a:t>
             </a:r>
           </a:p>
           <a:p>
@@ -14612,7 +14612,7 @@
         </p:nvGraphicFramePr>
         <p:xfrm>
           <a:off x="411480" y="1298448"/>
-          <a:ext cx="11368733" cy="3188970"/>
+          <a:ext cx="11368733" cy="3846195"/>
         </p:xfrm>
         <a:graphic>
           <a:graphicData uri="http://schemas.openxmlformats.org/drawingml/2006/table">
@@ -14621,10 +14621,10 @@
                 <a:tableStyleId>{5C22544A-7EE6-4342-B048-85BDC9FD1C3A}</a:tableStyleId>
               </a:tblPr>
               <a:tblGrid>
-                <a:gridCol w="2398268"/>
-                <a:gridCol w="4942910"/>
-                <a:gridCol w="2458378"/>
-                <a:gridCol w="1569177"/>
+                <a:gridCol w="991903"/>
+                <a:gridCol w="5086682"/>
+                <a:gridCol w="2899408"/>
+                <a:gridCol w="2390740"/>
               </a:tblGrid>
               <a:tr h="280035">
                 <a:tc>
@@ -14806,7 +14806,7 @@
                   </a:tcPr>
                 </a:tc>
               </a:tr>
-              <a:tr h="468630">
+              <a:tr h="657225">
                 <a:tc>
                   <a:txBody>
                     <a:bodyPr wrap="square"/>
@@ -14986,7 +14986,7 @@
                   </a:tcPr>
                 </a:tc>
               </a:tr>
-              <a:tr h="657225">
+              <a:tr h="468630">
                 <a:tc>
                   <a:txBody>
                     <a:bodyPr wrap="square"/>
@@ -15162,6 +15162,96 @@
                   <a:tcPr marL="54864" marR="54864" marT="18288" marB="18288">
                     <a:solidFill>
                       <a:srgbClr val="FFFFFF"/>
+                    </a:solidFill>
+                  </a:tcPr>
+                </a:tc>
+              </a:tr>
+              <a:tr h="657225">
+                <a:tc>
+                  <a:txBody>
+                    <a:bodyPr wrap="square"/>
+                    <a:lstStyle/>
+                    <a:p>
+                      <a:r>
+                        <a:rPr sz="1100" b="0">
+                          <a:solidFill>
+                            <a:srgbClr val="282828"/>
+                          </a:solidFill>
+                          <a:latin typeface="Arial"/>
+                        </a:rPr>
+                        <a:t>optimizer asphere step and failure exit</a:t>
+                      </a:r>
+                    </a:p>
+                  </a:txBody>
+                  <a:tcPr marL="54864" marR="54864" marT="18288" marB="18288">
+                    <a:solidFill>
+                      <a:srgbClr val="ECF1F6"/>
+                    </a:solidFill>
+                  </a:tcPr>
+                </a:tc>
+                <a:tc>
+                  <a:txBody>
+                    <a:bodyPr wrap="square"/>
+                    <a:lstStyle/>
+                    <a:p>
+                      <a:r>
+                        <a:rPr sz="1100" b="0">
+                          <a:solidFill>
+                            <a:srgbClr val="282828"/>
+                          </a:solidFill>
+                          <a:latin typeface="Arial"/>
+                        </a:rPr>
+                        <a:t>an aspheric coefficient was probed by a fixed 1e-10, round-off on a deck in metres: a zero derivative column, a singular matrix at the first step, and a stop on that path that ended the MATLAB process</a:t>
+                      </a:r>
+                    </a:p>
+                  </a:txBody>
+                  <a:tcPr marL="54864" marR="54864" marT="18288" marB="18288">
+                    <a:solidFill>
+                      <a:srgbClr val="ECF1F6"/>
+                    </a:solidFill>
+                  </a:tcPr>
+                </a:tc>
+                <a:tc>
+                  <a:txBody>
+                    <a:bodyPr wrap="square"/>
+                    <a:lstStyle/>
+                    <a:p>
+                      <a:r>
+                        <a:rPr sz="1100" b="0">
+                          <a:solidFill>
+                            <a:srgbClr val="282828"/>
+                          </a:solidFill>
+                          <a:latin typeface="Arial"/>
+                        </a:rPr>
+                        <a:t>the step is 1e-3 of the coefficient (sag-based for a zero one); the failure restores the optics and returns a flag</a:t>
+                      </a:r>
+                    </a:p>
+                  </a:txBody>
+                  <a:tcPr marL="54864" marR="54864" marT="18288" marB="18288">
+                    <a:solidFill>
+                      <a:srgbClr val="ECF1F6"/>
+                    </a:solidFill>
+                  </a:tcPr>
+                </a:tc>
+                <a:tc>
+                  <a:txBody>
+                    <a:bodyPr wrap="square"/>
+                    <a:lstStyle/>
+                    <a:p>
+                      <a:r>
+                        <a:rPr sz="1100" b="0">
+                          <a:solidFill>
+                            <a:srgbClr val="282828"/>
+                          </a:solidFill>
+                          <a:latin typeface="Arial"/>
+                        </a:rPr>
+                        <a:t>tAsphCalib (2): a spoiled paraboloid driven back to zero; the failure path with the host alive</a:t>
+                      </a:r>
+                    </a:p>
+                  </a:txBody>
+                  <a:tcPr marL="54864" marR="54864" marT="18288" marB="18288">
+                    <a:solidFill>
+                      <a:srgbClr val="ECF1F6"/>
                     </a:solidFill>
                   </a:tcPr>
                 </a:tc>
@@ -15178,7 +15268,7 @@
         </p:nvSpPr>
         <p:spPr>
           <a:xfrm>
-            <a:off x="411480" y="4633722"/>
+            <a:off x="411480" y="5290947"/>
             <a:ext cx="11368735" cy="274320"/>
           </a:xfrm>
           <a:prstGeom prst="rect">
@@ -15204,7 +15294,7 @@
                 </a:solidFill>
                 <a:latin typeface="Arial"/>
               </a:rPr>
-              <a:t>Flat gratings are unchanged by the grating fixes; the wavefront-target optimizer, which every telescope design used, was never affected by the fifth.  A sixth item, a short AsphCoef= line killing the host process, now pads with zero and warns (tRxShortAsph).</a:t>
+              <a:t>Flat gratings are unchanged by the grating fixes; the wavefront-target optimizer, which every telescope design used, was never affected by the fifth.  A seventh item, a short AsphCoef= line killing the host process, now pads with zero and warns (tRxShortAsph).</a:t>
             </a:r>
           </a:p>
         </p:txBody>
@@ -15336,7 +15426,7 @@
         </p:nvGraphicFramePr>
         <p:xfrm>
           <a:off x="411480" y="1298448"/>
-          <a:ext cx="11368734" cy="4303395"/>
+          <a:ext cx="11368734" cy="4491990"/>
         </p:xfrm>
         <a:graphic>
           <a:graphicData uri="http://schemas.openxmlformats.org/drawingml/2006/table">
@@ -16340,7 +16430,7 @@
                   </a:tcPr>
                 </a:tc>
               </a:tr>
-              <a:tr h="280035">
+              <a:tr h="468630">
                 <a:tc>
                   <a:txBody>
                     <a:bodyPr wrap="square"/>
@@ -16375,29 +16465,29 @@
                           </a:solidFill>
                           <a:latin typeface="Arial"/>
                         </a:rPr>
-                        <a:t>s4 (native_enabled)</a:t>
-                      </a:r>
-                    </a:p>
-                  </a:txBody>
-                  <a:tcPr marL="54864" marR="54864" marT="18288" marB="18288">
-                    <a:solidFill>
-                      <a:srgbClr val="FFFFFF"/>
-                    </a:solidFill>
-                  </a:tcPr>
-                </a:tc>
-                <a:tc>
-                  <a:txBody>
-                    <a:bodyPr wrap="square"/>
-                    <a:lstStyle/>
-                    <a:p>
-                      <a:r>
-                        <a:rPr sz="1100" b="0">
-                          <a:solidFill>
-                            <a:srgbClr val="282828"/>
-                          </a:solidFill>
-                          <a:latin typeface="Arial"/>
-                        </a:rPr>
-                        <a:t>dyson5_s4_r4n_seed.in (the CALIB deck)</a:t>
+                        <a:t>s4</a:t>
+                      </a:r>
+                    </a:p>
+                  </a:txBody>
+                  <a:tcPr marL="54864" marR="54864" marT="18288" marB="18288">
+                    <a:solidFill>
+                      <a:srgbClr val="FFFFFF"/>
+                    </a:solidFill>
+                  </a:tcPr>
+                </a:tc>
+                <a:tc>
+                  <a:txBody>
+                    <a:bodyPr wrap="square"/>
+                    <a:lstStyle/>
+                    <a:p>
+                      <a:r>
+                        <a:rPr sz="1100" b="0">
+                          <a:solidFill>
+                            <a:srgbClr val="282828"/>
+                          </a:solidFill>
+                          <a:latin typeface="Arial"/>
+                        </a:rPr>
+                        <a:t>dyson5_s4.txt, dyson5_s4_r4n_seed.in (the CALIB deck), dyson5_s4_r4n.in</a:t>
                       </a:r>
                     </a:p>
                   </a:txBody>
@@ -16442,7 +16532,7 @@
         </p:nvSpPr>
         <p:spPr>
           <a:xfrm>
-            <a:off x="411480" y="5748147"/>
+            <a:off x="411480" y="5936742"/>
             <a:ext cx="11368735" cy="274320"/>
           </a:xfrm>
           <a:prstGeom prst="rect">
@@ -21336,7 +21426,7 @@
                 </a:solidFill>
                 <a:latin typeface="Arial"/>
               </a:rPr>
-              <a:t>Regression tests: 15 in five classes plus the optimizer's; the MACOS fast suite stands at 507 pass, 0 fail (2026-10-01).</a:t>
+              <a:t>Regression tests: 15 in five classes plus the optimizer's; the MACOS fast suite stands at 510 pass, 0 fail (2026-10-01).</a:t>
             </a:r>
           </a:p>
         </p:txBody>

</xml_diff>

<commit_message>
deck_dyson: beat 5 -- two slides (the telescope as traced, the instrument end to end); BRIEF_to_dyson5 addendum 18 (beat 5 run from the cleared context: the layout closes, the image does not -- Schwarzschild / freeform next); CURRENT_SLICE resume state
Figures are the runner's own output (engine renders tiled by tile_views.py,
maps recomposed at the panel level).  The edit copy of the deck is NOT synced
(Dave's word); the build is deck_dyson.pptx, 32 slides.

Co-Authored-By: Claude Fable 5.1 <noreply@anthropic.com>
</commit_message>
<xml_diff>
--- a/demo_session/deck_dyson.pptx
+++ b/demo_session/deck_dyson.pptx
@@ -35,6 +35,8 @@
     <p:sldId id="283" r:id="rId34"/>
     <p:sldId id="284" r:id="rId35"/>
     <p:sldId id="285" r:id="rId36"/>
+    <p:sldId id="286" r:id="rId37"/>
+    <p:sldId id="287" r:id="rId38"/>
   </p:sldIdLst>
   <p:sldSz cx="12191695" cy="6858000" type="screen4x3"/>
   <p:notesSz cx="6858000" cy="9144000"/>
@@ -9892,7 +9894,7 @@
                 </a:solidFill>
                 <a:latin typeface="Arial"/>
               </a:rPr>
-              <a:t>•  25 Next steps</a:t>
+              <a:t>•  25 The telescope that feeds the slit</a:t>
             </a:r>
           </a:p>
           <a:p>
@@ -9908,7 +9910,7 @@
                 </a:solidFill>
                 <a:latin typeface="Arial"/>
               </a:rPr>
-              <a:t>•  26 Run it yourself</a:t>
+              <a:t>•  26 Telescope and spectrometer end to end</a:t>
             </a:r>
           </a:p>
           <a:p>
@@ -9924,7 +9926,39 @@
                 </a:solidFill>
                 <a:latin typeface="Arial"/>
               </a:rPr>
-              <a:t>•  27 Backup</a:t>
+              <a:t>•  27 Next steps</a:t>
+            </a:r>
+          </a:p>
+          <a:p>
+            <a:pPr>
+              <a:spcAft>
+                <a:spcPts val="600"/>
+              </a:spcAft>
+            </a:pPr>
+            <a:r>
+              <a:rPr sz="1200" b="0">
+                <a:solidFill>
+                  <a:srgbClr val="282828"/>
+                </a:solidFill>
+                <a:latin typeface="Arial"/>
+              </a:rPr>
+              <a:t>•  28 Run it yourself</a:t>
+            </a:r>
+          </a:p>
+          <a:p>
+            <a:pPr>
+              <a:spcAft>
+                <a:spcPts val="600"/>
+              </a:spcAft>
+            </a:pPr>
+            <a:r>
+              <a:rPr sz="1200" b="0">
+                <a:solidFill>
+                  <a:srgbClr val="282828"/>
+                </a:solidFill>
+                <a:latin typeface="Arial"/>
+              </a:rPr>
+              <a:t>•  29 Backup</a:t>
             </a:r>
           </a:p>
         </p:txBody>
@@ -13795,7 +13829,7 @@
                 </a:solidFill>
                 <a:latin typeface="Arial"/>
               </a:rPr>
-              <a:t>Next steps</a:t>
+              <a:t>The telescope that feeds the slit, as traced by the engine</a:t>
             </a:r>
           </a:p>
           <a:p>
@@ -13811,7 +13845,7 @@
                 </a:solidFill>
                 <a:latin typeface="Arial"/>
               </a:rPr>
-              <a:t>The native optimizer on the record, the cold window, and the telescope that feeds the slit</a:t>
+              <a:t>EMIT's parameters: f = 126 mm, 70 mm at F/1.8, 24.6° onto the 54 mm slit; a folded three-mirror laid out, unobscured and pupil-matched; its image is not yet at the pixel</a:t>
             </a:r>
           </a:p>
         </p:txBody>
@@ -13869,6 +13903,508 @@
         <p:spPr>
           <a:xfrm>
             <a:off x="411480" y="1298448"/>
+            <a:ext cx="11368735" cy="274320"/>
+          </a:xfrm>
+          <a:prstGeom prst="rect">
+            <a:avLst/>
+          </a:prstGeom>
+          <a:noFill/>
+        </p:spPr>
+        <p:txBody>
+          <a:bodyPr wrap="square">
+            <a:spAutoFit/>
+          </a:bodyPr>
+          <a:lstStyle/>
+          <a:p>
+            <a:pPr>
+              <a:spcAft>
+                <a:spcPts val="600"/>
+              </a:spcAft>
+            </a:pPr>
+            <a:r>
+              <a:rPr sz="1500" b="0">
+                <a:solidFill>
+                  <a:srgbClr val="282828"/>
+                </a:solidFill>
+                <a:latin typeface="Arial"/>
+              </a:rPr>
+              <a:t>•  Three facts first.  The spectrometer is telecentric at its slit to 0.09° (its accepted chief rays cross 16.8 m behind the slit), so the pupil match is measured as the chief's miss of the grating vertex when the telescope's chief is sent on through the block.  With a flat field and that pupil the three-mirror first order is a one-parameter family.  And the push-broom field is the sky line that images onto the straight slit, solved per field.</a:t>
+            </a:r>
+          </a:p>
+          <a:p>
+            <a:pPr>
+              <a:spcAft>
+                <a:spcPts val="600"/>
+              </a:spcAft>
+            </a:pPr>
+            <a:r>
+              <a:rPr sz="1500" b="0">
+                <a:solidFill>
+                  <a:srgbClr val="282828"/>
+                </a:solidFill>
+                <a:latin typeface="Arial"/>
+              </a:rPr>
+              <a:t>•  The layout.  The coaxial section cannot be unobscured at F/1.8 with spacings of the beam's size, so the chief is folded at each mirror (32°, −32°, 21°) and a flat fold after M3 turns the beam into the spectrometer.  Every leg clears every body (+0.75 mm beyond the 5 mm mount margin); the chief lands within 9.4 mm of the grating vertex and the grating admits 100 % of the beam at every field; focal length by the map 126.4 mm.</a:t>
+            </a:r>
+          </a:p>
+          <a:p>
+            <a:pPr>
+              <a:spcAft>
+                <a:spcPts val="600"/>
+              </a:spcAft>
+            </a:pPr>
+            <a:r>
+              <a:rPr sz="1500" b="0">
+                <a:solidFill>
+                  <a:srgbClr val="282828"/>
+                </a:solidFill>
+                <a:latin typeface="Arial"/>
+              </a:rPr>
+              <a:t>•  The image, and what it says.  Four rungs on the exact chain (layout; conics + radii + spacings; + h⁴/h⁶ aspheres; everything) reach 67 px rms at the slit with a 1.6 mm field-curvature swing: conics and symmetric aspheres on folded mirrors do not image at the pixel over ±12.3° at F/1.8.  Next, the review's forms for this regime: the two-mirror modified Schwarzschild, and freeform mirrors.  Record dyson5_t1.txt, deck dyson5_t1_t3.in, every rung engine-scored.</a:t>
+            </a:r>
+          </a:p>
+        </p:txBody>
+      </p:sp>
+      <p:pic>
+        <p:nvPicPr>
+          <p:cNvPr id="5" name="Picture 4" descr="dyson5_t1_t3_views.png"/>
+          <p:cNvPicPr>
+            <a:picLocks noChangeAspect="1"/>
+          </p:cNvPicPr>
+          <p:nvPr/>
+        </p:nvPicPr>
+        <p:blipFill>
+          <a:blip r:embed="rId2"/>
+          <a:stretch>
+            <a:fillRect/>
+          </a:stretch>
+        </p:blipFill>
+        <p:spPr>
+          <a:xfrm>
+            <a:off x="5242267" y="4727447"/>
+            <a:ext cx="1707159" cy="1571752"/>
+          </a:xfrm>
+          <a:prstGeom prst="rect">
+            <a:avLst/>
+          </a:prstGeom>
+        </p:spPr>
+      </p:pic>
+      <p:sp>
+        <p:nvSpPr>
+          <p:cNvPr id="6" name="TextBox 5"/>
+          <p:cNvSpPr txBox="1"/>
+          <p:nvPr/>
+        </p:nvSpPr>
+        <p:spPr>
+          <a:xfrm>
+            <a:off x="411480" y="6317488"/>
+            <a:ext cx="11368735" cy="394208"/>
+          </a:xfrm>
+          <a:prstGeom prst="rect">
+            <a:avLst/>
+          </a:prstGeom>
+          <a:noFill/>
+        </p:spPr>
+        <p:txBody>
+          <a:bodyPr wrap="square">
+            <a:spAutoFit/>
+          </a:bodyPr>
+          <a:lstStyle/>
+          <a:p>
+            <a:pPr algn="ctr">
+              <a:spcAft>
+                <a:spcPts val="0"/>
+              </a:spcAft>
+            </a:pPr>
+            <a:r>
+              <a:rPr sz="1000" b="0">
+                <a:solidFill>
+                  <a:srgbClr val="6E6E6E"/>
+                </a:solidFill>
+                <a:latin typeface="Arial"/>
+              </a:rPr>
+              <a:t>3-D view and the dispersion plane (Y-Z), metres, global frame: the sky from +y, M1 at the bottom, M2 and M3 above it, the fold flat (E4) turning the beam into the slit (E6) on the Dyson's axis; apertures are the declared ellipses.</a:t>
+            </a:r>
+          </a:p>
+        </p:txBody>
+      </p:sp>
+    </p:spTree>
+  </p:cSld>
+  <p:clrMapOvr>
+    <a:masterClrMapping/>
+  </p:clrMapOvr>
+</p:sld>
+</file>
+
+<file path=ppt/slides/slide26.xml><?xml version="1.0" encoding="utf-8"?>
+<p:sld xmlns:a="http://schemas.openxmlformats.org/drawingml/2006/main" xmlns:p="http://schemas.openxmlformats.org/presentationml/2006/main" xmlns:r="http://schemas.openxmlformats.org/officeDocument/2006/relationships">
+  <p:cSld>
+    <p:spTree>
+      <p:nvGrpSpPr>
+        <p:cNvPr id="1" name=""/>
+        <p:cNvGrpSpPr/>
+        <p:nvPr/>
+      </p:nvGrpSpPr>
+      <p:grpSpPr/>
+      <p:sp>
+        <p:nvSpPr>
+          <p:cNvPr id="2" name="TextBox 1"/>
+          <p:cNvSpPr txBox="1"/>
+          <p:nvPr/>
+        </p:nvSpPr>
+        <p:spPr>
+          <a:xfrm>
+            <a:off x="411480" y="201168"/>
+            <a:ext cx="11368735" cy="914400"/>
+          </a:xfrm>
+          <a:prstGeom prst="rect">
+            <a:avLst/>
+          </a:prstGeom>
+          <a:noFill/>
+        </p:spPr>
+        <p:txBody>
+          <a:bodyPr wrap="square">
+            <a:spAutoFit/>
+          </a:bodyPr>
+          <a:lstStyle/>
+          <a:p>
+            <a:pPr>
+              <a:spcAft>
+                <a:spcPts val="400"/>
+              </a:spcAft>
+            </a:pPr>
+            <a:r>
+              <a:rPr sz="2400" b="1">
+                <a:solidFill>
+                  <a:srgbClr val="1F4E79"/>
+                </a:solidFill>
+                <a:latin typeface="Arial"/>
+              </a:rPr>
+              <a:t>Telescope and spectrometer end to end</a:t>
+            </a:r>
+          </a:p>
+          <a:p>
+            <a:pPr>
+              <a:spcAft>
+                <a:spcPts val="0"/>
+              </a:spcAft>
+            </a:pPr>
+            <a:r>
+              <a:rPr sz="1250" b="0">
+                <a:solidFill>
+                  <a:srgbClr val="6E6E6E"/>
+                </a:solidFill>
+                <a:latin typeface="Arial"/>
+              </a:rPr>
+              <a:t>One prescription of 16 (R4) and 19 (R5) elements, the grating its stop; the spectrometer's scorer sees the telescope's blur</a:t>
+            </a:r>
+          </a:p>
+        </p:txBody>
+      </p:sp>
+      <p:sp>
+        <p:nvSpPr>
+          <p:cNvPr id="3" name="Rectangle 2"/>
+          <p:cNvSpPr/>
+          <p:nvPr/>
+        </p:nvSpPr>
+        <p:spPr>
+          <a:xfrm>
+            <a:off x="411480" y="1133856"/>
+            <a:ext cx="11368735" cy="20320"/>
+          </a:xfrm>
+          <a:prstGeom prst="rect">
+            <a:avLst/>
+          </a:prstGeom>
+          <a:solidFill>
+            <a:srgbClr val="B8C6D4"/>
+          </a:solidFill>
+          <a:ln>
+            <a:noFill/>
+          </a:ln>
+          <a:effectLst/>
+        </p:spPr>
+        <p:style>
+          <a:lnRef idx="1">
+            <a:schemeClr val="accent1"/>
+          </a:lnRef>
+          <a:fillRef idx="3">
+            <a:schemeClr val="accent1"/>
+          </a:fillRef>
+          <a:effectRef idx="2">
+            <a:schemeClr val="accent1"/>
+          </a:effectRef>
+          <a:fontRef idx="minor">
+            <a:schemeClr val="lt1"/>
+          </a:fontRef>
+        </p:style>
+        <p:txBody>
+          <a:bodyPr rtlCol="0" anchor="ctr"/>
+          <a:lstStyle/>
+          <a:p>
+            <a:pPr algn="ctr"/>
+          </a:p>
+        </p:txBody>
+      </p:sp>
+      <p:sp>
+        <p:nvSpPr>
+          <p:cNvPr id="4" name="TextBox 3"/>
+          <p:cNvSpPr txBox="1"/>
+          <p:nvPr/>
+        </p:nvSpPr>
+        <p:spPr>
+          <a:xfrm>
+            <a:off x="411480" y="1298448"/>
+            <a:ext cx="11368735" cy="274320"/>
+          </a:xfrm>
+          <a:prstGeom prst="rect">
+            <a:avLst/>
+          </a:prstGeom>
+          <a:noFill/>
+        </p:spPr>
+        <p:txBody>
+          <a:bodyPr wrap="square">
+            <a:spAutoFit/>
+          </a:bodyPr>
+          <a:lstStyle/>
+          <a:p>
+            <a:pPr>
+              <a:spcAft>
+                <a:spcPts val="600"/>
+              </a:spcAft>
+            </a:pPr>
+            <a:r>
+              <a:rPr sz="1500" b="0">
+                <a:solidFill>
+                  <a:srgbClr val="282828"/>
+                </a:solidFill>
+                <a:latin typeface="Arial"/>
+              </a:rPr>
+              <a:t>•  The deck.  The telescope's surfaces are prepended to the spectrometer of record — sky, M1, M2, M3, fold, the slit as a pass-through reference, then block, meniscus, grating and detector — with a collimated 70 mm source per field and the grating declared the stop.  Gate tTelescopeRx: every ray at the slit and at the detector within 1e-9 m of the design solver's.</a:t>
+            </a:r>
+          </a:p>
+          <a:p>
+            <a:pPr>
+              <a:spcAft>
+                <a:spcPts val="600"/>
+              </a:spcAft>
+            </a:pPr>
+            <a:r>
+              <a:rPr sz="1500" b="0">
+                <a:solidFill>
+                  <a:srgbClr val="282828"/>
+                </a:solidFill>
+                <a:latin typeface="Arial"/>
+              </a:rPr>
+              <a:t>•  The score (7 fields × 7 wavelengths, the spectrometer's own scorer): with R4 smile 3.1 px, keystone 0.59 px, SRF 15.7 px, CRF 15.5 px; R5 the same to 0.03 px.  Against the spectrometer alone (smile 0.005, keystone 0.003, CRF 1.33 px) these are the telescope's 67 px blur passing through.  Clearance across both +0.75 mm with R4; with R5 the fold mirror's blur-widened footprint meets the detector package at −0.11 mm.</a:t>
+            </a:r>
+          </a:p>
+          <a:p>
+            <a:pPr>
+              <a:spcAft>
+                <a:spcPts val="600"/>
+              </a:spcAft>
+            </a:pPr>
+            <a:r>
+              <a:rPr sz="1500" b="0">
+                <a:solidFill>
+                  <a:srgbClr val="282828"/>
+                </a:solidFill>
+                <a:latin typeface="Arial"/>
+              </a:rPr>
+              <a:t>•  What it establishes: the end-to-end machinery is in place and gated — a telescope deck of record, a combined prescription with the stop at the grating, the admitted fraction per field, the clearance gate across both instruments.  Records dyson5_t2.txt, decks dyson5_t2_r4.in, dyson5_t2_r5.in.</a:t>
+            </a:r>
+          </a:p>
+        </p:txBody>
+      </p:sp>
+      <p:pic>
+        <p:nvPicPr>
+          <p:cNvPr id="5" name="Picture 4" descr="dyson5_t2_r4_views.png"/>
+          <p:cNvPicPr>
+            <a:picLocks noChangeAspect="1"/>
+          </p:cNvPicPr>
+          <p:nvPr/>
+        </p:nvPicPr>
+        <p:blipFill>
+          <a:blip r:embed="rId2"/>
+          <a:stretch>
+            <a:fillRect/>
+          </a:stretch>
+        </p:blipFill>
+        <p:spPr>
+          <a:xfrm>
+            <a:off x="4994682" y="4479797"/>
+            <a:ext cx="2202329" cy="1819402"/>
+          </a:xfrm>
+          <a:prstGeom prst="rect">
+            <a:avLst/>
+          </a:prstGeom>
+        </p:spPr>
+      </p:pic>
+      <p:sp>
+        <p:nvSpPr>
+          <p:cNvPr id="6" name="TextBox 5"/>
+          <p:cNvSpPr txBox="1"/>
+          <p:nvPr/>
+        </p:nvSpPr>
+        <p:spPr>
+          <a:xfrm>
+            <a:off x="411480" y="6317488"/>
+            <a:ext cx="11368735" cy="394208"/>
+          </a:xfrm>
+          <a:prstGeom prst="rect">
+            <a:avLst/>
+          </a:prstGeom>
+          <a:noFill/>
+        </p:spPr>
+        <p:txBody>
+          <a:bodyPr wrap="square">
+            <a:spAutoFit/>
+          </a:bodyPr>
+          <a:lstStyle/>
+          <a:p>
+            <a:pPr algn="ctr">
+              <a:spcAft>
+                <a:spcPts val="0"/>
+              </a:spcAft>
+            </a:pPr>
+            <a:r>
+              <a:rPr sz="1000" b="0">
+                <a:solidFill>
+                  <a:srgbClr val="6E6E6E"/>
+                </a:solidFill>
+                <a:latin typeface="Arial"/>
+              </a:rPr>
+              <a:t>3-D view and the dispersion plane (Y-Z), metres: the folded telescope below the slit plane, the block, meniscus and grating (E10) above it along the Dyson's axis, the detector on the block's face.</a:t>
+            </a:r>
+          </a:p>
+        </p:txBody>
+      </p:sp>
+    </p:spTree>
+  </p:cSld>
+  <p:clrMapOvr>
+    <a:masterClrMapping/>
+  </p:clrMapOvr>
+</p:sld>
+</file>
+
+<file path=ppt/slides/slide27.xml><?xml version="1.0" encoding="utf-8"?>
+<p:sld xmlns:a="http://schemas.openxmlformats.org/drawingml/2006/main" xmlns:p="http://schemas.openxmlformats.org/presentationml/2006/main" xmlns:r="http://schemas.openxmlformats.org/officeDocument/2006/relationships">
+  <p:cSld>
+    <p:spTree>
+      <p:nvGrpSpPr>
+        <p:cNvPr id="1" name=""/>
+        <p:cNvGrpSpPr/>
+        <p:nvPr/>
+      </p:nvGrpSpPr>
+      <p:grpSpPr/>
+      <p:sp>
+        <p:nvSpPr>
+          <p:cNvPr id="2" name="TextBox 1"/>
+          <p:cNvSpPr txBox="1"/>
+          <p:nvPr/>
+        </p:nvSpPr>
+        <p:spPr>
+          <a:xfrm>
+            <a:off x="411480" y="201168"/>
+            <a:ext cx="11368735" cy="914400"/>
+          </a:xfrm>
+          <a:prstGeom prst="rect">
+            <a:avLst/>
+          </a:prstGeom>
+          <a:noFill/>
+        </p:spPr>
+        <p:txBody>
+          <a:bodyPr wrap="square">
+            <a:spAutoFit/>
+          </a:bodyPr>
+          <a:lstStyle/>
+          <a:p>
+            <a:pPr>
+              <a:spcAft>
+                <a:spcPts val="400"/>
+              </a:spcAft>
+            </a:pPr>
+            <a:r>
+              <a:rPr sz="2400" b="1">
+                <a:solidFill>
+                  <a:srgbClr val="1F4E79"/>
+                </a:solidFill>
+                <a:latin typeface="Arial"/>
+              </a:rPr>
+              <a:t>Next steps</a:t>
+            </a:r>
+          </a:p>
+          <a:p>
+            <a:pPr>
+              <a:spcAft>
+                <a:spcPts val="0"/>
+              </a:spcAft>
+            </a:pPr>
+            <a:r>
+              <a:rPr sz="1250" b="0">
+                <a:solidFill>
+                  <a:srgbClr val="6E6E6E"/>
+                </a:solidFill>
+                <a:latin typeface="Arial"/>
+              </a:rPr>
+              <a:t>The native optimizer on the record, the cold window, and the telescope that feeds the slit</a:t>
+            </a:r>
+          </a:p>
+        </p:txBody>
+      </p:sp>
+      <p:sp>
+        <p:nvSpPr>
+          <p:cNvPr id="3" name="Rectangle 2"/>
+          <p:cNvSpPr/>
+          <p:nvPr/>
+        </p:nvSpPr>
+        <p:spPr>
+          <a:xfrm>
+            <a:off x="411480" y="1133856"/>
+            <a:ext cx="11368735" cy="20320"/>
+          </a:xfrm>
+          <a:prstGeom prst="rect">
+            <a:avLst/>
+          </a:prstGeom>
+          <a:solidFill>
+            <a:srgbClr val="B8C6D4"/>
+          </a:solidFill>
+          <a:ln>
+            <a:noFill/>
+          </a:ln>
+          <a:effectLst/>
+        </p:spPr>
+        <p:style>
+          <a:lnRef idx="1">
+            <a:schemeClr val="accent1"/>
+          </a:lnRef>
+          <a:fillRef idx="3">
+            <a:schemeClr val="accent1"/>
+          </a:fillRef>
+          <a:effectRef idx="2">
+            <a:schemeClr val="accent1"/>
+          </a:effectRef>
+          <a:fontRef idx="minor">
+            <a:schemeClr val="lt1"/>
+          </a:fontRef>
+        </p:style>
+        <p:txBody>
+          <a:bodyPr rtlCol="0" anchor="ctr"/>
+          <a:lstStyle/>
+          <a:p>
+            <a:pPr algn="ctr"/>
+          </a:p>
+        </p:txBody>
+      </p:sp>
+      <p:sp>
+        <p:nvSpPr>
+          <p:cNvPr id="4" name="TextBox 3"/>
+          <p:cNvSpPr txBox="1"/>
+          <p:nvPr/>
+        </p:nvSpPr>
+        <p:spPr>
+          <a:xfrm>
+            <a:off x="411480" y="1298448"/>
             <a:ext cx="5806440" cy="274320"/>
           </a:xfrm>
           <a:prstGeom prst="rect">
@@ -13965,7 +14501,7 @@
                 </a:solidFill>
                 <a:latin typeface="Arial"/>
               </a:rPr>
-              <a:t>•  Beat 5, the telescope: EMIT parameters — 420 km, 60 m ground sample, 0.143 mrad IFOV, focal length 126 mm, 70 mm aperture at F/1.8, 24.6° cross-track field onto the 54 mm slit, telecentric and flat; the telescope's exit pupil on the grating.  Then spectrometer and telescope traced end to end as one deck.</a:t>
+              <a:t>•  The telescope's image (beat 5 continues): the folded three-mirror is laid out, unobscured, pupil-matched and traced end to end, but conics and symmetric aspheres leave 67 px at the slit.  Next: the two-mirror modified Schwarzschild the review recommends for wide fields at low F-number, and freeform (Zernike) mirrors on the folded three-mirror through the engine's native optimizer; then the end-to-end score and the full slit diffraction.</a:t>
             </a:r>
           </a:p>
           <a:p>
@@ -13994,7 +14530,7 @@
 </p:sld>
 </file>
 
-<file path=ppt/slides/slide26.xml><?xml version="1.0" encoding="utf-8"?>
+<file path=ppt/slides/slide28.xml><?xml version="1.0" encoding="utf-8"?>
 <p:sld xmlns:a="http://schemas.openxmlformats.org/drawingml/2006/main" xmlns:p="http://schemas.openxmlformats.org/presentationml/2006/main" xmlns:r="http://schemas.openxmlformats.org/officeDocument/2006/relationships">
   <p:cSld>
     <p:spTree>
@@ -14353,7 +14889,7 @@
 </p:sld>
 </file>
 
-<file path=ppt/slides/slide27.xml><?xml version="1.0" encoding="utf-8"?>
+<file path=ppt/slides/slide29.xml><?xml version="1.0" encoding="utf-8"?>
 <p:sld xmlns:a="http://schemas.openxmlformats.org/drawingml/2006/main" xmlns:p="http://schemas.openxmlformats.org/presentationml/2006/main" xmlns:r="http://schemas.openxmlformats.org/officeDocument/2006/relationships">
   <p:cSld>
     <p:spTree>
@@ -14493,7 +15029,7 @@
 </p:sld>
 </file>
 
-<file path=ppt/slides/slide28.xml><?xml version="1.0" encoding="utf-8"?>
+<file path=ppt/slides/slide3.xml><?xml version="1.0" encoding="utf-8"?>
 <p:sld xmlns:a="http://schemas.openxmlformats.org/drawingml/2006/main" xmlns:p="http://schemas.openxmlformats.org/presentationml/2006/main" xmlns:r="http://schemas.openxmlformats.org/officeDocument/2006/relationships">
   <p:cSld>
     <p:spTree>
@@ -14537,7 +15073,7 @@
                 </a:solidFill>
                 <a:latin typeface="Arial"/>
               </a:rPr>
-              <a:t>Backup: six engine findings, each with a regression test</a:t>
+              <a:t>The target and how it is scored</a:t>
             </a:r>
           </a:p>
           <a:p>
@@ -14553,7 +15089,7 @@
                 </a:solidFill>
                 <a:latin typeface="Arial"/>
               </a:rPr>
-              <a:t>Found by the challenge's checks on 2026-09-30 and 10-01, fixed in the engine the same day</a:t>
+              <a:t>Joe's specification, EMIT-class; the metrics stated once, here</a:t>
             </a:r>
           </a:p>
         </p:txBody>
@@ -14612,7 +15148,7 @@
         </p:nvGraphicFramePr>
         <p:xfrm>
           <a:off x="411480" y="1298448"/>
-          <a:ext cx="11368733" cy="3846195"/>
+          <a:ext cx="5806439" cy="2897505"/>
         </p:xfrm>
         <a:graphic>
           <a:graphicData uri="http://schemas.openxmlformats.org/drawingml/2006/table">
@@ -14621,10 +15157,8 @@
                 <a:tableStyleId>{5C22544A-7EE6-4342-B048-85BDC9FD1C3A}</a:tableStyleId>
               </a:tblPr>
               <a:tblGrid>
-                <a:gridCol w="991903"/>
-                <a:gridCol w="5086682"/>
-                <a:gridCol w="2899408"/>
-                <a:gridCol w="2390740"/>
+                <a:gridCol w="2274687"/>
+                <a:gridCol w="3531752"/>
               </a:tblGrid>
               <a:tr h="280035">
                 <a:tc>
@@ -14639,7 +15173,7 @@
                           </a:solidFill>
                           <a:latin typeface="Arial"/>
                         </a:rPr>
-                        <a:t>finding</a:t>
+                        <a:t>item</a:t>
                       </a:r>
                     </a:p>
                   </a:txBody>
@@ -14661,51 +15195,7 @@
                           </a:solidFill>
                           <a:latin typeface="Arial"/>
                         </a:rPr>
-                        <a:t>symptom</a:t>
-                      </a:r>
-                    </a:p>
-                  </a:txBody>
-                  <a:tcPr marL="54864" marR="54864" marT="18288" marB="18288">
-                    <a:solidFill>
-                      <a:srgbClr val="1F4E79"/>
-                    </a:solidFill>
-                  </a:tcPr>
-                </a:tc>
-                <a:tc>
-                  <a:txBody>
-                    <a:bodyPr wrap="square"/>
-                    <a:lstStyle/>
-                    <a:p>
-                      <a:r>
-                        <a:rPr sz="1100" b="1">
-                          <a:solidFill>
-                            <a:srgbClr val="FFFFFF"/>
-                          </a:solidFill>
-                          <a:latin typeface="Arial"/>
-                        </a:rPr>
-                        <a:t>fix</a:t>
-                      </a:r>
-                    </a:p>
-                  </a:txBody>
-                  <a:tcPr marL="54864" marR="54864" marT="18288" marB="18288">
-                    <a:solidFill>
-                      <a:srgbClr val="1F4E79"/>
-                    </a:solidFill>
-                  </a:tcPr>
-                </a:tc>
-                <a:tc>
-                  <a:txBody>
-                    <a:bodyPr wrap="square"/>
-                    <a:lstStyle/>
-                    <a:p>
-                      <a:r>
-                        <a:rPr sz="1100" b="1">
-                          <a:solidFill>
-                            <a:srgbClr val="FFFFFF"/>
-                          </a:solidFill>
-                          <a:latin typeface="Arial"/>
-                        </a:rPr>
-                        <a:t>test</a:t>
+                        <a:t>value</a:t>
                       </a:r>
                     </a:p>
                   </a:txBody>
@@ -14729,73 +15219,29 @@
                           </a:solidFill>
                           <a:latin typeface="Arial"/>
                         </a:rPr>
-                        <a:t>glass names ignored at load</a:t>
-                      </a:r>
-                    </a:p>
-                  </a:txBody>
-                  <a:tcPr marL="54864" marR="54864" marT="18288" marB="18288">
-                    <a:solidFill>
-                      <a:srgbClr val="FFFFFF"/>
-                    </a:solidFill>
-                  </a:tcPr>
-                </a:tc>
-                <a:tc>
-                  <a:txBody>
-                    <a:bodyPr wrap="square"/>
-                    <a:lstStyle/>
-                    <a:p>
-                      <a:r>
-                        <a:rPr sz="1100" b="0">
-                          <a:solidFill>
-                            <a:srgbClr val="282828"/>
-                          </a:solidFill>
-                          <a:latin typeface="Arial"/>
-                        </a:rPr>
-                        <a:t>a GlassElt= Silica element traced as air in every binding</a:t>
-                      </a:r>
-                    </a:p>
-                  </a:txBody>
-                  <a:tcPr marL="54864" marR="54864" marT="18288" marB="18288">
-                    <a:solidFill>
-                      <a:srgbClr val="FFFFFF"/>
-                    </a:solidFill>
-                  </a:tcPr>
-                </a:tc>
-                <a:tc>
-                  <a:txBody>
-                    <a:bodyPr wrap="square"/>
-                    <a:lstStyle/>
-                    <a:p>
-                      <a:r>
-                        <a:rPr sz="1100" b="0">
-                          <a:solidFill>
-                            <a:srgbClr val="282828"/>
-                          </a:solidFill>
-                          <a:latin typeface="Arial"/>
-                        </a:rPr>
-                        <a:t>the glass catalog is blanked once at allocation, not on every load</a:t>
-                      </a:r>
-                    </a:p>
-                  </a:txBody>
-                  <a:tcPr marL="54864" marR="54864" marT="18288" marB="18288">
-                    <a:solidFill>
-                      <a:srgbClr val="FFFFFF"/>
-                    </a:solidFill>
-                  </a:tcPr>
-                </a:tc>
-                <a:tc>
-                  <a:txBody>
-                    <a:bodyPr wrap="square"/>
-                    <a:lstStyle/>
-                    <a:p>
-                      <a:r>
-                        <a:rPr sz="1100" b="0">
-                          <a:solidFill>
-                            <a:srgbClr val="282828"/>
-                          </a:solidFill>
-                          <a:latin typeface="Arial"/>
-                        </a:rPr>
-                        <a:t>tGlassDispersion (3)</a:t>
+                        <a:t>F-number (air-equivalent, image space)</a:t>
+                      </a:r>
+                    </a:p>
+                  </a:txBody>
+                  <a:tcPr marL="54864" marR="54864" marT="18288" marB="18288">
+                    <a:solidFill>
+                      <a:srgbClr val="FFFFFF"/>
+                    </a:solidFill>
+                  </a:tcPr>
+                </a:tc>
+                <a:tc>
+                  <a:txBody>
+                    <a:bodyPr wrap="square"/>
+                    <a:lstStyle/>
+                    <a:p>
+                      <a:r>
+                        <a:rPr sz="1100" b="0">
+                          <a:solidFill>
+                            <a:srgbClr val="282828"/>
+                          </a:solidFill>
+                          <a:latin typeface="Arial"/>
+                        </a:rPr>
+                        <a:t>1.8</a:t>
                       </a:r>
                     </a:p>
                   </a:txBody>
@@ -14806,20 +15252,20 @@
                   </a:tcPr>
                 </a:tc>
               </a:tr>
-              <a:tr h="657225">
-                <a:tc>
-                  <a:txBody>
-                    <a:bodyPr wrap="square"/>
-                    <a:lstStyle/>
-                    <a:p>
-                      <a:r>
-                        <a:rPr sz="1100" b="0">
-                          <a:solidFill>
-                            <a:srgbClr val="282828"/>
-                          </a:solidFill>
-                          <a:latin typeface="Arial"/>
-                        </a:rPr>
-                        <a:t>vacuum wavelength inside glass</a:t>
+              <a:tr h="280035">
+                <a:tc>
+                  <a:txBody>
+                    <a:bodyPr wrap="square"/>
+                    <a:lstStyle/>
+                    <a:p>
+                      <a:r>
+                        <a:rPr sz="1100" b="0">
+                          <a:solidFill>
+                            <a:srgbClr val="282828"/>
+                          </a:solidFill>
+                          <a:latin typeface="Arial"/>
+                        </a:rPr>
+                        <a:t>focal plane</a:t>
                       </a:r>
                     </a:p>
                   </a:txBody>
@@ -14841,7 +15287,7 @@
                           </a:solidFill>
                           <a:latin typeface="Arial"/>
                         </a:rPr>
-                        <a:t>a propagation leg in a medium ran at the wrong Fresnel number by n</a:t>
+                        <a:t>3000 spatial × 500 spectral pixels, 18 µm</a:t>
                       </a:r>
                     </a:p>
                   </a:txBody>
@@ -14851,19 +15297,67 @@
                     </a:solidFill>
                   </a:tcPr>
                 </a:tc>
-                <a:tc>
-                  <a:txBody>
-                    <a:bodyPr wrap="square"/>
-                    <a:lstStyle/>
-                    <a:p>
-                      <a:r>
-                        <a:rPr sz="1100" b="0">
-                          <a:solidFill>
-                            <a:srgbClr val="282828"/>
-                          </a:solidFill>
-                          <a:latin typeface="Arial"/>
-                        </a:rPr>
-                        <a:t>every kernel takes λ/n of the leg's medium</a:t>
+              </a:tr>
+              <a:tr h="280035">
+                <a:tc>
+                  <a:txBody>
+                    <a:bodyPr wrap="square"/>
+                    <a:lstStyle/>
+                    <a:p>
+                      <a:r>
+                        <a:rPr sz="1100" b="0">
+                          <a:solidFill>
+                            <a:srgbClr val="282828"/>
+                          </a:solidFill>
+                          <a:latin typeface="Arial"/>
+                        </a:rPr>
+                        <a:t>slit</a:t>
+                      </a:r>
+                    </a:p>
+                  </a:txBody>
+                  <a:tcPr marL="54864" marR="54864" marT="18288" marB="18288">
+                    <a:solidFill>
+                      <a:srgbClr val="FFFFFF"/>
+                    </a:solidFill>
+                  </a:tcPr>
+                </a:tc>
+                <a:tc>
+                  <a:txBody>
+                    <a:bodyPr wrap="square"/>
+                    <a:lstStyle/>
+                    <a:p>
+                      <a:r>
+                        <a:rPr sz="1100" b="0">
+                          <a:solidFill>
+                            <a:srgbClr val="282828"/>
+                          </a:solidFill>
+                          <a:latin typeface="Arial"/>
+                        </a:rPr>
+                        <a:t>54 mm; spectral height 9 mm</a:t>
+                      </a:r>
+                    </a:p>
+                  </a:txBody>
+                  <a:tcPr marL="54864" marR="54864" marT="18288" marB="18288">
+                    <a:solidFill>
+                      <a:srgbClr val="FFFFFF"/>
+                    </a:solidFill>
+                  </a:tcPr>
+                </a:tc>
+              </a:tr>
+              <a:tr h="280035">
+                <a:tc>
+                  <a:txBody>
+                    <a:bodyPr wrap="square"/>
+                    <a:lstStyle/>
+                    <a:p>
+                      <a:r>
+                        <a:rPr sz="1100" b="0">
+                          <a:solidFill>
+                            <a:srgbClr val="282828"/>
+                          </a:solidFill>
+                          <a:latin typeface="Arial"/>
+                        </a:rPr>
+                        <a:t>band</a:t>
                       </a:r>
                     </a:p>
                   </a:txBody>
@@ -14885,7 +15379,7 @@
                           </a:solidFill>
                           <a:latin typeface="Arial"/>
                         </a:rPr>
-                        <a:t>tPropMedium (3): z in n ≡ z/n in vacuum</a:t>
+                        <a:t>380–2500 nm, 4.24 nm per pixel</a:t>
                       </a:r>
                     </a:p>
                   </a:txBody>
@@ -14896,86 +15390,134 @@
                   </a:tcPr>
                 </a:tc>
               </a:tr>
-              <a:tr h="657225">
-                <a:tc>
-                  <a:txBody>
-                    <a:bodyPr wrap="square"/>
-                    <a:lstStyle/>
-                    <a:p>
-                      <a:r>
-                        <a:rPr sz="1100" b="0">
-                          <a:solidFill>
-                            <a:srgbClr val="282828"/>
-                          </a:solidFill>
-                          <a:latin typeface="Arial"/>
-                        </a:rPr>
-                        <a:t>groove period along the surface</a:t>
-                      </a:r>
-                    </a:p>
-                  </a:txBody>
-                  <a:tcPr marL="54864" marR="54864" marT="18288" marB="18288">
-                    <a:solidFill>
-                      <a:srgbClr val="FFFFFF"/>
-                    </a:solidFill>
-                  </a:tcPr>
-                </a:tc>
-                <a:tc>
-                  <a:txBody>
-                    <a:bodyPr wrap="square"/>
-                    <a:lstStyle/>
-                    <a:p>
-                      <a:r>
-                        <a:rPr sz="1100" b="0">
-                          <a:solidFill>
-                            <a:srgbClr val="282828"/>
-                          </a:solidFill>
-                          <a:latin typeface="Arial"/>
-                        </a:rPr>
-                        <a:t>2.8 / 3.3 px rms spectral blur at 2500 nm (Offner / Dyson)</a:t>
-                      </a:r>
-                    </a:p>
-                  </a:txBody>
-                  <a:tcPr marL="54864" marR="54864" marT="18288" marB="18288">
-                    <a:solidFill>
-                      <a:srgbClr val="FFFFFF"/>
-                    </a:solidFill>
-                  </a:tcPr>
-                </a:tc>
-                <a:tc>
-                  <a:txBody>
-                    <a:bodyPr wrap="square"/>
-                    <a:lstStyle/>
-                    <a:p>
-                      <a:r>
-                        <a:rPr sz="1100" b="0">
-                          <a:solidFill>
-                            <a:srgbClr val="282828"/>
-                          </a:solidFill>
-                          <a:latin typeface="Arial"/>
-                        </a:rPr>
-                        <a:t>the local grating vector is the un-normalised projection of the ruling direction (chord-ruled)</a:t>
-                      </a:r>
-                    </a:p>
-                  </a:txBody>
-                  <a:tcPr marL="54864" marR="54864" marT="18288" marB="18288">
-                    <a:solidFill>
-                      <a:srgbClr val="FFFFFF"/>
-                    </a:solidFill>
-                  </a:tcPr>
-                </a:tc>
-                <a:tc>
-                  <a:txBody>
-                    <a:bodyPr wrap="square"/>
-                    <a:lstStyle/>
-                    <a:p>
-                      <a:r>
-                        <a:rPr sz="1100" b="0">
-                          <a:solidFill>
-                            <a:srgbClr val="282828"/>
-                          </a:solidFill>
-                          <a:latin typeface="Arial"/>
-                        </a:rPr>
-                        <a:t>tGratingImmersed (4), test_grating_chord</a:t>
+              <a:tr h="280035">
+                <a:tc>
+                  <a:txBody>
+                    <a:bodyPr wrap="square"/>
+                    <a:lstStyle/>
+                    <a:p>
+                      <a:r>
+                        <a:rPr sz="1100" b="0">
+                          <a:solidFill>
+                            <a:srgbClr val="282828"/>
+                          </a:solidFill>
+                          <a:latin typeface="Arial"/>
+                        </a:rPr>
+                        <a:t>smile, keystone</a:t>
+                      </a:r>
+                    </a:p>
+                  </a:txBody>
+                  <a:tcPr marL="54864" marR="54864" marT="18288" marB="18288">
+                    <a:solidFill>
+                      <a:srgbClr val="FFFFFF"/>
+                    </a:solidFill>
+                  </a:tcPr>
+                </a:tc>
+                <a:tc>
+                  <a:txBody>
+                    <a:bodyPr wrap="square"/>
+                    <a:lstStyle/>
+                    <a:p>
+                      <a:r>
+                        <a:rPr sz="1100" b="0">
+                          <a:solidFill>
+                            <a:srgbClr val="282828"/>
+                          </a:solidFill>
+                          <a:latin typeface="Arial"/>
+                        </a:rPr>
+                        <a:t>&lt; 0.1 pixel</a:t>
+                      </a:r>
+                    </a:p>
+                  </a:txBody>
+                  <a:tcPr marL="54864" marR="54864" marT="18288" marB="18288">
+                    <a:solidFill>
+                      <a:srgbClr val="FFFFFF"/>
+                    </a:solidFill>
+                  </a:tcPr>
+                </a:tc>
+              </a:tr>
+              <a:tr h="280035">
+                <a:tc>
+                  <a:txBody>
+                    <a:bodyPr wrap="square"/>
+                    <a:lstStyle/>
+                    <a:p>
+                      <a:r>
+                        <a:rPr sz="1100" b="0">
+                          <a:solidFill>
+                            <a:srgbClr val="282828"/>
+                          </a:solidFill>
+                          <a:latin typeface="Arial"/>
+                        </a:rPr>
+                        <a:t>SRF FWHM</a:t>
+                      </a:r>
+                    </a:p>
+                  </a:txBody>
+                  <a:tcPr marL="54864" marR="54864" marT="18288" marB="18288">
+                    <a:solidFill>
+                      <a:srgbClr val="ECF1F6"/>
+                    </a:solidFill>
+                  </a:tcPr>
+                </a:tc>
+                <a:tc>
+                  <a:txBody>
+                    <a:bodyPr wrap="square"/>
+                    <a:lstStyle/>
+                    <a:p>
+                      <a:r>
+                        <a:rPr sz="1100" b="0">
+                          <a:solidFill>
+                            <a:srgbClr val="282828"/>
+                          </a:solidFill>
+                          <a:latin typeface="Arial"/>
+                        </a:rPr>
+                        <a:t>&lt; 1.5–2.0 pixels</a:t>
+                      </a:r>
+                    </a:p>
+                  </a:txBody>
+                  <a:tcPr marL="54864" marR="54864" marT="18288" marB="18288">
+                    <a:solidFill>
+                      <a:srgbClr val="ECF1F6"/>
+                    </a:solidFill>
+                  </a:tcPr>
+                </a:tc>
+              </a:tr>
+              <a:tr h="280035">
+                <a:tc>
+                  <a:txBody>
+                    <a:bodyPr wrap="square"/>
+                    <a:lstStyle/>
+                    <a:p>
+                      <a:r>
+                        <a:rPr sz="1100" b="0">
+                          <a:solidFill>
+                            <a:srgbClr val="282828"/>
+                          </a:solidFill>
+                          <a:latin typeface="Arial"/>
+                        </a:rPr>
+                        <a:t>CRF FWHM</a:t>
+                      </a:r>
+                    </a:p>
+                  </a:txBody>
+                  <a:tcPr marL="54864" marR="54864" marT="18288" marB="18288">
+                    <a:solidFill>
+                      <a:srgbClr val="FFFFFF"/>
+                    </a:solidFill>
+                  </a:tcPr>
+                </a:tc>
+                <a:tc>
+                  <a:txBody>
+                    <a:bodyPr wrap="square"/>
+                    <a:lstStyle/>
+                    <a:p>
+                      <a:r>
+                        <a:rPr sz="1100" b="0">
+                          <a:solidFill>
+                            <a:srgbClr val="282828"/>
+                          </a:solidFill>
+                          <a:latin typeface="Arial"/>
+                        </a:rPr>
+                        <a:t>&lt; 1.5 pixels</a:t>
                       </a:r>
                     </a:p>
                   </a:txBody>
@@ -14999,7 +15541,7 @@
                           </a:solidFill>
                           <a:latin typeface="Arial"/>
                         </a:rPr>
-                        <a:t>grating path-length jump</a:t>
+                        <a:t>radiometric chain</a:t>
                       </a:r>
                     </a:p>
                   </a:txBody>
@@ -15021,231 +15563,7 @@
                           </a:solidFill>
                           <a:latin typeface="Arial"/>
                         </a:rPr>
-                        <a:t>4 waves rms of pupil OPD where the rays converged to 0.05 µm</a:t>
-                      </a:r>
-                    </a:p>
-                  </a:txBody>
-                  <a:tcPr marL="54864" marR="54864" marT="18288" marB="18288">
-                    <a:solidFill>
-                      <a:srgbClr val="ECF1F6"/>
-                    </a:solidFill>
-                  </a:tcPr>
-                </a:tc>
-                <a:tc>
-                  <a:txBody>
-                    <a:bodyPr wrap="square"/>
-                    <a:lstStyle/>
-                    <a:p>
-                      <a:r>
-                        <a:rPr sz="1100" b="0">
-                          <a:solidFill>
-                            <a:srgbClr val="282828"/>
-                          </a:solidFill>
-                          <a:latin typeface="Arial"/>
-                        </a:rPr>
-                        <a:t>the jump is the groove count from the vertex along the ruling direction</a:t>
-                      </a:r>
-                    </a:p>
-                  </a:txBody>
-                  <a:tcPr marL="54864" marR="54864" marT="18288" marB="18288">
-                    <a:solidFill>
-                      <a:srgbClr val="ECF1F6"/>
-                    </a:solidFill>
-                  </a:tcPr>
-                </a:tc>
-                <a:tc>
-                  <a:txBody>
-                    <a:bodyPr wrap="square"/>
-                    <a:lstStyle/>
-                    <a:p>
-                      <a:r>
-                        <a:rPr sz="1100" b="0">
-                          <a:solidFill>
-                            <a:srgbClr val="282828"/>
-                          </a:solidFill>
-                          <a:latin typeface="Arial"/>
-                        </a:rPr>
-                        <a:t>tGratingOpl (2)</a:t>
-                      </a:r>
-                    </a:p>
-                  </a:txBody>
-                  <a:tcPr marL="54864" marR="54864" marT="18288" marB="18288">
-                    <a:solidFill>
-                      <a:srgbClr val="ECF1F6"/>
-                    </a:solidFill>
-                  </a:tcPr>
-                </a:tc>
-              </a:tr>
-              <a:tr h="657225">
-                <a:tc>
-                  <a:txBody>
-                    <a:bodyPr wrap="square"/>
-                    <a:lstStyle/>
-                    <a:p>
-                      <a:r>
-                        <a:rPr sz="1100" b="0">
-                          <a:solidFill>
-                            <a:srgbClr val="282828"/>
-                          </a:solidFill>
-                          <a:latin typeface="Arial"/>
-                        </a:rPr>
-                        <a:t>optimizer derivative stride</a:t>
-                      </a:r>
-                    </a:p>
-                  </a:txBody>
-                  <a:tcPr marL="54864" marR="54864" marT="18288" marB="18288">
-                    <a:solidFill>
-                      <a:srgbClr val="FFFFFF"/>
-                    </a:solidFill>
-                  </a:tcPr>
-                </a:tc>
-                <a:tc>
-                  <a:txBody>
-                    <a:bodyPr wrap="square"/>
-                    <a:lstStyle/>
-                    <a:p>
-                      <a:r>
-                        <a:rPr sz="1100" b="0">
-                          <a:solidFill>
-                            <a:srgbClr val="282828"/>
-                          </a:solidFill>
-                          <a:latin typeface="Arial"/>
-                        </a:rPr>
-                        <a:t>a spot-size optimisation over several fields overwrote memory on its second field (the derivative columns advanced by the wavefront's size, not the objective's) and crashed or hung the host</a:t>
-                      </a:r>
-                    </a:p>
-                  </a:txBody>
-                  <a:tcPr marL="54864" marR="54864" marT="18288" marB="18288">
-                    <a:solidFill>
-                      <a:srgbClr val="FFFFFF"/>
-                    </a:solidFill>
-                  </a:tcPr>
-                </a:tc>
-                <a:tc>
-                  <a:txBody>
-                    <a:bodyPr wrap="square"/>
-                    <a:lstStyle/>
-                    <a:p>
-                      <a:r>
-                        <a:rPr sz="1100" b="0">
-                          <a:solidFill>
-                            <a:srgbClr val="282828"/>
-                          </a:solidFill>
-                          <a:latin typeface="Arial"/>
-                        </a:rPr>
-                        <a:t>advance by the objective's size, as the value loop does</a:t>
-                      </a:r>
-                    </a:p>
-                  </a:txBody>
-                  <a:tcPr marL="54864" marR="54864" marT="18288" marB="18288">
-                    <a:solidFill>
-                      <a:srgbClr val="FFFFFF"/>
-                    </a:solidFill>
-                  </a:tcPr>
-                </a:tc>
-                <a:tc>
-                  <a:txBody>
-                    <a:bodyPr wrap="square"/>
-                    <a:lstStyle/>
-                    <a:p>
-                      <a:r>
-                        <a:rPr sz="1100" b="0">
-                          <a:solidFill>
-                            <a:srgbClr val="282828"/>
-                          </a:solidFill>
-                          <a:latin typeface="Arial"/>
-                        </a:rPr>
-                        <a:t>tSpectrometerRx native leg, tDesignTelescope (70, unchanged)</a:t>
-                      </a:r>
-                    </a:p>
-                  </a:txBody>
-                  <a:tcPr marL="54864" marR="54864" marT="18288" marB="18288">
-                    <a:solidFill>
-                      <a:srgbClr val="FFFFFF"/>
-                    </a:solidFill>
-                  </a:tcPr>
-                </a:tc>
-              </a:tr>
-              <a:tr h="657225">
-                <a:tc>
-                  <a:txBody>
-                    <a:bodyPr wrap="square"/>
-                    <a:lstStyle/>
-                    <a:p>
-                      <a:r>
-                        <a:rPr sz="1100" b="0">
-                          <a:solidFill>
-                            <a:srgbClr val="282828"/>
-                          </a:solidFill>
-                          <a:latin typeface="Arial"/>
-                        </a:rPr>
-                        <a:t>optimizer asphere step and failure exit</a:t>
-                      </a:r>
-                    </a:p>
-                  </a:txBody>
-                  <a:tcPr marL="54864" marR="54864" marT="18288" marB="18288">
-                    <a:solidFill>
-                      <a:srgbClr val="ECF1F6"/>
-                    </a:solidFill>
-                  </a:tcPr>
-                </a:tc>
-                <a:tc>
-                  <a:txBody>
-                    <a:bodyPr wrap="square"/>
-                    <a:lstStyle/>
-                    <a:p>
-                      <a:r>
-                        <a:rPr sz="1100" b="0">
-                          <a:solidFill>
-                            <a:srgbClr val="282828"/>
-                          </a:solidFill>
-                          <a:latin typeface="Arial"/>
-                        </a:rPr>
-                        <a:t>an aspheric coefficient was probed by a fixed 1e-10, round-off on a deck in metres: a zero derivative column, a singular matrix at the first step, and a stop on that path that ended the MATLAB process</a:t>
-                      </a:r>
-                    </a:p>
-                  </a:txBody>
-                  <a:tcPr marL="54864" marR="54864" marT="18288" marB="18288">
-                    <a:solidFill>
-                      <a:srgbClr val="ECF1F6"/>
-                    </a:solidFill>
-                  </a:tcPr>
-                </a:tc>
-                <a:tc>
-                  <a:txBody>
-                    <a:bodyPr wrap="square"/>
-                    <a:lstStyle/>
-                    <a:p>
-                      <a:r>
-                        <a:rPr sz="1100" b="0">
-                          <a:solidFill>
-                            <a:srgbClr val="282828"/>
-                          </a:solidFill>
-                          <a:latin typeface="Arial"/>
-                        </a:rPr>
-                        <a:t>the step is 1e-3 of the coefficient (sag-based for a zero one); the failure restores the optics and returns a flag</a:t>
-                      </a:r>
-                    </a:p>
-                  </a:txBody>
-                  <a:tcPr marL="54864" marR="54864" marT="18288" marB="18288">
-                    <a:solidFill>
-                      <a:srgbClr val="ECF1F6"/>
-                    </a:solidFill>
-                  </a:tcPr>
-                </a:tc>
-                <a:tc>
-                  <a:txBody>
-                    <a:bodyPr wrap="square"/>
-                    <a:lstStyle/>
-                    <a:p>
-                      <a:r>
-                        <a:rPr sz="1100" b="0">
-                          <a:solidFill>
-                            <a:srgbClr val="282828"/>
-                          </a:solidFill>
-                          <a:latin typeface="Arial"/>
-                        </a:rPr>
-                        <a:t>tAsphCalib (2): a spoiled paraboloid driven back to zero; the failure path with the host alive</a:t>
+                        <a:t>throughput, grating efficiency, QE, slit loss vs wavelength</a:t>
                       </a:r>
                     </a:p>
                   </a:txBody>
@@ -15268,8 +15586,8 @@
         </p:nvSpPr>
         <p:spPr>
           <a:xfrm>
-            <a:off x="411480" y="5290947"/>
-            <a:ext cx="11368735" cy="274320"/>
+            <a:off x="6400800" y="1298448"/>
+            <a:ext cx="5394960" cy="274320"/>
           </a:xfrm>
           <a:prstGeom prst="rect">
             <a:avLst/>
@@ -15288,13 +15606,100 @@
               </a:spcAft>
             </a:pPr>
             <a:r>
+              <a:rPr sz="1200" b="0">
+                <a:solidFill>
+                  <a:srgbClr val="282828"/>
+                </a:solidFill>
+                <a:latin typeface="Arial"/>
+              </a:rPr>
+              <a:t>•  Smile: centroid drift along the slit at fixed wavelength; keystone: drift across wavelength at fixed slit position; both in pixels from ray centroids.</a:t>
+            </a:r>
+          </a:p>
+          <a:p>
+            <a:pPr>
+              <a:spcAft>
+                <a:spcPts val="600"/>
+              </a:spcAft>
+            </a:pPr>
+            <a:r>
+              <a:rPr sz="1200" b="0">
+                <a:solidFill>
+                  <a:srgbClr val="282828"/>
+                </a:solidFill>
+                <a:latin typeface="Arial"/>
+              </a:rPr>
+              <a:t>•  SRF, CRF: slit ⊗ line-spread function ⊗ pixel ⊗ Airy, FWHM in pixels (Mouroulis &amp; Green 2018 definitions); the Airy diameter at 2500 nm is 11 µm, under the 18 µm pixel, so the incoherent chain is valid.</a:t>
+            </a:r>
+          </a:p>
+          <a:p>
+            <a:pPr>
+              <a:spcAft>
+                <a:spcPts val="600"/>
+              </a:spcAft>
+            </a:pPr>
+            <a:r>
+              <a:rPr sz="1200" b="0">
+                <a:solidFill>
+                  <a:srgbClr val="282828"/>
+                </a:solidFill>
+                <a:latin typeface="Arial"/>
+              </a:rPr>
+              <a:t>•  Design rules adopted from the literature: distortion to ~1 % of a pixel at design, &gt; 75 % of the energy in one pixel, degraded spots accepted for uniformity, the grating is the stop.</a:t>
+            </a:r>
+          </a:p>
+          <a:p>
+            <a:pPr>
+              <a:spcAft>
+                <a:spcPts val="600"/>
+              </a:spcAft>
+            </a:pPr>
+            <a:r>
+              <a:rPr sz="1200" b="0">
+                <a:solidFill>
+                  <a:srgbClr val="282828"/>
+                </a:solidFill>
+                <a:latin typeface="Arial"/>
+              </a:rPr>
+              <a:t>•  Realism (Jim): as-built SRF is 2.5–3 pixels, slits are 2 pixels wide, the systems are photon-limited; smile and keystone drive the design.</a:t>
+            </a:r>
+          </a:p>
+        </p:txBody>
+      </p:sp>
+      <p:sp>
+        <p:nvSpPr>
+          <p:cNvPr id="6" name="TextBox 5"/>
+          <p:cNvSpPr txBox="1"/>
+          <p:nvPr/>
+        </p:nvSpPr>
+        <p:spPr>
+          <a:xfrm>
+            <a:off x="6400800" y="4075175"/>
+            <a:ext cx="5394960" cy="274320"/>
+          </a:xfrm>
+          <a:prstGeom prst="rect">
+            <a:avLst/>
+          </a:prstGeom>
+          <a:noFill/>
+        </p:spPr>
+        <p:txBody>
+          <a:bodyPr wrap="square">
+            <a:spAutoFit/>
+          </a:bodyPr>
+          <a:lstStyle/>
+          <a:p>
+            <a:pPr>
+              <a:spcAft>
+                <a:spcPts val="600"/>
+              </a:spcAft>
+            </a:pPr>
+            <a:r>
               <a:rPr sz="1050" b="0">
                 <a:solidFill>
                   <a:srgbClr val="6E6E6E"/>
                 </a:solidFill>
                 <a:latin typeface="Arial"/>
               </a:rPr>
-              <a:t>Flat gratings are unchanged by the grating fixes; the wavefront-target optimizer, which every telescope design used, was never affected by the fifth.  A seventh item, a short AsphCoef= line killing the host process, now pads with zero and warns (tRxShortAsph).</a:t>
+              <a:t>The 54 mm slit is 2.3× EMIT's; Table 3 of the review places this spec in the ALIS class (3200 spatial pixels, 380–2500 nm).  Public comparison point: Carbon-I (arXiv:2505.22545), F/2.2, 2040–2380 nm.</a:t>
             </a:r>
           </a:p>
         </p:txBody>
@@ -15307,7 +15712,7 @@
 </p:sld>
 </file>
 
-<file path=ppt/slides/slide29.xml><?xml version="1.0" encoding="utf-8"?>
+<file path=ppt/slides/slide30.xml><?xml version="1.0" encoding="utf-8"?>
 <p:sld xmlns:a="http://schemas.openxmlformats.org/drawingml/2006/main" xmlns:p="http://schemas.openxmlformats.org/presentationml/2006/main" xmlns:r="http://schemas.openxmlformats.org/officeDocument/2006/relationships">
   <p:cSld>
     <p:spTree>
@@ -15351,7 +15756,7 @@
                 </a:solidFill>
                 <a:latin typeface="Arial"/>
               </a:rPr>
-              <a:t>Backup: records and tools behind each slide</a:t>
+              <a:t>Backup: six engine findings, each with a regression test</a:t>
             </a:r>
           </a:p>
           <a:p>
@@ -15367,7 +15772,7 @@
                 </a:solidFill>
                 <a:latin typeface="Arial"/>
               </a:rPr>
-              <a:t>Every number traces to a runner stage and its record file</a:t>
+              <a:t>Found by the challenge's checks on 2026-09-30 and 10-01, fixed in the engine the same day</a:t>
             </a:r>
           </a:p>
         </p:txBody>
@@ -15426,7 +15831,7 @@
         </p:nvGraphicFramePr>
         <p:xfrm>
           <a:off x="411480" y="1298448"/>
-          <a:ext cx="11368734" cy="4491990"/>
+          <a:ext cx="11368733" cy="3846195"/>
         </p:xfrm>
         <a:graphic>
           <a:graphicData uri="http://schemas.openxmlformats.org/drawingml/2006/table">
@@ -15435,10 +15840,10 @@
                 <a:tableStyleId>{5C22544A-7EE6-4342-B048-85BDC9FD1C3A}</a:tableStyleId>
               </a:tblPr>
               <a:tblGrid>
-                <a:gridCol w="2107692"/>
-                <a:gridCol w="1817116"/>
-                <a:gridCol w="4549066"/>
-                <a:gridCol w="2894860"/>
+                <a:gridCol w="991903"/>
+                <a:gridCol w="5086682"/>
+                <a:gridCol w="2899408"/>
+                <a:gridCol w="2390740"/>
               </a:tblGrid>
               <a:tr h="280035">
                 <a:tc>
@@ -15453,7 +15858,7 @@
                           </a:solidFill>
                           <a:latin typeface="Arial"/>
                         </a:rPr>
-                        <a:t>slide</a:t>
+                        <a:t>finding</a:t>
                       </a:r>
                     </a:p>
                   </a:txBody>
@@ -15475,7 +15880,7 @@
                           </a:solidFill>
                           <a:latin typeface="Arial"/>
                         </a:rPr>
-                        <a:t>runner stage</a:t>
+                        <a:t>symptom</a:t>
                       </a:r>
                     </a:p>
                   </a:txBody>
@@ -15497,7 +15902,7 @@
                           </a:solidFill>
                           <a:latin typeface="Arial"/>
                         </a:rPr>
-                        <a:t>record</a:t>
+                        <a:t>fix</a:t>
                       </a:r>
                     </a:p>
                   </a:txBody>
@@ -15519,7 +15924,7 @@
                           </a:solidFill>
                           <a:latin typeface="Arial"/>
                         </a:rPr>
-                        <a:t>tool</a:t>
+                        <a:t>test</a:t>
                       </a:r>
                     </a:p>
                   </a:txBody>
@@ -15543,73 +15948,73 @@
                           </a:solidFill>
                           <a:latin typeface="Arial"/>
                         </a:rPr>
-                        <a:t>scaling law</a:t>
-                      </a:r>
-                    </a:p>
-                  </a:txBody>
-                  <a:tcPr marL="54864" marR="54864" marT="18288" marB="18288">
-                    <a:solidFill>
-                      <a:srgbClr val="FFFFFF"/>
-                    </a:solidFill>
-                  </a:tcPr>
-                </a:tc>
-                <a:tc>
-                  <a:txBody>
-                    <a:bodyPr wrap="square"/>
-                    <a:lstStyle/>
-                    <a:p>
-                      <a:r>
-                        <a:rPr sz="1100" b="0">
-                          <a:solidFill>
-                            <a:srgbClr val="282828"/>
-                          </a:solidFill>
-                          <a:latin typeface="Arial"/>
-                        </a:rPr>
-                        <a:t>s0 (engine-free)</a:t>
-                      </a:r>
-                    </a:p>
-                  </a:txBody>
-                  <a:tcPr marL="54864" marR="54864" marT="18288" marB="18288">
-                    <a:solidFill>
-                      <a:srgbClr val="FFFFFF"/>
-                    </a:solidFill>
-                  </a:tcPr>
-                </a:tc>
-                <a:tc>
-                  <a:txBody>
-                    <a:bodyPr wrap="square"/>
-                    <a:lstStyle/>
-                    <a:p>
-                      <a:r>
-                        <a:rPr sz="1100" b="0">
-                          <a:solidFill>
-                            <a:srgbClr val="282828"/>
-                          </a:solidFill>
-                          <a:latin typeface="Arial"/>
-                        </a:rPr>
-                        <a:t>dyson5_s0_scaling.txt</a:t>
-                      </a:r>
-                    </a:p>
-                  </a:txBody>
-                  <a:tcPr marL="54864" marR="54864" marT="18288" marB="18288">
-                    <a:solidFill>
-                      <a:srgbClr val="FFFFFF"/>
-                    </a:solidFill>
-                  </a:tcPr>
-                </a:tc>
-                <a:tc>
-                  <a:txBody>
-                    <a:bodyPr wrap="square"/>
-                    <a:lstStyle/>
-                    <a:p>
-                      <a:r>
-                        <a:rPr sz="1100" b="0">
-                          <a:solidFill>
-                            <a:srgbClr val="282828"/>
-                          </a:solidFill>
-                          <a:latin typeface="Arial"/>
-                        </a:rPr>
-                        <a:t>design/src/dyson_layout.m, dyson_scaling.m</a:t>
+                        <a:t>glass names ignored at load</a:t>
+                      </a:r>
+                    </a:p>
+                  </a:txBody>
+                  <a:tcPr marL="54864" marR="54864" marT="18288" marB="18288">
+                    <a:solidFill>
+                      <a:srgbClr val="FFFFFF"/>
+                    </a:solidFill>
+                  </a:tcPr>
+                </a:tc>
+                <a:tc>
+                  <a:txBody>
+                    <a:bodyPr wrap="square"/>
+                    <a:lstStyle/>
+                    <a:p>
+                      <a:r>
+                        <a:rPr sz="1100" b="0">
+                          <a:solidFill>
+                            <a:srgbClr val="282828"/>
+                          </a:solidFill>
+                          <a:latin typeface="Arial"/>
+                        </a:rPr>
+                        <a:t>a GlassElt= Silica element traced as air in every binding</a:t>
+                      </a:r>
+                    </a:p>
+                  </a:txBody>
+                  <a:tcPr marL="54864" marR="54864" marT="18288" marB="18288">
+                    <a:solidFill>
+                      <a:srgbClr val="FFFFFF"/>
+                    </a:solidFill>
+                  </a:tcPr>
+                </a:tc>
+                <a:tc>
+                  <a:txBody>
+                    <a:bodyPr wrap="square"/>
+                    <a:lstStyle/>
+                    <a:p>
+                      <a:r>
+                        <a:rPr sz="1100" b="0">
+                          <a:solidFill>
+                            <a:srgbClr val="282828"/>
+                          </a:solidFill>
+                          <a:latin typeface="Arial"/>
+                        </a:rPr>
+                        <a:t>the glass catalog is blanked once at allocation, not on every load</a:t>
+                      </a:r>
+                    </a:p>
+                  </a:txBody>
+                  <a:tcPr marL="54864" marR="54864" marT="18288" marB="18288">
+                    <a:solidFill>
+                      <a:srgbClr val="FFFFFF"/>
+                    </a:solidFill>
+                  </a:tcPr>
+                </a:tc>
+                <a:tc>
+                  <a:txBody>
+                    <a:bodyPr wrap="square"/>
+                    <a:lstStyle/>
+                    <a:p>
+                      <a:r>
+                        <a:rPr sz="1100" b="0">
+                          <a:solidFill>
+                            <a:srgbClr val="282828"/>
+                          </a:solidFill>
+                          <a:latin typeface="Arial"/>
+                        </a:rPr>
+                        <a:t>tGlassDispersion (3)</a:t>
                       </a:r>
                     </a:p>
                   </a:txBody>
@@ -15620,20 +16025,20 @@
                   </a:tcPr>
                 </a:tc>
               </a:tr>
-              <a:tr h="280035">
-                <a:tc>
-                  <a:txBody>
-                    <a:bodyPr wrap="square"/>
-                    <a:lstStyle/>
-                    <a:p>
-                      <a:r>
-                        <a:rPr sz="1100" b="0">
-                          <a:solidFill>
-                            <a:srgbClr val="282828"/>
-                          </a:solidFill>
-                          <a:latin typeface="Arial"/>
-                        </a:rPr>
-                        <a:t>as traced (every form)</a:t>
+              <a:tr h="657225">
+                <a:tc>
+                  <a:txBody>
+                    <a:bodyPr wrap="square"/>
+                    <a:lstStyle/>
+                    <a:p>
+                      <a:r>
+                        <a:rPr sz="1100" b="0">
+                          <a:solidFill>
+                            <a:srgbClr val="282828"/>
+                          </a:solidFill>
+                          <a:latin typeface="Arial"/>
+                        </a:rPr>
+                        <a:t>vacuum wavelength inside glass</a:t>
                       </a:r>
                     </a:p>
                   </a:txBody>
@@ -15655,7 +16060,7 @@
                           </a:solidFill>
                           <a:latin typeface="Arial"/>
                         </a:rPr>
-                        <a:t>dyson5_view_figs.m</a:t>
+                        <a:t>a propagation leg in a medium ran at the wrong Fresnel number by n</a:t>
                       </a:r>
                     </a:p>
                   </a:txBody>
@@ -15677,7 +16082,7 @@
                           </a:solidFill>
                           <a:latin typeface="Arial"/>
                         </a:rPr>
-                        <a:t>_view3d.png, _viewyz.png</a:t>
+                        <a:t>every kernel takes λ/n of the leg's medium</a:t>
                       </a:r>
                     </a:p>
                   </a:txBody>
@@ -15699,13 +16104,103 @@
                           </a:solidFill>
                           <a:latin typeface="Arial"/>
                         </a:rPr>
-                        <a:t>macos.view_rx on the deck</a:t>
+                        <a:t>tPropMedium (3): z in n ≡ z/n in vacuum</a:t>
                       </a:r>
                     </a:p>
                   </a:txBody>
                   <a:tcPr marL="54864" marR="54864" marT="18288" marB="18288">
                     <a:solidFill>
                       <a:srgbClr val="ECF1F6"/>
+                    </a:solidFill>
+                  </a:tcPr>
+                </a:tc>
+              </a:tr>
+              <a:tr h="657225">
+                <a:tc>
+                  <a:txBody>
+                    <a:bodyPr wrap="square"/>
+                    <a:lstStyle/>
+                    <a:p>
+                      <a:r>
+                        <a:rPr sz="1100" b="0">
+                          <a:solidFill>
+                            <a:srgbClr val="282828"/>
+                          </a:solidFill>
+                          <a:latin typeface="Arial"/>
+                        </a:rPr>
+                        <a:t>groove period along the surface</a:t>
+                      </a:r>
+                    </a:p>
+                  </a:txBody>
+                  <a:tcPr marL="54864" marR="54864" marT="18288" marB="18288">
+                    <a:solidFill>
+                      <a:srgbClr val="FFFFFF"/>
+                    </a:solidFill>
+                  </a:tcPr>
+                </a:tc>
+                <a:tc>
+                  <a:txBody>
+                    <a:bodyPr wrap="square"/>
+                    <a:lstStyle/>
+                    <a:p>
+                      <a:r>
+                        <a:rPr sz="1100" b="0">
+                          <a:solidFill>
+                            <a:srgbClr val="282828"/>
+                          </a:solidFill>
+                          <a:latin typeface="Arial"/>
+                        </a:rPr>
+                        <a:t>2.8 / 3.3 px rms spectral blur at 2500 nm (Offner / Dyson)</a:t>
+                      </a:r>
+                    </a:p>
+                  </a:txBody>
+                  <a:tcPr marL="54864" marR="54864" marT="18288" marB="18288">
+                    <a:solidFill>
+                      <a:srgbClr val="FFFFFF"/>
+                    </a:solidFill>
+                  </a:tcPr>
+                </a:tc>
+                <a:tc>
+                  <a:txBody>
+                    <a:bodyPr wrap="square"/>
+                    <a:lstStyle/>
+                    <a:p>
+                      <a:r>
+                        <a:rPr sz="1100" b="0">
+                          <a:solidFill>
+                            <a:srgbClr val="282828"/>
+                          </a:solidFill>
+                          <a:latin typeface="Arial"/>
+                        </a:rPr>
+                        <a:t>the local grating vector is the un-normalised projection of the ruling direction (chord-ruled)</a:t>
+                      </a:r>
+                    </a:p>
+                  </a:txBody>
+                  <a:tcPr marL="54864" marR="54864" marT="18288" marB="18288">
+                    <a:solidFill>
+                      <a:srgbClr val="FFFFFF"/>
+                    </a:solidFill>
+                  </a:tcPr>
+                </a:tc>
+                <a:tc>
+                  <a:txBody>
+                    <a:bodyPr wrap="square"/>
+                    <a:lstStyle/>
+                    <a:p>
+                      <a:r>
+                        <a:rPr sz="1100" b="0">
+                          <a:solidFill>
+                            <a:srgbClr val="282828"/>
+                          </a:solidFill>
+                          <a:latin typeface="Arial"/>
+                        </a:rPr>
+                        <a:t>tGratingImmersed (4), test_grating_chord</a:t>
+                      </a:r>
+                    </a:p>
+                  </a:txBody>
+                  <a:tcPr marL="54864" marR="54864" marT="18288" marB="18288">
+                    <a:solidFill>
+                      <a:srgbClr val="FFFFFF"/>
                     </a:solidFill>
                   </a:tcPr>
                 </a:tc>
@@ -15723,97 +16218,187 @@
                           </a:solidFill>
                           <a:latin typeface="Arial"/>
                         </a:rPr>
-                        <a:t>seed scored</a:t>
-                      </a:r>
-                    </a:p>
-                  </a:txBody>
-                  <a:tcPr marL="54864" marR="54864" marT="18288" marB="18288">
-                    <a:solidFill>
-                      <a:srgbClr val="FFFFFF"/>
-                    </a:solidFill>
-                  </a:tcPr>
-                </a:tc>
-                <a:tc>
-                  <a:txBody>
-                    <a:bodyPr wrap="square"/>
-                    <a:lstStyle/>
-                    <a:p>
-                      <a:r>
-                        <a:rPr sz="1100" b="0">
-                          <a:solidFill>
-                            <a:srgbClr val="282828"/>
-                          </a:solidFill>
-                          <a:latin typeface="Arial"/>
-                        </a:rPr>
-                        <a:t>s1 emit, s2 score</a:t>
-                      </a:r>
-                    </a:p>
-                  </a:txBody>
-                  <a:tcPr marL="54864" marR="54864" marT="18288" marB="18288">
-                    <a:solidFill>
-                      <a:srgbClr val="FFFFFF"/>
-                    </a:solidFill>
-                  </a:tcPr>
-                </a:tc>
-                <a:tc>
-                  <a:txBody>
-                    <a:bodyPr wrap="square"/>
-                    <a:lstStyle/>
-                    <a:p>
-                      <a:r>
-                        <a:rPr sz="1100" b="0">
-                          <a:solidFill>
-                            <a:srgbClr val="282828"/>
-                          </a:solidFill>
-                          <a:latin typeface="Arial"/>
-                        </a:rPr>
-                        <a:t>dyson5_s1.txt, dyson5_s2.txt, dyson5_s2_maps.png</a:t>
-                      </a:r>
-                    </a:p>
-                  </a:txBody>
-                  <a:tcPr marL="54864" marR="54864" marT="18288" marB="18288">
-                    <a:solidFill>
-                      <a:srgbClr val="FFFFFF"/>
-                    </a:solidFill>
-                  </a:tcPr>
-                </a:tc>
-                <a:tc>
-                  <a:txBody>
-                    <a:bodyPr wrap="square"/>
-                    <a:lstStyle/>
-                    <a:p>
-                      <a:r>
-                        <a:rPr sz="1100" b="0">
-                          <a:solidFill>
-                            <a:srgbClr val="282828"/>
-                          </a:solidFill>
-                          <a:latin typeface="Arial"/>
-                        </a:rPr>
-                        <a:t>spectrometer_geom.m, spectrometer_rx.m, spectrometer_score.m</a:t>
-                      </a:r>
-                    </a:p>
-                  </a:txBody>
-                  <a:tcPr marL="54864" marR="54864" marT="18288" marB="18288">
-                    <a:solidFill>
-                      <a:srgbClr val="FFFFFF"/>
+                        <a:t>grating path-length jump</a:t>
+                      </a:r>
+                    </a:p>
+                  </a:txBody>
+                  <a:tcPr marL="54864" marR="54864" marT="18288" marB="18288">
+                    <a:solidFill>
+                      <a:srgbClr val="ECF1F6"/>
+                    </a:solidFill>
+                  </a:tcPr>
+                </a:tc>
+                <a:tc>
+                  <a:txBody>
+                    <a:bodyPr wrap="square"/>
+                    <a:lstStyle/>
+                    <a:p>
+                      <a:r>
+                        <a:rPr sz="1100" b="0">
+                          <a:solidFill>
+                            <a:srgbClr val="282828"/>
+                          </a:solidFill>
+                          <a:latin typeface="Arial"/>
+                        </a:rPr>
+                        <a:t>4 waves rms of pupil OPD where the rays converged to 0.05 µm</a:t>
+                      </a:r>
+                    </a:p>
+                  </a:txBody>
+                  <a:tcPr marL="54864" marR="54864" marT="18288" marB="18288">
+                    <a:solidFill>
+                      <a:srgbClr val="ECF1F6"/>
+                    </a:solidFill>
+                  </a:tcPr>
+                </a:tc>
+                <a:tc>
+                  <a:txBody>
+                    <a:bodyPr wrap="square"/>
+                    <a:lstStyle/>
+                    <a:p>
+                      <a:r>
+                        <a:rPr sz="1100" b="0">
+                          <a:solidFill>
+                            <a:srgbClr val="282828"/>
+                          </a:solidFill>
+                          <a:latin typeface="Arial"/>
+                        </a:rPr>
+                        <a:t>the jump is the groove count from the vertex along the ruling direction</a:t>
+                      </a:r>
+                    </a:p>
+                  </a:txBody>
+                  <a:tcPr marL="54864" marR="54864" marT="18288" marB="18288">
+                    <a:solidFill>
+                      <a:srgbClr val="ECF1F6"/>
+                    </a:solidFill>
+                  </a:tcPr>
+                </a:tc>
+                <a:tc>
+                  <a:txBody>
+                    <a:bodyPr wrap="square"/>
+                    <a:lstStyle/>
+                    <a:p>
+                      <a:r>
+                        <a:rPr sz="1100" b="0">
+                          <a:solidFill>
+                            <a:srgbClr val="282828"/>
+                          </a:solidFill>
+                          <a:latin typeface="Arial"/>
+                        </a:rPr>
+                        <a:t>tGratingOpl (2)</a:t>
+                      </a:r>
+                    </a:p>
+                  </a:txBody>
+                  <a:tcPr marL="54864" marR="54864" marT="18288" marB="18288">
+                    <a:solidFill>
+                      <a:srgbClr val="ECF1F6"/>
                     </a:solidFill>
                   </a:tcPr>
                 </a:tc>
               </a:tr>
-              <a:tr h="280035">
-                <a:tc>
-                  <a:txBody>
-                    <a:bodyPr wrap="square"/>
-                    <a:lstStyle/>
-                    <a:p>
-                      <a:r>
-                        <a:rPr sz="1100" b="0">
-                          <a:solidFill>
-                            <a:srgbClr val="282828"/>
-                          </a:solidFill>
-                          <a:latin typeface="Arial"/>
-                        </a:rPr>
-                        <a:t>chain vs engine</a:t>
+              <a:tr h="657225">
+                <a:tc>
+                  <a:txBody>
+                    <a:bodyPr wrap="square"/>
+                    <a:lstStyle/>
+                    <a:p>
+                      <a:r>
+                        <a:rPr sz="1100" b="0">
+                          <a:solidFill>
+                            <a:srgbClr val="282828"/>
+                          </a:solidFill>
+                          <a:latin typeface="Arial"/>
+                        </a:rPr>
+                        <a:t>optimizer derivative stride</a:t>
+                      </a:r>
+                    </a:p>
+                  </a:txBody>
+                  <a:tcPr marL="54864" marR="54864" marT="18288" marB="18288">
+                    <a:solidFill>
+                      <a:srgbClr val="FFFFFF"/>
+                    </a:solidFill>
+                  </a:tcPr>
+                </a:tc>
+                <a:tc>
+                  <a:txBody>
+                    <a:bodyPr wrap="square"/>
+                    <a:lstStyle/>
+                    <a:p>
+                      <a:r>
+                        <a:rPr sz="1100" b="0">
+                          <a:solidFill>
+                            <a:srgbClr val="282828"/>
+                          </a:solidFill>
+                          <a:latin typeface="Arial"/>
+                        </a:rPr>
+                        <a:t>a spot-size optimisation over several fields overwrote memory on its second field (the derivative columns advanced by the wavefront's size, not the objective's) and crashed or hung the host</a:t>
+                      </a:r>
+                    </a:p>
+                  </a:txBody>
+                  <a:tcPr marL="54864" marR="54864" marT="18288" marB="18288">
+                    <a:solidFill>
+                      <a:srgbClr val="FFFFFF"/>
+                    </a:solidFill>
+                  </a:tcPr>
+                </a:tc>
+                <a:tc>
+                  <a:txBody>
+                    <a:bodyPr wrap="square"/>
+                    <a:lstStyle/>
+                    <a:p>
+                      <a:r>
+                        <a:rPr sz="1100" b="0">
+                          <a:solidFill>
+                            <a:srgbClr val="282828"/>
+                          </a:solidFill>
+                          <a:latin typeface="Arial"/>
+                        </a:rPr>
+                        <a:t>advance by the objective's size, as the value loop does</a:t>
+                      </a:r>
+                    </a:p>
+                  </a:txBody>
+                  <a:tcPr marL="54864" marR="54864" marT="18288" marB="18288">
+                    <a:solidFill>
+                      <a:srgbClr val="FFFFFF"/>
+                    </a:solidFill>
+                  </a:tcPr>
+                </a:tc>
+                <a:tc>
+                  <a:txBody>
+                    <a:bodyPr wrap="square"/>
+                    <a:lstStyle/>
+                    <a:p>
+                      <a:r>
+                        <a:rPr sz="1100" b="0">
+                          <a:solidFill>
+                            <a:srgbClr val="282828"/>
+                          </a:solidFill>
+                          <a:latin typeface="Arial"/>
+                        </a:rPr>
+                        <a:t>tSpectrometerRx native leg, tDesignTelescope (70, unchanged)</a:t>
+                      </a:r>
+                    </a:p>
+                  </a:txBody>
+                  <a:tcPr marL="54864" marR="54864" marT="18288" marB="18288">
+                    <a:solidFill>
+                      <a:srgbClr val="FFFFFF"/>
+                    </a:solidFill>
+                  </a:tcPr>
+                </a:tc>
+              </a:tr>
+              <a:tr h="657225">
+                <a:tc>
+                  <a:txBody>
+                    <a:bodyPr wrap="square"/>
+                    <a:lstStyle/>
+                    <a:p>
+                      <a:r>
+                        <a:rPr sz="1100" b="0">
+                          <a:solidFill>
+                            <a:srgbClr val="282828"/>
+                          </a:solidFill>
+                          <a:latin typeface="Arial"/>
+                        </a:rPr>
+                        <a:t>optimizer asphere step and failure exit</a:t>
                       </a:r>
                     </a:p>
                   </a:txBody>
@@ -15835,7 +16420,7 @@
                           </a:solidFill>
                           <a:latin typeface="Arial"/>
                         </a:rPr>
-                        <a:t>gate</a:t>
+                        <a:t>an aspheric coefficient was probed by a fixed 1e-10, round-off on a deck in metres: a zero derivative column, a singular matrix at the first step, and a stop on that path that ended the MATLAB process</a:t>
                       </a:r>
                     </a:p>
                   </a:txBody>
@@ -15857,7 +16442,7 @@
                           </a:solidFill>
                           <a:latin typeface="Arial"/>
                         </a:rPr>
-                        <a:t>tests/tSpectrometerRx.m</a:t>
+                        <a:t>the step is 1e-3 of the coefficient (sag-based for a zero one); the failure restores the optics and returns a flag</a:t>
                       </a:r>
                     </a:p>
                   </a:txBody>
@@ -15879,643 +16464,13 @@
                           </a:solidFill>
                           <a:latin typeface="Arial"/>
                         </a:rPr>
-                        <a:t>per-ray re-trace, 1e-9 m</a:t>
+                        <a:t>tAsphCalib (2): a spoiled paraboloid driven back to zero; the failure path with the host alive</a:t>
                       </a:r>
                     </a:p>
                   </a:txBody>
                   <a:tcPr marL="54864" marR="54864" marT="18288" marB="18288">
                     <a:solidFill>
                       <a:srgbClr val="ECF1F6"/>
-                    </a:solidFill>
-                  </a:tcPr>
-                </a:tc>
-              </a:tr>
-              <a:tr h="280035">
-                <a:tc>
-                  <a:txBody>
-                    <a:bodyPr wrap="square"/>
-                    <a:lstStyle/>
-                    <a:p>
-                      <a:r>
-                        <a:rPr sz="1100" b="0">
-                          <a:solidFill>
-                            <a:srgbClr val="282828"/>
-                          </a:solidFill>
-                          <a:latin typeface="Arial"/>
-                        </a:rPr>
-                        <a:t>propagation twin</a:t>
-                      </a:r>
-                    </a:p>
-                  </a:txBody>
-                  <a:tcPr marL="54864" marR="54864" marT="18288" marB="18288">
-                    <a:solidFill>
-                      <a:srgbClr val="FFFFFF"/>
-                    </a:solidFill>
-                  </a:tcPr>
-                </a:tc>
-                <a:tc>
-                  <a:txBody>
-                    <a:bodyPr wrap="square"/>
-                    <a:lstStyle/>
-                    <a:p>
-                      <a:r>
-                        <a:rPr sz="1100" b="0">
-                          <a:solidFill>
-                            <a:srgbClr val="282828"/>
-                          </a:solidFill>
-                          <a:latin typeface="Arial"/>
-                        </a:rPr>
-                        <a:t>s2w (opt-in, model 512)</a:t>
-                      </a:r>
-                    </a:p>
-                  </a:txBody>
-                  <a:tcPr marL="54864" marR="54864" marT="18288" marB="18288">
-                    <a:solidFill>
-                      <a:srgbClr val="FFFFFF"/>
-                    </a:solidFill>
-                  </a:tcPr>
-                </a:tc>
-                <a:tc>
-                  <a:txBody>
-                    <a:bodyPr wrap="square"/>
-                    <a:lstStyle/>
-                    <a:p>
-                      <a:r>
-                        <a:rPr sz="1100" b="0">
-                          <a:solidFill>
-                            <a:srgbClr val="282828"/>
-                          </a:solidFill>
-                          <a:latin typeface="Arial"/>
-                        </a:rPr>
-                        <a:t>dyson5_s2w.txt</a:t>
-                      </a:r>
-                    </a:p>
-                  </a:txBody>
-                  <a:tcPr marL="54864" marR="54864" marT="18288" marB="18288">
-                    <a:solidFill>
-                      <a:srgbClr val="FFFFFF"/>
-                    </a:solidFill>
-                  </a:tcPr>
-                </a:tc>
-                <a:tc>
-                  <a:txBody>
-                    <a:bodyPr wrap="square"/>
-                    <a:lstStyle/>
-                    <a:p>
-                      <a:r>
-                        <a:rPr sz="1100" b="0">
-                          <a:solidFill>
-                            <a:srgbClr val="282828"/>
-                          </a:solidFill>
-                          <a:latin typeface="Arial"/>
-                        </a:rPr>
-                        <a:t>spectrometer_wave.m</a:t>
-                      </a:r>
-                    </a:p>
-                  </a:txBody>
-                  <a:tcPr marL="54864" marR="54864" marT="18288" marB="18288">
-                    <a:solidFill>
-                      <a:srgbClr val="FFFFFF"/>
-                    </a:solidFill>
-                  </a:tcPr>
-                </a:tc>
-              </a:tr>
-              <a:tr h="468630">
-                <a:tc>
-                  <a:txBody>
-                    <a:bodyPr wrap="square"/>
-                    <a:lstStyle/>
-                    <a:p>
-                      <a:r>
-                        <a:rPr sz="1100" b="0">
-                          <a:solidFill>
-                            <a:srgbClr val="282828"/>
-                          </a:solidFill>
-                          <a:latin typeface="Arial"/>
-                        </a:rPr>
-                        <a:t>departure ladder, R4, trade</a:t>
-                      </a:r>
-                    </a:p>
-                  </a:txBody>
-                  <a:tcPr marL="54864" marR="54864" marT="18288" marB="18288">
-                    <a:solidFill>
-                      <a:srgbClr val="ECF1F6"/>
-                    </a:solidFill>
-                  </a:tcPr>
-                </a:tc>
-                <a:tc>
-                  <a:txBody>
-                    <a:bodyPr wrap="square"/>
-                    <a:lstStyle/>
-                    <a:p>
-                      <a:r>
-                        <a:rPr sz="1100" b="0">
-                          <a:solidFill>
-                            <a:srgbClr val="282828"/>
-                          </a:solidFill>
-                          <a:latin typeface="Arial"/>
-                        </a:rPr>
-                        <a:t>s3, s3free, s3b</a:t>
-                      </a:r>
-                    </a:p>
-                  </a:txBody>
-                  <a:tcPr marL="54864" marR="54864" marT="18288" marB="18288">
-                    <a:solidFill>
-                      <a:srgbClr val="ECF1F6"/>
-                    </a:solidFill>
-                  </a:tcPr>
-                </a:tc>
-                <a:tc>
-                  <a:txBody>
-                    <a:bodyPr wrap="square"/>
-                    <a:lstStyle/>
-                    <a:p>
-                      <a:r>
-                        <a:rPr sz="1100" b="0">
-                          <a:solidFill>
-                            <a:srgbClr val="282828"/>
-                          </a:solidFill>
-                          <a:latin typeface="Arial"/>
-                        </a:rPr>
-                        <a:t>dyson5_s3.txt, dyson5_s3free.txt, dyson5_s3_trade.txt, dyson5_s3_layout_r.png, dyson5_s3_maps_r.png</a:t>
-                      </a:r>
-                    </a:p>
-                  </a:txBody>
-                  <a:tcPr marL="54864" marR="54864" marT="18288" marB="18288">
-                    <a:solidFill>
-                      <a:srgbClr val="ECF1F6"/>
-                    </a:solidFill>
-                  </a:tcPr>
-                </a:tc>
-                <a:tc>
-                  <a:txBody>
-                    <a:bodyPr wrap="square"/>
-                    <a:lstStyle/>
-                    <a:p>
-                      <a:r>
-                        <a:rPr sz="1100" b="0">
-                          <a:solidFill>
-                            <a:srgbClr val="282828"/>
-                          </a:solidFill>
-                          <a:latin typeface="Arial"/>
-                        </a:rPr>
-                        <a:t>dyson_ladder.m, dyson5_trade.m</a:t>
-                      </a:r>
-                    </a:p>
-                  </a:txBody>
-                  <a:tcPr marL="54864" marR="54864" marT="18288" marB="18288">
-                    <a:solidFill>
-                      <a:srgbClr val="ECF1F6"/>
-                    </a:solidFill>
-                  </a:tcPr>
-                </a:tc>
-              </a:tr>
-              <a:tr h="280035">
-                <a:tc>
-                  <a:txBody>
-                    <a:bodyPr wrap="square"/>
-                    <a:lstStyle/>
-                    <a:p>
-                      <a:r>
-                        <a:rPr sz="1100" b="0">
-                          <a:solidFill>
-                            <a:srgbClr val="282828"/>
-                          </a:solidFill>
-                          <a:latin typeface="Arial"/>
-                        </a:rPr>
-                        <a:t>meniscus search</a:t>
-                      </a:r>
-                    </a:p>
-                  </a:txBody>
-                  <a:tcPr marL="54864" marR="54864" marT="18288" marB="18288">
-                    <a:solidFill>
-                      <a:srgbClr val="FFFFFF"/>
-                    </a:solidFill>
-                  </a:tcPr>
-                </a:tc>
-                <a:tc>
-                  <a:txBody>
-                    <a:bodyPr wrap="square"/>
-                    <a:lstStyle/>
-                    <a:p>
-                      <a:r>
-                        <a:rPr sz="1100" b="0">
-                          <a:solidFill>
-                            <a:srgbClr val="282828"/>
-                          </a:solidFill>
-                          <a:latin typeface="Arial"/>
-                        </a:rPr>
-                        <a:t>tool</a:t>
-                      </a:r>
-                    </a:p>
-                  </a:txBody>
-                  <a:tcPr marL="54864" marR="54864" marT="18288" marB="18288">
-                    <a:solidFill>
-                      <a:srgbClr val="FFFFFF"/>
-                    </a:solidFill>
-                  </a:tcPr>
-                </a:tc>
-                <a:tc>
-                  <a:txBody>
-                    <a:bodyPr wrap="square"/>
-                    <a:lstStyle/>
-                    <a:p>
-                      <a:r>
-                        <a:rPr sz="1100" b="0">
-                          <a:solidFill>
-                            <a:srgbClr val="282828"/>
-                          </a:solidFill>
-                          <a:latin typeface="Arial"/>
-                        </a:rPr>
-                        <a:t>dyson5_s3_r4global.txt</a:t>
-                      </a:r>
-                    </a:p>
-                  </a:txBody>
-                  <a:tcPr marL="54864" marR="54864" marT="18288" marB="18288">
-                    <a:solidFill>
-                      <a:srgbClr val="FFFFFF"/>
-                    </a:solidFill>
-                  </a:tcPr>
-                </a:tc>
-                <a:tc>
-                  <a:txBody>
-                    <a:bodyPr wrap="square"/>
-                    <a:lstStyle/>
-                    <a:p>
-                      <a:r>
-                        <a:rPr sz="1100" b="0">
-                          <a:solidFill>
-                            <a:srgbClr val="282828"/>
-                          </a:solidFill>
-                          <a:latin typeface="Arial"/>
-                        </a:rPr>
-                        <a:t>dyson_r4_global.m</a:t>
-                      </a:r>
-                    </a:p>
-                  </a:txBody>
-                  <a:tcPr marL="54864" marR="54864" marT="18288" marB="18288">
-                    <a:solidFill>
-                      <a:srgbClr val="FFFFFF"/>
-                    </a:solidFill>
-                  </a:tcPr>
-                </a:tc>
-              </a:tr>
-              <a:tr h="468630">
-                <a:tc>
-                  <a:txBody>
-                    <a:bodyPr wrap="square"/>
-                    <a:lstStyle/>
-                    <a:p>
-                      <a:r>
-                        <a:rPr sz="1100" b="0">
-                          <a:solidFill>
-                            <a:srgbClr val="282828"/>
-                          </a:solidFill>
-                          <a:latin typeface="Arial"/>
-                        </a:rPr>
-                        <a:t>slit loss</a:t>
-                      </a:r>
-                    </a:p>
-                  </a:txBody>
-                  <a:tcPr marL="54864" marR="54864" marT="18288" marB="18288">
-                    <a:solidFill>
-                      <a:srgbClr val="ECF1F6"/>
-                    </a:solidFill>
-                  </a:tcPr>
-                </a:tc>
-                <a:tc>
-                  <a:txBody>
-                    <a:bodyPr wrap="square"/>
-                    <a:lstStyle/>
-                    <a:p>
-                      <a:r>
-                        <a:rPr sz="1100" b="0">
-                          <a:solidFill>
-                            <a:srgbClr val="282828"/>
-                          </a:solidFill>
-                          <a:latin typeface="Arial"/>
-                        </a:rPr>
-                        <a:t>s2l + tool</a:t>
-                      </a:r>
-                    </a:p>
-                  </a:txBody>
-                  <a:tcPr marL="54864" marR="54864" marT="18288" marB="18288">
-                    <a:solidFill>
-                      <a:srgbClr val="ECF1F6"/>
-                    </a:solidFill>
-                  </a:tcPr>
-                </a:tc>
-                <a:tc>
-                  <a:txBody>
-                    <a:bodyPr wrap="square"/>
-                    <a:lstStyle/>
-                    <a:p>
-                      <a:r>
-                        <a:rPr sz="1100" b="0">
-                          <a:solidFill>
-                            <a:srgbClr val="282828"/>
-                          </a:solidFill>
-                          <a:latin typeface="Arial"/>
-                        </a:rPr>
-                        <a:t>dyson5_s2l.txt, dyson5_s2l_tests.txt, dyson5_s2l_slitloss.png</a:t>
-                      </a:r>
-                    </a:p>
-                  </a:txBody>
-                  <a:tcPr marL="54864" marR="54864" marT="18288" marB="18288">
-                    <a:solidFill>
-                      <a:srgbClr val="ECF1F6"/>
-                    </a:solidFill>
-                  </a:tcPr>
-                </a:tc>
-                <a:tc>
-                  <a:txBody>
-                    <a:bodyPr wrap="square"/>
-                    <a:lstStyle/>
-                    <a:p>
-                      <a:r>
-                        <a:rPr sz="1100" b="0">
-                          <a:solidFill>
-                            <a:srgbClr val="282828"/>
-                          </a:solidFill>
-                          <a:latin typeface="Arial"/>
-                        </a:rPr>
-                        <a:t>far-field leg vs sinc²; dyson5_slitloss_tests.m</a:t>
-                      </a:r>
-                    </a:p>
-                  </a:txBody>
-                  <a:tcPr marL="54864" marR="54864" marT="18288" marB="18288">
-                    <a:solidFill>
-                      <a:srgbClr val="ECF1F6"/>
-                    </a:solidFill>
-                  </a:tcPr>
-                </a:tc>
-              </a:tr>
-              <a:tr h="468630">
-                <a:tc>
-                  <a:txBody>
-                    <a:bodyPr wrap="square"/>
-                    <a:lstStyle/>
-                    <a:p>
-                      <a:r>
-                        <a:rPr sz="1100" b="0">
-                          <a:solidFill>
-                            <a:srgbClr val="282828"/>
-                          </a:solidFill>
-                          <a:latin typeface="Arial"/>
-                        </a:rPr>
-                        <a:t>fold prism, cold shield</a:t>
-                      </a:r>
-                    </a:p>
-                  </a:txBody>
-                  <a:tcPr marL="54864" marR="54864" marT="18288" marB="18288">
-                    <a:solidFill>
-                      <a:srgbClr val="FFFFFF"/>
-                    </a:solidFill>
-                  </a:tcPr>
-                </a:tc>
-                <a:tc>
-                  <a:txBody>
-                    <a:bodyPr wrap="square"/>
-                    <a:lstStyle/>
-                    <a:p>
-                      <a:r>
-                        <a:rPr sz="1100" b="0">
-                          <a:solidFill>
-                            <a:srgbClr val="282828"/>
-                          </a:solidFill>
-                          <a:latin typeface="Arial"/>
-                        </a:rPr>
-                        <a:t>s5</a:t>
-                      </a:r>
-                    </a:p>
-                  </a:txBody>
-                  <a:tcPr marL="54864" marR="54864" marT="18288" marB="18288">
-                    <a:solidFill>
-                      <a:srgbClr val="FFFFFF"/>
-                    </a:solidFill>
-                  </a:tcPr>
-                </a:tc>
-                <a:tc>
-                  <a:txBody>
-                    <a:bodyPr wrap="square"/>
-                    <a:lstStyle/>
-                    <a:p>
-                      <a:r>
-                        <a:rPr sz="1100" b="0">
-                          <a:solidFill>
-                            <a:srgbClr val="282828"/>
-                          </a:solidFill>
-                          <a:latin typeface="Arial"/>
-                        </a:rPr>
-                        <a:t>dyson5_s5.txt, dyson5_s5_r5_h*.in, dyson5_s5_maps_r5.png, dyson5_s5_sweep.png</a:t>
-                      </a:r>
-                    </a:p>
-                  </a:txBody>
-                  <a:tcPr marL="54864" marR="54864" marT="18288" marB="18288">
-                    <a:solidFill>
-                      <a:srgbClr val="FFFFFF"/>
-                    </a:solidFill>
-                  </a:tcPr>
-                </a:tc>
-                <a:tc>
-                  <a:txBody>
-                    <a:bodyPr wrap="square"/>
-                    <a:lstStyle/>
-                    <a:p>
-                      <a:r>
-                        <a:rPr sz="1100" b="0">
-                          <a:solidFill>
-                            <a:srgbClr val="282828"/>
-                          </a:solidFill>
-                          <a:latin typeface="Arial"/>
-                        </a:rPr>
-                        <a:t>spectrometer_geom.m (form dyson_fold), spectrometer_clearance.m</a:t>
-                      </a:r>
-                    </a:p>
-                  </a:txBody>
-                  <a:tcPr marL="54864" marR="54864" marT="18288" marB="18288">
-                    <a:solidFill>
-                      <a:srgbClr val="FFFFFF"/>
-                    </a:solidFill>
-                  </a:tcPr>
-                </a:tc>
-              </a:tr>
-              <a:tr h="280035">
-                <a:tc>
-                  <a:txBody>
-                    <a:bodyPr wrap="square"/>
-                    <a:lstStyle/>
-                    <a:p>
-                      <a:r>
-                        <a:rPr sz="1100" b="0">
-                          <a:solidFill>
-                            <a:srgbClr val="282828"/>
-                          </a:solidFill>
-                          <a:latin typeface="Arial"/>
-                        </a:rPr>
-                        <a:t>closure envelope</a:t>
-                      </a:r>
-                    </a:p>
-                  </a:txBody>
-                  <a:tcPr marL="54864" marR="54864" marT="18288" marB="18288">
-                    <a:solidFill>
-                      <a:srgbClr val="ECF1F6"/>
-                    </a:solidFill>
-                  </a:tcPr>
-                </a:tc>
-                <a:tc>
-                  <a:txBody>
-                    <a:bodyPr wrap="square"/>
-                    <a:lstStyle/>
-                    <a:p>
-                      <a:r>
-                        <a:rPr sz="1100" b="0">
-                          <a:solidFill>
-                            <a:srgbClr val="282828"/>
-                          </a:solidFill>
-                          <a:latin typeface="Arial"/>
-                        </a:rPr>
-                        <a:t>s4env</a:t>
-                      </a:r>
-                    </a:p>
-                  </a:txBody>
-                  <a:tcPr marL="54864" marR="54864" marT="18288" marB="18288">
-                    <a:solidFill>
-                      <a:srgbClr val="ECF1F6"/>
-                    </a:solidFill>
-                  </a:tcPr>
-                </a:tc>
-                <a:tc>
-                  <a:txBody>
-                    <a:bodyPr wrap="square"/>
-                    <a:lstStyle/>
-                    <a:p>
-                      <a:r>
-                        <a:rPr sz="1100" b="0">
-                          <a:solidFill>
-                            <a:srgbClr val="282828"/>
-                          </a:solidFill>
-                          <a:latin typeface="Arial"/>
-                        </a:rPr>
-                        <a:t>dyson5_s4env.txt, dyson5_s4env.png, dyson5_s4env_*.in</a:t>
-                      </a:r>
-                    </a:p>
-                  </a:txBody>
-                  <a:tcPr marL="54864" marR="54864" marT="18288" marB="18288">
-                    <a:solidFill>
-                      <a:srgbClr val="ECF1F6"/>
-                    </a:solidFill>
-                  </a:tcPr>
-                </a:tc>
-                <a:tc>
-                  <a:txBody>
-                    <a:bodyPr wrap="square"/>
-                    <a:lstStyle/>
-                    <a:p>
-                      <a:r>
-                        <a:rPr sz="1100" b="0">
-                          <a:solidFill>
-                            <a:srgbClr val="282828"/>
-                          </a:solidFill>
-                          <a:latin typeface="Arial"/>
-                        </a:rPr>
-                        <a:t>dyson5_envelope.m</a:t>
-                      </a:r>
-                    </a:p>
-                  </a:txBody>
-                  <a:tcPr marL="54864" marR="54864" marT="18288" marB="18288">
-                    <a:solidFill>
-                      <a:srgbClr val="ECF1F6"/>
-                    </a:solidFill>
-                  </a:tcPr>
-                </a:tc>
-              </a:tr>
-              <a:tr h="468630">
-                <a:tc>
-                  <a:txBody>
-                    <a:bodyPr wrap="square"/>
-                    <a:lstStyle/>
-                    <a:p>
-                      <a:r>
-                        <a:rPr sz="1100" b="0">
-                          <a:solidFill>
-                            <a:srgbClr val="282828"/>
-                          </a:solidFill>
-                          <a:latin typeface="Arial"/>
-                        </a:rPr>
-                        <a:t>native optimizer</a:t>
-                      </a:r>
-                    </a:p>
-                  </a:txBody>
-                  <a:tcPr marL="54864" marR="54864" marT="18288" marB="18288">
-                    <a:solidFill>
-                      <a:srgbClr val="FFFFFF"/>
-                    </a:solidFill>
-                  </a:tcPr>
-                </a:tc>
-                <a:tc>
-                  <a:txBody>
-                    <a:bodyPr wrap="square"/>
-                    <a:lstStyle/>
-                    <a:p>
-                      <a:r>
-                        <a:rPr sz="1100" b="0">
-                          <a:solidFill>
-                            <a:srgbClr val="282828"/>
-                          </a:solidFill>
-                          <a:latin typeface="Arial"/>
-                        </a:rPr>
-                        <a:t>s4</a:t>
-                      </a:r>
-                    </a:p>
-                  </a:txBody>
-                  <a:tcPr marL="54864" marR="54864" marT="18288" marB="18288">
-                    <a:solidFill>
-                      <a:srgbClr val="FFFFFF"/>
-                    </a:solidFill>
-                  </a:tcPr>
-                </a:tc>
-                <a:tc>
-                  <a:txBody>
-                    <a:bodyPr wrap="square"/>
-                    <a:lstStyle/>
-                    <a:p>
-                      <a:r>
-                        <a:rPr sz="1100" b="0">
-                          <a:solidFill>
-                            <a:srgbClr val="282828"/>
-                          </a:solidFill>
-                          <a:latin typeface="Arial"/>
-                        </a:rPr>
-                        <a:t>dyson5_s4.txt, dyson5_s4_r4n_seed.in (the CALIB deck), dyson5_s4_r4n.in</a:t>
-                      </a:r>
-                    </a:p>
-                  </a:txBody>
-                  <a:tcPr marL="54864" marR="54864" marT="18288" marB="18288">
-                    <a:solidFill>
-                      <a:srgbClr val="FFFFFF"/>
-                    </a:solidFill>
-                  </a:tcPr>
-                </a:tc>
-                <a:tc>
-                  <a:txBody>
-                    <a:bodyPr wrap="square"/>
-                    <a:lstStyle/>
-                    <a:p>
-                      <a:r>
-                        <a:rPr sz="1100" b="0">
-                          <a:solidFill>
-                            <a:srgbClr val="282828"/>
-                          </a:solidFill>
-                          <a:latin typeface="Arial"/>
-                        </a:rPr>
-                        <a:t>dyson_native.m</a:t>
-                      </a:r>
-                    </a:p>
-                  </a:txBody>
-                  <a:tcPr marL="54864" marR="54864" marT="18288" marB="18288">
-                    <a:solidFill>
-                      <a:srgbClr val="FFFFFF"/>
                     </a:solidFill>
                   </a:tcPr>
                 </a:tc>
@@ -16532,7 +16487,7 @@
         </p:nvSpPr>
         <p:spPr>
           <a:xfrm>
-            <a:off x="411480" y="5936742"/>
+            <a:off x="411480" y="5290947"/>
             <a:ext cx="11368735" cy="274320"/>
           </a:xfrm>
           <a:prstGeom prst="rect">
@@ -16558,7 +16513,7 @@
                 </a:solidFill>
                 <a:latin typeface="Arial"/>
               </a:rPr>
-              <a:t>Conventions behind the scaling law: block index n(silica, 1 µm) = 1.450417; in-glass marginal half-angle u = asin(1 / 2nF); field height h from the Dyson axis on the flat face; the slit corner is h = hypot(27 mm, 8 mm).</a:t>
+              <a:t>Flat gratings are unchanged by the grating fixes; the wavefront-target optimizer, which every telescope design used, was never affected by the fifth.  A seventh item, a short AsphCoef= line killing the host process, now pads with zero and warns (tRxShortAsph).</a:t>
             </a:r>
           </a:p>
         </p:txBody>
@@ -16571,7 +16526,7 @@
 </p:sld>
 </file>
 
-<file path=ppt/slides/slide3.xml><?xml version="1.0" encoding="utf-8"?>
+<file path=ppt/slides/slide31.xml><?xml version="1.0" encoding="utf-8"?>
 <p:sld xmlns:a="http://schemas.openxmlformats.org/drawingml/2006/main" xmlns:p="http://schemas.openxmlformats.org/presentationml/2006/main" xmlns:r="http://schemas.openxmlformats.org/officeDocument/2006/relationships">
   <p:cSld>
     <p:spTree>
@@ -16615,7 +16570,7 @@
                 </a:solidFill>
                 <a:latin typeface="Arial"/>
               </a:rPr>
-              <a:t>The target and how it is scored</a:t>
+              <a:t>Backup: records and tools behind each slide</a:t>
             </a:r>
           </a:p>
           <a:p>
@@ -16631,7 +16586,7 @@
                 </a:solidFill>
                 <a:latin typeface="Arial"/>
               </a:rPr>
-              <a:t>Joe's specification, EMIT-class; the metrics stated once, here</a:t>
+              <a:t>Every number traces to a runner stage and its record file</a:t>
             </a:r>
           </a:p>
         </p:txBody>
@@ -16690,7 +16645,7 @@
         </p:nvGraphicFramePr>
         <p:xfrm>
           <a:off x="411480" y="1298448"/>
-          <a:ext cx="5806439" cy="2897505"/>
+          <a:ext cx="11368734" cy="4491990"/>
         </p:xfrm>
         <a:graphic>
           <a:graphicData uri="http://schemas.openxmlformats.org/drawingml/2006/table">
@@ -16699,8 +16654,10 @@
                 <a:tableStyleId>{5C22544A-7EE6-4342-B048-85BDC9FD1C3A}</a:tableStyleId>
               </a:tblPr>
               <a:tblGrid>
-                <a:gridCol w="2274687"/>
-                <a:gridCol w="3531752"/>
+                <a:gridCol w="2107692"/>
+                <a:gridCol w="1817116"/>
+                <a:gridCol w="4549066"/>
+                <a:gridCol w="2894860"/>
               </a:tblGrid>
               <a:tr h="280035">
                 <a:tc>
@@ -16715,7 +16672,7 @@
                           </a:solidFill>
                           <a:latin typeface="Arial"/>
                         </a:rPr>
-                        <a:t>item</a:t>
+                        <a:t>slide</a:t>
                       </a:r>
                     </a:p>
                   </a:txBody>
@@ -16737,7 +16694,51 @@
                           </a:solidFill>
                           <a:latin typeface="Arial"/>
                         </a:rPr>
-                        <a:t>value</a:t>
+                        <a:t>runner stage</a:t>
+                      </a:r>
+                    </a:p>
+                  </a:txBody>
+                  <a:tcPr marL="54864" marR="54864" marT="18288" marB="18288">
+                    <a:solidFill>
+                      <a:srgbClr val="1F4E79"/>
+                    </a:solidFill>
+                  </a:tcPr>
+                </a:tc>
+                <a:tc>
+                  <a:txBody>
+                    <a:bodyPr wrap="square"/>
+                    <a:lstStyle/>
+                    <a:p>
+                      <a:r>
+                        <a:rPr sz="1100" b="1">
+                          <a:solidFill>
+                            <a:srgbClr val="FFFFFF"/>
+                          </a:solidFill>
+                          <a:latin typeface="Arial"/>
+                        </a:rPr>
+                        <a:t>record</a:t>
+                      </a:r>
+                    </a:p>
+                  </a:txBody>
+                  <a:tcPr marL="54864" marR="54864" marT="18288" marB="18288">
+                    <a:solidFill>
+                      <a:srgbClr val="1F4E79"/>
+                    </a:solidFill>
+                  </a:tcPr>
+                </a:tc>
+                <a:tc>
+                  <a:txBody>
+                    <a:bodyPr wrap="square"/>
+                    <a:lstStyle/>
+                    <a:p>
+                      <a:r>
+                        <a:rPr sz="1100" b="1">
+                          <a:solidFill>
+                            <a:srgbClr val="FFFFFF"/>
+                          </a:solidFill>
+                          <a:latin typeface="Arial"/>
+                        </a:rPr>
+                        <a:t>tool</a:t>
                       </a:r>
                     </a:p>
                   </a:txBody>
@@ -16761,29 +16762,73 @@
                           </a:solidFill>
                           <a:latin typeface="Arial"/>
                         </a:rPr>
-                        <a:t>F-number (air-equivalent, image space)</a:t>
-                      </a:r>
-                    </a:p>
-                  </a:txBody>
-                  <a:tcPr marL="54864" marR="54864" marT="18288" marB="18288">
-                    <a:solidFill>
-                      <a:srgbClr val="FFFFFF"/>
-                    </a:solidFill>
-                  </a:tcPr>
-                </a:tc>
-                <a:tc>
-                  <a:txBody>
-                    <a:bodyPr wrap="square"/>
-                    <a:lstStyle/>
-                    <a:p>
-                      <a:r>
-                        <a:rPr sz="1100" b="0">
-                          <a:solidFill>
-                            <a:srgbClr val="282828"/>
-                          </a:solidFill>
-                          <a:latin typeface="Arial"/>
-                        </a:rPr>
-                        <a:t>1.8</a:t>
+                        <a:t>scaling law</a:t>
+                      </a:r>
+                    </a:p>
+                  </a:txBody>
+                  <a:tcPr marL="54864" marR="54864" marT="18288" marB="18288">
+                    <a:solidFill>
+                      <a:srgbClr val="FFFFFF"/>
+                    </a:solidFill>
+                  </a:tcPr>
+                </a:tc>
+                <a:tc>
+                  <a:txBody>
+                    <a:bodyPr wrap="square"/>
+                    <a:lstStyle/>
+                    <a:p>
+                      <a:r>
+                        <a:rPr sz="1100" b="0">
+                          <a:solidFill>
+                            <a:srgbClr val="282828"/>
+                          </a:solidFill>
+                          <a:latin typeface="Arial"/>
+                        </a:rPr>
+                        <a:t>s0 (engine-free)</a:t>
+                      </a:r>
+                    </a:p>
+                  </a:txBody>
+                  <a:tcPr marL="54864" marR="54864" marT="18288" marB="18288">
+                    <a:solidFill>
+                      <a:srgbClr val="FFFFFF"/>
+                    </a:solidFill>
+                  </a:tcPr>
+                </a:tc>
+                <a:tc>
+                  <a:txBody>
+                    <a:bodyPr wrap="square"/>
+                    <a:lstStyle/>
+                    <a:p>
+                      <a:r>
+                        <a:rPr sz="1100" b="0">
+                          <a:solidFill>
+                            <a:srgbClr val="282828"/>
+                          </a:solidFill>
+                          <a:latin typeface="Arial"/>
+                        </a:rPr>
+                        <a:t>dyson5_s0_scaling.txt</a:t>
+                      </a:r>
+                    </a:p>
+                  </a:txBody>
+                  <a:tcPr marL="54864" marR="54864" marT="18288" marB="18288">
+                    <a:solidFill>
+                      <a:srgbClr val="FFFFFF"/>
+                    </a:solidFill>
+                  </a:tcPr>
+                </a:tc>
+                <a:tc>
+                  <a:txBody>
+                    <a:bodyPr wrap="square"/>
+                    <a:lstStyle/>
+                    <a:p>
+                      <a:r>
+                        <a:rPr sz="1100" b="0">
+                          <a:solidFill>
+                            <a:srgbClr val="282828"/>
+                          </a:solidFill>
+                          <a:latin typeface="Arial"/>
+                        </a:rPr>
+                        <a:t>design/src/dyson_layout.m, dyson_scaling.m</a:t>
                       </a:r>
                     </a:p>
                   </a:txBody>
@@ -16807,7 +16852,7 @@
                           </a:solidFill>
                           <a:latin typeface="Arial"/>
                         </a:rPr>
-                        <a:t>focal plane</a:t>
+                        <a:t>as traced (every form)</a:t>
                       </a:r>
                     </a:p>
                   </a:txBody>
@@ -16829,13 +16874,147 @@
                           </a:solidFill>
                           <a:latin typeface="Arial"/>
                         </a:rPr>
-                        <a:t>3000 spatial × 500 spectral pixels, 18 µm</a:t>
+                        <a:t>dyson5_view_figs.m</a:t>
                       </a:r>
                     </a:p>
                   </a:txBody>
                   <a:tcPr marL="54864" marR="54864" marT="18288" marB="18288">
                     <a:solidFill>
                       <a:srgbClr val="ECF1F6"/>
+                    </a:solidFill>
+                  </a:tcPr>
+                </a:tc>
+                <a:tc>
+                  <a:txBody>
+                    <a:bodyPr wrap="square"/>
+                    <a:lstStyle/>
+                    <a:p>
+                      <a:r>
+                        <a:rPr sz="1100" b="0">
+                          <a:solidFill>
+                            <a:srgbClr val="282828"/>
+                          </a:solidFill>
+                          <a:latin typeface="Arial"/>
+                        </a:rPr>
+                        <a:t>_view3d.png, _viewyz.png</a:t>
+                      </a:r>
+                    </a:p>
+                  </a:txBody>
+                  <a:tcPr marL="54864" marR="54864" marT="18288" marB="18288">
+                    <a:solidFill>
+                      <a:srgbClr val="ECF1F6"/>
+                    </a:solidFill>
+                  </a:tcPr>
+                </a:tc>
+                <a:tc>
+                  <a:txBody>
+                    <a:bodyPr wrap="square"/>
+                    <a:lstStyle/>
+                    <a:p>
+                      <a:r>
+                        <a:rPr sz="1100" b="0">
+                          <a:solidFill>
+                            <a:srgbClr val="282828"/>
+                          </a:solidFill>
+                          <a:latin typeface="Arial"/>
+                        </a:rPr>
+                        <a:t>macos.view_rx on the deck</a:t>
+                      </a:r>
+                    </a:p>
+                  </a:txBody>
+                  <a:tcPr marL="54864" marR="54864" marT="18288" marB="18288">
+                    <a:solidFill>
+                      <a:srgbClr val="ECF1F6"/>
+                    </a:solidFill>
+                  </a:tcPr>
+                </a:tc>
+              </a:tr>
+              <a:tr h="468630">
+                <a:tc>
+                  <a:txBody>
+                    <a:bodyPr wrap="square"/>
+                    <a:lstStyle/>
+                    <a:p>
+                      <a:r>
+                        <a:rPr sz="1100" b="0">
+                          <a:solidFill>
+                            <a:srgbClr val="282828"/>
+                          </a:solidFill>
+                          <a:latin typeface="Arial"/>
+                        </a:rPr>
+                        <a:t>seed scored</a:t>
+                      </a:r>
+                    </a:p>
+                  </a:txBody>
+                  <a:tcPr marL="54864" marR="54864" marT="18288" marB="18288">
+                    <a:solidFill>
+                      <a:srgbClr val="FFFFFF"/>
+                    </a:solidFill>
+                  </a:tcPr>
+                </a:tc>
+                <a:tc>
+                  <a:txBody>
+                    <a:bodyPr wrap="square"/>
+                    <a:lstStyle/>
+                    <a:p>
+                      <a:r>
+                        <a:rPr sz="1100" b="0">
+                          <a:solidFill>
+                            <a:srgbClr val="282828"/>
+                          </a:solidFill>
+                          <a:latin typeface="Arial"/>
+                        </a:rPr>
+                        <a:t>s1 emit, s2 score</a:t>
+                      </a:r>
+                    </a:p>
+                  </a:txBody>
+                  <a:tcPr marL="54864" marR="54864" marT="18288" marB="18288">
+                    <a:solidFill>
+                      <a:srgbClr val="FFFFFF"/>
+                    </a:solidFill>
+                  </a:tcPr>
+                </a:tc>
+                <a:tc>
+                  <a:txBody>
+                    <a:bodyPr wrap="square"/>
+                    <a:lstStyle/>
+                    <a:p>
+                      <a:r>
+                        <a:rPr sz="1100" b="0">
+                          <a:solidFill>
+                            <a:srgbClr val="282828"/>
+                          </a:solidFill>
+                          <a:latin typeface="Arial"/>
+                        </a:rPr>
+                        <a:t>dyson5_s1.txt, dyson5_s2.txt, dyson5_s2_maps.png</a:t>
+                      </a:r>
+                    </a:p>
+                  </a:txBody>
+                  <a:tcPr marL="54864" marR="54864" marT="18288" marB="18288">
+                    <a:solidFill>
+                      <a:srgbClr val="FFFFFF"/>
+                    </a:solidFill>
+                  </a:tcPr>
+                </a:tc>
+                <a:tc>
+                  <a:txBody>
+                    <a:bodyPr wrap="square"/>
+                    <a:lstStyle/>
+                    <a:p>
+                      <a:r>
+                        <a:rPr sz="1100" b="0">
+                          <a:solidFill>
+                            <a:srgbClr val="282828"/>
+                          </a:solidFill>
+                          <a:latin typeface="Arial"/>
+                        </a:rPr>
+                        <a:t>spectrometer_geom.m, spectrometer_rx.m, spectrometer_score.m</a:t>
+                      </a:r>
+                    </a:p>
+                  </a:txBody>
+                  <a:tcPr marL="54864" marR="54864" marT="18288" marB="18288">
+                    <a:solidFill>
+                      <a:srgbClr val="FFFFFF"/>
                     </a:solidFill>
                   </a:tcPr>
                 </a:tc>
@@ -16853,35 +17032,79 @@
                           </a:solidFill>
                           <a:latin typeface="Arial"/>
                         </a:rPr>
-                        <a:t>slit</a:t>
-                      </a:r>
-                    </a:p>
-                  </a:txBody>
-                  <a:tcPr marL="54864" marR="54864" marT="18288" marB="18288">
-                    <a:solidFill>
-                      <a:srgbClr val="FFFFFF"/>
-                    </a:solidFill>
-                  </a:tcPr>
-                </a:tc>
-                <a:tc>
-                  <a:txBody>
-                    <a:bodyPr wrap="square"/>
-                    <a:lstStyle/>
-                    <a:p>
-                      <a:r>
-                        <a:rPr sz="1100" b="0">
-                          <a:solidFill>
-                            <a:srgbClr val="282828"/>
-                          </a:solidFill>
-                          <a:latin typeface="Arial"/>
-                        </a:rPr>
-                        <a:t>54 mm; spectral height 9 mm</a:t>
-                      </a:r>
-                    </a:p>
-                  </a:txBody>
-                  <a:tcPr marL="54864" marR="54864" marT="18288" marB="18288">
-                    <a:solidFill>
-                      <a:srgbClr val="FFFFFF"/>
+                        <a:t>chain vs engine</a:t>
+                      </a:r>
+                    </a:p>
+                  </a:txBody>
+                  <a:tcPr marL="54864" marR="54864" marT="18288" marB="18288">
+                    <a:solidFill>
+                      <a:srgbClr val="ECF1F6"/>
+                    </a:solidFill>
+                  </a:tcPr>
+                </a:tc>
+                <a:tc>
+                  <a:txBody>
+                    <a:bodyPr wrap="square"/>
+                    <a:lstStyle/>
+                    <a:p>
+                      <a:r>
+                        <a:rPr sz="1100" b="0">
+                          <a:solidFill>
+                            <a:srgbClr val="282828"/>
+                          </a:solidFill>
+                          <a:latin typeface="Arial"/>
+                        </a:rPr>
+                        <a:t>gate</a:t>
+                      </a:r>
+                    </a:p>
+                  </a:txBody>
+                  <a:tcPr marL="54864" marR="54864" marT="18288" marB="18288">
+                    <a:solidFill>
+                      <a:srgbClr val="ECF1F6"/>
+                    </a:solidFill>
+                  </a:tcPr>
+                </a:tc>
+                <a:tc>
+                  <a:txBody>
+                    <a:bodyPr wrap="square"/>
+                    <a:lstStyle/>
+                    <a:p>
+                      <a:r>
+                        <a:rPr sz="1100" b="0">
+                          <a:solidFill>
+                            <a:srgbClr val="282828"/>
+                          </a:solidFill>
+                          <a:latin typeface="Arial"/>
+                        </a:rPr>
+                        <a:t>tests/tSpectrometerRx.m</a:t>
+                      </a:r>
+                    </a:p>
+                  </a:txBody>
+                  <a:tcPr marL="54864" marR="54864" marT="18288" marB="18288">
+                    <a:solidFill>
+                      <a:srgbClr val="ECF1F6"/>
+                    </a:solidFill>
+                  </a:tcPr>
+                </a:tc>
+                <a:tc>
+                  <a:txBody>
+                    <a:bodyPr wrap="square"/>
+                    <a:lstStyle/>
+                    <a:p>
+                      <a:r>
+                        <a:rPr sz="1100" b="0">
+                          <a:solidFill>
+                            <a:srgbClr val="282828"/>
+                          </a:solidFill>
+                          <a:latin typeface="Arial"/>
+                        </a:rPr>
+                        <a:t>per-ray re-trace, 1e-9 m</a:t>
+                      </a:r>
+                    </a:p>
+                  </a:txBody>
+                  <a:tcPr marL="54864" marR="54864" marT="18288" marB="18288">
+                    <a:solidFill>
+                      <a:srgbClr val="ECF1F6"/>
                     </a:solidFill>
                   </a:tcPr>
                 </a:tc>
@@ -16899,7 +17122,97 @@
                           </a:solidFill>
                           <a:latin typeface="Arial"/>
                         </a:rPr>
-                        <a:t>band</a:t>
+                        <a:t>propagation twin</a:t>
+                      </a:r>
+                    </a:p>
+                  </a:txBody>
+                  <a:tcPr marL="54864" marR="54864" marT="18288" marB="18288">
+                    <a:solidFill>
+                      <a:srgbClr val="FFFFFF"/>
+                    </a:solidFill>
+                  </a:tcPr>
+                </a:tc>
+                <a:tc>
+                  <a:txBody>
+                    <a:bodyPr wrap="square"/>
+                    <a:lstStyle/>
+                    <a:p>
+                      <a:r>
+                        <a:rPr sz="1100" b="0">
+                          <a:solidFill>
+                            <a:srgbClr val="282828"/>
+                          </a:solidFill>
+                          <a:latin typeface="Arial"/>
+                        </a:rPr>
+                        <a:t>s2w (opt-in, model 512)</a:t>
+                      </a:r>
+                    </a:p>
+                  </a:txBody>
+                  <a:tcPr marL="54864" marR="54864" marT="18288" marB="18288">
+                    <a:solidFill>
+                      <a:srgbClr val="FFFFFF"/>
+                    </a:solidFill>
+                  </a:tcPr>
+                </a:tc>
+                <a:tc>
+                  <a:txBody>
+                    <a:bodyPr wrap="square"/>
+                    <a:lstStyle/>
+                    <a:p>
+                      <a:r>
+                        <a:rPr sz="1100" b="0">
+                          <a:solidFill>
+                            <a:srgbClr val="282828"/>
+                          </a:solidFill>
+                          <a:latin typeface="Arial"/>
+                        </a:rPr>
+                        <a:t>dyson5_s2w.txt</a:t>
+                      </a:r>
+                    </a:p>
+                  </a:txBody>
+                  <a:tcPr marL="54864" marR="54864" marT="18288" marB="18288">
+                    <a:solidFill>
+                      <a:srgbClr val="FFFFFF"/>
+                    </a:solidFill>
+                  </a:tcPr>
+                </a:tc>
+                <a:tc>
+                  <a:txBody>
+                    <a:bodyPr wrap="square"/>
+                    <a:lstStyle/>
+                    <a:p>
+                      <a:r>
+                        <a:rPr sz="1100" b="0">
+                          <a:solidFill>
+                            <a:srgbClr val="282828"/>
+                          </a:solidFill>
+                          <a:latin typeface="Arial"/>
+                        </a:rPr>
+                        <a:t>spectrometer_wave.m</a:t>
+                      </a:r>
+                    </a:p>
+                  </a:txBody>
+                  <a:tcPr marL="54864" marR="54864" marT="18288" marB="18288">
+                    <a:solidFill>
+                      <a:srgbClr val="FFFFFF"/>
+                    </a:solidFill>
+                  </a:tcPr>
+                </a:tc>
+              </a:tr>
+              <a:tr h="468630">
+                <a:tc>
+                  <a:txBody>
+                    <a:bodyPr wrap="square"/>
+                    <a:lstStyle/>
+                    <a:p>
+                      <a:r>
+                        <a:rPr sz="1100" b="0">
+                          <a:solidFill>
+                            <a:srgbClr val="282828"/>
+                          </a:solidFill>
+                          <a:latin typeface="Arial"/>
+                        </a:rPr>
+                        <a:t>departure ladder, R4, trade</a:t>
                       </a:r>
                     </a:p>
                   </a:txBody>
@@ -16921,7 +17234,51 @@
                           </a:solidFill>
                           <a:latin typeface="Arial"/>
                         </a:rPr>
-                        <a:t>380–2500 nm, 4.24 nm per pixel</a:t>
+                        <a:t>s3, s3free, s3b</a:t>
+                      </a:r>
+                    </a:p>
+                  </a:txBody>
+                  <a:tcPr marL="54864" marR="54864" marT="18288" marB="18288">
+                    <a:solidFill>
+                      <a:srgbClr val="ECF1F6"/>
+                    </a:solidFill>
+                  </a:tcPr>
+                </a:tc>
+                <a:tc>
+                  <a:txBody>
+                    <a:bodyPr wrap="square"/>
+                    <a:lstStyle/>
+                    <a:p>
+                      <a:r>
+                        <a:rPr sz="1100" b="0">
+                          <a:solidFill>
+                            <a:srgbClr val="282828"/>
+                          </a:solidFill>
+                          <a:latin typeface="Arial"/>
+                        </a:rPr>
+                        <a:t>dyson5_s3.txt, dyson5_s3free.txt, dyson5_s3_trade.txt, dyson5_s3_layout_r.png, dyson5_s3_maps_r.png</a:t>
+                      </a:r>
+                    </a:p>
+                  </a:txBody>
+                  <a:tcPr marL="54864" marR="54864" marT="18288" marB="18288">
+                    <a:solidFill>
+                      <a:srgbClr val="ECF1F6"/>
+                    </a:solidFill>
+                  </a:tcPr>
+                </a:tc>
+                <a:tc>
+                  <a:txBody>
+                    <a:bodyPr wrap="square"/>
+                    <a:lstStyle/>
+                    <a:p>
+                      <a:r>
+                        <a:rPr sz="1100" b="0">
+                          <a:solidFill>
+                            <a:srgbClr val="282828"/>
+                          </a:solidFill>
+                          <a:latin typeface="Arial"/>
+                        </a:rPr>
+                        <a:t>dyson_ladder.m, dyson5_trade.m</a:t>
                       </a:r>
                     </a:p>
                   </a:txBody>
@@ -16945,29 +17302,253 @@
                           </a:solidFill>
                           <a:latin typeface="Arial"/>
                         </a:rPr>
-                        <a:t>smile, keystone</a:t>
-                      </a:r>
-                    </a:p>
-                  </a:txBody>
-                  <a:tcPr marL="54864" marR="54864" marT="18288" marB="18288">
-                    <a:solidFill>
-                      <a:srgbClr val="FFFFFF"/>
-                    </a:solidFill>
-                  </a:tcPr>
-                </a:tc>
-                <a:tc>
-                  <a:txBody>
-                    <a:bodyPr wrap="square"/>
-                    <a:lstStyle/>
-                    <a:p>
-                      <a:r>
-                        <a:rPr sz="1100" b="0">
-                          <a:solidFill>
-                            <a:srgbClr val="282828"/>
-                          </a:solidFill>
-                          <a:latin typeface="Arial"/>
-                        </a:rPr>
-                        <a:t>&lt; 0.1 pixel</a:t>
+                        <a:t>meniscus search</a:t>
+                      </a:r>
+                    </a:p>
+                  </a:txBody>
+                  <a:tcPr marL="54864" marR="54864" marT="18288" marB="18288">
+                    <a:solidFill>
+                      <a:srgbClr val="FFFFFF"/>
+                    </a:solidFill>
+                  </a:tcPr>
+                </a:tc>
+                <a:tc>
+                  <a:txBody>
+                    <a:bodyPr wrap="square"/>
+                    <a:lstStyle/>
+                    <a:p>
+                      <a:r>
+                        <a:rPr sz="1100" b="0">
+                          <a:solidFill>
+                            <a:srgbClr val="282828"/>
+                          </a:solidFill>
+                          <a:latin typeface="Arial"/>
+                        </a:rPr>
+                        <a:t>tool</a:t>
+                      </a:r>
+                    </a:p>
+                  </a:txBody>
+                  <a:tcPr marL="54864" marR="54864" marT="18288" marB="18288">
+                    <a:solidFill>
+                      <a:srgbClr val="FFFFFF"/>
+                    </a:solidFill>
+                  </a:tcPr>
+                </a:tc>
+                <a:tc>
+                  <a:txBody>
+                    <a:bodyPr wrap="square"/>
+                    <a:lstStyle/>
+                    <a:p>
+                      <a:r>
+                        <a:rPr sz="1100" b="0">
+                          <a:solidFill>
+                            <a:srgbClr val="282828"/>
+                          </a:solidFill>
+                          <a:latin typeface="Arial"/>
+                        </a:rPr>
+                        <a:t>dyson5_s3_r4global.txt</a:t>
+                      </a:r>
+                    </a:p>
+                  </a:txBody>
+                  <a:tcPr marL="54864" marR="54864" marT="18288" marB="18288">
+                    <a:solidFill>
+                      <a:srgbClr val="FFFFFF"/>
+                    </a:solidFill>
+                  </a:tcPr>
+                </a:tc>
+                <a:tc>
+                  <a:txBody>
+                    <a:bodyPr wrap="square"/>
+                    <a:lstStyle/>
+                    <a:p>
+                      <a:r>
+                        <a:rPr sz="1100" b="0">
+                          <a:solidFill>
+                            <a:srgbClr val="282828"/>
+                          </a:solidFill>
+                          <a:latin typeface="Arial"/>
+                        </a:rPr>
+                        <a:t>dyson_r4_global.m</a:t>
+                      </a:r>
+                    </a:p>
+                  </a:txBody>
+                  <a:tcPr marL="54864" marR="54864" marT="18288" marB="18288">
+                    <a:solidFill>
+                      <a:srgbClr val="FFFFFF"/>
+                    </a:solidFill>
+                  </a:tcPr>
+                </a:tc>
+              </a:tr>
+              <a:tr h="468630">
+                <a:tc>
+                  <a:txBody>
+                    <a:bodyPr wrap="square"/>
+                    <a:lstStyle/>
+                    <a:p>
+                      <a:r>
+                        <a:rPr sz="1100" b="0">
+                          <a:solidFill>
+                            <a:srgbClr val="282828"/>
+                          </a:solidFill>
+                          <a:latin typeface="Arial"/>
+                        </a:rPr>
+                        <a:t>slit loss</a:t>
+                      </a:r>
+                    </a:p>
+                  </a:txBody>
+                  <a:tcPr marL="54864" marR="54864" marT="18288" marB="18288">
+                    <a:solidFill>
+                      <a:srgbClr val="ECF1F6"/>
+                    </a:solidFill>
+                  </a:tcPr>
+                </a:tc>
+                <a:tc>
+                  <a:txBody>
+                    <a:bodyPr wrap="square"/>
+                    <a:lstStyle/>
+                    <a:p>
+                      <a:r>
+                        <a:rPr sz="1100" b="0">
+                          <a:solidFill>
+                            <a:srgbClr val="282828"/>
+                          </a:solidFill>
+                          <a:latin typeface="Arial"/>
+                        </a:rPr>
+                        <a:t>s2l + tool</a:t>
+                      </a:r>
+                    </a:p>
+                  </a:txBody>
+                  <a:tcPr marL="54864" marR="54864" marT="18288" marB="18288">
+                    <a:solidFill>
+                      <a:srgbClr val="ECF1F6"/>
+                    </a:solidFill>
+                  </a:tcPr>
+                </a:tc>
+                <a:tc>
+                  <a:txBody>
+                    <a:bodyPr wrap="square"/>
+                    <a:lstStyle/>
+                    <a:p>
+                      <a:r>
+                        <a:rPr sz="1100" b="0">
+                          <a:solidFill>
+                            <a:srgbClr val="282828"/>
+                          </a:solidFill>
+                          <a:latin typeface="Arial"/>
+                        </a:rPr>
+                        <a:t>dyson5_s2l.txt, dyson5_s2l_tests.txt, dyson5_s2l_slitloss.png</a:t>
+                      </a:r>
+                    </a:p>
+                  </a:txBody>
+                  <a:tcPr marL="54864" marR="54864" marT="18288" marB="18288">
+                    <a:solidFill>
+                      <a:srgbClr val="ECF1F6"/>
+                    </a:solidFill>
+                  </a:tcPr>
+                </a:tc>
+                <a:tc>
+                  <a:txBody>
+                    <a:bodyPr wrap="square"/>
+                    <a:lstStyle/>
+                    <a:p>
+                      <a:r>
+                        <a:rPr sz="1100" b="0">
+                          <a:solidFill>
+                            <a:srgbClr val="282828"/>
+                          </a:solidFill>
+                          <a:latin typeface="Arial"/>
+                        </a:rPr>
+                        <a:t>far-field leg vs sinc²; dyson5_slitloss_tests.m</a:t>
+                      </a:r>
+                    </a:p>
+                  </a:txBody>
+                  <a:tcPr marL="54864" marR="54864" marT="18288" marB="18288">
+                    <a:solidFill>
+                      <a:srgbClr val="ECF1F6"/>
+                    </a:solidFill>
+                  </a:tcPr>
+                </a:tc>
+              </a:tr>
+              <a:tr h="468630">
+                <a:tc>
+                  <a:txBody>
+                    <a:bodyPr wrap="square"/>
+                    <a:lstStyle/>
+                    <a:p>
+                      <a:r>
+                        <a:rPr sz="1100" b="0">
+                          <a:solidFill>
+                            <a:srgbClr val="282828"/>
+                          </a:solidFill>
+                          <a:latin typeface="Arial"/>
+                        </a:rPr>
+                        <a:t>fold prism, cold shield</a:t>
+                      </a:r>
+                    </a:p>
+                  </a:txBody>
+                  <a:tcPr marL="54864" marR="54864" marT="18288" marB="18288">
+                    <a:solidFill>
+                      <a:srgbClr val="FFFFFF"/>
+                    </a:solidFill>
+                  </a:tcPr>
+                </a:tc>
+                <a:tc>
+                  <a:txBody>
+                    <a:bodyPr wrap="square"/>
+                    <a:lstStyle/>
+                    <a:p>
+                      <a:r>
+                        <a:rPr sz="1100" b="0">
+                          <a:solidFill>
+                            <a:srgbClr val="282828"/>
+                          </a:solidFill>
+                          <a:latin typeface="Arial"/>
+                        </a:rPr>
+                        <a:t>s5</a:t>
+                      </a:r>
+                    </a:p>
+                  </a:txBody>
+                  <a:tcPr marL="54864" marR="54864" marT="18288" marB="18288">
+                    <a:solidFill>
+                      <a:srgbClr val="FFFFFF"/>
+                    </a:solidFill>
+                  </a:tcPr>
+                </a:tc>
+                <a:tc>
+                  <a:txBody>
+                    <a:bodyPr wrap="square"/>
+                    <a:lstStyle/>
+                    <a:p>
+                      <a:r>
+                        <a:rPr sz="1100" b="0">
+                          <a:solidFill>
+                            <a:srgbClr val="282828"/>
+                          </a:solidFill>
+                          <a:latin typeface="Arial"/>
+                        </a:rPr>
+                        <a:t>dyson5_s5.txt, dyson5_s5_r5_h*.in, dyson5_s5_maps_r5.png, dyson5_s5_sweep.png</a:t>
+                      </a:r>
+                    </a:p>
+                  </a:txBody>
+                  <a:tcPr marL="54864" marR="54864" marT="18288" marB="18288">
+                    <a:solidFill>
+                      <a:srgbClr val="FFFFFF"/>
+                    </a:solidFill>
+                  </a:tcPr>
+                </a:tc>
+                <a:tc>
+                  <a:txBody>
+                    <a:bodyPr wrap="square"/>
+                    <a:lstStyle/>
+                    <a:p>
+                      <a:r>
+                        <a:rPr sz="1100" b="0">
+                          <a:solidFill>
+                            <a:srgbClr val="282828"/>
+                          </a:solidFill>
+                          <a:latin typeface="Arial"/>
+                        </a:rPr>
+                        <a:t>spectrometer_geom.m (form dyson_fold), spectrometer_clearance.m</a:t>
                       </a:r>
                     </a:p>
                   </a:txBody>
@@ -16991,7 +17572,7 @@
                           </a:solidFill>
                           <a:latin typeface="Arial"/>
                         </a:rPr>
-                        <a:t>SRF FWHM</a:t>
+                        <a:t>closure envelope</a:t>
                       </a:r>
                     </a:p>
                   </a:txBody>
@@ -17013,7 +17594,7 @@
                           </a:solidFill>
                           <a:latin typeface="Arial"/>
                         </a:rPr>
-                        <a:t>&lt; 1.5–2.0 pixels</a:t>
+                        <a:t>s4env</a:t>
                       </a:r>
                     </a:p>
                   </a:txBody>
@@ -17023,49 +17604,47 @@
                     </a:solidFill>
                   </a:tcPr>
                 </a:tc>
-              </a:tr>
-              <a:tr h="280035">
-                <a:tc>
-                  <a:txBody>
-                    <a:bodyPr wrap="square"/>
-                    <a:lstStyle/>
-                    <a:p>
-                      <a:r>
-                        <a:rPr sz="1100" b="0">
-                          <a:solidFill>
-                            <a:srgbClr val="282828"/>
-                          </a:solidFill>
-                          <a:latin typeface="Arial"/>
-                        </a:rPr>
-                        <a:t>CRF FWHM</a:t>
-                      </a:r>
-                    </a:p>
-                  </a:txBody>
-                  <a:tcPr marL="54864" marR="54864" marT="18288" marB="18288">
-                    <a:solidFill>
-                      <a:srgbClr val="FFFFFF"/>
-                    </a:solidFill>
-                  </a:tcPr>
-                </a:tc>
-                <a:tc>
-                  <a:txBody>
-                    <a:bodyPr wrap="square"/>
-                    <a:lstStyle/>
-                    <a:p>
-                      <a:r>
-                        <a:rPr sz="1100" b="0">
-                          <a:solidFill>
-                            <a:srgbClr val="282828"/>
-                          </a:solidFill>
-                          <a:latin typeface="Arial"/>
-                        </a:rPr>
-                        <a:t>&lt; 1.5 pixels</a:t>
-                      </a:r>
-                    </a:p>
-                  </a:txBody>
-                  <a:tcPr marL="54864" marR="54864" marT="18288" marB="18288">
-                    <a:solidFill>
-                      <a:srgbClr val="FFFFFF"/>
+                <a:tc>
+                  <a:txBody>
+                    <a:bodyPr wrap="square"/>
+                    <a:lstStyle/>
+                    <a:p>
+                      <a:r>
+                        <a:rPr sz="1100" b="0">
+                          <a:solidFill>
+                            <a:srgbClr val="282828"/>
+                          </a:solidFill>
+                          <a:latin typeface="Arial"/>
+                        </a:rPr>
+                        <a:t>dyson5_s4env.txt, dyson5_s4env.png, dyson5_s4env_*.in</a:t>
+                      </a:r>
+                    </a:p>
+                  </a:txBody>
+                  <a:tcPr marL="54864" marR="54864" marT="18288" marB="18288">
+                    <a:solidFill>
+                      <a:srgbClr val="ECF1F6"/>
+                    </a:solidFill>
+                  </a:tcPr>
+                </a:tc>
+                <a:tc>
+                  <a:txBody>
+                    <a:bodyPr wrap="square"/>
+                    <a:lstStyle/>
+                    <a:p>
+                      <a:r>
+                        <a:rPr sz="1100" b="0">
+                          <a:solidFill>
+                            <a:srgbClr val="282828"/>
+                          </a:solidFill>
+                          <a:latin typeface="Arial"/>
+                        </a:rPr>
+                        <a:t>dyson5_envelope.m</a:t>
+                      </a:r>
+                    </a:p>
+                  </a:txBody>
+                  <a:tcPr marL="54864" marR="54864" marT="18288" marB="18288">
+                    <a:solidFill>
+                      <a:srgbClr val="ECF1F6"/>
                     </a:solidFill>
                   </a:tcPr>
                 </a:tc>
@@ -17083,35 +17662,79 @@
                           </a:solidFill>
                           <a:latin typeface="Arial"/>
                         </a:rPr>
-                        <a:t>radiometric chain</a:t>
-                      </a:r>
-                    </a:p>
-                  </a:txBody>
-                  <a:tcPr marL="54864" marR="54864" marT="18288" marB="18288">
-                    <a:solidFill>
-                      <a:srgbClr val="ECF1F6"/>
-                    </a:solidFill>
-                  </a:tcPr>
-                </a:tc>
-                <a:tc>
-                  <a:txBody>
-                    <a:bodyPr wrap="square"/>
-                    <a:lstStyle/>
-                    <a:p>
-                      <a:r>
-                        <a:rPr sz="1100" b="0">
-                          <a:solidFill>
-                            <a:srgbClr val="282828"/>
-                          </a:solidFill>
-                          <a:latin typeface="Arial"/>
-                        </a:rPr>
-                        <a:t>throughput, grating efficiency, QE, slit loss vs wavelength</a:t>
-                      </a:r>
-                    </a:p>
-                  </a:txBody>
-                  <a:tcPr marL="54864" marR="54864" marT="18288" marB="18288">
-                    <a:solidFill>
-                      <a:srgbClr val="ECF1F6"/>
+                        <a:t>native optimizer</a:t>
+                      </a:r>
+                    </a:p>
+                  </a:txBody>
+                  <a:tcPr marL="54864" marR="54864" marT="18288" marB="18288">
+                    <a:solidFill>
+                      <a:srgbClr val="FFFFFF"/>
+                    </a:solidFill>
+                  </a:tcPr>
+                </a:tc>
+                <a:tc>
+                  <a:txBody>
+                    <a:bodyPr wrap="square"/>
+                    <a:lstStyle/>
+                    <a:p>
+                      <a:r>
+                        <a:rPr sz="1100" b="0">
+                          <a:solidFill>
+                            <a:srgbClr val="282828"/>
+                          </a:solidFill>
+                          <a:latin typeface="Arial"/>
+                        </a:rPr>
+                        <a:t>s4</a:t>
+                      </a:r>
+                    </a:p>
+                  </a:txBody>
+                  <a:tcPr marL="54864" marR="54864" marT="18288" marB="18288">
+                    <a:solidFill>
+                      <a:srgbClr val="FFFFFF"/>
+                    </a:solidFill>
+                  </a:tcPr>
+                </a:tc>
+                <a:tc>
+                  <a:txBody>
+                    <a:bodyPr wrap="square"/>
+                    <a:lstStyle/>
+                    <a:p>
+                      <a:r>
+                        <a:rPr sz="1100" b="0">
+                          <a:solidFill>
+                            <a:srgbClr val="282828"/>
+                          </a:solidFill>
+                          <a:latin typeface="Arial"/>
+                        </a:rPr>
+                        <a:t>dyson5_s4.txt, dyson5_s4_r4n_seed.in (the CALIB deck), dyson5_s4_r4n.in</a:t>
+                      </a:r>
+                    </a:p>
+                  </a:txBody>
+                  <a:tcPr marL="54864" marR="54864" marT="18288" marB="18288">
+                    <a:solidFill>
+                      <a:srgbClr val="FFFFFF"/>
+                    </a:solidFill>
+                  </a:tcPr>
+                </a:tc>
+                <a:tc>
+                  <a:txBody>
+                    <a:bodyPr wrap="square"/>
+                    <a:lstStyle/>
+                    <a:p>
+                      <a:r>
+                        <a:rPr sz="1100" b="0">
+                          <a:solidFill>
+                            <a:srgbClr val="282828"/>
+                          </a:solidFill>
+                          <a:latin typeface="Arial"/>
+                        </a:rPr>
+                        <a:t>dyson_native.m</a:t>
+                      </a:r>
+                    </a:p>
+                  </a:txBody>
+                  <a:tcPr marL="54864" marR="54864" marT="18288" marB="18288">
+                    <a:solidFill>
+                      <a:srgbClr val="FFFFFF"/>
                     </a:solidFill>
                   </a:tcPr>
                 </a:tc>
@@ -17128,8 +17751,8 @@
         </p:nvSpPr>
         <p:spPr>
           <a:xfrm>
-            <a:off x="6400800" y="1298448"/>
-            <a:ext cx="5394960" cy="274320"/>
+            <a:off x="411480" y="5936742"/>
+            <a:ext cx="11368735" cy="274320"/>
           </a:xfrm>
           <a:prstGeom prst="rect">
             <a:avLst/>
@@ -17148,100 +17771,13 @@
               </a:spcAft>
             </a:pPr>
             <a:r>
-              <a:rPr sz="1200" b="0">
-                <a:solidFill>
-                  <a:srgbClr val="282828"/>
-                </a:solidFill>
-                <a:latin typeface="Arial"/>
-              </a:rPr>
-              <a:t>•  Smile: centroid drift along the slit at fixed wavelength; keystone: drift across wavelength at fixed slit position; both in pixels from ray centroids.</a:t>
-            </a:r>
-          </a:p>
-          <a:p>
-            <a:pPr>
-              <a:spcAft>
-                <a:spcPts val="600"/>
-              </a:spcAft>
-            </a:pPr>
-            <a:r>
-              <a:rPr sz="1200" b="0">
-                <a:solidFill>
-                  <a:srgbClr val="282828"/>
-                </a:solidFill>
-                <a:latin typeface="Arial"/>
-              </a:rPr>
-              <a:t>•  SRF, CRF: slit ⊗ line-spread function ⊗ pixel ⊗ Airy, FWHM in pixels (Mouroulis &amp; Green 2018 definitions); the Airy diameter at 2500 nm is 11 µm, under the 18 µm pixel, so the incoherent chain is valid.</a:t>
-            </a:r>
-          </a:p>
-          <a:p>
-            <a:pPr>
-              <a:spcAft>
-                <a:spcPts val="600"/>
-              </a:spcAft>
-            </a:pPr>
-            <a:r>
-              <a:rPr sz="1200" b="0">
-                <a:solidFill>
-                  <a:srgbClr val="282828"/>
-                </a:solidFill>
-                <a:latin typeface="Arial"/>
-              </a:rPr>
-              <a:t>•  Design rules adopted from the literature: distortion to ~1 % of a pixel at design, &gt; 75 % of the energy in one pixel, degraded spots accepted for uniformity, the grating is the stop.</a:t>
-            </a:r>
-          </a:p>
-          <a:p>
-            <a:pPr>
-              <a:spcAft>
-                <a:spcPts val="600"/>
-              </a:spcAft>
-            </a:pPr>
-            <a:r>
-              <a:rPr sz="1200" b="0">
-                <a:solidFill>
-                  <a:srgbClr val="282828"/>
-                </a:solidFill>
-                <a:latin typeface="Arial"/>
-              </a:rPr>
-              <a:t>•  Realism (Jim): as-built SRF is 2.5–3 pixels, slits are 2 pixels wide, the systems are photon-limited; smile and keystone drive the design.</a:t>
-            </a:r>
-          </a:p>
-        </p:txBody>
-      </p:sp>
-      <p:sp>
-        <p:nvSpPr>
-          <p:cNvPr id="6" name="TextBox 5"/>
-          <p:cNvSpPr txBox="1"/>
-          <p:nvPr/>
-        </p:nvSpPr>
-        <p:spPr>
-          <a:xfrm>
-            <a:off x="6400800" y="4075175"/>
-            <a:ext cx="5394960" cy="274320"/>
-          </a:xfrm>
-          <a:prstGeom prst="rect">
-            <a:avLst/>
-          </a:prstGeom>
-          <a:noFill/>
-        </p:spPr>
-        <p:txBody>
-          <a:bodyPr wrap="square">
-            <a:spAutoFit/>
-          </a:bodyPr>
-          <a:lstStyle/>
-          <a:p>
-            <a:pPr>
-              <a:spcAft>
-                <a:spcPts val="600"/>
-              </a:spcAft>
-            </a:pPr>
-            <a:r>
               <a:rPr sz="1050" b="0">
                 <a:solidFill>
                   <a:srgbClr val="6E6E6E"/>
                 </a:solidFill>
                 <a:latin typeface="Arial"/>
               </a:rPr>
-              <a:t>The 54 mm slit is 2.3× EMIT's; Table 3 of the review places this spec in the ALIS class (3200 spatial pixels, 380–2500 nm).  Public comparison point: Carbon-I (arXiv:2505.22545), F/2.2, 2040–2380 nm.</a:t>
+              <a:t>Conventions behind the scaling law: block index n(silica, 1 µm) = 1.450417; in-glass marginal half-angle u = asin(1 / 2nF); field height h from the Dyson axis on the flat face; the slit corner is h = hypot(27 mm, 8 mm).</a:t>
             </a:r>
           </a:p>
         </p:txBody>
@@ -17254,7 +17790,7 @@
 </p:sld>
 </file>
 
-<file path=ppt/slides/slide30.xml><?xml version="1.0" encoding="utf-8"?>
+<file path=ppt/slides/slide32.xml><?xml version="1.0" encoding="utf-8"?>
 <p:sld xmlns:a="http://schemas.openxmlformats.org/drawingml/2006/main" xmlns:p="http://schemas.openxmlformats.org/presentationml/2006/main" xmlns:r="http://schemas.openxmlformats.org/officeDocument/2006/relationships">
   <p:cSld>
     <p:spTree>

</xml_diff>

<commit_message>
deck_dyson: the block-size trade (CCMac, resources 9d3b6e2) -- two slides (figure; the numbers per family), the ladder table's glass column named as the hemisphere with the edged block's 3.7 L / 8.2 kg, the module-count decision in next steps, records row; 34 slides.  Edit copy NOT synced: it carries Dave's title-slide change
Co-Authored-By: Claude Fable 5.1 <noreply@anthropic.com>
</commit_message>
<xml_diff>
--- a/demo_session/deck_dyson.pptx
+++ b/demo_session/deck_dyson.pptx
@@ -37,6 +37,8 @@
     <p:sldId id="285" r:id="rId36"/>
     <p:sldId id="286" r:id="rId37"/>
     <p:sldId id="287" r:id="rId38"/>
+    <p:sldId id="288" r:id="rId39"/>
+    <p:sldId id="289" r:id="rId40"/>
   </p:sldIdLst>
   <p:sldSz cx="12191695" cy="6858000" type="screen4x3"/>
   <p:notesSz cx="6858000" cy="9144000"/>
@@ -3217,7 +3219,7 @@
                 </a:solidFill>
                 <a:latin typeface="Arial"/>
               </a:rPr>
-              <a:t>DRAFT — in progress.  Every number is from a committed, parameterized runner (mmacos, dyson5_run); records and figures are the runner's own output.  Design of record: the compact variant (step R4): keystone 0.0026 px, smile 0.005 px, CRF 1.33 px, 76 % of the energy in one pixel, at a 220 mm block.  The propagated point-spread function reproduces the ray centroids to 0.002 px, so these are the numbers a detector sees.  The fold-prism layout (step R5) takes the detector package out of the slit's plane at CRF 1.27 px and 70 % in one pixel; a cold shield cannot be bought in this form, since every millimetre of air before the detector costs about 0.5 px of CRF.</a:t>
+              <a:t>DRAFT — in progress.  Every number is from a committed, parameterized runner (mmacos, dyson5_run); records and figures are the runner's own output.  Design of record: the compact variant (step R4): keystone 0.0026 px, smile 0.005 px, CRF 1.33 px, 76 % of the energy in one pixel, at a 220 mm block.  The propagated point-spread function reproduces the ray centroids to 0.002 px, so these are the numbers a detector sees.  The fold-prism layout (step R5) takes the detector package out of the slit's plane at CRF 1.27 px and 70 % in one pixel; a cold shield cannot be bought in this form, since every millimetre of air before the detector costs about 0.5 px of CRF.  The block's size follows the slit: shared between two 27 mm modules, a 130 mm block of 1.7 kg matches the record against 220 mm and 8.2 kg for one module.</a:t>
             </a:r>
           </a:p>
         </p:txBody>
@@ -5410,7 +5412,7 @@
                 </a:solidFill>
                 <a:latin typeface="Arial"/>
               </a:rPr>
-              <a:t>SRF FWHM is 2.02–2.05 px on every step: the 2-pixel-slit floor.  Length = slit plane to grating vertex; footprint = diameter of the grating hits over slit centre and ends × band edges; glass = block cap + meniscus.  Record dyson5_s3_trade.txt.</a:t>
+              <a:t>SRF FWHM is 2.02–2.05 px on every step: the 2-pixel-slit floor.  Length = slit plane to grating vertex; footprint = diameter of the grating hits over slit centre and ends × band edges; glass = the full hemispherical cap + meniscus, an upper bound: edged to its clear aperture the R4 block is a rod 147 mm across and 221 mm long, 3.7 L and 8.2 kg in silica.  Record dyson5_s3_trade.txt.</a:t>
             </a:r>
           </a:p>
         </p:txBody>
@@ -9698,6 +9700,38 @@
               <a:t>•  14 The compact variant: the prescription</a:t>
             </a:r>
           </a:p>
+          <a:p>
+            <a:pPr>
+              <a:spcAft>
+                <a:spcPts val="600"/>
+              </a:spcAft>
+            </a:pPr>
+            <a:r>
+              <a:rPr sz="1200" b="0">
+                <a:solidFill>
+                  <a:srgbClr val="282828"/>
+                </a:solidFill>
+                <a:latin typeface="Arial"/>
+              </a:rPr>
+              <a:t>•  15 The compact variant in section</a:t>
+            </a:r>
+          </a:p>
+          <a:p>
+            <a:pPr>
+              <a:spcAft>
+                <a:spcPts val="600"/>
+              </a:spcAft>
+            </a:pPr>
+            <a:r>
+              <a:rPr sz="1200" b="0">
+                <a:solidFill>
+                  <a:srgbClr val="282828"/>
+                </a:solidFill>
+                <a:latin typeface="Arial"/>
+              </a:rPr>
+              <a:t>•  16 The compact variant, scored</a:t>
+            </a:r>
+          </a:p>
         </p:txBody>
       </p:sp>
       <p:sp>
@@ -9734,38 +9768,6 @@
                 </a:solidFill>
                 <a:latin typeface="Arial"/>
               </a:rPr>
-              <a:t>•  15 The compact variant in section</a:t>
-            </a:r>
-          </a:p>
-          <a:p>
-            <a:pPr>
-              <a:spcAft>
-                <a:spcPts val="600"/>
-              </a:spcAft>
-            </a:pPr>
-            <a:r>
-              <a:rPr sz="1200" b="0">
-                <a:solidFill>
-                  <a:srgbClr val="282828"/>
-                </a:solidFill>
-                <a:latin typeface="Arial"/>
-              </a:rPr>
-              <a:t>•  16 The compact variant, scored</a:t>
-            </a:r>
-          </a:p>
-          <a:p>
-            <a:pPr>
-              <a:spcAft>
-                <a:spcPts val="600"/>
-              </a:spcAft>
-            </a:pPr>
-            <a:r>
-              <a:rPr sz="1200" b="0">
-                <a:solidFill>
-                  <a:srgbClr val="282828"/>
-                </a:solidFill>
-                <a:latin typeface="Arial"/>
-              </a:rPr>
               <a:t>•  17 The trade at a glance</a:t>
             </a:r>
           </a:p>
@@ -9894,7 +9896,7 @@
                 </a:solidFill>
                 <a:latin typeface="Arial"/>
               </a:rPr>
-              <a:t>•  25 The telescope that feeds the slit</a:t>
+              <a:t>•  25 How small can the block be</a:t>
             </a:r>
           </a:p>
           <a:p>
@@ -9910,7 +9912,7 @@
                 </a:solidFill>
                 <a:latin typeface="Arial"/>
               </a:rPr>
-              <a:t>•  26 Telescope and spectrometer end to end</a:t>
+              <a:t>•  26 The block-size trade, by the numbers</a:t>
             </a:r>
           </a:p>
           <a:p>
@@ -9926,7 +9928,7 @@
                 </a:solidFill>
                 <a:latin typeface="Arial"/>
               </a:rPr>
-              <a:t>•  27 Next steps</a:t>
+              <a:t>•  27 The telescope that feeds the slit</a:t>
             </a:r>
           </a:p>
           <a:p>
@@ -9942,7 +9944,7 @@
                 </a:solidFill>
                 <a:latin typeface="Arial"/>
               </a:rPr>
-              <a:t>•  28 Run it yourself</a:t>
+              <a:t>•  28 Telescope and spectrometer end to end</a:t>
             </a:r>
           </a:p>
           <a:p>
@@ -9958,7 +9960,39 @@
                 </a:solidFill>
                 <a:latin typeface="Arial"/>
               </a:rPr>
-              <a:t>•  29 Backup</a:t>
+              <a:t>•  29 Next steps</a:t>
+            </a:r>
+          </a:p>
+          <a:p>
+            <a:pPr>
+              <a:spcAft>
+                <a:spcPts val="600"/>
+              </a:spcAft>
+            </a:pPr>
+            <a:r>
+              <a:rPr sz="1200" b="0">
+                <a:solidFill>
+                  <a:srgbClr val="282828"/>
+                </a:solidFill>
+                <a:latin typeface="Arial"/>
+              </a:rPr>
+              <a:t>•  30 Run it yourself</a:t>
+            </a:r>
+          </a:p>
+          <a:p>
+            <a:pPr>
+              <a:spcAft>
+                <a:spcPts val="600"/>
+              </a:spcAft>
+            </a:pPr>
+            <a:r>
+              <a:rPr sz="1200" b="0">
+                <a:solidFill>
+                  <a:srgbClr val="282828"/>
+                </a:solidFill>
+                <a:latin typeface="Arial"/>
+              </a:rPr>
+              <a:t>•  31 Backup</a:t>
             </a:r>
           </a:p>
         </p:txBody>
@@ -13829,6 +13863,1435 @@
                 </a:solidFill>
                 <a:latin typeface="Arial"/>
               </a:rPr>
+              <a:t>How small can the block be</a:t>
+            </a:r>
+          </a:p>
+          <a:p>
+            <a:pPr>
+              <a:spcAft>
+                <a:spcPts val="0"/>
+              </a:spcAft>
+            </a:pPr>
+            <a:r>
+              <a:rPr sz="1250" b="0">
+                <a:solidFill>
+                  <a:srgbClr val="6E6E6E"/>
+                </a:solidFill>
+                <a:latin typeface="Arial"/>
+              </a:rPr>
+              <a:t>The slit is the lever, not the glass: one module at the full 54 mm slit cannot shrink; two modules of 27 mm match the record with a 130 mm block of 1.7 kg</a:t>
+            </a:r>
+          </a:p>
+        </p:txBody>
+      </p:sp>
+      <p:sp>
+        <p:nvSpPr>
+          <p:cNvPr id="3" name="Rectangle 2"/>
+          <p:cNvSpPr/>
+          <p:nvPr/>
+        </p:nvSpPr>
+        <p:spPr>
+          <a:xfrm>
+            <a:off x="411480" y="1133856"/>
+            <a:ext cx="11368735" cy="20320"/>
+          </a:xfrm>
+          <a:prstGeom prst="rect">
+            <a:avLst/>
+          </a:prstGeom>
+          <a:solidFill>
+            <a:srgbClr val="B8C6D4"/>
+          </a:solidFill>
+          <a:ln>
+            <a:noFill/>
+          </a:ln>
+          <a:effectLst/>
+        </p:spPr>
+        <p:style>
+          <a:lnRef idx="1">
+            <a:schemeClr val="accent1"/>
+          </a:lnRef>
+          <a:fillRef idx="3">
+            <a:schemeClr val="accent1"/>
+          </a:fillRef>
+          <a:effectRef idx="2">
+            <a:schemeClr val="accent1"/>
+          </a:effectRef>
+          <a:fontRef idx="minor">
+            <a:schemeClr val="lt1"/>
+          </a:fontRef>
+        </p:style>
+        <p:txBody>
+          <a:bodyPr rtlCol="0" anchor="ctr"/>
+          <a:lstStyle/>
+          <a:p>
+            <a:pPr algn="ctr"/>
+          </a:p>
+        </p:txBody>
+      </p:sp>
+      <p:sp>
+        <p:nvSpPr>
+          <p:cNvPr id="4" name="TextBox 3"/>
+          <p:cNvSpPr txBox="1"/>
+          <p:nvPr/>
+        </p:nvSpPr>
+        <p:spPr>
+          <a:xfrm>
+            <a:off x="411480" y="1298448"/>
+            <a:ext cx="11368735" cy="274320"/>
+          </a:xfrm>
+          <a:prstGeom prst="rect">
+            <a:avLst/>
+          </a:prstGeom>
+          <a:noFill/>
+        </p:spPr>
+        <p:txBody>
+          <a:bodyPr wrap="square">
+            <a:spAutoFit/>
+          </a:bodyPr>
+          <a:lstStyle/>
+          <a:p>
+            <a:pPr>
+              <a:spcAft>
+                <a:spcPts val="600"/>
+              </a:spcAft>
+            </a:pPr>
+            <a:r>
+              <a:rPr sz="1500" b="0">
+                <a:solidFill>
+                  <a:srgbClr val="282828"/>
+                </a:solidFill>
+                <a:latin typeface="Arial"/>
+              </a:rPr>
+              <a:t>•  Why the record is 220 mm thick: in the Dyson form the flat face sits at the center of curvature, so the block's thickness is its radius, and the blur law of the scaling slide (h⁴/r³) ties the radius to the slit length.</a:t>
+            </a:r>
+          </a:p>
+          <a:p>
+            <a:pPr>
+              <a:spcAft>
+                <a:spcPts val="600"/>
+              </a:spcAft>
+            </a:pPr>
+            <a:r>
+              <a:rPr sz="1500" b="0">
+                <a:solidFill>
+                  <a:srgbClr val="282828"/>
+                </a:solidFill>
+                <a:latin typeface="Arial"/>
+              </a:rPr>
+              <a:t>•  The trade: each point is a full R4 re-solve walked down in radius, warm-started from the next larger block and scored in the engine; a filled marker matches the record's own scores.</a:t>
+            </a:r>
+          </a:p>
+        </p:txBody>
+      </p:sp>
+      <p:pic>
+        <p:nvPicPr>
+          <p:cNvPr id="5" name="Picture 4" descr="dyson5_size_rc.png"/>
+          <p:cNvPicPr>
+            <a:picLocks noChangeAspect="1"/>
+          </p:cNvPicPr>
+          <p:nvPr/>
+        </p:nvPicPr>
+        <p:blipFill>
+          <a:blip r:embed="rId2"/>
+          <a:stretch>
+            <a:fillRect/>
+          </a:stretch>
+        </p:blipFill>
+        <p:spPr>
+          <a:xfrm>
+            <a:off x="942381" y="2606039"/>
+            <a:ext cx="10306931" cy="3693160"/>
+          </a:xfrm>
+          <a:prstGeom prst="rect">
+            <a:avLst/>
+          </a:prstGeom>
+        </p:spPr>
+      </p:pic>
+      <p:sp>
+        <p:nvSpPr>
+          <p:cNvPr id="6" name="TextBox 5"/>
+          <p:cNvSpPr txBox="1"/>
+          <p:nvPr/>
+        </p:nvSpPr>
+        <p:spPr>
+          <a:xfrm>
+            <a:off x="411480" y="6317488"/>
+            <a:ext cx="11368735" cy="394208"/>
+          </a:xfrm>
+          <a:prstGeom prst="rect">
+            <a:avLst/>
+          </a:prstGeom>
+          <a:noFill/>
+        </p:spPr>
+        <p:txBody>
+          <a:bodyPr wrap="square">
+            <a:spAutoFit/>
+          </a:bodyPr>
+          <a:lstStyle/>
+          <a:p>
+            <a:pPr algn="ctr">
+              <a:spcAft>
+                <a:spcPts val="0"/>
+              </a:spcAft>
+            </a:pPr>
+            <a:r>
+              <a:rPr sz="1000" b="0">
+                <a:solidFill>
+                  <a:srgbClr val="6E6E6E"/>
+                </a:solidFill>
+                <a:latin typeface="Arial"/>
+              </a:rPr>
+              <a:t>Per block radius, four families: CRF (left), ensquared energy in one pixel (middle), mass of the edged block (right); filled markers match R4 of record, lines mark the record's values.</a:t>
+            </a:r>
+          </a:p>
+        </p:txBody>
+      </p:sp>
+    </p:spTree>
+  </p:cSld>
+  <p:clrMapOvr>
+    <a:masterClrMapping/>
+  </p:clrMapOvr>
+</p:sld>
+</file>
+
+<file path=ppt/slides/slide26.xml><?xml version="1.0" encoding="utf-8"?>
+<p:sld xmlns:a="http://schemas.openxmlformats.org/drawingml/2006/main" xmlns:p="http://schemas.openxmlformats.org/presentationml/2006/main" xmlns:r="http://schemas.openxmlformats.org/officeDocument/2006/relationships">
+  <p:cSld>
+    <p:spTree>
+      <p:nvGrpSpPr>
+        <p:cNvPr id="1" name=""/>
+        <p:cNvGrpSpPr/>
+        <p:nvPr/>
+      </p:nvGrpSpPr>
+      <p:grpSpPr/>
+      <p:sp>
+        <p:nvSpPr>
+          <p:cNvPr id="2" name="TextBox 1"/>
+          <p:cNvSpPr txBox="1"/>
+          <p:nvPr/>
+        </p:nvSpPr>
+        <p:spPr>
+          <a:xfrm>
+            <a:off x="411480" y="201168"/>
+            <a:ext cx="11368735" cy="914400"/>
+          </a:xfrm>
+          <a:prstGeom prst="rect">
+            <a:avLst/>
+          </a:prstGeom>
+          <a:noFill/>
+        </p:spPr>
+        <p:txBody>
+          <a:bodyPr wrap="square">
+            <a:spAutoFit/>
+          </a:bodyPr>
+          <a:lstStyle/>
+          <a:p>
+            <a:pPr>
+              <a:spcAft>
+                <a:spcPts val="400"/>
+              </a:spcAft>
+            </a:pPr>
+            <a:r>
+              <a:rPr sz="2400" b="1">
+                <a:solidFill>
+                  <a:srgbClr val="1F4E79"/>
+                </a:solidFill>
+                <a:latin typeface="Arial"/>
+              </a:rPr>
+              <a:t>The block-size trade, by the numbers</a:t>
+            </a:r>
+          </a:p>
+          <a:p>
+            <a:pPr>
+              <a:spcAft>
+                <a:spcPts val="0"/>
+              </a:spcAft>
+            </a:pPr>
+            <a:r>
+              <a:rPr sz="1250" b="0">
+                <a:solidFill>
+                  <a:srgbClr val="6E6E6E"/>
+                </a:solidFill>
+                <a:latin typeface="Arial"/>
+              </a:rPr>
+              <a:t>The smallest block per family that matches the record; mass is the block edged to its clear aperture</a:t>
+            </a:r>
+          </a:p>
+        </p:txBody>
+      </p:sp>
+      <p:sp>
+        <p:nvSpPr>
+          <p:cNvPr id="3" name="Rectangle 2"/>
+          <p:cNvSpPr/>
+          <p:nvPr/>
+        </p:nvSpPr>
+        <p:spPr>
+          <a:xfrm>
+            <a:off x="411480" y="1133856"/>
+            <a:ext cx="11368735" cy="20320"/>
+          </a:xfrm>
+          <a:prstGeom prst="rect">
+            <a:avLst/>
+          </a:prstGeom>
+          <a:solidFill>
+            <a:srgbClr val="B8C6D4"/>
+          </a:solidFill>
+          <a:ln>
+            <a:noFill/>
+          </a:ln>
+          <a:effectLst/>
+        </p:spPr>
+        <p:style>
+          <a:lnRef idx="1">
+            <a:schemeClr val="accent1"/>
+          </a:lnRef>
+          <a:fillRef idx="3">
+            <a:schemeClr val="accent1"/>
+          </a:fillRef>
+          <a:effectRef idx="2">
+            <a:schemeClr val="accent1"/>
+          </a:effectRef>
+          <a:fontRef idx="minor">
+            <a:schemeClr val="lt1"/>
+          </a:fontRef>
+        </p:style>
+        <p:txBody>
+          <a:bodyPr rtlCol="0" anchor="ctr"/>
+          <a:lstStyle/>
+          <a:p>
+            <a:pPr algn="ctr"/>
+          </a:p>
+        </p:txBody>
+      </p:sp>
+      <p:graphicFrame>
+        <p:nvGraphicFramePr>
+          <p:cNvPr id="4" name="Table 3"/>
+          <p:cNvGraphicFramePr>
+            <a:graphicFrameLocks noGrp="1"/>
+          </p:cNvGraphicFramePr>
+          <p:nvPr/>
+        </p:nvGraphicFramePr>
+        <p:xfrm>
+          <a:off x="411480" y="1298448"/>
+          <a:ext cx="11368732" cy="1680210"/>
+        </p:xfrm>
+        <a:graphic>
+          <a:graphicData uri="http://schemas.openxmlformats.org/drawingml/2006/table">
+            <a:tbl>
+              <a:tblPr firstRow="1" bandRow="1">
+                <a:tableStyleId>{5C22544A-7EE6-4342-B048-85BDC9FD1C3A}</a:tableStyleId>
+              </a:tblPr>
+              <a:tblGrid>
+                <a:gridCol w="4213587"/>
+                <a:gridCol w="1351527"/>
+                <a:gridCol w="1113023"/>
+                <a:gridCol w="1192524"/>
+                <a:gridCol w="636013"/>
+                <a:gridCol w="1192524"/>
+                <a:gridCol w="1669534"/>
+              </a:tblGrid>
+              <a:tr h="280035">
+                <a:tc>
+                  <a:txBody>
+                    <a:bodyPr wrap="square"/>
+                    <a:lstStyle/>
+                    <a:p>
+                      <a:r>
+                        <a:rPr sz="1100" b="1">
+                          <a:solidFill>
+                            <a:srgbClr val="FFFFFF"/>
+                          </a:solidFill>
+                          <a:latin typeface="Arial"/>
+                        </a:rPr>
+                        <a:t>configuration</a:t>
+                      </a:r>
+                    </a:p>
+                  </a:txBody>
+                  <a:tcPr marL="54864" marR="54864" marT="18288" marB="18288">
+                    <a:solidFill>
+                      <a:srgbClr val="1F4E79"/>
+                    </a:solidFill>
+                  </a:tcPr>
+                </a:tc>
+                <a:tc>
+                  <a:txBody>
+                    <a:bodyPr wrap="square"/>
+                    <a:lstStyle/>
+                    <a:p>
+                      <a:r>
+                        <a:rPr sz="1100" b="1">
+                          <a:solidFill>
+                            <a:srgbClr val="FFFFFF"/>
+                          </a:solidFill>
+                          <a:latin typeface="Arial"/>
+                        </a:rPr>
+                        <a:t>block radius (mm)</a:t>
+                      </a:r>
+                    </a:p>
+                  </a:txBody>
+                  <a:tcPr marL="54864" marR="54864" marT="18288" marB="18288">
+                    <a:solidFill>
+                      <a:srgbClr val="1F4E79"/>
+                    </a:solidFill>
+                  </a:tcPr>
+                </a:tc>
+                <a:tc>
+                  <a:txBody>
+                    <a:bodyPr wrap="square"/>
+                    <a:lstStyle/>
+                    <a:p>
+                      <a:r>
+                        <a:rPr sz="1100" b="1">
+                          <a:solidFill>
+                            <a:srgbClr val="FFFFFF"/>
+                          </a:solidFill>
+                          <a:latin typeface="Arial"/>
+                        </a:rPr>
+                        <a:t>thickness (mm)</a:t>
+                      </a:r>
+                    </a:p>
+                  </a:txBody>
+                  <a:tcPr marL="54864" marR="54864" marT="18288" marB="18288">
+                    <a:solidFill>
+                      <a:srgbClr val="1F4E79"/>
+                    </a:solidFill>
+                  </a:tcPr>
+                </a:tc>
+                <a:tc>
+                  <a:txBody>
+                    <a:bodyPr wrap="square"/>
+                    <a:lstStyle/>
+                    <a:p>
+                      <a:r>
+                        <a:rPr sz="1100" b="1">
+                          <a:solidFill>
+                            <a:srgbClr val="FFFFFF"/>
+                          </a:solidFill>
+                          <a:latin typeface="Arial"/>
+                        </a:rPr>
+                        <a:t>edged mass (kg)</a:t>
+                      </a:r>
+                    </a:p>
+                  </a:txBody>
+                  <a:tcPr marL="54864" marR="54864" marT="18288" marB="18288">
+                    <a:solidFill>
+                      <a:srgbClr val="1F4E79"/>
+                    </a:solidFill>
+                  </a:tcPr>
+                </a:tc>
+                <a:tc>
+                  <a:txBody>
+                    <a:bodyPr wrap="square"/>
+                    <a:lstStyle/>
+                    <a:p>
+                      <a:r>
+                        <a:rPr sz="1100" b="1">
+                          <a:solidFill>
+                            <a:srgbClr val="FFFFFF"/>
+                          </a:solidFill>
+                          <a:latin typeface="Arial"/>
+                        </a:rPr>
+                        <a:t>CRF (px)</a:t>
+                      </a:r>
+                    </a:p>
+                  </a:txBody>
+                  <a:tcPr marL="54864" marR="54864" marT="18288" marB="18288">
+                    <a:solidFill>
+                      <a:srgbClr val="1F4E79"/>
+                    </a:solidFill>
+                  </a:tcPr>
+                </a:tc>
+                <a:tc>
+                  <a:txBody>
+                    <a:bodyPr wrap="square"/>
+                    <a:lstStyle/>
+                    <a:p>
+                      <a:r>
+                        <a:rPr sz="1100" b="1">
+                          <a:solidFill>
+                            <a:srgbClr val="FFFFFF"/>
+                          </a:solidFill>
+                          <a:latin typeface="Arial"/>
+                        </a:rPr>
+                        <a:t>ensquared, 1 px</a:t>
+                      </a:r>
+                    </a:p>
+                  </a:txBody>
+                  <a:tcPr marL="54864" marR="54864" marT="18288" marB="18288">
+                    <a:solidFill>
+                      <a:srgbClr val="1F4E79"/>
+                    </a:solidFill>
+                  </a:tcPr>
+                </a:tc>
+                <a:tc>
+                  <a:txBody>
+                    <a:bodyPr wrap="square"/>
+                    <a:lstStyle/>
+                    <a:p>
+                      <a:r>
+                        <a:rPr sz="1100" b="1">
+                          <a:solidFill>
+                            <a:srgbClr val="FFFFFF"/>
+                          </a:solidFill>
+                          <a:latin typeface="Arial"/>
+                        </a:rPr>
+                        <a:t>smile / keystone (px)</a:t>
+                      </a:r>
+                    </a:p>
+                  </a:txBody>
+                  <a:tcPr marL="54864" marR="54864" marT="18288" marB="18288">
+                    <a:solidFill>
+                      <a:srgbClr val="1F4E79"/>
+                    </a:solidFill>
+                  </a:tcPr>
+                </a:tc>
+              </a:tr>
+              <a:tr h="280035">
+                <a:tc>
+                  <a:txBody>
+                    <a:bodyPr wrap="square"/>
+                    <a:lstStyle/>
+                    <a:p>
+                      <a:r>
+                        <a:rPr sz="1100" b="0">
+                          <a:solidFill>
+                            <a:srgbClr val="282828"/>
+                          </a:solidFill>
+                          <a:latin typeface="Arial"/>
+                        </a:rPr>
+                        <a:t>R4 of record: silica, one 54 mm slit</a:t>
+                      </a:r>
+                    </a:p>
+                  </a:txBody>
+                  <a:tcPr marL="54864" marR="54864" marT="18288" marB="18288">
+                    <a:solidFill>
+                      <a:srgbClr val="FFFFFF"/>
+                    </a:solidFill>
+                  </a:tcPr>
+                </a:tc>
+                <a:tc>
+                  <a:txBody>
+                    <a:bodyPr wrap="square"/>
+                    <a:lstStyle/>
+                    <a:p>
+                      <a:r>
+                        <a:rPr sz="1100" b="0">
+                          <a:solidFill>
+                            <a:srgbClr val="282828"/>
+                          </a:solidFill>
+                          <a:latin typeface="Arial"/>
+                        </a:rPr>
+                        <a:t>220</a:t>
+                      </a:r>
+                    </a:p>
+                  </a:txBody>
+                  <a:tcPr marL="54864" marR="54864" marT="18288" marB="18288">
+                    <a:solidFill>
+                      <a:srgbClr val="FFFFFF"/>
+                    </a:solidFill>
+                  </a:tcPr>
+                </a:tc>
+                <a:tc>
+                  <a:txBody>
+                    <a:bodyPr wrap="square"/>
+                    <a:lstStyle/>
+                    <a:p>
+                      <a:r>
+                        <a:rPr sz="1100" b="0">
+                          <a:solidFill>
+                            <a:srgbClr val="282828"/>
+                          </a:solidFill>
+                          <a:latin typeface="Arial"/>
+                        </a:rPr>
+                        <a:t>221</a:t>
+                      </a:r>
+                    </a:p>
+                  </a:txBody>
+                  <a:tcPr marL="54864" marR="54864" marT="18288" marB="18288">
+                    <a:solidFill>
+                      <a:srgbClr val="FFFFFF"/>
+                    </a:solidFill>
+                  </a:tcPr>
+                </a:tc>
+                <a:tc>
+                  <a:txBody>
+                    <a:bodyPr wrap="square"/>
+                    <a:lstStyle/>
+                    <a:p>
+                      <a:r>
+                        <a:rPr sz="1100" b="0">
+                          <a:solidFill>
+                            <a:srgbClr val="282828"/>
+                          </a:solidFill>
+                          <a:latin typeface="Arial"/>
+                        </a:rPr>
+                        <a:t>8.2</a:t>
+                      </a:r>
+                    </a:p>
+                  </a:txBody>
+                  <a:tcPr marL="54864" marR="54864" marT="18288" marB="18288">
+                    <a:solidFill>
+                      <a:srgbClr val="FFFFFF"/>
+                    </a:solidFill>
+                  </a:tcPr>
+                </a:tc>
+                <a:tc>
+                  <a:txBody>
+                    <a:bodyPr wrap="square"/>
+                    <a:lstStyle/>
+                    <a:p>
+                      <a:r>
+                        <a:rPr sz="1100" b="0">
+                          <a:solidFill>
+                            <a:srgbClr val="282828"/>
+                          </a:solidFill>
+                          <a:latin typeface="Arial"/>
+                        </a:rPr>
+                        <a:t>1.33</a:t>
+                      </a:r>
+                    </a:p>
+                  </a:txBody>
+                  <a:tcPr marL="54864" marR="54864" marT="18288" marB="18288">
+                    <a:solidFill>
+                      <a:srgbClr val="FFFFFF"/>
+                    </a:solidFill>
+                  </a:tcPr>
+                </a:tc>
+                <a:tc>
+                  <a:txBody>
+                    <a:bodyPr wrap="square"/>
+                    <a:lstStyle/>
+                    <a:p>
+                      <a:r>
+                        <a:rPr sz="1100" b="0">
+                          <a:solidFill>
+                            <a:srgbClr val="282828"/>
+                          </a:solidFill>
+                          <a:latin typeface="Arial"/>
+                        </a:rPr>
+                        <a:t>0.76</a:t>
+                      </a:r>
+                    </a:p>
+                  </a:txBody>
+                  <a:tcPr marL="54864" marR="54864" marT="18288" marB="18288">
+                    <a:solidFill>
+                      <a:srgbClr val="FFFFFF"/>
+                    </a:solidFill>
+                  </a:tcPr>
+                </a:tc>
+                <a:tc>
+                  <a:txBody>
+                    <a:bodyPr wrap="square"/>
+                    <a:lstStyle/>
+                    <a:p>
+                      <a:r>
+                        <a:rPr sz="1100" b="0">
+                          <a:solidFill>
+                            <a:srgbClr val="282828"/>
+                          </a:solidFill>
+                          <a:latin typeface="Arial"/>
+                        </a:rPr>
+                        <a:t>0.005 / 0.003</a:t>
+                      </a:r>
+                    </a:p>
+                  </a:txBody>
+                  <a:tcPr marL="54864" marR="54864" marT="18288" marB="18288">
+                    <a:solidFill>
+                      <a:srgbClr val="FFFFFF"/>
+                    </a:solidFill>
+                  </a:tcPr>
+                </a:tc>
+              </a:tr>
+              <a:tr h="280035">
+                <a:tc>
+                  <a:txBody>
+                    <a:bodyPr wrap="square"/>
+                    <a:lstStyle/>
+                    <a:p>
+                      <a:r>
+                        <a:rPr sz="1100" b="0">
+                          <a:solidFill>
+                            <a:srgbClr val="282828"/>
+                          </a:solidFill>
+                          <a:latin typeface="Arial"/>
+                        </a:rPr>
+                        <a:t>CaF2, one 54 mm slit</a:t>
+                      </a:r>
+                    </a:p>
+                  </a:txBody>
+                  <a:tcPr marL="54864" marR="54864" marT="18288" marB="18288">
+                    <a:solidFill>
+                      <a:srgbClr val="ECF1F6"/>
+                    </a:solidFill>
+                  </a:tcPr>
+                </a:tc>
+                <a:tc>
+                  <a:txBody>
+                    <a:bodyPr wrap="square"/>
+                    <a:lstStyle/>
+                    <a:p>
+                      <a:r>
+                        <a:rPr sz="1100" b="0">
+                          <a:solidFill>
+                            <a:srgbClr val="282828"/>
+                          </a:solidFill>
+                          <a:latin typeface="Arial"/>
+                        </a:rPr>
+                        <a:t>180</a:t>
+                      </a:r>
+                    </a:p>
+                  </a:txBody>
+                  <a:tcPr marL="54864" marR="54864" marT="18288" marB="18288">
+                    <a:solidFill>
+                      <a:srgbClr val="ECF1F6"/>
+                    </a:solidFill>
+                  </a:tcPr>
+                </a:tc>
+                <a:tc>
+                  <a:txBody>
+                    <a:bodyPr wrap="square"/>
+                    <a:lstStyle/>
+                    <a:p>
+                      <a:r>
+                        <a:rPr sz="1100" b="0">
+                          <a:solidFill>
+                            <a:srgbClr val="282828"/>
+                          </a:solidFill>
+                          <a:latin typeface="Arial"/>
+                        </a:rPr>
+                        <a:t>181</a:t>
+                      </a:r>
+                    </a:p>
+                  </a:txBody>
+                  <a:tcPr marL="54864" marR="54864" marT="18288" marB="18288">
+                    <a:solidFill>
+                      <a:srgbClr val="ECF1F6"/>
+                    </a:solidFill>
+                  </a:tcPr>
+                </a:tc>
+                <a:tc>
+                  <a:txBody>
+                    <a:bodyPr wrap="square"/>
+                    <a:lstStyle/>
+                    <a:p>
+                      <a:r>
+                        <a:rPr sz="1100" b="0">
+                          <a:solidFill>
+                            <a:srgbClr val="282828"/>
+                          </a:solidFill>
+                          <a:latin typeface="Arial"/>
+                        </a:rPr>
+                        <a:t>7.9</a:t>
+                      </a:r>
+                    </a:p>
+                  </a:txBody>
+                  <a:tcPr marL="54864" marR="54864" marT="18288" marB="18288">
+                    <a:solidFill>
+                      <a:srgbClr val="ECF1F6"/>
+                    </a:solidFill>
+                  </a:tcPr>
+                </a:tc>
+                <a:tc>
+                  <a:txBody>
+                    <a:bodyPr wrap="square"/>
+                    <a:lstStyle/>
+                    <a:p>
+                      <a:r>
+                        <a:rPr sz="1100" b="0">
+                          <a:solidFill>
+                            <a:srgbClr val="282828"/>
+                          </a:solidFill>
+                          <a:latin typeface="Arial"/>
+                        </a:rPr>
+                        <a:t>1.20</a:t>
+                      </a:r>
+                    </a:p>
+                  </a:txBody>
+                  <a:tcPr marL="54864" marR="54864" marT="18288" marB="18288">
+                    <a:solidFill>
+                      <a:srgbClr val="ECF1F6"/>
+                    </a:solidFill>
+                  </a:tcPr>
+                </a:tc>
+                <a:tc>
+                  <a:txBody>
+                    <a:bodyPr wrap="square"/>
+                    <a:lstStyle/>
+                    <a:p>
+                      <a:r>
+                        <a:rPr sz="1100" b="0">
+                          <a:solidFill>
+                            <a:srgbClr val="282828"/>
+                          </a:solidFill>
+                          <a:latin typeface="Arial"/>
+                        </a:rPr>
+                        <a:t>0.82</a:t>
+                      </a:r>
+                    </a:p>
+                  </a:txBody>
+                  <a:tcPr marL="54864" marR="54864" marT="18288" marB="18288">
+                    <a:solidFill>
+                      <a:srgbClr val="ECF1F6"/>
+                    </a:solidFill>
+                  </a:tcPr>
+                </a:tc>
+                <a:tc>
+                  <a:txBody>
+                    <a:bodyPr wrap="square"/>
+                    <a:lstStyle/>
+                    <a:p>
+                      <a:r>
+                        <a:rPr sz="1100" b="0">
+                          <a:solidFill>
+                            <a:srgbClr val="282828"/>
+                          </a:solidFill>
+                          <a:latin typeface="Arial"/>
+                        </a:rPr>
+                        <a:t>0.017 / 0.020</a:t>
+                      </a:r>
+                    </a:p>
+                  </a:txBody>
+                  <a:tcPr marL="54864" marR="54864" marT="18288" marB="18288">
+                    <a:solidFill>
+                      <a:srgbClr val="ECF1F6"/>
+                    </a:solidFill>
+                  </a:tcPr>
+                </a:tc>
+              </a:tr>
+              <a:tr h="280035">
+                <a:tc>
+                  <a:txBody>
+                    <a:bodyPr wrap="square"/>
+                    <a:lstStyle/>
+                    <a:p>
+                      <a:r>
+                        <a:rPr sz="1100" b="0">
+                          <a:solidFill>
+                            <a:srgbClr val="282828"/>
+                          </a:solidFill>
+                          <a:latin typeface="Arial"/>
+                        </a:rPr>
+                        <a:t>silica, two 27 mm slits, the record's distortion kept</a:t>
+                      </a:r>
+                    </a:p>
+                  </a:txBody>
+                  <a:tcPr marL="54864" marR="54864" marT="18288" marB="18288">
+                    <a:solidFill>
+                      <a:srgbClr val="FFFFFF"/>
+                    </a:solidFill>
+                  </a:tcPr>
+                </a:tc>
+                <a:tc>
+                  <a:txBody>
+                    <a:bodyPr wrap="square"/>
+                    <a:lstStyle/>
+                    <a:p>
+                      <a:r>
+                        <a:rPr sz="1100" b="0">
+                          <a:solidFill>
+                            <a:srgbClr val="282828"/>
+                          </a:solidFill>
+                          <a:latin typeface="Arial"/>
+                        </a:rPr>
+                        <a:t>130</a:t>
+                      </a:r>
+                    </a:p>
+                  </a:txBody>
+                  <a:tcPr marL="54864" marR="54864" marT="18288" marB="18288">
+                    <a:solidFill>
+                      <a:srgbClr val="FFFFFF"/>
+                    </a:solidFill>
+                  </a:tcPr>
+                </a:tc>
+                <a:tc>
+                  <a:txBody>
+                    <a:bodyPr wrap="square"/>
+                    <a:lstStyle/>
+                    <a:p>
+                      <a:r>
+                        <a:rPr sz="1100" b="0">
+                          <a:solidFill>
+                            <a:srgbClr val="282828"/>
+                          </a:solidFill>
+                          <a:latin typeface="Arial"/>
+                        </a:rPr>
+                        <a:t>131</a:t>
+                      </a:r>
+                    </a:p>
+                  </a:txBody>
+                  <a:tcPr marL="54864" marR="54864" marT="18288" marB="18288">
+                    <a:solidFill>
+                      <a:srgbClr val="FFFFFF"/>
+                    </a:solidFill>
+                  </a:tcPr>
+                </a:tc>
+                <a:tc>
+                  <a:txBody>
+                    <a:bodyPr wrap="square"/>
+                    <a:lstStyle/>
+                    <a:p>
+                      <a:r>
+                        <a:rPr sz="1100" b="0">
+                          <a:solidFill>
+                            <a:srgbClr val="282828"/>
+                          </a:solidFill>
+                          <a:latin typeface="Arial"/>
+                        </a:rPr>
+                        <a:t>1.7 each</a:t>
+                      </a:r>
+                    </a:p>
+                  </a:txBody>
+                  <a:tcPr marL="54864" marR="54864" marT="18288" marB="18288">
+                    <a:solidFill>
+                      <a:srgbClr val="FFFFFF"/>
+                    </a:solidFill>
+                  </a:tcPr>
+                </a:tc>
+                <a:tc>
+                  <a:txBody>
+                    <a:bodyPr wrap="square"/>
+                    <a:lstStyle/>
+                    <a:p>
+                      <a:r>
+                        <a:rPr sz="1100" b="0">
+                          <a:solidFill>
+                            <a:srgbClr val="282828"/>
+                          </a:solidFill>
+                          <a:latin typeface="Arial"/>
+                        </a:rPr>
+                        <a:t>1.03</a:t>
+                      </a:r>
+                    </a:p>
+                  </a:txBody>
+                  <a:tcPr marL="54864" marR="54864" marT="18288" marB="18288">
+                    <a:solidFill>
+                      <a:srgbClr val="FFFFFF"/>
+                    </a:solidFill>
+                  </a:tcPr>
+                </a:tc>
+                <a:tc>
+                  <a:txBody>
+                    <a:bodyPr wrap="square"/>
+                    <a:lstStyle/>
+                    <a:p>
+                      <a:r>
+                        <a:rPr sz="1100" b="0">
+                          <a:solidFill>
+                            <a:srgbClr val="282828"/>
+                          </a:solidFill>
+                          <a:latin typeface="Arial"/>
+                        </a:rPr>
+                        <a:t>1.00</a:t>
+                      </a:r>
+                    </a:p>
+                  </a:txBody>
+                  <a:tcPr marL="54864" marR="54864" marT="18288" marB="18288">
+                    <a:solidFill>
+                      <a:srgbClr val="FFFFFF"/>
+                    </a:solidFill>
+                  </a:tcPr>
+                </a:tc>
+                <a:tc>
+                  <a:txBody>
+                    <a:bodyPr wrap="square"/>
+                    <a:lstStyle/>
+                    <a:p>
+                      <a:r>
+                        <a:rPr sz="1100" b="0">
+                          <a:solidFill>
+                            <a:srgbClr val="282828"/>
+                          </a:solidFill>
+                          <a:latin typeface="Arial"/>
+                        </a:rPr>
+                        <a:t>0.009 / 0.009</a:t>
+                      </a:r>
+                    </a:p>
+                  </a:txBody>
+                  <a:tcPr marL="54864" marR="54864" marT="18288" marB="18288">
+                    <a:solidFill>
+                      <a:srgbClr val="FFFFFF"/>
+                    </a:solidFill>
+                  </a:tcPr>
+                </a:tc>
+              </a:tr>
+              <a:tr h="280035">
+                <a:tc>
+                  <a:txBody>
+                    <a:bodyPr wrap="square"/>
+                    <a:lstStyle/>
+                    <a:p>
+                      <a:r>
+                        <a:rPr sz="1100" b="0">
+                          <a:solidFill>
+                            <a:srgbClr val="282828"/>
+                          </a:solidFill>
+                          <a:latin typeface="Arial"/>
+                        </a:rPr>
+                        <a:t>silica, two 27 mm slits, smallest</a:t>
+                      </a:r>
+                    </a:p>
+                  </a:txBody>
+                  <a:tcPr marL="54864" marR="54864" marT="18288" marB="18288">
+                    <a:solidFill>
+                      <a:srgbClr val="ECF1F6"/>
+                    </a:solidFill>
+                  </a:tcPr>
+                </a:tc>
+                <a:tc>
+                  <a:txBody>
+                    <a:bodyPr wrap="square"/>
+                    <a:lstStyle/>
+                    <a:p>
+                      <a:r>
+                        <a:rPr sz="1100" b="0">
+                          <a:solidFill>
+                            <a:srgbClr val="282828"/>
+                          </a:solidFill>
+                          <a:latin typeface="Arial"/>
+                        </a:rPr>
+                        <a:t>100</a:t>
+                      </a:r>
+                    </a:p>
+                  </a:txBody>
+                  <a:tcPr marL="54864" marR="54864" marT="18288" marB="18288">
+                    <a:solidFill>
+                      <a:srgbClr val="ECF1F6"/>
+                    </a:solidFill>
+                  </a:tcPr>
+                </a:tc>
+                <a:tc>
+                  <a:txBody>
+                    <a:bodyPr wrap="square"/>
+                    <a:lstStyle/>
+                    <a:p>
+                      <a:r>
+                        <a:rPr sz="1100" b="0">
+                          <a:solidFill>
+                            <a:srgbClr val="282828"/>
+                          </a:solidFill>
+                          <a:latin typeface="Arial"/>
+                        </a:rPr>
+                        <a:t>101</a:t>
+                      </a:r>
+                    </a:p>
+                  </a:txBody>
+                  <a:tcPr marL="54864" marR="54864" marT="18288" marB="18288">
+                    <a:solidFill>
+                      <a:srgbClr val="ECF1F6"/>
+                    </a:solidFill>
+                  </a:tcPr>
+                </a:tc>
+                <a:tc>
+                  <a:txBody>
+                    <a:bodyPr wrap="square"/>
+                    <a:lstStyle/>
+                    <a:p>
+                      <a:r>
+                        <a:rPr sz="1100" b="0">
+                          <a:solidFill>
+                            <a:srgbClr val="282828"/>
+                          </a:solidFill>
+                          <a:latin typeface="Arial"/>
+                        </a:rPr>
+                        <a:t>1.0 each</a:t>
+                      </a:r>
+                    </a:p>
+                  </a:txBody>
+                  <a:tcPr marL="54864" marR="54864" marT="18288" marB="18288">
+                    <a:solidFill>
+                      <a:srgbClr val="ECF1F6"/>
+                    </a:solidFill>
+                  </a:tcPr>
+                </a:tc>
+                <a:tc>
+                  <a:txBody>
+                    <a:bodyPr wrap="square"/>
+                    <a:lstStyle/>
+                    <a:p>
+                      <a:r>
+                        <a:rPr sz="1100" b="0">
+                          <a:solidFill>
+                            <a:srgbClr val="282828"/>
+                          </a:solidFill>
+                          <a:latin typeface="Arial"/>
+                        </a:rPr>
+                        <a:t>1.05</a:t>
+                      </a:r>
+                    </a:p>
+                  </a:txBody>
+                  <a:tcPr marL="54864" marR="54864" marT="18288" marB="18288">
+                    <a:solidFill>
+                      <a:srgbClr val="ECF1F6"/>
+                    </a:solidFill>
+                  </a:tcPr>
+                </a:tc>
+                <a:tc>
+                  <a:txBody>
+                    <a:bodyPr wrap="square"/>
+                    <a:lstStyle/>
+                    <a:p>
+                      <a:r>
+                        <a:rPr sz="1100" b="0">
+                          <a:solidFill>
+                            <a:srgbClr val="282828"/>
+                          </a:solidFill>
+                          <a:latin typeface="Arial"/>
+                        </a:rPr>
+                        <a:t>0.96</a:t>
+                      </a:r>
+                    </a:p>
+                  </a:txBody>
+                  <a:tcPr marL="54864" marR="54864" marT="18288" marB="18288">
+                    <a:solidFill>
+                      <a:srgbClr val="ECF1F6"/>
+                    </a:solidFill>
+                  </a:tcPr>
+                </a:tc>
+                <a:tc>
+                  <a:txBody>
+                    <a:bodyPr wrap="square"/>
+                    <a:lstStyle/>
+                    <a:p>
+                      <a:r>
+                        <a:rPr sz="1100" b="0">
+                          <a:solidFill>
+                            <a:srgbClr val="282828"/>
+                          </a:solidFill>
+                          <a:latin typeface="Arial"/>
+                        </a:rPr>
+                        <a:t>0.044 / 0.049</a:t>
+                      </a:r>
+                    </a:p>
+                  </a:txBody>
+                  <a:tcPr marL="54864" marR="54864" marT="18288" marB="18288">
+                    <a:solidFill>
+                      <a:srgbClr val="ECF1F6"/>
+                    </a:solidFill>
+                  </a:tcPr>
+                </a:tc>
+              </a:tr>
+              <a:tr h="280035">
+                <a:tc>
+                  <a:txBody>
+                    <a:bodyPr wrap="square"/>
+                    <a:lstStyle/>
+                    <a:p>
+                      <a:r>
+                        <a:rPr sz="1100" b="0">
+                          <a:solidFill>
+                            <a:srgbClr val="282828"/>
+                          </a:solidFill>
+                          <a:latin typeface="Arial"/>
+                        </a:rPr>
+                        <a:t>CaF2, two 27 mm slits, smallest</a:t>
+                      </a:r>
+                    </a:p>
+                  </a:txBody>
+                  <a:tcPr marL="54864" marR="54864" marT="18288" marB="18288">
+                    <a:solidFill>
+                      <a:srgbClr val="FFFFFF"/>
+                    </a:solidFill>
+                  </a:tcPr>
+                </a:tc>
+                <a:tc>
+                  <a:txBody>
+                    <a:bodyPr wrap="square"/>
+                    <a:lstStyle/>
+                    <a:p>
+                      <a:r>
+                        <a:rPr sz="1100" b="0">
+                          <a:solidFill>
+                            <a:srgbClr val="282828"/>
+                          </a:solidFill>
+                          <a:latin typeface="Arial"/>
+                        </a:rPr>
+                        <a:t>80</a:t>
+                      </a:r>
+                    </a:p>
+                  </a:txBody>
+                  <a:tcPr marL="54864" marR="54864" marT="18288" marB="18288">
+                    <a:solidFill>
+                      <a:srgbClr val="FFFFFF"/>
+                    </a:solidFill>
+                  </a:tcPr>
+                </a:tc>
+                <a:tc>
+                  <a:txBody>
+                    <a:bodyPr wrap="square"/>
+                    <a:lstStyle/>
+                    <a:p>
+                      <a:r>
+                        <a:rPr sz="1100" b="0">
+                          <a:solidFill>
+                            <a:srgbClr val="282828"/>
+                          </a:solidFill>
+                          <a:latin typeface="Arial"/>
+                        </a:rPr>
+                        <a:t>81</a:t>
+                      </a:r>
+                    </a:p>
+                  </a:txBody>
+                  <a:tcPr marL="54864" marR="54864" marT="18288" marB="18288">
+                    <a:solidFill>
+                      <a:srgbClr val="FFFFFF"/>
+                    </a:solidFill>
+                  </a:tcPr>
+                </a:tc>
+                <a:tc>
+                  <a:txBody>
+                    <a:bodyPr wrap="square"/>
+                    <a:lstStyle/>
+                    <a:p>
+                      <a:r>
+                        <a:rPr sz="1100" b="0">
+                          <a:solidFill>
+                            <a:srgbClr val="282828"/>
+                          </a:solidFill>
+                          <a:latin typeface="Arial"/>
+                        </a:rPr>
+                        <a:t>0.9 each</a:t>
+                      </a:r>
+                    </a:p>
+                  </a:txBody>
+                  <a:tcPr marL="54864" marR="54864" marT="18288" marB="18288">
+                    <a:solidFill>
+                      <a:srgbClr val="FFFFFF"/>
+                    </a:solidFill>
+                  </a:tcPr>
+                </a:tc>
+                <a:tc>
+                  <a:txBody>
+                    <a:bodyPr wrap="square"/>
+                    <a:lstStyle/>
+                    <a:p>
+                      <a:r>
+                        <a:rPr sz="1100" b="0">
+                          <a:solidFill>
+                            <a:srgbClr val="282828"/>
+                          </a:solidFill>
+                          <a:latin typeface="Arial"/>
+                        </a:rPr>
+                        <a:t>1.04</a:t>
+                      </a:r>
+                    </a:p>
+                  </a:txBody>
+                  <a:tcPr marL="54864" marR="54864" marT="18288" marB="18288">
+                    <a:solidFill>
+                      <a:srgbClr val="FFFFFF"/>
+                    </a:solidFill>
+                  </a:tcPr>
+                </a:tc>
+                <a:tc>
+                  <a:txBody>
+                    <a:bodyPr wrap="square"/>
+                    <a:lstStyle/>
+                    <a:p>
+                      <a:r>
+                        <a:rPr sz="1100" b="0">
+                          <a:solidFill>
+                            <a:srgbClr val="282828"/>
+                          </a:solidFill>
+                          <a:latin typeface="Arial"/>
+                        </a:rPr>
+                        <a:t>0.97</a:t>
+                      </a:r>
+                    </a:p>
+                  </a:txBody>
+                  <a:tcPr marL="54864" marR="54864" marT="18288" marB="18288">
+                    <a:solidFill>
+                      <a:srgbClr val="FFFFFF"/>
+                    </a:solidFill>
+                  </a:tcPr>
+                </a:tc>
+                <a:tc>
+                  <a:txBody>
+                    <a:bodyPr wrap="square"/>
+                    <a:lstStyle/>
+                    <a:p>
+                      <a:r>
+                        <a:rPr sz="1100" b="0">
+                          <a:solidFill>
+                            <a:srgbClr val="282828"/>
+                          </a:solidFill>
+                          <a:latin typeface="Arial"/>
+                        </a:rPr>
+                        <a:t>0.009 / 0.018</a:t>
+                      </a:r>
+                    </a:p>
+                  </a:txBody>
+                  <a:tcPr marL="54864" marR="54864" marT="18288" marB="18288">
+                    <a:solidFill>
+                      <a:srgbClr val="FFFFFF"/>
+                    </a:solidFill>
+                  </a:tcPr>
+                </a:tc>
+              </a:tr>
+            </a:tbl>
+          </a:graphicData>
+        </a:graphic>
+      </p:graphicFrame>
+      <p:sp>
+        <p:nvSpPr>
+          <p:cNvPr id="5" name="TextBox 4"/>
+          <p:cNvSpPr txBox="1"/>
+          <p:nvPr/>
+        </p:nvSpPr>
+        <p:spPr>
+          <a:xfrm>
+            <a:off x="411480" y="3124962"/>
+            <a:ext cx="11368735" cy="274320"/>
+          </a:xfrm>
+          <a:prstGeom prst="rect">
+            <a:avLst/>
+          </a:prstGeom>
+          <a:noFill/>
+        </p:spPr>
+        <p:txBody>
+          <a:bodyPr wrap="square">
+            <a:spAutoFit/>
+          </a:bodyPr>
+          <a:lstStyle/>
+          <a:p>
+            <a:pPr>
+              <a:spcAft>
+                <a:spcPts val="600"/>
+              </a:spcAft>
+            </a:pPr>
+            <a:r>
+              <a:rPr sz="1500" b="0">
+                <a:solidFill>
+                  <a:srgbClr val="282828"/>
+                </a:solidFill>
+                <a:latin typeface="Arial"/>
+              </a:rPr>
+              <a:t>•  One module cannot shrink: silica already misses at 200 mm (CRF 1.34 px, 74 %), and CaF2's 180 mm block weighs the same as silica's 220 mm because it is denser.  The walk reproduces the closure envelope's 180 and 150 mm rows to 0.02 px, so those limits are the design's and not the solver's.</a:t>
+            </a:r>
+          </a:p>
+          <a:p>
+            <a:pPr>
+              <a:spcAft>
+                <a:spcPts val="600"/>
+              </a:spcAft>
+            </a:pPr>
+            <a:r>
+              <a:rPr sz="1500" b="0">
+                <a:solidFill>
+                  <a:srgbClr val="282828"/>
+                </a:solidFill>
+                <a:latin typeface="Arial"/>
+              </a:rPr>
+              <a:t>•  What two modules cost: two gratings and two detectors of 1500 pixels, and a swath split ahead of the slits, since each block is wider than its slit and the slits cannot abut.  The slit-to-detector clearance stays near 0.5 mm at every size.</a:t>
+            </a:r>
+          </a:p>
+          <a:p>
+            <a:pPr>
+              <a:spcAft>
+                <a:spcPts val="600"/>
+              </a:spcAft>
+            </a:pPr>
+            <a:r>
+              <a:rPr sz="1500" b="0">
+                <a:solidFill>
+                  <a:srgbClr val="282828"/>
+                </a:solidFill>
+                <a:latin typeface="Arial"/>
+              </a:rPr>
+              <a:t>•  What they also buy: halving the glass path halves the wavefront error from index inhomogeneity and from thermal gradients, estimated at 0.4 waves each for the 220 mm block.</a:t>
+            </a:r>
+          </a:p>
+        </p:txBody>
+      </p:sp>
+      <p:sp>
+        <p:nvSpPr>
+          <p:cNvPr id="6" name="TextBox 5"/>
+          <p:cNvSpPr txBox="1"/>
+          <p:nvPr/>
+        </p:nvSpPr>
+        <p:spPr>
+          <a:xfrm>
+            <a:off x="411480" y="5563362"/>
+            <a:ext cx="11368735" cy="274320"/>
+          </a:xfrm>
+          <a:prstGeom prst="rect">
+            <a:avLst/>
+          </a:prstGeom>
+          <a:noFill/>
+        </p:spPr>
+        <p:txBody>
+          <a:bodyPr wrap="square">
+            <a:spAutoFit/>
+          </a:bodyPr>
+          <a:lstStyle/>
+          <a:p>
+            <a:pPr>
+              <a:spcAft>
+                <a:spcPts val="600"/>
+              </a:spcAft>
+            </a:pPr>
+            <a:r>
+              <a:rPr sz="1050" b="0">
+                <a:solidFill>
+                  <a:srgbClr val="6E6E6E"/>
+                </a:solidFill>
+                <a:latin typeface="Arial"/>
+              </a:rPr>
+              <a:t>Record dyson5_size.txt (CCMac, 2026-10-02): 25 engine-scored points; the Mac's engine reproduces the Linux record of R4 to four decimals.</a:t>
+            </a:r>
+          </a:p>
+        </p:txBody>
+      </p:sp>
+    </p:spTree>
+  </p:cSld>
+  <p:clrMapOvr>
+    <a:masterClrMapping/>
+  </p:clrMapOvr>
+</p:sld>
+</file>
+
+<file path=ppt/slides/slide27.xml><?xml version="1.0" encoding="utf-8"?>
+<p:sld xmlns:a="http://schemas.openxmlformats.org/drawingml/2006/main" xmlns:p="http://schemas.openxmlformats.org/presentationml/2006/main" xmlns:r="http://schemas.openxmlformats.org/officeDocument/2006/relationships">
+  <p:cSld>
+    <p:spTree>
+      <p:nvGrpSpPr>
+        <p:cNvPr id="1" name=""/>
+        <p:cNvGrpSpPr/>
+        <p:nvPr/>
+      </p:nvGrpSpPr>
+      <p:grpSpPr/>
+      <p:sp>
+        <p:nvSpPr>
+          <p:cNvPr id="2" name="TextBox 1"/>
+          <p:cNvSpPr txBox="1"/>
+          <p:nvPr/>
+        </p:nvSpPr>
+        <p:spPr>
+          <a:xfrm>
+            <a:off x="411480" y="201168"/>
+            <a:ext cx="11368735" cy="914400"/>
+          </a:xfrm>
+          <a:prstGeom prst="rect">
+            <a:avLst/>
+          </a:prstGeom>
+          <a:noFill/>
+        </p:spPr>
+        <p:txBody>
+          <a:bodyPr wrap="square">
+            <a:spAutoFit/>
+          </a:bodyPr>
+          <a:lstStyle/>
+          <a:p>
+            <a:pPr>
+              <a:spcAft>
+                <a:spcPts val="400"/>
+              </a:spcAft>
+            </a:pPr>
+            <a:r>
+              <a:rPr sz="2400" b="1">
+                <a:solidFill>
+                  <a:srgbClr val="1F4E79"/>
+                </a:solidFill>
+                <a:latin typeface="Arial"/>
+              </a:rPr>
               <a:t>The telescope that feeds the slit, as traced by the engine</a:t>
             </a:r>
           </a:p>
@@ -14036,7 +15499,7 @@
 </p:sld>
 </file>
 
-<file path=ppt/slides/slide26.xml><?xml version="1.0" encoding="utf-8"?>
+<file path=ppt/slides/slide28.xml><?xml version="1.0" encoding="utf-8"?>
 <p:sld xmlns:a="http://schemas.openxmlformats.org/drawingml/2006/main" xmlns:p="http://schemas.openxmlformats.org/presentationml/2006/main" xmlns:r="http://schemas.openxmlformats.org/officeDocument/2006/relationships">
   <p:cSld>
     <p:spTree>
@@ -14287,7 +15750,7 @@
 </p:sld>
 </file>
 
-<file path=ppt/slides/slide27.xml><?xml version="1.0" encoding="utf-8"?>
+<file path=ppt/slides/slide29.xml><?xml version="1.0" encoding="utf-8"?>
 <p:sld xmlns:a="http://schemas.openxmlformats.org/drawingml/2006/main" xmlns:p="http://schemas.openxmlformats.org/presentationml/2006/main" xmlns:r="http://schemas.openxmlformats.org/officeDocument/2006/relationships">
   <p:cSld>
     <p:spTree>
@@ -14462,6 +15925,22 @@
                 </a:solidFill>
                 <a:latin typeface="Arial"/>
               </a:rPr>
+              <a:t>•  One module or two (a project decision): one 54 mm module needs the 220 mm, 8 kg block; two 27 mm modules need 130 mm and 1.7 kg each, with the swath split ahead of the slits.  The choice also sets the telescope's field: 24.6° for one, or 12.3° each for two.</a:t>
+            </a:r>
+          </a:p>
+          <a:p>
+            <a:pPr>
+              <a:spcAft>
+                <a:spcPts val="600"/>
+              </a:spcAft>
+            </a:pPr>
+            <a:r>
+              <a:rPr sz="1200" b="0">
+                <a:solidFill>
+                  <a:srgbClr val="282828"/>
+                </a:solidFill>
+                <a:latin typeface="Arial"/>
+              </a:rPr>
               <a:t>•  The radiometric chain against the band: throughput, grating efficiency, detector quantum efficiency and the slit loss above.</a:t>
             </a:r>
           </a:p>
@@ -14530,7 +16009,690 @@
 </p:sld>
 </file>
 
-<file path=ppt/slides/slide28.xml><?xml version="1.0" encoding="utf-8"?>
+<file path=ppt/slides/slide3.xml><?xml version="1.0" encoding="utf-8"?>
+<p:sld xmlns:a="http://schemas.openxmlformats.org/drawingml/2006/main" xmlns:p="http://schemas.openxmlformats.org/presentationml/2006/main" xmlns:r="http://schemas.openxmlformats.org/officeDocument/2006/relationships">
+  <p:cSld>
+    <p:spTree>
+      <p:nvGrpSpPr>
+        <p:cNvPr id="1" name=""/>
+        <p:cNvGrpSpPr/>
+        <p:nvPr/>
+      </p:nvGrpSpPr>
+      <p:grpSpPr/>
+      <p:sp>
+        <p:nvSpPr>
+          <p:cNvPr id="2" name="TextBox 1"/>
+          <p:cNvSpPr txBox="1"/>
+          <p:nvPr/>
+        </p:nvSpPr>
+        <p:spPr>
+          <a:xfrm>
+            <a:off x="411480" y="201168"/>
+            <a:ext cx="11368735" cy="914400"/>
+          </a:xfrm>
+          <a:prstGeom prst="rect">
+            <a:avLst/>
+          </a:prstGeom>
+          <a:noFill/>
+        </p:spPr>
+        <p:txBody>
+          <a:bodyPr wrap="square">
+            <a:spAutoFit/>
+          </a:bodyPr>
+          <a:lstStyle/>
+          <a:p>
+            <a:pPr>
+              <a:spcAft>
+                <a:spcPts val="400"/>
+              </a:spcAft>
+            </a:pPr>
+            <a:r>
+              <a:rPr sz="2400" b="1">
+                <a:solidFill>
+                  <a:srgbClr val="1F4E79"/>
+                </a:solidFill>
+                <a:latin typeface="Arial"/>
+              </a:rPr>
+              <a:t>The target and how it is scored</a:t>
+            </a:r>
+          </a:p>
+          <a:p>
+            <a:pPr>
+              <a:spcAft>
+                <a:spcPts val="0"/>
+              </a:spcAft>
+            </a:pPr>
+            <a:r>
+              <a:rPr sz="1250" b="0">
+                <a:solidFill>
+                  <a:srgbClr val="6E6E6E"/>
+                </a:solidFill>
+                <a:latin typeface="Arial"/>
+              </a:rPr>
+              <a:t>Joe's specification, EMIT-class; the metrics stated once, here</a:t>
+            </a:r>
+          </a:p>
+        </p:txBody>
+      </p:sp>
+      <p:sp>
+        <p:nvSpPr>
+          <p:cNvPr id="3" name="Rectangle 2"/>
+          <p:cNvSpPr/>
+          <p:nvPr/>
+        </p:nvSpPr>
+        <p:spPr>
+          <a:xfrm>
+            <a:off x="411480" y="1133856"/>
+            <a:ext cx="11368735" cy="20320"/>
+          </a:xfrm>
+          <a:prstGeom prst="rect">
+            <a:avLst/>
+          </a:prstGeom>
+          <a:solidFill>
+            <a:srgbClr val="B8C6D4"/>
+          </a:solidFill>
+          <a:ln>
+            <a:noFill/>
+          </a:ln>
+          <a:effectLst/>
+        </p:spPr>
+        <p:style>
+          <a:lnRef idx="1">
+            <a:schemeClr val="accent1"/>
+          </a:lnRef>
+          <a:fillRef idx="3">
+            <a:schemeClr val="accent1"/>
+          </a:fillRef>
+          <a:effectRef idx="2">
+            <a:schemeClr val="accent1"/>
+          </a:effectRef>
+          <a:fontRef idx="minor">
+            <a:schemeClr val="lt1"/>
+          </a:fontRef>
+        </p:style>
+        <p:txBody>
+          <a:bodyPr rtlCol="0" anchor="ctr"/>
+          <a:lstStyle/>
+          <a:p>
+            <a:pPr algn="ctr"/>
+          </a:p>
+        </p:txBody>
+      </p:sp>
+      <p:graphicFrame>
+        <p:nvGraphicFramePr>
+          <p:cNvPr id="4" name="Table 3"/>
+          <p:cNvGraphicFramePr>
+            <a:graphicFrameLocks noGrp="1"/>
+          </p:cNvGraphicFramePr>
+          <p:nvPr/>
+        </p:nvGraphicFramePr>
+        <p:xfrm>
+          <a:off x="411480" y="1298448"/>
+          <a:ext cx="5806439" cy="2897505"/>
+        </p:xfrm>
+        <a:graphic>
+          <a:graphicData uri="http://schemas.openxmlformats.org/drawingml/2006/table">
+            <a:tbl>
+              <a:tblPr firstRow="1" bandRow="1">
+                <a:tableStyleId>{5C22544A-7EE6-4342-B048-85BDC9FD1C3A}</a:tableStyleId>
+              </a:tblPr>
+              <a:tblGrid>
+                <a:gridCol w="2274687"/>
+                <a:gridCol w="3531752"/>
+              </a:tblGrid>
+              <a:tr h="280035">
+                <a:tc>
+                  <a:txBody>
+                    <a:bodyPr wrap="square"/>
+                    <a:lstStyle/>
+                    <a:p>
+                      <a:r>
+                        <a:rPr sz="1100" b="1">
+                          <a:solidFill>
+                            <a:srgbClr val="FFFFFF"/>
+                          </a:solidFill>
+                          <a:latin typeface="Arial"/>
+                        </a:rPr>
+                        <a:t>item</a:t>
+                      </a:r>
+                    </a:p>
+                  </a:txBody>
+                  <a:tcPr marL="54864" marR="54864" marT="18288" marB="18288">
+                    <a:solidFill>
+                      <a:srgbClr val="1F4E79"/>
+                    </a:solidFill>
+                  </a:tcPr>
+                </a:tc>
+                <a:tc>
+                  <a:txBody>
+                    <a:bodyPr wrap="square"/>
+                    <a:lstStyle/>
+                    <a:p>
+                      <a:r>
+                        <a:rPr sz="1100" b="1">
+                          <a:solidFill>
+                            <a:srgbClr val="FFFFFF"/>
+                          </a:solidFill>
+                          <a:latin typeface="Arial"/>
+                        </a:rPr>
+                        <a:t>value</a:t>
+                      </a:r>
+                    </a:p>
+                  </a:txBody>
+                  <a:tcPr marL="54864" marR="54864" marT="18288" marB="18288">
+                    <a:solidFill>
+                      <a:srgbClr val="1F4E79"/>
+                    </a:solidFill>
+                  </a:tcPr>
+                </a:tc>
+              </a:tr>
+              <a:tr h="468630">
+                <a:tc>
+                  <a:txBody>
+                    <a:bodyPr wrap="square"/>
+                    <a:lstStyle/>
+                    <a:p>
+                      <a:r>
+                        <a:rPr sz="1100" b="0">
+                          <a:solidFill>
+                            <a:srgbClr val="282828"/>
+                          </a:solidFill>
+                          <a:latin typeface="Arial"/>
+                        </a:rPr>
+                        <a:t>F-number (air-equivalent, image space)</a:t>
+                      </a:r>
+                    </a:p>
+                  </a:txBody>
+                  <a:tcPr marL="54864" marR="54864" marT="18288" marB="18288">
+                    <a:solidFill>
+                      <a:srgbClr val="FFFFFF"/>
+                    </a:solidFill>
+                  </a:tcPr>
+                </a:tc>
+                <a:tc>
+                  <a:txBody>
+                    <a:bodyPr wrap="square"/>
+                    <a:lstStyle/>
+                    <a:p>
+                      <a:r>
+                        <a:rPr sz="1100" b="0">
+                          <a:solidFill>
+                            <a:srgbClr val="282828"/>
+                          </a:solidFill>
+                          <a:latin typeface="Arial"/>
+                        </a:rPr>
+                        <a:t>1.8</a:t>
+                      </a:r>
+                    </a:p>
+                  </a:txBody>
+                  <a:tcPr marL="54864" marR="54864" marT="18288" marB="18288">
+                    <a:solidFill>
+                      <a:srgbClr val="FFFFFF"/>
+                    </a:solidFill>
+                  </a:tcPr>
+                </a:tc>
+              </a:tr>
+              <a:tr h="280035">
+                <a:tc>
+                  <a:txBody>
+                    <a:bodyPr wrap="square"/>
+                    <a:lstStyle/>
+                    <a:p>
+                      <a:r>
+                        <a:rPr sz="1100" b="0">
+                          <a:solidFill>
+                            <a:srgbClr val="282828"/>
+                          </a:solidFill>
+                          <a:latin typeface="Arial"/>
+                        </a:rPr>
+                        <a:t>focal plane</a:t>
+                      </a:r>
+                    </a:p>
+                  </a:txBody>
+                  <a:tcPr marL="54864" marR="54864" marT="18288" marB="18288">
+                    <a:solidFill>
+                      <a:srgbClr val="ECF1F6"/>
+                    </a:solidFill>
+                  </a:tcPr>
+                </a:tc>
+                <a:tc>
+                  <a:txBody>
+                    <a:bodyPr wrap="square"/>
+                    <a:lstStyle/>
+                    <a:p>
+                      <a:r>
+                        <a:rPr sz="1100" b="0">
+                          <a:solidFill>
+                            <a:srgbClr val="282828"/>
+                          </a:solidFill>
+                          <a:latin typeface="Arial"/>
+                        </a:rPr>
+                        <a:t>3000 spatial × 500 spectral pixels, 18 µm</a:t>
+                      </a:r>
+                    </a:p>
+                  </a:txBody>
+                  <a:tcPr marL="54864" marR="54864" marT="18288" marB="18288">
+                    <a:solidFill>
+                      <a:srgbClr val="ECF1F6"/>
+                    </a:solidFill>
+                  </a:tcPr>
+                </a:tc>
+              </a:tr>
+              <a:tr h="280035">
+                <a:tc>
+                  <a:txBody>
+                    <a:bodyPr wrap="square"/>
+                    <a:lstStyle/>
+                    <a:p>
+                      <a:r>
+                        <a:rPr sz="1100" b="0">
+                          <a:solidFill>
+                            <a:srgbClr val="282828"/>
+                          </a:solidFill>
+                          <a:latin typeface="Arial"/>
+                        </a:rPr>
+                        <a:t>slit</a:t>
+                      </a:r>
+                    </a:p>
+                  </a:txBody>
+                  <a:tcPr marL="54864" marR="54864" marT="18288" marB="18288">
+                    <a:solidFill>
+                      <a:srgbClr val="FFFFFF"/>
+                    </a:solidFill>
+                  </a:tcPr>
+                </a:tc>
+                <a:tc>
+                  <a:txBody>
+                    <a:bodyPr wrap="square"/>
+                    <a:lstStyle/>
+                    <a:p>
+                      <a:r>
+                        <a:rPr sz="1100" b="0">
+                          <a:solidFill>
+                            <a:srgbClr val="282828"/>
+                          </a:solidFill>
+                          <a:latin typeface="Arial"/>
+                        </a:rPr>
+                        <a:t>54 mm; spectral height 9 mm</a:t>
+                      </a:r>
+                    </a:p>
+                  </a:txBody>
+                  <a:tcPr marL="54864" marR="54864" marT="18288" marB="18288">
+                    <a:solidFill>
+                      <a:srgbClr val="FFFFFF"/>
+                    </a:solidFill>
+                  </a:tcPr>
+                </a:tc>
+              </a:tr>
+              <a:tr h="280035">
+                <a:tc>
+                  <a:txBody>
+                    <a:bodyPr wrap="square"/>
+                    <a:lstStyle/>
+                    <a:p>
+                      <a:r>
+                        <a:rPr sz="1100" b="0">
+                          <a:solidFill>
+                            <a:srgbClr val="282828"/>
+                          </a:solidFill>
+                          <a:latin typeface="Arial"/>
+                        </a:rPr>
+                        <a:t>band</a:t>
+                      </a:r>
+                    </a:p>
+                  </a:txBody>
+                  <a:tcPr marL="54864" marR="54864" marT="18288" marB="18288">
+                    <a:solidFill>
+                      <a:srgbClr val="ECF1F6"/>
+                    </a:solidFill>
+                  </a:tcPr>
+                </a:tc>
+                <a:tc>
+                  <a:txBody>
+                    <a:bodyPr wrap="square"/>
+                    <a:lstStyle/>
+                    <a:p>
+                      <a:r>
+                        <a:rPr sz="1100" b="0">
+                          <a:solidFill>
+                            <a:srgbClr val="282828"/>
+                          </a:solidFill>
+                          <a:latin typeface="Arial"/>
+                        </a:rPr>
+                        <a:t>380–2500 nm, 4.24 nm per pixel</a:t>
+                      </a:r>
+                    </a:p>
+                  </a:txBody>
+                  <a:tcPr marL="54864" marR="54864" marT="18288" marB="18288">
+                    <a:solidFill>
+                      <a:srgbClr val="ECF1F6"/>
+                    </a:solidFill>
+                  </a:tcPr>
+                </a:tc>
+              </a:tr>
+              <a:tr h="280035">
+                <a:tc>
+                  <a:txBody>
+                    <a:bodyPr wrap="square"/>
+                    <a:lstStyle/>
+                    <a:p>
+                      <a:r>
+                        <a:rPr sz="1100" b="0">
+                          <a:solidFill>
+                            <a:srgbClr val="282828"/>
+                          </a:solidFill>
+                          <a:latin typeface="Arial"/>
+                        </a:rPr>
+                        <a:t>smile, keystone</a:t>
+                      </a:r>
+                    </a:p>
+                  </a:txBody>
+                  <a:tcPr marL="54864" marR="54864" marT="18288" marB="18288">
+                    <a:solidFill>
+                      <a:srgbClr val="FFFFFF"/>
+                    </a:solidFill>
+                  </a:tcPr>
+                </a:tc>
+                <a:tc>
+                  <a:txBody>
+                    <a:bodyPr wrap="square"/>
+                    <a:lstStyle/>
+                    <a:p>
+                      <a:r>
+                        <a:rPr sz="1100" b="0">
+                          <a:solidFill>
+                            <a:srgbClr val="282828"/>
+                          </a:solidFill>
+                          <a:latin typeface="Arial"/>
+                        </a:rPr>
+                        <a:t>&lt; 0.1 pixel</a:t>
+                      </a:r>
+                    </a:p>
+                  </a:txBody>
+                  <a:tcPr marL="54864" marR="54864" marT="18288" marB="18288">
+                    <a:solidFill>
+                      <a:srgbClr val="FFFFFF"/>
+                    </a:solidFill>
+                  </a:tcPr>
+                </a:tc>
+              </a:tr>
+              <a:tr h="280035">
+                <a:tc>
+                  <a:txBody>
+                    <a:bodyPr wrap="square"/>
+                    <a:lstStyle/>
+                    <a:p>
+                      <a:r>
+                        <a:rPr sz="1100" b="0">
+                          <a:solidFill>
+                            <a:srgbClr val="282828"/>
+                          </a:solidFill>
+                          <a:latin typeface="Arial"/>
+                        </a:rPr>
+                        <a:t>SRF FWHM</a:t>
+                      </a:r>
+                    </a:p>
+                  </a:txBody>
+                  <a:tcPr marL="54864" marR="54864" marT="18288" marB="18288">
+                    <a:solidFill>
+                      <a:srgbClr val="ECF1F6"/>
+                    </a:solidFill>
+                  </a:tcPr>
+                </a:tc>
+                <a:tc>
+                  <a:txBody>
+                    <a:bodyPr wrap="square"/>
+                    <a:lstStyle/>
+                    <a:p>
+                      <a:r>
+                        <a:rPr sz="1100" b="0">
+                          <a:solidFill>
+                            <a:srgbClr val="282828"/>
+                          </a:solidFill>
+                          <a:latin typeface="Arial"/>
+                        </a:rPr>
+                        <a:t>&lt; 1.5–2.0 pixels</a:t>
+                      </a:r>
+                    </a:p>
+                  </a:txBody>
+                  <a:tcPr marL="54864" marR="54864" marT="18288" marB="18288">
+                    <a:solidFill>
+                      <a:srgbClr val="ECF1F6"/>
+                    </a:solidFill>
+                  </a:tcPr>
+                </a:tc>
+              </a:tr>
+              <a:tr h="280035">
+                <a:tc>
+                  <a:txBody>
+                    <a:bodyPr wrap="square"/>
+                    <a:lstStyle/>
+                    <a:p>
+                      <a:r>
+                        <a:rPr sz="1100" b="0">
+                          <a:solidFill>
+                            <a:srgbClr val="282828"/>
+                          </a:solidFill>
+                          <a:latin typeface="Arial"/>
+                        </a:rPr>
+                        <a:t>CRF FWHM</a:t>
+                      </a:r>
+                    </a:p>
+                  </a:txBody>
+                  <a:tcPr marL="54864" marR="54864" marT="18288" marB="18288">
+                    <a:solidFill>
+                      <a:srgbClr val="FFFFFF"/>
+                    </a:solidFill>
+                  </a:tcPr>
+                </a:tc>
+                <a:tc>
+                  <a:txBody>
+                    <a:bodyPr wrap="square"/>
+                    <a:lstStyle/>
+                    <a:p>
+                      <a:r>
+                        <a:rPr sz="1100" b="0">
+                          <a:solidFill>
+                            <a:srgbClr val="282828"/>
+                          </a:solidFill>
+                          <a:latin typeface="Arial"/>
+                        </a:rPr>
+                        <a:t>&lt; 1.5 pixels</a:t>
+                      </a:r>
+                    </a:p>
+                  </a:txBody>
+                  <a:tcPr marL="54864" marR="54864" marT="18288" marB="18288">
+                    <a:solidFill>
+                      <a:srgbClr val="FFFFFF"/>
+                    </a:solidFill>
+                  </a:tcPr>
+                </a:tc>
+              </a:tr>
+              <a:tr h="468630">
+                <a:tc>
+                  <a:txBody>
+                    <a:bodyPr wrap="square"/>
+                    <a:lstStyle/>
+                    <a:p>
+                      <a:r>
+                        <a:rPr sz="1100" b="0">
+                          <a:solidFill>
+                            <a:srgbClr val="282828"/>
+                          </a:solidFill>
+                          <a:latin typeface="Arial"/>
+                        </a:rPr>
+                        <a:t>radiometric chain</a:t>
+                      </a:r>
+                    </a:p>
+                  </a:txBody>
+                  <a:tcPr marL="54864" marR="54864" marT="18288" marB="18288">
+                    <a:solidFill>
+                      <a:srgbClr val="ECF1F6"/>
+                    </a:solidFill>
+                  </a:tcPr>
+                </a:tc>
+                <a:tc>
+                  <a:txBody>
+                    <a:bodyPr wrap="square"/>
+                    <a:lstStyle/>
+                    <a:p>
+                      <a:r>
+                        <a:rPr sz="1100" b="0">
+                          <a:solidFill>
+                            <a:srgbClr val="282828"/>
+                          </a:solidFill>
+                          <a:latin typeface="Arial"/>
+                        </a:rPr>
+                        <a:t>throughput, grating efficiency, QE, slit loss vs wavelength</a:t>
+                      </a:r>
+                    </a:p>
+                  </a:txBody>
+                  <a:tcPr marL="54864" marR="54864" marT="18288" marB="18288">
+                    <a:solidFill>
+                      <a:srgbClr val="ECF1F6"/>
+                    </a:solidFill>
+                  </a:tcPr>
+                </a:tc>
+              </a:tr>
+            </a:tbl>
+          </a:graphicData>
+        </a:graphic>
+      </p:graphicFrame>
+      <p:sp>
+        <p:nvSpPr>
+          <p:cNvPr id="5" name="TextBox 4"/>
+          <p:cNvSpPr txBox="1"/>
+          <p:nvPr/>
+        </p:nvSpPr>
+        <p:spPr>
+          <a:xfrm>
+            <a:off x="6400800" y="1298448"/>
+            <a:ext cx="5394960" cy="274320"/>
+          </a:xfrm>
+          <a:prstGeom prst="rect">
+            <a:avLst/>
+          </a:prstGeom>
+          <a:noFill/>
+        </p:spPr>
+        <p:txBody>
+          <a:bodyPr wrap="square">
+            <a:spAutoFit/>
+          </a:bodyPr>
+          <a:lstStyle/>
+          <a:p>
+            <a:pPr>
+              <a:spcAft>
+                <a:spcPts val="600"/>
+              </a:spcAft>
+            </a:pPr>
+            <a:r>
+              <a:rPr sz="1200" b="0">
+                <a:solidFill>
+                  <a:srgbClr val="282828"/>
+                </a:solidFill>
+                <a:latin typeface="Arial"/>
+              </a:rPr>
+              <a:t>•  Smile: centroid drift along the slit at fixed wavelength; keystone: drift across wavelength at fixed slit position; both in pixels from ray centroids.</a:t>
+            </a:r>
+          </a:p>
+          <a:p>
+            <a:pPr>
+              <a:spcAft>
+                <a:spcPts val="600"/>
+              </a:spcAft>
+            </a:pPr>
+            <a:r>
+              <a:rPr sz="1200" b="0">
+                <a:solidFill>
+                  <a:srgbClr val="282828"/>
+                </a:solidFill>
+                <a:latin typeface="Arial"/>
+              </a:rPr>
+              <a:t>•  SRF, CRF: slit ⊗ line-spread function ⊗ pixel ⊗ Airy, FWHM in pixels (Mouroulis &amp; Green 2018 definitions); the Airy diameter at 2500 nm is 11 µm, under the 18 µm pixel, so the incoherent chain is valid.</a:t>
+            </a:r>
+          </a:p>
+          <a:p>
+            <a:pPr>
+              <a:spcAft>
+                <a:spcPts val="600"/>
+              </a:spcAft>
+            </a:pPr>
+            <a:r>
+              <a:rPr sz="1200" b="0">
+                <a:solidFill>
+                  <a:srgbClr val="282828"/>
+                </a:solidFill>
+                <a:latin typeface="Arial"/>
+              </a:rPr>
+              <a:t>•  Design rules adopted from the literature: distortion to ~1 % of a pixel at design, &gt; 75 % of the energy in one pixel, degraded spots accepted for uniformity, the grating is the stop.</a:t>
+            </a:r>
+          </a:p>
+          <a:p>
+            <a:pPr>
+              <a:spcAft>
+                <a:spcPts val="600"/>
+              </a:spcAft>
+            </a:pPr>
+            <a:r>
+              <a:rPr sz="1200" b="0">
+                <a:solidFill>
+                  <a:srgbClr val="282828"/>
+                </a:solidFill>
+                <a:latin typeface="Arial"/>
+              </a:rPr>
+              <a:t>•  Realism (Jim): as-built SRF is 2.5–3 pixels, slits are 2 pixels wide, the systems are photon-limited; smile and keystone drive the design.</a:t>
+            </a:r>
+          </a:p>
+        </p:txBody>
+      </p:sp>
+      <p:sp>
+        <p:nvSpPr>
+          <p:cNvPr id="6" name="TextBox 5"/>
+          <p:cNvSpPr txBox="1"/>
+          <p:nvPr/>
+        </p:nvSpPr>
+        <p:spPr>
+          <a:xfrm>
+            <a:off x="6400800" y="4075175"/>
+            <a:ext cx="5394960" cy="274320"/>
+          </a:xfrm>
+          <a:prstGeom prst="rect">
+            <a:avLst/>
+          </a:prstGeom>
+          <a:noFill/>
+        </p:spPr>
+        <p:txBody>
+          <a:bodyPr wrap="square">
+            <a:spAutoFit/>
+          </a:bodyPr>
+          <a:lstStyle/>
+          <a:p>
+            <a:pPr>
+              <a:spcAft>
+                <a:spcPts val="600"/>
+              </a:spcAft>
+            </a:pPr>
+            <a:r>
+              <a:rPr sz="1050" b="0">
+                <a:solidFill>
+                  <a:srgbClr val="6E6E6E"/>
+                </a:solidFill>
+                <a:latin typeface="Arial"/>
+              </a:rPr>
+              <a:t>The 54 mm slit is 2.3× EMIT's; Table 3 of the review places this spec in the ALIS class (3200 spatial pixels, 380–2500 nm).  Public comparison point: Carbon-I (arXiv:2505.22545), F/2.2, 2040–2380 nm.</a:t>
+            </a:r>
+          </a:p>
+        </p:txBody>
+      </p:sp>
+    </p:spTree>
+  </p:cSld>
+  <p:clrMapOvr>
+    <a:masterClrMapping/>
+  </p:clrMapOvr>
+</p:sld>
+</file>
+
+<file path=ppt/slides/slide30.xml><?xml version="1.0" encoding="utf-8"?>
 <p:sld xmlns:a="http://schemas.openxmlformats.org/drawingml/2006/main" xmlns:p="http://schemas.openxmlformats.org/presentationml/2006/main" xmlns:r="http://schemas.openxmlformats.org/officeDocument/2006/relationships">
   <p:cSld>
     <p:spTree>
@@ -14889,7 +17051,7 @@
 </p:sld>
 </file>
 
-<file path=ppt/slides/slide29.xml><?xml version="1.0" encoding="utf-8"?>
+<file path=ppt/slides/slide31.xml><?xml version="1.0" encoding="utf-8"?>
 <p:sld xmlns:a="http://schemas.openxmlformats.org/drawingml/2006/main" xmlns:p="http://schemas.openxmlformats.org/presentationml/2006/main" xmlns:r="http://schemas.openxmlformats.org/officeDocument/2006/relationships">
   <p:cSld>
     <p:spTree>
@@ -15029,7 +17191,7 @@
 </p:sld>
 </file>
 
-<file path=ppt/slides/slide3.xml><?xml version="1.0" encoding="utf-8"?>
+<file path=ppt/slides/slide32.xml><?xml version="1.0" encoding="utf-8"?>
 <p:sld xmlns:a="http://schemas.openxmlformats.org/drawingml/2006/main" xmlns:p="http://schemas.openxmlformats.org/presentationml/2006/main" xmlns:r="http://schemas.openxmlformats.org/officeDocument/2006/relationships">
   <p:cSld>
     <p:spTree>
@@ -15073,7 +17235,7 @@
                 </a:solidFill>
                 <a:latin typeface="Arial"/>
               </a:rPr>
-              <a:t>The target and how it is scored</a:t>
+              <a:t>Backup: six engine findings, each with a regression test</a:t>
             </a:r>
           </a:p>
           <a:p>
@@ -15089,7 +17251,7 @@
                 </a:solidFill>
                 <a:latin typeface="Arial"/>
               </a:rPr>
-              <a:t>Joe's specification, EMIT-class; the metrics stated once, here</a:t>
+              <a:t>Found by the challenge's checks on 2026-09-30 and 10-01, fixed in the engine the same day</a:t>
             </a:r>
           </a:p>
         </p:txBody>
@@ -15148,7 +17310,7 @@
         </p:nvGraphicFramePr>
         <p:xfrm>
           <a:off x="411480" y="1298448"/>
-          <a:ext cx="5806439" cy="2897505"/>
+          <a:ext cx="11368733" cy="3846195"/>
         </p:xfrm>
         <a:graphic>
           <a:graphicData uri="http://schemas.openxmlformats.org/drawingml/2006/table">
@@ -15157,8 +17319,10 @@
                 <a:tableStyleId>{5C22544A-7EE6-4342-B048-85BDC9FD1C3A}</a:tableStyleId>
               </a:tblPr>
               <a:tblGrid>
-                <a:gridCol w="2274687"/>
-                <a:gridCol w="3531752"/>
+                <a:gridCol w="991903"/>
+                <a:gridCol w="5086682"/>
+                <a:gridCol w="2899408"/>
+                <a:gridCol w="2390740"/>
               </a:tblGrid>
               <a:tr h="280035">
                 <a:tc>
@@ -15173,7 +17337,7 @@
                           </a:solidFill>
                           <a:latin typeface="Arial"/>
                         </a:rPr>
-                        <a:t>item</a:t>
+                        <a:t>finding</a:t>
                       </a:r>
                     </a:p>
                   </a:txBody>
@@ -15195,7 +17359,51 @@
                           </a:solidFill>
                           <a:latin typeface="Arial"/>
                         </a:rPr>
-                        <a:t>value</a:t>
+                        <a:t>symptom</a:t>
+                      </a:r>
+                    </a:p>
+                  </a:txBody>
+                  <a:tcPr marL="54864" marR="54864" marT="18288" marB="18288">
+                    <a:solidFill>
+                      <a:srgbClr val="1F4E79"/>
+                    </a:solidFill>
+                  </a:tcPr>
+                </a:tc>
+                <a:tc>
+                  <a:txBody>
+                    <a:bodyPr wrap="square"/>
+                    <a:lstStyle/>
+                    <a:p>
+                      <a:r>
+                        <a:rPr sz="1100" b="1">
+                          <a:solidFill>
+                            <a:srgbClr val="FFFFFF"/>
+                          </a:solidFill>
+                          <a:latin typeface="Arial"/>
+                        </a:rPr>
+                        <a:t>fix</a:t>
+                      </a:r>
+                    </a:p>
+                  </a:txBody>
+                  <a:tcPr marL="54864" marR="54864" marT="18288" marB="18288">
+                    <a:solidFill>
+                      <a:srgbClr val="1F4E79"/>
+                    </a:solidFill>
+                  </a:tcPr>
+                </a:tc>
+                <a:tc>
+                  <a:txBody>
+                    <a:bodyPr wrap="square"/>
+                    <a:lstStyle/>
+                    <a:p>
+                      <a:r>
+                        <a:rPr sz="1100" b="1">
+                          <a:solidFill>
+                            <a:srgbClr val="FFFFFF"/>
+                          </a:solidFill>
+                          <a:latin typeface="Arial"/>
+                        </a:rPr>
+                        <a:t>test</a:t>
                       </a:r>
                     </a:p>
                   </a:txBody>
@@ -15219,29 +17427,73 @@
                           </a:solidFill>
                           <a:latin typeface="Arial"/>
                         </a:rPr>
-                        <a:t>F-number (air-equivalent, image space)</a:t>
-                      </a:r>
-                    </a:p>
-                  </a:txBody>
-                  <a:tcPr marL="54864" marR="54864" marT="18288" marB="18288">
-                    <a:solidFill>
-                      <a:srgbClr val="FFFFFF"/>
-                    </a:solidFill>
-                  </a:tcPr>
-                </a:tc>
-                <a:tc>
-                  <a:txBody>
-                    <a:bodyPr wrap="square"/>
-                    <a:lstStyle/>
-                    <a:p>
-                      <a:r>
-                        <a:rPr sz="1100" b="0">
-                          <a:solidFill>
-                            <a:srgbClr val="282828"/>
-                          </a:solidFill>
-                          <a:latin typeface="Arial"/>
-                        </a:rPr>
-                        <a:t>1.8</a:t>
+                        <a:t>glass names ignored at load</a:t>
+                      </a:r>
+                    </a:p>
+                  </a:txBody>
+                  <a:tcPr marL="54864" marR="54864" marT="18288" marB="18288">
+                    <a:solidFill>
+                      <a:srgbClr val="FFFFFF"/>
+                    </a:solidFill>
+                  </a:tcPr>
+                </a:tc>
+                <a:tc>
+                  <a:txBody>
+                    <a:bodyPr wrap="square"/>
+                    <a:lstStyle/>
+                    <a:p>
+                      <a:r>
+                        <a:rPr sz="1100" b="0">
+                          <a:solidFill>
+                            <a:srgbClr val="282828"/>
+                          </a:solidFill>
+                          <a:latin typeface="Arial"/>
+                        </a:rPr>
+                        <a:t>a GlassElt= Silica element traced as air in every binding</a:t>
+                      </a:r>
+                    </a:p>
+                  </a:txBody>
+                  <a:tcPr marL="54864" marR="54864" marT="18288" marB="18288">
+                    <a:solidFill>
+                      <a:srgbClr val="FFFFFF"/>
+                    </a:solidFill>
+                  </a:tcPr>
+                </a:tc>
+                <a:tc>
+                  <a:txBody>
+                    <a:bodyPr wrap="square"/>
+                    <a:lstStyle/>
+                    <a:p>
+                      <a:r>
+                        <a:rPr sz="1100" b="0">
+                          <a:solidFill>
+                            <a:srgbClr val="282828"/>
+                          </a:solidFill>
+                          <a:latin typeface="Arial"/>
+                        </a:rPr>
+                        <a:t>the glass catalog is blanked once at allocation, not on every load</a:t>
+                      </a:r>
+                    </a:p>
+                  </a:txBody>
+                  <a:tcPr marL="54864" marR="54864" marT="18288" marB="18288">
+                    <a:solidFill>
+                      <a:srgbClr val="FFFFFF"/>
+                    </a:solidFill>
+                  </a:tcPr>
+                </a:tc>
+                <a:tc>
+                  <a:txBody>
+                    <a:bodyPr wrap="square"/>
+                    <a:lstStyle/>
+                    <a:p>
+                      <a:r>
+                        <a:rPr sz="1100" b="0">
+                          <a:solidFill>
+                            <a:srgbClr val="282828"/>
+                          </a:solidFill>
+                          <a:latin typeface="Arial"/>
+                        </a:rPr>
+                        <a:t>tGlassDispersion (3)</a:t>
                       </a:r>
                     </a:p>
                   </a:txBody>
@@ -15252,20 +17504,20 @@
                   </a:tcPr>
                 </a:tc>
               </a:tr>
-              <a:tr h="280035">
-                <a:tc>
-                  <a:txBody>
-                    <a:bodyPr wrap="square"/>
-                    <a:lstStyle/>
-                    <a:p>
-                      <a:r>
-                        <a:rPr sz="1100" b="0">
-                          <a:solidFill>
-                            <a:srgbClr val="282828"/>
-                          </a:solidFill>
-                          <a:latin typeface="Arial"/>
-                        </a:rPr>
-                        <a:t>focal plane</a:t>
+              <a:tr h="657225">
+                <a:tc>
+                  <a:txBody>
+                    <a:bodyPr wrap="square"/>
+                    <a:lstStyle/>
+                    <a:p>
+                      <a:r>
+                        <a:rPr sz="1100" b="0">
+                          <a:solidFill>
+                            <a:srgbClr val="282828"/>
+                          </a:solidFill>
+                          <a:latin typeface="Arial"/>
+                        </a:rPr>
+                        <a:t>vacuum wavelength inside glass</a:t>
                       </a:r>
                     </a:p>
                   </a:txBody>
@@ -15287,7 +17539,7 @@
                           </a:solidFill>
                           <a:latin typeface="Arial"/>
                         </a:rPr>
-                        <a:t>3000 spatial × 500 spectral pixels, 18 µm</a:t>
+                        <a:t>a propagation leg in a medium ran at the wrong Fresnel number by n</a:t>
                       </a:r>
                     </a:p>
                   </a:txBody>
@@ -15297,227 +17549,131 @@
                     </a:solidFill>
                   </a:tcPr>
                 </a:tc>
+                <a:tc>
+                  <a:txBody>
+                    <a:bodyPr wrap="square"/>
+                    <a:lstStyle/>
+                    <a:p>
+                      <a:r>
+                        <a:rPr sz="1100" b="0">
+                          <a:solidFill>
+                            <a:srgbClr val="282828"/>
+                          </a:solidFill>
+                          <a:latin typeface="Arial"/>
+                        </a:rPr>
+                        <a:t>every kernel takes λ/n of the leg's medium</a:t>
+                      </a:r>
+                    </a:p>
+                  </a:txBody>
+                  <a:tcPr marL="54864" marR="54864" marT="18288" marB="18288">
+                    <a:solidFill>
+                      <a:srgbClr val="ECF1F6"/>
+                    </a:solidFill>
+                  </a:tcPr>
+                </a:tc>
+                <a:tc>
+                  <a:txBody>
+                    <a:bodyPr wrap="square"/>
+                    <a:lstStyle/>
+                    <a:p>
+                      <a:r>
+                        <a:rPr sz="1100" b="0">
+                          <a:solidFill>
+                            <a:srgbClr val="282828"/>
+                          </a:solidFill>
+                          <a:latin typeface="Arial"/>
+                        </a:rPr>
+                        <a:t>tPropMedium (3): z in n ≡ z/n in vacuum</a:t>
+                      </a:r>
+                    </a:p>
+                  </a:txBody>
+                  <a:tcPr marL="54864" marR="54864" marT="18288" marB="18288">
+                    <a:solidFill>
+                      <a:srgbClr val="ECF1F6"/>
+                    </a:solidFill>
+                  </a:tcPr>
+                </a:tc>
               </a:tr>
-              <a:tr h="280035">
-                <a:tc>
-                  <a:txBody>
-                    <a:bodyPr wrap="square"/>
-                    <a:lstStyle/>
-                    <a:p>
-                      <a:r>
-                        <a:rPr sz="1100" b="0">
-                          <a:solidFill>
-                            <a:srgbClr val="282828"/>
-                          </a:solidFill>
-                          <a:latin typeface="Arial"/>
-                        </a:rPr>
-                        <a:t>slit</a:t>
-                      </a:r>
-                    </a:p>
-                  </a:txBody>
-                  <a:tcPr marL="54864" marR="54864" marT="18288" marB="18288">
-                    <a:solidFill>
-                      <a:srgbClr val="FFFFFF"/>
-                    </a:solidFill>
-                  </a:tcPr>
-                </a:tc>
-                <a:tc>
-                  <a:txBody>
-                    <a:bodyPr wrap="square"/>
-                    <a:lstStyle/>
-                    <a:p>
-                      <a:r>
-                        <a:rPr sz="1100" b="0">
-                          <a:solidFill>
-                            <a:srgbClr val="282828"/>
-                          </a:solidFill>
-                          <a:latin typeface="Arial"/>
-                        </a:rPr>
-                        <a:t>54 mm; spectral height 9 mm</a:t>
-                      </a:r>
-                    </a:p>
-                  </a:txBody>
-                  <a:tcPr marL="54864" marR="54864" marT="18288" marB="18288">
-                    <a:solidFill>
-                      <a:srgbClr val="FFFFFF"/>
-                    </a:solidFill>
-                  </a:tcPr>
-                </a:tc>
-              </a:tr>
-              <a:tr h="280035">
-                <a:tc>
-                  <a:txBody>
-                    <a:bodyPr wrap="square"/>
-                    <a:lstStyle/>
-                    <a:p>
-                      <a:r>
-                        <a:rPr sz="1100" b="0">
-                          <a:solidFill>
-                            <a:srgbClr val="282828"/>
-                          </a:solidFill>
-                          <a:latin typeface="Arial"/>
-                        </a:rPr>
-                        <a:t>band</a:t>
-                      </a:r>
-                    </a:p>
-                  </a:txBody>
-                  <a:tcPr marL="54864" marR="54864" marT="18288" marB="18288">
-                    <a:solidFill>
-                      <a:srgbClr val="ECF1F6"/>
-                    </a:solidFill>
-                  </a:tcPr>
-                </a:tc>
-                <a:tc>
-                  <a:txBody>
-                    <a:bodyPr wrap="square"/>
-                    <a:lstStyle/>
-                    <a:p>
-                      <a:r>
-                        <a:rPr sz="1100" b="0">
-                          <a:solidFill>
-                            <a:srgbClr val="282828"/>
-                          </a:solidFill>
-                          <a:latin typeface="Arial"/>
-                        </a:rPr>
-                        <a:t>380–2500 nm, 4.24 nm per pixel</a:t>
-                      </a:r>
-                    </a:p>
-                  </a:txBody>
-                  <a:tcPr marL="54864" marR="54864" marT="18288" marB="18288">
-                    <a:solidFill>
-                      <a:srgbClr val="ECF1F6"/>
-                    </a:solidFill>
-                  </a:tcPr>
-                </a:tc>
-              </a:tr>
-              <a:tr h="280035">
-                <a:tc>
-                  <a:txBody>
-                    <a:bodyPr wrap="square"/>
-                    <a:lstStyle/>
-                    <a:p>
-                      <a:r>
-                        <a:rPr sz="1100" b="0">
-                          <a:solidFill>
-                            <a:srgbClr val="282828"/>
-                          </a:solidFill>
-                          <a:latin typeface="Arial"/>
-                        </a:rPr>
-                        <a:t>smile, keystone</a:t>
-                      </a:r>
-                    </a:p>
-                  </a:txBody>
-                  <a:tcPr marL="54864" marR="54864" marT="18288" marB="18288">
-                    <a:solidFill>
-                      <a:srgbClr val="FFFFFF"/>
-                    </a:solidFill>
-                  </a:tcPr>
-                </a:tc>
-                <a:tc>
-                  <a:txBody>
-                    <a:bodyPr wrap="square"/>
-                    <a:lstStyle/>
-                    <a:p>
-                      <a:r>
-                        <a:rPr sz="1100" b="0">
-                          <a:solidFill>
-                            <a:srgbClr val="282828"/>
-                          </a:solidFill>
-                          <a:latin typeface="Arial"/>
-                        </a:rPr>
-                        <a:t>&lt; 0.1 pixel</a:t>
-                      </a:r>
-                    </a:p>
-                  </a:txBody>
-                  <a:tcPr marL="54864" marR="54864" marT="18288" marB="18288">
-                    <a:solidFill>
-                      <a:srgbClr val="FFFFFF"/>
-                    </a:solidFill>
-                  </a:tcPr>
-                </a:tc>
-              </a:tr>
-              <a:tr h="280035">
-                <a:tc>
-                  <a:txBody>
-                    <a:bodyPr wrap="square"/>
-                    <a:lstStyle/>
-                    <a:p>
-                      <a:r>
-                        <a:rPr sz="1100" b="0">
-                          <a:solidFill>
-                            <a:srgbClr val="282828"/>
-                          </a:solidFill>
-                          <a:latin typeface="Arial"/>
-                        </a:rPr>
-                        <a:t>SRF FWHM</a:t>
-                      </a:r>
-                    </a:p>
-                  </a:txBody>
-                  <a:tcPr marL="54864" marR="54864" marT="18288" marB="18288">
-                    <a:solidFill>
-                      <a:srgbClr val="ECF1F6"/>
-                    </a:solidFill>
-                  </a:tcPr>
-                </a:tc>
-                <a:tc>
-                  <a:txBody>
-                    <a:bodyPr wrap="square"/>
-                    <a:lstStyle/>
-                    <a:p>
-                      <a:r>
-                        <a:rPr sz="1100" b="0">
-                          <a:solidFill>
-                            <a:srgbClr val="282828"/>
-                          </a:solidFill>
-                          <a:latin typeface="Arial"/>
-                        </a:rPr>
-                        <a:t>&lt; 1.5–2.0 pixels</a:t>
-                      </a:r>
-                    </a:p>
-                  </a:txBody>
-                  <a:tcPr marL="54864" marR="54864" marT="18288" marB="18288">
-                    <a:solidFill>
-                      <a:srgbClr val="ECF1F6"/>
-                    </a:solidFill>
-                  </a:tcPr>
-                </a:tc>
-              </a:tr>
-              <a:tr h="280035">
-                <a:tc>
-                  <a:txBody>
-                    <a:bodyPr wrap="square"/>
-                    <a:lstStyle/>
-                    <a:p>
-                      <a:r>
-                        <a:rPr sz="1100" b="0">
-                          <a:solidFill>
-                            <a:srgbClr val="282828"/>
-                          </a:solidFill>
-                          <a:latin typeface="Arial"/>
-                        </a:rPr>
-                        <a:t>CRF FWHM</a:t>
-                      </a:r>
-                    </a:p>
-                  </a:txBody>
-                  <a:tcPr marL="54864" marR="54864" marT="18288" marB="18288">
-                    <a:solidFill>
-                      <a:srgbClr val="FFFFFF"/>
-                    </a:solidFill>
-                  </a:tcPr>
-                </a:tc>
-                <a:tc>
-                  <a:txBody>
-                    <a:bodyPr wrap="square"/>
-                    <a:lstStyle/>
-                    <a:p>
-                      <a:r>
-                        <a:rPr sz="1100" b="0">
-                          <a:solidFill>
-                            <a:srgbClr val="282828"/>
-                          </a:solidFill>
-                          <a:latin typeface="Arial"/>
-                        </a:rPr>
-                        <a:t>&lt; 1.5 pixels</a:t>
+              <a:tr h="657225">
+                <a:tc>
+                  <a:txBody>
+                    <a:bodyPr wrap="square"/>
+                    <a:lstStyle/>
+                    <a:p>
+                      <a:r>
+                        <a:rPr sz="1100" b="0">
+                          <a:solidFill>
+                            <a:srgbClr val="282828"/>
+                          </a:solidFill>
+                          <a:latin typeface="Arial"/>
+                        </a:rPr>
+                        <a:t>groove period along the surface</a:t>
+                      </a:r>
+                    </a:p>
+                  </a:txBody>
+                  <a:tcPr marL="54864" marR="54864" marT="18288" marB="18288">
+                    <a:solidFill>
+                      <a:srgbClr val="FFFFFF"/>
+                    </a:solidFill>
+                  </a:tcPr>
+                </a:tc>
+                <a:tc>
+                  <a:txBody>
+                    <a:bodyPr wrap="square"/>
+                    <a:lstStyle/>
+                    <a:p>
+                      <a:r>
+                        <a:rPr sz="1100" b="0">
+                          <a:solidFill>
+                            <a:srgbClr val="282828"/>
+                          </a:solidFill>
+                          <a:latin typeface="Arial"/>
+                        </a:rPr>
+                        <a:t>2.8 / 3.3 px rms spectral blur at 2500 nm (Offner / Dyson)</a:t>
+                      </a:r>
+                    </a:p>
+                  </a:txBody>
+                  <a:tcPr marL="54864" marR="54864" marT="18288" marB="18288">
+                    <a:solidFill>
+                      <a:srgbClr val="FFFFFF"/>
+                    </a:solidFill>
+                  </a:tcPr>
+                </a:tc>
+                <a:tc>
+                  <a:txBody>
+                    <a:bodyPr wrap="square"/>
+                    <a:lstStyle/>
+                    <a:p>
+                      <a:r>
+                        <a:rPr sz="1100" b="0">
+                          <a:solidFill>
+                            <a:srgbClr val="282828"/>
+                          </a:solidFill>
+                          <a:latin typeface="Arial"/>
+                        </a:rPr>
+                        <a:t>the local grating vector is the un-normalised projection of the ruling direction (chord-ruled)</a:t>
+                      </a:r>
+                    </a:p>
+                  </a:txBody>
+                  <a:tcPr marL="54864" marR="54864" marT="18288" marB="18288">
+                    <a:solidFill>
+                      <a:srgbClr val="FFFFFF"/>
+                    </a:solidFill>
+                  </a:tcPr>
+                </a:tc>
+                <a:tc>
+                  <a:txBody>
+                    <a:bodyPr wrap="square"/>
+                    <a:lstStyle/>
+                    <a:p>
+                      <a:r>
+                        <a:rPr sz="1100" b="0">
+                          <a:solidFill>
+                            <a:srgbClr val="282828"/>
+                          </a:solidFill>
+                          <a:latin typeface="Arial"/>
+                        </a:rPr>
+                        <a:t>tGratingImmersed (4), test_grating_chord</a:t>
                       </a:r>
                     </a:p>
                   </a:txBody>
@@ -15541,7 +17697,7 @@
                           </a:solidFill>
                           <a:latin typeface="Arial"/>
                         </a:rPr>
-                        <a:t>radiometric chain</a:t>
+                        <a:t>grating path-length jump</a:t>
                       </a:r>
                     </a:p>
                   </a:txBody>
@@ -15563,7 +17719,231 @@
                           </a:solidFill>
                           <a:latin typeface="Arial"/>
                         </a:rPr>
-                        <a:t>throughput, grating efficiency, QE, slit loss vs wavelength</a:t>
+                        <a:t>4 waves rms of pupil OPD where the rays converged to 0.05 µm</a:t>
+                      </a:r>
+                    </a:p>
+                  </a:txBody>
+                  <a:tcPr marL="54864" marR="54864" marT="18288" marB="18288">
+                    <a:solidFill>
+                      <a:srgbClr val="ECF1F6"/>
+                    </a:solidFill>
+                  </a:tcPr>
+                </a:tc>
+                <a:tc>
+                  <a:txBody>
+                    <a:bodyPr wrap="square"/>
+                    <a:lstStyle/>
+                    <a:p>
+                      <a:r>
+                        <a:rPr sz="1100" b="0">
+                          <a:solidFill>
+                            <a:srgbClr val="282828"/>
+                          </a:solidFill>
+                          <a:latin typeface="Arial"/>
+                        </a:rPr>
+                        <a:t>the jump is the groove count from the vertex along the ruling direction</a:t>
+                      </a:r>
+                    </a:p>
+                  </a:txBody>
+                  <a:tcPr marL="54864" marR="54864" marT="18288" marB="18288">
+                    <a:solidFill>
+                      <a:srgbClr val="ECF1F6"/>
+                    </a:solidFill>
+                  </a:tcPr>
+                </a:tc>
+                <a:tc>
+                  <a:txBody>
+                    <a:bodyPr wrap="square"/>
+                    <a:lstStyle/>
+                    <a:p>
+                      <a:r>
+                        <a:rPr sz="1100" b="0">
+                          <a:solidFill>
+                            <a:srgbClr val="282828"/>
+                          </a:solidFill>
+                          <a:latin typeface="Arial"/>
+                        </a:rPr>
+                        <a:t>tGratingOpl (2)</a:t>
+                      </a:r>
+                    </a:p>
+                  </a:txBody>
+                  <a:tcPr marL="54864" marR="54864" marT="18288" marB="18288">
+                    <a:solidFill>
+                      <a:srgbClr val="ECF1F6"/>
+                    </a:solidFill>
+                  </a:tcPr>
+                </a:tc>
+              </a:tr>
+              <a:tr h="657225">
+                <a:tc>
+                  <a:txBody>
+                    <a:bodyPr wrap="square"/>
+                    <a:lstStyle/>
+                    <a:p>
+                      <a:r>
+                        <a:rPr sz="1100" b="0">
+                          <a:solidFill>
+                            <a:srgbClr val="282828"/>
+                          </a:solidFill>
+                          <a:latin typeface="Arial"/>
+                        </a:rPr>
+                        <a:t>optimizer derivative stride</a:t>
+                      </a:r>
+                    </a:p>
+                  </a:txBody>
+                  <a:tcPr marL="54864" marR="54864" marT="18288" marB="18288">
+                    <a:solidFill>
+                      <a:srgbClr val="FFFFFF"/>
+                    </a:solidFill>
+                  </a:tcPr>
+                </a:tc>
+                <a:tc>
+                  <a:txBody>
+                    <a:bodyPr wrap="square"/>
+                    <a:lstStyle/>
+                    <a:p>
+                      <a:r>
+                        <a:rPr sz="1100" b="0">
+                          <a:solidFill>
+                            <a:srgbClr val="282828"/>
+                          </a:solidFill>
+                          <a:latin typeface="Arial"/>
+                        </a:rPr>
+                        <a:t>a spot-size optimisation over several fields overwrote memory on its second field (the derivative columns advanced by the wavefront's size, not the objective's) and crashed or hung the host</a:t>
+                      </a:r>
+                    </a:p>
+                  </a:txBody>
+                  <a:tcPr marL="54864" marR="54864" marT="18288" marB="18288">
+                    <a:solidFill>
+                      <a:srgbClr val="FFFFFF"/>
+                    </a:solidFill>
+                  </a:tcPr>
+                </a:tc>
+                <a:tc>
+                  <a:txBody>
+                    <a:bodyPr wrap="square"/>
+                    <a:lstStyle/>
+                    <a:p>
+                      <a:r>
+                        <a:rPr sz="1100" b="0">
+                          <a:solidFill>
+                            <a:srgbClr val="282828"/>
+                          </a:solidFill>
+                          <a:latin typeface="Arial"/>
+                        </a:rPr>
+                        <a:t>advance by the objective's size, as the value loop does</a:t>
+                      </a:r>
+                    </a:p>
+                  </a:txBody>
+                  <a:tcPr marL="54864" marR="54864" marT="18288" marB="18288">
+                    <a:solidFill>
+                      <a:srgbClr val="FFFFFF"/>
+                    </a:solidFill>
+                  </a:tcPr>
+                </a:tc>
+                <a:tc>
+                  <a:txBody>
+                    <a:bodyPr wrap="square"/>
+                    <a:lstStyle/>
+                    <a:p>
+                      <a:r>
+                        <a:rPr sz="1100" b="0">
+                          <a:solidFill>
+                            <a:srgbClr val="282828"/>
+                          </a:solidFill>
+                          <a:latin typeface="Arial"/>
+                        </a:rPr>
+                        <a:t>tSpectrometerRx native leg, tDesignTelescope (70, unchanged)</a:t>
+                      </a:r>
+                    </a:p>
+                  </a:txBody>
+                  <a:tcPr marL="54864" marR="54864" marT="18288" marB="18288">
+                    <a:solidFill>
+                      <a:srgbClr val="FFFFFF"/>
+                    </a:solidFill>
+                  </a:tcPr>
+                </a:tc>
+              </a:tr>
+              <a:tr h="657225">
+                <a:tc>
+                  <a:txBody>
+                    <a:bodyPr wrap="square"/>
+                    <a:lstStyle/>
+                    <a:p>
+                      <a:r>
+                        <a:rPr sz="1100" b="0">
+                          <a:solidFill>
+                            <a:srgbClr val="282828"/>
+                          </a:solidFill>
+                          <a:latin typeface="Arial"/>
+                        </a:rPr>
+                        <a:t>optimizer asphere step and failure exit</a:t>
+                      </a:r>
+                    </a:p>
+                  </a:txBody>
+                  <a:tcPr marL="54864" marR="54864" marT="18288" marB="18288">
+                    <a:solidFill>
+                      <a:srgbClr val="ECF1F6"/>
+                    </a:solidFill>
+                  </a:tcPr>
+                </a:tc>
+                <a:tc>
+                  <a:txBody>
+                    <a:bodyPr wrap="square"/>
+                    <a:lstStyle/>
+                    <a:p>
+                      <a:r>
+                        <a:rPr sz="1100" b="0">
+                          <a:solidFill>
+                            <a:srgbClr val="282828"/>
+                          </a:solidFill>
+                          <a:latin typeface="Arial"/>
+                        </a:rPr>
+                        <a:t>an aspheric coefficient was probed by a fixed 1e-10, round-off on a deck in metres: a zero derivative column, a singular matrix at the first step, and a stop on that path that ended the MATLAB process</a:t>
+                      </a:r>
+                    </a:p>
+                  </a:txBody>
+                  <a:tcPr marL="54864" marR="54864" marT="18288" marB="18288">
+                    <a:solidFill>
+                      <a:srgbClr val="ECF1F6"/>
+                    </a:solidFill>
+                  </a:tcPr>
+                </a:tc>
+                <a:tc>
+                  <a:txBody>
+                    <a:bodyPr wrap="square"/>
+                    <a:lstStyle/>
+                    <a:p>
+                      <a:r>
+                        <a:rPr sz="1100" b="0">
+                          <a:solidFill>
+                            <a:srgbClr val="282828"/>
+                          </a:solidFill>
+                          <a:latin typeface="Arial"/>
+                        </a:rPr>
+                        <a:t>the step is 1e-3 of the coefficient (sag-based for a zero one); the failure restores the optics and returns a flag</a:t>
+                      </a:r>
+                    </a:p>
+                  </a:txBody>
+                  <a:tcPr marL="54864" marR="54864" marT="18288" marB="18288">
+                    <a:solidFill>
+                      <a:srgbClr val="ECF1F6"/>
+                    </a:solidFill>
+                  </a:tcPr>
+                </a:tc>
+                <a:tc>
+                  <a:txBody>
+                    <a:bodyPr wrap="square"/>
+                    <a:lstStyle/>
+                    <a:p>
+                      <a:r>
+                        <a:rPr sz="1100" b="0">
+                          <a:solidFill>
+                            <a:srgbClr val="282828"/>
+                          </a:solidFill>
+                          <a:latin typeface="Arial"/>
+                        </a:rPr>
+                        <a:t>tAsphCalib (2): a spoiled paraboloid driven back to zero; the failure path with the host alive</a:t>
                       </a:r>
                     </a:p>
                   </a:txBody>
@@ -15586,8 +17966,8 @@
         </p:nvSpPr>
         <p:spPr>
           <a:xfrm>
-            <a:off x="6400800" y="1298448"/>
-            <a:ext cx="5394960" cy="274320"/>
+            <a:off x="411480" y="5290947"/>
+            <a:ext cx="11368735" cy="274320"/>
           </a:xfrm>
           <a:prstGeom prst="rect">
             <a:avLst/>
@@ -15606,100 +17986,13 @@
               </a:spcAft>
             </a:pPr>
             <a:r>
-              <a:rPr sz="1200" b="0">
-                <a:solidFill>
-                  <a:srgbClr val="282828"/>
-                </a:solidFill>
-                <a:latin typeface="Arial"/>
-              </a:rPr>
-              <a:t>•  Smile: centroid drift along the slit at fixed wavelength; keystone: drift across wavelength at fixed slit position; both in pixels from ray centroids.</a:t>
-            </a:r>
-          </a:p>
-          <a:p>
-            <a:pPr>
-              <a:spcAft>
-                <a:spcPts val="600"/>
-              </a:spcAft>
-            </a:pPr>
-            <a:r>
-              <a:rPr sz="1200" b="0">
-                <a:solidFill>
-                  <a:srgbClr val="282828"/>
-                </a:solidFill>
-                <a:latin typeface="Arial"/>
-              </a:rPr>
-              <a:t>•  SRF, CRF: slit ⊗ line-spread function ⊗ pixel ⊗ Airy, FWHM in pixels (Mouroulis &amp; Green 2018 definitions); the Airy diameter at 2500 nm is 11 µm, under the 18 µm pixel, so the incoherent chain is valid.</a:t>
-            </a:r>
-          </a:p>
-          <a:p>
-            <a:pPr>
-              <a:spcAft>
-                <a:spcPts val="600"/>
-              </a:spcAft>
-            </a:pPr>
-            <a:r>
-              <a:rPr sz="1200" b="0">
-                <a:solidFill>
-                  <a:srgbClr val="282828"/>
-                </a:solidFill>
-                <a:latin typeface="Arial"/>
-              </a:rPr>
-              <a:t>•  Design rules adopted from the literature: distortion to ~1 % of a pixel at design, &gt; 75 % of the energy in one pixel, degraded spots accepted for uniformity, the grating is the stop.</a:t>
-            </a:r>
-          </a:p>
-          <a:p>
-            <a:pPr>
-              <a:spcAft>
-                <a:spcPts val="600"/>
-              </a:spcAft>
-            </a:pPr>
-            <a:r>
-              <a:rPr sz="1200" b="0">
-                <a:solidFill>
-                  <a:srgbClr val="282828"/>
-                </a:solidFill>
-                <a:latin typeface="Arial"/>
-              </a:rPr>
-              <a:t>•  Realism (Jim): as-built SRF is 2.5–3 pixels, slits are 2 pixels wide, the systems are photon-limited; smile and keystone drive the design.</a:t>
-            </a:r>
-          </a:p>
-        </p:txBody>
-      </p:sp>
-      <p:sp>
-        <p:nvSpPr>
-          <p:cNvPr id="6" name="TextBox 5"/>
-          <p:cNvSpPr txBox="1"/>
-          <p:nvPr/>
-        </p:nvSpPr>
-        <p:spPr>
-          <a:xfrm>
-            <a:off x="6400800" y="4075175"/>
-            <a:ext cx="5394960" cy="274320"/>
-          </a:xfrm>
-          <a:prstGeom prst="rect">
-            <a:avLst/>
-          </a:prstGeom>
-          <a:noFill/>
-        </p:spPr>
-        <p:txBody>
-          <a:bodyPr wrap="square">
-            <a:spAutoFit/>
-          </a:bodyPr>
-          <a:lstStyle/>
-          <a:p>
-            <a:pPr>
-              <a:spcAft>
-                <a:spcPts val="600"/>
-              </a:spcAft>
-            </a:pPr>
-            <a:r>
               <a:rPr sz="1050" b="0">
                 <a:solidFill>
                   <a:srgbClr val="6E6E6E"/>
                 </a:solidFill>
                 <a:latin typeface="Arial"/>
               </a:rPr>
-              <a:t>The 54 mm slit is 2.3× EMIT's; Table 3 of the review places this spec in the ALIS class (3200 spatial pixels, 380–2500 nm).  Public comparison point: Carbon-I (arXiv:2505.22545), F/2.2, 2040–2380 nm.</a:t>
+              <a:t>Flat gratings are unchanged by the grating fixes; the wavefront-target optimizer, which every telescope design used, was never affected by the fifth.  A seventh item, a short AsphCoef= line killing the host process, now pads with zero and warns (tRxShortAsph).</a:t>
             </a:r>
           </a:p>
         </p:txBody>
@@ -15712,7 +18005,7 @@
 </p:sld>
 </file>
 
-<file path=ppt/slides/slide30.xml><?xml version="1.0" encoding="utf-8"?>
+<file path=ppt/slides/slide33.xml><?xml version="1.0" encoding="utf-8"?>
 <p:sld xmlns:a="http://schemas.openxmlformats.org/drawingml/2006/main" xmlns:p="http://schemas.openxmlformats.org/presentationml/2006/main" xmlns:r="http://schemas.openxmlformats.org/officeDocument/2006/relationships">
   <p:cSld>
     <p:spTree>
@@ -15756,7 +18049,7 @@
                 </a:solidFill>
                 <a:latin typeface="Arial"/>
               </a:rPr>
-              <a:t>Backup: six engine findings, each with a regression test</a:t>
+              <a:t>Backup: records and tools behind each slide</a:t>
             </a:r>
           </a:p>
           <a:p>
@@ -15772,7 +18065,7 @@
                 </a:solidFill>
                 <a:latin typeface="Arial"/>
               </a:rPr>
-              <a:t>Found by the challenge's checks on 2026-09-30 and 10-01, fixed in the engine the same day</a:t>
+              <a:t>Every number traces to a runner stage and its record file</a:t>
             </a:r>
           </a:p>
         </p:txBody>
@@ -15831,821 +18124,7 @@
         </p:nvGraphicFramePr>
         <p:xfrm>
           <a:off x="411480" y="1298448"/>
-          <a:ext cx="11368733" cy="3846195"/>
-        </p:xfrm>
-        <a:graphic>
-          <a:graphicData uri="http://schemas.openxmlformats.org/drawingml/2006/table">
-            <a:tbl>
-              <a:tblPr firstRow="1" bandRow="1">
-                <a:tableStyleId>{5C22544A-7EE6-4342-B048-85BDC9FD1C3A}</a:tableStyleId>
-              </a:tblPr>
-              <a:tblGrid>
-                <a:gridCol w="991903"/>
-                <a:gridCol w="5086682"/>
-                <a:gridCol w="2899408"/>
-                <a:gridCol w="2390740"/>
-              </a:tblGrid>
-              <a:tr h="280035">
-                <a:tc>
-                  <a:txBody>
-                    <a:bodyPr wrap="square"/>
-                    <a:lstStyle/>
-                    <a:p>
-                      <a:r>
-                        <a:rPr sz="1100" b="1">
-                          <a:solidFill>
-                            <a:srgbClr val="FFFFFF"/>
-                          </a:solidFill>
-                          <a:latin typeface="Arial"/>
-                        </a:rPr>
-                        <a:t>finding</a:t>
-                      </a:r>
-                    </a:p>
-                  </a:txBody>
-                  <a:tcPr marL="54864" marR="54864" marT="18288" marB="18288">
-                    <a:solidFill>
-                      <a:srgbClr val="1F4E79"/>
-                    </a:solidFill>
-                  </a:tcPr>
-                </a:tc>
-                <a:tc>
-                  <a:txBody>
-                    <a:bodyPr wrap="square"/>
-                    <a:lstStyle/>
-                    <a:p>
-                      <a:r>
-                        <a:rPr sz="1100" b="1">
-                          <a:solidFill>
-                            <a:srgbClr val="FFFFFF"/>
-                          </a:solidFill>
-                          <a:latin typeface="Arial"/>
-                        </a:rPr>
-                        <a:t>symptom</a:t>
-                      </a:r>
-                    </a:p>
-                  </a:txBody>
-                  <a:tcPr marL="54864" marR="54864" marT="18288" marB="18288">
-                    <a:solidFill>
-                      <a:srgbClr val="1F4E79"/>
-                    </a:solidFill>
-                  </a:tcPr>
-                </a:tc>
-                <a:tc>
-                  <a:txBody>
-                    <a:bodyPr wrap="square"/>
-                    <a:lstStyle/>
-                    <a:p>
-                      <a:r>
-                        <a:rPr sz="1100" b="1">
-                          <a:solidFill>
-                            <a:srgbClr val="FFFFFF"/>
-                          </a:solidFill>
-                          <a:latin typeface="Arial"/>
-                        </a:rPr>
-                        <a:t>fix</a:t>
-                      </a:r>
-                    </a:p>
-                  </a:txBody>
-                  <a:tcPr marL="54864" marR="54864" marT="18288" marB="18288">
-                    <a:solidFill>
-                      <a:srgbClr val="1F4E79"/>
-                    </a:solidFill>
-                  </a:tcPr>
-                </a:tc>
-                <a:tc>
-                  <a:txBody>
-                    <a:bodyPr wrap="square"/>
-                    <a:lstStyle/>
-                    <a:p>
-                      <a:r>
-                        <a:rPr sz="1100" b="1">
-                          <a:solidFill>
-                            <a:srgbClr val="FFFFFF"/>
-                          </a:solidFill>
-                          <a:latin typeface="Arial"/>
-                        </a:rPr>
-                        <a:t>test</a:t>
-                      </a:r>
-                    </a:p>
-                  </a:txBody>
-                  <a:tcPr marL="54864" marR="54864" marT="18288" marB="18288">
-                    <a:solidFill>
-                      <a:srgbClr val="1F4E79"/>
-                    </a:solidFill>
-                  </a:tcPr>
-                </a:tc>
-              </a:tr>
-              <a:tr h="468630">
-                <a:tc>
-                  <a:txBody>
-                    <a:bodyPr wrap="square"/>
-                    <a:lstStyle/>
-                    <a:p>
-                      <a:r>
-                        <a:rPr sz="1100" b="0">
-                          <a:solidFill>
-                            <a:srgbClr val="282828"/>
-                          </a:solidFill>
-                          <a:latin typeface="Arial"/>
-                        </a:rPr>
-                        <a:t>glass names ignored at load</a:t>
-                      </a:r>
-                    </a:p>
-                  </a:txBody>
-                  <a:tcPr marL="54864" marR="54864" marT="18288" marB="18288">
-                    <a:solidFill>
-                      <a:srgbClr val="FFFFFF"/>
-                    </a:solidFill>
-                  </a:tcPr>
-                </a:tc>
-                <a:tc>
-                  <a:txBody>
-                    <a:bodyPr wrap="square"/>
-                    <a:lstStyle/>
-                    <a:p>
-                      <a:r>
-                        <a:rPr sz="1100" b="0">
-                          <a:solidFill>
-                            <a:srgbClr val="282828"/>
-                          </a:solidFill>
-                          <a:latin typeface="Arial"/>
-                        </a:rPr>
-                        <a:t>a GlassElt= Silica element traced as air in every binding</a:t>
-                      </a:r>
-                    </a:p>
-                  </a:txBody>
-                  <a:tcPr marL="54864" marR="54864" marT="18288" marB="18288">
-                    <a:solidFill>
-                      <a:srgbClr val="FFFFFF"/>
-                    </a:solidFill>
-                  </a:tcPr>
-                </a:tc>
-                <a:tc>
-                  <a:txBody>
-                    <a:bodyPr wrap="square"/>
-                    <a:lstStyle/>
-                    <a:p>
-                      <a:r>
-                        <a:rPr sz="1100" b="0">
-                          <a:solidFill>
-                            <a:srgbClr val="282828"/>
-                          </a:solidFill>
-                          <a:latin typeface="Arial"/>
-                        </a:rPr>
-                        <a:t>the glass catalog is blanked once at allocation, not on every load</a:t>
-                      </a:r>
-                    </a:p>
-                  </a:txBody>
-                  <a:tcPr marL="54864" marR="54864" marT="18288" marB="18288">
-                    <a:solidFill>
-                      <a:srgbClr val="FFFFFF"/>
-                    </a:solidFill>
-                  </a:tcPr>
-                </a:tc>
-                <a:tc>
-                  <a:txBody>
-                    <a:bodyPr wrap="square"/>
-                    <a:lstStyle/>
-                    <a:p>
-                      <a:r>
-                        <a:rPr sz="1100" b="0">
-                          <a:solidFill>
-                            <a:srgbClr val="282828"/>
-                          </a:solidFill>
-                          <a:latin typeface="Arial"/>
-                        </a:rPr>
-                        <a:t>tGlassDispersion (3)</a:t>
-                      </a:r>
-                    </a:p>
-                  </a:txBody>
-                  <a:tcPr marL="54864" marR="54864" marT="18288" marB="18288">
-                    <a:solidFill>
-                      <a:srgbClr val="FFFFFF"/>
-                    </a:solidFill>
-                  </a:tcPr>
-                </a:tc>
-              </a:tr>
-              <a:tr h="657225">
-                <a:tc>
-                  <a:txBody>
-                    <a:bodyPr wrap="square"/>
-                    <a:lstStyle/>
-                    <a:p>
-                      <a:r>
-                        <a:rPr sz="1100" b="0">
-                          <a:solidFill>
-                            <a:srgbClr val="282828"/>
-                          </a:solidFill>
-                          <a:latin typeface="Arial"/>
-                        </a:rPr>
-                        <a:t>vacuum wavelength inside glass</a:t>
-                      </a:r>
-                    </a:p>
-                  </a:txBody>
-                  <a:tcPr marL="54864" marR="54864" marT="18288" marB="18288">
-                    <a:solidFill>
-                      <a:srgbClr val="ECF1F6"/>
-                    </a:solidFill>
-                  </a:tcPr>
-                </a:tc>
-                <a:tc>
-                  <a:txBody>
-                    <a:bodyPr wrap="square"/>
-                    <a:lstStyle/>
-                    <a:p>
-                      <a:r>
-                        <a:rPr sz="1100" b="0">
-                          <a:solidFill>
-                            <a:srgbClr val="282828"/>
-                          </a:solidFill>
-                          <a:latin typeface="Arial"/>
-                        </a:rPr>
-                        <a:t>a propagation leg in a medium ran at the wrong Fresnel number by n</a:t>
-                      </a:r>
-                    </a:p>
-                  </a:txBody>
-                  <a:tcPr marL="54864" marR="54864" marT="18288" marB="18288">
-                    <a:solidFill>
-                      <a:srgbClr val="ECF1F6"/>
-                    </a:solidFill>
-                  </a:tcPr>
-                </a:tc>
-                <a:tc>
-                  <a:txBody>
-                    <a:bodyPr wrap="square"/>
-                    <a:lstStyle/>
-                    <a:p>
-                      <a:r>
-                        <a:rPr sz="1100" b="0">
-                          <a:solidFill>
-                            <a:srgbClr val="282828"/>
-                          </a:solidFill>
-                          <a:latin typeface="Arial"/>
-                        </a:rPr>
-                        <a:t>every kernel takes λ/n of the leg's medium</a:t>
-                      </a:r>
-                    </a:p>
-                  </a:txBody>
-                  <a:tcPr marL="54864" marR="54864" marT="18288" marB="18288">
-                    <a:solidFill>
-                      <a:srgbClr val="ECF1F6"/>
-                    </a:solidFill>
-                  </a:tcPr>
-                </a:tc>
-                <a:tc>
-                  <a:txBody>
-                    <a:bodyPr wrap="square"/>
-                    <a:lstStyle/>
-                    <a:p>
-                      <a:r>
-                        <a:rPr sz="1100" b="0">
-                          <a:solidFill>
-                            <a:srgbClr val="282828"/>
-                          </a:solidFill>
-                          <a:latin typeface="Arial"/>
-                        </a:rPr>
-                        <a:t>tPropMedium (3): z in n ≡ z/n in vacuum</a:t>
-                      </a:r>
-                    </a:p>
-                  </a:txBody>
-                  <a:tcPr marL="54864" marR="54864" marT="18288" marB="18288">
-                    <a:solidFill>
-                      <a:srgbClr val="ECF1F6"/>
-                    </a:solidFill>
-                  </a:tcPr>
-                </a:tc>
-              </a:tr>
-              <a:tr h="657225">
-                <a:tc>
-                  <a:txBody>
-                    <a:bodyPr wrap="square"/>
-                    <a:lstStyle/>
-                    <a:p>
-                      <a:r>
-                        <a:rPr sz="1100" b="0">
-                          <a:solidFill>
-                            <a:srgbClr val="282828"/>
-                          </a:solidFill>
-                          <a:latin typeface="Arial"/>
-                        </a:rPr>
-                        <a:t>groove period along the surface</a:t>
-                      </a:r>
-                    </a:p>
-                  </a:txBody>
-                  <a:tcPr marL="54864" marR="54864" marT="18288" marB="18288">
-                    <a:solidFill>
-                      <a:srgbClr val="FFFFFF"/>
-                    </a:solidFill>
-                  </a:tcPr>
-                </a:tc>
-                <a:tc>
-                  <a:txBody>
-                    <a:bodyPr wrap="square"/>
-                    <a:lstStyle/>
-                    <a:p>
-                      <a:r>
-                        <a:rPr sz="1100" b="0">
-                          <a:solidFill>
-                            <a:srgbClr val="282828"/>
-                          </a:solidFill>
-                          <a:latin typeface="Arial"/>
-                        </a:rPr>
-                        <a:t>2.8 / 3.3 px rms spectral blur at 2500 nm (Offner / Dyson)</a:t>
-                      </a:r>
-                    </a:p>
-                  </a:txBody>
-                  <a:tcPr marL="54864" marR="54864" marT="18288" marB="18288">
-                    <a:solidFill>
-                      <a:srgbClr val="FFFFFF"/>
-                    </a:solidFill>
-                  </a:tcPr>
-                </a:tc>
-                <a:tc>
-                  <a:txBody>
-                    <a:bodyPr wrap="square"/>
-                    <a:lstStyle/>
-                    <a:p>
-                      <a:r>
-                        <a:rPr sz="1100" b="0">
-                          <a:solidFill>
-                            <a:srgbClr val="282828"/>
-                          </a:solidFill>
-                          <a:latin typeface="Arial"/>
-                        </a:rPr>
-                        <a:t>the local grating vector is the un-normalised projection of the ruling direction (chord-ruled)</a:t>
-                      </a:r>
-                    </a:p>
-                  </a:txBody>
-                  <a:tcPr marL="54864" marR="54864" marT="18288" marB="18288">
-                    <a:solidFill>
-                      <a:srgbClr val="FFFFFF"/>
-                    </a:solidFill>
-                  </a:tcPr>
-                </a:tc>
-                <a:tc>
-                  <a:txBody>
-                    <a:bodyPr wrap="square"/>
-                    <a:lstStyle/>
-                    <a:p>
-                      <a:r>
-                        <a:rPr sz="1100" b="0">
-                          <a:solidFill>
-                            <a:srgbClr val="282828"/>
-                          </a:solidFill>
-                          <a:latin typeface="Arial"/>
-                        </a:rPr>
-                        <a:t>tGratingImmersed (4), test_grating_chord</a:t>
-                      </a:r>
-                    </a:p>
-                  </a:txBody>
-                  <a:tcPr marL="54864" marR="54864" marT="18288" marB="18288">
-                    <a:solidFill>
-                      <a:srgbClr val="FFFFFF"/>
-                    </a:solidFill>
-                  </a:tcPr>
-                </a:tc>
-              </a:tr>
-              <a:tr h="468630">
-                <a:tc>
-                  <a:txBody>
-                    <a:bodyPr wrap="square"/>
-                    <a:lstStyle/>
-                    <a:p>
-                      <a:r>
-                        <a:rPr sz="1100" b="0">
-                          <a:solidFill>
-                            <a:srgbClr val="282828"/>
-                          </a:solidFill>
-                          <a:latin typeface="Arial"/>
-                        </a:rPr>
-                        <a:t>grating path-length jump</a:t>
-                      </a:r>
-                    </a:p>
-                  </a:txBody>
-                  <a:tcPr marL="54864" marR="54864" marT="18288" marB="18288">
-                    <a:solidFill>
-                      <a:srgbClr val="ECF1F6"/>
-                    </a:solidFill>
-                  </a:tcPr>
-                </a:tc>
-                <a:tc>
-                  <a:txBody>
-                    <a:bodyPr wrap="square"/>
-                    <a:lstStyle/>
-                    <a:p>
-                      <a:r>
-                        <a:rPr sz="1100" b="0">
-                          <a:solidFill>
-                            <a:srgbClr val="282828"/>
-                          </a:solidFill>
-                          <a:latin typeface="Arial"/>
-                        </a:rPr>
-                        <a:t>4 waves rms of pupil OPD where the rays converged to 0.05 µm</a:t>
-                      </a:r>
-                    </a:p>
-                  </a:txBody>
-                  <a:tcPr marL="54864" marR="54864" marT="18288" marB="18288">
-                    <a:solidFill>
-                      <a:srgbClr val="ECF1F6"/>
-                    </a:solidFill>
-                  </a:tcPr>
-                </a:tc>
-                <a:tc>
-                  <a:txBody>
-                    <a:bodyPr wrap="square"/>
-                    <a:lstStyle/>
-                    <a:p>
-                      <a:r>
-                        <a:rPr sz="1100" b="0">
-                          <a:solidFill>
-                            <a:srgbClr val="282828"/>
-                          </a:solidFill>
-                          <a:latin typeface="Arial"/>
-                        </a:rPr>
-                        <a:t>the jump is the groove count from the vertex along the ruling direction</a:t>
-                      </a:r>
-                    </a:p>
-                  </a:txBody>
-                  <a:tcPr marL="54864" marR="54864" marT="18288" marB="18288">
-                    <a:solidFill>
-                      <a:srgbClr val="ECF1F6"/>
-                    </a:solidFill>
-                  </a:tcPr>
-                </a:tc>
-                <a:tc>
-                  <a:txBody>
-                    <a:bodyPr wrap="square"/>
-                    <a:lstStyle/>
-                    <a:p>
-                      <a:r>
-                        <a:rPr sz="1100" b="0">
-                          <a:solidFill>
-                            <a:srgbClr val="282828"/>
-                          </a:solidFill>
-                          <a:latin typeface="Arial"/>
-                        </a:rPr>
-                        <a:t>tGratingOpl (2)</a:t>
-                      </a:r>
-                    </a:p>
-                  </a:txBody>
-                  <a:tcPr marL="54864" marR="54864" marT="18288" marB="18288">
-                    <a:solidFill>
-                      <a:srgbClr val="ECF1F6"/>
-                    </a:solidFill>
-                  </a:tcPr>
-                </a:tc>
-              </a:tr>
-              <a:tr h="657225">
-                <a:tc>
-                  <a:txBody>
-                    <a:bodyPr wrap="square"/>
-                    <a:lstStyle/>
-                    <a:p>
-                      <a:r>
-                        <a:rPr sz="1100" b="0">
-                          <a:solidFill>
-                            <a:srgbClr val="282828"/>
-                          </a:solidFill>
-                          <a:latin typeface="Arial"/>
-                        </a:rPr>
-                        <a:t>optimizer derivative stride</a:t>
-                      </a:r>
-                    </a:p>
-                  </a:txBody>
-                  <a:tcPr marL="54864" marR="54864" marT="18288" marB="18288">
-                    <a:solidFill>
-                      <a:srgbClr val="FFFFFF"/>
-                    </a:solidFill>
-                  </a:tcPr>
-                </a:tc>
-                <a:tc>
-                  <a:txBody>
-                    <a:bodyPr wrap="square"/>
-                    <a:lstStyle/>
-                    <a:p>
-                      <a:r>
-                        <a:rPr sz="1100" b="0">
-                          <a:solidFill>
-                            <a:srgbClr val="282828"/>
-                          </a:solidFill>
-                          <a:latin typeface="Arial"/>
-                        </a:rPr>
-                        <a:t>a spot-size optimisation over several fields overwrote memory on its second field (the derivative columns advanced by the wavefront's size, not the objective's) and crashed or hung the host</a:t>
-                      </a:r>
-                    </a:p>
-                  </a:txBody>
-                  <a:tcPr marL="54864" marR="54864" marT="18288" marB="18288">
-                    <a:solidFill>
-                      <a:srgbClr val="FFFFFF"/>
-                    </a:solidFill>
-                  </a:tcPr>
-                </a:tc>
-                <a:tc>
-                  <a:txBody>
-                    <a:bodyPr wrap="square"/>
-                    <a:lstStyle/>
-                    <a:p>
-                      <a:r>
-                        <a:rPr sz="1100" b="0">
-                          <a:solidFill>
-                            <a:srgbClr val="282828"/>
-                          </a:solidFill>
-                          <a:latin typeface="Arial"/>
-                        </a:rPr>
-                        <a:t>advance by the objective's size, as the value loop does</a:t>
-                      </a:r>
-                    </a:p>
-                  </a:txBody>
-                  <a:tcPr marL="54864" marR="54864" marT="18288" marB="18288">
-                    <a:solidFill>
-                      <a:srgbClr val="FFFFFF"/>
-                    </a:solidFill>
-                  </a:tcPr>
-                </a:tc>
-                <a:tc>
-                  <a:txBody>
-                    <a:bodyPr wrap="square"/>
-                    <a:lstStyle/>
-                    <a:p>
-                      <a:r>
-                        <a:rPr sz="1100" b="0">
-                          <a:solidFill>
-                            <a:srgbClr val="282828"/>
-                          </a:solidFill>
-                          <a:latin typeface="Arial"/>
-                        </a:rPr>
-                        <a:t>tSpectrometerRx native leg, tDesignTelescope (70, unchanged)</a:t>
-                      </a:r>
-                    </a:p>
-                  </a:txBody>
-                  <a:tcPr marL="54864" marR="54864" marT="18288" marB="18288">
-                    <a:solidFill>
-                      <a:srgbClr val="FFFFFF"/>
-                    </a:solidFill>
-                  </a:tcPr>
-                </a:tc>
-              </a:tr>
-              <a:tr h="657225">
-                <a:tc>
-                  <a:txBody>
-                    <a:bodyPr wrap="square"/>
-                    <a:lstStyle/>
-                    <a:p>
-                      <a:r>
-                        <a:rPr sz="1100" b="0">
-                          <a:solidFill>
-                            <a:srgbClr val="282828"/>
-                          </a:solidFill>
-                          <a:latin typeface="Arial"/>
-                        </a:rPr>
-                        <a:t>optimizer asphere step and failure exit</a:t>
-                      </a:r>
-                    </a:p>
-                  </a:txBody>
-                  <a:tcPr marL="54864" marR="54864" marT="18288" marB="18288">
-                    <a:solidFill>
-                      <a:srgbClr val="ECF1F6"/>
-                    </a:solidFill>
-                  </a:tcPr>
-                </a:tc>
-                <a:tc>
-                  <a:txBody>
-                    <a:bodyPr wrap="square"/>
-                    <a:lstStyle/>
-                    <a:p>
-                      <a:r>
-                        <a:rPr sz="1100" b="0">
-                          <a:solidFill>
-                            <a:srgbClr val="282828"/>
-                          </a:solidFill>
-                          <a:latin typeface="Arial"/>
-                        </a:rPr>
-                        <a:t>an aspheric coefficient was probed by a fixed 1e-10, round-off on a deck in metres: a zero derivative column, a singular matrix at the first step, and a stop on that path that ended the MATLAB process</a:t>
-                      </a:r>
-                    </a:p>
-                  </a:txBody>
-                  <a:tcPr marL="54864" marR="54864" marT="18288" marB="18288">
-                    <a:solidFill>
-                      <a:srgbClr val="ECF1F6"/>
-                    </a:solidFill>
-                  </a:tcPr>
-                </a:tc>
-                <a:tc>
-                  <a:txBody>
-                    <a:bodyPr wrap="square"/>
-                    <a:lstStyle/>
-                    <a:p>
-                      <a:r>
-                        <a:rPr sz="1100" b="0">
-                          <a:solidFill>
-                            <a:srgbClr val="282828"/>
-                          </a:solidFill>
-                          <a:latin typeface="Arial"/>
-                        </a:rPr>
-                        <a:t>the step is 1e-3 of the coefficient (sag-based for a zero one); the failure restores the optics and returns a flag</a:t>
-                      </a:r>
-                    </a:p>
-                  </a:txBody>
-                  <a:tcPr marL="54864" marR="54864" marT="18288" marB="18288">
-                    <a:solidFill>
-                      <a:srgbClr val="ECF1F6"/>
-                    </a:solidFill>
-                  </a:tcPr>
-                </a:tc>
-                <a:tc>
-                  <a:txBody>
-                    <a:bodyPr wrap="square"/>
-                    <a:lstStyle/>
-                    <a:p>
-                      <a:r>
-                        <a:rPr sz="1100" b="0">
-                          <a:solidFill>
-                            <a:srgbClr val="282828"/>
-                          </a:solidFill>
-                          <a:latin typeface="Arial"/>
-                        </a:rPr>
-                        <a:t>tAsphCalib (2): a spoiled paraboloid driven back to zero; the failure path with the host alive</a:t>
-                      </a:r>
-                    </a:p>
-                  </a:txBody>
-                  <a:tcPr marL="54864" marR="54864" marT="18288" marB="18288">
-                    <a:solidFill>
-                      <a:srgbClr val="ECF1F6"/>
-                    </a:solidFill>
-                  </a:tcPr>
-                </a:tc>
-              </a:tr>
-            </a:tbl>
-          </a:graphicData>
-        </a:graphic>
-      </p:graphicFrame>
-      <p:sp>
-        <p:nvSpPr>
-          <p:cNvPr id="5" name="TextBox 4"/>
-          <p:cNvSpPr txBox="1"/>
-          <p:nvPr/>
-        </p:nvSpPr>
-        <p:spPr>
-          <a:xfrm>
-            <a:off x="411480" y="5290947"/>
-            <a:ext cx="11368735" cy="274320"/>
-          </a:xfrm>
-          <a:prstGeom prst="rect">
-            <a:avLst/>
-          </a:prstGeom>
-          <a:noFill/>
-        </p:spPr>
-        <p:txBody>
-          <a:bodyPr wrap="square">
-            <a:spAutoFit/>
-          </a:bodyPr>
-          <a:lstStyle/>
-          <a:p>
-            <a:pPr>
-              <a:spcAft>
-                <a:spcPts val="600"/>
-              </a:spcAft>
-            </a:pPr>
-            <a:r>
-              <a:rPr sz="1050" b="0">
-                <a:solidFill>
-                  <a:srgbClr val="6E6E6E"/>
-                </a:solidFill>
-                <a:latin typeface="Arial"/>
-              </a:rPr>
-              <a:t>Flat gratings are unchanged by the grating fixes; the wavefront-target optimizer, which every telescope design used, was never affected by the fifth.  A seventh item, a short AsphCoef= line killing the host process, now pads with zero and warns (tRxShortAsph).</a:t>
-            </a:r>
-          </a:p>
-        </p:txBody>
-      </p:sp>
-    </p:spTree>
-  </p:cSld>
-  <p:clrMapOvr>
-    <a:masterClrMapping/>
-  </p:clrMapOvr>
-</p:sld>
-</file>
-
-<file path=ppt/slides/slide31.xml><?xml version="1.0" encoding="utf-8"?>
-<p:sld xmlns:a="http://schemas.openxmlformats.org/drawingml/2006/main" xmlns:p="http://schemas.openxmlformats.org/presentationml/2006/main" xmlns:r="http://schemas.openxmlformats.org/officeDocument/2006/relationships">
-  <p:cSld>
-    <p:spTree>
-      <p:nvGrpSpPr>
-        <p:cNvPr id="1" name=""/>
-        <p:cNvGrpSpPr/>
-        <p:nvPr/>
-      </p:nvGrpSpPr>
-      <p:grpSpPr/>
-      <p:sp>
-        <p:nvSpPr>
-          <p:cNvPr id="2" name="TextBox 1"/>
-          <p:cNvSpPr txBox="1"/>
-          <p:nvPr/>
-        </p:nvSpPr>
-        <p:spPr>
-          <a:xfrm>
-            <a:off x="411480" y="201168"/>
-            <a:ext cx="11368735" cy="914400"/>
-          </a:xfrm>
-          <a:prstGeom prst="rect">
-            <a:avLst/>
-          </a:prstGeom>
-          <a:noFill/>
-        </p:spPr>
-        <p:txBody>
-          <a:bodyPr wrap="square">
-            <a:spAutoFit/>
-          </a:bodyPr>
-          <a:lstStyle/>
-          <a:p>
-            <a:pPr>
-              <a:spcAft>
-                <a:spcPts val="400"/>
-              </a:spcAft>
-            </a:pPr>
-            <a:r>
-              <a:rPr sz="2400" b="1">
-                <a:solidFill>
-                  <a:srgbClr val="1F4E79"/>
-                </a:solidFill>
-                <a:latin typeface="Arial"/>
-              </a:rPr>
-              <a:t>Backup: records and tools behind each slide</a:t>
-            </a:r>
-          </a:p>
-          <a:p>
-            <a:pPr>
-              <a:spcAft>
-                <a:spcPts val="0"/>
-              </a:spcAft>
-            </a:pPr>
-            <a:r>
-              <a:rPr sz="1250" b="0">
-                <a:solidFill>
-                  <a:srgbClr val="6E6E6E"/>
-                </a:solidFill>
-                <a:latin typeface="Arial"/>
-              </a:rPr>
-              <a:t>Every number traces to a runner stage and its record file</a:t>
-            </a:r>
-          </a:p>
-        </p:txBody>
-      </p:sp>
-      <p:sp>
-        <p:nvSpPr>
-          <p:cNvPr id="3" name="Rectangle 2"/>
-          <p:cNvSpPr/>
-          <p:nvPr/>
-        </p:nvSpPr>
-        <p:spPr>
-          <a:xfrm>
-            <a:off x="411480" y="1133856"/>
-            <a:ext cx="11368735" cy="20320"/>
-          </a:xfrm>
-          <a:prstGeom prst="rect">
-            <a:avLst/>
-          </a:prstGeom>
-          <a:solidFill>
-            <a:srgbClr val="B8C6D4"/>
-          </a:solidFill>
-          <a:ln>
-            <a:noFill/>
-          </a:ln>
-          <a:effectLst/>
-        </p:spPr>
-        <p:style>
-          <a:lnRef idx="1">
-            <a:schemeClr val="accent1"/>
-          </a:lnRef>
-          <a:fillRef idx="3">
-            <a:schemeClr val="accent1"/>
-          </a:fillRef>
-          <a:effectRef idx="2">
-            <a:schemeClr val="accent1"/>
-          </a:effectRef>
-          <a:fontRef idx="minor">
-            <a:schemeClr val="lt1"/>
-          </a:fontRef>
-        </p:style>
-        <p:txBody>
-          <a:bodyPr rtlCol="0" anchor="ctr"/>
-          <a:lstStyle/>
-          <a:p>
-            <a:pPr algn="ctr"/>
-          </a:p>
-        </p:txBody>
-      </p:sp>
-      <p:graphicFrame>
-        <p:nvGraphicFramePr>
-          <p:cNvPr id="4" name="Table 3"/>
-          <p:cNvGraphicFramePr>
-            <a:graphicFrameLocks noGrp="1"/>
-          </p:cNvGraphicFramePr>
-          <p:nvPr/>
-        </p:nvGraphicFramePr>
-        <p:xfrm>
-          <a:off x="411480" y="1298448"/>
-          <a:ext cx="11368734" cy="4491990"/>
+          <a:ext cx="11368734" cy="4960620"/>
         </p:xfrm>
         <a:graphic>
           <a:graphicData uri="http://schemas.openxmlformats.org/drawingml/2006/table">
@@ -17739,6 +19218,96 @@
                   </a:tcPr>
                 </a:tc>
               </a:tr>
+              <a:tr h="468630">
+                <a:tc>
+                  <a:txBody>
+                    <a:bodyPr wrap="square"/>
+                    <a:lstStyle/>
+                    <a:p>
+                      <a:r>
+                        <a:rPr sz="1100" b="0">
+                          <a:solidFill>
+                            <a:srgbClr val="282828"/>
+                          </a:solidFill>
+                          <a:latin typeface="Arial"/>
+                        </a:rPr>
+                        <a:t>block-size trade</a:t>
+                      </a:r>
+                    </a:p>
+                  </a:txBody>
+                  <a:tcPr marL="54864" marR="54864" marT="18288" marB="18288">
+                    <a:solidFill>
+                      <a:srgbClr val="ECF1F6"/>
+                    </a:solidFill>
+                  </a:tcPr>
+                </a:tc>
+                <a:tc>
+                  <a:txBody>
+                    <a:bodyPr wrap="square"/>
+                    <a:lstStyle/>
+                    <a:p>
+                      <a:r>
+                        <a:rPr sz="1100" b="0">
+                          <a:solidFill>
+                            <a:srgbClr val="282828"/>
+                          </a:solidFill>
+                          <a:latin typeface="Arial"/>
+                        </a:rPr>
+                        <a:t>dyson5_size_trade.m</a:t>
+                      </a:r>
+                    </a:p>
+                  </a:txBody>
+                  <a:tcPr marL="54864" marR="54864" marT="18288" marB="18288">
+                    <a:solidFill>
+                      <a:srgbClr val="ECF1F6"/>
+                    </a:solidFill>
+                  </a:tcPr>
+                </a:tc>
+                <a:tc>
+                  <a:txBody>
+                    <a:bodyPr wrap="square"/>
+                    <a:lstStyle/>
+                    <a:p>
+                      <a:r>
+                        <a:rPr sz="1100" b="0">
+                          <a:solidFill>
+                            <a:srgbClr val="282828"/>
+                          </a:solidFill>
+                          <a:latin typeface="Arial"/>
+                        </a:rPr>
+                        <a:t>dyson5_size.txt, dyson5_size.png, dyson5_size_*.in, BRIEF_dyson5_size.md</a:t>
+                      </a:r>
+                    </a:p>
+                  </a:txBody>
+                  <a:tcPr marL="54864" marR="54864" marT="18288" marB="18288">
+                    <a:solidFill>
+                      <a:srgbClr val="ECF1F6"/>
+                    </a:solidFill>
+                  </a:tcPr>
+                </a:tc>
+                <a:tc>
+                  <a:txBody>
+                    <a:bodyPr wrap="square"/>
+                    <a:lstStyle/>
+                    <a:p>
+                      <a:r>
+                        <a:rPr sz="1100" b="0">
+                          <a:solidFill>
+                            <a:srgbClr val="282828"/>
+                          </a:solidFill>
+                          <a:latin typeface="Arial"/>
+                        </a:rPr>
+                        <a:t>continuation walks over dyson_ladder.m</a:t>
+                      </a:r>
+                    </a:p>
+                  </a:txBody>
+                  <a:tcPr marL="54864" marR="54864" marT="18288" marB="18288">
+                    <a:solidFill>
+                      <a:srgbClr val="ECF1F6"/>
+                    </a:solidFill>
+                  </a:tcPr>
+                </a:tc>
+              </a:tr>
             </a:tbl>
           </a:graphicData>
         </a:graphic>
@@ -17751,7 +19320,7 @@
         </p:nvSpPr>
         <p:spPr>
           <a:xfrm>
-            <a:off x="411480" y="5936742"/>
+            <a:off x="411480" y="6405372"/>
             <a:ext cx="11368735" cy="274320"/>
           </a:xfrm>
           <a:prstGeom prst="rect">
@@ -17790,7 +19359,7 @@
 </p:sld>
 </file>
 
-<file path=ppt/slides/slide32.xml><?xml version="1.0" encoding="utf-8"?>
+<file path=ppt/slides/slide34.xml><?xml version="1.0" encoding="utf-8"?>
 <p:sld xmlns:a="http://schemas.openxmlformats.org/drawingml/2006/main" xmlns:p="http://schemas.openxmlformats.org/presentationml/2006/main" xmlns:r="http://schemas.openxmlformats.org/officeDocument/2006/relationships">
   <p:cSld>
     <p:spTree>

</xml_diff>

<commit_message>
deck_dyson: block-size trade round 2 (CCMac, resources 46797d0) -- no meniscus at the two-module slit: silica 130 mm / 1.6 kg at CRF 1.03 px with 4 crossings; thick menisci miss the spec; one module without a meniscus only in CaF2 at 240 mm / 14 kg
Co-Authored-By: Claude Fable 5.1 <noreply@anthropic.com>
</commit_message>
<xml_diff>
--- a/demo_session/deck_dyson.pptx
+++ b/demo_session/deck_dyson.pptx
@@ -3219,7 +3219,7 @@
                 </a:solidFill>
                 <a:latin typeface="Arial"/>
               </a:rPr>
-              <a:t>DRAFT — in progress.  Every number is from a committed, parameterized runner (mmacos, dyson5_run); records and figures are the runner's own output.  Design of record: the compact variant (step R4): keystone 0.0026 px, smile 0.005 px, CRF 1.33 px, 76 % of the energy in one pixel, at a 220 mm block.  The propagated point-spread function reproduces the ray centroids to 0.002 px, so these are the numbers a detector sees.  The fold-prism layout (step R5) takes the detector package out of the slit's plane at CRF 1.27 px and 70 % in one pixel; a cold shield cannot be bought in this form, since every millimetre of air before the detector costs about 0.5 px of CRF.  The block's size follows the slit: shared between two 27 mm modules, a 130 mm block of 1.7 kg matches the record against 220 mm and 8.2 kg for one module.</a:t>
+              <a:t>DRAFT — in progress.  Every number is from a committed, parameterized runner (mmacos, dyson5_run); records and figures are the runner's own output.  Design of record: the compact variant (step R4): keystone 0.0026 px, smile 0.005 px, CRF 1.33 px, 76 % of the energy in one pixel, at a 220 mm block.  The propagated point-spread function reproduces the ray centroids to 0.002 px, so these are the numbers a detector sees.  The fold-prism layout (step R5) takes the detector package out of the slit's plane at CRF 1.27 px and 70 % in one pixel; a cold shield cannot be bought in this form, since every millimetre of air before the detector costs about 0.5 px of CRF.  The block's size follows the slit: shared between two 27 mm modules, a 130 mm silica block of 1.6 kg with no meniscus images at the pixel (CRF 1.03 px) with half the record's air-glass crossings, against 220 mm, 8.2 kg and a 4 mm meniscus for one module.</a:t>
             </a:r>
           </a:p>
         </p:txBody>
@@ -13879,7 +13879,7 @@
                 </a:solidFill>
                 <a:latin typeface="Arial"/>
               </a:rPr>
-              <a:t>The slit is the lever, not the glass: one module at the full 54 mm slit cannot shrink; two modules of 27 mm match the record with a 130 mm block of 1.7 kg</a:t>
+              <a:t>The slit is the lever: shared between two 27 mm modules the block falls from 220 mm to 130 mm or less, and the meniscus is no longer needed</a:t>
             </a:r>
           </a:p>
         </p:txBody>
@@ -13978,7 +13978,7 @@
                 </a:solidFill>
                 <a:latin typeface="Arial"/>
               </a:rPr>
-              <a:t>•  The trade: each point is a full R4 re-solve walked down in radius, warm-started from the next larger block and scored in the engine; a filled marker matches the record's own scores.</a:t>
+              <a:t>•  The trade: each point is a full re-solve walked down in radius, warm-started from the next larger block and scored in the engine, with the meniscus (solid lines, step R4) and without it (dashed, step R3); a filled marker meets the specification and a ringed one also matches the record's own scores.</a:t>
             </a:r>
           </a:p>
         </p:txBody>
@@ -13999,8 +13999,8 @@
         </p:blipFill>
         <p:spPr>
           <a:xfrm>
-            <a:off x="942381" y="2606039"/>
-            <a:ext cx="10306931" cy="3693160"/>
+            <a:off x="1275528" y="2853690"/>
+            <a:ext cx="9640638" cy="3445510"/>
           </a:xfrm>
           <a:prstGeom prst="rect">
             <a:avLst/>
@@ -14041,7 +14041,7 @@
                 </a:solidFill>
                 <a:latin typeface="Arial"/>
               </a:rPr>
-              <a:t>Per block radius, four families: CRF (left), ensquared energy in one pixel (middle), mass of the edged block (right); filled markers match R4 of record, lines mark the record's values.</a:t>
+              <a:t>Per block radius: CRF (left), ensquared energy in one pixel (middle), mass of the edged block (right); solid lines with the meniscus, dashed without; filled = meets the specification, black ring = matches R4 of record.</a:t>
             </a:r>
           </a:p>
         </p:txBody>
@@ -14114,7 +14114,7 @@
                 </a:solidFill>
                 <a:latin typeface="Arial"/>
               </a:rPr>
-              <a:t>The smallest block per family that matches the record; mass is the block edged to its clear aperture</a:t>
+              <a:t>Two modules with no meniscus: a 130 mm silica block at 1.6 kg images at the pixel with half the air-glass crossings of the record</a:t>
             </a:r>
           </a:p>
         </p:txBody>
@@ -14173,7 +14173,7 @@
         </p:nvGraphicFramePr>
         <p:xfrm>
           <a:off x="411480" y="1298448"/>
-          <a:ext cx="11368732" cy="1680210"/>
+          <a:ext cx="11368733" cy="2245995"/>
         </p:xfrm>
         <a:graphic>
           <a:graphicData uri="http://schemas.openxmlformats.org/drawingml/2006/table">
@@ -14182,15 +14182,15 @@
                 <a:tableStyleId>{5C22544A-7EE6-4342-B048-85BDC9FD1C3A}</a:tableStyleId>
               </a:tblPr>
               <a:tblGrid>
-                <a:gridCol w="4213587"/>
-                <a:gridCol w="1351527"/>
-                <a:gridCol w="1113023"/>
-                <a:gridCol w="1192524"/>
-                <a:gridCol w="636013"/>
-                <a:gridCol w="1192524"/>
-                <a:gridCol w="1669534"/>
+                <a:gridCol w="3828247"/>
+                <a:gridCol w="1798116"/>
+                <a:gridCol w="870056"/>
+                <a:gridCol w="2320150"/>
+                <a:gridCol w="464030"/>
+                <a:gridCol w="870056"/>
+                <a:gridCol w="1218078"/>
               </a:tblGrid>
-              <a:tr h="280035">
+              <a:tr h="468630">
                 <a:tc>
                   <a:txBody>
                     <a:bodyPr wrap="square"/>
@@ -14225,7 +14225,7 @@
                           </a:solidFill>
                           <a:latin typeface="Arial"/>
                         </a:rPr>
-                        <a:t>block radius (mm)</a:t>
+                        <a:t>block radius and thickness (mm)</a:t>
                       </a:r>
                     </a:p>
                   </a:txBody>
@@ -14247,7 +14247,7 @@
                           </a:solidFill>
                           <a:latin typeface="Arial"/>
                         </a:rPr>
-                        <a:t>thickness (mm)</a:t>
+                        <a:t>edged mass (kg)</a:t>
                       </a:r>
                     </a:p>
                   </a:txBody>
@@ -14269,7 +14269,7 @@
                           </a:solidFill>
                           <a:latin typeface="Arial"/>
                         </a:rPr>
-                        <a:t>edged mass (kg)</a:t>
+                        <a:t>air-glass crossings, uncoated throughput</a:t>
                       </a:r>
                     </a:p>
                   </a:txBody>
@@ -14359,7 +14359,7 @@
                           </a:solidFill>
                           <a:latin typeface="Arial"/>
                         </a:rPr>
-                        <a:t>R4 of record: silica, one 54 mm slit</a:t>
+                        <a:t>R4 of record: silica, one 54 mm slit, meniscus</a:t>
                       </a:r>
                     </a:p>
                   </a:txBody>
@@ -14403,29 +14403,29 @@
                           </a:solidFill>
                           <a:latin typeface="Arial"/>
                         </a:rPr>
-                        <a:t>221</a:t>
-                      </a:r>
-                    </a:p>
-                  </a:txBody>
-                  <a:tcPr marL="54864" marR="54864" marT="18288" marB="18288">
-                    <a:solidFill>
-                      <a:srgbClr val="FFFFFF"/>
-                    </a:solidFill>
-                  </a:tcPr>
-                </a:tc>
-                <a:tc>
-                  <a:txBody>
-                    <a:bodyPr wrap="square"/>
-                    <a:lstStyle/>
-                    <a:p>
-                      <a:r>
-                        <a:rPr sz="1100" b="0">
-                          <a:solidFill>
-                            <a:srgbClr val="282828"/>
-                          </a:solidFill>
-                          <a:latin typeface="Arial"/>
-                        </a:rPr>
                         <a:t>8.2</a:t>
+                      </a:r>
+                    </a:p>
+                  </a:txBody>
+                  <a:tcPr marL="54864" marR="54864" marT="18288" marB="18288">
+                    <a:solidFill>
+                      <a:srgbClr val="FFFFFF"/>
+                    </a:solidFill>
+                  </a:tcPr>
+                </a:tc>
+                <a:tc>
+                  <a:txBody>
+                    <a:bodyPr wrap="square"/>
+                    <a:lstStyle/>
+                    <a:p>
+                      <a:r>
+                        <a:rPr sz="1100" b="0">
+                          <a:solidFill>
+                            <a:srgbClr val="282828"/>
+                          </a:solidFill>
+                          <a:latin typeface="Arial"/>
+                        </a:rPr>
+                        <a:t>8, 0.76</a:t>
                       </a:r>
                     </a:p>
                   </a:txBody>
@@ -14515,7 +14515,7 @@
                           </a:solidFill>
                           <a:latin typeface="Arial"/>
                         </a:rPr>
-                        <a:t>CaF2, one 54 mm slit</a:t>
+                        <a:t>CaF2, one 54 mm slit, no meniscus</a:t>
                       </a:r>
                     </a:p>
                   </a:txBody>
@@ -14537,7 +14537,7 @@
                           </a:solidFill>
                           <a:latin typeface="Arial"/>
                         </a:rPr>
-                        <a:t>180</a:t>
+                        <a:t>240</a:t>
                       </a:r>
                     </a:p>
                   </a:txBody>
@@ -14559,7 +14559,7 @@
                           </a:solidFill>
                           <a:latin typeface="Arial"/>
                         </a:rPr>
-                        <a:t>181</a:t>
+                        <a:t>14.3</a:t>
                       </a:r>
                     </a:p>
                   </a:txBody>
@@ -14581,7 +14581,7 @@
                           </a:solidFill>
                           <a:latin typeface="Arial"/>
                         </a:rPr>
-                        <a:t>7.9</a:t>
+                        <a:t>4, 0.88</a:t>
                       </a:r>
                     </a:p>
                   </a:txBody>
@@ -14603,7 +14603,7 @@
                           </a:solidFill>
                           <a:latin typeface="Arial"/>
                         </a:rPr>
-                        <a:t>1.20</a:t>
+                        <a:t>1.21</a:t>
                       </a:r>
                     </a:p>
                   </a:txBody>
@@ -14647,7 +14647,7 @@
                           </a:solidFill>
                           <a:latin typeface="Arial"/>
                         </a:rPr>
-                        <a:t>0.017 / 0.020</a:t>
+                        <a:t>0.005 / 0.006</a:t>
                       </a:r>
                     </a:p>
                   </a:txBody>
@@ -14671,7 +14671,7 @@
                           </a:solidFill>
                           <a:latin typeface="Arial"/>
                         </a:rPr>
-                        <a:t>silica, two 27 mm slits, the record's distortion kept</a:t>
+                        <a:t>silica, two 27 mm slits, no meniscus</a:t>
                       </a:r>
                     </a:p>
                   </a:txBody>
@@ -14715,29 +14715,29 @@
                           </a:solidFill>
                           <a:latin typeface="Arial"/>
                         </a:rPr>
-                        <a:t>131</a:t>
-                      </a:r>
-                    </a:p>
-                  </a:txBody>
-                  <a:tcPr marL="54864" marR="54864" marT="18288" marB="18288">
-                    <a:solidFill>
-                      <a:srgbClr val="FFFFFF"/>
-                    </a:solidFill>
-                  </a:tcPr>
-                </a:tc>
-                <a:tc>
-                  <a:txBody>
-                    <a:bodyPr wrap="square"/>
-                    <a:lstStyle/>
-                    <a:p>
-                      <a:r>
-                        <a:rPr sz="1100" b="0">
-                          <a:solidFill>
-                            <a:srgbClr val="282828"/>
-                          </a:solidFill>
-                          <a:latin typeface="Arial"/>
-                        </a:rPr>
-                        <a:t>1.7 each</a:t>
+                        <a:t>1.6 each</a:t>
+                      </a:r>
+                    </a:p>
+                  </a:txBody>
+                  <a:tcPr marL="54864" marR="54864" marT="18288" marB="18288">
+                    <a:solidFill>
+                      <a:srgbClr val="FFFFFF"/>
+                    </a:solidFill>
+                  </a:tcPr>
+                </a:tc>
+                <a:tc>
+                  <a:txBody>
+                    <a:bodyPr wrap="square"/>
+                    <a:lstStyle/>
+                    <a:p>
+                      <a:r>
+                        <a:rPr sz="1100" b="0">
+                          <a:solidFill>
+                            <a:srgbClr val="282828"/>
+                          </a:solidFill>
+                          <a:latin typeface="Arial"/>
+                        </a:rPr>
+                        <a:t>4, 0.87</a:t>
                       </a:r>
                     </a:p>
                   </a:txBody>
@@ -14803,7 +14803,7 @@
                           </a:solidFill>
                           <a:latin typeface="Arial"/>
                         </a:rPr>
-                        <a:t>0.009 / 0.009</a:t>
+                        <a:t>0.007 / 0.009</a:t>
                       </a:r>
                     </a:p>
                   </a:txBody>
@@ -14814,20 +14814,20 @@
                   </a:tcPr>
                 </a:tc>
               </a:tr>
-              <a:tr h="280035">
-                <a:tc>
-                  <a:txBody>
-                    <a:bodyPr wrap="square"/>
-                    <a:lstStyle/>
-                    <a:p>
-                      <a:r>
-                        <a:rPr sz="1100" b="0">
-                          <a:solidFill>
-                            <a:srgbClr val="282828"/>
-                          </a:solidFill>
-                          <a:latin typeface="Arial"/>
-                        </a:rPr>
-                        <a:t>silica, two 27 mm slits, smallest</a:t>
+              <a:tr h="468630">
+                <a:tc>
+                  <a:txBody>
+                    <a:bodyPr wrap="square"/>
+                    <a:lstStyle/>
+                    <a:p>
+                      <a:r>
+                        <a:rPr sz="1100" b="0">
+                          <a:solidFill>
+                            <a:srgbClr val="282828"/>
+                          </a:solidFill>
+                          <a:latin typeface="Arial"/>
+                        </a:rPr>
+                        <a:t>silica, two 27 mm slits, no meniscus, smallest matching the record</a:t>
                       </a:r>
                     </a:p>
                   </a:txBody>
@@ -14871,7 +14871,7 @@
                           </a:solidFill>
                           <a:latin typeface="Arial"/>
                         </a:rPr>
-                        <a:t>101</a:t>
+                        <a:t>0.9 each</a:t>
                       </a:r>
                     </a:p>
                   </a:txBody>
@@ -14893,7 +14893,7 @@
                           </a:solidFill>
                           <a:latin typeface="Arial"/>
                         </a:rPr>
-                        <a:t>1.0 each</a:t>
+                        <a:t>4, 0.87</a:t>
                       </a:r>
                     </a:p>
                   </a:txBody>
@@ -14915,7 +14915,7 @@
                           </a:solidFill>
                           <a:latin typeface="Arial"/>
                         </a:rPr>
-                        <a:t>1.05</a:t>
+                        <a:t>1.25</a:t>
                       </a:r>
                     </a:p>
                   </a:txBody>
@@ -14937,7 +14937,7 @@
                           </a:solidFill>
                           <a:latin typeface="Arial"/>
                         </a:rPr>
-                        <a:t>0.96</a:t>
+                        <a:t>0.80</a:t>
                       </a:r>
                     </a:p>
                   </a:txBody>
@@ -14959,7 +14959,7 @@
                           </a:solidFill>
                           <a:latin typeface="Arial"/>
                         </a:rPr>
-                        <a:t>0.044 / 0.049</a:t>
+                        <a:t>0.008 / 0.012</a:t>
                       </a:r>
                     </a:p>
                   </a:txBody>
@@ -14970,20 +14970,20 @@
                   </a:tcPr>
                 </a:tc>
               </a:tr>
-              <a:tr h="280035">
-                <a:tc>
-                  <a:txBody>
-                    <a:bodyPr wrap="square"/>
-                    <a:lstStyle/>
-                    <a:p>
-                      <a:r>
-                        <a:rPr sz="1100" b="0">
-                          <a:solidFill>
-                            <a:srgbClr val="282828"/>
-                          </a:solidFill>
-                          <a:latin typeface="Arial"/>
-                        </a:rPr>
-                        <a:t>CaF2, two 27 mm slits, smallest</a:t>
+              <a:tr h="468630">
+                <a:tc>
+                  <a:txBody>
+                    <a:bodyPr wrap="square"/>
+                    <a:lstStyle/>
+                    <a:p>
+                      <a:r>
+                        <a:rPr sz="1100" b="0">
+                          <a:solidFill>
+                            <a:srgbClr val="282828"/>
+                          </a:solidFill>
+                          <a:latin typeface="Arial"/>
+                        </a:rPr>
+                        <a:t>CaF2, two 27 mm slits, no meniscus, smallest matching the record</a:t>
                       </a:r>
                     </a:p>
                   </a:txBody>
@@ -15027,28 +15027,6 @@
                           </a:solidFill>
                           <a:latin typeface="Arial"/>
                         </a:rPr>
-                        <a:t>81</a:t>
-                      </a:r>
-                    </a:p>
-                  </a:txBody>
-                  <a:tcPr marL="54864" marR="54864" marT="18288" marB="18288">
-                    <a:solidFill>
-                      <a:srgbClr val="FFFFFF"/>
-                    </a:solidFill>
-                  </a:tcPr>
-                </a:tc>
-                <a:tc>
-                  <a:txBody>
-                    <a:bodyPr wrap="square"/>
-                    <a:lstStyle/>
-                    <a:p>
-                      <a:r>
-                        <a:rPr sz="1100" b="0">
-                          <a:solidFill>
-                            <a:srgbClr val="282828"/>
-                          </a:solidFill>
-                          <a:latin typeface="Arial"/>
-                        </a:rPr>
                         <a:t>0.9 each</a:t>
                       </a:r>
                     </a:p>
@@ -15071,51 +15049,73 @@
                           </a:solidFill>
                           <a:latin typeface="Arial"/>
                         </a:rPr>
-                        <a:t>1.04</a:t>
-                      </a:r>
-                    </a:p>
-                  </a:txBody>
-                  <a:tcPr marL="54864" marR="54864" marT="18288" marB="18288">
-                    <a:solidFill>
-                      <a:srgbClr val="FFFFFF"/>
-                    </a:solidFill>
-                  </a:tcPr>
-                </a:tc>
-                <a:tc>
-                  <a:txBody>
-                    <a:bodyPr wrap="square"/>
-                    <a:lstStyle/>
-                    <a:p>
-                      <a:r>
-                        <a:rPr sz="1100" b="0">
-                          <a:solidFill>
-                            <a:srgbClr val="282828"/>
-                          </a:solidFill>
-                          <a:latin typeface="Arial"/>
-                        </a:rPr>
-                        <a:t>0.97</a:t>
-                      </a:r>
-                    </a:p>
-                  </a:txBody>
-                  <a:tcPr marL="54864" marR="54864" marT="18288" marB="18288">
-                    <a:solidFill>
-                      <a:srgbClr val="FFFFFF"/>
-                    </a:solidFill>
-                  </a:tcPr>
-                </a:tc>
-                <a:tc>
-                  <a:txBody>
-                    <a:bodyPr wrap="square"/>
-                    <a:lstStyle/>
-                    <a:p>
-                      <a:r>
-                        <a:rPr sz="1100" b="0">
-                          <a:solidFill>
-                            <a:srgbClr val="282828"/>
-                          </a:solidFill>
-                          <a:latin typeface="Arial"/>
-                        </a:rPr>
-                        <a:t>0.009 / 0.018</a:t>
+                        <a:t>4, 0.88</a:t>
+                      </a:r>
+                    </a:p>
+                  </a:txBody>
+                  <a:tcPr marL="54864" marR="54864" marT="18288" marB="18288">
+                    <a:solidFill>
+                      <a:srgbClr val="FFFFFF"/>
+                    </a:solidFill>
+                  </a:tcPr>
+                </a:tc>
+                <a:tc>
+                  <a:txBody>
+                    <a:bodyPr wrap="square"/>
+                    <a:lstStyle/>
+                    <a:p>
+                      <a:r>
+                        <a:rPr sz="1100" b="0">
+                          <a:solidFill>
+                            <a:srgbClr val="282828"/>
+                          </a:solidFill>
+                          <a:latin typeface="Arial"/>
+                        </a:rPr>
+                        <a:t>1.02</a:t>
+                      </a:r>
+                    </a:p>
+                  </a:txBody>
+                  <a:tcPr marL="54864" marR="54864" marT="18288" marB="18288">
+                    <a:solidFill>
+                      <a:srgbClr val="FFFFFF"/>
+                    </a:solidFill>
+                  </a:tcPr>
+                </a:tc>
+                <a:tc>
+                  <a:txBody>
+                    <a:bodyPr wrap="square"/>
+                    <a:lstStyle/>
+                    <a:p>
+                      <a:r>
+                        <a:rPr sz="1100" b="0">
+                          <a:solidFill>
+                            <a:srgbClr val="282828"/>
+                          </a:solidFill>
+                          <a:latin typeface="Arial"/>
+                        </a:rPr>
+                        <a:t>1.00</a:t>
+                      </a:r>
+                    </a:p>
+                  </a:txBody>
+                  <a:tcPr marL="54864" marR="54864" marT="18288" marB="18288">
+                    <a:solidFill>
+                      <a:srgbClr val="FFFFFF"/>
+                    </a:solidFill>
+                  </a:tcPr>
+                </a:tc>
+                <a:tc>
+                  <a:txBody>
+                    <a:bodyPr wrap="square"/>
+                    <a:lstStyle/>
+                    <a:p>
+                      <a:r>
+                        <a:rPr sz="1100" b="0">
+                          <a:solidFill>
+                            <a:srgbClr val="282828"/>
+                          </a:solidFill>
+                          <a:latin typeface="Arial"/>
+                        </a:rPr>
+                        <a:t>0.002 / 0.007</a:t>
                       </a:r>
                     </a:p>
                   </a:txBody>
@@ -15138,7 +15138,7 @@
         </p:nvSpPr>
         <p:spPr>
           <a:xfrm>
-            <a:off x="411480" y="3124962"/>
+            <a:off x="411480" y="3690747"/>
             <a:ext cx="11368735" cy="274320"/>
           </a:xfrm>
           <a:prstGeom prst="rect">
@@ -15164,7 +15164,7 @@
                 </a:solidFill>
                 <a:latin typeface="Arial"/>
               </a:rPr>
-              <a:t>•  One module cannot shrink: silica already misses at 200 mm (CRF 1.34 px, 74 %), and CaF2's 180 mm block weighs the same as silica's 220 mm because it is denser.  The walk reproduces the closure envelope's 180 and 150 mm rows to 0.02 px, so those limits are the design's and not the solver's.</a:t>
+              <a:t>•  The meniscus was paying for the long slit. With one 54 mm slit, silica closes only with the meniscus, a plate 4 mm thick and 155 mm across that the solve wants thinner still; the thicker meniscus designs of the global search (about 30 mm) miss the specification at CRF 1.64 and 1.72 px.  Without a meniscus, one module closes only in CaF2 and only at 240 mm and 14 kg.</a:t>
             </a:r>
           </a:p>
           <a:p>
@@ -15180,7 +15180,7 @@
                 </a:solidFill>
                 <a:latin typeface="Arial"/>
               </a:rPr>
-              <a:t>•  What two modules cost: two gratings and two detectors of 1500 pixels, and a swath split ahead of the slits, since each block is wider than its slit and the slits cannot abut.  The slit-to-detector clearance stays near 0.5 mm at every size.</a:t>
+              <a:t>•  With two modules it is not needed: the plain block matches the record from 220 mm down to 100 mm in silica and 80 mm in CaF2, with four air-glass crossings where the record has eight, 15 % more light before any coating, and no thin part to make, mount or shake.</a:t>
             </a:r>
           </a:p>
           <a:p>
@@ -15196,7 +15196,7 @@
                 </a:solidFill>
                 <a:latin typeface="Arial"/>
               </a:rPr>
-              <a:t>•  What they also buy: halving the glass path halves the wavefront error from index inhomogeneity and from thermal gradients, estimated at 0.4 waves each for the 220 mm block.</a:t>
+              <a:t>•  What two modules cost: two gratings and two detectors of 1500 pixels, and a swath split ahead of the slits, since each block is wider than its slit and the slits cannot abut.  The slit-to-detector clearance stays near 0.5 mm at every size.  Halving the glass path also halves the wavefront error from index inhomogeneity and thermal gradients, estimated at 0.4 waves each for the 220 mm block.</a:t>
             </a:r>
           </a:p>
         </p:txBody>
@@ -15209,7 +15209,7 @@
         </p:nvSpPr>
         <p:spPr>
           <a:xfrm>
-            <a:off x="411480" y="5563362"/>
+            <a:off x="411480" y="6872096"/>
             <a:ext cx="11368735" cy="274320"/>
           </a:xfrm>
           <a:prstGeom prst="rect">
@@ -15235,7 +15235,7 @@
                 </a:solidFill>
                 <a:latin typeface="Arial"/>
               </a:rPr>
-              <a:t>Record dyson5_size.txt (CCMac, 2026-10-02): 25 engine-scored points; the Mac's engine reproduces the Linux record of R4 to four decimals.</a:t>
+              <a:t>Record dyson5_size.txt (CCMac, 2026-10-02): 48 engine-scored points; throughput is the uncoated Fresnel product at 1 µm, normal incidence; the Mac's engine reproduces the Linux record of R4 to four decimals.</a:t>
             </a:r>
           </a:p>
         </p:txBody>
@@ -15925,7 +15925,7 @@
                 </a:solidFill>
                 <a:latin typeface="Arial"/>
               </a:rPr>
-              <a:t>•  One module or two (a project decision): one 54 mm module needs the 220 mm, 8 kg block; two 27 mm modules need 130 mm and 1.7 kg each, with the swath split ahead of the slits.  The choice also sets the telescope's field: 24.6° for one, or 12.3° each for two.</a:t>
+              <a:t>•  One module or two (a project decision): one 54 mm module needs the 220 mm, 8 kg block and its thin meniscus; two 27 mm modules need a plain 130 mm block of 1.6 kg each, with the swath split ahead of the slits.  The choice also sets the telescope's field: 24.6° for one, or 12.3° each for two.</a:t>
             </a:r>
           </a:p>
           <a:p>

</xml_diff>

<commit_message>
deck_dyson: say why 130 mm silica and 80 mm CaF2 are both on the table -- CaF2 images at the pixel at 80 mm where silica has fallen to CRF 1.49 px; a materials choice
Co-Authored-By: Claude Fable 5.1 <noreply@anthropic.com>
</commit_message>
<xml_diff>
--- a/demo_session/deck_dyson.pptx
+++ b/demo_session/deck_dyson.pptx
@@ -15180,7 +15180,7 @@
                 </a:solidFill>
                 <a:latin typeface="Arial"/>
               </a:rPr>
-              <a:t>•  With two modules it is not needed: the plain block matches the record from 220 mm down to 100 mm in silica and 80 mm in CaF2, with four air-glass crossings where the record has eight, 15 % more light before any coating, and no thin part to make, mount or shake.</a:t>
+              <a:t>•  With two modules it is not needed: the plain block matches the record from 220 mm down to 100 mm in silica and 80 mm in CaF2, with four air-glass crossings where the record has eight, 15 % more light before any coating, and no thin part to make, mount or shake.  CaF2 still images at the pixel at 80 mm, where silica has fallen to CRF 1.49 px; silica needs 130 mm for the same image.  An 80 mm CaF2 block or a 130 mm silica block is a materials choice the ray trace cannot make.</a:t>
             </a:r>
           </a:p>
           <a:p>
@@ -15209,7 +15209,7 @@
         </p:nvSpPr>
         <p:spPr>
           <a:xfrm>
-            <a:off x="411480" y="6872096"/>
+            <a:off x="411480" y="7367397"/>
             <a:ext cx="11368735" cy="274320"/>
           </a:xfrm>
           <a:prstGeom prst="rect">

</xml_diff>

<commit_message>
deck_dyson: the packaged TMS under the smooth clearance operand (TO befa6e9): 123 / 178 px at 30 deg, +5.4 / +4.8 mm; next = constrained solve + wall-off bound
Co-Authored-By: Claude Fable 5.1 <noreply@anthropic.com>
</commit_message>
<xml_diff>
--- a/demo_session/deck_dyson.pptx
+++ b/demo_session/deck_dyson.pptx
@@ -15423,7 +15423,7 @@
                 </a:solidFill>
                 <a:latin typeface="Arial"/>
               </a:rPr>
-              <a:t>•  The two-mirror modified Schwarzschild (the review's form for this regime).  Convex primary, concave secondary, the stop virtual at M2's front focus so the output is telecentric; closed-form first order, exact chain, engine equal to chain on every ray.  On axis — obscured, M1 in the image cone — it images: 1.10 px max rms spot for the 1.5k module (0.59 on axis), 4.26 px for the 3k, each solved on its own strip with M1 and M2 aspheres, the review's own TMS scaled to this focal length sitting at 2.3–4.6 px.  It packages only with the strip 30–40° off axis, where the clearance-wall solves stall at 200–250 px — a stalled solve's value, not a minimum, because the clearance operand is a minimum over sampled points and no finite-difference step is accepted at its knee.  A smooth clearance operand is the one thing between "packages" and an image number; no end-to-end row exists until then.</a:t>
+              <a:t>•  The two-mirror modified Schwarzschild (the review's form for this regime).  Convex primary, concave secondary, the stop virtual at M2's front focus so the output is telecentric; closed-form first order, exact chain, engine equal to chain on every ray.  On axis — obscured, M1 in the image cone — it images: 1.10 px max rms spot for the 1.5k module (0.59 on axis), 4.26 px for the 3k, each solved on its own strip with M1 and M2 aspheres, the review's own TMS scaled to this focal length sitting at 2.3–4.6 px.  It packages only with the strip 30° off axis: with the clearance operand made smooth (an exact segment-to-disc distance and a softmin over rays, where a sampled minimum had stalled every step) the packaged solves reach 123 px (1.5k, +5.4 mm clear) and 178 px (3k, +4.8 mm) — two orders of magnitude from the pixel, and the solver stalls at the wall's knee again, so the number is a knee, not a floor.  What remains is a constrained solve (the wall as an inequality, not a penalty) and an honest lower bound without the wall; no end-to-end row exists for the TMS until one of them lands at the pixel.</a:t>
             </a:r>
           </a:p>
         </p:txBody>
@@ -15444,7 +15444,7 @@
         </p:blipFill>
         <p:spPr>
           <a:xfrm>
-            <a:off x="5643125" y="6213347"/>
+            <a:off x="5643125" y="6708648"/>
             <a:ext cx="905443" cy="365760"/>
           </a:xfrm>
           <a:prstGeom prst="rect">
@@ -15460,7 +15460,7 @@
         </p:nvSpPr>
         <p:spPr>
           <a:xfrm>
-            <a:off x="411480" y="6597395"/>
+            <a:off x="411480" y="7092696"/>
             <a:ext cx="11368735" cy="394208"/>
           </a:xfrm>
           <a:prstGeom prst="rect">
@@ -15980,7 +15980,7 @@
                 </a:solidFill>
                 <a:latin typeface="Arial"/>
               </a:rPr>
-              <a:t>•  The telescope's image (beat 5 continues): at Jim's numbers the modified Schwarzschild images at the pixel on axis (1.10 px for a 1.5k module) and the TMA parent holds a third of the swath; neither is packaged with an image.  Next: a smooth clearance operand so the solver can carry the Schwarzschild off axis with its image; the unobscured section and freeform mirrors on the TMA; the telecentricity of the chosen form against the Dyson's (the optimizer now scores the chief ray's direction and the ray centroid at the image, per field); then the end-to-end score and the full slit diffraction.</a:t>
+              <a:t>•  The telescope's image (beat 5 continues): at Jim's numbers the modified Schwarzschild images at the pixel on axis (1.10 px for a 1.5k module) but at 123 px once packaged 30° off axis, and the TMA parent holds a third of the swath; neither is packaged with an image.  Next: the packaged Schwarzschild under a true inequality-constrained solve, and its lower bound with the wall off (if that is far from the pixel the form is out, not the solver); the unobscured section and freeform mirrors on the TMA; the telecentricity of the chosen form against the Dyson's (the optimizer now scores the chief ray's direction and the ray centroid at the image, per field); then the end-to-end score and the full slit diffraction.</a:t>
             </a:r>
           </a:p>
           <a:p>

</xml_diff>

<commit_message>
deck_dyson: TMS verdict (TO a7dafd2) -- wall-off bound 25 px at 30 deg, the form is out; no end-to-end row for the Schwarzschild
Co-Authored-By: Claude Fable 5.1 <noreply@anthropic.com>
</commit_message>
<xml_diff>
--- a/demo_session/deck_dyson.pptx
+++ b/demo_session/deck_dyson.pptx
@@ -15423,7 +15423,7 @@
                 </a:solidFill>
                 <a:latin typeface="Arial"/>
               </a:rPr>
-              <a:t>•  The two-mirror modified Schwarzschild (the review's form for this regime).  Convex primary, concave secondary, the stop virtual at M2's front focus so the output is telecentric; closed-form first order, exact chain, engine equal to chain on every ray.  On axis — obscured, M1 in the image cone — it images: 1.10 px max rms spot for the 1.5k module (0.59 on axis), 4.26 px for the 3k, each solved on its own strip with M1 and M2 aspheres, the review's own TMS scaled to this focal length sitting at 2.3–4.6 px.  It packages only with the strip 30° off axis: with the clearance operand made smooth (an exact segment-to-disc distance and a softmin over rays, where a sampled minimum had stalled every step) the packaged solves reach 123 px (1.5k, +5.4 mm clear) and 178 px (3k, +4.8 mm) — two orders of magnitude from the pixel, and the solver stalls at the wall's knee again, so the number is a knee, not a floor.  What remains is a constrained solve (the wall as an inequality, not a penalty) and an honest lower bound without the wall; no end-to-end row exists for the TMS until one of them lands at the pixel.</a:t>
+              <a:t>•  The two-mirror modified Schwarzschild (the review's form for this regime).  Convex primary, concave secondary, the stop virtual at M2's front focus so the output is telecentric; closed-form first order, exact chain, engine equal to chain on every ray.  On axis — obscured, M1 in the image cone — it images: 1.10 px max rms spot for the 1.5k module (0.59 on axis), 4.26 px for the 3k, each solved on its own strip with M1 and M2 aspheres, the review's own TMS scaled to this focal length sitting at 2.3–4.6 px.  It packages only with the strip 30° off axis: with the clearance operand made smooth (an exact segment-to-disc distance and a softmin over rays, where a sampled minimum had stalled every step) the packaged solves reach 123 px (1.5k, +5.4 mm clear) and 178 px (3k, +4.8 mm) and stall at the wall's knee.  The bound settles it: with the wall switched off, the same 30° layouts still sit at 25 px (3k; and the 1.5k solve ran pathological) — the form, not the solver, is out at this bias.  Verdict: no packaged Schwarzschild images at the pixel at f = 330 mm, F/1.8; no end-to-end row for it.</a:t>
             </a:r>
           </a:p>
         </p:txBody>
@@ -15980,7 +15980,7 @@
                 </a:solidFill>
                 <a:latin typeface="Arial"/>
               </a:rPr>
-              <a:t>•  The telescope's image (beat 5 continues): at Jim's numbers the modified Schwarzschild images at the pixel on axis (1.10 px for a 1.5k module) but at 123 px once packaged 30° off axis, and the TMA parent holds a third of the swath; neither is packaged with an image.  Next: the packaged Schwarzschild under a true inequality-constrained solve, and its lower bound with the wall off (if that is far from the pixel the form is out, not the solver); the unobscured section and freeform mirrors on the TMA; the telecentricity of the chosen form against the Dyson's (the optimizer now scores the chief ray's direction and the ray centroid at the image, per field); then the end-to-end score and the full slit diffraction.</a:t>
+              <a:t>•  The telescope's image (beat 5 continues): at Jim's numbers the modified Schwarzschild images at the pixel on axis (1.10 px for a 1.5k module) but at 123 px once packaged 30° off axis, and the TMA parent holds a third of the swath; neither is packaged with an image.  The Schwarzschild is out (its wall-off bound at 30° is 25 px).  Next: the unobscured section and freeform mirrors on the TMA; the telecentricity of the chosen form against the Dyson's (the optimizer now scores the chief ray's direction and the ray centroid at the image, per field); then the end-to-end score and the full slit diffraction.</a:t>
             </a:r>
           </a:p>
           <a:p>

</xml_diff>

<commit_message>
deck_dyson: TMA step 2 (Linux) -- the unobscured section holds the 1.5k strip at 6-7 px, 3k ends at 10 mm; plate-scale caveat; records row; CURRENT_SLICE
Co-Authored-By: Claude Fable 5.1 <noreply@anthropic.com>
</commit_message>
<xml_diff>
--- a/demo_session/deck_dyson.pptx
+++ b/demo_session/deck_dyson.pptx
@@ -15407,7 +15407,7 @@
                 </a:solidFill>
                 <a:latin typeface="Arial"/>
               </a:rPr>
-              <a:t>•  The coaxial three-mirror parent (two routes).  The chain's offset solves at 9–10° leave a field-constant residual — the parent's own aberration off its axis — 2 944 nm at best with the clearance gate failing, 6–65 px rms spots in the engine.  The design layer's Korsch TMA with conics solved by the native optimizer at a scanned bias is diffraction-limited on axis (0.008 waves) and holds to ±1.5°: at 1° bias the strip centre is 0.41 px but the imageable half-field is a third of the swath, and the bias cannot be raised to unobscure.  Three conics do not correct 9.4° at F/1.8; the unobscured section and freeform mirrors are the way out.</a:t>
+              <a:t>•  The coaxial three-mirror parent (two routes).  The chain's offset solves at 9–10° leave a field-constant residual — the parent's own aberration off its axis — 2 944 nm at best with the clearance gate failing, 6–65 px rms spots in the engine.  The design layer's Korsch TMA with conics solved by the native optimizer at a scanned bias is diffraction-limited on axis (0.008 waves) and holds to ±1.5°: at 1° bias the strip centre is 0.41 px but the imageable half-field is a third of the swath, and the bias cannot be raised to unobscure.  Three conics do not correct 9.4° at F/1.8 on the coaxial form.  The unobscured eccentric section of the same parent (pupil decentered 190 mm, the beam folded past M2 to M3 and a focal plane beside it, no hole, no central obstruction) holds the 1.5k strip at 6–7 px with three conics — uniform across ±2.35°, M2 1.2 mm from clearing the incoming beam — but leaves the 3k strip's ends at 10 mm; its local plate scale at the 3° bias is 450 mm, not 330, so it must be re-centred before it feeds a slit.  The 3k module needs more than conics on either form: aspheres through the native optimizer, or freeform.</a:t>
             </a:r>
           </a:p>
           <a:p>
@@ -15430,7 +15430,7 @@
       </p:sp>
       <p:pic>
         <p:nvPicPr>
-          <p:cNvPr id="5" name="Picture 4" descr="dyson5_t4_tma_views.png"/>
+          <p:cNvPr id="5" name="Picture 4" descr="dyson5_tma_step2_views.png"/>
           <p:cNvPicPr>
             <a:picLocks noChangeAspect="1"/>
           </p:cNvPicPr>
@@ -15444,8 +15444,8 @@
         </p:blipFill>
         <p:spPr>
           <a:xfrm>
-            <a:off x="5643125" y="6708648"/>
-            <a:ext cx="905443" cy="365760"/>
+            <a:off x="5426084" y="7699247"/>
+            <a:ext cx="1339525" cy="365760"/>
           </a:xfrm>
           <a:prstGeom prst="rect">
             <a:avLst/>
@@ -15460,7 +15460,7 @@
         </p:nvSpPr>
         <p:spPr>
           <a:xfrm>
-            <a:off x="411480" y="7092696"/>
+            <a:off x="411480" y="8083295"/>
             <a:ext cx="11368735" cy="394208"/>
           </a:xfrm>
           <a:prstGeom prst="rect">
@@ -15486,7 +15486,7 @@
                 </a:solidFill>
                 <a:latin typeface="Arial"/>
               </a:rPr>
-              <a:t>Left: the 1.5k modified Schwarzschild on axis (R2c), dispersion plane, metres — the entrance pupil ahead of the convex M1, the concave M2, the image inside the cone.  Right: the coaxial TMA parent at the 1° bias (step 1), the layout as the design layer renders it.</a:t>
+              <a:t>Left: the unobscured eccentric section of the TMA parent for the 1.5k module (step 2, 190 mm decenter, 3° bias), YZ and XZ as the design layer renders it — M1 above, M2 below the incoming beam, the intermediate focus, M3, the focal plane beside it.  Right: the same section at 170 mm for the 3k strip, whose ends do not image.</a:t>
             </a:r>
           </a:p>
         </p:txBody>
@@ -15980,7 +15980,7 @@
                 </a:solidFill>
                 <a:latin typeface="Arial"/>
               </a:rPr>
-              <a:t>•  The telescope's image (beat 5 continues): at Jim's numbers the modified Schwarzschild images at the pixel on axis (1.10 px for a 1.5k module) but at 123 px once packaged 30° off axis, and the TMA parent holds a third of the swath; neither is packaged with an image.  The Schwarzschild is out (its wall-off bound at 30° is 25 px).  Next: the unobscured section and freeform mirrors on the TMA; the telecentricity of the chosen form against the Dyson's (the optimizer now scores the chief ray's direction and the ray centroid at the image, per field); then the end-to-end score and the full slit diffraction.</a:t>
+              <a:t>•  The telescope's image (beat 5 continues): at Jim's numbers the modified Schwarzschild images at the pixel on axis (1.10 px for a 1.5k module) but at 123 px once packaged 30° off axis, and the TMA parent holds a third of the swath; neither is packaged with an image.  The Schwarzschild is out (its wall-off bound at 30° is 25 px); the TMA's unobscured section holds the 1.5k strip at 6–7 px and is one decenter from packaging.  Next: re-centre that section's plate scale at the working bias and clear M2 (step 2b), then its telecentricity against the Dyson; the unobscured section and freeform mirrors on the TMA; the telecentricity of the chosen form against the Dyson's (the optimizer now scores the chief ray's direction and the ray centroid at the image, per field); then the end-to-end score and the full slit diffraction.</a:t>
             </a:r>
           </a:p>
           <a:p>
@@ -18304,7 +18304,7 @@
         </p:nvGraphicFramePr>
         <p:xfrm>
           <a:off x="411480" y="1298448"/>
-          <a:ext cx="11368733" cy="6366510"/>
+          <a:ext cx="11368734" cy="6835140"/>
         </p:xfrm>
         <a:graphic>
           <a:graphicData uri="http://schemas.openxmlformats.org/drawingml/2006/table">
@@ -18313,10 +18313,10 @@
                 <a:tableStyleId>{5C22544A-7EE6-4342-B048-85BDC9FD1C3A}</a:tableStyleId>
               </a:tblPr>
               <a:tblGrid>
-                <a:gridCol w="1929144"/>
-                <a:gridCol w="1817116"/>
-                <a:gridCol w="4658178"/>
-                <a:gridCol w="2964295"/>
+                <a:gridCol w="2201278"/>
+                <a:gridCol w="1889760"/>
+                <a:gridCol w="4447481"/>
+                <a:gridCol w="2830215"/>
               </a:tblGrid>
               <a:tr h="280035">
                 <a:tc>
@@ -19754,6 +19754,96 @@
                   <a:tcPr marL="54864" marR="54864" marT="18288" marB="18288">
                     <a:solidFill>
                       <a:srgbClr val="FFFFFF"/>
+                    </a:solidFill>
+                  </a:tcPr>
+                </a:tc>
+              </a:tr>
+              <a:tr h="468630">
+                <a:tc>
+                  <a:txBody>
+                    <a:bodyPr wrap="square"/>
+                    <a:lstStyle/>
+                    <a:p>
+                      <a:r>
+                        <a:rPr sz="1100" b="0">
+                          <a:solidFill>
+                            <a:srgbClr val="282828"/>
+                          </a:solidFill>
+                          <a:latin typeface="Arial"/>
+                        </a:rPr>
+                        <a:t>telescope, TMA unobscured section (step 2, Linux)</a:t>
+                      </a:r>
+                    </a:p>
+                  </a:txBody>
+                  <a:tcPr marL="54864" marR="54864" marT="18288" marB="18288">
+                    <a:solidFill>
+                      <a:srgbClr val="ECF1F6"/>
+                    </a:solidFill>
+                  </a:tcPr>
+                </a:tc>
+                <a:tc>
+                  <a:txBody>
+                    <a:bodyPr wrap="square"/>
+                    <a:lstStyle/>
+                    <a:p>
+                      <a:r>
+                        <a:rPr sz="1100" b="0">
+                          <a:solidFill>
+                            <a:srgbClr val="282828"/>
+                          </a:solidFill>
+                          <a:latin typeface="Arial"/>
+                        </a:rPr>
+                        <a:t>dyson5_tma_step2_linux.m</a:t>
+                      </a:r>
+                    </a:p>
+                  </a:txBody>
+                  <a:tcPr marL="54864" marR="54864" marT="18288" marB="18288">
+                    <a:solidFill>
+                      <a:srgbClr val="ECF1F6"/>
+                    </a:solidFill>
+                  </a:tcPr>
+                </a:tc>
+                <a:tc>
+                  <a:txBody>
+                    <a:bodyPr wrap="square"/>
+                    <a:lstStyle/>
+                    <a:p>
+                      <a:r>
+                        <a:rPr sz="1100" b="0">
+                          <a:solidFill>
+                            <a:srgbClr val="282828"/>
+                          </a:solidFill>
+                          <a:latin typeface="Arial"/>
+                        </a:rPr>
+                        <a:t>dyson5_tma_step2_linux_d170.txt, _d190.txt, _d190_1k5.in, _layout_*.png</a:t>
+                      </a:r>
+                    </a:p>
+                  </a:txBody>
+                  <a:tcPr marL="54864" marR="54864" marT="18288" marB="18288">
+                    <a:solidFill>
+                      <a:srgbClr val="ECF1F6"/>
+                    </a:solidFill>
+                  </a:tcPr>
+                </a:tc>
+                <a:tc>
+                  <a:txBody>
+                    <a:bodyPr wrap="square"/>
+                    <a:lstStyle/>
+                    <a:p>
+                      <a:r>
+                        <a:rPr sz="1100" b="0">
+                          <a:solidFill>
+                            <a:srgbClr val="282828"/>
+                          </a:solidFill>
+                          <a:latin typeface="Arial"/>
+                        </a:rPr>
+                        <a:t>Telescope.set_offaxis, CALIB over the strip, check_clipping</a:t>
+                      </a:r>
+                    </a:p>
+                  </a:txBody>
+                  <a:tcPr marL="54864" marR="54864" marT="18288" marB="18288">
+                    <a:solidFill>
+                      <a:srgbClr val="ECF1F6"/>
                     </a:solidFill>
                   </a:tcPr>
                 </a:tc>
@@ -19770,7 +19860,7 @@
         </p:nvSpPr>
         <p:spPr>
           <a:xfrm>
-            <a:off x="411480" y="7811262"/>
+            <a:off x="411480" y="8279892"/>
             <a:ext cx="11368735" cy="274320"/>
           </a:xfrm>
           <a:prstGeom prst="rect">

</xml_diff>

<commit_message>
deck_dyson: TMA step 2b -- the first packaged unobscured imaging telescope (1.5k strip 8.9 px, clearance PASS, 1.05 kg) at 447 mm plate scale; blur vs plate scale with three conics
Co-Authored-By: Claude Fable 5.1 <noreply@anthropic.com>
</commit_message>
<xml_diff>
--- a/demo_session/deck_dyson.pptx
+++ b/demo_session/deck_dyson.pptx
@@ -15407,7 +15407,7 @@
                 </a:solidFill>
                 <a:latin typeface="Arial"/>
               </a:rPr>
-              <a:t>•  The coaxial three-mirror parent (two routes).  The chain's offset solves at 9–10° leave a field-constant residual — the parent's own aberration off its axis — 2 944 nm at best with the clearance gate failing, 6–65 px rms spots in the engine.  The design layer's Korsch TMA with conics solved by the native optimizer at a scanned bias is diffraction-limited on axis (0.008 waves) and holds to ±1.5°: at 1° bias the strip centre is 0.41 px but the imageable half-field is a third of the swath, and the bias cannot be raised to unobscure.  Three conics do not correct 9.4° at F/1.8 on the coaxial form.  The unobscured eccentric section of the same parent (pupil decentered 190 mm, the beam folded past M2 to M3 and a focal plane beside it, no hole, no central obstruction) holds the 1.5k strip at 6–7 px with three conics — uniform across ±2.35°, M2 1.2 mm from clearing the incoming beam — but leaves the 3k strip's ends at 10 mm; its local plate scale at the 3° bias is 450 mm, not 330, so it must be re-centred before it feeds a slit.  The 3k module needs more than conics on either form: aspheres through the native optimizer, or freeform.</a:t>
+              <a:t>•  The coaxial three-mirror parent (two routes).  The chain's offset solves at 9–10° leave a field-constant residual — the parent's own aberration off its axis — 2 944 nm at best with the clearance gate failing, 6–65 px rms spots in the engine.  The design layer's Korsch TMA with conics solved by the native optimizer at a scanned bias is diffraction-limited on axis (0.008 waves) and holds to ±1.5°: at 1° bias the strip centre is 0.41 px but the imageable half-field is a third of the swath, and the bias cannot be raised to unobscure.  Three conics do not correct 9.4° at F/1.8 on the coaxial form.  The unobscured eccentric section of the same parent (pupil decentered 205 mm, the beam passing below M2 to M3 and a focal plane beside it, no hole, no central obstruction) is the first packaged imaging telescope in the record: three conics hold the 1.5k strip at 8.9 px (4.3 px at the strip centre), every body clear, 1.05 kg of mirror — at a plate scale of 447 mm, not the 330 mm the ground sample asks.  Asked to hold the plate scale too (the optimizer's new per-field image-position rows), the same three conics give up the blur: blur and plate scale compete, and the 3k strip's ends sit at 10 mm on this form.  Both modules need more than conics: aspheres through the native optimizer, or freeform.</a:t>
             </a:r>
           </a:p>
           <a:p>
@@ -15444,8 +15444,8 @@
         </p:blipFill>
         <p:spPr>
           <a:xfrm>
-            <a:off x="5426084" y="7699247"/>
-            <a:ext cx="1339525" cy="365760"/>
+            <a:off x="5426302" y="7946897"/>
+            <a:ext cx="1339090" cy="365760"/>
           </a:xfrm>
           <a:prstGeom prst="rect">
             <a:avLst/>
@@ -15460,7 +15460,7 @@
         </p:nvSpPr>
         <p:spPr>
           <a:xfrm>
-            <a:off x="411480" y="8083295"/>
+            <a:off x="411480" y="8330945"/>
             <a:ext cx="11368735" cy="394208"/>
           </a:xfrm>
           <a:prstGeom prst="rect">
@@ -15486,7 +15486,7 @@
                 </a:solidFill>
                 <a:latin typeface="Arial"/>
               </a:rPr>
-              <a:t>Left: the unobscured eccentric section of the TMA parent for the 1.5k module (step 2, 190 mm decenter, 3° bias), YZ and XZ as the design layer renders it — M1 above, M2 below the incoming beam, the intermediate focus, M3, the focal plane beside it.  Right: the same section at 170 mm for the 3k strip, whose ends do not image.</a:t>
+              <a:t>Left: the packaged unobscured section of the TMA parent for the 1.5k module (step 2b, 205 mm decenter, 3° bias, clearance +0.1 mm), YZ and XZ as the design layer renders it — M1 above, M2 below the incoming beam, the intermediate focus, M3, the focal plane beside it.  Right: the same section at 170 mm for the 3k strip, whose ends do not image.</a:t>
             </a:r>
           </a:p>
         </p:txBody>
@@ -15980,7 +15980,7 @@
                 </a:solidFill>
                 <a:latin typeface="Arial"/>
               </a:rPr>
-              <a:t>•  The telescope's image (beat 5 continues): at Jim's numbers the modified Schwarzschild images at the pixel on axis (1.10 px for a 1.5k module) but at 123 px once packaged 30° off axis, and the TMA parent holds a third of the swath; neither is packaged with an image.  The Schwarzschild is out (its wall-off bound at 30° is 25 px); the TMA's unobscured section holds the 1.5k strip at 6–7 px and is one decenter from packaging.  Next: re-centre that section's plate scale at the working bias and clear M2 (step 2b), then its telecentricity against the Dyson; the unobscured section and freeform mirrors on the TMA; the telecentricity of the chosen form against the Dyson's (the optimizer now scores the chief ray's direction and the ray centroid at the image, per field); then the end-to-end score and the full slit diffraction.</a:t>
+              <a:t>•  The telescope's image (beat 5 continues): at Jim's numbers the modified Schwarzschild images at the pixel on axis (1.10 px for a 1.5k module) but at 123 px once packaged 30° off axis, and the TMA parent holds a third of the swath; neither is packaged with an image.  The Schwarzschild is out (its wall-off bound at 30° is 25 px); the TMA's unobscured section packages and images the 1.5k strip at 8.9 px, at 447 mm plate scale.  Next: the plate scale and the blur together with aspheres on the section (the optimizer carries both as rows now), then its telecentricity against the Dyson; the unobscured section and freeform mirrors on the TMA; the telecentricity of the chosen form against the Dyson's (the optimizer now scores the chief ray's direction and the ray centroid at the image, per field); then the end-to-end score and the full slit diffraction.</a:t>
             </a:r>
           </a:p>
           <a:p>
@@ -18304,7 +18304,7 @@
         </p:nvGraphicFramePr>
         <p:xfrm>
           <a:off x="411480" y="1298448"/>
-          <a:ext cx="11368734" cy="6835140"/>
+          <a:ext cx="11368734" cy="6646545"/>
         </p:xfrm>
         <a:graphic>
           <a:graphicData uri="http://schemas.openxmlformats.org/drawingml/2006/table">
@@ -18313,10 +18313,10 @@
                 <a:tableStyleId>{5C22544A-7EE6-4342-B048-85BDC9FD1C3A}</a:tableStyleId>
               </a:tblPr>
               <a:tblGrid>
-                <a:gridCol w="2201278"/>
+                <a:gridCol w="1979545"/>
                 <a:gridCol w="1889760"/>
-                <a:gridCol w="4447481"/>
-                <a:gridCol w="2830215"/>
+                <a:gridCol w="3997158"/>
+                <a:gridCol w="3502271"/>
               </a:tblGrid>
               <a:tr h="280035">
                 <a:tc>
@@ -18408,7 +18408,7 @@
                   </a:tcPr>
                 </a:tc>
               </a:tr>
-              <a:tr h="468630">
+              <a:tr h="280035">
                 <a:tc>
                   <a:txBody>
                     <a:bodyPr wrap="square"/>
@@ -19771,7 +19771,7 @@
                           </a:solidFill>
                           <a:latin typeface="Arial"/>
                         </a:rPr>
-                        <a:t>telescope, TMA unobscured section (step 2, Linux)</a:t>
+                        <a:t>telescope, TMA unobscured section (step 2/2b, Linux)</a:t>
                       </a:r>
                     </a:p>
                   </a:txBody>
@@ -19815,7 +19815,7 @@
                           </a:solidFill>
                           <a:latin typeface="Arial"/>
                         </a:rPr>
-                        <a:t>dyson5_tma_step2_linux_d170.txt, _d190.txt, _d190_1k5.in, _layout_*.png</a:t>
+                        <a:t>dyson5_tma_step2_linux_d170.txt, _d190.txt, dyson5_tma_step2b_linux_d205.txt, _d205_1k5.in, _layout_*.png</a:t>
                       </a:r>
                     </a:p>
                   </a:txBody>
@@ -19837,7 +19837,7 @@
                           </a:solidFill>
                           <a:latin typeface="Arial"/>
                         </a:rPr>
-                        <a:t>Telescope.set_offaxis, CALIB over the strip, check_clipping</a:t>
+                        <a:t>Telescope.set_offaxis, CALIB over the strip with the per-field position rows, check_clipping</a:t>
                       </a:r>
                     </a:p>
                   </a:txBody>
@@ -19860,7 +19860,7 @@
         </p:nvSpPr>
         <p:spPr>
           <a:xfrm>
-            <a:off x="411480" y="8279892"/>
+            <a:off x="411480" y="8091297"/>
             <a:ext cx="11368735" cy="274320"/>
           </a:xfrm>
           <a:prstGeom prst="rect">

</xml_diff>

<commit_message>
deck_dyson: the first end-to-end row at Jim's f-number (TO 29a6df0, informative): d205 TMA + 130 mm silica module, 68.7% of the swath on the slit, smile 44.5 px = the telescope seen through the Dyson
Co-Authored-By: Claude Fable 5.1 <noreply@anthropic.com>
</commit_message>
<xml_diff>
--- a/demo_session/deck_dyson.pptx
+++ b/demo_session/deck_dyson.pptx
@@ -15677,6 +15677,22 @@
               <a:t>•  What it establishes: the end-to-end machinery is in place and gated — a telescope deck of record, a combined prescription with the stop at the grating, the admitted fraction per field, the clearance gate across both instruments.  Records dyson5_t2.txt, decks dyson5_t2_r4.in, dyson5_t2_r5.in.</a:t>
             </a:r>
           </a:p>
+          <a:p>
+            <a:pPr>
+              <a:spcAft>
+                <a:spcPts val="600"/>
+              </a:spcAft>
+            </a:pPr>
+            <a:r>
+              <a:rPr sz="1500" b="0">
+                <a:solidFill>
+                  <a:srgbClr val="282828"/>
+                </a:solidFill>
+                <a:latin typeface="Arial"/>
+              </a:rPr>
+              <a:t>•  The first row at Jim's f-number (informative, not the number).  The packaged unobscured TMA section (1.5k, three conics) joined to the 130 mm silica module: its 27 mm slit admits 68.7 % of the ±2.34° swath (plate scale 450 mm local, 521 mm at the strip edge, against 330), the straight sky line images bowed by 7 mm at the strip end, and over the admitted field the scorer reads smile 44.5 px, keystone 0.14 px, CRF 15.7 px — the telescope's image and pupil mismatch seen through the Dyson, the same at every wavelength, not the Dyson's distortion.  Clearance +0.37 mm, chain and engine to 4e-12 m.  Record dyson5_t5e_1k5.txt, deck dyson5_t5e_1k5_e2e.in.</a:t>
+            </a:r>
+          </a:p>
         </p:txBody>
       </p:sp>
       <p:pic>
@@ -15695,8 +15711,8 @@
         </p:blipFill>
         <p:spPr>
           <a:xfrm>
-            <a:off x="4994682" y="4479797"/>
-            <a:ext cx="2202329" cy="1819402"/>
+            <a:off x="5874477" y="6105905"/>
+            <a:ext cx="442741" cy="365760"/>
           </a:xfrm>
           <a:prstGeom prst="rect">
             <a:avLst/>
@@ -15711,7 +15727,7 @@
         </p:nvSpPr>
         <p:spPr>
           <a:xfrm>
-            <a:off x="411480" y="6317488"/>
+            <a:off x="411480" y="6489953"/>
             <a:ext cx="11368735" cy="394208"/>
           </a:xfrm>
           <a:prstGeom prst="rect">
@@ -18304,7 +18320,7 @@
         </p:nvGraphicFramePr>
         <p:xfrm>
           <a:off x="411480" y="1298448"/>
-          <a:ext cx="11368734" cy="6646545"/>
+          <a:ext cx="11368734" cy="7115175"/>
         </p:xfrm>
         <a:graphic>
           <a:graphicData uri="http://schemas.openxmlformats.org/drawingml/2006/table">
@@ -19771,13 +19787,103 @@
                           </a:solidFill>
                           <a:latin typeface="Arial"/>
                         </a:rPr>
+                        <a:t>end to end at Jim's f-number (informative)</a:t>
+                      </a:r>
+                    </a:p>
+                  </a:txBody>
+                  <a:tcPr marL="54864" marR="54864" marT="18288" marB="18288">
+                    <a:solidFill>
+                      <a:srgbClr val="ECF1F6"/>
+                    </a:solidFill>
+                  </a:tcPr>
+                </a:tc>
+                <a:tc>
+                  <a:txBody>
+                    <a:bodyPr wrap="square"/>
+                    <a:lstStyle/>
+                    <a:p>
+                      <a:r>
+                        <a:rPr sz="1100" b="0">
+                          <a:solidFill>
+                            <a:srgbClr val="282828"/>
+                          </a:solidFill>
+                          <a:latin typeface="Arial"/>
+                        </a:rPr>
+                        <a:t>t5e</a:t>
+                      </a:r>
+                    </a:p>
+                  </a:txBody>
+                  <a:tcPr marL="54864" marR="54864" marT="18288" marB="18288">
+                    <a:solidFill>
+                      <a:srgbClr val="ECF1F6"/>
+                    </a:solidFill>
+                  </a:tcPr>
+                </a:tc>
+                <a:tc>
+                  <a:txBody>
+                    <a:bodyPr wrap="square"/>
+                    <a:lstStyle/>
+                    <a:p>
+                      <a:r>
+                        <a:rPr sz="1100" b="0">
+                          <a:solidFill>
+                            <a:srgbClr val="282828"/>
+                          </a:solidFill>
+                          <a:latin typeface="Arial"/>
+                        </a:rPr>
+                        <a:t>dyson5_t5e_1k5.txt, dyson5_t5e_1k5_e2e.in, dyson5_t5e_1k5_maps.png</a:t>
+                      </a:r>
+                    </a:p>
+                  </a:txBody>
+                  <a:tcPr marL="54864" marR="54864" marT="18288" marB="18288">
+                    <a:solidFill>
+                      <a:srgbClr val="ECF1F6"/>
+                    </a:solidFill>
+                  </a:tcPr>
+                </a:tc>
+                <a:tc>
+                  <a:txBody>
+                    <a:bodyPr wrap="square"/>
+                    <a:lstStyle/>
+                    <a:p>
+                      <a:r>
+                        <a:rPr sz="1100" b="0">
+                          <a:solidFill>
+                            <a:srgbClr val="282828"/>
+                          </a:solidFill>
+                          <a:latin typeface="Arial"/>
+                        </a:rPr>
+                        <a:t>tel_deck_geom.m (the exact chain from a Telescope deck), the spectrometer's scorer</a:t>
+                      </a:r>
+                    </a:p>
+                  </a:txBody>
+                  <a:tcPr marL="54864" marR="54864" marT="18288" marB="18288">
+                    <a:solidFill>
+                      <a:srgbClr val="ECF1F6"/>
+                    </a:solidFill>
+                  </a:tcPr>
+                </a:tc>
+              </a:tr>
+              <a:tr h="468630">
+                <a:tc>
+                  <a:txBody>
+                    <a:bodyPr wrap="square"/>
+                    <a:lstStyle/>
+                    <a:p>
+                      <a:r>
+                        <a:rPr sz="1100" b="0">
+                          <a:solidFill>
+                            <a:srgbClr val="282828"/>
+                          </a:solidFill>
+                          <a:latin typeface="Arial"/>
+                        </a:rPr>
                         <a:t>telescope, TMA unobscured section (step 2/2b, Linux)</a:t>
                       </a:r>
                     </a:p>
                   </a:txBody>
                   <a:tcPr marL="54864" marR="54864" marT="18288" marB="18288">
                     <a:solidFill>
-                      <a:srgbClr val="ECF1F6"/>
+                      <a:srgbClr val="FFFFFF"/>
                     </a:solidFill>
                   </a:tcPr>
                 </a:tc>
@@ -19799,7 +19905,7 @@
                   </a:txBody>
                   <a:tcPr marL="54864" marR="54864" marT="18288" marB="18288">
                     <a:solidFill>
-                      <a:srgbClr val="ECF1F6"/>
+                      <a:srgbClr val="FFFFFF"/>
                     </a:solidFill>
                   </a:tcPr>
                 </a:tc>
@@ -19821,7 +19927,7 @@
                   </a:txBody>
                   <a:tcPr marL="54864" marR="54864" marT="18288" marB="18288">
                     <a:solidFill>
-                      <a:srgbClr val="ECF1F6"/>
+                      <a:srgbClr val="FFFFFF"/>
                     </a:solidFill>
                   </a:tcPr>
                 </a:tc>
@@ -19843,7 +19949,7 @@
                   </a:txBody>
                   <a:tcPr marL="54864" marR="54864" marT="18288" marB="18288">
                     <a:solidFill>
-                      <a:srgbClr val="ECF1F6"/>
+                      <a:srgbClr val="FFFFFF"/>
                     </a:solidFill>
                   </a:tcPr>
                 </a:tc>
@@ -19860,7 +19966,7 @@
         </p:nvSpPr>
         <p:spPr>
           <a:xfrm>
-            <a:off x="411480" y="8091297"/>
+            <a:off x="411480" y="8559927"/>
             <a:ext cx="11368735" cy="274320"/>
           </a:xfrm>
           <a:prstGeom prst="rect">

</xml_diff>

<commit_message>
deck_dyson: TO's step 3 -- the d205 section's exit pupil is 22 mm in front of the image (chief 12-46 deg to the slit normal), a first-order condition; step 4 starts from a telecentric layout
Co-Authored-By: Claude Fable 5.1 <noreply@anthropic.com>
</commit_message>
<xml_diff>
--- a/demo_session/deck_dyson.pptx
+++ b/demo_session/deck_dyson.pptx
@@ -15690,7 +15690,7 @@
                 </a:solidFill>
                 <a:latin typeface="Arial"/>
               </a:rPr>
-              <a:t>•  The first row at Jim's f-number (informative, not the number).  The packaged unobscured TMA section (1.5k, three conics) joined to the 130 mm silica module: its 27 mm slit admits 68.7 % of the ±2.34° swath (plate scale 450 mm local, 521 mm at the strip edge, against 330), the straight sky line images bowed by 7 mm at the strip end, and over the admitted field the scorer reads smile 44.5 px, keystone 0.14 px, CRF 15.7 px — the telescope's image and pupil mismatch seen through the Dyson, the same at every wavelength, not the Dyson's distortion.  Clearance +0.37 mm, chain and engine to 4e-12 m.  Record dyson5_t5e_1k5.txt, deck dyson5_t5e_1k5_e2e.in.</a:t>
+              <a:t>•  The first row at Jim's f-number (informative, not the number).  The packaged unobscured TMA section (1.5k, three conics) joined to the 130 mm silica module: its 27 mm slit admits 68.7 % of the ±2.34° swath (plate scale 450 mm local, 521 mm at the strip edge, against 330), the straight sky line images bowed by 7 mm at the strip end, and over the admitted field the scorer reads smile 44.5 px, keystone 0.14 px, CRF 15.7 px — the telescope's image and pupil mismatch seen through the Dyson, the same at every wavelength, not the Dyson's distortion.  Clearance +0.37 mm, chain and engine to 4e-12 m.  The pupil-match table says why: the section's exit pupil sits 22 mm in front of its image, so the chief meets the slit at 12° to 46° across the strip against a near-telecentric Dyson (its chiefs cross 14–44 m away) and misses the grating vertex by 58–114 mm; only the inner field is fully admitted.  The pupil is a first-order layout condition (the stop's place), not figure — step 4 must start from a telecentric layout.  Records dyson5_t5e_1k5.txt, deck dyson5_t5e_1k5_e2e.in.</a:t>
             </a:r>
           </a:p>
         </p:txBody>
@@ -15711,7 +15711,7 @@
         </p:blipFill>
         <p:spPr>
           <a:xfrm>
-            <a:off x="5874477" y="6105905"/>
+            <a:off x="5874477" y="7096506"/>
             <a:ext cx="442741" cy="365760"/>
           </a:xfrm>
           <a:prstGeom prst="rect">
@@ -15727,7 +15727,7 @@
         </p:nvSpPr>
         <p:spPr>
           <a:xfrm>
-            <a:off x="411480" y="6489953"/>
+            <a:off x="411480" y="7480553"/>
             <a:ext cx="11368735" cy="394208"/>
           </a:xfrm>
           <a:prstGeom prst="rect">
@@ -15996,7 +15996,7 @@
                 </a:solidFill>
                 <a:latin typeface="Arial"/>
               </a:rPr>
-              <a:t>•  The telescope's image (beat 5 continues): at Jim's numbers the modified Schwarzschild images at the pixel on axis (1.10 px for a 1.5k module) but at 123 px once packaged 30° off axis, and the TMA parent holds a third of the swath; neither is packaged with an image.  The Schwarzschild is out (its wall-off bound at 30° is 25 px); the TMA's unobscured section packages and images the 1.5k strip at 8.9 px, at 447 mm plate scale.  Next: the plate scale and the blur together with aspheres on the section (the optimizer carries both as rows now), then its telecentricity against the Dyson; the unobscured section and freeform mirrors on the TMA; the telecentricity of the chosen form against the Dyson's (the optimizer now scores the chief ray's direction and the ray centroid at the image, per field); then the end-to-end score and the full slit diffraction.</a:t>
+              <a:t>•  The telescope's image (beat 5 continues): at Jim's numbers the modified Schwarzschild images at the pixel on axis (1.10 px for a 1.5k module) but at 123 px once packaged 30° off axis, and the TMA parent holds a third of the swath; neither is packaged with an image.  The Schwarzschild is out (its wall-off bound at 30° is 25 px); the TMA's unobscured section packages and images the 1.5k strip at 8.9 px, at 447 mm plate scale.  Next: re-pose the section's first order with the exit pupil at infinity (the optimizer now carries chief-direction rows, which measure the pupil and move only with layout freedoms), then the plate scale and the blur with aspheres on it; the unobscured section and freeform mirrors on the TMA; the telecentricity of the chosen form against the Dyson's (the optimizer now scores the chief ray's direction and the ray centroid at the image, per field); then the end-to-end score and the full slit diffraction.</a:t>
             </a:r>
           </a:p>
           <a:p>

</xml_diff>

<commit_message>
deck_dyson: stage A (TO 174682b) -- on the telecentric parent the pupil is fixed (chiefs within 0.5 deg, every field admitted) and the plate scale calibrates to 329.5 mm; blur is the figure stage's job
Co-Authored-By: Claude Fable 5.1 <noreply@anthropic.com>
</commit_message>
<xml_diff>
--- a/demo_session/deck_dyson.pptx
+++ b/demo_session/deck_dyson.pptx
@@ -15690,7 +15690,7 @@
                 </a:solidFill>
                 <a:latin typeface="Arial"/>
               </a:rPr>
-              <a:t>•  The first row at Jim's f-number (informative, not the number).  The packaged unobscured TMA section (1.5k, three conics) joined to the 130 mm silica module: its 27 mm slit admits 68.7 % of the ±2.34° swath (plate scale 450 mm local, 521 mm at the strip edge, against 330), the straight sky line images bowed by 7 mm at the strip end, and over the admitted field the scorer reads smile 44.5 px, keystone 0.14 px, CRF 15.7 px — the telescope's image and pupil mismatch seen through the Dyson, the same at every wavelength, not the Dyson's distortion.  Clearance +0.37 mm, chain and engine to 4e-12 m.  The pupil-match table says why: the section's exit pupil sits 22 mm in front of its image, so the chief meets the slit at 12° to 46° across the strip against a near-telecentric Dyson (its chiefs cross 14–44 m away) and misses the grating vertex by 58–114 mm; only the inner field is fully admitted.  The pupil is a first-order layout condition (the stop's place), not figure — step 4 must start from a telecentric layout.  Records dyson5_t5e_1k5.txt, deck dyson5_t5e_1k5_e2e.in.</a:t>
+              <a:t>•  The first row at Jim's f-number (informative, not the number).  The packaged unobscured TMA section (1.5k, three conics) joined to the 130 mm silica module: its 27 mm slit admits 68.7 % of the ±2.34° swath (plate scale 450 mm local, 521 mm at the strip edge, against 330), the straight sky line images bowed by 7 mm at the strip end, and over the admitted field the scorer reads smile 44.5 px, keystone 0.14 px, CRF 15.7 px — the telescope's image and pupil mismatch seen through the Dyson, the same at every wavelength, not the Dyson's distortion.  Clearance +0.37 mm, chain and engine to 4e-12 m.  The pupil-match table says why: the section's exit pupil sits 22 mm in front of its image, so the chief meets the slit at 12° to 46° across the strip against a near-telecentric Dyson (its chiefs cross 14–44 m away) and misses the grating vertex by 58–114 mm; only the inner field is fully admitted.  The pupil is a first-order layout condition, not figure: the Korsch with a real intermediate focus between M2 and M3 can never be telecentric, so the layout was re-posed with M3 in front of that focus (the Cook/EMIT form, tma_layout 'telecentric').  On that parent's section the chiefs are within 0.5° across the 1.5k strip, the pupil sits ~1 m out and every field is admitted (0.997–1.000); at the working point (3° bias, 160 mm decenter, clearance +3.7 mm) the plate scale calibrates to 329.5 mm.  First order closes; blur with conics alone is 18.6 px (1.5k) and 36 px (3k), the figure stage's job.  Records dyson5_t5e_1k5.txt, stage tA.</a:t>
             </a:r>
           </a:p>
         </p:txBody>
@@ -15711,7 +15711,7 @@
         </p:blipFill>
         <p:spPr>
           <a:xfrm>
-            <a:off x="5874477" y="7096506"/>
+            <a:off x="5874477" y="7839455"/>
             <a:ext cx="442741" cy="365760"/>
           </a:xfrm>
           <a:prstGeom prst="rect">
@@ -15727,7 +15727,7 @@
         </p:nvSpPr>
         <p:spPr>
           <a:xfrm>
-            <a:off x="411480" y="7480553"/>
+            <a:off x="411480" y="8223503"/>
             <a:ext cx="11368735" cy="394208"/>
           </a:xfrm>
           <a:prstGeom prst="rect">
@@ -15996,7 +15996,7 @@
                 </a:solidFill>
                 <a:latin typeface="Arial"/>
               </a:rPr>
-              <a:t>•  The telescope's image (beat 5 continues): at Jim's numbers the modified Schwarzschild images at the pixel on axis (1.10 px for a 1.5k module) but at 123 px once packaged 30° off axis, and the TMA parent holds a third of the swath; neither is packaged with an image.  The Schwarzschild is out (its wall-off bound at 30° is 25 px); the TMA's unobscured section packages and images the 1.5k strip at 8.9 px, at 447 mm plate scale.  Next: re-pose the section's first order with the exit pupil at infinity (the optimizer now carries chief-direction rows, which measure the pupil and move only with layout freedoms), then the plate scale and the blur with aspheres on it; the unobscured section and freeform mirrors on the TMA; the telecentricity of the chosen form against the Dyson's (the optimizer now scores the chief ray's direction and the ray centroid at the image, per field); then the end-to-end score and the full slit diffraction.</a:t>
+              <a:t>•  The telescope's image (beat 5 continues): at Jim's numbers the modified Schwarzschild images at the pixel on axis (1.10 px for a 1.5k module) but at 123 px once packaged 30° off axis, and the TMA parent holds a third of the swath; neither is packaged with an image.  The Schwarzschild is out (its wall-off bound at 30° is 25 px); the TMA's unobscured section packages and images the 1.5k strip at 8.9 px, at 447 mm plate scale.  Next: figure on the telecentric section — aspheres with the per-field position rows carried in every rung (the strip conic solve alone flips between two plate-scale basins, 319 and 341 mm), freeform if the strip edges remain the limit; and the Dyson's roll about the chief to clear its detector package from the telescope's M2; the unobscured section and freeform mirrors on the TMA; the telecentricity of the chosen form against the Dyson's (the optimizer now scores the chief ray's direction and the ray centroid at the image, per field); then the end-to-end score and the full slit diffraction.</a:t>
             </a:r>
           </a:p>
           <a:p>

</xml_diff>

<commit_message>
deck_dyson + addendum 38: stage B (TO 027fa9d/7535d56) -- 1.5k module at the pixel over the inner strip on the telecentric section, 330.8 mm, 99.4% on the slit; 3k edge fields blocked by a CALIB evaluation item (engine, CC)
Co-Authored-By: Claude Fable 5.1 <noreply@anthropic.com>
</commit_message>
<xml_diff>
--- a/demo_session/deck_dyson.pptx
+++ b/demo_session/deck_dyson.pptx
@@ -15690,7 +15690,7 @@
                 </a:solidFill>
                 <a:latin typeface="Arial"/>
               </a:rPr>
-              <a:t>•  The first row at Jim's f-number (informative, not the number).  The packaged unobscured TMA section (1.5k, three conics) joined to the 130 mm silica module: its 27 mm slit admits 68.7 % of the ±2.34° swath (plate scale 450 mm local, 521 mm at the strip edge, against 330), the straight sky line images bowed by 7 mm at the strip end, and over the admitted field the scorer reads smile 44.5 px, keystone 0.14 px, CRF 15.7 px — the telescope's image and pupil mismatch seen through the Dyson, the same at every wavelength, not the Dyson's distortion.  Clearance +0.37 mm, chain and engine to 4e-12 m.  The pupil-match table says why: the section's exit pupil sits 22 mm in front of its image, so the chief meets the slit at 12° to 46° across the strip against a near-telecentric Dyson (its chiefs cross 14–44 m away) and misses the grating vertex by 58–114 mm; only the inner field is fully admitted.  The pupil is a first-order layout condition, not figure: the Korsch with a real intermediate focus between M2 and M3 can never be telecentric, so the layout was re-posed with M3 in front of that focus (the Cook/EMIT form, tma_layout 'telecentric').  On that parent's section the chiefs are within 0.5° across the 1.5k strip, the pupil sits ~1 m out and every field is admitted (0.997–1.000); at the working point (3° bias, 160 mm decenter, clearance +3.7 mm) the plate scale calibrates to 329.5 mm.  First order closes; blur with conics alone is 18.6 px (1.5k) and 36 px (3k), the figure stage's job.  Records dyson5_t5e_1k5.txt, stage tA.</a:t>
+              <a:t>•  The first row at Jim's f-number (informative, not the number).  The packaged unobscured TMA section (1.5k, three conics) joined to the 130 mm silica module: its 27 mm slit admits 68.7 % of the ±2.34° swath (plate scale 450 mm local, 521 mm at the strip edge, against 330), the straight sky line images bowed by 7 mm at the strip end, and over the admitted field the scorer reads smile 44.5 px, keystone 0.14 px, CRF 15.7 px — the telescope's image and pupil mismatch seen through the Dyson, the same at every wavelength, not the Dyson's distortion.  Clearance +0.37 mm, chain and engine to 4e-12 m.  The pupil-match table says why: the section's exit pupil sits 22 mm in front of its image, so the chief meets the slit at 12° to 46° across the strip against a near-telecentric Dyson (its chiefs cross 14–44 m away) and misses the grating vertex by 58–114 mm; only the inner field is fully admitted.  The pupil is a first-order layout condition, not figure: the Korsch with a real intermediate focus between M2 and M3 can never be telecentric, so the layout was re-posed with M3 in front of that focus (the Cook/EMIT form, tma_layout 'telecentric').  On that parent's section the chiefs are within 0.5° across the 1.5k strip, the pupil sits ~1 m out and every field is admitted (0.997–1.000); at the working point (3° bias, 160 mm decenter, clearance +3.7 mm) the plate scale calibrates to 329.5 mm.  First order closes.  With h⁴+h⁶ aspheres on all three mirrors and the per-field image positions carried as targets, the 1.5k module images at 1.3 px at the strip centre and ≤ 2.7 px over the inner half-strip, 15.8 px at the ±2.35° edges, plate scale 330.8 mm, distortion 0.5 %, clearance +2.9 mm; joined to the 130 mm module (the Dyson rolled 180° about the chief to clear its detector package from M2): 99.4 % of the swath on the slit, every field admitted, the chief within 0.8° of the Dyson's, smile 1.96 px, keystone 0.68 px, CRF 15.5 px set by the strip edges.  The 3k module closes its first order at 4° bias (328 mm, 100 % on the 54 mm slit) but its edge fields are not yet solved: the native optimizer cannot evaluate the section at 3° and drops the ±4.7° fields at 4° — an engine item.  Records dyson5_t5e_1k5.txt, stages tA / tB.</a:t>
             </a:r>
           </a:p>
         </p:txBody>
@@ -15711,7 +15711,7 @@
         </p:blipFill>
         <p:spPr>
           <a:xfrm>
-            <a:off x="5874477" y="7839455"/>
+            <a:off x="5874477" y="9325355"/>
             <a:ext cx="442741" cy="365760"/>
           </a:xfrm>
           <a:prstGeom prst="rect">
@@ -15727,7 +15727,7 @@
         </p:nvSpPr>
         <p:spPr>
           <a:xfrm>
-            <a:off x="411480" y="8223503"/>
+            <a:off x="411480" y="9709403"/>
             <a:ext cx="11368735" cy="394208"/>
           </a:xfrm>
           <a:prstGeom prst="rect">
@@ -15996,7 +15996,7 @@
                 </a:solidFill>
                 <a:latin typeface="Arial"/>
               </a:rPr>
-              <a:t>•  The telescope's image (beat 5 continues): at Jim's numbers the modified Schwarzschild images at the pixel on axis (1.10 px for a 1.5k module) but at 123 px once packaged 30° off axis, and the TMA parent holds a third of the swath; neither is packaged with an image.  The Schwarzschild is out (its wall-off bound at 30° is 25 px); the TMA's unobscured section packages and images the 1.5k strip at 8.9 px, at 447 mm plate scale.  Next: figure on the telecentric section — aspheres with the per-field position rows carried in every rung (the strip conic solve alone flips between two plate-scale basins, 319 and 341 mm), freeform if the strip edges remain the limit; and the Dyson's roll about the chief to clear its detector package from the telescope's M2; the unobscured section and freeform mirrors on the TMA; the telecentricity of the chosen form against the Dyson's (the optimizer now scores the chief ray's direction and the ray centroid at the image, per field); then the end-to-end score and the full slit diffraction.</a:t>
+              <a:t>•  The telescope's image (beat 5 continues): at Jim's numbers the modified Schwarzschild images at the pixel on axis (1.10 px for a 1.5k module) but at 123 px once packaged 30° off axis, and the TMA parent holds a third of the swath; neither is packaged with an image.  The Schwarzschild is out (its wall-off bound at 30° is 25 px); the TMA's unobscured section packages and images the 1.5k strip at 8.9 px, at 447 mm plate scale.  Next: the optimizer's evaluation of the 3k section's edge fields (engine); freeform terms for the outer field on both modules (the edges are now the limit: 15.8 px at ±2.35°); more decenter for clearance margin; the unobscured section and freeform mirrors on the TMA; the telecentricity of the chosen form against the Dyson's (the optimizer now scores the chief ray's direction and the ray centroid at the image, per field); then the end-to-end score and the full slit diffraction.</a:t>
             </a:r>
           </a:p>
           <a:p>

</xml_diff>

<commit_message>
deck_dyson: the telescope through today's record -- 1.5k through its Dyson on the corrected engine (2.1 px centre, 19 px edges, 98.8 % on slit), the strip-edge diagnosis (cross-track astigmatism; metric, Petzval and astigmatism-mode legs), four more findings in Backup, next steps; Dave's slide-20 placement folded into deck_dyson.geo.json; edit copy re-synced
37 slides.  The 2026-10-04 stage-B row (1.3 / 15.8 px) is superseded in a
footnote (its solve's aperture circle clipped the edge fields).  Figure
added: the -4/190 e2e maps as the tool emits them, recomposed to two rows.

Co-Authored-By: Claude Fable 5.1 <noreply@anthropic.com>
</commit_message>
<xml_diff>
--- a/demo_session/deck_dyson.pptx
+++ b/demo_session/deck_dyson.pptx
@@ -39,6 +39,9 @@
     <p:sldId id="287" r:id="rId38"/>
     <p:sldId id="288" r:id="rId39"/>
     <p:sldId id="289" r:id="rId40"/>
+    <p:sldId id="290" r:id="rId41"/>
+    <p:sldId id="291" r:id="rId42"/>
+    <p:sldId id="292" r:id="rId43"/>
   </p:sldIdLst>
   <p:sldSz cx="12191695" cy="6858000" type="screen4x3"/>
   <p:notesSz cx="6858000" cy="9144000"/>
@@ -10201,8 +10204,8 @@
         </p:blipFill>
         <p:spPr>
           <a:xfrm>
-            <a:off x="4531435" y="3984498"/>
-            <a:ext cx="3128823" cy="2479802"/>
+            <a:off x="3657600" y="3291840"/>
+            <a:ext cx="4005072" cy="3172968"/>
           </a:xfrm>
           <a:prstGeom prst="rect">
             <a:avLst/>
@@ -10217,8 +10220,8 @@
         </p:nvSpPr>
         <p:spPr>
           <a:xfrm>
-            <a:off x="411480" y="6482588"/>
-            <a:ext cx="11368735" cy="229107"/>
+            <a:off x="3657600" y="6483096"/>
+            <a:ext cx="4005072" cy="559307"/>
           </a:xfrm>
           <a:prstGeom prst="rect">
             <a:avLst/>
@@ -15677,22 +15680,6 @@
               <a:t>•  What it establishes: the end-to-end machinery is in place and gated — a telescope deck of record, a combined prescription with the stop at the grating, the admitted fraction per field, the clearance gate across both instruments.  Records dyson5_t2.txt, decks dyson5_t2_r4.in, dyson5_t2_r5.in.</a:t>
             </a:r>
           </a:p>
-          <a:p>
-            <a:pPr>
-              <a:spcAft>
-                <a:spcPts val="600"/>
-              </a:spcAft>
-            </a:pPr>
-            <a:r>
-              <a:rPr sz="1500" b="0">
-                <a:solidFill>
-                  <a:srgbClr val="282828"/>
-                </a:solidFill>
-                <a:latin typeface="Arial"/>
-              </a:rPr>
-              <a:t>•  The first row at Jim's f-number (informative, not the number).  The packaged unobscured TMA section (1.5k, three conics) joined to the 130 mm silica module: its 27 mm slit admits 68.7 % of the ±2.34° swath (plate scale 450 mm local, 521 mm at the strip edge, against 330), the straight sky line images bowed by 7 mm at the strip end, and over the admitted field the scorer reads smile 44.5 px, keystone 0.14 px, CRF 15.7 px — the telescope's image and pupil mismatch seen through the Dyson, the same at every wavelength, not the Dyson's distortion.  Clearance +0.37 mm, chain and engine to 4e-12 m.  The pupil-match table says why: the section's exit pupil sits 22 mm in front of its image, so the chief meets the slit at 12° to 46° across the strip against a near-telecentric Dyson (its chiefs cross 14–44 m away) and misses the grating vertex by 58–114 mm; only the inner field is fully admitted.  The pupil is a first-order layout condition, not figure: the Korsch with a real intermediate focus between M2 and M3 can never be telecentric, so the layout was re-posed with M3 in front of that focus (the Cook/EMIT form, tma_layout 'telecentric').  On that parent's section the chiefs are within 0.5° across the 1.5k strip, the pupil sits ~1 m out and every field is admitted (0.997–1.000); at the working point (3° bias, 160 mm decenter, clearance +3.7 mm) the plate scale calibrates to 329.5 mm.  First order closes.  With h⁴+h⁶ aspheres on all three mirrors and the per-field image positions carried as targets, the 1.5k module images at 1.3 px at the strip centre and ≤ 2.7 px over the inner half-strip, 15.8 px at the ±2.35° edges, plate scale 330.8 mm, distortion 0.5 %, clearance +2.9 mm; joined to the 130 mm module (the Dyson rolled 180° about the chief to clear its detector package from M2): 99.4 % of the swath on the slit, every field admitted, the chief within 0.8° of the Dyson's, smile 1.96 px, keystone 0.68 px, CRF 15.5 px set by the strip edges.  The 3k module closes its first order at 4° bias (328 mm, 100 % on the 54 mm slit) but its edge fields are not yet solved: the native optimizer cannot evaluate the section at 3° and drops the ±4.7° fields at 4° — an engine item.  Records dyson5_t5e_1k5.txt, stages tA / tB.</a:t>
-            </a:r>
-          </a:p>
         </p:txBody>
       </p:sp>
       <p:pic>
@@ -15711,8 +15698,8 @@
         </p:blipFill>
         <p:spPr>
           <a:xfrm>
-            <a:off x="5874477" y="9325355"/>
-            <a:ext cx="442741" cy="365760"/>
+            <a:off x="4994682" y="4479797"/>
+            <a:ext cx="2202329" cy="1819402"/>
           </a:xfrm>
           <a:prstGeom prst="rect">
             <a:avLst/>
@@ -15727,7 +15714,7 @@
         </p:nvSpPr>
         <p:spPr>
           <a:xfrm>
-            <a:off x="411480" y="9709403"/>
+            <a:off x="411480" y="6317488"/>
             <a:ext cx="11368735" cy="394208"/>
           </a:xfrm>
           <a:prstGeom prst="rect">
@@ -15810,7 +15797,7 @@
                 </a:solidFill>
                 <a:latin typeface="Arial"/>
               </a:rPr>
-              <a:t>Next steps</a:t>
+              <a:t>The 1.5k telescope through its Dyson</a:t>
             </a:r>
           </a:p>
           <a:p>
@@ -15826,7 +15813,7 @@
                 </a:solidFill>
                 <a:latin typeface="Arial"/>
               </a:rPr>
-              <a:t>The native optimizer on the record, the cold window, and the telescope that feeds the slit</a:t>
+              <a:t>On the telecentric parent every field is admitted and the plate scale holds; the strip's inner half images at 2–10 px, its edges at 19 px</a:t>
             </a:r>
           </a:p>
         </p:txBody>
@@ -15909,7 +15896,7 @@
                 </a:solidFill>
                 <a:latin typeface="Arial"/>
               </a:rPr>
-              <a:t>•  The native multi-wavelength optimizer (MACOS CALIB) confirms the compact variant: the engine's spot-size solve over 5 slit positions × 6 wavelengths, the double-pass copies of each surface linked as one, smile and keystone held as walls between iteration chunks, the engine's design read back under an identity check (2e-16 m).  With the blur freedoms (block face radius and conic, meniscus faces, focus) every step is rejected: R4 is a local optimum of the engine's merit as well as the chain's.  With the grating's position free the engine bought blur with 15 px of keystone in five iterations and the wall rejected it: the reason the design needs distortion operands, queued as an engine feature.  From a deliberate 0.3 mm defocus the same solve cuts the spot from 97 to 21 µm, so it moves when there is something to gain.  The block's asphere joins the freedoms now that its differential step is fixed (Backup).</a:t>
+              <a:t>•  The pupil is a first-order condition.  The section's exit pupil must sit near infinity to feed the near-telecentric Dyson (its chiefs cross 14–44 m away; it accepts chiefs within 0.09° of its own).  A Korsch with a real intermediate focus between M2 and M3 can never be telecentric, so the layout was re-posed with M3 in front of that focus (the Cook/EMIT form, tma_layout 'telecentric'): on that parent's section the chiefs are within 0.5° across the strip, the pupil ~1 m out, every field admitted (0.997–1.000), the plate scale calibrated to the spec by the parent's f-number.</a:t>
             </a:r>
           </a:p>
           <a:p>
@@ -15925,7 +15912,7 @@
                 </a:solidFill>
                 <a:latin typeface="Arial"/>
               </a:rPr>
-              <a:t>•  The cold window: the R5 variant with the shield as the detector housing behind a window cemented as the prism's exit face, under the same clearance gate.</a:t>
+              <a:t>•  The figure stage (h⁴+h⁶ on all three mirrors, the per-field image positions as targets, scored on the corrected engine): at 4° bias and 190 mm decenter — the point the clearance walk selects — the strip images at 2.1 px at the centre, 4.2 / 9.8 px at ±0.8° / ±1.6°, 19 px at the ±2.3° edges (best-focus rms 37 / 75 / 176 / 343 µm), plate scale 333.8 mm, clearance +3.97 mm with the mount counted once.</a:t>
             </a:r>
           </a:p>
           <a:p>
@@ -15941,7 +15928,7 @@
                 </a:solidFill>
                 <a:latin typeface="Arial"/>
               </a:rPr>
-              <a:t>•  One module or two (a project decision): one 54 mm module needs the 220 mm, 8 kg block and its thin meniscus; two 27 mm modules need a plain 130 mm block of 1.6 kg each, with the swath split ahead of the slits.  The choice also sets the telescope's field: 24.6° for one, or 12.3° each for two.</a:t>
+              <a:t>•  Through the 130 mm module (the Dyson rolled 180° about the chief to clear its detector package from M2): 98.8 % of the swath on the slit, every field admitted, smile 3.26 px, keystone 0.63 px, CRF 15.5 px, SRF 5.9 px — the telescope's edge blur seen through the Dyson, the same at every wavelength.  Chain and engine agree to 1e-14 m.</a:t>
             </a:r>
           </a:p>
           <a:p>
@@ -15957,20 +15944,83 @@
                 </a:solidFill>
                 <a:latin typeface="Arial"/>
               </a:rPr>
-              <a:t>•  The radiometric chain against the band: throughput, grating efficiency, detector quantum efficiency and the slit loss above.</a:t>
+              <a:t>•  The 3k section (4° bias, 180 mm) closes its scale and distortion — 326.8 / 319.2 mm, 100 % on the 54 mm slit, smile 10.6 px, keystone 1.37 px — with its edge fields at 1.23 mm (68 px).  Records dyson5_tA_B3_.txt, dyson5_t5e_tA_B3_.txt.</a:t>
             </a:r>
           </a:p>
         </p:txBody>
       </p:sp>
+      <p:pic>
+        <p:nvPicPr>
+          <p:cNvPr id="5" name="Picture 4" descr="dyson5_t5e_tA_B3_1k5_b4d190_B1_maps_rc.png"/>
+          <p:cNvPicPr>
+            <a:picLocks noChangeAspect="1"/>
+          </p:cNvPicPr>
+          <p:nvPr/>
+        </p:nvPicPr>
+        <p:blipFill>
+          <a:blip r:embed="rId2"/>
+          <a:stretch>
+            <a:fillRect/>
+          </a:stretch>
+        </p:blipFill>
+        <p:spPr>
+          <a:xfrm>
+            <a:off x="6475777" y="1298448"/>
+            <a:ext cx="5245004" cy="4670552"/>
+          </a:xfrm>
+          <a:prstGeom prst="rect">
+            <a:avLst/>
+          </a:prstGeom>
+        </p:spPr>
+      </p:pic>
       <p:sp>
         <p:nvSpPr>
-          <p:cNvPr id="5" name="TextBox 4"/>
+          <p:cNvPr id="6" name="TextBox 5"/>
           <p:cNvSpPr txBox="1"/>
           <p:nvPr/>
         </p:nvSpPr>
         <p:spPr>
           <a:xfrm>
-            <a:off x="6400800" y="1298448"/>
+            <a:off x="6400800" y="5987288"/>
+            <a:ext cx="5394960" cy="724408"/>
+          </a:xfrm>
+          <a:prstGeom prst="rect">
+            <a:avLst/>
+          </a:prstGeom>
+          <a:noFill/>
+        </p:spPr>
+        <p:txBody>
+          <a:bodyPr wrap="square">
+            <a:spAutoFit/>
+          </a:bodyPr>
+          <a:lstStyle/>
+          <a:p>
+            <a:pPr algn="ctr">
+              <a:spcAft>
+                <a:spcPts val="0"/>
+              </a:spcAft>
+            </a:pPr>
+            <a:r>
+              <a:rPr sz="1000" b="0">
+                <a:solidFill>
+                  <a:srgbClr val="6E6E6E"/>
+                </a:solidFill>
+                <a:latin typeface="Arial"/>
+              </a:rPr>
+              <a:t>The 1.5k telescope through its Dyson (dyson5_t5e_tA_B3_1k5_b4d190_B1), per slit position and wavelength: the field-angle, keystone and smile maps, the spectral and spatial response widths, and the energy in one pixel.  The response widths rise at the two strip ends and nowhere else.</a:t>
+            </a:r>
+          </a:p>
+        </p:txBody>
+      </p:sp>
+      <p:sp>
+        <p:nvSpPr>
+          <p:cNvPr id="7" name="TextBox 6"/>
+          <p:cNvSpPr txBox="1"/>
+          <p:nvPr/>
+        </p:nvSpPr>
+        <p:spPr>
+          <a:xfrm>
+            <a:off x="6400800" y="6748272"/>
             <a:ext cx="5394960" cy="274320"/>
           </a:xfrm>
           <a:prstGeom prst="rect">
@@ -15990,29 +16040,13 @@
               </a:spcAft>
             </a:pPr>
             <a:r>
-              <a:rPr sz="1200" b="0">
+              <a:rPr sz="1050" b="0">
                 <a:solidFill>
-                  <a:srgbClr val="282828"/>
+                  <a:srgbClr val="6E6E6E"/>
                 </a:solidFill>
                 <a:latin typeface="Arial"/>
               </a:rPr>
-              <a:t>•  The telescope's image (beat 5 continues): at Jim's numbers the modified Schwarzschild images at the pixel on axis (1.10 px for a 1.5k module) but at 123 px once packaged 30° off axis, and the TMA parent holds a third of the swath; neither is packaged with an image.  The Schwarzschild is out (its wall-off bound at 30° is 25 px); the TMA's unobscured section packages and images the 1.5k strip at 8.9 px, at 447 mm plate scale.  Next: the optimizer's evaluation of the 3k section's edge fields (engine); freeform terms for the outer field on both modules (the edges are now the limit: 15.8 px at ±2.35°); more decenter for clearance margin; the unobscured section and freeform mirrors on the TMA; the telecentricity of the chosen form against the Dyson's (the optimizer now scores the chief ray's direction and the ray centroid at the image, per field); then the end-to-end score and the full slit diffraction.</a:t>
-            </a:r>
-          </a:p>
-          <a:p>
-            <a:pPr>
-              <a:spcAft>
-                <a:spcPts val="600"/>
-              </a:spcAft>
-            </a:pPr>
-            <a:r>
-              <a:rPr sz="1200" b="0">
-                <a:solidFill>
-                  <a:srgbClr val="282828"/>
-                </a:solidFill>
-                <a:latin typeface="Arial"/>
-              </a:rPr>
-              <a:t>•  Future work, once the design of record is stable: a surface-by-surface tour of the prescription (role, ray footprint, clearance, and the field where a propagation leg ends, per surface); spot diagrams in the Mouroulis &amp; Green form, slit positions down and wavelengths across inside the 18 µm pixel box; the telescope and the end-to-end instrument; polarization sensitivity of the Dyson against the Offner, since the Dyson's near-normal incidence is what the literature credits for its low sensitivity; and, once the telescope exists, full diffraction from the slit through the grating to the detector, to put a number on the slit's truncation of the telescope's image (the literature expects about a 10 % effect on the response functions).</a:t>
+              <a:t>Supersedes the 2026-10-04 row (1.3 / 15.8 px): that solve's aperture circle clipped the edge fields (Backup, finding 10).</a:t>
             </a:r>
           </a:p>
         </p:txBody>
@@ -16709,6 +16743,970 @@
 </file>
 
 <file path=ppt/slides/slide30.xml><?xml version="1.0" encoding="utf-8"?>
+<p:sld xmlns:a="http://schemas.openxmlformats.org/drawingml/2006/main" xmlns:p="http://schemas.openxmlformats.org/presentationml/2006/main" xmlns:r="http://schemas.openxmlformats.org/officeDocument/2006/relationships">
+  <p:cSld>
+    <p:spTree>
+      <p:nvGrpSpPr>
+        <p:cNvPr id="1" name=""/>
+        <p:cNvGrpSpPr/>
+        <p:nvPr/>
+      </p:nvGrpSpPr>
+      <p:grpSpPr/>
+      <p:sp>
+        <p:nvSpPr>
+          <p:cNvPr id="2" name="TextBox 1"/>
+          <p:cNvSpPr txBox="1"/>
+          <p:nvPr/>
+        </p:nvSpPr>
+        <p:spPr>
+          <a:xfrm>
+            <a:off x="411480" y="201168"/>
+            <a:ext cx="11368735" cy="914400"/>
+          </a:xfrm>
+          <a:prstGeom prst="rect">
+            <a:avLst/>
+          </a:prstGeom>
+          <a:noFill/>
+        </p:spPr>
+        <p:txBody>
+          <a:bodyPr wrap="square">
+            <a:spAutoFit/>
+          </a:bodyPr>
+          <a:lstStyle/>
+          <a:p>
+            <a:pPr>
+              <a:spcAft>
+                <a:spcPts val="400"/>
+              </a:spcAft>
+            </a:pPr>
+            <a:r>
+              <a:rPr sz="2400" b="1">
+                <a:solidFill>
+                  <a:srgbClr val="1F4E79"/>
+                </a:solidFill>
+                <a:latin typeface="Arial"/>
+              </a:rPr>
+              <a:t>What limits the strip edge</a:t>
+            </a:r>
+          </a:p>
+          <a:p>
+            <a:pPr>
+              <a:spcAft>
+                <a:spcPts val="0"/>
+              </a:spcAft>
+            </a:pPr>
+            <a:r>
+              <a:rPr sz="1250" b="0">
+                <a:solidFill>
+                  <a:srgbClr val="6E6E6E"/>
+                </a:solidFill>
+                <a:latin typeface="Arial"/>
+              </a:rPr>
+              <a:t>Cross-track astigmatism of the eccentric section, growing as the square of the field; untouched by focus, by the mirrors' power split, or by astigmatism terms alone</a:t>
+            </a:r>
+          </a:p>
+        </p:txBody>
+      </p:sp>
+      <p:sp>
+        <p:nvSpPr>
+          <p:cNvPr id="3" name="Rectangle 2"/>
+          <p:cNvSpPr/>
+          <p:nvPr/>
+        </p:nvSpPr>
+        <p:spPr>
+          <a:xfrm>
+            <a:off x="411480" y="1133856"/>
+            <a:ext cx="11368735" cy="20320"/>
+          </a:xfrm>
+          <a:prstGeom prst="rect">
+            <a:avLst/>
+          </a:prstGeom>
+          <a:solidFill>
+            <a:srgbClr val="B8C6D4"/>
+          </a:solidFill>
+          <a:ln>
+            <a:noFill/>
+          </a:ln>
+          <a:effectLst/>
+        </p:spPr>
+        <p:style>
+          <a:lnRef idx="1">
+            <a:schemeClr val="accent1"/>
+          </a:lnRef>
+          <a:fillRef idx="3">
+            <a:schemeClr val="accent1"/>
+          </a:fillRef>
+          <a:effectRef idx="2">
+            <a:schemeClr val="accent1"/>
+          </a:effectRef>
+          <a:fontRef idx="minor">
+            <a:schemeClr val="lt1"/>
+          </a:fontRef>
+        </p:style>
+        <p:txBody>
+          <a:bodyPr rtlCol="0" anchor="ctr"/>
+          <a:lstStyle/>
+          <a:p>
+            <a:pPr algn="ctr"/>
+          </a:p>
+        </p:txBody>
+      </p:sp>
+      <p:sp>
+        <p:nvSpPr>
+          <p:cNvPr id="4" name="TextBox 3"/>
+          <p:cNvSpPr txBox="1"/>
+          <p:nvPr/>
+        </p:nvSpPr>
+        <p:spPr>
+          <a:xfrm>
+            <a:off x="411480" y="1298448"/>
+            <a:ext cx="5806440" cy="274320"/>
+          </a:xfrm>
+          <a:prstGeom prst="rect">
+            <a:avLst/>
+          </a:prstGeom>
+          <a:noFill/>
+        </p:spPr>
+        <p:txBody>
+          <a:bodyPr wrap="square">
+            <a:spAutoFit/>
+          </a:bodyPr>
+          <a:lstStyle/>
+          <a:p>
+            <a:pPr>
+              <a:spcAft>
+                <a:spcPts val="600"/>
+              </a:spcAft>
+            </a:pPr>
+            <a:r>
+              <a:rPr sz="1200" b="0">
+                <a:solidFill>
+                  <a:srgbClr val="282828"/>
+                </a:solidFill>
+                <a:latin typeface="Arial"/>
+              </a:rPr>
+              <a:t>•  It is not the metric.  The optimizer's default merit, the path length to each ray's own point on the detector (which the chiefs meet at 31°), floors at 16 µm at every field and ranks the strip edge at 2.1× the centre where the true reference sphere ranks it 13.7×.  Re-solving the same conics and aspheres on the true sphere moves the edge 343 → 332 µm, 3 % — inside the solver's run-to-run scatter.  The reference sphere is the reporting metric from here on (about the detector point, and about best focus; they answer different questions).</a:t>
+            </a:r>
+          </a:p>
+          <a:p>
+            <a:pPr>
+              <a:spcAft>
+                <a:spcPts val="600"/>
+              </a:spcAft>
+            </a:pPr>
+            <a:r>
+              <a:rPr sz="1200" b="0">
+                <a:solidFill>
+                  <a:srgbClr val="282828"/>
+                </a:solidFill>
+                <a:latin typeface="Arial"/>
+              </a:rPr>
+              <a:t>•  It is not focus, and not the field curvature of the parent.  Along the strip the along-track focus is flat at every secondary magnification; the cross-track focus curves 2–4 mm, and the two line foci at the edge sit 2.2–5.3 mm apart.  The parent's Petzval sum predicts a flat field near m₂ = 2.9 and the engine shows none there; the magnification that flattens the mean focus (m₂ = 6) is 2× worse once solved.  m₂ = 3.0 is modestly better than the 3.5 used so far (edge 343 → 291 µm) and is the parent for the freeform work.</a:t>
+            </a:r>
+          </a:p>
+          <a:p>
+            <a:pPr>
+              <a:spcAft>
+                <a:spcPts val="600"/>
+              </a:spcAft>
+            </a:pPr>
+            <a:r>
+              <a:rPr sz="1200" b="0">
+                <a:solidFill>
+                  <a:srgbClr val="282828"/>
+                </a:solidFill>
+                <a:latin typeface="Arial"/>
+              </a:rPr>
+              <a:t>•  It is not astigmatism terms alone.  With the aspheres carried exactly on each mirror and Zernike astigmatism added about each section's pole, the edge does not move (291 → 297 µm): those terms are field-constant, the defect is field-quadratic (line-focus separation 0 / 0.9 / 2.1 mm at 0° / 1.6° / 2.3°).  The field dependence enters through the footprint's walk across each mirror times its higher terms — coma and trefoil, then the symmetric terms — the steps now running.</a:t>
+            </a:r>
+          </a:p>
+        </p:txBody>
+      </p:sp>
+      <p:graphicFrame>
+        <p:nvGraphicFramePr>
+          <p:cNvPr id="5" name="Table 4"/>
+          <p:cNvGraphicFramePr>
+            <a:graphicFrameLocks noGrp="1"/>
+          </p:cNvGraphicFramePr>
+          <p:nvPr/>
+        </p:nvGraphicFramePr>
+        <p:xfrm>
+          <a:off x="6400800" y="1298448"/>
+          <a:ext cx="5394957" cy="2171700"/>
+        </p:xfrm>
+        <a:graphic>
+          <a:graphicData uri="http://schemas.openxmlformats.org/drawingml/2006/table">
+            <a:tbl>
+              <a:tblPr firstRow="1" bandRow="1">
+                <a:tableStyleId>{5C22544A-7EE6-4342-B048-85BDC9FD1C3A}</a:tableStyleId>
+              </a:tblPr>
+              <a:tblGrid>
+                <a:gridCol w="1124745"/>
+                <a:gridCol w="1004823"/>
+                <a:gridCol w="2068080"/>
+                <a:gridCol w="1197309"/>
+              </a:tblGrid>
+              <a:tr h="434340">
+                <a:tc>
+                  <a:txBody>
+                    <a:bodyPr wrap="square"/>
+                    <a:lstStyle/>
+                    <a:p>
+                      <a:r>
+                        <a:rPr sz="1000" b="1">
+                          <a:solidFill>
+                            <a:srgbClr val="FFFFFF"/>
+                          </a:solidFill>
+                          <a:latin typeface="Arial"/>
+                        </a:rPr>
+                        <a:t>step</a:t>
+                      </a:r>
+                    </a:p>
+                  </a:txBody>
+                  <a:tcPr marL="54864" marR="54864" marT="18288" marB="18288">
+                    <a:solidFill>
+                      <a:srgbClr val="1F4E79"/>
+                    </a:solidFill>
+                  </a:tcPr>
+                </a:tc>
+                <a:tc>
+                  <a:txBody>
+                    <a:bodyPr wrap="square"/>
+                    <a:lstStyle/>
+                    <a:p>
+                      <a:r>
+                        <a:rPr sz="1000" b="1">
+                          <a:solidFill>
+                            <a:srgbClr val="FFFFFF"/>
+                          </a:solidFill>
+                          <a:latin typeface="Arial"/>
+                        </a:rPr>
+                        <a:t>edge rms spot</a:t>
+                      </a:r>
+                    </a:p>
+                  </a:txBody>
+                  <a:tcPr marL="54864" marR="54864" marT="18288" marB="18288">
+                    <a:solidFill>
+                      <a:srgbClr val="1F4E79"/>
+                    </a:solidFill>
+                  </a:tcPr>
+                </a:tc>
+                <a:tc>
+                  <a:txBody>
+                    <a:bodyPr wrap="square"/>
+                    <a:lstStyle/>
+                    <a:p>
+                      <a:r>
+                        <a:rPr sz="1000" b="1">
+                          <a:solidFill>
+                            <a:srgbClr val="FFFFFF"/>
+                          </a:solidFill>
+                          <a:latin typeface="Arial"/>
+                        </a:rPr>
+                        <a:t>edge wavefront (sphere about detector point / best focus)</a:t>
+                      </a:r>
+                    </a:p>
+                  </a:txBody>
+                  <a:tcPr marL="54864" marR="54864" marT="18288" marB="18288">
+                    <a:solidFill>
+                      <a:srgbClr val="1F4E79"/>
+                    </a:solidFill>
+                  </a:tcPr>
+                </a:tc>
+                <a:tc>
+                  <a:txBody>
+                    <a:bodyPr wrap="square"/>
+                    <a:lstStyle/>
+                    <a:p>
+                      <a:r>
+                        <a:rPr sz="1000" b="1">
+                          <a:solidFill>
+                            <a:srgbClr val="FFFFFF"/>
+                          </a:solidFill>
+                          <a:latin typeface="Arial"/>
+                        </a:rPr>
+                        <a:t>line-focus separation at the edge</a:t>
+                      </a:r>
+                    </a:p>
+                  </a:txBody>
+                  <a:tcPr marL="54864" marR="54864" marT="18288" marB="18288">
+                    <a:solidFill>
+                      <a:srgbClr val="1F4E79"/>
+                    </a:solidFill>
+                  </a:tcPr>
+                </a:tc>
+              </a:tr>
+              <a:tr h="434340">
+                <a:tc>
+                  <a:txBody>
+                    <a:bodyPr wrap="square"/>
+                    <a:lstStyle/>
+                    <a:p>
+                      <a:r>
+                        <a:rPr sz="1000" b="0">
+                          <a:solidFill>
+                            <a:srgbClr val="282828"/>
+                          </a:solidFill>
+                          <a:latin typeface="Arial"/>
+                        </a:rPr>
+                        <a:t>conics + aspheres, m₂ = 3.5</a:t>
+                      </a:r>
+                    </a:p>
+                  </a:txBody>
+                  <a:tcPr marL="54864" marR="54864" marT="18288" marB="18288">
+                    <a:solidFill>
+                      <a:srgbClr val="FFFFFF"/>
+                    </a:solidFill>
+                  </a:tcPr>
+                </a:tc>
+                <a:tc>
+                  <a:txBody>
+                    <a:bodyPr wrap="square"/>
+                    <a:lstStyle/>
+                    <a:p>
+                      <a:r>
+                        <a:rPr sz="1000" b="0">
+                          <a:solidFill>
+                            <a:srgbClr val="282828"/>
+                          </a:solidFill>
+                          <a:latin typeface="Arial"/>
+                        </a:rPr>
+                        <a:t>343 µm</a:t>
+                      </a:r>
+                    </a:p>
+                  </a:txBody>
+                  <a:tcPr marL="54864" marR="54864" marT="18288" marB="18288">
+                    <a:solidFill>
+                      <a:srgbClr val="FFFFFF"/>
+                    </a:solidFill>
+                  </a:tcPr>
+                </a:tc>
+                <a:tc>
+                  <a:txBody>
+                    <a:bodyPr wrap="square"/>
+                    <a:lstStyle/>
+                    <a:p>
+                      <a:r>
+                        <a:rPr sz="1000" b="0">
+                          <a:solidFill>
+                            <a:srgbClr val="282828"/>
+                          </a:solidFill>
+                          <a:latin typeface="Arial"/>
+                        </a:rPr>
+                        <a:t>33.9 / 26.8 µm</a:t>
+                      </a:r>
+                    </a:p>
+                  </a:txBody>
+                  <a:tcPr marL="54864" marR="54864" marT="18288" marB="18288">
+                    <a:solidFill>
+                      <a:srgbClr val="FFFFFF"/>
+                    </a:solidFill>
+                  </a:tcPr>
+                </a:tc>
+                <a:tc>
+                  <a:txBody>
+                    <a:bodyPr wrap="square"/>
+                    <a:lstStyle/>
+                    <a:p>
+                      <a:r>
+                        <a:rPr sz="1000" b="0">
+                          <a:solidFill>
+                            <a:srgbClr val="282828"/>
+                          </a:solidFill>
+                          <a:latin typeface="Arial"/>
+                        </a:rPr>
+                        <a:t>2.8 mm</a:t>
+                      </a:r>
+                    </a:p>
+                  </a:txBody>
+                  <a:tcPr marL="54864" marR="54864" marT="18288" marB="18288">
+                    <a:solidFill>
+                      <a:srgbClr val="FFFFFF"/>
+                    </a:solidFill>
+                  </a:tcPr>
+                </a:tc>
+              </a:tr>
+              <a:tr h="434340">
+                <a:tc>
+                  <a:txBody>
+                    <a:bodyPr wrap="square"/>
+                    <a:lstStyle/>
+                    <a:p>
+                      <a:r>
+                        <a:rPr sz="1000" b="0">
+                          <a:solidFill>
+                            <a:srgbClr val="282828"/>
+                          </a:solidFill>
+                          <a:latin typeface="Arial"/>
+                        </a:rPr>
+                        <a:t>same, solved on the true sphere</a:t>
+                      </a:r>
+                    </a:p>
+                  </a:txBody>
+                  <a:tcPr marL="54864" marR="54864" marT="18288" marB="18288">
+                    <a:solidFill>
+                      <a:srgbClr val="ECF1F6"/>
+                    </a:solidFill>
+                  </a:tcPr>
+                </a:tc>
+                <a:tc>
+                  <a:txBody>
+                    <a:bodyPr wrap="square"/>
+                    <a:lstStyle/>
+                    <a:p>
+                      <a:r>
+                        <a:rPr sz="1000" b="0">
+                          <a:solidFill>
+                            <a:srgbClr val="282828"/>
+                          </a:solidFill>
+                          <a:latin typeface="Arial"/>
+                        </a:rPr>
+                        <a:t>332 µm</a:t>
+                      </a:r>
+                    </a:p>
+                  </a:txBody>
+                  <a:tcPr marL="54864" marR="54864" marT="18288" marB="18288">
+                    <a:solidFill>
+                      <a:srgbClr val="ECF1F6"/>
+                    </a:solidFill>
+                  </a:tcPr>
+                </a:tc>
+                <a:tc>
+                  <a:txBody>
+                    <a:bodyPr wrap="square"/>
+                    <a:lstStyle/>
+                    <a:p>
+                      <a:r>
+                        <a:rPr sz="1000" b="0">
+                          <a:solidFill>
+                            <a:srgbClr val="282828"/>
+                          </a:solidFill>
+                          <a:latin typeface="Arial"/>
+                        </a:rPr>
+                        <a:t>— / 25.7 µm</a:t>
+                      </a:r>
+                    </a:p>
+                  </a:txBody>
+                  <a:tcPr marL="54864" marR="54864" marT="18288" marB="18288">
+                    <a:solidFill>
+                      <a:srgbClr val="ECF1F6"/>
+                    </a:solidFill>
+                  </a:tcPr>
+                </a:tc>
+                <a:tc>
+                  <a:txBody>
+                    <a:bodyPr wrap="square"/>
+                    <a:lstStyle/>
+                    <a:p>
+                      <a:r>
+                        <a:rPr sz="1000" b="0">
+                          <a:solidFill>
+                            <a:srgbClr val="282828"/>
+                          </a:solidFill>
+                          <a:latin typeface="Arial"/>
+                        </a:rPr>
+                        <a:t>—</a:t>
+                      </a:r>
+                    </a:p>
+                  </a:txBody>
+                  <a:tcPr marL="54864" marR="54864" marT="18288" marB="18288">
+                    <a:solidFill>
+                      <a:srgbClr val="ECF1F6"/>
+                    </a:solidFill>
+                  </a:tcPr>
+                </a:tc>
+              </a:tr>
+              <a:tr h="434340">
+                <a:tc>
+                  <a:txBody>
+                    <a:bodyPr wrap="square"/>
+                    <a:lstStyle/>
+                    <a:p>
+                      <a:r>
+                        <a:rPr sz="1000" b="0">
+                          <a:solidFill>
+                            <a:srgbClr val="282828"/>
+                          </a:solidFill>
+                          <a:latin typeface="Arial"/>
+                        </a:rPr>
+                        <a:t>conics + aspheres, m₂ = 3.0</a:t>
+                      </a:r>
+                    </a:p>
+                  </a:txBody>
+                  <a:tcPr marL="54864" marR="54864" marT="18288" marB="18288">
+                    <a:solidFill>
+                      <a:srgbClr val="FFFFFF"/>
+                    </a:solidFill>
+                  </a:tcPr>
+                </a:tc>
+                <a:tc>
+                  <a:txBody>
+                    <a:bodyPr wrap="square"/>
+                    <a:lstStyle/>
+                    <a:p>
+                      <a:r>
+                        <a:rPr sz="1000" b="0">
+                          <a:solidFill>
+                            <a:srgbClr val="282828"/>
+                          </a:solidFill>
+                          <a:latin typeface="Arial"/>
+                        </a:rPr>
+                        <a:t>291 µm</a:t>
+                      </a:r>
+                    </a:p>
+                  </a:txBody>
+                  <a:tcPr marL="54864" marR="54864" marT="18288" marB="18288">
+                    <a:solidFill>
+                      <a:srgbClr val="FFFFFF"/>
+                    </a:solidFill>
+                  </a:tcPr>
+                </a:tc>
+                <a:tc>
+                  <a:txBody>
+                    <a:bodyPr wrap="square"/>
+                    <a:lstStyle/>
+                    <a:p>
+                      <a:r>
+                        <a:rPr sz="1000" b="0">
+                          <a:solidFill>
+                            <a:srgbClr val="282828"/>
+                          </a:solidFill>
+                          <a:latin typeface="Arial"/>
+                        </a:rPr>
+                        <a:t>27.9 / 23.0 µm</a:t>
+                      </a:r>
+                    </a:p>
+                  </a:txBody>
+                  <a:tcPr marL="54864" marR="54864" marT="18288" marB="18288">
+                    <a:solidFill>
+                      <a:srgbClr val="FFFFFF"/>
+                    </a:solidFill>
+                  </a:tcPr>
+                </a:tc>
+                <a:tc>
+                  <a:txBody>
+                    <a:bodyPr wrap="square"/>
+                    <a:lstStyle/>
+                    <a:p>
+                      <a:r>
+                        <a:rPr sz="1000" b="0">
+                          <a:solidFill>
+                            <a:srgbClr val="282828"/>
+                          </a:solidFill>
+                          <a:latin typeface="Arial"/>
+                        </a:rPr>
+                        <a:t>2.2 mm</a:t>
+                      </a:r>
+                    </a:p>
+                  </a:txBody>
+                  <a:tcPr marL="54864" marR="54864" marT="18288" marB="18288">
+                    <a:solidFill>
+                      <a:srgbClr val="FFFFFF"/>
+                    </a:solidFill>
+                  </a:tcPr>
+                </a:tc>
+              </a:tr>
+              <a:tr h="434340">
+                <a:tc>
+                  <a:txBody>
+                    <a:bodyPr wrap="square"/>
+                    <a:lstStyle/>
+                    <a:p>
+                      <a:r>
+                        <a:rPr sz="1000" b="0">
+                          <a:solidFill>
+                            <a:srgbClr val="282828"/>
+                          </a:solidFill>
+                          <a:latin typeface="Arial"/>
+                        </a:rPr>
+                        <a:t>+ Zernike astigmatism, m₂ = 3.0</a:t>
+                      </a:r>
+                    </a:p>
+                  </a:txBody>
+                  <a:tcPr marL="54864" marR="54864" marT="18288" marB="18288">
+                    <a:solidFill>
+                      <a:srgbClr val="ECF1F6"/>
+                    </a:solidFill>
+                  </a:tcPr>
+                </a:tc>
+                <a:tc>
+                  <a:txBody>
+                    <a:bodyPr wrap="square"/>
+                    <a:lstStyle/>
+                    <a:p>
+                      <a:r>
+                        <a:rPr sz="1000" b="0">
+                          <a:solidFill>
+                            <a:srgbClr val="282828"/>
+                          </a:solidFill>
+                          <a:latin typeface="Arial"/>
+                        </a:rPr>
+                        <a:t>297 µm</a:t>
+                      </a:r>
+                    </a:p>
+                  </a:txBody>
+                  <a:tcPr marL="54864" marR="54864" marT="18288" marB="18288">
+                    <a:solidFill>
+                      <a:srgbClr val="ECF1F6"/>
+                    </a:solidFill>
+                  </a:tcPr>
+                </a:tc>
+                <a:tc>
+                  <a:txBody>
+                    <a:bodyPr wrap="square"/>
+                    <a:lstStyle/>
+                    <a:p>
+                      <a:r>
+                        <a:rPr sz="1000" b="0">
+                          <a:solidFill>
+                            <a:srgbClr val="282828"/>
+                          </a:solidFill>
+                          <a:latin typeface="Arial"/>
+                        </a:rPr>
+                        <a:t>27.8 / 23.5 µm</a:t>
+                      </a:r>
+                    </a:p>
+                  </a:txBody>
+                  <a:tcPr marL="54864" marR="54864" marT="18288" marB="18288">
+                    <a:solidFill>
+                      <a:srgbClr val="ECF1F6"/>
+                    </a:solidFill>
+                  </a:tcPr>
+                </a:tc>
+                <a:tc>
+                  <a:txBody>
+                    <a:bodyPr wrap="square"/>
+                    <a:lstStyle/>
+                    <a:p>
+                      <a:r>
+                        <a:rPr sz="1000" b="0">
+                          <a:solidFill>
+                            <a:srgbClr val="282828"/>
+                          </a:solidFill>
+                          <a:latin typeface="Arial"/>
+                        </a:rPr>
+                        <a:t>2.3 mm</a:t>
+                      </a:r>
+                    </a:p>
+                  </a:txBody>
+                  <a:tcPr marL="54864" marR="54864" marT="18288" marB="18288">
+                    <a:solidFill>
+                      <a:srgbClr val="ECF1F6"/>
+                    </a:solidFill>
+                  </a:tcPr>
+                </a:tc>
+              </a:tr>
+            </a:tbl>
+          </a:graphicData>
+        </a:graphic>
+      </p:graphicFrame>
+      <p:sp>
+        <p:nvSpPr>
+          <p:cNvPr id="6" name="TextBox 5"/>
+          <p:cNvSpPr txBox="1"/>
+          <p:nvPr/>
+        </p:nvSpPr>
+        <p:spPr>
+          <a:xfrm>
+            <a:off x="6400800" y="3616452"/>
+            <a:ext cx="5394960" cy="274320"/>
+          </a:xfrm>
+          <a:prstGeom prst="rect">
+            <a:avLst/>
+          </a:prstGeom>
+          <a:noFill/>
+        </p:spPr>
+        <p:txBody>
+          <a:bodyPr wrap="square">
+            <a:spAutoFit/>
+          </a:bodyPr>
+          <a:lstStyle/>
+          <a:p>
+            <a:pPr>
+              <a:spcAft>
+                <a:spcPts val="600"/>
+              </a:spcAft>
+            </a:pPr>
+            <a:r>
+              <a:rPr sz="1050" b="0">
+                <a:solidFill>
+                  <a:srgbClr val="6E6E6E"/>
+                </a:solidFill>
+                <a:latin typeface="Arial"/>
+              </a:rPr>
+              <a:t>1.5k section at 4° bias, 190 mm decenter, ±2.34° field; wavefront rms over the pupil at 633 nm; the two line foci from the x- and y-slices of the bundle along the chief.  Records dyson5_tA_EP_cp*.txt, dyson5_tA_pz_1k5.txt, dyson5_tA_FF_1k5.txt.</a:t>
+            </a:r>
+          </a:p>
+        </p:txBody>
+      </p:sp>
+    </p:spTree>
+  </p:cSld>
+  <p:clrMapOvr>
+    <a:masterClrMapping/>
+  </p:clrMapOvr>
+</p:sld>
+</file>
+
+<file path=ppt/slides/slide31.xml><?xml version="1.0" encoding="utf-8"?>
+<p:sld xmlns:a="http://schemas.openxmlformats.org/drawingml/2006/main" xmlns:p="http://schemas.openxmlformats.org/presentationml/2006/main" xmlns:r="http://schemas.openxmlformats.org/officeDocument/2006/relationships">
+  <p:cSld>
+    <p:spTree>
+      <p:nvGrpSpPr>
+        <p:cNvPr id="1" name=""/>
+        <p:cNvGrpSpPr/>
+        <p:nvPr/>
+      </p:nvGrpSpPr>
+      <p:grpSpPr/>
+      <p:sp>
+        <p:nvSpPr>
+          <p:cNvPr id="2" name="TextBox 1"/>
+          <p:cNvSpPr txBox="1"/>
+          <p:nvPr/>
+        </p:nvSpPr>
+        <p:spPr>
+          <a:xfrm>
+            <a:off x="411480" y="201168"/>
+            <a:ext cx="11368735" cy="914400"/>
+          </a:xfrm>
+          <a:prstGeom prst="rect">
+            <a:avLst/>
+          </a:prstGeom>
+          <a:noFill/>
+        </p:spPr>
+        <p:txBody>
+          <a:bodyPr wrap="square">
+            <a:spAutoFit/>
+          </a:bodyPr>
+          <a:lstStyle/>
+          <a:p>
+            <a:pPr>
+              <a:spcAft>
+                <a:spcPts val="400"/>
+              </a:spcAft>
+            </a:pPr>
+            <a:r>
+              <a:rPr sz="2400" b="1">
+                <a:solidFill>
+                  <a:srgbClr val="1F4E79"/>
+                </a:solidFill>
+                <a:latin typeface="Arial"/>
+              </a:rPr>
+              <a:t>Next steps</a:t>
+            </a:r>
+          </a:p>
+          <a:p>
+            <a:pPr>
+              <a:spcAft>
+                <a:spcPts val="0"/>
+              </a:spcAft>
+            </a:pPr>
+            <a:r>
+              <a:rPr sz="1250" b="0">
+                <a:solidFill>
+                  <a:srgbClr val="6E6E6E"/>
+                </a:solidFill>
+                <a:latin typeface="Arial"/>
+              </a:rPr>
+              <a:t>The native optimizer on the record, the cold window, and the telescope that feeds the slit</a:t>
+            </a:r>
+          </a:p>
+        </p:txBody>
+      </p:sp>
+      <p:sp>
+        <p:nvSpPr>
+          <p:cNvPr id="3" name="Rectangle 2"/>
+          <p:cNvSpPr/>
+          <p:nvPr/>
+        </p:nvSpPr>
+        <p:spPr>
+          <a:xfrm>
+            <a:off x="411480" y="1133856"/>
+            <a:ext cx="11368735" cy="20320"/>
+          </a:xfrm>
+          <a:prstGeom prst="rect">
+            <a:avLst/>
+          </a:prstGeom>
+          <a:solidFill>
+            <a:srgbClr val="B8C6D4"/>
+          </a:solidFill>
+          <a:ln>
+            <a:noFill/>
+          </a:ln>
+          <a:effectLst/>
+        </p:spPr>
+        <p:style>
+          <a:lnRef idx="1">
+            <a:schemeClr val="accent1"/>
+          </a:lnRef>
+          <a:fillRef idx="3">
+            <a:schemeClr val="accent1"/>
+          </a:fillRef>
+          <a:effectRef idx="2">
+            <a:schemeClr val="accent1"/>
+          </a:effectRef>
+          <a:fontRef idx="minor">
+            <a:schemeClr val="lt1"/>
+          </a:fontRef>
+        </p:style>
+        <p:txBody>
+          <a:bodyPr rtlCol="0" anchor="ctr"/>
+          <a:lstStyle/>
+          <a:p>
+            <a:pPr algn="ctr"/>
+          </a:p>
+        </p:txBody>
+      </p:sp>
+      <p:sp>
+        <p:nvSpPr>
+          <p:cNvPr id="4" name="TextBox 3"/>
+          <p:cNvSpPr txBox="1"/>
+          <p:nvPr/>
+        </p:nvSpPr>
+        <p:spPr>
+          <a:xfrm>
+            <a:off x="411480" y="1298448"/>
+            <a:ext cx="5806440" cy="274320"/>
+          </a:xfrm>
+          <a:prstGeom prst="rect">
+            <a:avLst/>
+          </a:prstGeom>
+          <a:noFill/>
+        </p:spPr>
+        <p:txBody>
+          <a:bodyPr wrap="square">
+            <a:spAutoFit/>
+          </a:bodyPr>
+          <a:lstStyle/>
+          <a:p>
+            <a:pPr>
+              <a:spcAft>
+                <a:spcPts val="600"/>
+              </a:spcAft>
+            </a:pPr>
+            <a:r>
+              <a:rPr sz="1200" b="0">
+                <a:solidFill>
+                  <a:srgbClr val="282828"/>
+                </a:solidFill>
+                <a:latin typeface="Arial"/>
+              </a:rPr>
+              <a:t>•  The native multi-wavelength optimizer (MACOS CALIB) confirms the compact variant: the engine's spot-size solve over 5 slit positions × 6 wavelengths, the double-pass copies of each surface linked as one, smile and keystone held as walls between iteration chunks, the engine's design read back under an identity check (2e-16 m).  With the blur freedoms (block face radius and conic, meniscus faces, focus) every step is rejected: R4 is a local optimum of the engine's merit as well as the chain's.  With the grating's position free the engine bought blur with 15 px of keystone in five iterations and the wall rejected it: the reason the design needs distortion operands, queued as an engine feature.  From a deliberate 0.3 mm defocus the same solve cuts the spot from 97 to 21 µm, so it moves when there is something to gain.  The block's asphere joins the freedoms now that its differential step is fixed (Backup).</a:t>
+            </a:r>
+          </a:p>
+          <a:p>
+            <a:pPr>
+              <a:spcAft>
+                <a:spcPts val="600"/>
+              </a:spcAft>
+            </a:pPr>
+            <a:r>
+              <a:rPr sz="1200" b="0">
+                <a:solidFill>
+                  <a:srgbClr val="282828"/>
+                </a:solidFill>
+                <a:latin typeface="Arial"/>
+              </a:rPr>
+              <a:t>•  The cold window: the R5 variant with the shield as the detector housing behind a window cemented as the prism's exit face, under the same clearance gate.</a:t>
+            </a:r>
+          </a:p>
+          <a:p>
+            <a:pPr>
+              <a:spcAft>
+                <a:spcPts val="600"/>
+              </a:spcAft>
+            </a:pPr>
+            <a:r>
+              <a:rPr sz="1200" b="0">
+                <a:solidFill>
+                  <a:srgbClr val="282828"/>
+                </a:solidFill>
+                <a:latin typeface="Arial"/>
+              </a:rPr>
+              <a:t>•  One module or two (a project decision): one 54 mm module needs the 220 mm, 8 kg block and its thin meniscus; two 27 mm modules need a plain 130 mm block of 1.6 kg each, with the swath split ahead of the slits.  The choice also sets the telescope's field: 24.6° for one, or 12.3° each for two.</a:t>
+            </a:r>
+          </a:p>
+          <a:p>
+            <a:pPr>
+              <a:spcAft>
+                <a:spcPts val="600"/>
+              </a:spcAft>
+            </a:pPr>
+            <a:r>
+              <a:rPr sz="1200" b="0">
+                <a:solidFill>
+                  <a:srgbClr val="282828"/>
+                </a:solidFill>
+                <a:latin typeface="Arial"/>
+              </a:rPr>
+              <a:t>•  The radiometric chain against the band: throughput, grating efficiency, detector quantum efficiency and the slit loss above.</a:t>
+            </a:r>
+          </a:p>
+        </p:txBody>
+      </p:sp>
+      <p:sp>
+        <p:nvSpPr>
+          <p:cNvPr id="5" name="TextBox 4"/>
+          <p:cNvSpPr txBox="1"/>
+          <p:nvPr/>
+        </p:nvSpPr>
+        <p:spPr>
+          <a:xfrm>
+            <a:off x="6400800" y="1298448"/>
+            <a:ext cx="5394960" cy="274320"/>
+          </a:xfrm>
+          <a:prstGeom prst="rect">
+            <a:avLst/>
+          </a:prstGeom>
+          <a:noFill/>
+        </p:spPr>
+        <p:txBody>
+          <a:bodyPr wrap="square">
+            <a:spAutoFit/>
+          </a:bodyPr>
+          <a:lstStyle/>
+          <a:p>
+            <a:pPr>
+              <a:spcAft>
+                <a:spcPts val="600"/>
+              </a:spcAft>
+            </a:pPr>
+            <a:r>
+              <a:rPr sz="1200" b="0">
+                <a:solidFill>
+                  <a:srgbClr val="282828"/>
+                </a:solidFill>
+                <a:latin typeface="Arial"/>
+              </a:rPr>
+              <a:t>•  The telescope's image: the unobscured section of the telecentric three-mirror parent packages and holds the 1.5k strip's inner half at 2–10 px with its plate scale and every clearance; the strip edges (19 px at ±2.3°, 68 px at ±4.7° for 3k) are cross-track astigmatism that no symmetric surface term reaches.  Running now: the freeform steps on the m₂ = 3.0 parent — coma and trefoil, then the symmetric terms, warm-started step to step on the true reference sphere; then the same for the 3k module; then the end-to-end row with each module's Dyson.  Queued in the engine: the fixed-station reference sphere for the optimizer on near-telecentric designs, and the asphere + Zernike surface as one emitted option.</a:t>
+            </a:r>
+          </a:p>
+          <a:p>
+            <a:pPr>
+              <a:spcAft>
+                <a:spcPts val="600"/>
+              </a:spcAft>
+            </a:pPr>
+            <a:r>
+              <a:rPr sz="1200" b="0">
+                <a:solidFill>
+                  <a:srgbClr val="282828"/>
+                </a:solidFill>
+                <a:latin typeface="Arial"/>
+              </a:rPr>
+              <a:t>•  Future work, once the design of record is stable: a surface-by-surface tour of the prescription (role, ray footprint, clearance, and the field where a propagation leg ends, per surface); spot diagrams in the Mouroulis &amp; Green form, slit positions down and wavelengths across inside the 18 µm pixel box; the telescope and the end-to-end instrument; polarization sensitivity of the Dyson against the Offner, since the Dyson's near-normal incidence is what the literature credits for its low sensitivity; and, once the telescope exists, full diffraction from the slit through the grating to the detector, to put a number on the slit's truncation of the telescope's image (the literature expects about a 10 % effect on the response functions).</a:t>
+            </a:r>
+          </a:p>
+        </p:txBody>
+      </p:sp>
+    </p:spTree>
+  </p:cSld>
+  <p:clrMapOvr>
+    <a:masterClrMapping/>
+  </p:clrMapOvr>
+</p:sld>
+</file>
+
+<file path=ppt/slides/slide32.xml><?xml version="1.0" encoding="utf-8"?>
 <p:sld xmlns:a="http://schemas.openxmlformats.org/drawingml/2006/main" xmlns:p="http://schemas.openxmlformats.org/presentationml/2006/main" xmlns:r="http://schemas.openxmlformats.org/officeDocument/2006/relationships">
   <p:cSld>
     <p:spTree>
@@ -17067,7 +18065,7 @@
 </p:sld>
 </file>
 
-<file path=ppt/slides/slide31.xml><?xml version="1.0" encoding="utf-8"?>
+<file path=ppt/slides/slide33.xml><?xml version="1.0" encoding="utf-8"?>
 <p:sld xmlns:a="http://schemas.openxmlformats.org/drawingml/2006/main" xmlns:p="http://schemas.openxmlformats.org/presentationml/2006/main" xmlns:r="http://schemas.openxmlformats.org/officeDocument/2006/relationships">
   <p:cSld>
     <p:spTree>
@@ -17207,7 +18205,7 @@
 </p:sld>
 </file>
 
-<file path=ppt/slides/slide32.xml><?xml version="1.0" encoding="utf-8"?>
+<file path=ppt/slides/slide34.xml><?xml version="1.0" encoding="utf-8"?>
 <p:sld xmlns:a="http://schemas.openxmlformats.org/drawingml/2006/main" xmlns:p="http://schemas.openxmlformats.org/presentationml/2006/main" xmlns:r="http://schemas.openxmlformats.org/officeDocument/2006/relationships">
   <p:cSld>
     <p:spTree>
@@ -18188,7 +19186,7 @@
                 </a:solidFill>
                 <a:latin typeface="Arial"/>
               </a:rPr>
-              <a:t>Flat gratings are unchanged by the grating fixes; the wavefront-target optimizer, which every telescope design used, was never affected by the fifth.  A seventh item, a short AsphCoef= line killing the host process, now pads with zero and warns (tRxShortAsph).</a:t>
+              <a:t>Flat gratings are unchanged by the grating fixes; the wavefront-target optimizer, which every telescope design used, was never affected by the fifth.  A seventh item, a short AsphCoef= line killing the host process, now pads with zero and warns (tRxShortAsph); the same guard for ZernCoef= is queued.</a:t>
             </a:r>
           </a:p>
         </p:txBody>
@@ -18201,7 +19199,7 @@
 </p:sld>
 </file>
 
-<file path=ppt/slides/slide33.xml><?xml version="1.0" encoding="utf-8"?>
+<file path=ppt/slides/slide35.xml><?xml version="1.0" encoding="utf-8"?>
 <p:sld xmlns:a="http://schemas.openxmlformats.org/drawingml/2006/main" xmlns:p="http://schemas.openxmlformats.org/presentationml/2006/main" xmlns:r="http://schemas.openxmlformats.org/officeDocument/2006/relationships">
   <p:cSld>
     <p:spTree>
@@ -18245,7 +19243,7 @@
                 </a:solidFill>
                 <a:latin typeface="Arial"/>
               </a:rPr>
-              <a:t>Backup: records and tools behind each slide</a:t>
+              <a:t>Backup: four more findings from the telescope's eccentric section</a:t>
             </a:r>
           </a:p>
           <a:p>
@@ -18261,7 +19259,7 @@
                 </a:solidFill>
                 <a:latin typeface="Arial"/>
               </a:rPr>
-              <a:t>Every number traces to a runner stage and its record file</a:t>
+              <a:t>Found 2026-10-04 to 10-05, each invisible on a coaxial design, each fixed the same day</a:t>
             </a:r>
           </a:p>
         </p:txBody>
@@ -18320,7 +19318,7 @@
         </p:nvGraphicFramePr>
         <p:xfrm>
           <a:off x="411480" y="1298448"/>
-          <a:ext cx="11368734" cy="7115175"/>
+          <a:ext cx="11368733" cy="3663315"/>
         </p:xfrm>
         <a:graphic>
           <a:graphicData uri="http://schemas.openxmlformats.org/drawingml/2006/table">
@@ -18329,10 +19327,10 @@
                 <a:tableStyleId>{5C22544A-7EE6-4342-B048-85BDC9FD1C3A}</a:tableStyleId>
               </a:tblPr>
               <a:tblGrid>
-                <a:gridCol w="1979545"/>
-                <a:gridCol w="1889760"/>
-                <a:gridCol w="3997158"/>
-                <a:gridCol w="3502271"/>
+                <a:gridCol w="727756"/>
+                <a:gridCol w="4681243"/>
+                <a:gridCol w="4405876"/>
+                <a:gridCol w="1553858"/>
               </a:tblGrid>
               <a:tr h="280035">
                 <a:tc>
@@ -18347,7 +19345,7 @@
                           </a:solidFill>
                           <a:latin typeface="Arial"/>
                         </a:rPr>
-                        <a:t>slide</a:t>
+                        <a:t>finding</a:t>
                       </a:r>
                     </a:p>
                   </a:txBody>
@@ -18369,7 +19367,7 @@
                           </a:solidFill>
                           <a:latin typeface="Arial"/>
                         </a:rPr>
-                        <a:t>runner stage</a:t>
+                        <a:t>symptom</a:t>
                       </a:r>
                     </a:p>
                   </a:txBody>
@@ -18391,7 +19389,7 @@
                           </a:solidFill>
                           <a:latin typeface="Arial"/>
                         </a:rPr>
-                        <a:t>record</a:t>
+                        <a:t>fix</a:t>
                       </a:r>
                     </a:p>
                   </a:txBody>
@@ -18413,7 +19411,7 @@
                           </a:solidFill>
                           <a:latin typeface="Arial"/>
                         </a:rPr>
-                        <a:t>tool</a:t>
+                        <a:t>test</a:t>
                       </a:r>
                     </a:p>
                   </a:txBody>
@@ -18424,86 +19422,86 @@
                   </a:tcPr>
                 </a:tc>
               </a:tr>
-              <a:tr h="280035">
-                <a:tc>
-                  <a:txBody>
-                    <a:bodyPr wrap="square"/>
-                    <a:lstStyle/>
-                    <a:p>
-                      <a:r>
-                        <a:rPr sz="1100" b="0">
-                          <a:solidFill>
-                            <a:srgbClr val="282828"/>
-                          </a:solidFill>
-                          <a:latin typeface="Arial"/>
-                        </a:rPr>
-                        <a:t>scaling law</a:t>
-                      </a:r>
-                    </a:p>
-                  </a:txBody>
-                  <a:tcPr marL="54864" marR="54864" marT="18288" marB="18288">
-                    <a:solidFill>
-                      <a:srgbClr val="FFFFFF"/>
-                    </a:solidFill>
-                  </a:tcPr>
-                </a:tc>
-                <a:tc>
-                  <a:txBody>
-                    <a:bodyPr wrap="square"/>
-                    <a:lstStyle/>
-                    <a:p>
-                      <a:r>
-                        <a:rPr sz="1100" b="0">
-                          <a:solidFill>
-                            <a:srgbClr val="282828"/>
-                          </a:solidFill>
-                          <a:latin typeface="Arial"/>
-                        </a:rPr>
-                        <a:t>s0 (engine-free)</a:t>
-                      </a:r>
-                    </a:p>
-                  </a:txBody>
-                  <a:tcPr marL="54864" marR="54864" marT="18288" marB="18288">
-                    <a:solidFill>
-                      <a:srgbClr val="FFFFFF"/>
-                    </a:solidFill>
-                  </a:tcPr>
-                </a:tc>
-                <a:tc>
-                  <a:txBody>
-                    <a:bodyPr wrap="square"/>
-                    <a:lstStyle/>
-                    <a:p>
-                      <a:r>
-                        <a:rPr sz="1100" b="0">
-                          <a:solidFill>
-                            <a:srgbClr val="282828"/>
-                          </a:solidFill>
-                          <a:latin typeface="Arial"/>
-                        </a:rPr>
-                        <a:t>dyson5_s0_scaling.txt</a:t>
-                      </a:r>
-                    </a:p>
-                  </a:txBody>
-                  <a:tcPr marL="54864" marR="54864" marT="18288" marB="18288">
-                    <a:solidFill>
-                      <a:srgbClr val="FFFFFF"/>
-                    </a:solidFill>
-                  </a:tcPr>
-                </a:tc>
-                <a:tc>
-                  <a:txBody>
-                    <a:bodyPr wrap="square"/>
-                    <a:lstStyle/>
-                    <a:p>
-                      <a:r>
-                        <a:rPr sz="1100" b="0">
-                          <a:solidFill>
-                            <a:srgbClr val="282828"/>
-                          </a:solidFill>
-                          <a:latin typeface="Arial"/>
-                        </a:rPr>
-                        <a:t>design/src/dyson_layout.m, dyson_scaling.m</a:t>
+              <a:tr h="845820">
+                <a:tc>
+                  <a:txBody>
+                    <a:bodyPr wrap="square"/>
+                    <a:lstStyle/>
+                    <a:p>
+                      <a:r>
+                        <a:rPr sz="1100" b="0">
+                          <a:solidFill>
+                            <a:srgbClr val="282828"/>
+                          </a:solidFill>
+                          <a:latin typeface="Arial"/>
+                        </a:rPr>
+                        <a:t>ray on the far sheet of a hyperboloid</a:t>
+                      </a:r>
+                    </a:p>
+                  </a:txBody>
+                  <a:tcPr marL="54864" marR="54864" marT="18288" marB="18288">
+                    <a:solidFill>
+                      <a:srgbClr val="FFFFFF"/>
+                    </a:solidFill>
+                  </a:tcPr>
+                </a:tc>
+                <a:tc>
+                  <a:txBody>
+                    <a:bodyPr wrap="square"/>
+                    <a:lstStyle/>
+                    <a:p>
+                      <a:r>
+                        <a:rPr sz="1100" b="0">
+                          <a:solidFill>
+                            <a:srgbClr val="282828"/>
+                          </a:solidFill>
+                          <a:latin typeface="Arial"/>
+                        </a:rPr>
+                        <a:t>40 of 1185 rays on the section's M3 (sheets 22 mm apart) took the second sheet: 44 mm of extra path, a 10 mm spot tail, every ray reported as passing — 7.8 mm rms wavefront at the focal plane while an outlier-cut spot read 400 µm</a:t>
+                      </a:r>
+                    </a:p>
+                  </a:txBody>
+                  <a:tcPr marL="54864" marR="54864" marT="18288" marB="18288">
+                    <a:solidFill>
+                      <a:srgbClr val="FFFFFF"/>
+                    </a:solidFill>
+                  </a:tcPr>
+                </a:tc>
+                <a:tc>
+                  <a:txBody>
+                    <a:bodyPr wrap="square"/>
+                    <a:lstStyle/>
+                    <a:p>
+                      <a:r>
+                        <a:rPr sz="1100" b="0">
+                          <a:solidFill>
+                            <a:srgbClr val="282828"/>
+                          </a:solidFill>
+                          <a:latin typeface="Arial"/>
+                        </a:rPr>
+                        <a:t>the intersection is the root on the sheet the vertex is on (the normal's axial component keeps the sign it has at the vertex); first crossing on a tie; the first crossing alone is wrong, since M2's far sheet sits in the beam</a:t>
+                      </a:r>
+                    </a:p>
+                  </a:txBody>
+                  <a:tcPr marL="54864" marR="54864" marT="18288" marB="18288">
+                    <a:solidFill>
+                      <a:srgbClr val="FFFFFF"/>
+                    </a:solidFill>
+                  </a:tcPr>
+                </a:tc>
+                <a:tc>
+                  <a:txBody>
+                    <a:bodyPr wrap="square"/>
+                    <a:lstStyle/>
+                    <a:p>
+                      <a:r>
+                        <a:rPr sz="1100" b="0">
+                          <a:solidFill>
+                            <a:srgbClr val="282828"/>
+                          </a:solidFill>
+                          <a:latin typeface="Arial"/>
+                        </a:rPr>
+                        <a:t>tFwdRoot (5); 406 decks pre/post identical</a:t>
                       </a:r>
                     </a:p>
                   </a:txBody>
@@ -18514,20 +19512,20 @@
                   </a:tcPr>
                 </a:tc>
               </a:tr>
-              <a:tr h="280035">
-                <a:tc>
-                  <a:txBody>
-                    <a:bodyPr wrap="square"/>
-                    <a:lstStyle/>
-                    <a:p>
-                      <a:r>
-                        <a:rPr sz="1100" b="0">
-                          <a:solidFill>
-                            <a:srgbClr val="282828"/>
-                          </a:solidFill>
-                          <a:latin typeface="Arial"/>
-                        </a:rPr>
-                        <a:t>as traced (every form)</a:t>
+              <a:tr h="845820">
+                <a:tc>
+                  <a:txBody>
+                    <a:bodyPr wrap="square"/>
+                    <a:lstStyle/>
+                    <a:p>
+                      <a:r>
+                        <a:rPr sz="1100" b="0">
+                          <a:solidFill>
+                            <a:srgbClr val="282828"/>
+                          </a:solidFill>
+                          <a:latin typeface="Arial"/>
+                        </a:rPr>
+                        <a:t>optimizer aperture sized at one field</a:t>
                       </a:r>
                     </a:p>
                   </a:txBody>
@@ -18549,7 +19547,7 @@
                           </a:solidFill>
                           <a:latin typeface="Arial"/>
                         </a:rPr>
-                        <a:t>dyson5_view_figs.m</a:t>
+                        <a:t>the circle declared for the asphere solve enclosed the nominal field's footprint only; the strip-edge fields lost every ray on M3 and were dropped by the solve (the 9.9999e36 sentinel), which then drove M3's conic blind to them</a:t>
                       </a:r>
                     </a:p>
                   </a:txBody>
@@ -18571,7 +19569,7 @@
                           </a:solidFill>
                           <a:latin typeface="Arial"/>
                         </a:rPr>
-                        <a:t>_view3d.png, _viewyz.png</a:t>
+                        <a:t>the circle encloses the footprint over every field of the solve</a:t>
                       </a:r>
                     </a:p>
                   </a:txBody>
@@ -18593,7 +19591,7 @@
                           </a:solidFill>
                           <a:latin typeface="Arial"/>
                         </a:rPr>
-                        <a:t>macos.view_rx on the deck</a:t>
+                        <a:t>tAsphHook (3): its first pin was the wavefront of the surviving rays; re-pinned</a:t>
                       </a:r>
                     </a:p>
                   </a:txBody>
@@ -18604,86 +19602,86 @@
                   </a:tcPr>
                 </a:tc>
               </a:tr>
-              <a:tr h="468630">
-                <a:tc>
-                  <a:txBody>
-                    <a:bodyPr wrap="square"/>
-                    <a:lstStyle/>
-                    <a:p>
-                      <a:r>
-                        <a:rPr sz="1100" b="0">
-                          <a:solidFill>
-                            <a:srgbClr val="282828"/>
-                          </a:solidFill>
-                          <a:latin typeface="Arial"/>
-                        </a:rPr>
-                        <a:t>seed scored</a:t>
-                      </a:r>
-                    </a:p>
-                  </a:txBody>
-                  <a:tcPr marL="54864" marR="54864" marT="18288" marB="18288">
-                    <a:solidFill>
-                      <a:srgbClr val="FFFFFF"/>
-                    </a:solidFill>
-                  </a:tcPr>
-                </a:tc>
-                <a:tc>
-                  <a:txBody>
-                    <a:bodyPr wrap="square"/>
-                    <a:lstStyle/>
-                    <a:p>
-                      <a:r>
-                        <a:rPr sz="1100" b="0">
-                          <a:solidFill>
-                            <a:srgbClr val="282828"/>
-                          </a:solidFill>
-                          <a:latin typeface="Arial"/>
-                        </a:rPr>
-                        <a:t>s1 emit, s2 score</a:t>
-                      </a:r>
-                    </a:p>
-                  </a:txBody>
-                  <a:tcPr marL="54864" marR="54864" marT="18288" marB="18288">
-                    <a:solidFill>
-                      <a:srgbClr val="FFFFFF"/>
-                    </a:solidFill>
-                  </a:tcPr>
-                </a:tc>
-                <a:tc>
-                  <a:txBody>
-                    <a:bodyPr wrap="square"/>
-                    <a:lstStyle/>
-                    <a:p>
-                      <a:r>
-                        <a:rPr sz="1100" b="0">
-                          <a:solidFill>
-                            <a:srgbClr val="282828"/>
-                          </a:solidFill>
-                          <a:latin typeface="Arial"/>
-                        </a:rPr>
-                        <a:t>dyson5_s1.txt, dyson5_s2.txt, dyson5_s2_maps.png</a:t>
-                      </a:r>
-                    </a:p>
-                  </a:txBody>
-                  <a:tcPr marL="54864" marR="54864" marT="18288" marB="18288">
-                    <a:solidFill>
-                      <a:srgbClr val="FFFFFF"/>
-                    </a:solidFill>
-                  </a:tcPr>
-                </a:tc>
-                <a:tc>
-                  <a:txBody>
-                    <a:bodyPr wrap="square"/>
-                    <a:lstStyle/>
-                    <a:p>
-                      <a:r>
-                        <a:rPr sz="1100" b="0">
-                          <a:solidFill>
-                            <a:srgbClr val="282828"/>
-                          </a:solidFill>
-                          <a:latin typeface="Arial"/>
-                        </a:rPr>
-                        <a:t>spectrometer_geom.m, spectrometer_rx.m, spectrometer_score.m</a:t>
+              <a:tr h="845820">
+                <a:tc>
+                  <a:txBody>
+                    <a:bodyPr wrap="square"/>
+                    <a:lstStyle/>
+                    <a:p>
+                      <a:r>
+                        <a:rPr sz="1100" b="0">
+                          <a:solidFill>
+                            <a:srgbClr val="282828"/>
+                          </a:solidFill>
+                          <a:latin typeface="Arial"/>
+                        </a:rPr>
+                        <a:t>stop aimed at the parent vertex</a:t>
+                      </a:r>
+                    </a:p>
+                  </a:txBody>
+                  <a:tcPr marL="54864" marR="54864" marT="18288" marB="18288">
+                    <a:solidFill>
+                      <a:srgbClr val="FFFFFF"/>
+                    </a:solidFill>
+                  </a:tcPr>
+                </a:tc>
+                <a:tc>
+                  <a:txBody>
+                    <a:bodyPr wrap="square"/>
+                    <a:lstStyle/>
+                    <a:p>
+                      <a:r>
+                        <a:rPr sz="1100" b="0">
+                          <a:solidFill>
+                            <a:srgbClr val="282828"/>
+                          </a:solidFill>
+                          <a:latin typeface="Arial"/>
+                        </a:rPr>
+                        <a:t>the exit-pupil finder and the optimizer set the stop on M1 with no offset; on an eccentric section that is the parent vertex, 190 mm from the beam, and the pupil sphere was placed for the wrong beam</a:t>
+                      </a:r>
+                    </a:p>
+                  </a:txBody>
+                  <a:tcPr marL="54864" marR="54864" marT="18288" marB="18288">
+                    <a:solidFill>
+                      <a:srgbClr val="FFFFFF"/>
+                    </a:solidFill>
+                  </a:tcPr>
+                </a:tc>
+                <a:tc>
+                  <a:txBody>
+                    <a:bodyPr wrap="square"/>
+                    <a:lstStyle/>
+                    <a:p>
+                      <a:r>
+                        <a:rPr sz="1100" b="0">
+                          <a:solidFill>
+                            <a:srgbClr val="282828"/>
+                          </a:solidFill>
+                          <a:latin typeface="Arial"/>
+                        </a:rPr>
+                        <a:t>the stop at the deck's object-space stop point</a:t>
+                      </a:r>
+                    </a:p>
+                  </a:txBody>
+                  <a:tcPr marL="54864" marR="54864" marT="18288" marB="18288">
+                    <a:solidFill>
+                      <a:srgbClr val="FFFFFF"/>
+                    </a:solidFill>
+                  </a:tcPr>
+                </a:tc>
+                <a:tc>
+                  <a:txBody>
+                    <a:bodyPr wrap="square"/>
+                    <a:lstStyle/>
+                    <a:p>
+                      <a:r>
+                        <a:rPr sz="1100" b="0">
+                          <a:solidFill>
+                            <a:srgbClr val="282828"/>
+                          </a:solidFill>
+                          <a:latin typeface="Arial"/>
+                        </a:rPr>
+                        <a:t>tStopApStop (4)</a:t>
                       </a:r>
                     </a:p>
                   </a:txBody>
@@ -18694,20 +19692,20 @@
                   </a:tcPr>
                 </a:tc>
               </a:tr>
-              <a:tr h="280035">
-                <a:tc>
-                  <a:txBody>
-                    <a:bodyPr wrap="square"/>
-                    <a:lstStyle/>
-                    <a:p>
-                      <a:r>
-                        <a:rPr sz="1100" b="0">
-                          <a:solidFill>
-                            <a:srgbClr val="282828"/>
-                          </a:solidFill>
-                          <a:latin typeface="Arial"/>
-                        </a:rPr>
-                        <a:t>chain vs engine</a:t>
+              <a:tr h="845820">
+                <a:tc>
+                  <a:txBody>
+                    <a:bodyPr wrap="square"/>
+                    <a:lstStyle/>
+                    <a:p>
+                      <a:r>
+                        <a:rPr sz="1100" b="0">
+                          <a:solidFill>
+                            <a:srgbClr val="282828"/>
+                          </a:solidFill>
+                          <a:latin typeface="Arial"/>
+                        </a:rPr>
+                        <a:t>Zernike origin at the parent vertex</a:t>
                       </a:r>
                     </a:p>
                   </a:txBody>
@@ -18729,7 +19727,7 @@
                           </a:solidFill>
                           <a:latin typeface="Arial"/>
                         </a:rPr>
-                        <a:t>gate</a:t>
+                        <a:t>the emitter placed each mirror's Zernike origin at its vertex while the axes were the section pole's, so freeform terms on a section were evaluated 3.8 radii outside the unit disc (1 µm of defocus moved the chief 0.19 mm instead of 0.005)</a:t>
                       </a:r>
                     </a:p>
                   </a:txBody>
@@ -18751,7 +19749,7 @@
                           </a:solidFill>
                           <a:latin typeface="Arial"/>
                         </a:rPr>
-                        <a:t>tests/tSpectrometerRx.m</a:t>
+                        <a:t>the origin is the element's pole</a:t>
                       </a:r>
                     </a:p>
                   </a:txBody>
@@ -18773,1183 +19771,13 @@
                           </a:solidFill>
                           <a:latin typeface="Arial"/>
                         </a:rPr>
-                        <a:t>per-ray re-trace, 1e-9 m</a:t>
+                        <a:t>tFreeformPole (3)</a:t>
                       </a:r>
                     </a:p>
                   </a:txBody>
                   <a:tcPr marL="54864" marR="54864" marT="18288" marB="18288">
                     <a:solidFill>
                       <a:srgbClr val="ECF1F6"/>
-                    </a:solidFill>
-                  </a:tcPr>
-                </a:tc>
-              </a:tr>
-              <a:tr h="280035">
-                <a:tc>
-                  <a:txBody>
-                    <a:bodyPr wrap="square"/>
-                    <a:lstStyle/>
-                    <a:p>
-                      <a:r>
-                        <a:rPr sz="1100" b="0">
-                          <a:solidFill>
-                            <a:srgbClr val="282828"/>
-                          </a:solidFill>
-                          <a:latin typeface="Arial"/>
-                        </a:rPr>
-                        <a:t>propagation twin</a:t>
-                      </a:r>
-                    </a:p>
-                  </a:txBody>
-                  <a:tcPr marL="54864" marR="54864" marT="18288" marB="18288">
-                    <a:solidFill>
-                      <a:srgbClr val="FFFFFF"/>
-                    </a:solidFill>
-                  </a:tcPr>
-                </a:tc>
-                <a:tc>
-                  <a:txBody>
-                    <a:bodyPr wrap="square"/>
-                    <a:lstStyle/>
-                    <a:p>
-                      <a:r>
-                        <a:rPr sz="1100" b="0">
-                          <a:solidFill>
-                            <a:srgbClr val="282828"/>
-                          </a:solidFill>
-                          <a:latin typeface="Arial"/>
-                        </a:rPr>
-                        <a:t>s2w (opt-in, model 512)</a:t>
-                      </a:r>
-                    </a:p>
-                  </a:txBody>
-                  <a:tcPr marL="54864" marR="54864" marT="18288" marB="18288">
-                    <a:solidFill>
-                      <a:srgbClr val="FFFFFF"/>
-                    </a:solidFill>
-                  </a:tcPr>
-                </a:tc>
-                <a:tc>
-                  <a:txBody>
-                    <a:bodyPr wrap="square"/>
-                    <a:lstStyle/>
-                    <a:p>
-                      <a:r>
-                        <a:rPr sz="1100" b="0">
-                          <a:solidFill>
-                            <a:srgbClr val="282828"/>
-                          </a:solidFill>
-                          <a:latin typeface="Arial"/>
-                        </a:rPr>
-                        <a:t>dyson5_s2w.txt</a:t>
-                      </a:r>
-                    </a:p>
-                  </a:txBody>
-                  <a:tcPr marL="54864" marR="54864" marT="18288" marB="18288">
-                    <a:solidFill>
-                      <a:srgbClr val="FFFFFF"/>
-                    </a:solidFill>
-                  </a:tcPr>
-                </a:tc>
-                <a:tc>
-                  <a:txBody>
-                    <a:bodyPr wrap="square"/>
-                    <a:lstStyle/>
-                    <a:p>
-                      <a:r>
-                        <a:rPr sz="1100" b="0">
-                          <a:solidFill>
-                            <a:srgbClr val="282828"/>
-                          </a:solidFill>
-                          <a:latin typeface="Arial"/>
-                        </a:rPr>
-                        <a:t>spectrometer_wave.m</a:t>
-                      </a:r>
-                    </a:p>
-                  </a:txBody>
-                  <a:tcPr marL="54864" marR="54864" marT="18288" marB="18288">
-                    <a:solidFill>
-                      <a:srgbClr val="FFFFFF"/>
-                    </a:solidFill>
-                  </a:tcPr>
-                </a:tc>
-              </a:tr>
-              <a:tr h="468630">
-                <a:tc>
-                  <a:txBody>
-                    <a:bodyPr wrap="square"/>
-                    <a:lstStyle/>
-                    <a:p>
-                      <a:r>
-                        <a:rPr sz="1100" b="0">
-                          <a:solidFill>
-                            <a:srgbClr val="282828"/>
-                          </a:solidFill>
-                          <a:latin typeface="Arial"/>
-                        </a:rPr>
-                        <a:t>departure ladder, R4, trade</a:t>
-                      </a:r>
-                    </a:p>
-                  </a:txBody>
-                  <a:tcPr marL="54864" marR="54864" marT="18288" marB="18288">
-                    <a:solidFill>
-                      <a:srgbClr val="ECF1F6"/>
-                    </a:solidFill>
-                  </a:tcPr>
-                </a:tc>
-                <a:tc>
-                  <a:txBody>
-                    <a:bodyPr wrap="square"/>
-                    <a:lstStyle/>
-                    <a:p>
-                      <a:r>
-                        <a:rPr sz="1100" b="0">
-                          <a:solidFill>
-                            <a:srgbClr val="282828"/>
-                          </a:solidFill>
-                          <a:latin typeface="Arial"/>
-                        </a:rPr>
-                        <a:t>s3, s3free, s3b</a:t>
-                      </a:r>
-                    </a:p>
-                  </a:txBody>
-                  <a:tcPr marL="54864" marR="54864" marT="18288" marB="18288">
-                    <a:solidFill>
-                      <a:srgbClr val="ECF1F6"/>
-                    </a:solidFill>
-                  </a:tcPr>
-                </a:tc>
-                <a:tc>
-                  <a:txBody>
-                    <a:bodyPr wrap="square"/>
-                    <a:lstStyle/>
-                    <a:p>
-                      <a:r>
-                        <a:rPr sz="1100" b="0">
-                          <a:solidFill>
-                            <a:srgbClr val="282828"/>
-                          </a:solidFill>
-                          <a:latin typeface="Arial"/>
-                        </a:rPr>
-                        <a:t>dyson5_s3.txt, dyson5_s3free.txt, dyson5_s3_trade.txt, dyson5_s3_layout_r.png, dyson5_s3_maps_r.png</a:t>
-                      </a:r>
-                    </a:p>
-                  </a:txBody>
-                  <a:tcPr marL="54864" marR="54864" marT="18288" marB="18288">
-                    <a:solidFill>
-                      <a:srgbClr val="ECF1F6"/>
-                    </a:solidFill>
-                  </a:tcPr>
-                </a:tc>
-                <a:tc>
-                  <a:txBody>
-                    <a:bodyPr wrap="square"/>
-                    <a:lstStyle/>
-                    <a:p>
-                      <a:r>
-                        <a:rPr sz="1100" b="0">
-                          <a:solidFill>
-                            <a:srgbClr val="282828"/>
-                          </a:solidFill>
-                          <a:latin typeface="Arial"/>
-                        </a:rPr>
-                        <a:t>dyson_ladder.m, dyson5_trade.m</a:t>
-                      </a:r>
-                    </a:p>
-                  </a:txBody>
-                  <a:tcPr marL="54864" marR="54864" marT="18288" marB="18288">
-                    <a:solidFill>
-                      <a:srgbClr val="ECF1F6"/>
-                    </a:solidFill>
-                  </a:tcPr>
-                </a:tc>
-              </a:tr>
-              <a:tr h="280035">
-                <a:tc>
-                  <a:txBody>
-                    <a:bodyPr wrap="square"/>
-                    <a:lstStyle/>
-                    <a:p>
-                      <a:r>
-                        <a:rPr sz="1100" b="0">
-                          <a:solidFill>
-                            <a:srgbClr val="282828"/>
-                          </a:solidFill>
-                          <a:latin typeface="Arial"/>
-                        </a:rPr>
-                        <a:t>meniscus search</a:t>
-                      </a:r>
-                    </a:p>
-                  </a:txBody>
-                  <a:tcPr marL="54864" marR="54864" marT="18288" marB="18288">
-                    <a:solidFill>
-                      <a:srgbClr val="FFFFFF"/>
-                    </a:solidFill>
-                  </a:tcPr>
-                </a:tc>
-                <a:tc>
-                  <a:txBody>
-                    <a:bodyPr wrap="square"/>
-                    <a:lstStyle/>
-                    <a:p>
-                      <a:r>
-                        <a:rPr sz="1100" b="0">
-                          <a:solidFill>
-                            <a:srgbClr val="282828"/>
-                          </a:solidFill>
-                          <a:latin typeface="Arial"/>
-                        </a:rPr>
-                        <a:t>tool</a:t>
-                      </a:r>
-                    </a:p>
-                  </a:txBody>
-                  <a:tcPr marL="54864" marR="54864" marT="18288" marB="18288">
-                    <a:solidFill>
-                      <a:srgbClr val="FFFFFF"/>
-                    </a:solidFill>
-                  </a:tcPr>
-                </a:tc>
-                <a:tc>
-                  <a:txBody>
-                    <a:bodyPr wrap="square"/>
-                    <a:lstStyle/>
-                    <a:p>
-                      <a:r>
-                        <a:rPr sz="1100" b="0">
-                          <a:solidFill>
-                            <a:srgbClr val="282828"/>
-                          </a:solidFill>
-                          <a:latin typeface="Arial"/>
-                        </a:rPr>
-                        <a:t>dyson5_s3_r4global.txt</a:t>
-                      </a:r>
-                    </a:p>
-                  </a:txBody>
-                  <a:tcPr marL="54864" marR="54864" marT="18288" marB="18288">
-                    <a:solidFill>
-                      <a:srgbClr val="FFFFFF"/>
-                    </a:solidFill>
-                  </a:tcPr>
-                </a:tc>
-                <a:tc>
-                  <a:txBody>
-                    <a:bodyPr wrap="square"/>
-                    <a:lstStyle/>
-                    <a:p>
-                      <a:r>
-                        <a:rPr sz="1100" b="0">
-                          <a:solidFill>
-                            <a:srgbClr val="282828"/>
-                          </a:solidFill>
-                          <a:latin typeface="Arial"/>
-                        </a:rPr>
-                        <a:t>dyson_r4_global.m</a:t>
-                      </a:r>
-                    </a:p>
-                  </a:txBody>
-                  <a:tcPr marL="54864" marR="54864" marT="18288" marB="18288">
-                    <a:solidFill>
-                      <a:srgbClr val="FFFFFF"/>
-                    </a:solidFill>
-                  </a:tcPr>
-                </a:tc>
-              </a:tr>
-              <a:tr h="468630">
-                <a:tc>
-                  <a:txBody>
-                    <a:bodyPr wrap="square"/>
-                    <a:lstStyle/>
-                    <a:p>
-                      <a:r>
-                        <a:rPr sz="1100" b="0">
-                          <a:solidFill>
-                            <a:srgbClr val="282828"/>
-                          </a:solidFill>
-                          <a:latin typeface="Arial"/>
-                        </a:rPr>
-                        <a:t>slit loss</a:t>
-                      </a:r>
-                    </a:p>
-                  </a:txBody>
-                  <a:tcPr marL="54864" marR="54864" marT="18288" marB="18288">
-                    <a:solidFill>
-                      <a:srgbClr val="ECF1F6"/>
-                    </a:solidFill>
-                  </a:tcPr>
-                </a:tc>
-                <a:tc>
-                  <a:txBody>
-                    <a:bodyPr wrap="square"/>
-                    <a:lstStyle/>
-                    <a:p>
-                      <a:r>
-                        <a:rPr sz="1100" b="0">
-                          <a:solidFill>
-                            <a:srgbClr val="282828"/>
-                          </a:solidFill>
-                          <a:latin typeface="Arial"/>
-                        </a:rPr>
-                        <a:t>s2l + tool</a:t>
-                      </a:r>
-                    </a:p>
-                  </a:txBody>
-                  <a:tcPr marL="54864" marR="54864" marT="18288" marB="18288">
-                    <a:solidFill>
-                      <a:srgbClr val="ECF1F6"/>
-                    </a:solidFill>
-                  </a:tcPr>
-                </a:tc>
-                <a:tc>
-                  <a:txBody>
-                    <a:bodyPr wrap="square"/>
-                    <a:lstStyle/>
-                    <a:p>
-                      <a:r>
-                        <a:rPr sz="1100" b="0">
-                          <a:solidFill>
-                            <a:srgbClr val="282828"/>
-                          </a:solidFill>
-                          <a:latin typeface="Arial"/>
-                        </a:rPr>
-                        <a:t>dyson5_s2l.txt, dyson5_s2l_tests.txt, dyson5_s2l_slitloss.png</a:t>
-                      </a:r>
-                    </a:p>
-                  </a:txBody>
-                  <a:tcPr marL="54864" marR="54864" marT="18288" marB="18288">
-                    <a:solidFill>
-                      <a:srgbClr val="ECF1F6"/>
-                    </a:solidFill>
-                  </a:tcPr>
-                </a:tc>
-                <a:tc>
-                  <a:txBody>
-                    <a:bodyPr wrap="square"/>
-                    <a:lstStyle/>
-                    <a:p>
-                      <a:r>
-                        <a:rPr sz="1100" b="0">
-                          <a:solidFill>
-                            <a:srgbClr val="282828"/>
-                          </a:solidFill>
-                          <a:latin typeface="Arial"/>
-                        </a:rPr>
-                        <a:t>far-field leg vs sinc²; dyson5_slitloss_tests.m</a:t>
-                      </a:r>
-                    </a:p>
-                  </a:txBody>
-                  <a:tcPr marL="54864" marR="54864" marT="18288" marB="18288">
-                    <a:solidFill>
-                      <a:srgbClr val="ECF1F6"/>
-                    </a:solidFill>
-                  </a:tcPr>
-                </a:tc>
-              </a:tr>
-              <a:tr h="468630">
-                <a:tc>
-                  <a:txBody>
-                    <a:bodyPr wrap="square"/>
-                    <a:lstStyle/>
-                    <a:p>
-                      <a:r>
-                        <a:rPr sz="1100" b="0">
-                          <a:solidFill>
-                            <a:srgbClr val="282828"/>
-                          </a:solidFill>
-                          <a:latin typeface="Arial"/>
-                        </a:rPr>
-                        <a:t>fold prism, cold shield</a:t>
-                      </a:r>
-                    </a:p>
-                  </a:txBody>
-                  <a:tcPr marL="54864" marR="54864" marT="18288" marB="18288">
-                    <a:solidFill>
-                      <a:srgbClr val="FFFFFF"/>
-                    </a:solidFill>
-                  </a:tcPr>
-                </a:tc>
-                <a:tc>
-                  <a:txBody>
-                    <a:bodyPr wrap="square"/>
-                    <a:lstStyle/>
-                    <a:p>
-                      <a:r>
-                        <a:rPr sz="1100" b="0">
-                          <a:solidFill>
-                            <a:srgbClr val="282828"/>
-                          </a:solidFill>
-                          <a:latin typeface="Arial"/>
-                        </a:rPr>
-                        <a:t>s5</a:t>
-                      </a:r>
-                    </a:p>
-                  </a:txBody>
-                  <a:tcPr marL="54864" marR="54864" marT="18288" marB="18288">
-                    <a:solidFill>
-                      <a:srgbClr val="FFFFFF"/>
-                    </a:solidFill>
-                  </a:tcPr>
-                </a:tc>
-                <a:tc>
-                  <a:txBody>
-                    <a:bodyPr wrap="square"/>
-                    <a:lstStyle/>
-                    <a:p>
-                      <a:r>
-                        <a:rPr sz="1100" b="0">
-                          <a:solidFill>
-                            <a:srgbClr val="282828"/>
-                          </a:solidFill>
-                          <a:latin typeface="Arial"/>
-                        </a:rPr>
-                        <a:t>dyson5_s5.txt, dyson5_s5_r5_h*.in, dyson5_s5_maps_r5.png, dyson5_s5_sweep.png</a:t>
-                      </a:r>
-                    </a:p>
-                  </a:txBody>
-                  <a:tcPr marL="54864" marR="54864" marT="18288" marB="18288">
-                    <a:solidFill>
-                      <a:srgbClr val="FFFFFF"/>
-                    </a:solidFill>
-                  </a:tcPr>
-                </a:tc>
-                <a:tc>
-                  <a:txBody>
-                    <a:bodyPr wrap="square"/>
-                    <a:lstStyle/>
-                    <a:p>
-                      <a:r>
-                        <a:rPr sz="1100" b="0">
-                          <a:solidFill>
-                            <a:srgbClr val="282828"/>
-                          </a:solidFill>
-                          <a:latin typeface="Arial"/>
-                        </a:rPr>
-                        <a:t>spectrometer_geom.m (form dyson_fold), spectrometer_clearance.m</a:t>
-                      </a:r>
-                    </a:p>
-                  </a:txBody>
-                  <a:tcPr marL="54864" marR="54864" marT="18288" marB="18288">
-                    <a:solidFill>
-                      <a:srgbClr val="FFFFFF"/>
-                    </a:solidFill>
-                  </a:tcPr>
-                </a:tc>
-              </a:tr>
-              <a:tr h="280035">
-                <a:tc>
-                  <a:txBody>
-                    <a:bodyPr wrap="square"/>
-                    <a:lstStyle/>
-                    <a:p>
-                      <a:r>
-                        <a:rPr sz="1100" b="0">
-                          <a:solidFill>
-                            <a:srgbClr val="282828"/>
-                          </a:solidFill>
-                          <a:latin typeface="Arial"/>
-                        </a:rPr>
-                        <a:t>closure envelope</a:t>
-                      </a:r>
-                    </a:p>
-                  </a:txBody>
-                  <a:tcPr marL="54864" marR="54864" marT="18288" marB="18288">
-                    <a:solidFill>
-                      <a:srgbClr val="ECF1F6"/>
-                    </a:solidFill>
-                  </a:tcPr>
-                </a:tc>
-                <a:tc>
-                  <a:txBody>
-                    <a:bodyPr wrap="square"/>
-                    <a:lstStyle/>
-                    <a:p>
-                      <a:r>
-                        <a:rPr sz="1100" b="0">
-                          <a:solidFill>
-                            <a:srgbClr val="282828"/>
-                          </a:solidFill>
-                          <a:latin typeface="Arial"/>
-                        </a:rPr>
-                        <a:t>s4env</a:t>
-                      </a:r>
-                    </a:p>
-                  </a:txBody>
-                  <a:tcPr marL="54864" marR="54864" marT="18288" marB="18288">
-                    <a:solidFill>
-                      <a:srgbClr val="ECF1F6"/>
-                    </a:solidFill>
-                  </a:tcPr>
-                </a:tc>
-                <a:tc>
-                  <a:txBody>
-                    <a:bodyPr wrap="square"/>
-                    <a:lstStyle/>
-                    <a:p>
-                      <a:r>
-                        <a:rPr sz="1100" b="0">
-                          <a:solidFill>
-                            <a:srgbClr val="282828"/>
-                          </a:solidFill>
-                          <a:latin typeface="Arial"/>
-                        </a:rPr>
-                        <a:t>dyson5_s4env.txt, dyson5_s4env.png, dyson5_s4env_*.in</a:t>
-                      </a:r>
-                    </a:p>
-                  </a:txBody>
-                  <a:tcPr marL="54864" marR="54864" marT="18288" marB="18288">
-                    <a:solidFill>
-                      <a:srgbClr val="ECF1F6"/>
-                    </a:solidFill>
-                  </a:tcPr>
-                </a:tc>
-                <a:tc>
-                  <a:txBody>
-                    <a:bodyPr wrap="square"/>
-                    <a:lstStyle/>
-                    <a:p>
-                      <a:r>
-                        <a:rPr sz="1100" b="0">
-                          <a:solidFill>
-                            <a:srgbClr val="282828"/>
-                          </a:solidFill>
-                          <a:latin typeface="Arial"/>
-                        </a:rPr>
-                        <a:t>dyson5_envelope.m</a:t>
-                      </a:r>
-                    </a:p>
-                  </a:txBody>
-                  <a:tcPr marL="54864" marR="54864" marT="18288" marB="18288">
-                    <a:solidFill>
-                      <a:srgbClr val="ECF1F6"/>
-                    </a:solidFill>
-                  </a:tcPr>
-                </a:tc>
-              </a:tr>
-              <a:tr h="468630">
-                <a:tc>
-                  <a:txBody>
-                    <a:bodyPr wrap="square"/>
-                    <a:lstStyle/>
-                    <a:p>
-                      <a:r>
-                        <a:rPr sz="1100" b="0">
-                          <a:solidFill>
-                            <a:srgbClr val="282828"/>
-                          </a:solidFill>
-                          <a:latin typeface="Arial"/>
-                        </a:rPr>
-                        <a:t>native optimizer</a:t>
-                      </a:r>
-                    </a:p>
-                  </a:txBody>
-                  <a:tcPr marL="54864" marR="54864" marT="18288" marB="18288">
-                    <a:solidFill>
-                      <a:srgbClr val="FFFFFF"/>
-                    </a:solidFill>
-                  </a:tcPr>
-                </a:tc>
-                <a:tc>
-                  <a:txBody>
-                    <a:bodyPr wrap="square"/>
-                    <a:lstStyle/>
-                    <a:p>
-                      <a:r>
-                        <a:rPr sz="1100" b="0">
-                          <a:solidFill>
-                            <a:srgbClr val="282828"/>
-                          </a:solidFill>
-                          <a:latin typeface="Arial"/>
-                        </a:rPr>
-                        <a:t>s4</a:t>
-                      </a:r>
-                    </a:p>
-                  </a:txBody>
-                  <a:tcPr marL="54864" marR="54864" marT="18288" marB="18288">
-                    <a:solidFill>
-                      <a:srgbClr val="FFFFFF"/>
-                    </a:solidFill>
-                  </a:tcPr>
-                </a:tc>
-                <a:tc>
-                  <a:txBody>
-                    <a:bodyPr wrap="square"/>
-                    <a:lstStyle/>
-                    <a:p>
-                      <a:r>
-                        <a:rPr sz="1100" b="0">
-                          <a:solidFill>
-                            <a:srgbClr val="282828"/>
-                          </a:solidFill>
-                          <a:latin typeface="Arial"/>
-                        </a:rPr>
-                        <a:t>dyson5_s4.txt, dyson5_s4_r4n_seed.in (the CALIB deck), dyson5_s4_r4n.in</a:t>
-                      </a:r>
-                    </a:p>
-                  </a:txBody>
-                  <a:tcPr marL="54864" marR="54864" marT="18288" marB="18288">
-                    <a:solidFill>
-                      <a:srgbClr val="FFFFFF"/>
-                    </a:solidFill>
-                  </a:tcPr>
-                </a:tc>
-                <a:tc>
-                  <a:txBody>
-                    <a:bodyPr wrap="square"/>
-                    <a:lstStyle/>
-                    <a:p>
-                      <a:r>
-                        <a:rPr sz="1100" b="0">
-                          <a:solidFill>
-                            <a:srgbClr val="282828"/>
-                          </a:solidFill>
-                          <a:latin typeface="Arial"/>
-                        </a:rPr>
-                        <a:t>dyson_native.m</a:t>
-                      </a:r>
-                    </a:p>
-                  </a:txBody>
-                  <a:tcPr marL="54864" marR="54864" marT="18288" marB="18288">
-                    <a:solidFill>
-                      <a:srgbClr val="FFFFFF"/>
-                    </a:solidFill>
-                  </a:tcPr>
-                </a:tc>
-              </a:tr>
-              <a:tr h="468630">
-                <a:tc>
-                  <a:txBody>
-                    <a:bodyPr wrap="square"/>
-                    <a:lstStyle/>
-                    <a:p>
-                      <a:r>
-                        <a:rPr sz="1100" b="0">
-                          <a:solidFill>
-                            <a:srgbClr val="282828"/>
-                          </a:solidFill>
-                          <a:latin typeface="Arial"/>
-                        </a:rPr>
-                        <a:t>block-size trade</a:t>
-                      </a:r>
-                    </a:p>
-                  </a:txBody>
-                  <a:tcPr marL="54864" marR="54864" marT="18288" marB="18288">
-                    <a:solidFill>
-                      <a:srgbClr val="ECF1F6"/>
-                    </a:solidFill>
-                  </a:tcPr>
-                </a:tc>
-                <a:tc>
-                  <a:txBody>
-                    <a:bodyPr wrap="square"/>
-                    <a:lstStyle/>
-                    <a:p>
-                      <a:r>
-                        <a:rPr sz="1100" b="0">
-                          <a:solidFill>
-                            <a:srgbClr val="282828"/>
-                          </a:solidFill>
-                          <a:latin typeface="Arial"/>
-                        </a:rPr>
-                        <a:t>dyson5_size_trade.m</a:t>
-                      </a:r>
-                    </a:p>
-                  </a:txBody>
-                  <a:tcPr marL="54864" marR="54864" marT="18288" marB="18288">
-                    <a:solidFill>
-                      <a:srgbClr val="ECF1F6"/>
-                    </a:solidFill>
-                  </a:tcPr>
-                </a:tc>
-                <a:tc>
-                  <a:txBody>
-                    <a:bodyPr wrap="square"/>
-                    <a:lstStyle/>
-                    <a:p>
-                      <a:r>
-                        <a:rPr sz="1100" b="0">
-                          <a:solidFill>
-                            <a:srgbClr val="282828"/>
-                          </a:solidFill>
-                          <a:latin typeface="Arial"/>
-                        </a:rPr>
-                        <a:t>dyson5_size.txt, dyson5_size.png, dyson5_size_*.in, BRIEF_dyson5_size.md</a:t>
-                      </a:r>
-                    </a:p>
-                  </a:txBody>
-                  <a:tcPr marL="54864" marR="54864" marT="18288" marB="18288">
-                    <a:solidFill>
-                      <a:srgbClr val="ECF1F6"/>
-                    </a:solidFill>
-                  </a:tcPr>
-                </a:tc>
-                <a:tc>
-                  <a:txBody>
-                    <a:bodyPr wrap="square"/>
-                    <a:lstStyle/>
-                    <a:p>
-                      <a:r>
-                        <a:rPr sz="1100" b="0">
-                          <a:solidFill>
-                            <a:srgbClr val="282828"/>
-                          </a:solidFill>
-                          <a:latin typeface="Arial"/>
-                        </a:rPr>
-                        <a:t>continuation walks over dyson_ladder.m</a:t>
-                      </a:r>
-                    </a:p>
-                  </a:txBody>
-                  <a:tcPr marL="54864" marR="54864" marT="18288" marB="18288">
-                    <a:solidFill>
-                      <a:srgbClr val="ECF1F6"/>
-                    </a:solidFill>
-                  </a:tcPr>
-                </a:tc>
-              </a:tr>
-              <a:tr h="468630">
-                <a:tc>
-                  <a:txBody>
-                    <a:bodyPr wrap="square"/>
-                    <a:lstStyle/>
-                    <a:p>
-                      <a:r>
-                        <a:rPr sz="1100" b="0">
-                          <a:solidFill>
-                            <a:srgbClr val="282828"/>
-                          </a:solidFill>
-                          <a:latin typeface="Arial"/>
-                        </a:rPr>
-                        <a:t>telescope, three-mirror at Jim's numbers</a:t>
-                      </a:r>
-                    </a:p>
-                  </a:txBody>
-                  <a:tcPr marL="54864" marR="54864" marT="18288" marB="18288">
-                    <a:solidFill>
-                      <a:srgbClr val="FFFFFF"/>
-                    </a:solidFill>
-                  </a:tcPr>
-                </a:tc>
-                <a:tc>
-                  <a:txBody>
-                    <a:bodyPr wrap="square"/>
-                    <a:lstStyle/>
-                    <a:p>
-                      <a:r>
-                        <a:rPr sz="1100" b="0">
-                          <a:solidFill>
-                            <a:srgbClr val="282828"/>
-                          </a:solidFill>
-                          <a:latin typeface="Arial"/>
-                        </a:rPr>
-                        <a:t>t3s, t3w, t3o, t3e</a:t>
-                      </a:r>
-                    </a:p>
-                  </a:txBody>
-                  <a:tcPr marL="54864" marR="54864" marT="18288" marB="18288">
-                    <a:solidFill>
-                      <a:srgbClr val="FFFFFF"/>
-                    </a:solidFill>
-                  </a:tcPr>
-                </a:tc>
-                <a:tc>
-                  <a:txBody>
-                    <a:bodyPr wrap="square"/>
-                    <a:lstStyle/>
-                    <a:p>
-                      <a:r>
-                        <a:rPr sz="1100" b="0">
-                          <a:solidFill>
-                            <a:srgbClr val="282828"/>
-                          </a:solidFill>
-                          <a:latin typeface="Arial"/>
-                        </a:rPr>
-                        <a:t>dyson5_t3*.txt, BRIEF_dyson5_beat5c.md</a:t>
-                      </a:r>
-                    </a:p>
-                  </a:txBody>
-                  <a:tcPr marL="54864" marR="54864" marT="18288" marB="18288">
-                    <a:solidFill>
-                      <a:srgbClr val="FFFFFF"/>
-                    </a:solidFill>
-                  </a:tcPr>
-                </a:tc>
-                <a:tc>
-                  <a:txBody>
-                    <a:bodyPr wrap="square"/>
-                    <a:lstStyle/>
-                    <a:p>
-                      <a:r>
-                        <a:rPr sz="1100" b="0">
-                          <a:solidFill>
-                            <a:srgbClr val="282828"/>
-                          </a:solidFill>
-                          <a:latin typeface="Arial"/>
-                        </a:rPr>
-                        <a:t>tma_screen, the offset solves on telescope_geom.m</a:t>
-                      </a:r>
-                    </a:p>
-                  </a:txBody>
-                  <a:tcPr marL="54864" marR="54864" marT="18288" marB="18288">
-                    <a:solidFill>
-                      <a:srgbClr val="FFFFFF"/>
-                    </a:solidFill>
-                  </a:tcPr>
-                </a:tc>
-              </a:tr>
-              <a:tr h="468630">
-                <a:tc>
-                  <a:txBody>
-                    <a:bodyPr wrap="square"/>
-                    <a:lstStyle/>
-                    <a:p>
-                      <a:r>
-                        <a:rPr sz="1100" b="0">
-                          <a:solidFill>
-                            <a:srgbClr val="282828"/>
-                          </a:solidFill>
-                          <a:latin typeface="Arial"/>
-                        </a:rPr>
-                        <a:t>telescope, modified Schwarzschild</a:t>
-                      </a:r>
-                    </a:p>
-                  </a:txBody>
-                  <a:tcPr marL="54864" marR="54864" marT="18288" marB="18288">
-                    <a:solidFill>
-                      <a:srgbClr val="ECF1F6"/>
-                    </a:solidFill>
-                  </a:tcPr>
-                </a:tc>
-                <a:tc>
-                  <a:txBody>
-                    <a:bodyPr wrap="square"/>
-                    <a:lstStyle/>
-                    <a:p>
-                      <a:r>
-                        <a:rPr sz="1100" b="0">
-                          <a:solidFill>
-                            <a:srgbClr val="282828"/>
-                          </a:solidFill>
-                          <a:latin typeface="Arial"/>
-                        </a:rPr>
-                        <a:t>t4</a:t>
-                      </a:r>
-                    </a:p>
-                  </a:txBody>
-                  <a:tcPr marL="54864" marR="54864" marT="18288" marB="18288">
-                    <a:solidFill>
-                      <a:srgbClr val="ECF1F6"/>
-                    </a:solidFill>
-                  </a:tcPr>
-                </a:tc>
-                <a:tc>
-                  <a:txBody>
-                    <a:bodyPr wrap="square"/>
-                    <a:lstStyle/>
-                    <a:p>
-                      <a:r>
-                        <a:rPr sz="1100" b="0">
-                          <a:solidFill>
-                            <a:srgbClr val="282828"/>
-                          </a:solidFill>
-                          <a:latin typeface="Arial"/>
-                        </a:rPr>
-                        <a:t>dyson5_t4.txt, dyson5_t4_r2c_.in, _view.png</a:t>
-                      </a:r>
-                    </a:p>
-                  </a:txBody>
-                  <a:tcPr marL="54864" marR="54864" marT="18288" marB="18288">
-                    <a:solidFill>
-                      <a:srgbClr val="ECF1F6"/>
-                    </a:solidFill>
-                  </a:tcPr>
-                </a:tc>
-                <a:tc>
-                  <a:txBody>
-                    <a:bodyPr wrap="square"/>
-                    <a:lstStyle/>
-                    <a:p>
-                      <a:r>
-                        <a:rPr sz="1100" b="0">
-                          <a:solidFill>
-                            <a:srgbClr val="282828"/>
-                          </a:solidFill>
-                          <a:latin typeface="Arial"/>
-                        </a:rPr>
-                        <a:t>tms_paraxial.m, tms_firstorder.m, tms_geom.m, tms_clear.m</a:t>
-                      </a:r>
-                    </a:p>
-                  </a:txBody>
-                  <a:tcPr marL="54864" marR="54864" marT="18288" marB="18288">
-                    <a:solidFill>
-                      <a:srgbClr val="ECF1F6"/>
-                    </a:solidFill>
-                  </a:tcPr>
-                </a:tc>
-              </a:tr>
-              <a:tr h="468630">
-                <a:tc>
-                  <a:txBody>
-                    <a:bodyPr wrap="square"/>
-                    <a:lstStyle/>
-                    <a:p>
-                      <a:r>
-                        <a:rPr sz="1100" b="0">
-                          <a:solidFill>
-                            <a:srgbClr val="282828"/>
-                          </a:solidFill>
-                          <a:latin typeface="Arial"/>
-                        </a:rPr>
-                        <a:t>telescope, TMA parent by the design layer</a:t>
-                      </a:r>
-                    </a:p>
-                  </a:txBody>
-                  <a:tcPr marL="54864" marR="54864" marT="18288" marB="18288">
-                    <a:solidFill>
-                      <a:srgbClr val="FFFFFF"/>
-                    </a:solidFill>
-                  </a:tcPr>
-                </a:tc>
-                <a:tc>
-                  <a:txBody>
-                    <a:bodyPr wrap="square"/>
-                    <a:lstStyle/>
-                    <a:p>
-                      <a:r>
-                        <a:rPr sz="1100" b="0">
-                          <a:solidFill>
-                            <a:srgbClr val="282828"/>
-                          </a:solidFill>
-                          <a:latin typeface="Arial"/>
-                        </a:rPr>
-                        <a:t>dyson5_tma_step1.m</a:t>
-                      </a:r>
-                    </a:p>
-                  </a:txBody>
-                  <a:tcPr marL="54864" marR="54864" marT="18288" marB="18288">
-                    <a:solidFill>
-                      <a:srgbClr val="FFFFFF"/>
-                    </a:solidFill>
-                  </a:tcPr>
-                </a:tc>
-                <a:tc>
-                  <a:txBody>
-                    <a:bodyPr wrap="square"/>
-                    <a:lstStyle/>
-                    <a:p>
-                      <a:r>
-                        <a:rPr sz="1100" b="0">
-                          <a:solidFill>
-                            <a:srgbClr val="282828"/>
-                          </a:solidFill>
-                          <a:latin typeface="Arial"/>
-                        </a:rPr>
-                        <a:t>dyson5_tma_step1.txt, dyson5_tma_step1_layout.png, BRIEF_dyson5_tma.md</a:t>
-                      </a:r>
-                    </a:p>
-                  </a:txBody>
-                  <a:tcPr marL="54864" marR="54864" marT="18288" marB="18288">
-                    <a:solidFill>
-                      <a:srgbClr val="FFFFFF"/>
-                    </a:solidFill>
-                  </a:tcPr>
-                </a:tc>
-                <a:tc>
-                  <a:txBody>
-                    <a:bodyPr wrap="square"/>
-                    <a:lstStyle/>
-                    <a:p>
-                      <a:r>
-                        <a:rPr sz="1100" b="0">
-                          <a:solidFill>
-                            <a:srgbClr val="282828"/>
-                          </a:solidFill>
-                          <a:latin typeface="Arial"/>
-                        </a:rPr>
-                        <a:t>macos.design.tma_layout, Telescope, CALIB</a:t>
-                      </a:r>
-                    </a:p>
-                  </a:txBody>
-                  <a:tcPr marL="54864" marR="54864" marT="18288" marB="18288">
-                    <a:solidFill>
-                      <a:srgbClr val="FFFFFF"/>
-                    </a:solidFill>
-                  </a:tcPr>
-                </a:tc>
-              </a:tr>
-              <a:tr h="468630">
-                <a:tc>
-                  <a:txBody>
-                    <a:bodyPr wrap="square"/>
-                    <a:lstStyle/>
-                    <a:p>
-                      <a:r>
-                        <a:rPr sz="1100" b="0">
-                          <a:solidFill>
-                            <a:srgbClr val="282828"/>
-                          </a:solidFill>
-                          <a:latin typeface="Arial"/>
-                        </a:rPr>
-                        <a:t>end to end at Jim's f-number (informative)</a:t>
-                      </a:r>
-                    </a:p>
-                  </a:txBody>
-                  <a:tcPr marL="54864" marR="54864" marT="18288" marB="18288">
-                    <a:solidFill>
-                      <a:srgbClr val="ECF1F6"/>
-                    </a:solidFill>
-                  </a:tcPr>
-                </a:tc>
-                <a:tc>
-                  <a:txBody>
-                    <a:bodyPr wrap="square"/>
-                    <a:lstStyle/>
-                    <a:p>
-                      <a:r>
-                        <a:rPr sz="1100" b="0">
-                          <a:solidFill>
-                            <a:srgbClr val="282828"/>
-                          </a:solidFill>
-                          <a:latin typeface="Arial"/>
-                        </a:rPr>
-                        <a:t>t5e</a:t>
-                      </a:r>
-                    </a:p>
-                  </a:txBody>
-                  <a:tcPr marL="54864" marR="54864" marT="18288" marB="18288">
-                    <a:solidFill>
-                      <a:srgbClr val="ECF1F6"/>
-                    </a:solidFill>
-                  </a:tcPr>
-                </a:tc>
-                <a:tc>
-                  <a:txBody>
-                    <a:bodyPr wrap="square"/>
-                    <a:lstStyle/>
-                    <a:p>
-                      <a:r>
-                        <a:rPr sz="1100" b="0">
-                          <a:solidFill>
-                            <a:srgbClr val="282828"/>
-                          </a:solidFill>
-                          <a:latin typeface="Arial"/>
-                        </a:rPr>
-                        <a:t>dyson5_t5e_1k5.txt, dyson5_t5e_1k5_e2e.in, dyson5_t5e_1k5_maps.png</a:t>
-                      </a:r>
-                    </a:p>
-                  </a:txBody>
-                  <a:tcPr marL="54864" marR="54864" marT="18288" marB="18288">
-                    <a:solidFill>
-                      <a:srgbClr val="ECF1F6"/>
-                    </a:solidFill>
-                  </a:tcPr>
-                </a:tc>
-                <a:tc>
-                  <a:txBody>
-                    <a:bodyPr wrap="square"/>
-                    <a:lstStyle/>
-                    <a:p>
-                      <a:r>
-                        <a:rPr sz="1100" b="0">
-                          <a:solidFill>
-                            <a:srgbClr val="282828"/>
-                          </a:solidFill>
-                          <a:latin typeface="Arial"/>
-                        </a:rPr>
-                        <a:t>tel_deck_geom.m (the exact chain from a Telescope deck), the spectrometer's scorer</a:t>
-                      </a:r>
-                    </a:p>
-                  </a:txBody>
-                  <a:tcPr marL="54864" marR="54864" marT="18288" marB="18288">
-                    <a:solidFill>
-                      <a:srgbClr val="ECF1F6"/>
-                    </a:solidFill>
-                  </a:tcPr>
-                </a:tc>
-              </a:tr>
-              <a:tr h="468630">
-                <a:tc>
-                  <a:txBody>
-                    <a:bodyPr wrap="square"/>
-                    <a:lstStyle/>
-                    <a:p>
-                      <a:r>
-                        <a:rPr sz="1100" b="0">
-                          <a:solidFill>
-                            <a:srgbClr val="282828"/>
-                          </a:solidFill>
-                          <a:latin typeface="Arial"/>
-                        </a:rPr>
-                        <a:t>telescope, TMA unobscured section (step 2/2b, Linux)</a:t>
-                      </a:r>
-                    </a:p>
-                  </a:txBody>
-                  <a:tcPr marL="54864" marR="54864" marT="18288" marB="18288">
-                    <a:solidFill>
-                      <a:srgbClr val="FFFFFF"/>
-                    </a:solidFill>
-                  </a:tcPr>
-                </a:tc>
-                <a:tc>
-                  <a:txBody>
-                    <a:bodyPr wrap="square"/>
-                    <a:lstStyle/>
-                    <a:p>
-                      <a:r>
-                        <a:rPr sz="1100" b="0">
-                          <a:solidFill>
-                            <a:srgbClr val="282828"/>
-                          </a:solidFill>
-                          <a:latin typeface="Arial"/>
-                        </a:rPr>
-                        <a:t>dyson5_tma_step2_linux.m</a:t>
-                      </a:r>
-                    </a:p>
-                  </a:txBody>
-                  <a:tcPr marL="54864" marR="54864" marT="18288" marB="18288">
-                    <a:solidFill>
-                      <a:srgbClr val="FFFFFF"/>
-                    </a:solidFill>
-                  </a:tcPr>
-                </a:tc>
-                <a:tc>
-                  <a:txBody>
-                    <a:bodyPr wrap="square"/>
-                    <a:lstStyle/>
-                    <a:p>
-                      <a:r>
-                        <a:rPr sz="1100" b="0">
-                          <a:solidFill>
-                            <a:srgbClr val="282828"/>
-                          </a:solidFill>
-                          <a:latin typeface="Arial"/>
-                        </a:rPr>
-                        <a:t>dyson5_tma_step2_linux_d170.txt, _d190.txt, dyson5_tma_step2b_linux_d205.txt, _d205_1k5.in, _layout_*.png</a:t>
-                      </a:r>
-                    </a:p>
-                  </a:txBody>
-                  <a:tcPr marL="54864" marR="54864" marT="18288" marB="18288">
-                    <a:solidFill>
-                      <a:srgbClr val="FFFFFF"/>
-                    </a:solidFill>
-                  </a:tcPr>
-                </a:tc>
-                <a:tc>
-                  <a:txBody>
-                    <a:bodyPr wrap="square"/>
-                    <a:lstStyle/>
-                    <a:p>
-                      <a:r>
-                        <a:rPr sz="1100" b="0">
-                          <a:solidFill>
-                            <a:srgbClr val="282828"/>
-                          </a:solidFill>
-                          <a:latin typeface="Arial"/>
-                        </a:rPr>
-                        <a:t>Telescope.set_offaxis, CALIB over the strip with the per-field position rows, check_clipping</a:t>
-                      </a:r>
-                    </a:p>
-                  </a:txBody>
-                  <a:tcPr marL="54864" marR="54864" marT="18288" marB="18288">
-                    <a:solidFill>
-                      <a:srgbClr val="FFFFFF"/>
                     </a:solidFill>
                   </a:tcPr>
                 </a:tc>
@@ -19966,7 +19794,7 @@
         </p:nvSpPr>
         <p:spPr>
           <a:xfrm>
-            <a:off x="411480" y="8559927"/>
+            <a:off x="411480" y="5108067"/>
             <a:ext cx="11368735" cy="274320"/>
           </a:xfrm>
           <a:prstGeom prst="rect">
@@ -19992,7 +19820,7 @@
                 </a:solidFill>
                 <a:latin typeface="Arial"/>
               </a:rPr>
-              <a:t>Conventions behind the scaling law: block index n(silica, 1 µm) = 1.450417; in-glass marginal half-angle u = asin(1 / 2nF); field height h from the Dyson axis on the flat face; the slit corner is h = hypot(27 mm, 8 mm).</a:t>
+              <a:t>Every one of the four passed every existing check: the rays "passed", the solve "converged", the deck loaded.  What exposed them was a section whose beam is 190 mm from its parent's vertex — the first design in the record where the vertex and the lit patch are not the same place.</a:t>
             </a:r>
           </a:p>
         </p:txBody>
@@ -20005,7 +19833,1991 @@
 </p:sld>
 </file>
 
-<file path=ppt/slides/slide34.xml><?xml version="1.0" encoding="utf-8"?>
+<file path=ppt/slides/slide36.xml><?xml version="1.0" encoding="utf-8"?>
+<p:sld xmlns:a="http://schemas.openxmlformats.org/drawingml/2006/main" xmlns:p="http://schemas.openxmlformats.org/presentationml/2006/main" xmlns:r="http://schemas.openxmlformats.org/officeDocument/2006/relationships">
+  <p:cSld>
+    <p:spTree>
+      <p:nvGrpSpPr>
+        <p:cNvPr id="1" name=""/>
+        <p:cNvGrpSpPr/>
+        <p:nvPr/>
+      </p:nvGrpSpPr>
+      <p:grpSpPr/>
+      <p:sp>
+        <p:nvSpPr>
+          <p:cNvPr id="2" name="TextBox 1"/>
+          <p:cNvSpPr txBox="1"/>
+          <p:nvPr/>
+        </p:nvSpPr>
+        <p:spPr>
+          <a:xfrm>
+            <a:off x="411480" y="201168"/>
+            <a:ext cx="11368735" cy="914400"/>
+          </a:xfrm>
+          <a:prstGeom prst="rect">
+            <a:avLst/>
+          </a:prstGeom>
+          <a:noFill/>
+        </p:spPr>
+        <p:txBody>
+          <a:bodyPr wrap="square">
+            <a:spAutoFit/>
+          </a:bodyPr>
+          <a:lstStyle/>
+          <a:p>
+            <a:pPr>
+              <a:spcAft>
+                <a:spcPts val="400"/>
+              </a:spcAft>
+            </a:pPr>
+            <a:r>
+              <a:rPr sz="2400" b="1">
+                <a:solidFill>
+                  <a:srgbClr val="1F4E79"/>
+                </a:solidFill>
+                <a:latin typeface="Arial"/>
+              </a:rPr>
+              <a:t>Backup: records and tools behind each slide</a:t>
+            </a:r>
+          </a:p>
+          <a:p>
+            <a:pPr>
+              <a:spcAft>
+                <a:spcPts val="0"/>
+              </a:spcAft>
+            </a:pPr>
+            <a:r>
+              <a:rPr sz="1250" b="0">
+                <a:solidFill>
+                  <a:srgbClr val="6E6E6E"/>
+                </a:solidFill>
+                <a:latin typeface="Arial"/>
+              </a:rPr>
+              <a:t>Every number traces to a runner stage and its record file</a:t>
+            </a:r>
+          </a:p>
+        </p:txBody>
+      </p:sp>
+      <p:sp>
+        <p:nvSpPr>
+          <p:cNvPr id="3" name="Rectangle 2"/>
+          <p:cNvSpPr/>
+          <p:nvPr/>
+        </p:nvSpPr>
+        <p:spPr>
+          <a:xfrm>
+            <a:off x="411480" y="1133856"/>
+            <a:ext cx="11368735" cy="20320"/>
+          </a:xfrm>
+          <a:prstGeom prst="rect">
+            <a:avLst/>
+          </a:prstGeom>
+          <a:solidFill>
+            <a:srgbClr val="B8C6D4"/>
+          </a:solidFill>
+          <a:ln>
+            <a:noFill/>
+          </a:ln>
+          <a:effectLst/>
+        </p:spPr>
+        <p:style>
+          <a:lnRef idx="1">
+            <a:schemeClr val="accent1"/>
+          </a:lnRef>
+          <a:fillRef idx="3">
+            <a:schemeClr val="accent1"/>
+          </a:fillRef>
+          <a:effectRef idx="2">
+            <a:schemeClr val="accent1"/>
+          </a:effectRef>
+          <a:fontRef idx="minor">
+            <a:schemeClr val="lt1"/>
+          </a:fontRef>
+        </p:style>
+        <p:txBody>
+          <a:bodyPr rtlCol="0" anchor="ctr"/>
+          <a:lstStyle/>
+          <a:p>
+            <a:pPr algn="ctr"/>
+          </a:p>
+        </p:txBody>
+      </p:sp>
+      <p:graphicFrame>
+        <p:nvGraphicFramePr>
+          <p:cNvPr id="4" name="Table 3"/>
+          <p:cNvGraphicFramePr>
+            <a:graphicFrameLocks noGrp="1"/>
+          </p:cNvGraphicFramePr>
+          <p:nvPr/>
+        </p:nvGraphicFramePr>
+        <p:xfrm>
+          <a:off x="411480" y="1298448"/>
+          <a:ext cx="11368733" cy="8995410"/>
+        </p:xfrm>
+        <a:graphic>
+          <a:graphicData uri="http://schemas.openxmlformats.org/drawingml/2006/table">
+            <a:tbl>
+              <a:tblPr firstRow="1" bandRow="1">
+                <a:tableStyleId>{5C22544A-7EE6-4342-B048-85BDC9FD1C3A}</a:tableStyleId>
+              </a:tblPr>
+              <a:tblGrid>
+                <a:gridCol w="1828288"/>
+                <a:gridCol w="1889760"/>
+                <a:gridCol w="2953389"/>
+                <a:gridCol w="4697296"/>
+              </a:tblGrid>
+              <a:tr h="280035">
+                <a:tc>
+                  <a:txBody>
+                    <a:bodyPr wrap="square"/>
+                    <a:lstStyle/>
+                    <a:p>
+                      <a:r>
+                        <a:rPr sz="1100" b="1">
+                          <a:solidFill>
+                            <a:srgbClr val="FFFFFF"/>
+                          </a:solidFill>
+                          <a:latin typeface="Arial"/>
+                        </a:rPr>
+                        <a:t>slide</a:t>
+                      </a:r>
+                    </a:p>
+                  </a:txBody>
+                  <a:tcPr marL="54864" marR="54864" marT="18288" marB="18288">
+                    <a:solidFill>
+                      <a:srgbClr val="1F4E79"/>
+                    </a:solidFill>
+                  </a:tcPr>
+                </a:tc>
+                <a:tc>
+                  <a:txBody>
+                    <a:bodyPr wrap="square"/>
+                    <a:lstStyle/>
+                    <a:p>
+                      <a:r>
+                        <a:rPr sz="1100" b="1">
+                          <a:solidFill>
+                            <a:srgbClr val="FFFFFF"/>
+                          </a:solidFill>
+                          <a:latin typeface="Arial"/>
+                        </a:rPr>
+                        <a:t>runner stage</a:t>
+                      </a:r>
+                    </a:p>
+                  </a:txBody>
+                  <a:tcPr marL="54864" marR="54864" marT="18288" marB="18288">
+                    <a:solidFill>
+                      <a:srgbClr val="1F4E79"/>
+                    </a:solidFill>
+                  </a:tcPr>
+                </a:tc>
+                <a:tc>
+                  <a:txBody>
+                    <a:bodyPr wrap="square"/>
+                    <a:lstStyle/>
+                    <a:p>
+                      <a:r>
+                        <a:rPr sz="1100" b="1">
+                          <a:solidFill>
+                            <a:srgbClr val="FFFFFF"/>
+                          </a:solidFill>
+                          <a:latin typeface="Arial"/>
+                        </a:rPr>
+                        <a:t>record</a:t>
+                      </a:r>
+                    </a:p>
+                  </a:txBody>
+                  <a:tcPr marL="54864" marR="54864" marT="18288" marB="18288">
+                    <a:solidFill>
+                      <a:srgbClr val="1F4E79"/>
+                    </a:solidFill>
+                  </a:tcPr>
+                </a:tc>
+                <a:tc>
+                  <a:txBody>
+                    <a:bodyPr wrap="square"/>
+                    <a:lstStyle/>
+                    <a:p>
+                      <a:r>
+                        <a:rPr sz="1100" b="1">
+                          <a:solidFill>
+                            <a:srgbClr val="FFFFFF"/>
+                          </a:solidFill>
+                          <a:latin typeface="Arial"/>
+                        </a:rPr>
+                        <a:t>tool</a:t>
+                      </a:r>
+                    </a:p>
+                  </a:txBody>
+                  <a:tcPr marL="54864" marR="54864" marT="18288" marB="18288">
+                    <a:solidFill>
+                      <a:srgbClr val="1F4E79"/>
+                    </a:solidFill>
+                  </a:tcPr>
+                </a:tc>
+              </a:tr>
+              <a:tr h="280035">
+                <a:tc>
+                  <a:txBody>
+                    <a:bodyPr wrap="square"/>
+                    <a:lstStyle/>
+                    <a:p>
+                      <a:r>
+                        <a:rPr sz="1100" b="0">
+                          <a:solidFill>
+                            <a:srgbClr val="282828"/>
+                          </a:solidFill>
+                          <a:latin typeface="Arial"/>
+                        </a:rPr>
+                        <a:t>scaling law</a:t>
+                      </a:r>
+                    </a:p>
+                  </a:txBody>
+                  <a:tcPr marL="54864" marR="54864" marT="18288" marB="18288">
+                    <a:solidFill>
+                      <a:srgbClr val="FFFFFF"/>
+                    </a:solidFill>
+                  </a:tcPr>
+                </a:tc>
+                <a:tc>
+                  <a:txBody>
+                    <a:bodyPr wrap="square"/>
+                    <a:lstStyle/>
+                    <a:p>
+                      <a:r>
+                        <a:rPr sz="1100" b="0">
+                          <a:solidFill>
+                            <a:srgbClr val="282828"/>
+                          </a:solidFill>
+                          <a:latin typeface="Arial"/>
+                        </a:rPr>
+                        <a:t>s0 (engine-free)</a:t>
+                      </a:r>
+                    </a:p>
+                  </a:txBody>
+                  <a:tcPr marL="54864" marR="54864" marT="18288" marB="18288">
+                    <a:solidFill>
+                      <a:srgbClr val="FFFFFF"/>
+                    </a:solidFill>
+                  </a:tcPr>
+                </a:tc>
+                <a:tc>
+                  <a:txBody>
+                    <a:bodyPr wrap="square"/>
+                    <a:lstStyle/>
+                    <a:p>
+                      <a:r>
+                        <a:rPr sz="1100" b="0">
+                          <a:solidFill>
+                            <a:srgbClr val="282828"/>
+                          </a:solidFill>
+                          <a:latin typeface="Arial"/>
+                        </a:rPr>
+                        <a:t>dyson5_s0_scaling.txt</a:t>
+                      </a:r>
+                    </a:p>
+                  </a:txBody>
+                  <a:tcPr marL="54864" marR="54864" marT="18288" marB="18288">
+                    <a:solidFill>
+                      <a:srgbClr val="FFFFFF"/>
+                    </a:solidFill>
+                  </a:tcPr>
+                </a:tc>
+                <a:tc>
+                  <a:txBody>
+                    <a:bodyPr wrap="square"/>
+                    <a:lstStyle/>
+                    <a:p>
+                      <a:r>
+                        <a:rPr sz="1100" b="0">
+                          <a:solidFill>
+                            <a:srgbClr val="282828"/>
+                          </a:solidFill>
+                          <a:latin typeface="Arial"/>
+                        </a:rPr>
+                        <a:t>design/src/dyson_layout.m, dyson_scaling.m</a:t>
+                      </a:r>
+                    </a:p>
+                  </a:txBody>
+                  <a:tcPr marL="54864" marR="54864" marT="18288" marB="18288">
+                    <a:solidFill>
+                      <a:srgbClr val="FFFFFF"/>
+                    </a:solidFill>
+                  </a:tcPr>
+                </a:tc>
+              </a:tr>
+              <a:tr h="280035">
+                <a:tc>
+                  <a:txBody>
+                    <a:bodyPr wrap="square"/>
+                    <a:lstStyle/>
+                    <a:p>
+                      <a:r>
+                        <a:rPr sz="1100" b="0">
+                          <a:solidFill>
+                            <a:srgbClr val="282828"/>
+                          </a:solidFill>
+                          <a:latin typeface="Arial"/>
+                        </a:rPr>
+                        <a:t>as traced (every form)</a:t>
+                      </a:r>
+                    </a:p>
+                  </a:txBody>
+                  <a:tcPr marL="54864" marR="54864" marT="18288" marB="18288">
+                    <a:solidFill>
+                      <a:srgbClr val="ECF1F6"/>
+                    </a:solidFill>
+                  </a:tcPr>
+                </a:tc>
+                <a:tc>
+                  <a:txBody>
+                    <a:bodyPr wrap="square"/>
+                    <a:lstStyle/>
+                    <a:p>
+                      <a:r>
+                        <a:rPr sz="1100" b="0">
+                          <a:solidFill>
+                            <a:srgbClr val="282828"/>
+                          </a:solidFill>
+                          <a:latin typeface="Arial"/>
+                        </a:rPr>
+                        <a:t>dyson5_view_figs.m</a:t>
+                      </a:r>
+                    </a:p>
+                  </a:txBody>
+                  <a:tcPr marL="54864" marR="54864" marT="18288" marB="18288">
+                    <a:solidFill>
+                      <a:srgbClr val="ECF1F6"/>
+                    </a:solidFill>
+                  </a:tcPr>
+                </a:tc>
+                <a:tc>
+                  <a:txBody>
+                    <a:bodyPr wrap="square"/>
+                    <a:lstStyle/>
+                    <a:p>
+                      <a:r>
+                        <a:rPr sz="1100" b="0">
+                          <a:solidFill>
+                            <a:srgbClr val="282828"/>
+                          </a:solidFill>
+                          <a:latin typeface="Arial"/>
+                        </a:rPr>
+                        <a:t>_view3d.png, _viewyz.png</a:t>
+                      </a:r>
+                    </a:p>
+                  </a:txBody>
+                  <a:tcPr marL="54864" marR="54864" marT="18288" marB="18288">
+                    <a:solidFill>
+                      <a:srgbClr val="ECF1F6"/>
+                    </a:solidFill>
+                  </a:tcPr>
+                </a:tc>
+                <a:tc>
+                  <a:txBody>
+                    <a:bodyPr wrap="square"/>
+                    <a:lstStyle/>
+                    <a:p>
+                      <a:r>
+                        <a:rPr sz="1100" b="0">
+                          <a:solidFill>
+                            <a:srgbClr val="282828"/>
+                          </a:solidFill>
+                          <a:latin typeface="Arial"/>
+                        </a:rPr>
+                        <a:t>macos.view_rx on the deck</a:t>
+                      </a:r>
+                    </a:p>
+                  </a:txBody>
+                  <a:tcPr marL="54864" marR="54864" marT="18288" marB="18288">
+                    <a:solidFill>
+                      <a:srgbClr val="ECF1F6"/>
+                    </a:solidFill>
+                  </a:tcPr>
+                </a:tc>
+              </a:tr>
+              <a:tr h="468630">
+                <a:tc>
+                  <a:txBody>
+                    <a:bodyPr wrap="square"/>
+                    <a:lstStyle/>
+                    <a:p>
+                      <a:r>
+                        <a:rPr sz="1100" b="0">
+                          <a:solidFill>
+                            <a:srgbClr val="282828"/>
+                          </a:solidFill>
+                          <a:latin typeface="Arial"/>
+                        </a:rPr>
+                        <a:t>seed scored</a:t>
+                      </a:r>
+                    </a:p>
+                  </a:txBody>
+                  <a:tcPr marL="54864" marR="54864" marT="18288" marB="18288">
+                    <a:solidFill>
+                      <a:srgbClr val="FFFFFF"/>
+                    </a:solidFill>
+                  </a:tcPr>
+                </a:tc>
+                <a:tc>
+                  <a:txBody>
+                    <a:bodyPr wrap="square"/>
+                    <a:lstStyle/>
+                    <a:p>
+                      <a:r>
+                        <a:rPr sz="1100" b="0">
+                          <a:solidFill>
+                            <a:srgbClr val="282828"/>
+                          </a:solidFill>
+                          <a:latin typeface="Arial"/>
+                        </a:rPr>
+                        <a:t>s1 emit, s2 score</a:t>
+                      </a:r>
+                    </a:p>
+                  </a:txBody>
+                  <a:tcPr marL="54864" marR="54864" marT="18288" marB="18288">
+                    <a:solidFill>
+                      <a:srgbClr val="FFFFFF"/>
+                    </a:solidFill>
+                  </a:tcPr>
+                </a:tc>
+                <a:tc>
+                  <a:txBody>
+                    <a:bodyPr wrap="square"/>
+                    <a:lstStyle/>
+                    <a:p>
+                      <a:r>
+                        <a:rPr sz="1100" b="0">
+                          <a:solidFill>
+                            <a:srgbClr val="282828"/>
+                          </a:solidFill>
+                          <a:latin typeface="Arial"/>
+                        </a:rPr>
+                        <a:t>dyson5_s1.txt, dyson5_s2.txt, dyson5_s2_maps.png</a:t>
+                      </a:r>
+                    </a:p>
+                  </a:txBody>
+                  <a:tcPr marL="54864" marR="54864" marT="18288" marB="18288">
+                    <a:solidFill>
+                      <a:srgbClr val="FFFFFF"/>
+                    </a:solidFill>
+                  </a:tcPr>
+                </a:tc>
+                <a:tc>
+                  <a:txBody>
+                    <a:bodyPr wrap="square"/>
+                    <a:lstStyle/>
+                    <a:p>
+                      <a:r>
+                        <a:rPr sz="1100" b="0">
+                          <a:solidFill>
+                            <a:srgbClr val="282828"/>
+                          </a:solidFill>
+                          <a:latin typeface="Arial"/>
+                        </a:rPr>
+                        <a:t>spectrometer_geom.m, spectrometer_rx.m, spectrometer_score.m</a:t>
+                      </a:r>
+                    </a:p>
+                  </a:txBody>
+                  <a:tcPr marL="54864" marR="54864" marT="18288" marB="18288">
+                    <a:solidFill>
+                      <a:srgbClr val="FFFFFF"/>
+                    </a:solidFill>
+                  </a:tcPr>
+                </a:tc>
+              </a:tr>
+              <a:tr h="280035">
+                <a:tc>
+                  <a:txBody>
+                    <a:bodyPr wrap="square"/>
+                    <a:lstStyle/>
+                    <a:p>
+                      <a:r>
+                        <a:rPr sz="1100" b="0">
+                          <a:solidFill>
+                            <a:srgbClr val="282828"/>
+                          </a:solidFill>
+                          <a:latin typeface="Arial"/>
+                        </a:rPr>
+                        <a:t>chain vs engine</a:t>
+                      </a:r>
+                    </a:p>
+                  </a:txBody>
+                  <a:tcPr marL="54864" marR="54864" marT="18288" marB="18288">
+                    <a:solidFill>
+                      <a:srgbClr val="ECF1F6"/>
+                    </a:solidFill>
+                  </a:tcPr>
+                </a:tc>
+                <a:tc>
+                  <a:txBody>
+                    <a:bodyPr wrap="square"/>
+                    <a:lstStyle/>
+                    <a:p>
+                      <a:r>
+                        <a:rPr sz="1100" b="0">
+                          <a:solidFill>
+                            <a:srgbClr val="282828"/>
+                          </a:solidFill>
+                          <a:latin typeface="Arial"/>
+                        </a:rPr>
+                        <a:t>gate</a:t>
+                      </a:r>
+                    </a:p>
+                  </a:txBody>
+                  <a:tcPr marL="54864" marR="54864" marT="18288" marB="18288">
+                    <a:solidFill>
+                      <a:srgbClr val="ECF1F6"/>
+                    </a:solidFill>
+                  </a:tcPr>
+                </a:tc>
+                <a:tc>
+                  <a:txBody>
+                    <a:bodyPr wrap="square"/>
+                    <a:lstStyle/>
+                    <a:p>
+                      <a:r>
+                        <a:rPr sz="1100" b="0">
+                          <a:solidFill>
+                            <a:srgbClr val="282828"/>
+                          </a:solidFill>
+                          <a:latin typeface="Arial"/>
+                        </a:rPr>
+                        <a:t>tests/tSpectrometerRx.m</a:t>
+                      </a:r>
+                    </a:p>
+                  </a:txBody>
+                  <a:tcPr marL="54864" marR="54864" marT="18288" marB="18288">
+                    <a:solidFill>
+                      <a:srgbClr val="ECF1F6"/>
+                    </a:solidFill>
+                  </a:tcPr>
+                </a:tc>
+                <a:tc>
+                  <a:txBody>
+                    <a:bodyPr wrap="square"/>
+                    <a:lstStyle/>
+                    <a:p>
+                      <a:r>
+                        <a:rPr sz="1100" b="0">
+                          <a:solidFill>
+                            <a:srgbClr val="282828"/>
+                          </a:solidFill>
+                          <a:latin typeface="Arial"/>
+                        </a:rPr>
+                        <a:t>per-ray re-trace, 1e-9 m</a:t>
+                      </a:r>
+                    </a:p>
+                  </a:txBody>
+                  <a:tcPr marL="54864" marR="54864" marT="18288" marB="18288">
+                    <a:solidFill>
+                      <a:srgbClr val="ECF1F6"/>
+                    </a:solidFill>
+                  </a:tcPr>
+                </a:tc>
+              </a:tr>
+              <a:tr h="280035">
+                <a:tc>
+                  <a:txBody>
+                    <a:bodyPr wrap="square"/>
+                    <a:lstStyle/>
+                    <a:p>
+                      <a:r>
+                        <a:rPr sz="1100" b="0">
+                          <a:solidFill>
+                            <a:srgbClr val="282828"/>
+                          </a:solidFill>
+                          <a:latin typeface="Arial"/>
+                        </a:rPr>
+                        <a:t>propagation twin</a:t>
+                      </a:r>
+                    </a:p>
+                  </a:txBody>
+                  <a:tcPr marL="54864" marR="54864" marT="18288" marB="18288">
+                    <a:solidFill>
+                      <a:srgbClr val="FFFFFF"/>
+                    </a:solidFill>
+                  </a:tcPr>
+                </a:tc>
+                <a:tc>
+                  <a:txBody>
+                    <a:bodyPr wrap="square"/>
+                    <a:lstStyle/>
+                    <a:p>
+                      <a:r>
+                        <a:rPr sz="1100" b="0">
+                          <a:solidFill>
+                            <a:srgbClr val="282828"/>
+                          </a:solidFill>
+                          <a:latin typeface="Arial"/>
+                        </a:rPr>
+                        <a:t>s2w (opt-in, model 512)</a:t>
+                      </a:r>
+                    </a:p>
+                  </a:txBody>
+                  <a:tcPr marL="54864" marR="54864" marT="18288" marB="18288">
+                    <a:solidFill>
+                      <a:srgbClr val="FFFFFF"/>
+                    </a:solidFill>
+                  </a:tcPr>
+                </a:tc>
+                <a:tc>
+                  <a:txBody>
+                    <a:bodyPr wrap="square"/>
+                    <a:lstStyle/>
+                    <a:p>
+                      <a:r>
+                        <a:rPr sz="1100" b="0">
+                          <a:solidFill>
+                            <a:srgbClr val="282828"/>
+                          </a:solidFill>
+                          <a:latin typeface="Arial"/>
+                        </a:rPr>
+                        <a:t>dyson5_s2w.txt</a:t>
+                      </a:r>
+                    </a:p>
+                  </a:txBody>
+                  <a:tcPr marL="54864" marR="54864" marT="18288" marB="18288">
+                    <a:solidFill>
+                      <a:srgbClr val="FFFFFF"/>
+                    </a:solidFill>
+                  </a:tcPr>
+                </a:tc>
+                <a:tc>
+                  <a:txBody>
+                    <a:bodyPr wrap="square"/>
+                    <a:lstStyle/>
+                    <a:p>
+                      <a:r>
+                        <a:rPr sz="1100" b="0">
+                          <a:solidFill>
+                            <a:srgbClr val="282828"/>
+                          </a:solidFill>
+                          <a:latin typeface="Arial"/>
+                        </a:rPr>
+                        <a:t>spectrometer_wave.m</a:t>
+                      </a:r>
+                    </a:p>
+                  </a:txBody>
+                  <a:tcPr marL="54864" marR="54864" marT="18288" marB="18288">
+                    <a:solidFill>
+                      <a:srgbClr val="FFFFFF"/>
+                    </a:solidFill>
+                  </a:tcPr>
+                </a:tc>
+              </a:tr>
+              <a:tr h="657225">
+                <a:tc>
+                  <a:txBody>
+                    <a:bodyPr wrap="square"/>
+                    <a:lstStyle/>
+                    <a:p>
+                      <a:r>
+                        <a:rPr sz="1100" b="0">
+                          <a:solidFill>
+                            <a:srgbClr val="282828"/>
+                          </a:solidFill>
+                          <a:latin typeface="Arial"/>
+                        </a:rPr>
+                        <a:t>departure ladder, R4, trade</a:t>
+                      </a:r>
+                    </a:p>
+                  </a:txBody>
+                  <a:tcPr marL="54864" marR="54864" marT="18288" marB="18288">
+                    <a:solidFill>
+                      <a:srgbClr val="ECF1F6"/>
+                    </a:solidFill>
+                  </a:tcPr>
+                </a:tc>
+                <a:tc>
+                  <a:txBody>
+                    <a:bodyPr wrap="square"/>
+                    <a:lstStyle/>
+                    <a:p>
+                      <a:r>
+                        <a:rPr sz="1100" b="0">
+                          <a:solidFill>
+                            <a:srgbClr val="282828"/>
+                          </a:solidFill>
+                          <a:latin typeface="Arial"/>
+                        </a:rPr>
+                        <a:t>s3, s3free, s3b</a:t>
+                      </a:r>
+                    </a:p>
+                  </a:txBody>
+                  <a:tcPr marL="54864" marR="54864" marT="18288" marB="18288">
+                    <a:solidFill>
+                      <a:srgbClr val="ECF1F6"/>
+                    </a:solidFill>
+                  </a:tcPr>
+                </a:tc>
+                <a:tc>
+                  <a:txBody>
+                    <a:bodyPr wrap="square"/>
+                    <a:lstStyle/>
+                    <a:p>
+                      <a:r>
+                        <a:rPr sz="1100" b="0">
+                          <a:solidFill>
+                            <a:srgbClr val="282828"/>
+                          </a:solidFill>
+                          <a:latin typeface="Arial"/>
+                        </a:rPr>
+                        <a:t>dyson5_s3.txt, dyson5_s3free.txt, dyson5_s3_trade.txt, dyson5_s3_layout_r.png, dyson5_s3_maps_r.png</a:t>
+                      </a:r>
+                    </a:p>
+                  </a:txBody>
+                  <a:tcPr marL="54864" marR="54864" marT="18288" marB="18288">
+                    <a:solidFill>
+                      <a:srgbClr val="ECF1F6"/>
+                    </a:solidFill>
+                  </a:tcPr>
+                </a:tc>
+                <a:tc>
+                  <a:txBody>
+                    <a:bodyPr wrap="square"/>
+                    <a:lstStyle/>
+                    <a:p>
+                      <a:r>
+                        <a:rPr sz="1100" b="0">
+                          <a:solidFill>
+                            <a:srgbClr val="282828"/>
+                          </a:solidFill>
+                          <a:latin typeface="Arial"/>
+                        </a:rPr>
+                        <a:t>dyson_ladder.m, dyson5_trade.m</a:t>
+                      </a:r>
+                    </a:p>
+                  </a:txBody>
+                  <a:tcPr marL="54864" marR="54864" marT="18288" marB="18288">
+                    <a:solidFill>
+                      <a:srgbClr val="ECF1F6"/>
+                    </a:solidFill>
+                  </a:tcPr>
+                </a:tc>
+              </a:tr>
+              <a:tr h="280035">
+                <a:tc>
+                  <a:txBody>
+                    <a:bodyPr wrap="square"/>
+                    <a:lstStyle/>
+                    <a:p>
+                      <a:r>
+                        <a:rPr sz="1100" b="0">
+                          <a:solidFill>
+                            <a:srgbClr val="282828"/>
+                          </a:solidFill>
+                          <a:latin typeface="Arial"/>
+                        </a:rPr>
+                        <a:t>meniscus search</a:t>
+                      </a:r>
+                    </a:p>
+                  </a:txBody>
+                  <a:tcPr marL="54864" marR="54864" marT="18288" marB="18288">
+                    <a:solidFill>
+                      <a:srgbClr val="FFFFFF"/>
+                    </a:solidFill>
+                  </a:tcPr>
+                </a:tc>
+                <a:tc>
+                  <a:txBody>
+                    <a:bodyPr wrap="square"/>
+                    <a:lstStyle/>
+                    <a:p>
+                      <a:r>
+                        <a:rPr sz="1100" b="0">
+                          <a:solidFill>
+                            <a:srgbClr val="282828"/>
+                          </a:solidFill>
+                          <a:latin typeface="Arial"/>
+                        </a:rPr>
+                        <a:t>tool</a:t>
+                      </a:r>
+                    </a:p>
+                  </a:txBody>
+                  <a:tcPr marL="54864" marR="54864" marT="18288" marB="18288">
+                    <a:solidFill>
+                      <a:srgbClr val="FFFFFF"/>
+                    </a:solidFill>
+                  </a:tcPr>
+                </a:tc>
+                <a:tc>
+                  <a:txBody>
+                    <a:bodyPr wrap="square"/>
+                    <a:lstStyle/>
+                    <a:p>
+                      <a:r>
+                        <a:rPr sz="1100" b="0">
+                          <a:solidFill>
+                            <a:srgbClr val="282828"/>
+                          </a:solidFill>
+                          <a:latin typeface="Arial"/>
+                        </a:rPr>
+                        <a:t>dyson5_s3_r4global.txt</a:t>
+                      </a:r>
+                    </a:p>
+                  </a:txBody>
+                  <a:tcPr marL="54864" marR="54864" marT="18288" marB="18288">
+                    <a:solidFill>
+                      <a:srgbClr val="FFFFFF"/>
+                    </a:solidFill>
+                  </a:tcPr>
+                </a:tc>
+                <a:tc>
+                  <a:txBody>
+                    <a:bodyPr wrap="square"/>
+                    <a:lstStyle/>
+                    <a:p>
+                      <a:r>
+                        <a:rPr sz="1100" b="0">
+                          <a:solidFill>
+                            <a:srgbClr val="282828"/>
+                          </a:solidFill>
+                          <a:latin typeface="Arial"/>
+                        </a:rPr>
+                        <a:t>dyson_r4_global.m</a:t>
+                      </a:r>
+                    </a:p>
+                  </a:txBody>
+                  <a:tcPr marL="54864" marR="54864" marT="18288" marB="18288">
+                    <a:solidFill>
+                      <a:srgbClr val="FFFFFF"/>
+                    </a:solidFill>
+                  </a:tcPr>
+                </a:tc>
+              </a:tr>
+              <a:tr h="468630">
+                <a:tc>
+                  <a:txBody>
+                    <a:bodyPr wrap="square"/>
+                    <a:lstStyle/>
+                    <a:p>
+                      <a:r>
+                        <a:rPr sz="1100" b="0">
+                          <a:solidFill>
+                            <a:srgbClr val="282828"/>
+                          </a:solidFill>
+                          <a:latin typeface="Arial"/>
+                        </a:rPr>
+                        <a:t>slit loss</a:t>
+                      </a:r>
+                    </a:p>
+                  </a:txBody>
+                  <a:tcPr marL="54864" marR="54864" marT="18288" marB="18288">
+                    <a:solidFill>
+                      <a:srgbClr val="ECF1F6"/>
+                    </a:solidFill>
+                  </a:tcPr>
+                </a:tc>
+                <a:tc>
+                  <a:txBody>
+                    <a:bodyPr wrap="square"/>
+                    <a:lstStyle/>
+                    <a:p>
+                      <a:r>
+                        <a:rPr sz="1100" b="0">
+                          <a:solidFill>
+                            <a:srgbClr val="282828"/>
+                          </a:solidFill>
+                          <a:latin typeface="Arial"/>
+                        </a:rPr>
+                        <a:t>s2l + tool</a:t>
+                      </a:r>
+                    </a:p>
+                  </a:txBody>
+                  <a:tcPr marL="54864" marR="54864" marT="18288" marB="18288">
+                    <a:solidFill>
+                      <a:srgbClr val="ECF1F6"/>
+                    </a:solidFill>
+                  </a:tcPr>
+                </a:tc>
+                <a:tc>
+                  <a:txBody>
+                    <a:bodyPr wrap="square"/>
+                    <a:lstStyle/>
+                    <a:p>
+                      <a:r>
+                        <a:rPr sz="1100" b="0">
+                          <a:solidFill>
+                            <a:srgbClr val="282828"/>
+                          </a:solidFill>
+                          <a:latin typeface="Arial"/>
+                        </a:rPr>
+                        <a:t>dyson5_s2l.txt, dyson5_s2l_tests.txt, dyson5_s2l_slitloss.png</a:t>
+                      </a:r>
+                    </a:p>
+                  </a:txBody>
+                  <a:tcPr marL="54864" marR="54864" marT="18288" marB="18288">
+                    <a:solidFill>
+                      <a:srgbClr val="ECF1F6"/>
+                    </a:solidFill>
+                  </a:tcPr>
+                </a:tc>
+                <a:tc>
+                  <a:txBody>
+                    <a:bodyPr wrap="square"/>
+                    <a:lstStyle/>
+                    <a:p>
+                      <a:r>
+                        <a:rPr sz="1100" b="0">
+                          <a:solidFill>
+                            <a:srgbClr val="282828"/>
+                          </a:solidFill>
+                          <a:latin typeface="Arial"/>
+                        </a:rPr>
+                        <a:t>far-field leg vs sinc²; dyson5_slitloss_tests.m</a:t>
+                      </a:r>
+                    </a:p>
+                  </a:txBody>
+                  <a:tcPr marL="54864" marR="54864" marT="18288" marB="18288">
+                    <a:solidFill>
+                      <a:srgbClr val="ECF1F6"/>
+                    </a:solidFill>
+                  </a:tcPr>
+                </a:tc>
+              </a:tr>
+              <a:tr h="468630">
+                <a:tc>
+                  <a:txBody>
+                    <a:bodyPr wrap="square"/>
+                    <a:lstStyle/>
+                    <a:p>
+                      <a:r>
+                        <a:rPr sz="1100" b="0">
+                          <a:solidFill>
+                            <a:srgbClr val="282828"/>
+                          </a:solidFill>
+                          <a:latin typeface="Arial"/>
+                        </a:rPr>
+                        <a:t>fold prism, cold shield</a:t>
+                      </a:r>
+                    </a:p>
+                  </a:txBody>
+                  <a:tcPr marL="54864" marR="54864" marT="18288" marB="18288">
+                    <a:solidFill>
+                      <a:srgbClr val="FFFFFF"/>
+                    </a:solidFill>
+                  </a:tcPr>
+                </a:tc>
+                <a:tc>
+                  <a:txBody>
+                    <a:bodyPr wrap="square"/>
+                    <a:lstStyle/>
+                    <a:p>
+                      <a:r>
+                        <a:rPr sz="1100" b="0">
+                          <a:solidFill>
+                            <a:srgbClr val="282828"/>
+                          </a:solidFill>
+                          <a:latin typeface="Arial"/>
+                        </a:rPr>
+                        <a:t>s5</a:t>
+                      </a:r>
+                    </a:p>
+                  </a:txBody>
+                  <a:tcPr marL="54864" marR="54864" marT="18288" marB="18288">
+                    <a:solidFill>
+                      <a:srgbClr val="FFFFFF"/>
+                    </a:solidFill>
+                  </a:tcPr>
+                </a:tc>
+                <a:tc>
+                  <a:txBody>
+                    <a:bodyPr wrap="square"/>
+                    <a:lstStyle/>
+                    <a:p>
+                      <a:r>
+                        <a:rPr sz="1100" b="0">
+                          <a:solidFill>
+                            <a:srgbClr val="282828"/>
+                          </a:solidFill>
+                          <a:latin typeface="Arial"/>
+                        </a:rPr>
+                        <a:t>dyson5_s5.txt, dyson5_s5_r5_h*.in, dyson5_s5_maps_r5.png, dyson5_s5_sweep.png</a:t>
+                      </a:r>
+                    </a:p>
+                  </a:txBody>
+                  <a:tcPr marL="54864" marR="54864" marT="18288" marB="18288">
+                    <a:solidFill>
+                      <a:srgbClr val="FFFFFF"/>
+                    </a:solidFill>
+                  </a:tcPr>
+                </a:tc>
+                <a:tc>
+                  <a:txBody>
+                    <a:bodyPr wrap="square"/>
+                    <a:lstStyle/>
+                    <a:p>
+                      <a:r>
+                        <a:rPr sz="1100" b="0">
+                          <a:solidFill>
+                            <a:srgbClr val="282828"/>
+                          </a:solidFill>
+                          <a:latin typeface="Arial"/>
+                        </a:rPr>
+                        <a:t>spectrometer_geom.m (form dyson_fold), spectrometer_clearance.m</a:t>
+                      </a:r>
+                    </a:p>
+                  </a:txBody>
+                  <a:tcPr marL="54864" marR="54864" marT="18288" marB="18288">
+                    <a:solidFill>
+                      <a:srgbClr val="FFFFFF"/>
+                    </a:solidFill>
+                  </a:tcPr>
+                </a:tc>
+              </a:tr>
+              <a:tr h="468630">
+                <a:tc>
+                  <a:txBody>
+                    <a:bodyPr wrap="square"/>
+                    <a:lstStyle/>
+                    <a:p>
+                      <a:r>
+                        <a:rPr sz="1100" b="0">
+                          <a:solidFill>
+                            <a:srgbClr val="282828"/>
+                          </a:solidFill>
+                          <a:latin typeface="Arial"/>
+                        </a:rPr>
+                        <a:t>closure envelope</a:t>
+                      </a:r>
+                    </a:p>
+                  </a:txBody>
+                  <a:tcPr marL="54864" marR="54864" marT="18288" marB="18288">
+                    <a:solidFill>
+                      <a:srgbClr val="ECF1F6"/>
+                    </a:solidFill>
+                  </a:tcPr>
+                </a:tc>
+                <a:tc>
+                  <a:txBody>
+                    <a:bodyPr wrap="square"/>
+                    <a:lstStyle/>
+                    <a:p>
+                      <a:r>
+                        <a:rPr sz="1100" b="0">
+                          <a:solidFill>
+                            <a:srgbClr val="282828"/>
+                          </a:solidFill>
+                          <a:latin typeface="Arial"/>
+                        </a:rPr>
+                        <a:t>s4env</a:t>
+                      </a:r>
+                    </a:p>
+                  </a:txBody>
+                  <a:tcPr marL="54864" marR="54864" marT="18288" marB="18288">
+                    <a:solidFill>
+                      <a:srgbClr val="ECF1F6"/>
+                    </a:solidFill>
+                  </a:tcPr>
+                </a:tc>
+                <a:tc>
+                  <a:txBody>
+                    <a:bodyPr wrap="square"/>
+                    <a:lstStyle/>
+                    <a:p>
+                      <a:r>
+                        <a:rPr sz="1100" b="0">
+                          <a:solidFill>
+                            <a:srgbClr val="282828"/>
+                          </a:solidFill>
+                          <a:latin typeface="Arial"/>
+                        </a:rPr>
+                        <a:t>dyson5_s4env.txt, dyson5_s4env.png, dyson5_s4env_*.in</a:t>
+                      </a:r>
+                    </a:p>
+                  </a:txBody>
+                  <a:tcPr marL="54864" marR="54864" marT="18288" marB="18288">
+                    <a:solidFill>
+                      <a:srgbClr val="ECF1F6"/>
+                    </a:solidFill>
+                  </a:tcPr>
+                </a:tc>
+                <a:tc>
+                  <a:txBody>
+                    <a:bodyPr wrap="square"/>
+                    <a:lstStyle/>
+                    <a:p>
+                      <a:r>
+                        <a:rPr sz="1100" b="0">
+                          <a:solidFill>
+                            <a:srgbClr val="282828"/>
+                          </a:solidFill>
+                          <a:latin typeface="Arial"/>
+                        </a:rPr>
+                        <a:t>dyson5_envelope.m</a:t>
+                      </a:r>
+                    </a:p>
+                  </a:txBody>
+                  <a:tcPr marL="54864" marR="54864" marT="18288" marB="18288">
+                    <a:solidFill>
+                      <a:srgbClr val="ECF1F6"/>
+                    </a:solidFill>
+                  </a:tcPr>
+                </a:tc>
+              </a:tr>
+              <a:tr h="468630">
+                <a:tc>
+                  <a:txBody>
+                    <a:bodyPr wrap="square"/>
+                    <a:lstStyle/>
+                    <a:p>
+                      <a:r>
+                        <a:rPr sz="1100" b="0">
+                          <a:solidFill>
+                            <a:srgbClr val="282828"/>
+                          </a:solidFill>
+                          <a:latin typeface="Arial"/>
+                        </a:rPr>
+                        <a:t>native optimizer</a:t>
+                      </a:r>
+                    </a:p>
+                  </a:txBody>
+                  <a:tcPr marL="54864" marR="54864" marT="18288" marB="18288">
+                    <a:solidFill>
+                      <a:srgbClr val="FFFFFF"/>
+                    </a:solidFill>
+                  </a:tcPr>
+                </a:tc>
+                <a:tc>
+                  <a:txBody>
+                    <a:bodyPr wrap="square"/>
+                    <a:lstStyle/>
+                    <a:p>
+                      <a:r>
+                        <a:rPr sz="1100" b="0">
+                          <a:solidFill>
+                            <a:srgbClr val="282828"/>
+                          </a:solidFill>
+                          <a:latin typeface="Arial"/>
+                        </a:rPr>
+                        <a:t>s4</a:t>
+                      </a:r>
+                    </a:p>
+                  </a:txBody>
+                  <a:tcPr marL="54864" marR="54864" marT="18288" marB="18288">
+                    <a:solidFill>
+                      <a:srgbClr val="FFFFFF"/>
+                    </a:solidFill>
+                  </a:tcPr>
+                </a:tc>
+                <a:tc>
+                  <a:txBody>
+                    <a:bodyPr wrap="square"/>
+                    <a:lstStyle/>
+                    <a:p>
+                      <a:r>
+                        <a:rPr sz="1100" b="0">
+                          <a:solidFill>
+                            <a:srgbClr val="282828"/>
+                          </a:solidFill>
+                          <a:latin typeface="Arial"/>
+                        </a:rPr>
+                        <a:t>dyson5_s4.txt, dyson5_s4_r4n_seed.in (the CALIB deck), dyson5_s4_r4n.in</a:t>
+                      </a:r>
+                    </a:p>
+                  </a:txBody>
+                  <a:tcPr marL="54864" marR="54864" marT="18288" marB="18288">
+                    <a:solidFill>
+                      <a:srgbClr val="FFFFFF"/>
+                    </a:solidFill>
+                  </a:tcPr>
+                </a:tc>
+                <a:tc>
+                  <a:txBody>
+                    <a:bodyPr wrap="square"/>
+                    <a:lstStyle/>
+                    <a:p>
+                      <a:r>
+                        <a:rPr sz="1100" b="0">
+                          <a:solidFill>
+                            <a:srgbClr val="282828"/>
+                          </a:solidFill>
+                          <a:latin typeface="Arial"/>
+                        </a:rPr>
+                        <a:t>dyson_native.m</a:t>
+                      </a:r>
+                    </a:p>
+                  </a:txBody>
+                  <a:tcPr marL="54864" marR="54864" marT="18288" marB="18288">
+                    <a:solidFill>
+                      <a:srgbClr val="FFFFFF"/>
+                    </a:solidFill>
+                  </a:tcPr>
+                </a:tc>
+              </a:tr>
+              <a:tr h="468630">
+                <a:tc>
+                  <a:txBody>
+                    <a:bodyPr wrap="square"/>
+                    <a:lstStyle/>
+                    <a:p>
+                      <a:r>
+                        <a:rPr sz="1100" b="0">
+                          <a:solidFill>
+                            <a:srgbClr val="282828"/>
+                          </a:solidFill>
+                          <a:latin typeface="Arial"/>
+                        </a:rPr>
+                        <a:t>block-size trade</a:t>
+                      </a:r>
+                    </a:p>
+                  </a:txBody>
+                  <a:tcPr marL="54864" marR="54864" marT="18288" marB="18288">
+                    <a:solidFill>
+                      <a:srgbClr val="ECF1F6"/>
+                    </a:solidFill>
+                  </a:tcPr>
+                </a:tc>
+                <a:tc>
+                  <a:txBody>
+                    <a:bodyPr wrap="square"/>
+                    <a:lstStyle/>
+                    <a:p>
+                      <a:r>
+                        <a:rPr sz="1100" b="0">
+                          <a:solidFill>
+                            <a:srgbClr val="282828"/>
+                          </a:solidFill>
+                          <a:latin typeface="Arial"/>
+                        </a:rPr>
+                        <a:t>dyson5_size_trade.m</a:t>
+                      </a:r>
+                    </a:p>
+                  </a:txBody>
+                  <a:tcPr marL="54864" marR="54864" marT="18288" marB="18288">
+                    <a:solidFill>
+                      <a:srgbClr val="ECF1F6"/>
+                    </a:solidFill>
+                  </a:tcPr>
+                </a:tc>
+                <a:tc>
+                  <a:txBody>
+                    <a:bodyPr wrap="square"/>
+                    <a:lstStyle/>
+                    <a:p>
+                      <a:r>
+                        <a:rPr sz="1100" b="0">
+                          <a:solidFill>
+                            <a:srgbClr val="282828"/>
+                          </a:solidFill>
+                          <a:latin typeface="Arial"/>
+                        </a:rPr>
+                        <a:t>dyson5_size.txt, dyson5_size.png, dyson5_size_*.in, BRIEF_dyson5_size.md</a:t>
+                      </a:r>
+                    </a:p>
+                  </a:txBody>
+                  <a:tcPr marL="54864" marR="54864" marT="18288" marB="18288">
+                    <a:solidFill>
+                      <a:srgbClr val="ECF1F6"/>
+                    </a:solidFill>
+                  </a:tcPr>
+                </a:tc>
+                <a:tc>
+                  <a:txBody>
+                    <a:bodyPr wrap="square"/>
+                    <a:lstStyle/>
+                    <a:p>
+                      <a:r>
+                        <a:rPr sz="1100" b="0">
+                          <a:solidFill>
+                            <a:srgbClr val="282828"/>
+                          </a:solidFill>
+                          <a:latin typeface="Arial"/>
+                        </a:rPr>
+                        <a:t>continuation walks over dyson_ladder.m</a:t>
+                      </a:r>
+                    </a:p>
+                  </a:txBody>
+                  <a:tcPr marL="54864" marR="54864" marT="18288" marB="18288">
+                    <a:solidFill>
+                      <a:srgbClr val="ECF1F6"/>
+                    </a:solidFill>
+                  </a:tcPr>
+                </a:tc>
+              </a:tr>
+              <a:tr h="468630">
+                <a:tc>
+                  <a:txBody>
+                    <a:bodyPr wrap="square"/>
+                    <a:lstStyle/>
+                    <a:p>
+                      <a:r>
+                        <a:rPr sz="1100" b="0">
+                          <a:solidFill>
+                            <a:srgbClr val="282828"/>
+                          </a:solidFill>
+                          <a:latin typeface="Arial"/>
+                        </a:rPr>
+                        <a:t>telescope, three-mirror at Jim's numbers</a:t>
+                      </a:r>
+                    </a:p>
+                  </a:txBody>
+                  <a:tcPr marL="54864" marR="54864" marT="18288" marB="18288">
+                    <a:solidFill>
+                      <a:srgbClr val="FFFFFF"/>
+                    </a:solidFill>
+                  </a:tcPr>
+                </a:tc>
+                <a:tc>
+                  <a:txBody>
+                    <a:bodyPr wrap="square"/>
+                    <a:lstStyle/>
+                    <a:p>
+                      <a:r>
+                        <a:rPr sz="1100" b="0">
+                          <a:solidFill>
+                            <a:srgbClr val="282828"/>
+                          </a:solidFill>
+                          <a:latin typeface="Arial"/>
+                        </a:rPr>
+                        <a:t>t3s, t3w, t3o, t3e</a:t>
+                      </a:r>
+                    </a:p>
+                  </a:txBody>
+                  <a:tcPr marL="54864" marR="54864" marT="18288" marB="18288">
+                    <a:solidFill>
+                      <a:srgbClr val="FFFFFF"/>
+                    </a:solidFill>
+                  </a:tcPr>
+                </a:tc>
+                <a:tc>
+                  <a:txBody>
+                    <a:bodyPr wrap="square"/>
+                    <a:lstStyle/>
+                    <a:p>
+                      <a:r>
+                        <a:rPr sz="1100" b="0">
+                          <a:solidFill>
+                            <a:srgbClr val="282828"/>
+                          </a:solidFill>
+                          <a:latin typeface="Arial"/>
+                        </a:rPr>
+                        <a:t>dyson5_t3*.txt, BRIEF_dyson5_beat5c.md</a:t>
+                      </a:r>
+                    </a:p>
+                  </a:txBody>
+                  <a:tcPr marL="54864" marR="54864" marT="18288" marB="18288">
+                    <a:solidFill>
+                      <a:srgbClr val="FFFFFF"/>
+                    </a:solidFill>
+                  </a:tcPr>
+                </a:tc>
+                <a:tc>
+                  <a:txBody>
+                    <a:bodyPr wrap="square"/>
+                    <a:lstStyle/>
+                    <a:p>
+                      <a:r>
+                        <a:rPr sz="1100" b="0">
+                          <a:solidFill>
+                            <a:srgbClr val="282828"/>
+                          </a:solidFill>
+                          <a:latin typeface="Arial"/>
+                        </a:rPr>
+                        <a:t>tma_screen, the offset solves on telescope_geom.m</a:t>
+                      </a:r>
+                    </a:p>
+                  </a:txBody>
+                  <a:tcPr marL="54864" marR="54864" marT="18288" marB="18288">
+                    <a:solidFill>
+                      <a:srgbClr val="FFFFFF"/>
+                    </a:solidFill>
+                  </a:tcPr>
+                </a:tc>
+              </a:tr>
+              <a:tr h="468630">
+                <a:tc>
+                  <a:txBody>
+                    <a:bodyPr wrap="square"/>
+                    <a:lstStyle/>
+                    <a:p>
+                      <a:r>
+                        <a:rPr sz="1100" b="0">
+                          <a:solidFill>
+                            <a:srgbClr val="282828"/>
+                          </a:solidFill>
+                          <a:latin typeface="Arial"/>
+                        </a:rPr>
+                        <a:t>telescope, modified Schwarzschild</a:t>
+                      </a:r>
+                    </a:p>
+                  </a:txBody>
+                  <a:tcPr marL="54864" marR="54864" marT="18288" marB="18288">
+                    <a:solidFill>
+                      <a:srgbClr val="ECF1F6"/>
+                    </a:solidFill>
+                  </a:tcPr>
+                </a:tc>
+                <a:tc>
+                  <a:txBody>
+                    <a:bodyPr wrap="square"/>
+                    <a:lstStyle/>
+                    <a:p>
+                      <a:r>
+                        <a:rPr sz="1100" b="0">
+                          <a:solidFill>
+                            <a:srgbClr val="282828"/>
+                          </a:solidFill>
+                          <a:latin typeface="Arial"/>
+                        </a:rPr>
+                        <a:t>t4</a:t>
+                      </a:r>
+                    </a:p>
+                  </a:txBody>
+                  <a:tcPr marL="54864" marR="54864" marT="18288" marB="18288">
+                    <a:solidFill>
+                      <a:srgbClr val="ECF1F6"/>
+                    </a:solidFill>
+                  </a:tcPr>
+                </a:tc>
+                <a:tc>
+                  <a:txBody>
+                    <a:bodyPr wrap="square"/>
+                    <a:lstStyle/>
+                    <a:p>
+                      <a:r>
+                        <a:rPr sz="1100" b="0">
+                          <a:solidFill>
+                            <a:srgbClr val="282828"/>
+                          </a:solidFill>
+                          <a:latin typeface="Arial"/>
+                        </a:rPr>
+                        <a:t>dyson5_t4.txt, dyson5_t4_r2c_.in, _view.png</a:t>
+                      </a:r>
+                    </a:p>
+                  </a:txBody>
+                  <a:tcPr marL="54864" marR="54864" marT="18288" marB="18288">
+                    <a:solidFill>
+                      <a:srgbClr val="ECF1F6"/>
+                    </a:solidFill>
+                  </a:tcPr>
+                </a:tc>
+                <a:tc>
+                  <a:txBody>
+                    <a:bodyPr wrap="square"/>
+                    <a:lstStyle/>
+                    <a:p>
+                      <a:r>
+                        <a:rPr sz="1100" b="0">
+                          <a:solidFill>
+                            <a:srgbClr val="282828"/>
+                          </a:solidFill>
+                          <a:latin typeface="Arial"/>
+                        </a:rPr>
+                        <a:t>tms_paraxial.m, tms_firstorder.m, tms_geom.m, tms_clear.m</a:t>
+                      </a:r>
+                    </a:p>
+                  </a:txBody>
+                  <a:tcPr marL="54864" marR="54864" marT="18288" marB="18288">
+                    <a:solidFill>
+                      <a:srgbClr val="ECF1F6"/>
+                    </a:solidFill>
+                  </a:tcPr>
+                </a:tc>
+              </a:tr>
+              <a:tr h="468630">
+                <a:tc>
+                  <a:txBody>
+                    <a:bodyPr wrap="square"/>
+                    <a:lstStyle/>
+                    <a:p>
+                      <a:r>
+                        <a:rPr sz="1100" b="0">
+                          <a:solidFill>
+                            <a:srgbClr val="282828"/>
+                          </a:solidFill>
+                          <a:latin typeface="Arial"/>
+                        </a:rPr>
+                        <a:t>telescope, TMA parent by the design layer</a:t>
+                      </a:r>
+                    </a:p>
+                  </a:txBody>
+                  <a:tcPr marL="54864" marR="54864" marT="18288" marB="18288">
+                    <a:solidFill>
+                      <a:srgbClr val="FFFFFF"/>
+                    </a:solidFill>
+                  </a:tcPr>
+                </a:tc>
+                <a:tc>
+                  <a:txBody>
+                    <a:bodyPr wrap="square"/>
+                    <a:lstStyle/>
+                    <a:p>
+                      <a:r>
+                        <a:rPr sz="1100" b="0">
+                          <a:solidFill>
+                            <a:srgbClr val="282828"/>
+                          </a:solidFill>
+                          <a:latin typeface="Arial"/>
+                        </a:rPr>
+                        <a:t>dyson5_tma_step1.m</a:t>
+                      </a:r>
+                    </a:p>
+                  </a:txBody>
+                  <a:tcPr marL="54864" marR="54864" marT="18288" marB="18288">
+                    <a:solidFill>
+                      <a:srgbClr val="FFFFFF"/>
+                    </a:solidFill>
+                  </a:tcPr>
+                </a:tc>
+                <a:tc>
+                  <a:txBody>
+                    <a:bodyPr wrap="square"/>
+                    <a:lstStyle/>
+                    <a:p>
+                      <a:r>
+                        <a:rPr sz="1100" b="0">
+                          <a:solidFill>
+                            <a:srgbClr val="282828"/>
+                          </a:solidFill>
+                          <a:latin typeface="Arial"/>
+                        </a:rPr>
+                        <a:t>dyson5_tma_step1.txt, dyson5_tma_step1_layout.png, BRIEF_dyson5_tma.md</a:t>
+                      </a:r>
+                    </a:p>
+                  </a:txBody>
+                  <a:tcPr marL="54864" marR="54864" marT="18288" marB="18288">
+                    <a:solidFill>
+                      <a:srgbClr val="FFFFFF"/>
+                    </a:solidFill>
+                  </a:tcPr>
+                </a:tc>
+                <a:tc>
+                  <a:txBody>
+                    <a:bodyPr wrap="square"/>
+                    <a:lstStyle/>
+                    <a:p>
+                      <a:r>
+                        <a:rPr sz="1100" b="0">
+                          <a:solidFill>
+                            <a:srgbClr val="282828"/>
+                          </a:solidFill>
+                          <a:latin typeface="Arial"/>
+                        </a:rPr>
+                        <a:t>macos.design.tma_layout, Telescope, CALIB</a:t>
+                      </a:r>
+                    </a:p>
+                  </a:txBody>
+                  <a:tcPr marL="54864" marR="54864" marT="18288" marB="18288">
+                    <a:solidFill>
+                      <a:srgbClr val="FFFFFF"/>
+                    </a:solidFill>
+                  </a:tcPr>
+                </a:tc>
+              </a:tr>
+              <a:tr h="468630">
+                <a:tc>
+                  <a:txBody>
+                    <a:bodyPr wrap="square"/>
+                    <a:lstStyle/>
+                    <a:p>
+                      <a:r>
+                        <a:rPr sz="1100" b="0">
+                          <a:solidFill>
+                            <a:srgbClr val="282828"/>
+                          </a:solidFill>
+                          <a:latin typeface="Arial"/>
+                        </a:rPr>
+                        <a:t>end to end at Jim's f-number (informative)</a:t>
+                      </a:r>
+                    </a:p>
+                  </a:txBody>
+                  <a:tcPr marL="54864" marR="54864" marT="18288" marB="18288">
+                    <a:solidFill>
+                      <a:srgbClr val="ECF1F6"/>
+                    </a:solidFill>
+                  </a:tcPr>
+                </a:tc>
+                <a:tc>
+                  <a:txBody>
+                    <a:bodyPr wrap="square"/>
+                    <a:lstStyle/>
+                    <a:p>
+                      <a:r>
+                        <a:rPr sz="1100" b="0">
+                          <a:solidFill>
+                            <a:srgbClr val="282828"/>
+                          </a:solidFill>
+                          <a:latin typeface="Arial"/>
+                        </a:rPr>
+                        <a:t>t5e</a:t>
+                      </a:r>
+                    </a:p>
+                  </a:txBody>
+                  <a:tcPr marL="54864" marR="54864" marT="18288" marB="18288">
+                    <a:solidFill>
+                      <a:srgbClr val="ECF1F6"/>
+                    </a:solidFill>
+                  </a:tcPr>
+                </a:tc>
+                <a:tc>
+                  <a:txBody>
+                    <a:bodyPr wrap="square"/>
+                    <a:lstStyle/>
+                    <a:p>
+                      <a:r>
+                        <a:rPr sz="1100" b="0">
+                          <a:solidFill>
+                            <a:srgbClr val="282828"/>
+                          </a:solidFill>
+                          <a:latin typeface="Arial"/>
+                        </a:rPr>
+                        <a:t>dyson5_t5e_1k5.txt, dyson5_t5e_1k5_e2e.in, dyson5_t5e_1k5_maps.png</a:t>
+                      </a:r>
+                    </a:p>
+                  </a:txBody>
+                  <a:tcPr marL="54864" marR="54864" marT="18288" marB="18288">
+                    <a:solidFill>
+                      <a:srgbClr val="ECF1F6"/>
+                    </a:solidFill>
+                  </a:tcPr>
+                </a:tc>
+                <a:tc>
+                  <a:txBody>
+                    <a:bodyPr wrap="square"/>
+                    <a:lstStyle/>
+                    <a:p>
+                      <a:r>
+                        <a:rPr sz="1100" b="0">
+                          <a:solidFill>
+                            <a:srgbClr val="282828"/>
+                          </a:solidFill>
+                          <a:latin typeface="Arial"/>
+                        </a:rPr>
+                        <a:t>tel_deck_geom.m (the exact chain from a Telescope deck), the spectrometer's scorer</a:t>
+                      </a:r>
+                    </a:p>
+                  </a:txBody>
+                  <a:tcPr marL="54864" marR="54864" marT="18288" marB="18288">
+                    <a:solidFill>
+                      <a:srgbClr val="ECF1F6"/>
+                    </a:solidFill>
+                  </a:tcPr>
+                </a:tc>
+              </a:tr>
+              <a:tr h="657225">
+                <a:tc>
+                  <a:txBody>
+                    <a:bodyPr wrap="square"/>
+                    <a:lstStyle/>
+                    <a:p>
+                      <a:r>
+                        <a:rPr sz="1100" b="0">
+                          <a:solidFill>
+                            <a:srgbClr val="282828"/>
+                          </a:solidFill>
+                          <a:latin typeface="Arial"/>
+                        </a:rPr>
+                        <a:t>telescope, telecentric parent: first order, figure, decenter walk</a:t>
+                      </a:r>
+                    </a:p>
+                  </a:txBody>
+                  <a:tcPr marL="54864" marR="54864" marT="18288" marB="18288">
+                    <a:solidFill>
+                      <a:srgbClr val="FFFFFF"/>
+                    </a:solidFill>
+                  </a:tcPr>
+                </a:tc>
+                <a:tc>
+                  <a:txBody>
+                    <a:bodyPr wrap="square"/>
+                    <a:lstStyle/>
+                    <a:p>
+                      <a:r>
+                        <a:rPr sz="1100" b="0">
+                          <a:solidFill>
+                            <a:srgbClr val="282828"/>
+                          </a:solidFill>
+                          <a:latin typeface="Arial"/>
+                        </a:rPr>
+                        <a:t>tA (stages A, B, re-run)</a:t>
+                      </a:r>
+                    </a:p>
+                  </a:txBody>
+                  <a:tcPr marL="54864" marR="54864" marT="18288" marB="18288">
+                    <a:solidFill>
+                      <a:srgbClr val="FFFFFF"/>
+                    </a:solidFill>
+                  </a:tcPr>
+                </a:tc>
+                <a:tc>
+                  <a:txBody>
+                    <a:bodyPr wrap="square"/>
+                    <a:lstStyle/>
+                    <a:p>
+                      <a:r>
+                        <a:rPr sz="1100" b="0">
+                          <a:solidFill>
+                            <a:srgbClr val="282828"/>
+                          </a:solidFill>
+                          <a:latin typeface="Arial"/>
+                        </a:rPr>
+                        <a:t>dyson5_tA_B3_.txt, dyson5_t5e_tA_B3_.txt/.png, decks per point</a:t>
+                      </a:r>
+                    </a:p>
+                  </a:txBody>
+                  <a:tcPr marL="54864" marR="54864" marT="18288" marB="18288">
+                    <a:solidFill>
+                      <a:srgbClr val="FFFFFF"/>
+                    </a:solidFill>
+                  </a:tcPr>
+                </a:tc>
+                <a:tc>
+                  <a:txBody>
+                    <a:bodyPr wrap="square"/>
+                    <a:lstStyle/>
+                    <a:p>
+                      <a:r>
+                        <a:rPr sz="1100" b="0">
+                          <a:solidFill>
+                            <a:srgbClr val="282828"/>
+                          </a:solidFill>
+                          <a:latin typeface="Arial"/>
+                        </a:rPr>
+                        <a:t>tma_layout 'telecentric', Telescope.optimize with aspheres and position rows, spectrometer_clearance (mount once)</a:t>
+                      </a:r>
+                    </a:p>
+                  </a:txBody>
+                  <a:tcPr marL="54864" marR="54864" marT="18288" marB="18288">
+                    <a:solidFill>
+                      <a:srgbClr val="FFFFFF"/>
+                    </a:solidFill>
+                  </a:tcPr>
+                </a:tc>
+              </a:tr>
+              <a:tr h="657225">
+                <a:tc>
+                  <a:txBody>
+                    <a:bodyPr wrap="square"/>
+                    <a:lstStyle/>
+                    <a:p>
+                      <a:r>
+                        <a:rPr sz="1100" b="0">
+                          <a:solidFill>
+                            <a:srgbClr val="282828"/>
+                          </a:solidFill>
+                          <a:latin typeface="Arial"/>
+                        </a:rPr>
+                        <a:t>strip edge: metric, Petzval, freeform steps</a:t>
+                      </a:r>
+                    </a:p>
+                  </a:txBody>
+                  <a:tcPr marL="54864" marR="54864" marT="18288" marB="18288">
+                    <a:solidFill>
+                      <a:srgbClr val="ECF1F6"/>
+                    </a:solidFill>
+                  </a:tcPr>
+                </a:tc>
+                <a:tc>
+                  <a:txBody>
+                    <a:bodyPr wrap="square"/>
+                    <a:lstStyle/>
+                    <a:p>
+                      <a:r>
+                        <a:rPr sz="1100" b="0">
+                          <a:solidFill>
+                            <a:srgbClr val="282828"/>
+                          </a:solidFill>
+                          <a:latin typeface="Arial"/>
+                        </a:rPr>
+                        <a:t>tEP, tPZ, tFF</a:t>
+                      </a:r>
+                    </a:p>
+                  </a:txBody>
+                  <a:tcPr marL="54864" marR="54864" marT="18288" marB="18288">
+                    <a:solidFill>
+                      <a:srgbClr val="ECF1F6"/>
+                    </a:solidFill>
+                  </a:tcPr>
+                </a:tc>
+                <a:tc>
+                  <a:txBody>
+                    <a:bodyPr wrap="square"/>
+                    <a:lstStyle/>
+                    <a:p>
+                      <a:r>
+                        <a:rPr sz="1100" b="0">
+                          <a:solidFill>
+                            <a:srgbClr val="282828"/>
+                          </a:solidFill>
+                          <a:latin typeface="Arial"/>
+                        </a:rPr>
+                        <a:t>dyson5_tA_EP_cp1/cp2*.txt, dyson5_tA_pz_1k5.txt, dyson5_tA_FF_1k5.txt, BRIEF_to_dyson5.md addenda 42–44</a:t>
+                      </a:r>
+                    </a:p>
+                  </a:txBody>
+                  <a:tcPr marL="54864" marR="54864" marT="18288" marB="18288">
+                    <a:solidFill>
+                      <a:srgbClr val="ECF1F6"/>
+                    </a:solidFill>
+                  </a:tcPr>
+                </a:tc>
+                <a:tc>
+                  <a:txBody>
+                    <a:bodyPr wrap="square"/>
+                    <a:lstStyle/>
+                    <a:p>
+                      <a:r>
+                        <a:rPr sz="1100" b="0">
+                          <a:solidFill>
+                            <a:srgbClr val="282828"/>
+                          </a:solidFill>
+                          <a:latin typeface="Arial"/>
+                        </a:rPr>
+                        <a:t>the reference-sphere evaluator and solver (tEP_strict_solve_), the line-focus probe, FreeForm decks with the asphere in the Mon channel and the Zernikes about the pole</a:t>
+                      </a:r>
+                    </a:p>
+                  </a:txBody>
+                  <a:tcPr marL="54864" marR="54864" marT="18288" marB="18288">
+                    <a:solidFill>
+                      <a:srgbClr val="ECF1F6"/>
+                    </a:solidFill>
+                  </a:tcPr>
+                </a:tc>
+              </a:tr>
+              <a:tr h="657225">
+                <a:tc>
+                  <a:txBody>
+                    <a:bodyPr wrap="square"/>
+                    <a:lstStyle/>
+                    <a:p>
+                      <a:r>
+                        <a:rPr sz="1100" b="0">
+                          <a:solidFill>
+                            <a:srgbClr val="282828"/>
+                          </a:solidFill>
+                          <a:latin typeface="Arial"/>
+                        </a:rPr>
+                        <a:t>telescope, TMA unobscured section (step 2/2b, Linux)</a:t>
+                      </a:r>
+                    </a:p>
+                  </a:txBody>
+                  <a:tcPr marL="54864" marR="54864" marT="18288" marB="18288">
+                    <a:solidFill>
+                      <a:srgbClr val="FFFFFF"/>
+                    </a:solidFill>
+                  </a:tcPr>
+                </a:tc>
+                <a:tc>
+                  <a:txBody>
+                    <a:bodyPr wrap="square"/>
+                    <a:lstStyle/>
+                    <a:p>
+                      <a:r>
+                        <a:rPr sz="1100" b="0">
+                          <a:solidFill>
+                            <a:srgbClr val="282828"/>
+                          </a:solidFill>
+                          <a:latin typeface="Arial"/>
+                        </a:rPr>
+                        <a:t>dyson5_tma_step2_linux.m</a:t>
+                      </a:r>
+                    </a:p>
+                  </a:txBody>
+                  <a:tcPr marL="54864" marR="54864" marT="18288" marB="18288">
+                    <a:solidFill>
+                      <a:srgbClr val="FFFFFF"/>
+                    </a:solidFill>
+                  </a:tcPr>
+                </a:tc>
+                <a:tc>
+                  <a:txBody>
+                    <a:bodyPr wrap="square"/>
+                    <a:lstStyle/>
+                    <a:p>
+                      <a:r>
+                        <a:rPr sz="1100" b="0">
+                          <a:solidFill>
+                            <a:srgbClr val="282828"/>
+                          </a:solidFill>
+                          <a:latin typeface="Arial"/>
+                        </a:rPr>
+                        <a:t>dyson5_tma_step2_linux_d170.txt, _d190.txt, dyson5_tma_step2b_linux_d205.txt, _d205_1k5.in, _layout_*.png</a:t>
+                      </a:r>
+                    </a:p>
+                  </a:txBody>
+                  <a:tcPr marL="54864" marR="54864" marT="18288" marB="18288">
+                    <a:solidFill>
+                      <a:srgbClr val="FFFFFF"/>
+                    </a:solidFill>
+                  </a:tcPr>
+                </a:tc>
+                <a:tc>
+                  <a:txBody>
+                    <a:bodyPr wrap="square"/>
+                    <a:lstStyle/>
+                    <a:p>
+                      <a:r>
+                        <a:rPr sz="1100" b="0">
+                          <a:solidFill>
+                            <a:srgbClr val="282828"/>
+                          </a:solidFill>
+                          <a:latin typeface="Arial"/>
+                        </a:rPr>
+                        <a:t>Telescope.set_offaxis, CALIB over the strip with the per-field position rows, check_clipping</a:t>
+                      </a:r>
+                    </a:p>
+                  </a:txBody>
+                  <a:tcPr marL="54864" marR="54864" marT="18288" marB="18288">
+                    <a:solidFill>
+                      <a:srgbClr val="FFFFFF"/>
+                    </a:solidFill>
+                  </a:tcPr>
+                </a:tc>
+              </a:tr>
+            </a:tbl>
+          </a:graphicData>
+        </a:graphic>
+      </p:graphicFrame>
+      <p:sp>
+        <p:nvSpPr>
+          <p:cNvPr id="5" name="TextBox 4"/>
+          <p:cNvSpPr txBox="1"/>
+          <p:nvPr/>
+        </p:nvSpPr>
+        <p:spPr>
+          <a:xfrm>
+            <a:off x="411480" y="10440162"/>
+            <a:ext cx="11368735" cy="274320"/>
+          </a:xfrm>
+          <a:prstGeom prst="rect">
+            <a:avLst/>
+          </a:prstGeom>
+          <a:noFill/>
+        </p:spPr>
+        <p:txBody>
+          <a:bodyPr wrap="square">
+            <a:spAutoFit/>
+          </a:bodyPr>
+          <a:lstStyle/>
+          <a:p>
+            <a:pPr>
+              <a:spcAft>
+                <a:spcPts val="600"/>
+              </a:spcAft>
+            </a:pPr>
+            <a:r>
+              <a:rPr sz="1050" b="0">
+                <a:solidFill>
+                  <a:srgbClr val="6E6E6E"/>
+                </a:solidFill>
+                <a:latin typeface="Arial"/>
+              </a:rPr>
+              <a:t>Conventions behind the scaling law: block index n(silica, 1 µm) = 1.450417; in-glass marginal half-angle u = asin(1 / 2nF); field height h from the Dyson axis on the flat face; the slit corner is h = hypot(27 mm, 8 mm).</a:t>
+            </a:r>
+          </a:p>
+        </p:txBody>
+      </p:sp>
+    </p:spTree>
+  </p:cSld>
+  <p:clrMapOvr>
+    <a:masterClrMapping/>
+  </p:clrMapOvr>
+</p:sld>
+</file>
+
+<file path=ppt/slides/slide37.xml><?xml version="1.0" encoding="utf-8"?>
 <p:sld xmlns:a="http://schemas.openxmlformats.org/drawingml/2006/main" xmlns:p="http://schemas.openxmlformats.org/presentationml/2006/main" xmlns:r="http://schemas.openxmlformats.org/officeDocument/2006/relationships">
   <p:cSld>
     <p:spTree>

</xml_diff>

<commit_message>
deck_dyson: the strict-merit solve and the astigmatism-step rows withdrawn pending TO's re-run (the solver stopped at its first step: residuals in metres vs absolute tolerances); the ranking facts stay
Co-Authored-By: Claude Fable 5.1 <noreply@anthropic.com>
</commit_message>
<xml_diff>
--- a/demo_session/deck_dyson.pptx
+++ b/demo_session/deck_dyson.pptx
@@ -16802,7 +16802,7 @@
                 </a:solidFill>
                 <a:latin typeface="Arial"/>
               </a:rPr>
-              <a:t>Cross-track astigmatism of the eccentric section, growing as the square of the field; untouched by focus, by the mirrors' power split, or by astigmatism terms alone</a:t>
+              <a:t>Cross-track astigmatism of the eccentric section, growing as the square of the field; untouched by focus or by the mirrors' power split</a:t>
             </a:r>
           </a:p>
         </p:txBody>
@@ -16885,7 +16885,7 @@
                 </a:solidFill>
                 <a:latin typeface="Arial"/>
               </a:rPr>
-              <a:t>•  It is not the metric.  The optimizer's default merit, the path length to each ray's own point on the detector (which the chiefs meet at 31°), floors at 16 µm at every field and ranks the strip edge at 2.1× the centre where the true reference sphere ranks it 13.7×.  Re-solving the same conics and aspheres on the true sphere moves the edge 343 → 332 µm, 3 % — inside the solver's run-to-run scatter.  The reference sphere is the reporting metric from here on (about the detector point, and about best focus; they answer different questions).</a:t>
+              <a:t>•  The optimizer's default merit mis-ranks the fields.  The path length to each ray's own point on the detector (which the chiefs meet at 31°) floors at 16 µm at every field and ranks the strip edge at 2.1× the centre where the true reference sphere ranks it 13.7×.  The reference sphere is the reporting metric from here on (about the detector point, and about best focus; they answer different questions); whether solving on it buys the edge is being re-run (footnote).</a:t>
             </a:r>
           </a:p>
           <a:p>
@@ -16917,7 +16917,7 @@
                 </a:solidFill>
                 <a:latin typeface="Arial"/>
               </a:rPr>
-              <a:t>•  It is not astigmatism terms alone.  With the aspheres carried exactly on each mirror and Zernike astigmatism added about each section's pole, the edge does not move (291 → 297 µm): those terms are field-constant, the defect is field-quadratic (line-focus separation 0 / 0.9 / 2.1 mm at 0° / 1.6° / 2.3°).  The field dependence enters through the footprint's walk across each mirror times its higher terms — coma and trefoil, then the symmetric terms — the steps now running.</a:t>
+              <a:t>•  Astigmatism terms are not expected to reach it alone: about each section's pole they are field-constant, the defect is field-quadratic (line-focus separation 0 / 0.9 / 2.1 mm at 0° / 1.6° / 2.3°); the field dependence enters through the footprint's walk across each mirror times its higher terms — coma and trefoil, then the symmetric terms.  The freeform steps are running on the true reference sphere.</a:t>
             </a:r>
           </a:p>
         </p:txBody>
@@ -16932,7 +16932,7 @@
         </p:nvGraphicFramePr>
         <p:xfrm>
           <a:off x="6400800" y="1298448"/>
-          <a:ext cx="5394957" cy="2171700"/>
+          <a:ext cx="5394958" cy="1303020"/>
         </p:xfrm>
         <a:graphic>
           <a:graphicData uri="http://schemas.openxmlformats.org/drawingml/2006/table">
@@ -16941,10 +16941,10 @@
                 <a:tableStyleId>{5C22544A-7EE6-4342-B048-85BDC9FD1C3A}</a:tableStyleId>
               </a:tblPr>
               <a:tblGrid>
-                <a:gridCol w="1124745"/>
+                <a:gridCol w="1013108"/>
                 <a:gridCol w="1004823"/>
-                <a:gridCol w="2068080"/>
-                <a:gridCol w="1197309"/>
+                <a:gridCol w="2138784"/>
+                <a:gridCol w="1238243"/>
               </a:tblGrid>
               <a:tr h="434340">
                 <a:tc>
@@ -17139,7 +17139,7 @@
                           </a:solidFill>
                           <a:latin typeface="Arial"/>
                         </a:rPr>
-                        <a:t>same, solved on the true sphere</a:t>
+                        <a:t>conics + aspheres, m₂ = 3.0</a:t>
                       </a:r>
                     </a:p>
                   </a:txBody>
@@ -17161,7 +17161,7 @@
                           </a:solidFill>
                           <a:latin typeface="Arial"/>
                         </a:rPr>
-                        <a:t>332 µm</a:t>
+                        <a:t>291 µm</a:t>
                       </a:r>
                     </a:p>
                   </a:txBody>
@@ -17183,7 +17183,7 @@
                           </a:solidFill>
                           <a:latin typeface="Arial"/>
                         </a:rPr>
-                        <a:t>— / 25.7 µm</a:t>
+                        <a:t>27.9 / 23.0 µm</a:t>
                       </a:r>
                     </a:p>
                   </a:txBody>
@@ -17205,187 +17205,7 @@
                           </a:solidFill>
                           <a:latin typeface="Arial"/>
                         </a:rPr>
-                        <a:t>—</a:t>
-                      </a:r>
-                    </a:p>
-                  </a:txBody>
-                  <a:tcPr marL="54864" marR="54864" marT="18288" marB="18288">
-                    <a:solidFill>
-                      <a:srgbClr val="ECF1F6"/>
-                    </a:solidFill>
-                  </a:tcPr>
-                </a:tc>
-              </a:tr>
-              <a:tr h="434340">
-                <a:tc>
-                  <a:txBody>
-                    <a:bodyPr wrap="square"/>
-                    <a:lstStyle/>
-                    <a:p>
-                      <a:r>
-                        <a:rPr sz="1000" b="0">
-                          <a:solidFill>
-                            <a:srgbClr val="282828"/>
-                          </a:solidFill>
-                          <a:latin typeface="Arial"/>
-                        </a:rPr>
-                        <a:t>conics + aspheres, m₂ = 3.0</a:t>
-                      </a:r>
-                    </a:p>
-                  </a:txBody>
-                  <a:tcPr marL="54864" marR="54864" marT="18288" marB="18288">
-                    <a:solidFill>
-                      <a:srgbClr val="FFFFFF"/>
-                    </a:solidFill>
-                  </a:tcPr>
-                </a:tc>
-                <a:tc>
-                  <a:txBody>
-                    <a:bodyPr wrap="square"/>
-                    <a:lstStyle/>
-                    <a:p>
-                      <a:r>
-                        <a:rPr sz="1000" b="0">
-                          <a:solidFill>
-                            <a:srgbClr val="282828"/>
-                          </a:solidFill>
-                          <a:latin typeface="Arial"/>
-                        </a:rPr>
-                        <a:t>291 µm</a:t>
-                      </a:r>
-                    </a:p>
-                  </a:txBody>
-                  <a:tcPr marL="54864" marR="54864" marT="18288" marB="18288">
-                    <a:solidFill>
-                      <a:srgbClr val="FFFFFF"/>
-                    </a:solidFill>
-                  </a:tcPr>
-                </a:tc>
-                <a:tc>
-                  <a:txBody>
-                    <a:bodyPr wrap="square"/>
-                    <a:lstStyle/>
-                    <a:p>
-                      <a:r>
-                        <a:rPr sz="1000" b="0">
-                          <a:solidFill>
-                            <a:srgbClr val="282828"/>
-                          </a:solidFill>
-                          <a:latin typeface="Arial"/>
-                        </a:rPr>
-                        <a:t>27.9 / 23.0 µm</a:t>
-                      </a:r>
-                    </a:p>
-                  </a:txBody>
-                  <a:tcPr marL="54864" marR="54864" marT="18288" marB="18288">
-                    <a:solidFill>
-                      <a:srgbClr val="FFFFFF"/>
-                    </a:solidFill>
-                  </a:tcPr>
-                </a:tc>
-                <a:tc>
-                  <a:txBody>
-                    <a:bodyPr wrap="square"/>
-                    <a:lstStyle/>
-                    <a:p>
-                      <a:r>
-                        <a:rPr sz="1000" b="0">
-                          <a:solidFill>
-                            <a:srgbClr val="282828"/>
-                          </a:solidFill>
-                          <a:latin typeface="Arial"/>
-                        </a:rPr>
                         <a:t>2.2 mm</a:t>
-                      </a:r>
-                    </a:p>
-                  </a:txBody>
-                  <a:tcPr marL="54864" marR="54864" marT="18288" marB="18288">
-                    <a:solidFill>
-                      <a:srgbClr val="FFFFFF"/>
-                    </a:solidFill>
-                  </a:tcPr>
-                </a:tc>
-              </a:tr>
-              <a:tr h="434340">
-                <a:tc>
-                  <a:txBody>
-                    <a:bodyPr wrap="square"/>
-                    <a:lstStyle/>
-                    <a:p>
-                      <a:r>
-                        <a:rPr sz="1000" b="0">
-                          <a:solidFill>
-                            <a:srgbClr val="282828"/>
-                          </a:solidFill>
-                          <a:latin typeface="Arial"/>
-                        </a:rPr>
-                        <a:t>+ Zernike astigmatism, m₂ = 3.0</a:t>
-                      </a:r>
-                    </a:p>
-                  </a:txBody>
-                  <a:tcPr marL="54864" marR="54864" marT="18288" marB="18288">
-                    <a:solidFill>
-                      <a:srgbClr val="ECF1F6"/>
-                    </a:solidFill>
-                  </a:tcPr>
-                </a:tc>
-                <a:tc>
-                  <a:txBody>
-                    <a:bodyPr wrap="square"/>
-                    <a:lstStyle/>
-                    <a:p>
-                      <a:r>
-                        <a:rPr sz="1000" b="0">
-                          <a:solidFill>
-                            <a:srgbClr val="282828"/>
-                          </a:solidFill>
-                          <a:latin typeface="Arial"/>
-                        </a:rPr>
-                        <a:t>297 µm</a:t>
-                      </a:r>
-                    </a:p>
-                  </a:txBody>
-                  <a:tcPr marL="54864" marR="54864" marT="18288" marB="18288">
-                    <a:solidFill>
-                      <a:srgbClr val="ECF1F6"/>
-                    </a:solidFill>
-                  </a:tcPr>
-                </a:tc>
-                <a:tc>
-                  <a:txBody>
-                    <a:bodyPr wrap="square"/>
-                    <a:lstStyle/>
-                    <a:p>
-                      <a:r>
-                        <a:rPr sz="1000" b="0">
-                          <a:solidFill>
-                            <a:srgbClr val="282828"/>
-                          </a:solidFill>
-                          <a:latin typeface="Arial"/>
-                        </a:rPr>
-                        <a:t>27.8 / 23.5 µm</a:t>
-                      </a:r>
-                    </a:p>
-                  </a:txBody>
-                  <a:tcPr marL="54864" marR="54864" marT="18288" marB="18288">
-                    <a:solidFill>
-                      <a:srgbClr val="ECF1F6"/>
-                    </a:solidFill>
-                  </a:tcPr>
-                </a:tc>
-                <a:tc>
-                  <a:txBody>
-                    <a:bodyPr wrap="square"/>
-                    <a:lstStyle/>
-                    <a:p>
-                      <a:r>
-                        <a:rPr sz="1000" b="0">
-                          <a:solidFill>
-                            <a:srgbClr val="282828"/>
-                          </a:solidFill>
-                          <a:latin typeface="Arial"/>
-                        </a:rPr>
-                        <a:t>2.3 mm</a:t>
                       </a:r>
                     </a:p>
                   </a:txBody>
@@ -17408,7 +17228,7 @@
         </p:nvSpPr>
         <p:spPr>
           <a:xfrm>
-            <a:off x="6400800" y="3616452"/>
+            <a:off x="6400800" y="2747772"/>
             <a:ext cx="5394960" cy="274320"/>
           </a:xfrm>
           <a:prstGeom prst="rect">
@@ -17434,7 +17254,7 @@
                 </a:solidFill>
                 <a:latin typeface="Arial"/>
               </a:rPr>
-              <a:t>1.5k section at 4° bias, 190 mm decenter, ±2.34° field; wavefront rms over the pupil at 633 nm; the two line foci from the x- and y-slices of the bundle along the chief.  Records dyson5_tA_EP_cp*.txt, dyson5_tA_pz_1k5.txt, dyson5_tA_FF_1k5.txt.</a:t>
+              <a:t>1.5k section at 4° bias, 190 mm decenter, ±2.34° field; wavefront rms over the pupil at 633 nm; the two line foci from the x- and y-slices of the bundle along the chief.  The solves ON the reference sphere (the same freedoms, and the freeform steps) first stopped at their solver's first step through a tolerance set in the wrong units; they are re-running and are not reported here.  Records dyson5_tA_EP_cp*.txt, dyson5_tA_pz_1k5.txt.</a:t>
             </a:r>
           </a:p>
         </p:txBody>

</xml_diff>

<commit_message>
deck_dyson: the 1.5k telescope of record (three off-axis aspheres, CRF 1.22 px, clearance +39 mm) and what it took (metric + geometry; the step table); 3k = freeform (c); next steps
Co-Authored-By: Claude Fable 5.1 <noreply@anthropic.com>
</commit_message>
<xml_diff>
--- a/demo_session/deck_dyson.pptx
+++ b/demo_session/deck_dyson.pptx
@@ -15797,7 +15797,7 @@
                 </a:solidFill>
                 <a:latin typeface="Arial"/>
               </a:rPr>
-              <a:t>The 1.5k telescope through its Dyson</a:t>
+              <a:t>The 1.5k telescope of record: three off-axis aspheres</a:t>
             </a:r>
           </a:p>
           <a:p>
@@ -15813,7 +15813,7 @@
                 </a:solidFill>
                 <a:latin typeface="Arial"/>
               </a:rPr>
-              <a:t>On the telecentric parent every field is admitted and the plate scale holds; the strip's inner half images at 2–10 px, its edges at 19 px</a:t>
+              <a:t>Every field admitted, plate scale held, the strip at the pixel end to end: smile 0.51, keystone 0.01, CRF 1.22, SRF 2.20 px; clearance +39 mm</a:t>
             </a:r>
           </a:p>
         </p:txBody>
@@ -15896,7 +15896,7 @@
                 </a:solidFill>
                 <a:latin typeface="Arial"/>
               </a:rPr>
-              <a:t>•  The pupil is a first-order condition.  The section's exit pupil must sit near infinity to feed the near-telecentric Dyson (its chiefs cross 14–44 m away; it accepts chiefs within 0.09° of its own).  A Korsch with a real intermediate focus between M2 and M3 can never be telecentric, so the layout was re-posed with M3 in front of that focus (the Cook/EMIT form, tma_layout 'telecentric'): on that parent's section the chiefs are within 0.5° across the strip, the pupil ~1 m out, every field admitted (0.997–1.000), the plate scale calibrated to the spec by the parent's f-number.</a:t>
+              <a:t>•  The pupil is a first-order condition.  The section's exit pupil must sit near infinity to feed the near-telecentric Dyson (its chiefs cross 14–44 m away; it accepts chiefs within 0.09° of its own).  A Korsch with a real intermediate focus between M2 and M3 can never be telecentric, so the layout was re-posed with M3 in front of that focus (the Cook/EMIT form, tma_layout 'telecentric'): chiefs within 0.5° across the strip, every field admitted, the plate scale calibrated by the parent's f-number.</a:t>
             </a:r>
           </a:p>
           <a:p>
@@ -15912,7 +15912,7 @@
                 </a:solidFill>
                 <a:latin typeface="Arial"/>
               </a:rPr>
-              <a:t>•  The figure stage (h⁴+h⁶ on all three mirrors, the per-field image positions as targets, scored on the corrected engine): at 4° bias and 190 mm decenter — the point the clearance walk selects — the strip images at 2.1 px at the centre, 4.2 / 9.8 px at ±0.8° / ±1.6°, 19 px at the ±2.3° edges (best-focus rms 37 / 75 / 176 / 343 µm), plate scale 333.8 mm, clearance +3.97 mm with the mount counted once.</a:t>
+              <a:t>•  Two levers closed the strip edge, neither a figure term.  The merit: the per-ray transverse spot at the slit with the per-field image positions, in place of the wavefront rms (at F/1.8 with tens of µm of path error the image is far from diffraction-limited, and the wavefront merit flattened the field by trading the centre).  The geometry: M2 and M3 tilt and decenter and the focus as variables, which every earlier solve had frozen from first order.  With both, conics + h⁴/h⁶ with each mirror's own vertex and axis — three off-axis aspheres, no freeform — image the 1.5k strip at 8 / 14 µm as placed at the centre / ±2.3° edge (0.4 / 0.8 px).</a:t>
             </a:r>
           </a:p>
           <a:p>
@@ -15928,7 +15928,7 @@
                 </a:solidFill>
                 <a:latin typeface="Arial"/>
               </a:rPr>
-              <a:t>•  Through the 130 mm module (the Dyson rolled 180° about the chief to clear its detector package from M2): 98.8 % of the swath on the slit, every field admitted, smile 3.26 px, keystone 0.63 px, CRF 15.5 px, SRF 5.9 px — the telescope's edge blur seen through the Dyson, the same at every wavelength.  Chain and engine agree to 1e-14 m.</a:t>
+              <a:t>•  Through the 130 mm module (4° bias, 190 mm decenter, m₂ = 3.0 parent; the Dyson rolled 180° about the chief): smile 0.51 px, keystone 0.01 px, CRF 1.22 px, SRF 2.20 px, plate 327 / 331 mm, every field admitted; clearance +39 mm telescope-internal, +0.38 mm overall (the Dyson's own package).  Deck dyson5_tA_GM_1k5_bAs.in.</a:t>
             </a:r>
           </a:p>
           <a:p>
@@ -15944,7 +15944,7 @@
                 </a:solidFill>
                 <a:latin typeface="Arial"/>
               </a:rPr>
-              <a:t>•  The 3k section (4° bias, 180 mm) closes its scale and distortion — 326.8 / 319.2 mm, 100 % on the 54 mm slit, smile 10.6 px, keystone 1.37 px — with its edge fields at 1.23 mm (68 px).  Records dyson5_tA_B3_.txt, dyson5_t5e_tA_B3_.txt.</a:t>
+              <a:t>•  The 3k section needs genuine freeform (M2 1.7 mm of departure at 126 mrad) and reaches smile 2.05 / keystone 0.05 / CRF 4.22 / SRF 4.90 px; its figure and geometry work against each other, which points at the stop's position (M2) as the next layout question.</a:t>
             </a:r>
           </a:p>
         </p:txBody>
@@ -16046,7 +16046,7 @@
                 </a:solidFill>
                 <a:latin typeface="Arial"/>
               </a:rPr>
-              <a:t>Supersedes the 2026-10-04 row (1.3 / 15.8 px): that solve's aperture circle clipped the edge fields (Backup, finding 10).</a:t>
+              <a:t>Maps: the stage-B asphere solve on the wavefront merit (edges 19 px); the solve of record is scored in dyson5_tA_GM_ / dyson5_t5f_GM_ (maps next).</a:t>
             </a:r>
           </a:p>
         </p:txBody>
@@ -16786,7 +16786,7 @@
                 </a:solidFill>
                 <a:latin typeface="Arial"/>
               </a:rPr>
-              <a:t>What limits the strip edge</a:t>
+              <a:t>What it took to reach the pixel at the strip edge</a:t>
             </a:r>
           </a:p>
           <a:p>
@@ -16802,7 +16802,7 @@
                 </a:solidFill>
                 <a:latin typeface="Arial"/>
               </a:rPr>
-              <a:t>Cross-track astigmatism of the eccentric section, growing as the square of the field; untouched by focus or by the mirrors' power split</a:t>
+              <a:t>The defect was cross-track astigmatism growing as the square of the field; figure terms alone flattened the strip by trade, the merit and the geometry removed it</a:t>
             </a:r>
           </a:p>
         </p:txBody>
@@ -16885,7 +16885,7 @@
                 </a:solidFill>
                 <a:latin typeface="Arial"/>
               </a:rPr>
-              <a:t>•  The optimizer's default merit mis-ranks the fields.  The path length to each ray's own point on the detector (which the chiefs meet at 31°) floors at 16 µm at every field and ranks the strip edge at 2.1× the centre where the true reference sphere ranks it 13.7×.  The reference sphere is the reporting metric from here on (about the detector point, and about best focus; they answer different questions); whether solving on it buys the edge is being re-run (footnote).</a:t>
+              <a:t>•  It was not focus or the mirrors' power split: along the strip the along-track focus is flat, the cross-track focus curves 2–4 mm and the two line foci at the edge sit 2.2–5.3 mm apart; no secondary magnification flattens both, and a field lens has no leverage at the slit.</a:t>
             </a:r>
           </a:p>
           <a:p>
@@ -16901,7 +16901,7 @@
                 </a:solidFill>
                 <a:latin typeface="Arial"/>
               </a:rPr>
-              <a:t>•  It is not focus, and not the field curvature of the parent.  Along the strip the along-track focus is flat at every secondary magnification; the cross-track focus curves 2–4 mm, and the two line foci at the edge sit 2.2–5.3 mm apart.  The parent's Petzval sum predicts a flat field near m₂ = 2.9 and the engine shows none there; the magnification that flattens the mean focus (m₂ = 6) is 2× worse once solved.  m₂ = 3.0 is modestly better than the 3.5 used so far (edge 343 → 291 µm) and is the parent for the freeform work.</a:t>
+              <a:t>•  Figure terms alone trade the centre for the edge.  Zernike departures on all three mirrors took the 1.5k edge 291 → 170 µm while the centre went 29 → 73 µm; on 3k 1086 → 485 µm for a centre of 68 → 190 µm.  A control with the wavefront merit written per ray gave the same flattening: the merit, not the surfaces, set the trade.</a:t>
             </a:r>
           </a:p>
           <a:p>
@@ -16917,7 +16917,7 @@
                 </a:solidFill>
                 <a:latin typeface="Arial"/>
               </a:rPr>
-              <a:t>•  Astigmatism terms are not expected to reach it alone: about each section's pole they are field-constant, the defect is field-quadratic (line-focus separation 0 / 0.9 / 2.1 mm at 0° / 1.6° / 2.3°); the field dependence enters through the footprint's walk across each mirror times its higher terms — coma and trefoil, then the symmetric terms.  The freeform steps are running on the true reference sphere.</a:t>
+              <a:t>•  The transverse merit and the geometry removed it.  Per-ray spot rows at the slit plus M2/M3 tilt, decenter and focus as variables: 1.5k edge 170 → 13 µm, centre 73 → 6 µm, with the freeform coefficients collapsing to a re-fitted set of off-axis aspheres (surface residual ≤ 17 µm, re-optimised as aspheres: the slide before).  The emission had to be re-solved, not just re-fitted: a 1.7 mrad slope residual is a millimetre of blur over 0.3 m.</a:t>
             </a:r>
           </a:p>
         </p:txBody>
@@ -16932,7 +16932,7 @@
         </p:nvGraphicFramePr>
         <p:xfrm>
           <a:off x="6400800" y="1298448"/>
-          <a:ext cx="5394958" cy="1303020"/>
+          <a:ext cx="5394959" cy="2091690"/>
         </p:xfrm>
         <a:graphic>
           <a:graphicData uri="http://schemas.openxmlformats.org/drawingml/2006/table">
@@ -16941,10 +16941,9 @@
                 <a:tableStyleId>{5C22544A-7EE6-4342-B048-85BDC9FD1C3A}</a:tableStyleId>
               </a:tblPr>
               <a:tblGrid>
-                <a:gridCol w="1013108"/>
-                <a:gridCol w="1004823"/>
-                <a:gridCol w="2138784"/>
-                <a:gridCol w="1238243"/>
+                <a:gridCol w="2291664"/>
+                <a:gridCol w="1336804"/>
+                <a:gridCol w="1766491"/>
               </a:tblGrid>
               <a:tr h="434340">
                 <a:tc>
@@ -16959,7 +16958,7 @@
                           </a:solidFill>
                           <a:latin typeface="Arial"/>
                         </a:rPr>
-                        <a:t>step</a:t>
+                        <a:t>step (1.5k, same seed, same budget)</a:t>
                       </a:r>
                     </a:p>
                   </a:txBody>
@@ -16981,7 +16980,7 @@
                           </a:solidFill>
                           <a:latin typeface="Arial"/>
                         </a:rPr>
-                        <a:t>edge rms spot</a:t>
+                        <a:t>as-placed spot centre / edge</a:t>
                       </a:r>
                     </a:p>
                   </a:txBody>
@@ -17003,7 +17002,7 @@
                           </a:solidFill>
                           <a:latin typeface="Arial"/>
                         </a:rPr>
-                        <a:t>edge wavefront (sphere about detector point / best focus)</a:t>
+                        <a:t>e2e smile / keystone / CRF / SRF (px)</a:t>
                       </a:r>
                     </a:p>
                   </a:txBody>
@@ -17013,25 +17012,71 @@
                     </a:solidFill>
                   </a:tcPr>
                 </a:tc>
-                <a:tc>
-                  <a:txBody>
-                    <a:bodyPr wrap="square"/>
-                    <a:lstStyle/>
-                    <a:p>
-                      <a:r>
-                        <a:rPr sz="1000" b="1">
-                          <a:solidFill>
-                            <a:srgbClr val="FFFFFF"/>
-                          </a:solidFill>
-                          <a:latin typeface="Arial"/>
-                        </a:rPr>
-                        <a:t>line-focus separation at the edge</a:t>
-                      </a:r>
-                    </a:p>
-                  </a:txBody>
-                  <a:tcPr marL="54864" marR="54864" marT="18288" marB="18288">
-                    <a:solidFill>
-                      <a:srgbClr val="1F4E79"/>
+              </a:tr>
+              <a:tr h="262890">
+                <a:tc>
+                  <a:txBody>
+                    <a:bodyPr wrap="square"/>
+                    <a:lstStyle/>
+                    <a:p>
+                      <a:r>
+                        <a:rPr sz="1000" b="0">
+                          <a:solidFill>
+                            <a:srgbClr val="282828"/>
+                          </a:solidFill>
+                          <a:latin typeface="Arial"/>
+                        </a:rPr>
+                        <a:t>conics + aspheres, wavefront merit</a:t>
+                      </a:r>
+                    </a:p>
+                  </a:txBody>
+                  <a:tcPr marL="54864" marR="54864" marT="18288" marB="18288">
+                    <a:solidFill>
+                      <a:srgbClr val="FFFFFF"/>
+                    </a:solidFill>
+                  </a:tcPr>
+                </a:tc>
+                <a:tc>
+                  <a:txBody>
+                    <a:bodyPr wrap="square"/>
+                    <a:lstStyle/>
+                    <a:p>
+                      <a:r>
+                        <a:rPr sz="1000" b="0">
+                          <a:solidFill>
+                            <a:srgbClr val="282828"/>
+                          </a:solidFill>
+                          <a:latin typeface="Arial"/>
+                        </a:rPr>
+                        <a:t>37 / 343 µm</a:t>
+                      </a:r>
+                    </a:p>
+                  </a:txBody>
+                  <a:tcPr marL="54864" marR="54864" marT="18288" marB="18288">
+                    <a:solidFill>
+                      <a:srgbClr val="FFFFFF"/>
+                    </a:solidFill>
+                  </a:tcPr>
+                </a:tc>
+                <a:tc>
+                  <a:txBody>
+                    <a:bodyPr wrap="square"/>
+                    <a:lstStyle/>
+                    <a:p>
+                      <a:r>
+                        <a:rPr sz="1000" b="0">
+                          <a:solidFill>
+                            <a:srgbClr val="282828"/>
+                          </a:solidFill>
+                          <a:latin typeface="Arial"/>
+                        </a:rPr>
+                        <a:t>3.26 / 0.63 / 15.5 / 5.9</a:t>
+                      </a:r>
+                    </a:p>
+                  </a:txBody>
+                  <a:tcPr marL="54864" marR="54864" marT="18288" marB="18288">
+                    <a:solidFill>
+                      <a:srgbClr val="FFFFFF"/>
                     </a:solidFill>
                   </a:tcPr>
                 </a:tc>
@@ -17049,13 +17094,13 @@
                           </a:solidFill>
                           <a:latin typeface="Arial"/>
                         </a:rPr>
-                        <a:t>conics + aspheres, m₂ = 3.5</a:t>
-                      </a:r>
-                    </a:p>
-                  </a:txBody>
-                  <a:tcPr marL="54864" marR="54864" marT="18288" marB="18288">
-                    <a:solidFill>
-                      <a:srgbClr val="FFFFFF"/>
+                        <a:t>+ Zernike freeform, wavefront merit</a:t>
+                      </a:r>
+                    </a:p>
+                  </a:txBody>
+                  <a:tcPr marL="54864" marR="54864" marT="18288" marB="18288">
+                    <a:solidFill>
+                      <a:srgbClr val="ECF1F6"/>
                     </a:solidFill>
                   </a:tcPr>
                 </a:tc>
@@ -17071,13 +17116,13 @@
                           </a:solidFill>
                           <a:latin typeface="Arial"/>
                         </a:rPr>
-                        <a:t>343 µm</a:t>
-                      </a:r>
-                    </a:p>
-                  </a:txBody>
-                  <a:tcPr marL="54864" marR="54864" marT="18288" marB="18288">
-                    <a:solidFill>
-                      <a:srgbClr val="FFFFFF"/>
+                        <a:t>99 / 219</a:t>
+                      </a:r>
+                    </a:p>
+                  </a:txBody>
+                  <a:tcPr marL="54864" marR="54864" marT="18288" marB="18288">
+                    <a:solidFill>
+                      <a:srgbClr val="ECF1F6"/>
                     </a:solidFill>
                   </a:tcPr>
                 </a:tc>
@@ -17093,16 +17138,18 @@
                           </a:solidFill>
                           <a:latin typeface="Arial"/>
                         </a:rPr>
-                        <a:t>33.9 / 26.8 µm</a:t>
-                      </a:r>
-                    </a:p>
-                  </a:txBody>
-                  <a:tcPr marL="54864" marR="54864" marT="18288" marB="18288">
-                    <a:solidFill>
-                      <a:srgbClr val="FFFFFF"/>
-                    </a:solidFill>
-                  </a:tcPr>
-                </a:tc>
+                        <a:t>0.82 / 0.33 / 7.7 / 9.2</a:t>
+                      </a:r>
+                    </a:p>
+                  </a:txBody>
+                  <a:tcPr marL="54864" marR="54864" marT="18288" marB="18288">
+                    <a:solidFill>
+                      <a:srgbClr val="ECF1F6"/>
+                    </a:solidFill>
+                  </a:tcPr>
+                </a:tc>
+              </a:tr>
+              <a:tr h="262890">
                 <a:tc>
                   <a:txBody>
                     <a:bodyPr wrap="square"/>
@@ -17115,13 +17162,125 @@
                           </a:solidFill>
                           <a:latin typeface="Arial"/>
                         </a:rPr>
-                        <a:t>2.8 mm</a:t>
-                      </a:r>
-                    </a:p>
-                  </a:txBody>
-                  <a:tcPr marL="54864" marR="54864" marT="18288" marB="18288">
-                    <a:solidFill>
-                      <a:srgbClr val="FFFFFF"/>
+                        <a:t>same DOFs, transverse (spot) merit</a:t>
+                      </a:r>
+                    </a:p>
+                  </a:txBody>
+                  <a:tcPr marL="54864" marR="54864" marT="18288" marB="18288">
+                    <a:solidFill>
+                      <a:srgbClr val="FFFFFF"/>
+                    </a:solidFill>
+                  </a:tcPr>
+                </a:tc>
+                <a:tc>
+                  <a:txBody>
+                    <a:bodyPr wrap="square"/>
+                    <a:lstStyle/>
+                    <a:p>
+                      <a:r>
+                        <a:rPr sz="1000" b="0">
+                          <a:solidFill>
+                            <a:srgbClr val="282828"/>
+                          </a:solidFill>
+                          <a:latin typeface="Arial"/>
+                        </a:rPr>
+                        <a:t>18 / 27</a:t>
+                      </a:r>
+                    </a:p>
+                  </a:txBody>
+                  <a:tcPr marL="54864" marR="54864" marT="18288" marB="18288">
+                    <a:solidFill>
+                      <a:srgbClr val="FFFFFF"/>
+                    </a:solidFill>
+                  </a:tcPr>
+                </a:tc>
+                <a:tc>
+                  <a:txBody>
+                    <a:bodyPr wrap="square"/>
+                    <a:lstStyle/>
+                    <a:p>
+                      <a:r>
+                        <a:rPr sz="1000" b="0">
+                          <a:solidFill>
+                            <a:srgbClr val="282828"/>
+                          </a:solidFill>
+                          <a:latin typeface="Arial"/>
+                        </a:rPr>
+                        <a:t>1.54 / 0.03 / 2.34 / 4.46</a:t>
+                      </a:r>
+                    </a:p>
+                  </a:txBody>
+                  <a:tcPr marL="54864" marR="54864" marT="18288" marB="18288">
+                    <a:solidFill>
+                      <a:srgbClr val="FFFFFF"/>
+                    </a:solidFill>
+                  </a:tcPr>
+                </a:tc>
+              </a:tr>
+              <a:tr h="262890">
+                <a:tc>
+                  <a:txBody>
+                    <a:bodyPr wrap="square"/>
+                    <a:lstStyle/>
+                    <a:p>
+                      <a:r>
+                        <a:rPr sz="1000" b="0">
+                          <a:solidFill>
+                            <a:srgbClr val="282828"/>
+                          </a:solidFill>
+                          <a:latin typeface="Arial"/>
+                        </a:rPr>
+                        <a:t>+ M2/M3 tilt, decenter, focus</a:t>
+                      </a:r>
+                    </a:p>
+                  </a:txBody>
+                  <a:tcPr marL="54864" marR="54864" marT="18288" marB="18288">
+                    <a:solidFill>
+                      <a:srgbClr val="ECF1F6"/>
+                    </a:solidFill>
+                  </a:tcPr>
+                </a:tc>
+                <a:tc>
+                  <a:txBody>
+                    <a:bodyPr wrap="square"/>
+                    <a:lstStyle/>
+                    <a:p>
+                      <a:r>
+                        <a:rPr sz="1000" b="0">
+                          <a:solidFill>
+                            <a:srgbClr val="282828"/>
+                          </a:solidFill>
+                          <a:latin typeface="Arial"/>
+                        </a:rPr>
+                        <a:t>6 / 13</a:t>
+                      </a:r>
+                    </a:p>
+                  </a:txBody>
+                  <a:tcPr marL="54864" marR="54864" marT="18288" marB="18288">
+                    <a:solidFill>
+                      <a:srgbClr val="ECF1F6"/>
+                    </a:solidFill>
+                  </a:tcPr>
+                </a:tc>
+                <a:tc>
+                  <a:txBody>
+                    <a:bodyPr wrap="square"/>
+                    <a:lstStyle/>
+                    <a:p>
+                      <a:r>
+                        <a:rPr sz="1000" b="0">
+                          <a:solidFill>
+                            <a:srgbClr val="282828"/>
+                          </a:solidFill>
+                          <a:latin typeface="Arial"/>
+                        </a:rPr>
+                        <a:t>0.60 / 0.02 / 1.49 / 2.30</a:t>
+                      </a:r>
+                    </a:p>
+                  </a:txBody>
+                  <a:tcPr marL="54864" marR="54864" marT="18288" marB="18288">
+                    <a:solidFill>
+                      <a:srgbClr val="ECF1F6"/>
                     </a:solidFill>
                   </a:tcPr>
                 </a:tc>
@@ -17139,13 +17298,13 @@
                           </a:solidFill>
                           <a:latin typeface="Arial"/>
                         </a:rPr>
-                        <a:t>conics + aspheres, m₂ = 3.0</a:t>
-                      </a:r>
-                    </a:p>
-                  </a:txBody>
-                  <a:tcPr marL="54864" marR="54864" marT="18288" marB="18288">
-                    <a:solidFill>
-                      <a:srgbClr val="ECF1F6"/>
+                        <a:t>three off-axis aspheres, same merit and geometry</a:t>
+                      </a:r>
+                    </a:p>
+                  </a:txBody>
+                  <a:tcPr marL="54864" marR="54864" marT="18288" marB="18288">
+                    <a:solidFill>
+                      <a:srgbClr val="FFFFFF"/>
                     </a:solidFill>
                   </a:tcPr>
                 </a:tc>
@@ -17161,13 +17320,13 @@
                           </a:solidFill>
                           <a:latin typeface="Arial"/>
                         </a:rPr>
-                        <a:t>291 µm</a:t>
-                      </a:r>
-                    </a:p>
-                  </a:txBody>
-                  <a:tcPr marL="54864" marR="54864" marT="18288" marB="18288">
-                    <a:solidFill>
-                      <a:srgbClr val="ECF1F6"/>
+                        <a:t>8 / 14</a:t>
+                      </a:r>
+                    </a:p>
+                  </a:txBody>
+                  <a:tcPr marL="54864" marR="54864" marT="18288" marB="18288">
+                    <a:solidFill>
+                      <a:srgbClr val="FFFFFF"/>
                     </a:solidFill>
                   </a:tcPr>
                 </a:tc>
@@ -17183,35 +17342,13 @@
                           </a:solidFill>
                           <a:latin typeface="Arial"/>
                         </a:rPr>
-                        <a:t>27.9 / 23.0 µm</a:t>
-                      </a:r>
-                    </a:p>
-                  </a:txBody>
-                  <a:tcPr marL="54864" marR="54864" marT="18288" marB="18288">
-                    <a:solidFill>
-                      <a:srgbClr val="ECF1F6"/>
-                    </a:solidFill>
-                  </a:tcPr>
-                </a:tc>
-                <a:tc>
-                  <a:txBody>
-                    <a:bodyPr wrap="square"/>
-                    <a:lstStyle/>
-                    <a:p>
-                      <a:r>
-                        <a:rPr sz="1000" b="0">
-                          <a:solidFill>
-                            <a:srgbClr val="282828"/>
-                          </a:solidFill>
-                          <a:latin typeface="Arial"/>
-                        </a:rPr>
-                        <a:t>2.2 mm</a:t>
-                      </a:r>
-                    </a:p>
-                  </a:txBody>
-                  <a:tcPr marL="54864" marR="54864" marT="18288" marB="18288">
-                    <a:solidFill>
-                      <a:srgbClr val="ECF1F6"/>
+                        <a:t>0.51 / 0.01 / 1.22 / 2.20</a:t>
+                      </a:r>
+                    </a:p>
+                  </a:txBody>
+                  <a:tcPr marL="54864" marR="54864" marT="18288" marB="18288">
+                    <a:solidFill>
+                      <a:srgbClr val="FFFFFF"/>
                     </a:solidFill>
                   </a:tcPr>
                 </a:tc>
@@ -17228,7 +17365,7 @@
         </p:nvSpPr>
         <p:spPr>
           <a:xfrm>
-            <a:off x="6400800" y="2747772"/>
+            <a:off x="6400800" y="3536441"/>
             <a:ext cx="5394960" cy="274320"/>
           </a:xfrm>
           <a:prstGeom prst="rect">
@@ -17254,7 +17391,7 @@
                 </a:solidFill>
                 <a:latin typeface="Arial"/>
               </a:rPr>
-              <a:t>1.5k section at 4° bias, 190 mm decenter, ±2.34° field; wavefront rms over the pupil at 633 nm; the two line foci from the x- and y-slices of the bundle along the chief.  The solves ON the reference sphere (the same freedoms, and the freeform steps) first stopped at their solver's first step through a tolerance set in the wrong units; they are re-running and are not reported here.  Records dyson5_tA_EP_cp*.txt, dyson5_tA_pz_1k5.txt.</a:t>
+              <a:t>Records dyson5_tA_EP_, dyson5_tA_pz_, dyson5_tA_FF_, dyson5_tA_GM_; the e2e rows through the engine-placed join (identity with the chain join to every printed digit on the aspheric deck).  Solves run to a fixed evaluation budget; none is converged in the optimizer's sense.</a:t>
             </a:r>
           </a:p>
         </p:txBody>
@@ -17497,7 +17634,7 @@
                 </a:solidFill>
                 <a:latin typeface="Arial"/>
               </a:rPr>
-              <a:t>•  The telescope's image: the unobscured section of the telecentric three-mirror parent packages and holds the 1.5k strip's inner half at 2–10 px with its plate scale and every clearance; the strip edges (19 px at ±2.3°, 68 px at ±4.7° for 3k) are cross-track astigmatism that no symmetric surface term reaches.  Running now: the freeform steps on the m₂ = 3.0 parent — coma and trefoil, then the symmetric terms, warm-started step to step on the true reference sphere; then the same for the 3k module; then the end-to-end row with each module's Dyson.  Queued in the engine: the fixed-station reference sphere for the optimizer on near-telecentric designs, and the asphere + Zernike surface as one emitted option.</a:t>
+              <a:t>•  The telescope's image: the 1.5k module has its telescope of record — three off-axis aspheres at the pixel end to end (CRF 1.22 px, clearance +39 mm).  Next: the 3k module's layout (the stop at M2; an asphere-only solve), a FWHM-faithful instrument merit for the final rung, the field weighting as a project ruling, and the end-to-end row with each module's Dyson as the entry in the comparison for Jim.  Queued in the engine: the fixed-station reference sphere and the asphere + Zernike surface option.</a:t>
             </a:r>
           </a:p>
           <a:p>

</xml_diff>